<commit_message>
Endurecer servicio ante caidas y duplicados
</commit_message>
<xml_diff>
--- a/entrega/Presentacion_INF513_P1_Grupo09SA.pptx
+++ b/entrega/Presentacion_INF513_P1_Grupo09SA.pptx
@@ -2,22 +2,22 @@
 <file path=ppt/presentation.xml><?xml version="1.0" encoding="utf-8"?>
 <p:presentation xmlns:p="http://schemas.openxmlformats.org/presentationml/2006/main">
   <p:sldMasterIdLst>
-    <p:sldMasterId xmlns:r="http://schemas.openxmlformats.org/officeDocument/2006/relationships" id="2147483648" r:id="Rf5151b01acd94724"/>
+    <p:sldMasterId xmlns:r="http://schemas.openxmlformats.org/officeDocument/2006/relationships" id="2147483648" r:id="R0629df0b0d8644d6"/>
   </p:sldMasterIdLst>
   <p:notesMasterIdLst>
-    <p:notesMasterId xmlns:r="http://schemas.openxmlformats.org/officeDocument/2006/relationships" r:id="Re4f4aa4cd2d540b6"/>
+    <p:notesMasterId xmlns:r="http://schemas.openxmlformats.org/officeDocument/2006/relationships" r:id="Ra533003d3f1c42fa"/>
   </p:notesMasterIdLst>
   <p:sldIdLst>
-    <p:sldId xmlns:r="http://schemas.openxmlformats.org/officeDocument/2006/relationships" id="256" r:id="R02559e8055a54ecf"/>
-    <p:sldId xmlns:r="http://schemas.openxmlformats.org/officeDocument/2006/relationships" id="257" r:id="R919e98196b7b47bc"/>
-    <p:sldId xmlns:r="http://schemas.openxmlformats.org/officeDocument/2006/relationships" id="258" r:id="Rf4ac6f90afd44e34"/>
-    <p:sldId xmlns:r="http://schemas.openxmlformats.org/officeDocument/2006/relationships" id="259" r:id="Rb2f43df9e1e34137"/>
-    <p:sldId xmlns:r="http://schemas.openxmlformats.org/officeDocument/2006/relationships" id="260" r:id="R7b98193887a74bff"/>
-    <p:sldId xmlns:r="http://schemas.openxmlformats.org/officeDocument/2006/relationships" id="261" r:id="Ra9fc3932f4bc45e0"/>
-    <p:sldId xmlns:r="http://schemas.openxmlformats.org/officeDocument/2006/relationships" id="262" r:id="Rc45579d9c6f245d4"/>
-    <p:sldId xmlns:r="http://schemas.openxmlformats.org/officeDocument/2006/relationships" id="263" r:id="Rdb88d041b1354290"/>
-    <p:sldId xmlns:r="http://schemas.openxmlformats.org/officeDocument/2006/relationships" id="264" r:id="R53470eba5a6d44a7"/>
-    <p:sldId xmlns:r="http://schemas.openxmlformats.org/officeDocument/2006/relationships" id="265" r:id="R149110a49a794364"/>
+    <p:sldId xmlns:r="http://schemas.openxmlformats.org/officeDocument/2006/relationships" id="256" r:id="Rd590515aa1844d8b"/>
+    <p:sldId xmlns:r="http://schemas.openxmlformats.org/officeDocument/2006/relationships" id="257" r:id="R79cadbc2cd234713"/>
+    <p:sldId xmlns:r="http://schemas.openxmlformats.org/officeDocument/2006/relationships" id="258" r:id="R496e503f9a3044a1"/>
+    <p:sldId xmlns:r="http://schemas.openxmlformats.org/officeDocument/2006/relationships" id="259" r:id="R7200763feb3242ae"/>
+    <p:sldId xmlns:r="http://schemas.openxmlformats.org/officeDocument/2006/relationships" id="260" r:id="R11c2b42dcec04fc2"/>
+    <p:sldId xmlns:r="http://schemas.openxmlformats.org/officeDocument/2006/relationships" id="261" r:id="Rb915c16a25bd4289"/>
+    <p:sldId xmlns:r="http://schemas.openxmlformats.org/officeDocument/2006/relationships" id="262" r:id="R2f20edea218f4583"/>
+    <p:sldId xmlns:r="http://schemas.openxmlformats.org/officeDocument/2006/relationships" id="263" r:id="R33a3e0d3ab984270"/>
+    <p:sldId xmlns:r="http://schemas.openxmlformats.org/officeDocument/2006/relationships" id="264" r:id="Rd1c96349caa1434b"/>
+    <p:sldId xmlns:r="http://schemas.openxmlformats.org/officeDocument/2006/relationships" id="265" r:id="R34c32c1b723a4cce"/>
   </p:sldIdLst>
   <p:sldSz cx="12192000" cy="6858000"/>
   <p:notesSz cx="6858000" cy="9144000"/>
@@ -1088,7 +1088,7 @@
           <p:cNvPr id="3" name="Title">
             <a:extLst xmlns:a="http://schemas.openxmlformats.org/drawingml/2006/main">
               <a:ext uri="{FF2B5EF4-FFF2-40B4-BE49-F238E27FC236}">
-                <a16:creationId xmlns:a16="http://schemas.microsoft.com/office/drawing/2014/main" id="{355F31C7-BC70-4FBB-8479-5CF8209995F0}"/>
+                <a16:creationId xmlns:a16="http://schemas.microsoft.com/office/drawing/2014/main" id="{6DA8EA78-0CE2-4C3F-9434-5BE4D7465951}"/>
               </a:ext>
             </a:extLst>
           </p:cNvPr>
@@ -1245,7 +1245,7 @@
           <p:cNvPr id="2" name="Subtitle">
             <a:extLst xmlns:a="http://schemas.openxmlformats.org/drawingml/2006/main">
               <a:ext uri="{FF2B5EF4-FFF2-40B4-BE49-F238E27FC236}">
-                <a16:creationId xmlns:a16="http://schemas.microsoft.com/office/drawing/2014/main" id="{A0132CEC-AED5-43E7-8928-83CFB75BB4E5}"/>
+                <a16:creationId xmlns:a16="http://schemas.microsoft.com/office/drawing/2014/main" id="{FAA2046B-D013-4F7A-BCC6-2FBB3BF6A23E}"/>
               </a:ext>
             </a:extLst>
           </p:cNvPr>
@@ -1419,7 +1419,7 @@
           <p:cNvPr id="2" name="Section title">
             <a:extLst xmlns:a="http://schemas.openxmlformats.org/drawingml/2006/main">
               <a:ext uri="{FF2B5EF4-FFF2-40B4-BE49-F238E27FC236}">
-                <a16:creationId xmlns:a16="http://schemas.microsoft.com/office/drawing/2014/main" id="{22892F0A-88E2-45F2-8F83-172AB9A369FA}"/>
+                <a16:creationId xmlns:a16="http://schemas.microsoft.com/office/drawing/2014/main" id="{3718BB34-B0D7-4E81-B74B-0A5E8044EF9B}"/>
               </a:ext>
             </a:extLst>
           </p:cNvPr>
@@ -1593,7 +1593,7 @@
           <p:cNvPr id="3" name="Title">
             <a:extLst xmlns:a="http://schemas.openxmlformats.org/drawingml/2006/main">
               <a:ext uri="{FF2B5EF4-FFF2-40B4-BE49-F238E27FC236}">
-                <a16:creationId xmlns:a16="http://schemas.microsoft.com/office/drawing/2014/main" id="{4356E3CA-904A-49F2-A354-C50F15AD822A}"/>
+                <a16:creationId xmlns:a16="http://schemas.microsoft.com/office/drawing/2014/main" id="{22087808-EC31-413D-BC12-796964FAA8D1}"/>
               </a:ext>
             </a:extLst>
           </p:cNvPr>
@@ -1750,7 +1750,7 @@
           <p:cNvPr id="2" name="Body">
             <a:extLst xmlns:a="http://schemas.openxmlformats.org/drawingml/2006/main">
               <a:ext uri="{FF2B5EF4-FFF2-40B4-BE49-F238E27FC236}">
-                <a16:creationId xmlns:a16="http://schemas.microsoft.com/office/drawing/2014/main" id="{3807E59C-9A69-4A0B-B1C3-B51596E3B2D6}"/>
+                <a16:creationId xmlns:a16="http://schemas.microsoft.com/office/drawing/2014/main" id="{15516AC3-B69F-4DAE-9DAA-2AD880F68BBC}"/>
               </a:ext>
             </a:extLst>
           </p:cNvPr>
@@ -1924,7 +1924,7 @@
           <p:cNvPr id="4" name="Title">
             <a:extLst xmlns:a="http://schemas.openxmlformats.org/drawingml/2006/main">
               <a:ext uri="{FF2B5EF4-FFF2-40B4-BE49-F238E27FC236}">
-                <a16:creationId xmlns:a16="http://schemas.microsoft.com/office/drawing/2014/main" id="{EE6FB8A6-468F-4C21-9242-85966312C6B8}"/>
+                <a16:creationId xmlns:a16="http://schemas.microsoft.com/office/drawing/2014/main" id="{4C32F8F5-AB41-4AB1-9E2D-675966E93BF2}"/>
               </a:ext>
             </a:extLst>
           </p:cNvPr>
@@ -2081,7 +2081,7 @@
           <p:cNvPr id="2" name="Left column">
             <a:extLst xmlns:a="http://schemas.openxmlformats.org/drawingml/2006/main">
               <a:ext uri="{FF2B5EF4-FFF2-40B4-BE49-F238E27FC236}">
-                <a16:creationId xmlns:a16="http://schemas.microsoft.com/office/drawing/2014/main" id="{1928982A-978C-43C3-9A38-73C5F05A55E2}"/>
+                <a16:creationId xmlns:a16="http://schemas.microsoft.com/office/drawing/2014/main" id="{D8E5012C-669E-4C33-AE61-884F8727A12D}"/>
               </a:ext>
             </a:extLst>
           </p:cNvPr>
@@ -2238,7 +2238,7 @@
           <p:cNvPr id="3" name="Right column">
             <a:extLst xmlns:a="http://schemas.openxmlformats.org/drawingml/2006/main">
               <a:ext uri="{FF2B5EF4-FFF2-40B4-BE49-F238E27FC236}">
-                <a16:creationId xmlns:a16="http://schemas.microsoft.com/office/drawing/2014/main" id="{4B775B08-BD40-4EC0-819A-8E63290E3A10}"/>
+                <a16:creationId xmlns:a16="http://schemas.microsoft.com/office/drawing/2014/main" id="{2FCA2C27-2A16-4758-AEDF-B545389DF332}"/>
               </a:ext>
             </a:extLst>
           </p:cNvPr>
@@ -2412,7 +2412,7 @@
           <p:cNvPr id="3" name="Title">
             <a:extLst xmlns:a="http://schemas.openxmlformats.org/drawingml/2006/main">
               <a:ext uri="{FF2B5EF4-FFF2-40B4-BE49-F238E27FC236}">
-                <a16:creationId xmlns:a16="http://schemas.microsoft.com/office/drawing/2014/main" id="{1351526E-8824-469E-8E8C-B6338B3BCA8F}"/>
+                <a16:creationId xmlns:a16="http://schemas.microsoft.com/office/drawing/2014/main" id="{B83CD5ED-37B9-440B-B3FF-0FDB95ED93BA}"/>
               </a:ext>
             </a:extLst>
           </p:cNvPr>
@@ -2569,7 +2569,7 @@
           <p:cNvPr id="2" name="Left column">
             <a:extLst xmlns:a="http://schemas.openxmlformats.org/drawingml/2006/main">
               <a:ext uri="{FF2B5EF4-FFF2-40B4-BE49-F238E27FC236}">
-                <a16:creationId xmlns:a16="http://schemas.microsoft.com/office/drawing/2014/main" id="{0513766A-367E-4B1C-A05C-8705915EAD66}"/>
+                <a16:creationId xmlns:a16="http://schemas.microsoft.com/office/drawing/2014/main" id="{7001CD12-22EC-49AA-ABA6-70AE4914FC14}"/>
               </a:ext>
             </a:extLst>
           </p:cNvPr>
@@ -2764,12 +2764,12 @@
   </p:cSld>
   <p:clrMap bg1="lt1" tx1="dk1" bg2="lt2" tx2="dk2" accent1="accent1" accent2="accent2" accent3="accent3" accent4="accent4" accent5="accent5" accent6="accent6" hlink="hlink" folHlink="folHlink"/>
   <p:sldLayoutIdLst>
-    <p:sldLayoutId xmlns:r="http://schemas.openxmlformats.org/officeDocument/2006/relationships" id="2147483649" r:id="R41614b7ecea0469a"/>
-    <p:sldLayoutId xmlns:r="http://schemas.openxmlformats.org/officeDocument/2006/relationships" id="2147483650" r:id="R35fd7d764f054ae0"/>
-    <p:sldLayoutId xmlns:r="http://schemas.openxmlformats.org/officeDocument/2006/relationships" id="2147483651" r:id="Rde6d78aee1ca48fe"/>
-    <p:sldLayoutId xmlns:r="http://schemas.openxmlformats.org/officeDocument/2006/relationships" id="2147483652" r:id="Rde2a0b90e4ae491d"/>
-    <p:sldLayoutId xmlns:r="http://schemas.openxmlformats.org/officeDocument/2006/relationships" id="2147483653" r:id="R0042d5d9459744e5"/>
-    <p:sldLayoutId xmlns:r="http://schemas.openxmlformats.org/officeDocument/2006/relationships" id="2147483654" r:id="R001a9086a5084a13"/>
+    <p:sldLayoutId xmlns:r="http://schemas.openxmlformats.org/officeDocument/2006/relationships" id="2147483649" r:id="Rc7e9adf8be1a4c1f"/>
+    <p:sldLayoutId xmlns:r="http://schemas.openxmlformats.org/officeDocument/2006/relationships" id="2147483650" r:id="Rf2982ac9aec2450e"/>
+    <p:sldLayoutId xmlns:r="http://schemas.openxmlformats.org/officeDocument/2006/relationships" id="2147483651" r:id="Rf8e34fba80af491e"/>
+    <p:sldLayoutId xmlns:r="http://schemas.openxmlformats.org/officeDocument/2006/relationships" id="2147483652" r:id="R26201e9782594e06"/>
+    <p:sldLayoutId xmlns:r="http://schemas.openxmlformats.org/officeDocument/2006/relationships" id="2147483653" r:id="Reaae6e4da1d24f6e"/>
+    <p:sldLayoutId xmlns:r="http://schemas.openxmlformats.org/officeDocument/2006/relationships" id="2147483654" r:id="R00f851c5b7e84c03"/>
   </p:sldLayoutIdLst>
   <p:txStyles>
     <p:titleStyle>
@@ -3320,7 +3320,7 @@
           <p:cNvPr id="8" name="">
             <a:extLst xmlns:a="http://schemas.openxmlformats.org/drawingml/2006/main">
               <a:ext uri="{FF2B5EF4-FFF2-40B4-BE49-F238E27FC236}">
-                <a16:creationId xmlns:a16="http://schemas.microsoft.com/office/drawing/2014/main" id="{F58940A8-E754-4C46-BCFD-5C5744733BF6}"/>
+                <a16:creationId xmlns:a16="http://schemas.microsoft.com/office/drawing/2014/main" id="{4828A0FE-A209-4451-91B9-6D76FAA4B179}"/>
               </a:ext>
             </a:extLst>
           </p:cNvPr>
@@ -3378,7 +3378,7 @@
           <p:cNvPr id="2" name="">
             <a:extLst xmlns:a="http://schemas.openxmlformats.org/drawingml/2006/main">
               <a:ext uri="{FF2B5EF4-FFF2-40B4-BE49-F238E27FC236}">
-                <a16:creationId xmlns:a16="http://schemas.microsoft.com/office/drawing/2014/main" id="{50B6DB3F-9A5F-4886-A7C6-45F76F7A2FCD}"/>
+                <a16:creationId xmlns:a16="http://schemas.microsoft.com/office/drawing/2014/main" id="{125F1C1B-2BAA-4769-AAF5-AA1696336931}"/>
               </a:ext>
             </a:extLst>
           </p:cNvPr>
@@ -3436,7 +3436,7 @@
           <p:cNvPr id="3" name="">
             <a:extLst xmlns:a="http://schemas.openxmlformats.org/drawingml/2006/main">
               <a:ext uri="{FF2B5EF4-FFF2-40B4-BE49-F238E27FC236}">
-                <a16:creationId xmlns:a16="http://schemas.microsoft.com/office/drawing/2014/main" id="{39E8043B-5950-49EA-9701-B2169D3D5327}"/>
+                <a16:creationId xmlns:a16="http://schemas.microsoft.com/office/drawing/2014/main" id="{CE34522E-DE1C-474C-BB01-8269345CE43C}"/>
               </a:ext>
             </a:extLst>
           </p:cNvPr>
@@ -3494,7 +3494,7 @@
           <p:cNvPr id="4" name="">
             <a:extLst xmlns:a="http://schemas.openxmlformats.org/drawingml/2006/main">
               <a:ext uri="{FF2B5EF4-FFF2-40B4-BE49-F238E27FC236}">
-                <a16:creationId xmlns:a16="http://schemas.microsoft.com/office/drawing/2014/main" id="{70FF7894-D410-4AFE-96EC-6968EF73C276}"/>
+                <a16:creationId xmlns:a16="http://schemas.microsoft.com/office/drawing/2014/main" id="{1D9AFED4-D59D-4C59-B935-9966EBA32660}"/>
               </a:ext>
             </a:extLst>
           </p:cNvPr>
@@ -3529,7 +3529,7 @@
           <p:cNvPr id="5" name="">
             <a:extLst xmlns:a="http://schemas.openxmlformats.org/drawingml/2006/main">
               <a:ext uri="{FF2B5EF4-FFF2-40B4-BE49-F238E27FC236}">
-                <a16:creationId xmlns:a16="http://schemas.microsoft.com/office/drawing/2014/main" id="{CE2D1DC1-CEDC-413B-9004-8FB483DF2392}"/>
+                <a16:creationId xmlns:a16="http://schemas.microsoft.com/office/drawing/2014/main" id="{D67866E6-CC43-4CC5-A7CB-2A5ECEBC8659}"/>
               </a:ext>
             </a:extLst>
           </p:cNvPr>
@@ -3587,7 +3587,7 @@
           <p:cNvPr id="6" name="">
             <a:extLst xmlns:a="http://schemas.openxmlformats.org/drawingml/2006/main">
               <a:ext uri="{FF2B5EF4-FFF2-40B4-BE49-F238E27FC236}">
-                <a16:creationId xmlns:a16="http://schemas.microsoft.com/office/drawing/2014/main" id="{F91C03A3-29B3-429F-923D-7E2549DA3E3C}"/>
+                <a16:creationId xmlns:a16="http://schemas.microsoft.com/office/drawing/2014/main" id="{6A844D15-74A1-4BD3-9369-5B15A8C81F22}"/>
               </a:ext>
             </a:extLst>
           </p:cNvPr>
@@ -3740,7 +3740,7 @@
           <p:cNvPr id="7" name="">
             <a:extLst xmlns:a="http://schemas.openxmlformats.org/drawingml/2006/main">
               <a:ext uri="{FF2B5EF4-FFF2-40B4-BE49-F238E27FC236}">
-                <a16:creationId xmlns:a16="http://schemas.microsoft.com/office/drawing/2014/main" id="{66FDEC6F-82D0-4164-9E54-4093A71F9FFF}"/>
+                <a16:creationId xmlns:a16="http://schemas.microsoft.com/office/drawing/2014/main" id="{FEFD6691-5E4A-4551-BF64-9731062DC181}"/>
               </a:ext>
             </a:extLst>
           </p:cNvPr>
@@ -3813,7 +3813,7 @@
     </p:spTree>
     <p:extLst>
       <p:ext uri="{BB962C8B-B14F-4D97-AF65-F5344CB8AC3E}">
-        <p14:creationId xmlns:p14="http://schemas.microsoft.com/office/powerpoint/2010/main" val="291311563"/>
+        <p14:creationId xmlns:p14="http://schemas.microsoft.com/office/powerpoint/2010/main" val="234085056"/>
       </p:ext>
     </p:extLst>
   </p:cSld>
@@ -3844,7 +3844,7 @@
           <p:cNvPr id="17" name="">
             <a:extLst xmlns:a="http://schemas.openxmlformats.org/drawingml/2006/main">
               <a:ext uri="{FF2B5EF4-FFF2-40B4-BE49-F238E27FC236}">
-                <a16:creationId xmlns:a16="http://schemas.microsoft.com/office/drawing/2014/main" id="{5232DD84-4AEC-472B-ABCB-14A64CC860B3}"/>
+                <a16:creationId xmlns:a16="http://schemas.microsoft.com/office/drawing/2014/main" id="{28989F8A-673D-4E35-AF21-C8EE4290CD03}"/>
               </a:ext>
             </a:extLst>
           </p:cNvPr>
@@ -3902,7 +3902,7 @@
           <p:cNvPr id="2" name="">
             <a:extLst xmlns:a="http://schemas.openxmlformats.org/drawingml/2006/main">
               <a:ext uri="{FF2B5EF4-FFF2-40B4-BE49-F238E27FC236}">
-                <a16:creationId xmlns:a16="http://schemas.microsoft.com/office/drawing/2014/main" id="{562D2145-FA22-4043-887E-E7DE6D9E1B6B}"/>
+                <a16:creationId xmlns:a16="http://schemas.microsoft.com/office/drawing/2014/main" id="{342B7A07-EDB2-43E4-AF49-8AEB5B4B0253}"/>
               </a:ext>
             </a:extLst>
           </p:cNvPr>
@@ -3960,7 +3960,7 @@
           <p:cNvPr id="3" name="">
             <a:extLst xmlns:a="http://schemas.openxmlformats.org/drawingml/2006/main">
               <a:ext uri="{FF2B5EF4-FFF2-40B4-BE49-F238E27FC236}">
-                <a16:creationId xmlns:a16="http://schemas.microsoft.com/office/drawing/2014/main" id="{9BADAC80-B2C3-4411-B4C2-513A5B8B904D}"/>
+                <a16:creationId xmlns:a16="http://schemas.microsoft.com/office/drawing/2014/main" id="{B99B661E-5551-4679-818B-E677F8F6ED9B}"/>
               </a:ext>
             </a:extLst>
           </p:cNvPr>
@@ -3993,7 +3993,7 @@
           <p:cNvPr id="4" name="">
             <a:extLst xmlns:a="http://schemas.openxmlformats.org/drawingml/2006/main">
               <a:ext uri="{FF2B5EF4-FFF2-40B4-BE49-F238E27FC236}">
-                <a16:creationId xmlns:a16="http://schemas.microsoft.com/office/drawing/2014/main" id="{E176C5E9-C362-435D-96CC-2D84A9A1427E}"/>
+                <a16:creationId xmlns:a16="http://schemas.microsoft.com/office/drawing/2014/main" id="{01BCCAFF-11CC-4E1A-9B90-218E256EF7C8}"/>
               </a:ext>
             </a:extLst>
           </p:cNvPr>
@@ -4051,7 +4051,7 @@
           <p:cNvPr id="5" name="">
             <a:extLst xmlns:a="http://schemas.openxmlformats.org/drawingml/2006/main">
               <a:ext uri="{FF2B5EF4-FFF2-40B4-BE49-F238E27FC236}">
-                <a16:creationId xmlns:a16="http://schemas.microsoft.com/office/drawing/2014/main" id="{B7DC61EE-3621-4926-BEAF-610D9333C89E}"/>
+                <a16:creationId xmlns:a16="http://schemas.microsoft.com/office/drawing/2014/main" id="{423FB7D1-DEE4-4F39-AA25-5C69DE6F4274}"/>
               </a:ext>
             </a:extLst>
           </p:cNvPr>
@@ -4109,7 +4109,7 @@
           <p:cNvPr id="6" name="">
             <a:extLst xmlns:a="http://schemas.openxmlformats.org/drawingml/2006/main">
               <a:ext uri="{FF2B5EF4-FFF2-40B4-BE49-F238E27FC236}">
-                <a16:creationId xmlns:a16="http://schemas.microsoft.com/office/drawing/2014/main" id="{C31E95C0-9D64-4ACD-843A-A4606CA8F40D}"/>
+                <a16:creationId xmlns:a16="http://schemas.microsoft.com/office/drawing/2014/main" id="{07C72917-457E-4820-B3A0-F5B2515449EB}"/>
               </a:ext>
             </a:extLst>
           </p:cNvPr>
@@ -4121,7 +4121,7 @@
         <p:spPr>
           <a:xfrm xmlns:a="http://schemas.openxmlformats.org/drawingml/2006/main">
             <a:off x="809625" y="1762125"/>
-            <a:ext cx="6858000" cy="552450"/>
+            <a:ext cx="9334500" cy="552450"/>
           </a:xfrm>
           <a:prstGeom xmlns:a="http://schemas.openxmlformats.org/drawingml/2006/main" prst="rect">
             <a:avLst/>
@@ -4157,7 +4157,7 @@
                   <a:srgbClr val="17365D"/>
                 </a:solidFill>
               </a:rPr>
-              <a:t>El sistema cumple el ciclo solicitado</a:t>
+              <a:t>El sistema cumple el ciclo y se recupera de cortes</a:t>
             </a:r>
           </a:p>
         </p:txBody>
@@ -4167,7 +4167,7 @@
           <p:cNvPr id="7" name="">
             <a:extLst xmlns:a="http://schemas.openxmlformats.org/drawingml/2006/main">
               <a:ext uri="{FF2B5EF4-FFF2-40B4-BE49-F238E27FC236}">
-                <a16:creationId xmlns:a16="http://schemas.microsoft.com/office/drawing/2014/main" id="{C9D1DA14-8C09-463D-B2A0-2F5A8B22F6DD}"/>
+                <a16:creationId xmlns:a16="http://schemas.microsoft.com/office/drawing/2014/main" id="{7A4CC6CF-DCA2-4027-89B3-61A1E077E779}"/>
               </a:ext>
             </a:extLst>
           </p:cNvPr>
@@ -4225,7 +4225,7 @@
           <p:cNvPr id="8" name="">
             <a:extLst xmlns:a="http://schemas.openxmlformats.org/drawingml/2006/main">
               <a:ext uri="{FF2B5EF4-FFF2-40B4-BE49-F238E27FC236}">
-                <a16:creationId xmlns:a16="http://schemas.microsoft.com/office/drawing/2014/main" id="{4E1A4CB5-DABD-4831-A905-A0AC4BCF28AE}"/>
+                <a16:creationId xmlns:a16="http://schemas.microsoft.com/office/drawing/2014/main" id="{A8280A19-9E51-4392-812B-03EC71BEC970}"/>
               </a:ext>
             </a:extLst>
           </p:cNvPr>
@@ -4260,7 +4260,7 @@
           <p:cNvPr id="9" name="">
             <a:extLst xmlns:a="http://schemas.openxmlformats.org/drawingml/2006/main">
               <a:ext uri="{FF2B5EF4-FFF2-40B4-BE49-F238E27FC236}">
-                <a16:creationId xmlns:a16="http://schemas.microsoft.com/office/drawing/2014/main" id="{72CE88CE-1BB6-473F-AC4A-E03A366B5F99}"/>
+                <a16:creationId xmlns:a16="http://schemas.microsoft.com/office/drawing/2014/main" id="{6794031E-607B-47EF-9978-E78A0F3D6E14}"/>
               </a:ext>
             </a:extLst>
           </p:cNvPr>
@@ -4293,7 +4293,7 @@
           <p:cNvPr id="10" name="">
             <a:extLst xmlns:a="http://schemas.openxmlformats.org/drawingml/2006/main">
               <a:ext uri="{FF2B5EF4-FFF2-40B4-BE49-F238E27FC236}">
-                <a16:creationId xmlns:a16="http://schemas.microsoft.com/office/drawing/2014/main" id="{042F4085-4FC3-4A12-9FD9-08E8E2ED88A9}"/>
+                <a16:creationId xmlns:a16="http://schemas.microsoft.com/office/drawing/2014/main" id="{8B0D0754-1E78-4E56-85CA-C77B0CA93950}"/>
               </a:ext>
             </a:extLst>
           </p:cNvPr>
@@ -4351,7 +4351,7 @@
           <p:cNvPr id="11" name="">
             <a:extLst xmlns:a="http://schemas.openxmlformats.org/drawingml/2006/main">
               <a:ext uri="{FF2B5EF4-FFF2-40B4-BE49-F238E27FC236}">
-                <a16:creationId xmlns:a16="http://schemas.microsoft.com/office/drawing/2014/main" id="{36A72A88-D79D-4383-97AF-E408BE4DE98E}"/>
+                <a16:creationId xmlns:a16="http://schemas.microsoft.com/office/drawing/2014/main" id="{99DAEF72-7792-4B18-8334-2A9FBDD54DC4}"/>
               </a:ext>
             </a:extLst>
           </p:cNvPr>
@@ -4416,7 +4416,7 @@
                   <a:srgbClr val="52606D"/>
                 </a:solidFill>
               </a:rPr>
-              <a:t>2. Iniciar el JAR</a:t>
+              <a:t>2. Iniciar en Windows o Fedora</a:t>
             </a:r>
           </a:p>
           <a:p xmlns:a="http://schemas.openxmlformats.org/drawingml/2006/main">
@@ -4450,7 +4450,7 @@
                   <a:srgbClr val="52606D"/>
                 </a:solidFill>
               </a:rPr>
-              <a:t>4. Mostrar base de datos, ranking y auditoría</a:t>
+              <a:t>4. Mostrar cola, reintentos y auditoría</a:t>
             </a:r>
           </a:p>
         </p:txBody>
@@ -4460,7 +4460,7 @@
           <p:cNvPr id="12" name="">
             <a:extLst xmlns:a="http://schemas.openxmlformats.org/drawingml/2006/main">
               <a:ext uri="{FF2B5EF4-FFF2-40B4-BE49-F238E27FC236}">
-                <a16:creationId xmlns:a16="http://schemas.microsoft.com/office/drawing/2014/main" id="{4A98E998-D6F5-4C6B-A255-02F75CB7BAEF}"/>
+                <a16:creationId xmlns:a16="http://schemas.microsoft.com/office/drawing/2014/main" id="{972D25D5-B977-410B-ABB0-C4B4E47F8EED}"/>
               </a:ext>
             </a:extLst>
           </p:cNvPr>
@@ -4495,7 +4495,7 @@
           <p:cNvPr id="13" name="">
             <a:extLst xmlns:a="http://schemas.openxmlformats.org/drawingml/2006/main">
               <a:ext uri="{FF2B5EF4-FFF2-40B4-BE49-F238E27FC236}">
-                <a16:creationId xmlns:a16="http://schemas.microsoft.com/office/drawing/2014/main" id="{E53C1DE6-2F67-4014-A676-838D6828C5AC}"/>
+                <a16:creationId xmlns:a16="http://schemas.microsoft.com/office/drawing/2014/main" id="{20C312D9-40F8-4C44-8B69-147DC3E5E4D6}"/>
               </a:ext>
             </a:extLst>
           </p:cNvPr>
@@ -4528,7 +4528,7 @@
           <p:cNvPr id="14" name="">
             <a:extLst xmlns:a="http://schemas.openxmlformats.org/drawingml/2006/main">
               <a:ext uri="{FF2B5EF4-FFF2-40B4-BE49-F238E27FC236}">
-                <a16:creationId xmlns:a16="http://schemas.microsoft.com/office/drawing/2014/main" id="{76D9274A-2529-48E3-A995-A3991390FCD3}"/>
+                <a16:creationId xmlns:a16="http://schemas.microsoft.com/office/drawing/2014/main" id="{833C3A95-EB0F-4BF8-BA98-E2C46E5FE642}"/>
               </a:ext>
             </a:extLst>
           </p:cNvPr>
@@ -4576,7 +4576,7 @@
                   <a:srgbClr val="16202A"/>
                 </a:solidFill>
               </a:rPr>
-              <a:t>Archivos de entrega</a:t>
+              <a:t>Resistencia y entrega</a:t>
             </a:r>
           </a:p>
         </p:txBody>
@@ -4586,7 +4586,7 @@
           <p:cNvPr id="15" name="">
             <a:extLst xmlns:a="http://schemas.openxmlformats.org/drawingml/2006/main">
               <a:ext uri="{FF2B5EF4-FFF2-40B4-BE49-F238E27FC236}">
-                <a16:creationId xmlns:a16="http://schemas.microsoft.com/office/drawing/2014/main" id="{E9EDF739-DAE7-453A-9E2B-6FE143CEC591}"/>
+                <a16:creationId xmlns:a16="http://schemas.microsoft.com/office/drawing/2014/main" id="{675206A2-E514-4E46-9A44-1C1B23436C6C}"/>
               </a:ext>
             </a:extLst>
           </p:cNvPr>
@@ -4634,7 +4634,7 @@
                   <a:srgbClr val="52606D"/>
                 </a:solidFill>
               </a:rPr>
-              <a:t>Código fuente Maven</a:t>
+              <a:t>Cola durable e idempotencia</a:t>
             </a:r>
           </a:p>
           <a:p xmlns:a="http://schemas.openxmlformats.org/drawingml/2006/main">
@@ -4651,7 +4651,7 @@
                   <a:srgbClr val="52606D"/>
                 </a:solidFill>
               </a:rPr>
-              <a:t>Esquema PostgreSQL</a:t>
+              <a:t>Reintentos con límite</a:t>
             </a:r>
           </a:p>
           <a:p xmlns:a="http://schemas.openxmlformats.org/drawingml/2006/main">
@@ -4668,7 +4668,7 @@
                   <a:srgbClr val="52606D"/>
                 </a:solidFill>
               </a:rPr>
-              <a:t>PUDS en DOCX y PDF</a:t>
+              <a:t>Scripts Windows y Linux</a:t>
             </a:r>
           </a:p>
           <a:p xmlns:a="http://schemas.openxmlformats.org/drawingml/2006/main">
@@ -4685,7 +4685,7 @@
                   <a:srgbClr val="52606D"/>
                 </a:solidFill>
               </a:rPr>
-              <a:t>Presentación</a:t>
+              <a:t>PUDS, presentación y código</a:t>
             </a:r>
           </a:p>
           <a:p xmlns:a="http://schemas.openxmlformats.org/drawingml/2006/main">
@@ -4712,7 +4712,7 @@
           <p:cNvPr id="16" name="">
             <a:extLst xmlns:a="http://schemas.openxmlformats.org/drawingml/2006/main">
               <a:ext uri="{FF2B5EF4-FFF2-40B4-BE49-F238E27FC236}">
-                <a16:creationId xmlns:a16="http://schemas.microsoft.com/office/drawing/2014/main" id="{532DD431-36D0-499B-88CA-E3C1F17A86C3}"/>
+                <a16:creationId xmlns:a16="http://schemas.microsoft.com/office/drawing/2014/main" id="{3057C647-C2D9-40D5-B65C-49C92ADB7AB5}"/>
               </a:ext>
             </a:extLst>
           </p:cNvPr>
@@ -4768,7 +4768,7 @@
     </p:spTree>
     <p:extLst>
       <p:ext uri="{BB962C8B-B14F-4D97-AF65-F5344CB8AC3E}">
-        <p14:creationId xmlns:p14="http://schemas.microsoft.com/office/powerpoint/2010/main" val="524910569"/>
+        <p14:creationId xmlns:p14="http://schemas.microsoft.com/office/powerpoint/2010/main" val="580839039"/>
       </p:ext>
     </p:extLst>
   </p:cSld>
@@ -4799,7 +4799,7 @@
           <p:cNvPr id="22" name="">
             <a:extLst xmlns:a="http://schemas.openxmlformats.org/drawingml/2006/main">
               <a:ext uri="{FF2B5EF4-FFF2-40B4-BE49-F238E27FC236}">
-                <a16:creationId xmlns:a16="http://schemas.microsoft.com/office/drawing/2014/main" id="{B28D83BD-43C1-4D49-BA9A-EB0639FB489F}"/>
+                <a16:creationId xmlns:a16="http://schemas.microsoft.com/office/drawing/2014/main" id="{9E2D003F-92F2-49BF-AC79-418130D5956C}"/>
               </a:ext>
             </a:extLst>
           </p:cNvPr>
@@ -4857,7 +4857,7 @@
           <p:cNvPr id="2" name="">
             <a:extLst xmlns:a="http://schemas.openxmlformats.org/drawingml/2006/main">
               <a:ext uri="{FF2B5EF4-FFF2-40B4-BE49-F238E27FC236}">
-                <a16:creationId xmlns:a16="http://schemas.microsoft.com/office/drawing/2014/main" id="{69D87FF6-DECF-4234-BDB4-21F52EDDF4BA}"/>
+                <a16:creationId xmlns:a16="http://schemas.microsoft.com/office/drawing/2014/main" id="{9713BC3A-1A66-41F6-9FFB-D725B35855C7}"/>
               </a:ext>
             </a:extLst>
           </p:cNvPr>
@@ -4915,7 +4915,7 @@
           <p:cNvPr id="3" name="">
             <a:extLst xmlns:a="http://schemas.openxmlformats.org/drawingml/2006/main">
               <a:ext uri="{FF2B5EF4-FFF2-40B4-BE49-F238E27FC236}">
-                <a16:creationId xmlns:a16="http://schemas.microsoft.com/office/drawing/2014/main" id="{D1F100F2-E483-4D79-B1E5-C6B8400EE8B2}"/>
+                <a16:creationId xmlns:a16="http://schemas.microsoft.com/office/drawing/2014/main" id="{00A84730-BFAA-4B4A-842C-C38670D11F99}"/>
               </a:ext>
             </a:extLst>
           </p:cNvPr>
@@ -4948,7 +4948,7 @@
           <p:cNvPr id="4" name="">
             <a:extLst xmlns:a="http://schemas.openxmlformats.org/drawingml/2006/main">
               <a:ext uri="{FF2B5EF4-FFF2-40B4-BE49-F238E27FC236}">
-                <a16:creationId xmlns:a16="http://schemas.microsoft.com/office/drawing/2014/main" id="{DAD2139F-5D1D-4C80-84D4-72A5473E6A70}"/>
+                <a16:creationId xmlns:a16="http://schemas.microsoft.com/office/drawing/2014/main" id="{567014CC-2734-4936-8C68-2E7DAA50CB8A}"/>
               </a:ext>
             </a:extLst>
           </p:cNvPr>
@@ -5006,7 +5006,7 @@
           <p:cNvPr id="5" name="">
             <a:extLst xmlns:a="http://schemas.openxmlformats.org/drawingml/2006/main">
               <a:ext uri="{FF2B5EF4-FFF2-40B4-BE49-F238E27FC236}">
-                <a16:creationId xmlns:a16="http://schemas.microsoft.com/office/drawing/2014/main" id="{A22318B2-C1B2-462D-A2FD-0EA8E3AF79A3}"/>
+                <a16:creationId xmlns:a16="http://schemas.microsoft.com/office/drawing/2014/main" id="{C355407C-DBB9-4AD6-8593-10B6A6E7B534}"/>
               </a:ext>
             </a:extLst>
           </p:cNvPr>
@@ -5064,7 +5064,7 @@
           <p:cNvPr id="6" name="">
             <a:extLst xmlns:a="http://schemas.openxmlformats.org/drawingml/2006/main">
               <a:ext uri="{FF2B5EF4-FFF2-40B4-BE49-F238E27FC236}">
-                <a16:creationId xmlns:a16="http://schemas.microsoft.com/office/drawing/2014/main" id="{EBED544C-65D4-427C-BA15-4A758FE372C7}"/>
+                <a16:creationId xmlns:a16="http://schemas.microsoft.com/office/drawing/2014/main" id="{2A8981D8-BFEC-4631-9B73-02A5B7B449ED}"/>
               </a:ext>
             </a:extLst>
           </p:cNvPr>
@@ -5099,7 +5099,7 @@
           <p:cNvPr id="7" name="">
             <a:extLst xmlns:a="http://schemas.openxmlformats.org/drawingml/2006/main">
               <a:ext uri="{FF2B5EF4-FFF2-40B4-BE49-F238E27FC236}">
-                <a16:creationId xmlns:a16="http://schemas.microsoft.com/office/drawing/2014/main" id="{E040CF40-3489-4B7B-99D9-1C3692C35A34}"/>
+                <a16:creationId xmlns:a16="http://schemas.microsoft.com/office/drawing/2014/main" id="{3699823A-33F9-4B92-BF22-3CFA2190B36A}"/>
               </a:ext>
             </a:extLst>
           </p:cNvPr>
@@ -5132,7 +5132,7 @@
           <p:cNvPr id="8" name="">
             <a:extLst xmlns:a="http://schemas.openxmlformats.org/drawingml/2006/main">
               <a:ext uri="{FF2B5EF4-FFF2-40B4-BE49-F238E27FC236}">
-                <a16:creationId xmlns:a16="http://schemas.microsoft.com/office/drawing/2014/main" id="{78D91752-9AD9-45FB-B217-7303A3550B28}"/>
+                <a16:creationId xmlns:a16="http://schemas.microsoft.com/office/drawing/2014/main" id="{CD0F273C-D186-4547-9918-75580D38EC10}"/>
               </a:ext>
             </a:extLst>
           </p:cNvPr>
@@ -5190,7 +5190,7 @@
           <p:cNvPr id="9" name="">
             <a:extLst xmlns:a="http://schemas.openxmlformats.org/drawingml/2006/main">
               <a:ext uri="{FF2B5EF4-FFF2-40B4-BE49-F238E27FC236}">
-                <a16:creationId xmlns:a16="http://schemas.microsoft.com/office/drawing/2014/main" id="{673018A5-31F3-45F3-AA3C-6D9517740203}"/>
+                <a16:creationId xmlns:a16="http://schemas.microsoft.com/office/drawing/2014/main" id="{19032391-CAC1-4A78-AB36-04AE593036BB}"/>
               </a:ext>
             </a:extLst>
           </p:cNvPr>
@@ -5248,7 +5248,7 @@
           <p:cNvPr id="10" name="">
             <a:extLst xmlns:a="http://schemas.openxmlformats.org/drawingml/2006/main">
               <a:ext uri="{FF2B5EF4-FFF2-40B4-BE49-F238E27FC236}">
-                <a16:creationId xmlns:a16="http://schemas.microsoft.com/office/drawing/2014/main" id="{69FA00BA-842E-40C1-BFD3-39A8A8C96A3F}"/>
+                <a16:creationId xmlns:a16="http://schemas.microsoft.com/office/drawing/2014/main" id="{F663F1EF-F857-4AEA-A9C1-84CDEF404F60}"/>
               </a:ext>
             </a:extLst>
           </p:cNvPr>
@@ -5283,7 +5283,7 @@
           <p:cNvPr id="11" name="">
             <a:extLst xmlns:a="http://schemas.openxmlformats.org/drawingml/2006/main">
               <a:ext uri="{FF2B5EF4-FFF2-40B4-BE49-F238E27FC236}">
-                <a16:creationId xmlns:a16="http://schemas.microsoft.com/office/drawing/2014/main" id="{71ACFDAE-E721-46B3-B8F9-CF60122AB8D0}"/>
+                <a16:creationId xmlns:a16="http://schemas.microsoft.com/office/drawing/2014/main" id="{E4D69EBD-E041-4FAA-BDD8-E5976D4E7A12}"/>
               </a:ext>
             </a:extLst>
           </p:cNvPr>
@@ -5316,7 +5316,7 @@
           <p:cNvPr id="12" name="">
             <a:extLst xmlns:a="http://schemas.openxmlformats.org/drawingml/2006/main">
               <a:ext uri="{FF2B5EF4-FFF2-40B4-BE49-F238E27FC236}">
-                <a16:creationId xmlns:a16="http://schemas.microsoft.com/office/drawing/2014/main" id="{7A11CDFE-616B-4532-879C-A305141A40F4}"/>
+                <a16:creationId xmlns:a16="http://schemas.microsoft.com/office/drawing/2014/main" id="{AE2AFC75-EAB5-46B0-AAA6-4724DCBF2E7D}"/>
               </a:ext>
             </a:extLst>
           </p:cNvPr>
@@ -5374,7 +5374,7 @@
           <p:cNvPr id="13" name="">
             <a:extLst xmlns:a="http://schemas.openxmlformats.org/drawingml/2006/main">
               <a:ext uri="{FF2B5EF4-FFF2-40B4-BE49-F238E27FC236}">
-                <a16:creationId xmlns:a16="http://schemas.microsoft.com/office/drawing/2014/main" id="{D8740CEE-3510-4837-AEF9-673F1277142B}"/>
+                <a16:creationId xmlns:a16="http://schemas.microsoft.com/office/drawing/2014/main" id="{DAB71C21-31EE-4456-BD92-EB086C32EA08}"/>
               </a:ext>
             </a:extLst>
           </p:cNvPr>
@@ -5432,7 +5432,7 @@
           <p:cNvPr id="14" name="">
             <a:extLst xmlns:a="http://schemas.openxmlformats.org/drawingml/2006/main">
               <a:ext uri="{FF2B5EF4-FFF2-40B4-BE49-F238E27FC236}">
-                <a16:creationId xmlns:a16="http://schemas.microsoft.com/office/drawing/2014/main" id="{DF91CDA1-6763-4677-9256-E8391C03373D}"/>
+                <a16:creationId xmlns:a16="http://schemas.microsoft.com/office/drawing/2014/main" id="{374E3EC9-B3D3-4483-8566-E690C15D91BB}"/>
               </a:ext>
             </a:extLst>
           </p:cNvPr>
@@ -5467,7 +5467,7 @@
           <p:cNvPr id="15" name="">
             <a:extLst xmlns:a="http://schemas.openxmlformats.org/drawingml/2006/main">
               <a:ext uri="{FF2B5EF4-FFF2-40B4-BE49-F238E27FC236}">
-                <a16:creationId xmlns:a16="http://schemas.microsoft.com/office/drawing/2014/main" id="{51C15217-3B86-4CCE-8EF0-8D01B7D25029}"/>
+                <a16:creationId xmlns:a16="http://schemas.microsoft.com/office/drawing/2014/main" id="{826D07BD-2008-46C2-AE2A-4D1E7A755AF1}"/>
               </a:ext>
             </a:extLst>
           </p:cNvPr>
@@ -5500,7 +5500,7 @@
           <p:cNvPr id="16" name="">
             <a:extLst xmlns:a="http://schemas.openxmlformats.org/drawingml/2006/main">
               <a:ext uri="{FF2B5EF4-FFF2-40B4-BE49-F238E27FC236}">
-                <a16:creationId xmlns:a16="http://schemas.microsoft.com/office/drawing/2014/main" id="{EFF0498F-5CAC-47BA-A075-FB4041E0DB12}"/>
+                <a16:creationId xmlns:a16="http://schemas.microsoft.com/office/drawing/2014/main" id="{9932C5FB-1909-4299-8C02-4EECBACF6C62}"/>
               </a:ext>
             </a:extLst>
           </p:cNvPr>
@@ -5558,7 +5558,7 @@
           <p:cNvPr id="17" name="">
             <a:extLst xmlns:a="http://schemas.openxmlformats.org/drawingml/2006/main">
               <a:ext uri="{FF2B5EF4-FFF2-40B4-BE49-F238E27FC236}">
-                <a16:creationId xmlns:a16="http://schemas.microsoft.com/office/drawing/2014/main" id="{50C83346-C5AD-4078-B525-9264414C50FD}"/>
+                <a16:creationId xmlns:a16="http://schemas.microsoft.com/office/drawing/2014/main" id="{98C5EF12-0D6C-4DAF-A4EC-0F9F86D0B951}"/>
               </a:ext>
             </a:extLst>
           </p:cNvPr>
@@ -5616,7 +5616,7 @@
           <p:cNvPr id="18" name="">
             <a:extLst xmlns:a="http://schemas.openxmlformats.org/drawingml/2006/main">
               <a:ext uri="{FF2B5EF4-FFF2-40B4-BE49-F238E27FC236}">
-                <a16:creationId xmlns:a16="http://schemas.microsoft.com/office/drawing/2014/main" id="{5550775A-855E-4431-8145-2F1A9F0E2D7F}"/>
+                <a16:creationId xmlns:a16="http://schemas.microsoft.com/office/drawing/2014/main" id="{34B9BD21-BEC7-402C-A454-0CCD825E4961}"/>
               </a:ext>
             </a:extLst>
           </p:cNvPr>
@@ -5674,7 +5674,7 @@
           <p:cNvPr id="19" name="">
             <a:extLst xmlns:a="http://schemas.openxmlformats.org/drawingml/2006/main">
               <a:ext uri="{FF2B5EF4-FFF2-40B4-BE49-F238E27FC236}">
-                <a16:creationId xmlns:a16="http://schemas.microsoft.com/office/drawing/2014/main" id="{8AC2E3A4-D05C-4ADB-A20B-1BF22C247809}"/>
+                <a16:creationId xmlns:a16="http://schemas.microsoft.com/office/drawing/2014/main" id="{0ABC1957-6D97-4CB8-A76E-28A2EC2BC82F}"/>
               </a:ext>
             </a:extLst>
           </p:cNvPr>
@@ -5709,7 +5709,7 @@
           <p:cNvPr id="20" name="">
             <a:extLst xmlns:a="http://schemas.openxmlformats.org/drawingml/2006/main">
               <a:ext uri="{FF2B5EF4-FFF2-40B4-BE49-F238E27FC236}">
-                <a16:creationId xmlns:a16="http://schemas.microsoft.com/office/drawing/2014/main" id="{96608C1F-4FAC-4E6A-B73E-FEAA9B7F596C}"/>
+                <a16:creationId xmlns:a16="http://schemas.microsoft.com/office/drawing/2014/main" id="{F9F9AD53-3AAD-417B-93EF-5729B6D365D0}"/>
               </a:ext>
             </a:extLst>
           </p:cNvPr>
@@ -5767,7 +5767,7 @@
           <p:cNvPr id="21" name="">
             <a:extLst xmlns:a="http://schemas.openxmlformats.org/drawingml/2006/main">
               <a:ext uri="{FF2B5EF4-FFF2-40B4-BE49-F238E27FC236}">
-                <a16:creationId xmlns:a16="http://schemas.microsoft.com/office/drawing/2014/main" id="{37B8B7CC-F42A-4ED3-BF90-6955AADB29CB}"/>
+                <a16:creationId xmlns:a16="http://schemas.microsoft.com/office/drawing/2014/main" id="{E7F2D38F-5B33-4322-8364-E66743A70284}"/>
               </a:ext>
             </a:extLst>
           </p:cNvPr>
@@ -5823,7 +5823,7 @@
     </p:spTree>
     <p:extLst>
       <p:ext uri="{BB962C8B-B14F-4D97-AF65-F5344CB8AC3E}">
-        <p14:creationId xmlns:p14="http://schemas.microsoft.com/office/powerpoint/2010/main" val="825921350"/>
+        <p14:creationId xmlns:p14="http://schemas.microsoft.com/office/powerpoint/2010/main" val="1060750720"/>
       </p:ext>
     </p:extLst>
   </p:cSld>
@@ -5854,7 +5854,7 @@
           <p:cNvPr id="36" name="">
             <a:extLst xmlns:a="http://schemas.openxmlformats.org/drawingml/2006/main">
               <a:ext uri="{FF2B5EF4-FFF2-40B4-BE49-F238E27FC236}">
-                <a16:creationId xmlns:a16="http://schemas.microsoft.com/office/drawing/2014/main" id="{070DAE97-C0D9-4C28-84A3-7D1603AB4B7C}"/>
+                <a16:creationId xmlns:a16="http://schemas.microsoft.com/office/drawing/2014/main" id="{F3EB1B66-2B98-4BFD-B244-F34E56CF8A0C}"/>
               </a:ext>
             </a:extLst>
           </p:cNvPr>
@@ -5912,7 +5912,7 @@
           <p:cNvPr id="2" name="">
             <a:extLst xmlns:a="http://schemas.openxmlformats.org/drawingml/2006/main">
               <a:ext uri="{FF2B5EF4-FFF2-40B4-BE49-F238E27FC236}">
-                <a16:creationId xmlns:a16="http://schemas.microsoft.com/office/drawing/2014/main" id="{408BBCA1-1254-486B-BAEC-38A7FB3E5756}"/>
+                <a16:creationId xmlns:a16="http://schemas.microsoft.com/office/drawing/2014/main" id="{0CB2C13B-6A9F-4E40-A71A-A38371870773}"/>
               </a:ext>
             </a:extLst>
           </p:cNvPr>
@@ -5970,7 +5970,7 @@
           <p:cNvPr id="3" name="">
             <a:extLst xmlns:a="http://schemas.openxmlformats.org/drawingml/2006/main">
               <a:ext uri="{FF2B5EF4-FFF2-40B4-BE49-F238E27FC236}">
-                <a16:creationId xmlns:a16="http://schemas.microsoft.com/office/drawing/2014/main" id="{E9BA9ED9-6034-4303-BA59-A722A677F867}"/>
+                <a16:creationId xmlns:a16="http://schemas.microsoft.com/office/drawing/2014/main" id="{9ED09B74-7FD2-41B9-AD71-945CC2C3006C}"/>
               </a:ext>
             </a:extLst>
           </p:cNvPr>
@@ -6003,7 +6003,7 @@
           <p:cNvPr id="4" name="">
             <a:extLst xmlns:a="http://schemas.openxmlformats.org/drawingml/2006/main">
               <a:ext uri="{FF2B5EF4-FFF2-40B4-BE49-F238E27FC236}">
-                <a16:creationId xmlns:a16="http://schemas.microsoft.com/office/drawing/2014/main" id="{AB5A356F-E528-465D-B349-138D2BBDF865}"/>
+                <a16:creationId xmlns:a16="http://schemas.microsoft.com/office/drawing/2014/main" id="{B6C5CBA9-1553-4053-B4BF-E82B37135363}"/>
               </a:ext>
             </a:extLst>
           </p:cNvPr>
@@ -6061,7 +6061,7 @@
           <p:cNvPr id="5" name="">
             <a:extLst xmlns:a="http://schemas.openxmlformats.org/drawingml/2006/main">
               <a:ext uri="{FF2B5EF4-FFF2-40B4-BE49-F238E27FC236}">
-                <a16:creationId xmlns:a16="http://schemas.microsoft.com/office/drawing/2014/main" id="{DCE41924-E6FA-48CA-9BA7-11FD5BBE95E9}"/>
+                <a16:creationId xmlns:a16="http://schemas.microsoft.com/office/drawing/2014/main" id="{88870EF0-AC92-428D-BBA4-4DAC2F11D2C8}"/>
               </a:ext>
             </a:extLst>
           </p:cNvPr>
@@ -6119,7 +6119,7 @@
           <p:cNvPr id="6" name="">
             <a:extLst xmlns:a="http://schemas.openxmlformats.org/drawingml/2006/main">
               <a:ext uri="{FF2B5EF4-FFF2-40B4-BE49-F238E27FC236}">
-                <a16:creationId xmlns:a16="http://schemas.microsoft.com/office/drawing/2014/main" id="{7E32A813-0B4F-49F7-AFF8-68017F33AABD}"/>
+                <a16:creationId xmlns:a16="http://schemas.microsoft.com/office/drawing/2014/main" id="{BCAE6F09-70C3-448E-8B7A-4953731166FD}"/>
               </a:ext>
             </a:extLst>
           </p:cNvPr>
@@ -6154,7 +6154,7 @@
           <p:cNvPr id="7" name="">
             <a:extLst xmlns:a="http://schemas.openxmlformats.org/drawingml/2006/main">
               <a:ext uri="{FF2B5EF4-FFF2-40B4-BE49-F238E27FC236}">
-                <a16:creationId xmlns:a16="http://schemas.microsoft.com/office/drawing/2014/main" id="{E8A3C9CB-A000-4F89-8F43-1BC7EFC91A3E}"/>
+                <a16:creationId xmlns:a16="http://schemas.microsoft.com/office/drawing/2014/main" id="{F5FCA550-8B99-4F9D-9B73-4DD4A0B6BD43}"/>
               </a:ext>
             </a:extLst>
           </p:cNvPr>
@@ -6212,7 +6212,7 @@
           <p:cNvPr id="8" name="">
             <a:extLst xmlns:a="http://schemas.openxmlformats.org/drawingml/2006/main">
               <a:ext uri="{FF2B5EF4-FFF2-40B4-BE49-F238E27FC236}">
-                <a16:creationId xmlns:a16="http://schemas.microsoft.com/office/drawing/2014/main" id="{45DC83DF-4655-4FB5-9667-91DE7DDC6AF7}"/>
+                <a16:creationId xmlns:a16="http://schemas.microsoft.com/office/drawing/2014/main" id="{FB97C33E-3C6A-407D-9CBD-A3AE9A757DD6}"/>
               </a:ext>
             </a:extLst>
           </p:cNvPr>
@@ -6243,7 +6243,7 @@
           <p:cNvPr id="9" name="">
             <a:extLst xmlns:a="http://schemas.openxmlformats.org/drawingml/2006/main">
               <a:ext uri="{FF2B5EF4-FFF2-40B4-BE49-F238E27FC236}">
-                <a16:creationId xmlns:a16="http://schemas.microsoft.com/office/drawing/2014/main" id="{E8E65393-A6E9-4A61-8CBD-1D7FAAB858C3}"/>
+                <a16:creationId xmlns:a16="http://schemas.microsoft.com/office/drawing/2014/main" id="{288BF864-5645-4447-937A-DA3A01B41E4D}"/>
               </a:ext>
             </a:extLst>
           </p:cNvPr>
@@ -6301,7 +6301,7 @@
           <p:cNvPr id="10" name="">
             <a:extLst xmlns:a="http://schemas.openxmlformats.org/drawingml/2006/main">
               <a:ext uri="{FF2B5EF4-FFF2-40B4-BE49-F238E27FC236}">
-                <a16:creationId xmlns:a16="http://schemas.microsoft.com/office/drawing/2014/main" id="{D8A7A685-4D6C-4875-A840-98D04AD54FC2}"/>
+                <a16:creationId xmlns:a16="http://schemas.microsoft.com/office/drawing/2014/main" id="{A3EA273E-9F32-4B5D-A596-B57E04289545}"/>
               </a:ext>
             </a:extLst>
           </p:cNvPr>
@@ -6359,7 +6359,7 @@
           <p:cNvPr id="11" name="">
             <a:extLst xmlns:a="http://schemas.openxmlformats.org/drawingml/2006/main">
               <a:ext uri="{FF2B5EF4-FFF2-40B4-BE49-F238E27FC236}">
-                <a16:creationId xmlns:a16="http://schemas.microsoft.com/office/drawing/2014/main" id="{F3D05ECD-4155-4BAE-B118-7FF8292C01AF}"/>
+                <a16:creationId xmlns:a16="http://schemas.microsoft.com/office/drawing/2014/main" id="{ACF0AF1E-ED0C-42F5-8B1E-6A2D9E65B84F}"/>
               </a:ext>
             </a:extLst>
           </p:cNvPr>
@@ -6417,7 +6417,7 @@
           <p:cNvPr id="12" name="">
             <a:extLst xmlns:a="http://schemas.openxmlformats.org/drawingml/2006/main">
               <a:ext uri="{FF2B5EF4-FFF2-40B4-BE49-F238E27FC236}">
-                <a16:creationId xmlns:a16="http://schemas.microsoft.com/office/drawing/2014/main" id="{B7914CFA-0B41-4BA9-A666-60C1EA78F6E6}"/>
+                <a16:creationId xmlns:a16="http://schemas.microsoft.com/office/drawing/2014/main" id="{89B92AAB-EC21-4ADB-A84F-3C7A4F79B852}"/>
               </a:ext>
             </a:extLst>
           </p:cNvPr>
@@ -6452,7 +6452,7 @@
           <p:cNvPr id="13" name="">
             <a:extLst xmlns:a="http://schemas.openxmlformats.org/drawingml/2006/main">
               <a:ext uri="{FF2B5EF4-FFF2-40B4-BE49-F238E27FC236}">
-                <a16:creationId xmlns:a16="http://schemas.microsoft.com/office/drawing/2014/main" id="{43700E32-4BA8-4AF0-9DD8-0A663F1C522E}"/>
+                <a16:creationId xmlns:a16="http://schemas.microsoft.com/office/drawing/2014/main" id="{01FB8E7F-4F18-40B9-94BB-51953CD22F77}"/>
               </a:ext>
             </a:extLst>
           </p:cNvPr>
@@ -6510,7 +6510,7 @@
           <p:cNvPr id="14" name="">
             <a:extLst xmlns:a="http://schemas.openxmlformats.org/drawingml/2006/main">
               <a:ext uri="{FF2B5EF4-FFF2-40B4-BE49-F238E27FC236}">
-                <a16:creationId xmlns:a16="http://schemas.microsoft.com/office/drawing/2014/main" id="{3D36B32F-9B80-412C-B755-7575A59E9BE4}"/>
+                <a16:creationId xmlns:a16="http://schemas.microsoft.com/office/drawing/2014/main" id="{59653A80-E8B2-4571-9AAF-0610996B9C3B}"/>
               </a:ext>
             </a:extLst>
           </p:cNvPr>
@@ -6541,7 +6541,7 @@
           <p:cNvPr id="15" name="">
             <a:extLst xmlns:a="http://schemas.openxmlformats.org/drawingml/2006/main">
               <a:ext uri="{FF2B5EF4-FFF2-40B4-BE49-F238E27FC236}">
-                <a16:creationId xmlns:a16="http://schemas.microsoft.com/office/drawing/2014/main" id="{92F84863-0ECF-4B15-9AE4-752073B14FBD}"/>
+                <a16:creationId xmlns:a16="http://schemas.microsoft.com/office/drawing/2014/main" id="{A7172E06-56AE-489E-AD44-F7AD1B92ACCE}"/>
               </a:ext>
             </a:extLst>
           </p:cNvPr>
@@ -6599,7 +6599,7 @@
           <p:cNvPr id="16" name="">
             <a:extLst xmlns:a="http://schemas.openxmlformats.org/drawingml/2006/main">
               <a:ext uri="{FF2B5EF4-FFF2-40B4-BE49-F238E27FC236}">
-                <a16:creationId xmlns:a16="http://schemas.microsoft.com/office/drawing/2014/main" id="{1D6A2597-E0AA-4704-B003-2562D0593B12}"/>
+                <a16:creationId xmlns:a16="http://schemas.microsoft.com/office/drawing/2014/main" id="{F1E8BE6F-AF84-429D-992E-16E4E0EC6B7D}"/>
               </a:ext>
             </a:extLst>
           </p:cNvPr>
@@ -6657,7 +6657,7 @@
           <p:cNvPr id="17" name="">
             <a:extLst xmlns:a="http://schemas.openxmlformats.org/drawingml/2006/main">
               <a:ext uri="{FF2B5EF4-FFF2-40B4-BE49-F238E27FC236}">
-                <a16:creationId xmlns:a16="http://schemas.microsoft.com/office/drawing/2014/main" id="{A8DEA9C5-7CF2-4A9F-83D1-D37700C5A6C9}"/>
+                <a16:creationId xmlns:a16="http://schemas.microsoft.com/office/drawing/2014/main" id="{AC9EE931-2356-4590-A214-559C07CD2F7A}"/>
               </a:ext>
             </a:extLst>
           </p:cNvPr>
@@ -6715,7 +6715,7 @@
           <p:cNvPr id="18" name="">
             <a:extLst xmlns:a="http://schemas.openxmlformats.org/drawingml/2006/main">
               <a:ext uri="{FF2B5EF4-FFF2-40B4-BE49-F238E27FC236}">
-                <a16:creationId xmlns:a16="http://schemas.microsoft.com/office/drawing/2014/main" id="{F5D2C88D-DE95-4C05-9CA9-50551DE5E31D}"/>
+                <a16:creationId xmlns:a16="http://schemas.microsoft.com/office/drawing/2014/main" id="{3CF553A9-A6C7-4806-BBB0-BCED4978F039}"/>
               </a:ext>
             </a:extLst>
           </p:cNvPr>
@@ -6750,7 +6750,7 @@
           <p:cNvPr id="19" name="">
             <a:extLst xmlns:a="http://schemas.openxmlformats.org/drawingml/2006/main">
               <a:ext uri="{FF2B5EF4-FFF2-40B4-BE49-F238E27FC236}">
-                <a16:creationId xmlns:a16="http://schemas.microsoft.com/office/drawing/2014/main" id="{D84C40AB-EFD0-4DBD-B4F6-89825D09F398}"/>
+                <a16:creationId xmlns:a16="http://schemas.microsoft.com/office/drawing/2014/main" id="{79950233-C7A2-41A2-8E1E-BC5A85FD3346}"/>
               </a:ext>
             </a:extLst>
           </p:cNvPr>
@@ -6808,7 +6808,7 @@
           <p:cNvPr id="20" name="">
             <a:extLst xmlns:a="http://schemas.openxmlformats.org/drawingml/2006/main">
               <a:ext uri="{FF2B5EF4-FFF2-40B4-BE49-F238E27FC236}">
-                <a16:creationId xmlns:a16="http://schemas.microsoft.com/office/drawing/2014/main" id="{F6067C3A-864C-426B-A54D-8836D845015F}"/>
+                <a16:creationId xmlns:a16="http://schemas.microsoft.com/office/drawing/2014/main" id="{817D3DC3-4514-4ED0-B530-CF8650FE4A1D}"/>
               </a:ext>
             </a:extLst>
           </p:cNvPr>
@@ -6839,7 +6839,7 @@
           <p:cNvPr id="21" name="">
             <a:extLst xmlns:a="http://schemas.openxmlformats.org/drawingml/2006/main">
               <a:ext uri="{FF2B5EF4-FFF2-40B4-BE49-F238E27FC236}">
-                <a16:creationId xmlns:a16="http://schemas.microsoft.com/office/drawing/2014/main" id="{21D1117F-5710-4EF3-AF67-8F42A3779F28}"/>
+                <a16:creationId xmlns:a16="http://schemas.microsoft.com/office/drawing/2014/main" id="{ED831D55-7B7B-4FC0-BAB7-8D92472E1DB8}"/>
               </a:ext>
             </a:extLst>
           </p:cNvPr>
@@ -6897,7 +6897,7 @@
           <p:cNvPr id="22" name="">
             <a:extLst xmlns:a="http://schemas.openxmlformats.org/drawingml/2006/main">
               <a:ext uri="{FF2B5EF4-FFF2-40B4-BE49-F238E27FC236}">
-                <a16:creationId xmlns:a16="http://schemas.microsoft.com/office/drawing/2014/main" id="{07B8864B-AF10-452C-8990-7E65B7E38F99}"/>
+                <a16:creationId xmlns:a16="http://schemas.microsoft.com/office/drawing/2014/main" id="{FC30DBB9-49F2-4495-9B44-6DE8F2FC1F3E}"/>
               </a:ext>
             </a:extLst>
           </p:cNvPr>
@@ -6955,7 +6955,7 @@
           <p:cNvPr id="23" name="">
             <a:extLst xmlns:a="http://schemas.openxmlformats.org/drawingml/2006/main">
               <a:ext uri="{FF2B5EF4-FFF2-40B4-BE49-F238E27FC236}">
-                <a16:creationId xmlns:a16="http://schemas.microsoft.com/office/drawing/2014/main" id="{66251AA4-76FD-4517-A922-774B09193A4B}"/>
+                <a16:creationId xmlns:a16="http://schemas.microsoft.com/office/drawing/2014/main" id="{0AB84646-3466-46D4-9CB1-8B5C22935DD0}"/>
               </a:ext>
             </a:extLst>
           </p:cNvPr>
@@ -7013,7 +7013,7 @@
           <p:cNvPr id="24" name="">
             <a:extLst xmlns:a="http://schemas.openxmlformats.org/drawingml/2006/main">
               <a:ext uri="{FF2B5EF4-FFF2-40B4-BE49-F238E27FC236}">
-                <a16:creationId xmlns:a16="http://schemas.microsoft.com/office/drawing/2014/main" id="{D81CFA24-370B-4528-A9E2-619C13944453}"/>
+                <a16:creationId xmlns:a16="http://schemas.microsoft.com/office/drawing/2014/main" id="{FC040C9A-2350-44FC-8419-231E86017C81}"/>
               </a:ext>
             </a:extLst>
           </p:cNvPr>
@@ -7048,7 +7048,7 @@
           <p:cNvPr id="25" name="">
             <a:extLst xmlns:a="http://schemas.openxmlformats.org/drawingml/2006/main">
               <a:ext uri="{FF2B5EF4-FFF2-40B4-BE49-F238E27FC236}">
-                <a16:creationId xmlns:a16="http://schemas.microsoft.com/office/drawing/2014/main" id="{6E2E72C7-B64D-4613-83E5-F05AA714D8B1}"/>
+                <a16:creationId xmlns:a16="http://schemas.microsoft.com/office/drawing/2014/main" id="{E35563A5-95DB-48FB-B278-A7504CBA7E59}"/>
               </a:ext>
             </a:extLst>
           </p:cNvPr>
@@ -7106,7 +7106,7 @@
           <p:cNvPr id="26" name="">
             <a:extLst xmlns:a="http://schemas.openxmlformats.org/drawingml/2006/main">
               <a:ext uri="{FF2B5EF4-FFF2-40B4-BE49-F238E27FC236}">
-                <a16:creationId xmlns:a16="http://schemas.microsoft.com/office/drawing/2014/main" id="{8DDD8BFA-9B3B-46C1-848E-085705B7CF9D}"/>
+                <a16:creationId xmlns:a16="http://schemas.microsoft.com/office/drawing/2014/main" id="{321BAD9A-F7AD-446B-84FC-38C028A28BC5}"/>
               </a:ext>
             </a:extLst>
           </p:cNvPr>
@@ -7137,7 +7137,7 @@
           <p:cNvPr id="27" name="">
             <a:extLst xmlns:a="http://schemas.openxmlformats.org/drawingml/2006/main">
               <a:ext uri="{FF2B5EF4-FFF2-40B4-BE49-F238E27FC236}">
-                <a16:creationId xmlns:a16="http://schemas.microsoft.com/office/drawing/2014/main" id="{624556D5-DEC2-43D3-B4A9-2E83B3CCA4D3}"/>
+                <a16:creationId xmlns:a16="http://schemas.microsoft.com/office/drawing/2014/main" id="{C6CEC038-6BC4-43FC-BF3D-FB518CB4716F}"/>
               </a:ext>
             </a:extLst>
           </p:cNvPr>
@@ -7195,7 +7195,7 @@
           <p:cNvPr id="28" name="">
             <a:extLst xmlns:a="http://schemas.openxmlformats.org/drawingml/2006/main">
               <a:ext uri="{FF2B5EF4-FFF2-40B4-BE49-F238E27FC236}">
-                <a16:creationId xmlns:a16="http://schemas.microsoft.com/office/drawing/2014/main" id="{29691C5B-32B3-4237-98E0-24FAB93EAAA5}"/>
+                <a16:creationId xmlns:a16="http://schemas.microsoft.com/office/drawing/2014/main" id="{92BFAF3F-C847-46B5-98AC-40A3AF6ACCE6}"/>
               </a:ext>
             </a:extLst>
           </p:cNvPr>
@@ -7253,7 +7253,7 @@
           <p:cNvPr id="29" name="">
             <a:extLst xmlns:a="http://schemas.openxmlformats.org/drawingml/2006/main">
               <a:ext uri="{FF2B5EF4-FFF2-40B4-BE49-F238E27FC236}">
-                <a16:creationId xmlns:a16="http://schemas.microsoft.com/office/drawing/2014/main" id="{A9DB4F61-23B6-4D81-86FA-9D1092038845}"/>
+                <a16:creationId xmlns:a16="http://schemas.microsoft.com/office/drawing/2014/main" id="{ABAE2C46-E503-4848-B3F6-A3E373C5E04B}"/>
               </a:ext>
             </a:extLst>
           </p:cNvPr>
@@ -7311,7 +7311,7 @@
           <p:cNvPr id="30" name="">
             <a:extLst xmlns:a="http://schemas.openxmlformats.org/drawingml/2006/main">
               <a:ext uri="{FF2B5EF4-FFF2-40B4-BE49-F238E27FC236}">
-                <a16:creationId xmlns:a16="http://schemas.microsoft.com/office/drawing/2014/main" id="{55DA708E-A4C6-400B-AB6B-E6EA77905704}"/>
+                <a16:creationId xmlns:a16="http://schemas.microsoft.com/office/drawing/2014/main" id="{2282FBC2-1D55-47E5-836F-FEEEA04E2058}"/>
               </a:ext>
             </a:extLst>
           </p:cNvPr>
@@ -7346,7 +7346,7 @@
           <p:cNvPr id="31" name="">
             <a:extLst xmlns:a="http://schemas.openxmlformats.org/drawingml/2006/main">
               <a:ext uri="{FF2B5EF4-FFF2-40B4-BE49-F238E27FC236}">
-                <a16:creationId xmlns:a16="http://schemas.microsoft.com/office/drawing/2014/main" id="{45F0CAA4-6D31-4538-BBFA-0812DFD01F9C}"/>
+                <a16:creationId xmlns:a16="http://schemas.microsoft.com/office/drawing/2014/main" id="{80F2BE2A-E45E-49FF-87BB-0F91C6819693}"/>
               </a:ext>
             </a:extLst>
           </p:cNvPr>
@@ -7404,7 +7404,7 @@
           <p:cNvPr id="32" name="">
             <a:extLst xmlns:a="http://schemas.openxmlformats.org/drawingml/2006/main">
               <a:ext uri="{FF2B5EF4-FFF2-40B4-BE49-F238E27FC236}">
-                <a16:creationId xmlns:a16="http://schemas.microsoft.com/office/drawing/2014/main" id="{4A2141BE-E4E9-4B70-87C5-F8322CC297C8}"/>
+                <a16:creationId xmlns:a16="http://schemas.microsoft.com/office/drawing/2014/main" id="{04B5EBF1-CB24-4D90-9829-24E25E2CA344}"/>
               </a:ext>
             </a:extLst>
           </p:cNvPr>
@@ -7435,7 +7435,7 @@
           <p:cNvPr id="33" name="">
             <a:extLst xmlns:a="http://schemas.openxmlformats.org/drawingml/2006/main">
               <a:ext uri="{FF2B5EF4-FFF2-40B4-BE49-F238E27FC236}">
-                <a16:creationId xmlns:a16="http://schemas.microsoft.com/office/drawing/2014/main" id="{E9D60B22-5833-4C0D-BF14-D3DDFE08DC96}"/>
+                <a16:creationId xmlns:a16="http://schemas.microsoft.com/office/drawing/2014/main" id="{FCCC0DE6-9000-477F-9C0B-A659E3915DAD}"/>
               </a:ext>
             </a:extLst>
           </p:cNvPr>
@@ -7493,7 +7493,7 @@
           <p:cNvPr id="34" name="">
             <a:extLst xmlns:a="http://schemas.openxmlformats.org/drawingml/2006/main">
               <a:ext uri="{FF2B5EF4-FFF2-40B4-BE49-F238E27FC236}">
-                <a16:creationId xmlns:a16="http://schemas.microsoft.com/office/drawing/2014/main" id="{D65C6929-CB3B-4194-AAD3-927C949E0E3B}"/>
+                <a16:creationId xmlns:a16="http://schemas.microsoft.com/office/drawing/2014/main" id="{F920C3F6-6A26-43E9-BE2E-8ECD47EBF825}"/>
               </a:ext>
             </a:extLst>
           </p:cNvPr>
@@ -7551,7 +7551,7 @@
           <p:cNvPr id="35" name="">
             <a:extLst xmlns:a="http://schemas.openxmlformats.org/drawingml/2006/main">
               <a:ext uri="{FF2B5EF4-FFF2-40B4-BE49-F238E27FC236}">
-                <a16:creationId xmlns:a16="http://schemas.microsoft.com/office/drawing/2014/main" id="{F3A2BA91-6CC5-401D-AC9A-C6DB0EDEAB53}"/>
+                <a16:creationId xmlns:a16="http://schemas.microsoft.com/office/drawing/2014/main" id="{D874E36D-DAAB-4B8D-B013-A67AD9882901}"/>
               </a:ext>
             </a:extLst>
           </p:cNvPr>
@@ -7607,7 +7607,7 @@
     </p:spTree>
     <p:extLst>
       <p:ext uri="{BB962C8B-B14F-4D97-AF65-F5344CB8AC3E}">
-        <p14:creationId xmlns:p14="http://schemas.microsoft.com/office/powerpoint/2010/main" val="56885062"/>
+        <p14:creationId xmlns:p14="http://schemas.microsoft.com/office/powerpoint/2010/main" val="1826262715"/>
       </p:ext>
     </p:extLst>
   </p:cSld>
@@ -7638,7 +7638,7 @@
           <p:cNvPr id="38" name="">
             <a:extLst xmlns:a="http://schemas.openxmlformats.org/drawingml/2006/main">
               <a:ext uri="{FF2B5EF4-FFF2-40B4-BE49-F238E27FC236}">
-                <a16:creationId xmlns:a16="http://schemas.microsoft.com/office/drawing/2014/main" id="{4878BA9A-CAAB-4FF8-BF53-9D70727FC9B9}"/>
+                <a16:creationId xmlns:a16="http://schemas.microsoft.com/office/drawing/2014/main" id="{EF541904-FBA1-41CF-97AA-EC4981361D50}"/>
               </a:ext>
             </a:extLst>
           </p:cNvPr>
@@ -7696,7 +7696,7 @@
           <p:cNvPr id="2" name="">
             <a:extLst xmlns:a="http://schemas.openxmlformats.org/drawingml/2006/main">
               <a:ext uri="{FF2B5EF4-FFF2-40B4-BE49-F238E27FC236}">
-                <a16:creationId xmlns:a16="http://schemas.microsoft.com/office/drawing/2014/main" id="{F91CC7B0-5BBD-4429-8C90-E97720637908}"/>
+                <a16:creationId xmlns:a16="http://schemas.microsoft.com/office/drawing/2014/main" id="{7928FEA8-B289-40E3-A798-8751A0C3718B}"/>
               </a:ext>
             </a:extLst>
           </p:cNvPr>
@@ -7754,7 +7754,7 @@
           <p:cNvPr id="3" name="">
             <a:extLst xmlns:a="http://schemas.openxmlformats.org/drawingml/2006/main">
               <a:ext uri="{FF2B5EF4-FFF2-40B4-BE49-F238E27FC236}">
-                <a16:creationId xmlns:a16="http://schemas.microsoft.com/office/drawing/2014/main" id="{90AB7E45-7096-47E6-83D7-EEB2CD80FA11}"/>
+                <a16:creationId xmlns:a16="http://schemas.microsoft.com/office/drawing/2014/main" id="{3C8086D6-110C-4682-99E2-66E704A220CC}"/>
               </a:ext>
             </a:extLst>
           </p:cNvPr>
@@ -7787,7 +7787,7 @@
           <p:cNvPr id="4" name="">
             <a:extLst xmlns:a="http://schemas.openxmlformats.org/drawingml/2006/main">
               <a:ext uri="{FF2B5EF4-FFF2-40B4-BE49-F238E27FC236}">
-                <a16:creationId xmlns:a16="http://schemas.microsoft.com/office/drawing/2014/main" id="{947E5151-0788-4609-BB81-49D9CD131C5F}"/>
+                <a16:creationId xmlns:a16="http://schemas.microsoft.com/office/drawing/2014/main" id="{153206B8-6603-414B-9236-44C7DACE5294}"/>
               </a:ext>
             </a:extLst>
           </p:cNvPr>
@@ -7845,7 +7845,7 @@
           <p:cNvPr id="5" name="">
             <a:extLst xmlns:a="http://schemas.openxmlformats.org/drawingml/2006/main">
               <a:ext uri="{FF2B5EF4-FFF2-40B4-BE49-F238E27FC236}">
-                <a16:creationId xmlns:a16="http://schemas.microsoft.com/office/drawing/2014/main" id="{3AD8D66A-0C2E-4CA6-8731-CA7EF504482B}"/>
+                <a16:creationId xmlns:a16="http://schemas.microsoft.com/office/drawing/2014/main" id="{B4E438EA-1E84-4AA1-AEAF-0640A597C877}"/>
               </a:ext>
             </a:extLst>
           </p:cNvPr>
@@ -7903,7 +7903,7 @@
           <p:cNvPr id="6" name="">
             <a:extLst xmlns:a="http://schemas.openxmlformats.org/drawingml/2006/main">
               <a:ext uri="{FF2B5EF4-FFF2-40B4-BE49-F238E27FC236}">
-                <a16:creationId xmlns:a16="http://schemas.microsoft.com/office/drawing/2014/main" id="{8D37F0F5-31AB-4258-B462-139081C35A6F}"/>
+                <a16:creationId xmlns:a16="http://schemas.microsoft.com/office/drawing/2014/main" id="{3D9E3E3D-4883-414B-9CAF-E2466A1FEB25}"/>
               </a:ext>
             </a:extLst>
           </p:cNvPr>
@@ -7938,7 +7938,7 @@
           <p:cNvPr id="7" name="">
             <a:extLst xmlns:a="http://schemas.openxmlformats.org/drawingml/2006/main">
               <a:ext uri="{FF2B5EF4-FFF2-40B4-BE49-F238E27FC236}">
-                <a16:creationId xmlns:a16="http://schemas.microsoft.com/office/drawing/2014/main" id="{0D73CE8F-7707-4F3D-9FAD-A1ACAD338326}"/>
+                <a16:creationId xmlns:a16="http://schemas.microsoft.com/office/drawing/2014/main" id="{DA9AF76A-9DB6-46E2-8A1D-CDD5E007155B}"/>
               </a:ext>
             </a:extLst>
           </p:cNvPr>
@@ -7996,7 +7996,7 @@
           <p:cNvPr id="8" name="">
             <a:extLst xmlns:a="http://schemas.openxmlformats.org/drawingml/2006/main">
               <a:ext uri="{FF2B5EF4-FFF2-40B4-BE49-F238E27FC236}">
-                <a16:creationId xmlns:a16="http://schemas.microsoft.com/office/drawing/2014/main" id="{EC8FF95C-F5C3-4FD9-9CF3-E08D7256C961}"/>
+                <a16:creationId xmlns:a16="http://schemas.microsoft.com/office/drawing/2014/main" id="{8353CD9C-140C-4D70-8781-C41FB346E982}"/>
               </a:ext>
             </a:extLst>
           </p:cNvPr>
@@ -8054,7 +8054,7 @@
           <p:cNvPr id="9" name="">
             <a:extLst xmlns:a="http://schemas.openxmlformats.org/drawingml/2006/main">
               <a:ext uri="{FF2B5EF4-FFF2-40B4-BE49-F238E27FC236}">
-                <a16:creationId xmlns:a16="http://schemas.microsoft.com/office/drawing/2014/main" id="{AC267F12-132A-49F7-95E1-05FBA4193A29}"/>
+                <a16:creationId xmlns:a16="http://schemas.microsoft.com/office/drawing/2014/main" id="{BD90653B-2F24-4E87-ACC7-A3B6B14BEC3B}"/>
               </a:ext>
             </a:extLst>
           </p:cNvPr>
@@ -8112,7 +8112,7 @@
           <p:cNvPr id="10" name="">
             <a:extLst xmlns:a="http://schemas.openxmlformats.org/drawingml/2006/main">
               <a:ext uri="{FF2B5EF4-FFF2-40B4-BE49-F238E27FC236}">
-                <a16:creationId xmlns:a16="http://schemas.microsoft.com/office/drawing/2014/main" id="{E9F48141-B307-4FE9-AA8A-8D84756295EF}"/>
+                <a16:creationId xmlns:a16="http://schemas.microsoft.com/office/drawing/2014/main" id="{8B19B79C-742D-4E64-9622-60318561243D}"/>
               </a:ext>
             </a:extLst>
           </p:cNvPr>
@@ -8147,7 +8147,7 @@
           <p:cNvPr id="11" name="">
             <a:extLst xmlns:a="http://schemas.openxmlformats.org/drawingml/2006/main">
               <a:ext uri="{FF2B5EF4-FFF2-40B4-BE49-F238E27FC236}">
-                <a16:creationId xmlns:a16="http://schemas.microsoft.com/office/drawing/2014/main" id="{F43038BC-F8F6-45BA-A5F4-BB0504F80D40}"/>
+                <a16:creationId xmlns:a16="http://schemas.microsoft.com/office/drawing/2014/main" id="{8DF74DC9-05DE-42CD-A3FA-1526DE5EBDB1}"/>
               </a:ext>
             </a:extLst>
           </p:cNvPr>
@@ -8205,7 +8205,7 @@
           <p:cNvPr id="12" name="">
             <a:extLst xmlns:a="http://schemas.openxmlformats.org/drawingml/2006/main">
               <a:ext uri="{FF2B5EF4-FFF2-40B4-BE49-F238E27FC236}">
-                <a16:creationId xmlns:a16="http://schemas.microsoft.com/office/drawing/2014/main" id="{3598C63E-1D39-4628-B2F6-812564472E72}"/>
+                <a16:creationId xmlns:a16="http://schemas.microsoft.com/office/drawing/2014/main" id="{DB16EA55-12EA-43AF-B7EA-8FB381A39AA6}"/>
               </a:ext>
             </a:extLst>
           </p:cNvPr>
@@ -8263,7 +8263,7 @@
           <p:cNvPr id="13" name="">
             <a:extLst xmlns:a="http://schemas.openxmlformats.org/drawingml/2006/main">
               <a:ext uri="{FF2B5EF4-FFF2-40B4-BE49-F238E27FC236}">
-                <a16:creationId xmlns:a16="http://schemas.microsoft.com/office/drawing/2014/main" id="{6F7C07A5-6F30-406F-9E4C-7EEF53F025E3}"/>
+                <a16:creationId xmlns:a16="http://schemas.microsoft.com/office/drawing/2014/main" id="{83EFAFCB-374B-4F63-B833-0EBB9C436166}"/>
               </a:ext>
             </a:extLst>
           </p:cNvPr>
@@ -8321,7 +8321,7 @@
           <p:cNvPr id="14" name="">
             <a:extLst xmlns:a="http://schemas.openxmlformats.org/drawingml/2006/main">
               <a:ext uri="{FF2B5EF4-FFF2-40B4-BE49-F238E27FC236}">
-                <a16:creationId xmlns:a16="http://schemas.microsoft.com/office/drawing/2014/main" id="{19E69EE9-D84E-4AC6-8976-1E1DDD7E9A1B}"/>
+                <a16:creationId xmlns:a16="http://schemas.microsoft.com/office/drawing/2014/main" id="{7AA8C41D-F30A-48E3-A9DD-588899C50B4B}"/>
               </a:ext>
             </a:extLst>
           </p:cNvPr>
@@ -8356,7 +8356,7 @@
           <p:cNvPr id="15" name="">
             <a:extLst xmlns:a="http://schemas.openxmlformats.org/drawingml/2006/main">
               <a:ext uri="{FF2B5EF4-FFF2-40B4-BE49-F238E27FC236}">
-                <a16:creationId xmlns:a16="http://schemas.microsoft.com/office/drawing/2014/main" id="{EE1DF238-9AC6-4809-8489-E51FCB2DDCBF}"/>
+                <a16:creationId xmlns:a16="http://schemas.microsoft.com/office/drawing/2014/main" id="{1ADE9B8C-A9EA-4186-9BE7-3ED0182437E7}"/>
               </a:ext>
             </a:extLst>
           </p:cNvPr>
@@ -8414,7 +8414,7 @@
           <p:cNvPr id="16" name="">
             <a:extLst xmlns:a="http://schemas.openxmlformats.org/drawingml/2006/main">
               <a:ext uri="{FF2B5EF4-FFF2-40B4-BE49-F238E27FC236}">
-                <a16:creationId xmlns:a16="http://schemas.microsoft.com/office/drawing/2014/main" id="{0D5FE4A9-6B1E-4EF1-99F8-FC2DD135E967}"/>
+                <a16:creationId xmlns:a16="http://schemas.microsoft.com/office/drawing/2014/main" id="{F20CFDAC-D28D-422A-804D-476C9A7BDB97}"/>
               </a:ext>
             </a:extLst>
           </p:cNvPr>
@@ -8472,7 +8472,7 @@
           <p:cNvPr id="17" name="">
             <a:extLst xmlns:a="http://schemas.openxmlformats.org/drawingml/2006/main">
               <a:ext uri="{FF2B5EF4-FFF2-40B4-BE49-F238E27FC236}">
-                <a16:creationId xmlns:a16="http://schemas.microsoft.com/office/drawing/2014/main" id="{F8EA2616-22AB-4609-BEC8-87217151F73D}"/>
+                <a16:creationId xmlns:a16="http://schemas.microsoft.com/office/drawing/2014/main" id="{5D910620-724D-4AE6-A025-46C5602A45A1}"/>
               </a:ext>
             </a:extLst>
           </p:cNvPr>
@@ -8530,7 +8530,7 @@
           <p:cNvPr id="18" name="">
             <a:extLst xmlns:a="http://schemas.openxmlformats.org/drawingml/2006/main">
               <a:ext uri="{FF2B5EF4-FFF2-40B4-BE49-F238E27FC236}">
-                <a16:creationId xmlns:a16="http://schemas.microsoft.com/office/drawing/2014/main" id="{A7FE607D-D165-4BBA-AC3D-AE6319BF4336}"/>
+                <a16:creationId xmlns:a16="http://schemas.microsoft.com/office/drawing/2014/main" id="{7DB0DD4F-0B24-4772-B648-CEAD7AD7E475}"/>
               </a:ext>
             </a:extLst>
           </p:cNvPr>
@@ -8565,7 +8565,7 @@
           <p:cNvPr id="19" name="">
             <a:extLst xmlns:a="http://schemas.openxmlformats.org/drawingml/2006/main">
               <a:ext uri="{FF2B5EF4-FFF2-40B4-BE49-F238E27FC236}">
-                <a16:creationId xmlns:a16="http://schemas.microsoft.com/office/drawing/2014/main" id="{EDDEA213-9BEC-4E5D-9D15-7592940D3CEC}"/>
+                <a16:creationId xmlns:a16="http://schemas.microsoft.com/office/drawing/2014/main" id="{E2D4D796-38D8-4F08-B58B-69EC7D00AD75}"/>
               </a:ext>
             </a:extLst>
           </p:cNvPr>
@@ -8623,7 +8623,7 @@
           <p:cNvPr id="20" name="">
             <a:extLst xmlns:a="http://schemas.openxmlformats.org/drawingml/2006/main">
               <a:ext uri="{FF2B5EF4-FFF2-40B4-BE49-F238E27FC236}">
-                <a16:creationId xmlns:a16="http://schemas.microsoft.com/office/drawing/2014/main" id="{E44FE6CC-795C-4C8B-9C6E-AB6A5F1FDF3A}"/>
+                <a16:creationId xmlns:a16="http://schemas.microsoft.com/office/drawing/2014/main" id="{1CD2E6C6-B6C6-4722-A6EC-84209DF3B942}"/>
               </a:ext>
             </a:extLst>
           </p:cNvPr>
@@ -8681,7 +8681,7 @@
           <p:cNvPr id="21" name="">
             <a:extLst xmlns:a="http://schemas.openxmlformats.org/drawingml/2006/main">
               <a:ext uri="{FF2B5EF4-FFF2-40B4-BE49-F238E27FC236}">
-                <a16:creationId xmlns:a16="http://schemas.microsoft.com/office/drawing/2014/main" id="{50D75A84-4474-4521-AFF0-DBC625B11D39}"/>
+                <a16:creationId xmlns:a16="http://schemas.microsoft.com/office/drawing/2014/main" id="{04F14DC6-8BB1-4F56-90D1-A875FE11BD4D}"/>
               </a:ext>
             </a:extLst>
           </p:cNvPr>
@@ -8739,7 +8739,7 @@
           <p:cNvPr id="22" name="">
             <a:extLst xmlns:a="http://schemas.openxmlformats.org/drawingml/2006/main">
               <a:ext uri="{FF2B5EF4-FFF2-40B4-BE49-F238E27FC236}">
-                <a16:creationId xmlns:a16="http://schemas.microsoft.com/office/drawing/2014/main" id="{E249BDDF-1901-4CC8-95E0-0AD97E6313F2}"/>
+                <a16:creationId xmlns:a16="http://schemas.microsoft.com/office/drawing/2014/main" id="{2EA2E9D9-2C23-47E0-BB9C-92CAAA229C24}"/>
               </a:ext>
             </a:extLst>
           </p:cNvPr>
@@ -8774,7 +8774,7 @@
           <p:cNvPr id="23" name="">
             <a:extLst xmlns:a="http://schemas.openxmlformats.org/drawingml/2006/main">
               <a:ext uri="{FF2B5EF4-FFF2-40B4-BE49-F238E27FC236}">
-                <a16:creationId xmlns:a16="http://schemas.microsoft.com/office/drawing/2014/main" id="{8C27E520-2063-48AE-9409-4E980E19D816}"/>
+                <a16:creationId xmlns:a16="http://schemas.microsoft.com/office/drawing/2014/main" id="{6A4B3856-62DB-417F-82BD-0106EF656851}"/>
               </a:ext>
             </a:extLst>
           </p:cNvPr>
@@ -8832,7 +8832,7 @@
           <p:cNvPr id="24" name="">
             <a:extLst xmlns:a="http://schemas.openxmlformats.org/drawingml/2006/main">
               <a:ext uri="{FF2B5EF4-FFF2-40B4-BE49-F238E27FC236}">
-                <a16:creationId xmlns:a16="http://schemas.microsoft.com/office/drawing/2014/main" id="{4C0ADBAD-A20B-4A29-82DC-7C50FB0C659B}"/>
+                <a16:creationId xmlns:a16="http://schemas.microsoft.com/office/drawing/2014/main" id="{6058A94E-F665-42F5-8D9C-30A8271C881E}"/>
               </a:ext>
             </a:extLst>
           </p:cNvPr>
@@ -8890,7 +8890,7 @@
           <p:cNvPr id="25" name="">
             <a:extLst xmlns:a="http://schemas.openxmlformats.org/drawingml/2006/main">
               <a:ext uri="{FF2B5EF4-FFF2-40B4-BE49-F238E27FC236}">
-                <a16:creationId xmlns:a16="http://schemas.microsoft.com/office/drawing/2014/main" id="{FD112F1C-EB9A-4D0F-AC20-D1674C4B64C2}"/>
+                <a16:creationId xmlns:a16="http://schemas.microsoft.com/office/drawing/2014/main" id="{E80BB833-8D32-4174-A0DC-69DE0E45CA00}"/>
               </a:ext>
             </a:extLst>
           </p:cNvPr>
@@ -8948,7 +8948,7 @@
           <p:cNvPr id="26" name="">
             <a:extLst xmlns:a="http://schemas.openxmlformats.org/drawingml/2006/main">
               <a:ext uri="{FF2B5EF4-FFF2-40B4-BE49-F238E27FC236}">
-                <a16:creationId xmlns:a16="http://schemas.microsoft.com/office/drawing/2014/main" id="{36BF5351-B7F2-4BD7-B553-7292CC0A5448}"/>
+                <a16:creationId xmlns:a16="http://schemas.microsoft.com/office/drawing/2014/main" id="{B923F47E-1932-45F8-A376-F144D077977A}"/>
               </a:ext>
             </a:extLst>
           </p:cNvPr>
@@ -8983,7 +8983,7 @@
           <p:cNvPr id="27" name="">
             <a:extLst xmlns:a="http://schemas.openxmlformats.org/drawingml/2006/main">
               <a:ext uri="{FF2B5EF4-FFF2-40B4-BE49-F238E27FC236}">
-                <a16:creationId xmlns:a16="http://schemas.microsoft.com/office/drawing/2014/main" id="{8E6A518E-5C04-473B-8174-2C189E43B062}"/>
+                <a16:creationId xmlns:a16="http://schemas.microsoft.com/office/drawing/2014/main" id="{6F688B49-88D4-4A40-87C5-855168559538}"/>
               </a:ext>
             </a:extLst>
           </p:cNvPr>
@@ -9041,7 +9041,7 @@
           <p:cNvPr id="28" name="">
             <a:extLst xmlns:a="http://schemas.openxmlformats.org/drawingml/2006/main">
               <a:ext uri="{FF2B5EF4-FFF2-40B4-BE49-F238E27FC236}">
-                <a16:creationId xmlns:a16="http://schemas.microsoft.com/office/drawing/2014/main" id="{BC45331B-104B-4784-B5AD-4964AA29F39B}"/>
+                <a16:creationId xmlns:a16="http://schemas.microsoft.com/office/drawing/2014/main" id="{97D6417D-9FAC-42A5-BF3A-943F0B9CD657}"/>
               </a:ext>
             </a:extLst>
           </p:cNvPr>
@@ -9099,7 +9099,7 @@
           <p:cNvPr id="29" name="">
             <a:extLst xmlns:a="http://schemas.openxmlformats.org/drawingml/2006/main">
               <a:ext uri="{FF2B5EF4-FFF2-40B4-BE49-F238E27FC236}">
-                <a16:creationId xmlns:a16="http://schemas.microsoft.com/office/drawing/2014/main" id="{4FDE33F0-28DC-44C7-BB9D-616512F937A8}"/>
+                <a16:creationId xmlns:a16="http://schemas.microsoft.com/office/drawing/2014/main" id="{BB30EA44-9CF9-4ED9-9927-6C9525889F65}"/>
               </a:ext>
             </a:extLst>
           </p:cNvPr>
@@ -9157,7 +9157,7 @@
           <p:cNvPr id="30" name="">
             <a:extLst xmlns:a="http://schemas.openxmlformats.org/drawingml/2006/main">
               <a:ext uri="{FF2B5EF4-FFF2-40B4-BE49-F238E27FC236}">
-                <a16:creationId xmlns:a16="http://schemas.microsoft.com/office/drawing/2014/main" id="{270D7442-4634-4034-A25B-DE1B0A87EA7A}"/>
+                <a16:creationId xmlns:a16="http://schemas.microsoft.com/office/drawing/2014/main" id="{4F576A46-1AA1-4C06-A6A3-CF1EEF333C87}"/>
               </a:ext>
             </a:extLst>
           </p:cNvPr>
@@ -9192,7 +9192,7 @@
           <p:cNvPr id="31" name="">
             <a:extLst xmlns:a="http://schemas.openxmlformats.org/drawingml/2006/main">
               <a:ext uri="{FF2B5EF4-FFF2-40B4-BE49-F238E27FC236}">
-                <a16:creationId xmlns:a16="http://schemas.microsoft.com/office/drawing/2014/main" id="{73DA38A7-33EE-4AAD-8DD3-F7B5FF4AC22D}"/>
+                <a16:creationId xmlns:a16="http://schemas.microsoft.com/office/drawing/2014/main" id="{CD966FE8-A3E3-4A98-953B-0B4E0889E991}"/>
               </a:ext>
             </a:extLst>
           </p:cNvPr>
@@ -9250,7 +9250,7 @@
           <p:cNvPr id="32" name="">
             <a:extLst xmlns:a="http://schemas.openxmlformats.org/drawingml/2006/main">
               <a:ext uri="{FF2B5EF4-FFF2-40B4-BE49-F238E27FC236}">
-                <a16:creationId xmlns:a16="http://schemas.microsoft.com/office/drawing/2014/main" id="{99F14DB9-6527-417C-9AEB-FCF001588C1D}"/>
+                <a16:creationId xmlns:a16="http://schemas.microsoft.com/office/drawing/2014/main" id="{707F69B1-FD64-42A9-A410-6A111D6C62C9}"/>
               </a:ext>
             </a:extLst>
           </p:cNvPr>
@@ -9308,7 +9308,7 @@
           <p:cNvPr id="33" name="">
             <a:extLst xmlns:a="http://schemas.openxmlformats.org/drawingml/2006/main">
               <a:ext uri="{FF2B5EF4-FFF2-40B4-BE49-F238E27FC236}">
-                <a16:creationId xmlns:a16="http://schemas.microsoft.com/office/drawing/2014/main" id="{6FD095DF-BCF0-42E7-93CF-651DCE809030}"/>
+                <a16:creationId xmlns:a16="http://schemas.microsoft.com/office/drawing/2014/main" id="{F48E8897-E490-49FE-9EAD-E6D4897D21AD}"/>
               </a:ext>
             </a:extLst>
           </p:cNvPr>
@@ -9366,7 +9366,7 @@
           <p:cNvPr id="34" name="">
             <a:extLst xmlns:a="http://schemas.openxmlformats.org/drawingml/2006/main">
               <a:ext uri="{FF2B5EF4-FFF2-40B4-BE49-F238E27FC236}">
-                <a16:creationId xmlns:a16="http://schemas.microsoft.com/office/drawing/2014/main" id="{454DE610-F761-46B2-A388-C8ED257AA10C}"/>
+                <a16:creationId xmlns:a16="http://schemas.microsoft.com/office/drawing/2014/main" id="{99DF5432-A61E-4E36-AD6F-72E891A2461D}"/>
               </a:ext>
             </a:extLst>
           </p:cNvPr>
@@ -9401,7 +9401,7 @@
           <p:cNvPr id="35" name="">
             <a:extLst xmlns:a="http://schemas.openxmlformats.org/drawingml/2006/main">
               <a:ext uri="{FF2B5EF4-FFF2-40B4-BE49-F238E27FC236}">
-                <a16:creationId xmlns:a16="http://schemas.microsoft.com/office/drawing/2014/main" id="{B47AD139-456F-4D6F-B313-8DE4D68A16DF}"/>
+                <a16:creationId xmlns:a16="http://schemas.microsoft.com/office/drawing/2014/main" id="{E7D695D1-5218-400A-81BF-90A05C687375}"/>
               </a:ext>
             </a:extLst>
           </p:cNvPr>
@@ -9459,7 +9459,7 @@
           <p:cNvPr id="36" name="">
             <a:extLst xmlns:a="http://schemas.openxmlformats.org/drawingml/2006/main">
               <a:ext uri="{FF2B5EF4-FFF2-40B4-BE49-F238E27FC236}">
-                <a16:creationId xmlns:a16="http://schemas.microsoft.com/office/drawing/2014/main" id="{3FAF413D-E03C-4255-AAA1-1F8FAB712109}"/>
+                <a16:creationId xmlns:a16="http://schemas.microsoft.com/office/drawing/2014/main" id="{965E6EF9-E7F2-4E66-BB7C-81C7D06B56D9}"/>
               </a:ext>
             </a:extLst>
           </p:cNvPr>
@@ -9517,7 +9517,7 @@
           <p:cNvPr id="37" name="">
             <a:extLst xmlns:a="http://schemas.openxmlformats.org/drawingml/2006/main">
               <a:ext uri="{FF2B5EF4-FFF2-40B4-BE49-F238E27FC236}">
-                <a16:creationId xmlns:a16="http://schemas.microsoft.com/office/drawing/2014/main" id="{CE66C913-01B0-4E96-991D-555D2A960529}"/>
+                <a16:creationId xmlns:a16="http://schemas.microsoft.com/office/drawing/2014/main" id="{FE965FA0-933C-4577-9A38-DBFE37D9D2AA}"/>
               </a:ext>
             </a:extLst>
           </p:cNvPr>
@@ -9573,7 +9573,7 @@
     </p:spTree>
     <p:extLst>
       <p:ext uri="{BB962C8B-B14F-4D97-AF65-F5344CB8AC3E}">
-        <p14:creationId xmlns:p14="http://schemas.microsoft.com/office/powerpoint/2010/main" val="1896897669"/>
+        <p14:creationId xmlns:p14="http://schemas.microsoft.com/office/powerpoint/2010/main" val="1012619998"/>
       </p:ext>
     </p:extLst>
   </p:cSld>
@@ -9604,7 +9604,7 @@
           <p:cNvPr id="19" name="">
             <a:extLst xmlns:a="http://schemas.openxmlformats.org/drawingml/2006/main">
               <a:ext uri="{FF2B5EF4-FFF2-40B4-BE49-F238E27FC236}">
-                <a16:creationId xmlns:a16="http://schemas.microsoft.com/office/drawing/2014/main" id="{D51E0C0A-F53B-4231-8291-61AD663608A7}"/>
+                <a16:creationId xmlns:a16="http://schemas.microsoft.com/office/drawing/2014/main" id="{8B15F01F-043C-4971-A670-DD7EDDD5BE87}"/>
               </a:ext>
             </a:extLst>
           </p:cNvPr>
@@ -9662,7 +9662,7 @@
           <p:cNvPr id="2" name="">
             <a:extLst xmlns:a="http://schemas.openxmlformats.org/drawingml/2006/main">
               <a:ext uri="{FF2B5EF4-FFF2-40B4-BE49-F238E27FC236}">
-                <a16:creationId xmlns:a16="http://schemas.microsoft.com/office/drawing/2014/main" id="{568A229A-1A3B-423B-B802-8988168C811B}"/>
+                <a16:creationId xmlns:a16="http://schemas.microsoft.com/office/drawing/2014/main" id="{92B6A1BE-AEF9-4029-8A79-C0D10766A4F6}"/>
               </a:ext>
             </a:extLst>
           </p:cNvPr>
@@ -9720,7 +9720,7 @@
           <p:cNvPr id="3" name="">
             <a:extLst xmlns:a="http://schemas.openxmlformats.org/drawingml/2006/main">
               <a:ext uri="{FF2B5EF4-FFF2-40B4-BE49-F238E27FC236}">
-                <a16:creationId xmlns:a16="http://schemas.microsoft.com/office/drawing/2014/main" id="{5413ACBB-07B4-4FDE-A431-3E7EF029B597}"/>
+                <a16:creationId xmlns:a16="http://schemas.microsoft.com/office/drawing/2014/main" id="{767349FF-48C3-414C-8462-7E214CFEA3C0}"/>
               </a:ext>
             </a:extLst>
           </p:cNvPr>
@@ -9753,7 +9753,7 @@
           <p:cNvPr id="4" name="">
             <a:extLst xmlns:a="http://schemas.openxmlformats.org/drawingml/2006/main">
               <a:ext uri="{FF2B5EF4-FFF2-40B4-BE49-F238E27FC236}">
-                <a16:creationId xmlns:a16="http://schemas.microsoft.com/office/drawing/2014/main" id="{6234F4F1-3F06-4C4A-8078-C2D4AF1C4FB7}"/>
+                <a16:creationId xmlns:a16="http://schemas.microsoft.com/office/drawing/2014/main" id="{3CA4BE3C-CBD3-4D83-830B-D1BCE5F51D71}"/>
               </a:ext>
             </a:extLst>
           </p:cNvPr>
@@ -9811,7 +9811,7 @@
           <p:cNvPr id="5" name="">
             <a:extLst xmlns:a="http://schemas.openxmlformats.org/drawingml/2006/main">
               <a:ext uri="{FF2B5EF4-FFF2-40B4-BE49-F238E27FC236}">
-                <a16:creationId xmlns:a16="http://schemas.microsoft.com/office/drawing/2014/main" id="{8D07DE15-36AD-4B38-8E35-61F3B6A6E9E3}"/>
+                <a16:creationId xmlns:a16="http://schemas.microsoft.com/office/drawing/2014/main" id="{ADDB6AFA-FCAA-4E88-A0FF-9F551DE4774A}"/>
               </a:ext>
             </a:extLst>
           </p:cNvPr>
@@ -9869,7 +9869,7 @@
           <p:cNvPr id="6" name="">
             <a:extLst xmlns:a="http://schemas.openxmlformats.org/drawingml/2006/main">
               <a:ext uri="{FF2B5EF4-FFF2-40B4-BE49-F238E27FC236}">
-                <a16:creationId xmlns:a16="http://schemas.microsoft.com/office/drawing/2014/main" id="{EA77D9E3-BAA7-40E9-AD51-4161DFEA28A5}"/>
+                <a16:creationId xmlns:a16="http://schemas.microsoft.com/office/drawing/2014/main" id="{75E6A92E-6C9E-4068-B88B-121A4CC6E92B}"/>
               </a:ext>
             </a:extLst>
           </p:cNvPr>
@@ -9904,7 +9904,7 @@
           <p:cNvPr id="7" name="">
             <a:extLst xmlns:a="http://schemas.openxmlformats.org/drawingml/2006/main">
               <a:ext uri="{FF2B5EF4-FFF2-40B4-BE49-F238E27FC236}">
-                <a16:creationId xmlns:a16="http://schemas.microsoft.com/office/drawing/2014/main" id="{C0DD66DA-FF13-4CF5-9365-7333A799E9A6}"/>
+                <a16:creationId xmlns:a16="http://schemas.microsoft.com/office/drawing/2014/main" id="{0AB01E39-39C6-4F0D-9614-1315FBE71335}"/>
               </a:ext>
             </a:extLst>
           </p:cNvPr>
@@ -9937,7 +9937,7 @@
           <p:cNvPr id="8" name="">
             <a:extLst xmlns:a="http://schemas.openxmlformats.org/drawingml/2006/main">
               <a:ext uri="{FF2B5EF4-FFF2-40B4-BE49-F238E27FC236}">
-                <a16:creationId xmlns:a16="http://schemas.microsoft.com/office/drawing/2014/main" id="{08392A32-B4D0-46A9-9FD9-449845F77A71}"/>
+                <a16:creationId xmlns:a16="http://schemas.microsoft.com/office/drawing/2014/main" id="{AFE1882D-30CA-4E31-B0EE-4E0E29AD26E2}"/>
               </a:ext>
             </a:extLst>
           </p:cNvPr>
@@ -9995,7 +9995,7 @@
           <p:cNvPr id="9" name="">
             <a:extLst xmlns:a="http://schemas.openxmlformats.org/drawingml/2006/main">
               <a:ext uri="{FF2B5EF4-FFF2-40B4-BE49-F238E27FC236}">
-                <a16:creationId xmlns:a16="http://schemas.microsoft.com/office/drawing/2014/main" id="{0821C9FC-7B04-4832-97BA-88E1FCA5ED27}"/>
+                <a16:creationId xmlns:a16="http://schemas.microsoft.com/office/drawing/2014/main" id="{C1B91042-28D5-4AC5-9EBA-698511F09AA5}"/>
               </a:ext>
             </a:extLst>
           </p:cNvPr>
@@ -10070,7 +10070,7 @@
           <p:cNvPr id="10" name="">
             <a:extLst xmlns:a="http://schemas.openxmlformats.org/drawingml/2006/main">
               <a:ext uri="{FF2B5EF4-FFF2-40B4-BE49-F238E27FC236}">
-                <a16:creationId xmlns:a16="http://schemas.microsoft.com/office/drawing/2014/main" id="{945924C6-0CB0-4AE0-B376-5AA120803219}"/>
+                <a16:creationId xmlns:a16="http://schemas.microsoft.com/office/drawing/2014/main" id="{65F7E0C6-9B21-42A7-9A5D-AE44BA591C54}"/>
               </a:ext>
             </a:extLst>
           </p:cNvPr>
@@ -10105,7 +10105,7 @@
           <p:cNvPr id="11" name="">
             <a:extLst xmlns:a="http://schemas.openxmlformats.org/drawingml/2006/main">
               <a:ext uri="{FF2B5EF4-FFF2-40B4-BE49-F238E27FC236}">
-                <a16:creationId xmlns:a16="http://schemas.microsoft.com/office/drawing/2014/main" id="{4E130DC7-53F3-47E3-8A55-6BABD444089F}"/>
+                <a16:creationId xmlns:a16="http://schemas.microsoft.com/office/drawing/2014/main" id="{A1F0D155-76BB-4FA1-BB28-7A5464D41D56}"/>
               </a:ext>
             </a:extLst>
           </p:cNvPr>
@@ -10138,7 +10138,7 @@
           <p:cNvPr id="12" name="">
             <a:extLst xmlns:a="http://schemas.openxmlformats.org/drawingml/2006/main">
               <a:ext uri="{FF2B5EF4-FFF2-40B4-BE49-F238E27FC236}">
-                <a16:creationId xmlns:a16="http://schemas.microsoft.com/office/drawing/2014/main" id="{353078B5-1AE8-4E50-A61B-EE0999F11BD0}"/>
+                <a16:creationId xmlns:a16="http://schemas.microsoft.com/office/drawing/2014/main" id="{4B337F14-449A-46D1-BA08-C5C78EB540E6}"/>
               </a:ext>
             </a:extLst>
           </p:cNvPr>
@@ -10196,7 +10196,7 @@
           <p:cNvPr id="13" name="">
             <a:extLst xmlns:a="http://schemas.openxmlformats.org/drawingml/2006/main">
               <a:ext uri="{FF2B5EF4-FFF2-40B4-BE49-F238E27FC236}">
-                <a16:creationId xmlns:a16="http://schemas.microsoft.com/office/drawing/2014/main" id="{F31A29E5-7BDD-4CDE-BE04-CEEDB237F421}"/>
+                <a16:creationId xmlns:a16="http://schemas.microsoft.com/office/drawing/2014/main" id="{2AE943EE-C175-4D5C-8D89-900589424BB3}"/>
               </a:ext>
             </a:extLst>
           </p:cNvPr>
@@ -10254,7 +10254,7 @@
           <p:cNvPr id="14" name="">
             <a:extLst xmlns:a="http://schemas.openxmlformats.org/drawingml/2006/main">
               <a:ext uri="{FF2B5EF4-FFF2-40B4-BE49-F238E27FC236}">
-                <a16:creationId xmlns:a16="http://schemas.microsoft.com/office/drawing/2014/main" id="{D879C280-3758-43A6-85AE-4F2519087FE8}"/>
+                <a16:creationId xmlns:a16="http://schemas.microsoft.com/office/drawing/2014/main" id="{B479A875-CE50-4EB0-8843-A48D29AF96ED}"/>
               </a:ext>
             </a:extLst>
           </p:cNvPr>
@@ -10289,7 +10289,7 @@
           <p:cNvPr id="15" name="">
             <a:extLst xmlns:a="http://schemas.openxmlformats.org/drawingml/2006/main">
               <a:ext uri="{FF2B5EF4-FFF2-40B4-BE49-F238E27FC236}">
-                <a16:creationId xmlns:a16="http://schemas.microsoft.com/office/drawing/2014/main" id="{5D02FA82-6A5F-41A9-9304-C8BBCC95CD3F}"/>
+                <a16:creationId xmlns:a16="http://schemas.microsoft.com/office/drawing/2014/main" id="{735FE1A1-B586-4105-94B2-09E2E5FC8F0A}"/>
               </a:ext>
             </a:extLst>
           </p:cNvPr>
@@ -10322,7 +10322,7 @@
           <p:cNvPr id="16" name="">
             <a:extLst xmlns:a="http://schemas.openxmlformats.org/drawingml/2006/main">
               <a:ext uri="{FF2B5EF4-FFF2-40B4-BE49-F238E27FC236}">
-                <a16:creationId xmlns:a16="http://schemas.microsoft.com/office/drawing/2014/main" id="{8E7B0E69-E144-4034-A35B-AB4B87179D1E}"/>
+                <a16:creationId xmlns:a16="http://schemas.microsoft.com/office/drawing/2014/main" id="{C088DB37-D329-4DD2-93CA-BAB69FF68C22}"/>
               </a:ext>
             </a:extLst>
           </p:cNvPr>
@@ -10380,7 +10380,7 @@
           <p:cNvPr id="17" name="">
             <a:extLst xmlns:a="http://schemas.openxmlformats.org/drawingml/2006/main">
               <a:ext uri="{FF2B5EF4-FFF2-40B4-BE49-F238E27FC236}">
-                <a16:creationId xmlns:a16="http://schemas.microsoft.com/office/drawing/2014/main" id="{49B3D11C-402C-496D-8F63-EE830166A752}"/>
+                <a16:creationId xmlns:a16="http://schemas.microsoft.com/office/drawing/2014/main" id="{129D8175-4EFB-4C5C-9FD5-E5D88932FFF7}"/>
               </a:ext>
             </a:extLst>
           </p:cNvPr>
@@ -10438,7 +10438,7 @@
           <p:cNvPr id="18" name="">
             <a:extLst xmlns:a="http://schemas.openxmlformats.org/drawingml/2006/main">
               <a:ext uri="{FF2B5EF4-FFF2-40B4-BE49-F238E27FC236}">
-                <a16:creationId xmlns:a16="http://schemas.microsoft.com/office/drawing/2014/main" id="{C3518193-BBDA-44FC-946A-733E794B9483}"/>
+                <a16:creationId xmlns:a16="http://schemas.microsoft.com/office/drawing/2014/main" id="{BC3A27AD-117C-411F-A0D1-3980610DA1ED}"/>
               </a:ext>
             </a:extLst>
           </p:cNvPr>
@@ -10494,7 +10494,7 @@
     </p:spTree>
     <p:extLst>
       <p:ext uri="{BB962C8B-B14F-4D97-AF65-F5344CB8AC3E}">
-        <p14:creationId xmlns:p14="http://schemas.microsoft.com/office/powerpoint/2010/main" val="1168708207"/>
+        <p14:creationId xmlns:p14="http://schemas.microsoft.com/office/powerpoint/2010/main" val="865381573"/>
       </p:ext>
     </p:extLst>
   </p:cSld>
@@ -10525,7 +10525,7 @@
           <p:cNvPr id="28" name="">
             <a:extLst xmlns:a="http://schemas.openxmlformats.org/drawingml/2006/main">
               <a:ext uri="{FF2B5EF4-FFF2-40B4-BE49-F238E27FC236}">
-                <a16:creationId xmlns:a16="http://schemas.microsoft.com/office/drawing/2014/main" id="{6CCB15C0-3DEB-4541-B908-0D020E676DFE}"/>
+                <a16:creationId xmlns:a16="http://schemas.microsoft.com/office/drawing/2014/main" id="{E3EDC77F-97AB-47CC-81C6-DBB34119EDA8}"/>
               </a:ext>
             </a:extLst>
           </p:cNvPr>
@@ -10583,7 +10583,7 @@
           <p:cNvPr id="2" name="">
             <a:extLst xmlns:a="http://schemas.openxmlformats.org/drawingml/2006/main">
               <a:ext uri="{FF2B5EF4-FFF2-40B4-BE49-F238E27FC236}">
-                <a16:creationId xmlns:a16="http://schemas.microsoft.com/office/drawing/2014/main" id="{895CBB22-0CFB-406B-8C01-34D0B940A555}"/>
+                <a16:creationId xmlns:a16="http://schemas.microsoft.com/office/drawing/2014/main" id="{D66F53CC-ADD4-4A2A-9600-2E8D1F6FEF95}"/>
               </a:ext>
             </a:extLst>
           </p:cNvPr>
@@ -10641,7 +10641,7 @@
           <p:cNvPr id="3" name="">
             <a:extLst xmlns:a="http://schemas.openxmlformats.org/drawingml/2006/main">
               <a:ext uri="{FF2B5EF4-FFF2-40B4-BE49-F238E27FC236}">
-                <a16:creationId xmlns:a16="http://schemas.microsoft.com/office/drawing/2014/main" id="{52554D50-0ECC-4EC2-87E6-40E3BEE78927}"/>
+                <a16:creationId xmlns:a16="http://schemas.microsoft.com/office/drawing/2014/main" id="{D633D72E-8544-44DE-BA73-7DC9AFFFCA80}"/>
               </a:ext>
             </a:extLst>
           </p:cNvPr>
@@ -10674,7 +10674,7 @@
           <p:cNvPr id="4" name="">
             <a:extLst xmlns:a="http://schemas.openxmlformats.org/drawingml/2006/main">
               <a:ext uri="{FF2B5EF4-FFF2-40B4-BE49-F238E27FC236}">
-                <a16:creationId xmlns:a16="http://schemas.microsoft.com/office/drawing/2014/main" id="{12087981-AB24-4E67-9711-9B151C9DA44A}"/>
+                <a16:creationId xmlns:a16="http://schemas.microsoft.com/office/drawing/2014/main" id="{D1B76DC9-E407-46DF-9971-072482BFCD9A}"/>
               </a:ext>
             </a:extLst>
           </p:cNvPr>
@@ -10732,7 +10732,7 @@
           <p:cNvPr id="5" name="">
             <a:extLst xmlns:a="http://schemas.openxmlformats.org/drawingml/2006/main">
               <a:ext uri="{FF2B5EF4-FFF2-40B4-BE49-F238E27FC236}">
-                <a16:creationId xmlns:a16="http://schemas.microsoft.com/office/drawing/2014/main" id="{03FB1B8E-B8D3-4421-804F-7C170F2C838C}"/>
+                <a16:creationId xmlns:a16="http://schemas.microsoft.com/office/drawing/2014/main" id="{55A9EC91-D228-435F-A1AB-2ABEE24E5620}"/>
               </a:ext>
             </a:extLst>
           </p:cNvPr>
@@ -10790,7 +10790,7 @@
           <p:cNvPr id="6" name="">
             <a:extLst xmlns:a="http://schemas.openxmlformats.org/drawingml/2006/main">
               <a:ext uri="{FF2B5EF4-FFF2-40B4-BE49-F238E27FC236}">
-                <a16:creationId xmlns:a16="http://schemas.microsoft.com/office/drawing/2014/main" id="{05742F5B-CFAA-4B0F-A34E-0637F2F0A9E6}"/>
+                <a16:creationId xmlns:a16="http://schemas.microsoft.com/office/drawing/2014/main" id="{AFE7E534-153E-4589-9300-57DF8CAD1CA9}"/>
               </a:ext>
             </a:extLst>
           </p:cNvPr>
@@ -10825,7 +10825,7 @@
           <p:cNvPr id="7" name="">
             <a:extLst xmlns:a="http://schemas.openxmlformats.org/drawingml/2006/main">
               <a:ext uri="{FF2B5EF4-FFF2-40B4-BE49-F238E27FC236}">
-                <a16:creationId xmlns:a16="http://schemas.microsoft.com/office/drawing/2014/main" id="{FC6696B4-ECF7-4508-B5C0-89995D2B8CA4}"/>
+                <a16:creationId xmlns:a16="http://schemas.microsoft.com/office/drawing/2014/main" id="{9CCB34F4-73B6-4A41-B6D3-0DAB9E4930A6}"/>
               </a:ext>
             </a:extLst>
           </p:cNvPr>
@@ -10883,7 +10883,7 @@
           <p:cNvPr id="8" name="">
             <a:extLst xmlns:a="http://schemas.openxmlformats.org/drawingml/2006/main">
               <a:ext uri="{FF2B5EF4-FFF2-40B4-BE49-F238E27FC236}">
-                <a16:creationId xmlns:a16="http://schemas.microsoft.com/office/drawing/2014/main" id="{512C42B7-4F4B-4629-B55D-4C4C31B50A66}"/>
+                <a16:creationId xmlns:a16="http://schemas.microsoft.com/office/drawing/2014/main" id="{C49A6199-B294-43FB-93F5-B7A1185A9027}"/>
               </a:ext>
             </a:extLst>
           </p:cNvPr>
@@ -10918,7 +10918,7 @@
           <p:cNvPr id="9" name="">
             <a:extLst xmlns:a="http://schemas.openxmlformats.org/drawingml/2006/main">
               <a:ext uri="{FF2B5EF4-FFF2-40B4-BE49-F238E27FC236}">
-                <a16:creationId xmlns:a16="http://schemas.microsoft.com/office/drawing/2014/main" id="{EB0A09F8-65A8-4AE6-AAE7-BC7A4AD068FF}"/>
+                <a16:creationId xmlns:a16="http://schemas.microsoft.com/office/drawing/2014/main" id="{141D96E4-EA5C-4287-90BE-DF999D5B2CBD}"/>
               </a:ext>
             </a:extLst>
           </p:cNvPr>
@@ -10976,7 +10976,7 @@
           <p:cNvPr id="10" name="">
             <a:extLst xmlns:a="http://schemas.openxmlformats.org/drawingml/2006/main">
               <a:ext uri="{FF2B5EF4-FFF2-40B4-BE49-F238E27FC236}">
-                <a16:creationId xmlns:a16="http://schemas.microsoft.com/office/drawing/2014/main" id="{8F6FAB91-DC4C-491C-96B1-F09EB8215EBF}"/>
+                <a16:creationId xmlns:a16="http://schemas.microsoft.com/office/drawing/2014/main" id="{9E332692-BF35-42FC-BB06-163CF97D2FF1}"/>
               </a:ext>
             </a:extLst>
           </p:cNvPr>
@@ -11011,7 +11011,7 @@
           <p:cNvPr id="11" name="">
             <a:extLst xmlns:a="http://schemas.openxmlformats.org/drawingml/2006/main">
               <a:ext uri="{FF2B5EF4-FFF2-40B4-BE49-F238E27FC236}">
-                <a16:creationId xmlns:a16="http://schemas.microsoft.com/office/drawing/2014/main" id="{EEA1276E-528A-487A-B7FE-3BDBBF47BCB4}"/>
+                <a16:creationId xmlns:a16="http://schemas.microsoft.com/office/drawing/2014/main" id="{617F7A8B-AA07-4EF6-B26E-3C83CA24CDCA}"/>
               </a:ext>
             </a:extLst>
           </p:cNvPr>
@@ -11069,7 +11069,7 @@
           <p:cNvPr id="12" name="">
             <a:extLst xmlns:a="http://schemas.openxmlformats.org/drawingml/2006/main">
               <a:ext uri="{FF2B5EF4-FFF2-40B4-BE49-F238E27FC236}">
-                <a16:creationId xmlns:a16="http://schemas.microsoft.com/office/drawing/2014/main" id="{8C24E08E-8DC3-4E75-B9D7-9D5399E40EB6}"/>
+                <a16:creationId xmlns:a16="http://schemas.microsoft.com/office/drawing/2014/main" id="{42268A1A-3D2B-43B7-99C6-A607B6C89750}"/>
               </a:ext>
             </a:extLst>
           </p:cNvPr>
@@ -11104,7 +11104,7 @@
           <p:cNvPr id="13" name="">
             <a:extLst xmlns:a="http://schemas.openxmlformats.org/drawingml/2006/main">
               <a:ext uri="{FF2B5EF4-FFF2-40B4-BE49-F238E27FC236}">
-                <a16:creationId xmlns:a16="http://schemas.microsoft.com/office/drawing/2014/main" id="{0F047659-8533-4EE8-B53B-7725D40DB282}"/>
+                <a16:creationId xmlns:a16="http://schemas.microsoft.com/office/drawing/2014/main" id="{05862B89-A322-4968-887B-5D9530FFEFEB}"/>
               </a:ext>
             </a:extLst>
           </p:cNvPr>
@@ -11162,7 +11162,7 @@
           <p:cNvPr id="14" name="">
             <a:extLst xmlns:a="http://schemas.openxmlformats.org/drawingml/2006/main">
               <a:ext uri="{FF2B5EF4-FFF2-40B4-BE49-F238E27FC236}">
-                <a16:creationId xmlns:a16="http://schemas.microsoft.com/office/drawing/2014/main" id="{A40EC677-4945-4FC7-85C8-A83176699798}"/>
+                <a16:creationId xmlns:a16="http://schemas.microsoft.com/office/drawing/2014/main" id="{7944DD58-D358-486D-BCE1-4DB569DB5CB4}"/>
               </a:ext>
             </a:extLst>
           </p:cNvPr>
@@ -11197,7 +11197,7 @@
           <p:cNvPr id="15" name="">
             <a:extLst xmlns:a="http://schemas.openxmlformats.org/drawingml/2006/main">
               <a:ext uri="{FF2B5EF4-FFF2-40B4-BE49-F238E27FC236}">
-                <a16:creationId xmlns:a16="http://schemas.microsoft.com/office/drawing/2014/main" id="{3BD3A8FC-2748-413D-ACCD-AC5D9CA5F5DE}"/>
+                <a16:creationId xmlns:a16="http://schemas.microsoft.com/office/drawing/2014/main" id="{897F3A1F-26D3-4557-96D1-1E18B343E411}"/>
               </a:ext>
             </a:extLst>
           </p:cNvPr>
@@ -11255,7 +11255,7 @@
           <p:cNvPr id="16" name="">
             <a:extLst xmlns:a="http://schemas.openxmlformats.org/drawingml/2006/main">
               <a:ext uri="{FF2B5EF4-FFF2-40B4-BE49-F238E27FC236}">
-                <a16:creationId xmlns:a16="http://schemas.microsoft.com/office/drawing/2014/main" id="{302A4C62-EF30-42CE-B9CC-3DAF8BCF6F25}"/>
+                <a16:creationId xmlns:a16="http://schemas.microsoft.com/office/drawing/2014/main" id="{A90ABC0E-11AB-42D2-B068-FF7B2F268415}"/>
               </a:ext>
             </a:extLst>
           </p:cNvPr>
@@ -11290,7 +11290,7 @@
           <p:cNvPr id="17" name="">
             <a:extLst xmlns:a="http://schemas.openxmlformats.org/drawingml/2006/main">
               <a:ext uri="{FF2B5EF4-FFF2-40B4-BE49-F238E27FC236}">
-                <a16:creationId xmlns:a16="http://schemas.microsoft.com/office/drawing/2014/main" id="{04D3F7F5-C9E4-4061-984F-1577D00C7AE4}"/>
+                <a16:creationId xmlns:a16="http://schemas.microsoft.com/office/drawing/2014/main" id="{0517B109-DE35-424E-8C9F-5E28310EB0BA}"/>
               </a:ext>
             </a:extLst>
           </p:cNvPr>
@@ -11348,7 +11348,7 @@
           <p:cNvPr id="18" name="">
             <a:extLst xmlns:a="http://schemas.openxmlformats.org/drawingml/2006/main">
               <a:ext uri="{FF2B5EF4-FFF2-40B4-BE49-F238E27FC236}">
-                <a16:creationId xmlns:a16="http://schemas.microsoft.com/office/drawing/2014/main" id="{E60D3537-DC68-417F-8EC3-4C1E20EC2B9D}"/>
+                <a16:creationId xmlns:a16="http://schemas.microsoft.com/office/drawing/2014/main" id="{430C60D9-0CA0-4CFA-9792-8FA229D94127}"/>
               </a:ext>
             </a:extLst>
           </p:cNvPr>
@@ -11383,7 +11383,7 @@
           <p:cNvPr id="19" name="">
             <a:extLst xmlns:a="http://schemas.openxmlformats.org/drawingml/2006/main">
               <a:ext uri="{FF2B5EF4-FFF2-40B4-BE49-F238E27FC236}">
-                <a16:creationId xmlns:a16="http://schemas.microsoft.com/office/drawing/2014/main" id="{BE6F57B5-A0C9-4789-AFAD-4503D6EF0651}"/>
+                <a16:creationId xmlns:a16="http://schemas.microsoft.com/office/drawing/2014/main" id="{5AE7FAB3-25BB-482D-AAD8-D404A6C9D315}"/>
               </a:ext>
             </a:extLst>
           </p:cNvPr>
@@ -11441,7 +11441,7 @@
           <p:cNvPr id="20" name="">
             <a:extLst xmlns:a="http://schemas.openxmlformats.org/drawingml/2006/main">
               <a:ext uri="{FF2B5EF4-FFF2-40B4-BE49-F238E27FC236}">
-                <a16:creationId xmlns:a16="http://schemas.microsoft.com/office/drawing/2014/main" id="{7662DE35-E930-4DD7-83ED-7FF29AC0AA63}"/>
+                <a16:creationId xmlns:a16="http://schemas.microsoft.com/office/drawing/2014/main" id="{4338DECF-3034-4153-95C1-8CD17039A9A3}"/>
               </a:ext>
             </a:extLst>
           </p:cNvPr>
@@ -11476,7 +11476,7 @@
           <p:cNvPr id="21" name="">
             <a:extLst xmlns:a="http://schemas.openxmlformats.org/drawingml/2006/main">
               <a:ext uri="{FF2B5EF4-FFF2-40B4-BE49-F238E27FC236}">
-                <a16:creationId xmlns:a16="http://schemas.microsoft.com/office/drawing/2014/main" id="{F3448148-229D-41E7-82A8-8D9DA7DEC641}"/>
+                <a16:creationId xmlns:a16="http://schemas.microsoft.com/office/drawing/2014/main" id="{D3D3F47E-2FE8-4159-8068-332009B6F41D}"/>
               </a:ext>
             </a:extLst>
           </p:cNvPr>
@@ -11534,7 +11534,7 @@
           <p:cNvPr id="22" name="">
             <a:extLst xmlns:a="http://schemas.openxmlformats.org/drawingml/2006/main">
               <a:ext uri="{FF2B5EF4-FFF2-40B4-BE49-F238E27FC236}">
-                <a16:creationId xmlns:a16="http://schemas.microsoft.com/office/drawing/2014/main" id="{6FC5F8B4-156F-496B-A8CE-B2CC428292A2}"/>
+                <a16:creationId xmlns:a16="http://schemas.microsoft.com/office/drawing/2014/main" id="{947BC645-5DB9-4DD8-B324-248A2D7A925C}"/>
               </a:ext>
             </a:extLst>
           </p:cNvPr>
@@ -11569,7 +11569,7 @@
           <p:cNvPr id="23" name="">
             <a:extLst xmlns:a="http://schemas.openxmlformats.org/drawingml/2006/main">
               <a:ext uri="{FF2B5EF4-FFF2-40B4-BE49-F238E27FC236}">
-                <a16:creationId xmlns:a16="http://schemas.microsoft.com/office/drawing/2014/main" id="{6394C234-FB87-4EB9-8BF1-3BC3103F27CD}"/>
+                <a16:creationId xmlns:a16="http://schemas.microsoft.com/office/drawing/2014/main" id="{377C25ED-E680-4B5A-9359-61FB26F85706}"/>
               </a:ext>
             </a:extLst>
           </p:cNvPr>
@@ -11627,7 +11627,7 @@
           <p:cNvPr id="24" name="">
             <a:extLst xmlns:a="http://schemas.openxmlformats.org/drawingml/2006/main">
               <a:ext uri="{FF2B5EF4-FFF2-40B4-BE49-F238E27FC236}">
-                <a16:creationId xmlns:a16="http://schemas.microsoft.com/office/drawing/2014/main" id="{1EA65A93-590D-461C-AB29-2A4FA3DF4A99}"/>
+                <a16:creationId xmlns:a16="http://schemas.microsoft.com/office/drawing/2014/main" id="{1F5B35EF-2B62-4888-BE38-42890AAF1A6D}"/>
               </a:ext>
             </a:extLst>
           </p:cNvPr>
@@ -11685,7 +11685,7 @@
           <p:cNvPr id="25" name="">
             <a:extLst xmlns:a="http://schemas.openxmlformats.org/drawingml/2006/main">
               <a:ext uri="{FF2B5EF4-FFF2-40B4-BE49-F238E27FC236}">
-                <a16:creationId xmlns:a16="http://schemas.microsoft.com/office/drawing/2014/main" id="{720306E6-07CF-4BAD-A776-F66DFBCDACFB}"/>
+                <a16:creationId xmlns:a16="http://schemas.microsoft.com/office/drawing/2014/main" id="{739404C3-50FA-4D76-82C9-5B190D3A9EFE}"/>
               </a:ext>
             </a:extLst>
           </p:cNvPr>
@@ -11743,7 +11743,7 @@
           <p:cNvPr id="26" name="">
             <a:extLst xmlns:a="http://schemas.openxmlformats.org/drawingml/2006/main">
               <a:ext uri="{FF2B5EF4-FFF2-40B4-BE49-F238E27FC236}">
-                <a16:creationId xmlns:a16="http://schemas.microsoft.com/office/drawing/2014/main" id="{4A68A9F2-FE7D-4735-AC2A-077B12B35AD0}"/>
+                <a16:creationId xmlns:a16="http://schemas.microsoft.com/office/drawing/2014/main" id="{0A7132CC-A740-47B6-B13A-40BFF7BE0FC5}"/>
               </a:ext>
             </a:extLst>
           </p:cNvPr>
@@ -11801,7 +11801,7 @@
           <p:cNvPr id="27" name="">
             <a:extLst xmlns:a="http://schemas.openxmlformats.org/drawingml/2006/main">
               <a:ext uri="{FF2B5EF4-FFF2-40B4-BE49-F238E27FC236}">
-                <a16:creationId xmlns:a16="http://schemas.microsoft.com/office/drawing/2014/main" id="{00E60F05-43D6-4C99-AB41-F2A19613E5E8}"/>
+                <a16:creationId xmlns:a16="http://schemas.microsoft.com/office/drawing/2014/main" id="{186CAFEB-3204-4741-926E-B2852775B3DC}"/>
               </a:ext>
             </a:extLst>
           </p:cNvPr>
@@ -11857,7 +11857,7 @@
     </p:spTree>
     <p:extLst>
       <p:ext uri="{BB962C8B-B14F-4D97-AF65-F5344CB8AC3E}">
-        <p14:creationId xmlns:p14="http://schemas.microsoft.com/office/powerpoint/2010/main" val="1284915951"/>
+        <p14:creationId xmlns:p14="http://schemas.microsoft.com/office/powerpoint/2010/main" val="58822680"/>
       </p:ext>
     </p:extLst>
   </p:cSld>
@@ -11888,7 +11888,7 @@
           <p:cNvPr id="27" name="">
             <a:extLst xmlns:a="http://schemas.openxmlformats.org/drawingml/2006/main">
               <a:ext uri="{FF2B5EF4-FFF2-40B4-BE49-F238E27FC236}">
-                <a16:creationId xmlns:a16="http://schemas.microsoft.com/office/drawing/2014/main" id="{FFDDCFE9-4E83-4CAF-8BE5-028455CDCCDE}"/>
+                <a16:creationId xmlns:a16="http://schemas.microsoft.com/office/drawing/2014/main" id="{AC28AFD6-514B-42E3-955D-1DC20844DB69}"/>
               </a:ext>
             </a:extLst>
           </p:cNvPr>
@@ -11946,7 +11946,7 @@
           <p:cNvPr id="2" name="">
             <a:extLst xmlns:a="http://schemas.openxmlformats.org/drawingml/2006/main">
               <a:ext uri="{FF2B5EF4-FFF2-40B4-BE49-F238E27FC236}">
-                <a16:creationId xmlns:a16="http://schemas.microsoft.com/office/drawing/2014/main" id="{0156714D-4A10-442E-B024-98B7F1D2D7A1}"/>
+                <a16:creationId xmlns:a16="http://schemas.microsoft.com/office/drawing/2014/main" id="{6064CE29-900A-41A3-8422-7D65C89CF3AB}"/>
               </a:ext>
             </a:extLst>
           </p:cNvPr>
@@ -12004,7 +12004,7 @@
           <p:cNvPr id="3" name="">
             <a:extLst xmlns:a="http://schemas.openxmlformats.org/drawingml/2006/main">
               <a:ext uri="{FF2B5EF4-FFF2-40B4-BE49-F238E27FC236}">
-                <a16:creationId xmlns:a16="http://schemas.microsoft.com/office/drawing/2014/main" id="{0CFB45FF-85C3-4008-8EE1-1EBCE24838D9}"/>
+                <a16:creationId xmlns:a16="http://schemas.microsoft.com/office/drawing/2014/main" id="{9DE5D5DE-1EC5-43B3-A4A9-195C578DB5F9}"/>
               </a:ext>
             </a:extLst>
           </p:cNvPr>
@@ -12037,7 +12037,7 @@
           <p:cNvPr id="4" name="">
             <a:extLst xmlns:a="http://schemas.openxmlformats.org/drawingml/2006/main">
               <a:ext uri="{FF2B5EF4-FFF2-40B4-BE49-F238E27FC236}">
-                <a16:creationId xmlns:a16="http://schemas.microsoft.com/office/drawing/2014/main" id="{160F2633-A4CA-4982-886E-48AA961E5DED}"/>
+                <a16:creationId xmlns:a16="http://schemas.microsoft.com/office/drawing/2014/main" id="{633F57C0-A8AA-42B6-B7DE-2C808165576C}"/>
               </a:ext>
             </a:extLst>
           </p:cNvPr>
@@ -12095,7 +12095,7 @@
           <p:cNvPr id="5" name="">
             <a:extLst xmlns:a="http://schemas.openxmlformats.org/drawingml/2006/main">
               <a:ext uri="{FF2B5EF4-FFF2-40B4-BE49-F238E27FC236}">
-                <a16:creationId xmlns:a16="http://schemas.microsoft.com/office/drawing/2014/main" id="{CF0EAA6E-E4CA-40D2-A89C-A0CA8684FEF7}"/>
+                <a16:creationId xmlns:a16="http://schemas.microsoft.com/office/drawing/2014/main" id="{712A5CB0-9446-4629-AE4E-B965811776F3}"/>
               </a:ext>
             </a:extLst>
           </p:cNvPr>
@@ -12153,7 +12153,7 @@
           <p:cNvPr id="6" name="">
             <a:extLst xmlns:a="http://schemas.openxmlformats.org/drawingml/2006/main">
               <a:ext uri="{FF2B5EF4-FFF2-40B4-BE49-F238E27FC236}">
-                <a16:creationId xmlns:a16="http://schemas.microsoft.com/office/drawing/2014/main" id="{FE1F5DB9-7E79-47AC-B01F-F6B861CE33D6}"/>
+                <a16:creationId xmlns:a16="http://schemas.microsoft.com/office/drawing/2014/main" id="{FFDB09D1-8DDF-428A-A623-0CBBB2F4ACB1}"/>
               </a:ext>
             </a:extLst>
           </p:cNvPr>
@@ -12188,7 +12188,7 @@
           <p:cNvPr id="7" name="">
             <a:extLst xmlns:a="http://schemas.openxmlformats.org/drawingml/2006/main">
               <a:ext uri="{FF2B5EF4-FFF2-40B4-BE49-F238E27FC236}">
-                <a16:creationId xmlns:a16="http://schemas.microsoft.com/office/drawing/2014/main" id="{6CF9145D-A248-4309-9636-D54B0D54DE0D}"/>
+                <a16:creationId xmlns:a16="http://schemas.microsoft.com/office/drawing/2014/main" id="{2A54841F-6013-46D9-89DC-AFF22898DA46}"/>
               </a:ext>
             </a:extLst>
           </p:cNvPr>
@@ -12246,7 +12246,7 @@
           <p:cNvPr id="8" name="">
             <a:extLst xmlns:a="http://schemas.openxmlformats.org/drawingml/2006/main">
               <a:ext uri="{FF2B5EF4-FFF2-40B4-BE49-F238E27FC236}">
-                <a16:creationId xmlns:a16="http://schemas.microsoft.com/office/drawing/2014/main" id="{17C1AD62-41C9-460D-8031-520DD322DEAE}"/>
+                <a16:creationId xmlns:a16="http://schemas.microsoft.com/office/drawing/2014/main" id="{77F63F55-B983-4C7B-94A1-CAC375301E67}"/>
               </a:ext>
             </a:extLst>
           </p:cNvPr>
@@ -12277,7 +12277,7 @@
           <p:cNvPr id="9" name="">
             <a:extLst xmlns:a="http://schemas.openxmlformats.org/drawingml/2006/main">
               <a:ext uri="{FF2B5EF4-FFF2-40B4-BE49-F238E27FC236}">
-                <a16:creationId xmlns:a16="http://schemas.microsoft.com/office/drawing/2014/main" id="{E40277D6-4486-4A2D-9E23-EA8047029DCA}"/>
+                <a16:creationId xmlns:a16="http://schemas.microsoft.com/office/drawing/2014/main" id="{FD1EDE22-D017-48E3-AA15-F360A25BC019}"/>
               </a:ext>
             </a:extLst>
           </p:cNvPr>
@@ -12335,7 +12335,7 @@
           <p:cNvPr id="10" name="">
             <a:extLst xmlns:a="http://schemas.openxmlformats.org/drawingml/2006/main">
               <a:ext uri="{FF2B5EF4-FFF2-40B4-BE49-F238E27FC236}">
-                <a16:creationId xmlns:a16="http://schemas.microsoft.com/office/drawing/2014/main" id="{686E7829-A405-4DB3-8547-CEC1DC82F312}"/>
+                <a16:creationId xmlns:a16="http://schemas.microsoft.com/office/drawing/2014/main" id="{E98B3EE1-375E-4B1B-99F8-5269017F1B89}"/>
               </a:ext>
             </a:extLst>
           </p:cNvPr>
@@ -12393,7 +12393,7 @@
           <p:cNvPr id="11" name="">
             <a:extLst xmlns:a="http://schemas.openxmlformats.org/drawingml/2006/main">
               <a:ext uri="{FF2B5EF4-FFF2-40B4-BE49-F238E27FC236}">
-                <a16:creationId xmlns:a16="http://schemas.microsoft.com/office/drawing/2014/main" id="{C615615C-DA0A-4CF9-982B-C31F9B86220B}"/>
+                <a16:creationId xmlns:a16="http://schemas.microsoft.com/office/drawing/2014/main" id="{18033517-6B22-4216-814D-A37A337E7C04}"/>
               </a:ext>
             </a:extLst>
           </p:cNvPr>
@@ -12428,7 +12428,7 @@
           <p:cNvPr id="12" name="">
             <a:extLst xmlns:a="http://schemas.openxmlformats.org/drawingml/2006/main">
               <a:ext uri="{FF2B5EF4-FFF2-40B4-BE49-F238E27FC236}">
-                <a16:creationId xmlns:a16="http://schemas.microsoft.com/office/drawing/2014/main" id="{486C27BB-DF14-4F27-827C-15F25B5F707B}"/>
+                <a16:creationId xmlns:a16="http://schemas.microsoft.com/office/drawing/2014/main" id="{0B7BFD1E-99A1-490E-BFCC-6E3C4BD9EF40}"/>
               </a:ext>
             </a:extLst>
           </p:cNvPr>
@@ -12486,7 +12486,7 @@
           <p:cNvPr id="13" name="">
             <a:extLst xmlns:a="http://schemas.openxmlformats.org/drawingml/2006/main">
               <a:ext uri="{FF2B5EF4-FFF2-40B4-BE49-F238E27FC236}">
-                <a16:creationId xmlns:a16="http://schemas.microsoft.com/office/drawing/2014/main" id="{9CE5E964-1DED-40D9-8C87-91B545BAD266}"/>
+                <a16:creationId xmlns:a16="http://schemas.microsoft.com/office/drawing/2014/main" id="{860FDDE8-F54C-4B00-A797-C33078F7E0E4}"/>
               </a:ext>
             </a:extLst>
           </p:cNvPr>
@@ -12517,7 +12517,7 @@
           <p:cNvPr id="14" name="">
             <a:extLst xmlns:a="http://schemas.openxmlformats.org/drawingml/2006/main">
               <a:ext uri="{FF2B5EF4-FFF2-40B4-BE49-F238E27FC236}">
-                <a16:creationId xmlns:a16="http://schemas.microsoft.com/office/drawing/2014/main" id="{F91C245B-B89A-48BB-9C4C-A142277E0854}"/>
+                <a16:creationId xmlns:a16="http://schemas.microsoft.com/office/drawing/2014/main" id="{4F50E9DE-2D62-48F0-9AEA-E98A40565A76}"/>
               </a:ext>
             </a:extLst>
           </p:cNvPr>
@@ -12575,7 +12575,7 @@
           <p:cNvPr id="15" name="">
             <a:extLst xmlns:a="http://schemas.openxmlformats.org/drawingml/2006/main">
               <a:ext uri="{FF2B5EF4-FFF2-40B4-BE49-F238E27FC236}">
-                <a16:creationId xmlns:a16="http://schemas.microsoft.com/office/drawing/2014/main" id="{9BAACA38-FC33-4CD9-9745-D2BECEEADF4B}"/>
+                <a16:creationId xmlns:a16="http://schemas.microsoft.com/office/drawing/2014/main" id="{E4040895-35FE-490A-91AA-DD04AB814805}"/>
               </a:ext>
             </a:extLst>
           </p:cNvPr>
@@ -12633,7 +12633,7 @@
           <p:cNvPr id="16" name="">
             <a:extLst xmlns:a="http://schemas.openxmlformats.org/drawingml/2006/main">
               <a:ext uri="{FF2B5EF4-FFF2-40B4-BE49-F238E27FC236}">
-                <a16:creationId xmlns:a16="http://schemas.microsoft.com/office/drawing/2014/main" id="{190F8AC5-2BBA-44CE-8EF5-0708B1B60EE1}"/>
+                <a16:creationId xmlns:a16="http://schemas.microsoft.com/office/drawing/2014/main" id="{62BF8BD1-9A0C-4F27-953D-D7F5AE8BE607}"/>
               </a:ext>
             </a:extLst>
           </p:cNvPr>
@@ -12668,7 +12668,7 @@
           <p:cNvPr id="17" name="">
             <a:extLst xmlns:a="http://schemas.openxmlformats.org/drawingml/2006/main">
               <a:ext uri="{FF2B5EF4-FFF2-40B4-BE49-F238E27FC236}">
-                <a16:creationId xmlns:a16="http://schemas.microsoft.com/office/drawing/2014/main" id="{AE0FEC7B-1D99-4318-BF10-7F6C88F01CC7}"/>
+                <a16:creationId xmlns:a16="http://schemas.microsoft.com/office/drawing/2014/main" id="{0A03C5D6-C8A7-4F57-8F68-CFD78DCC409A}"/>
               </a:ext>
             </a:extLst>
           </p:cNvPr>
@@ -12726,7 +12726,7 @@
           <p:cNvPr id="18" name="">
             <a:extLst xmlns:a="http://schemas.openxmlformats.org/drawingml/2006/main">
               <a:ext uri="{FF2B5EF4-FFF2-40B4-BE49-F238E27FC236}">
-                <a16:creationId xmlns:a16="http://schemas.microsoft.com/office/drawing/2014/main" id="{448A7E91-8321-42FF-A10B-32FFF41AC2AB}"/>
+                <a16:creationId xmlns:a16="http://schemas.microsoft.com/office/drawing/2014/main" id="{22DC80D0-1BE2-4817-9DE2-6284F7F3993F}"/>
               </a:ext>
             </a:extLst>
           </p:cNvPr>
@@ -12757,7 +12757,7 @@
           <p:cNvPr id="19" name="">
             <a:extLst xmlns:a="http://schemas.openxmlformats.org/drawingml/2006/main">
               <a:ext uri="{FF2B5EF4-FFF2-40B4-BE49-F238E27FC236}">
-                <a16:creationId xmlns:a16="http://schemas.microsoft.com/office/drawing/2014/main" id="{EE5C9D9D-350A-4F70-8633-C2F7A7D2EF87}"/>
+                <a16:creationId xmlns:a16="http://schemas.microsoft.com/office/drawing/2014/main" id="{0020AD70-7B50-4A54-8522-52960B30E041}"/>
               </a:ext>
             </a:extLst>
           </p:cNvPr>
@@ -12815,7 +12815,7 @@
           <p:cNvPr id="20" name="">
             <a:extLst xmlns:a="http://schemas.openxmlformats.org/drawingml/2006/main">
               <a:ext uri="{FF2B5EF4-FFF2-40B4-BE49-F238E27FC236}">
-                <a16:creationId xmlns:a16="http://schemas.microsoft.com/office/drawing/2014/main" id="{0306BFA6-6745-4915-B42F-A2C3D0417679}"/>
+                <a16:creationId xmlns:a16="http://schemas.microsoft.com/office/drawing/2014/main" id="{0A12E4EF-2ABD-4977-9704-ACFE5232625D}"/>
               </a:ext>
             </a:extLst>
           </p:cNvPr>
@@ -12873,7 +12873,7 @@
           <p:cNvPr id="21" name="">
             <a:extLst xmlns:a="http://schemas.openxmlformats.org/drawingml/2006/main">
               <a:ext uri="{FF2B5EF4-FFF2-40B4-BE49-F238E27FC236}">
-                <a16:creationId xmlns:a16="http://schemas.microsoft.com/office/drawing/2014/main" id="{76E18550-4FA3-4442-BA40-3213DFCE0F39}"/>
+                <a16:creationId xmlns:a16="http://schemas.microsoft.com/office/drawing/2014/main" id="{007C6C53-8592-426D-8FC1-CE704BCD38B0}"/>
               </a:ext>
             </a:extLst>
           </p:cNvPr>
@@ -12908,7 +12908,7 @@
           <p:cNvPr id="22" name="">
             <a:extLst xmlns:a="http://schemas.openxmlformats.org/drawingml/2006/main">
               <a:ext uri="{FF2B5EF4-FFF2-40B4-BE49-F238E27FC236}">
-                <a16:creationId xmlns:a16="http://schemas.microsoft.com/office/drawing/2014/main" id="{3E01BF98-73DF-47BF-B5C4-E2C967003721}"/>
+                <a16:creationId xmlns:a16="http://schemas.microsoft.com/office/drawing/2014/main" id="{52E9127F-6C6A-4D82-A15B-0AE955F29032}"/>
               </a:ext>
             </a:extLst>
           </p:cNvPr>
@@ -12966,7 +12966,7 @@
           <p:cNvPr id="23" name="">
             <a:extLst xmlns:a="http://schemas.openxmlformats.org/drawingml/2006/main">
               <a:ext uri="{FF2B5EF4-FFF2-40B4-BE49-F238E27FC236}">
-                <a16:creationId xmlns:a16="http://schemas.microsoft.com/office/drawing/2014/main" id="{ED53F715-427D-4878-8CC4-5A347FC2A4E1}"/>
+                <a16:creationId xmlns:a16="http://schemas.microsoft.com/office/drawing/2014/main" id="{9C5C341E-C19F-4DE3-A417-3746AE89EE2D}"/>
               </a:ext>
             </a:extLst>
           </p:cNvPr>
@@ -12997,7 +12997,7 @@
           <p:cNvPr id="24" name="">
             <a:extLst xmlns:a="http://schemas.openxmlformats.org/drawingml/2006/main">
               <a:ext uri="{FF2B5EF4-FFF2-40B4-BE49-F238E27FC236}">
-                <a16:creationId xmlns:a16="http://schemas.microsoft.com/office/drawing/2014/main" id="{EB59527D-C776-4083-B469-3CE2DFB84447}"/>
+                <a16:creationId xmlns:a16="http://schemas.microsoft.com/office/drawing/2014/main" id="{E1D103C5-F02B-4E5C-A60E-F3DDC304ED4F}"/>
               </a:ext>
             </a:extLst>
           </p:cNvPr>
@@ -13055,7 +13055,7 @@
           <p:cNvPr id="25" name="">
             <a:extLst xmlns:a="http://schemas.openxmlformats.org/drawingml/2006/main">
               <a:ext uri="{FF2B5EF4-FFF2-40B4-BE49-F238E27FC236}">
-                <a16:creationId xmlns:a16="http://schemas.microsoft.com/office/drawing/2014/main" id="{B3F29A3B-373B-4F05-99AA-4F873480FD42}"/>
+                <a16:creationId xmlns:a16="http://schemas.microsoft.com/office/drawing/2014/main" id="{334F504F-A118-4BC1-B9B1-E17FF32301CE}"/>
               </a:ext>
             </a:extLst>
           </p:cNvPr>
@@ -13113,7 +13113,7 @@
           <p:cNvPr id="26" name="">
             <a:extLst xmlns:a="http://schemas.openxmlformats.org/drawingml/2006/main">
               <a:ext uri="{FF2B5EF4-FFF2-40B4-BE49-F238E27FC236}">
-                <a16:creationId xmlns:a16="http://schemas.microsoft.com/office/drawing/2014/main" id="{1F4848A9-9F68-4A3B-8C64-3B870A00901B}"/>
+                <a16:creationId xmlns:a16="http://schemas.microsoft.com/office/drawing/2014/main" id="{FB623F5D-5724-45C1-9511-0AE5EF9EA6B4}"/>
               </a:ext>
             </a:extLst>
           </p:cNvPr>
@@ -13169,7 +13169,7 @@
     </p:spTree>
     <p:extLst>
       <p:ext uri="{BB962C8B-B14F-4D97-AF65-F5344CB8AC3E}">
-        <p14:creationId xmlns:p14="http://schemas.microsoft.com/office/powerpoint/2010/main" val="739485258"/>
+        <p14:creationId xmlns:p14="http://schemas.microsoft.com/office/powerpoint/2010/main" val="1129788133"/>
       </p:ext>
     </p:extLst>
   </p:cSld>
@@ -13200,7 +13200,7 @@
           <p:cNvPr id="22" name="">
             <a:extLst xmlns:a="http://schemas.openxmlformats.org/drawingml/2006/main">
               <a:ext uri="{FF2B5EF4-FFF2-40B4-BE49-F238E27FC236}">
-                <a16:creationId xmlns:a16="http://schemas.microsoft.com/office/drawing/2014/main" id="{21168B35-CCF5-496B-B3E7-7D435B265A24}"/>
+                <a16:creationId xmlns:a16="http://schemas.microsoft.com/office/drawing/2014/main" id="{649974C4-AA35-4CBB-A8DA-586BD7688DB6}"/>
               </a:ext>
             </a:extLst>
           </p:cNvPr>
@@ -13258,7 +13258,7 @@
           <p:cNvPr id="2" name="">
             <a:extLst xmlns:a="http://schemas.openxmlformats.org/drawingml/2006/main">
               <a:ext uri="{FF2B5EF4-FFF2-40B4-BE49-F238E27FC236}">
-                <a16:creationId xmlns:a16="http://schemas.microsoft.com/office/drawing/2014/main" id="{0FB505D2-6792-4D3C-A3CD-E0A4DB22DC76}"/>
+                <a16:creationId xmlns:a16="http://schemas.microsoft.com/office/drawing/2014/main" id="{39C0213C-FEBA-4569-BDBC-3388A75929A6}"/>
               </a:ext>
             </a:extLst>
           </p:cNvPr>
@@ -13316,7 +13316,7 @@
           <p:cNvPr id="3" name="">
             <a:extLst xmlns:a="http://schemas.openxmlformats.org/drawingml/2006/main">
               <a:ext uri="{FF2B5EF4-FFF2-40B4-BE49-F238E27FC236}">
-                <a16:creationId xmlns:a16="http://schemas.microsoft.com/office/drawing/2014/main" id="{19B6F09A-4A38-4015-A03B-935BE28592C4}"/>
+                <a16:creationId xmlns:a16="http://schemas.microsoft.com/office/drawing/2014/main" id="{DC7CE6E9-D2DF-4F0B-8A5B-AFD7A60A35C5}"/>
               </a:ext>
             </a:extLst>
           </p:cNvPr>
@@ -13349,7 +13349,7 @@
           <p:cNvPr id="4" name="">
             <a:extLst xmlns:a="http://schemas.openxmlformats.org/drawingml/2006/main">
               <a:ext uri="{FF2B5EF4-FFF2-40B4-BE49-F238E27FC236}">
-                <a16:creationId xmlns:a16="http://schemas.microsoft.com/office/drawing/2014/main" id="{ECD96F63-C943-4489-B869-9E42B4EFAAAD}"/>
+                <a16:creationId xmlns:a16="http://schemas.microsoft.com/office/drawing/2014/main" id="{F3C107F4-B8E5-4A39-B053-0417F9E9257F}"/>
               </a:ext>
             </a:extLst>
           </p:cNvPr>
@@ -13407,7 +13407,7 @@
           <p:cNvPr id="5" name="">
             <a:extLst xmlns:a="http://schemas.openxmlformats.org/drawingml/2006/main">
               <a:ext uri="{FF2B5EF4-FFF2-40B4-BE49-F238E27FC236}">
-                <a16:creationId xmlns:a16="http://schemas.microsoft.com/office/drawing/2014/main" id="{290A3B35-0137-437A-8C32-118A8F158C0E}"/>
+                <a16:creationId xmlns:a16="http://schemas.microsoft.com/office/drawing/2014/main" id="{D4BE66B8-DBFA-413E-9FF3-42370994F560}"/>
               </a:ext>
             </a:extLst>
           </p:cNvPr>
@@ -13465,7 +13465,7 @@
           <p:cNvPr id="6" name="">
             <a:extLst xmlns:a="http://schemas.openxmlformats.org/drawingml/2006/main">
               <a:ext uri="{FF2B5EF4-FFF2-40B4-BE49-F238E27FC236}">
-                <a16:creationId xmlns:a16="http://schemas.microsoft.com/office/drawing/2014/main" id="{027C400B-DC5C-4EA2-9642-5B1E5FC50DB9}"/>
+                <a16:creationId xmlns:a16="http://schemas.microsoft.com/office/drawing/2014/main" id="{C6295B62-781F-462E-A4A3-910CED171AAE}"/>
               </a:ext>
             </a:extLst>
           </p:cNvPr>
@@ -13500,7 +13500,7 @@
           <p:cNvPr id="7" name="">
             <a:extLst xmlns:a="http://schemas.openxmlformats.org/drawingml/2006/main">
               <a:ext uri="{FF2B5EF4-FFF2-40B4-BE49-F238E27FC236}">
-                <a16:creationId xmlns:a16="http://schemas.microsoft.com/office/drawing/2014/main" id="{371E810C-5001-45FA-8490-C6781301E0B9}"/>
+                <a16:creationId xmlns:a16="http://schemas.microsoft.com/office/drawing/2014/main" id="{848115B8-A678-4721-8CDB-EE0F81814F89}"/>
               </a:ext>
             </a:extLst>
           </p:cNvPr>
@@ -13533,7 +13533,7 @@
           <p:cNvPr id="8" name="">
             <a:extLst xmlns:a="http://schemas.openxmlformats.org/drawingml/2006/main">
               <a:ext uri="{FF2B5EF4-FFF2-40B4-BE49-F238E27FC236}">
-                <a16:creationId xmlns:a16="http://schemas.microsoft.com/office/drawing/2014/main" id="{5B0EA87B-1B31-4561-AF4C-FF669CDF0D49}"/>
+                <a16:creationId xmlns:a16="http://schemas.microsoft.com/office/drawing/2014/main" id="{1441BFF6-61C4-42A2-83C8-A3AF8211F67C}"/>
               </a:ext>
             </a:extLst>
           </p:cNvPr>
@@ -13591,7 +13591,7 @@
           <p:cNvPr id="9" name="">
             <a:extLst xmlns:a="http://schemas.openxmlformats.org/drawingml/2006/main">
               <a:ext uri="{FF2B5EF4-FFF2-40B4-BE49-F238E27FC236}">
-                <a16:creationId xmlns:a16="http://schemas.microsoft.com/office/drawing/2014/main" id="{898E207A-E0EB-4468-AB4D-99D4CD4846B9}"/>
+                <a16:creationId xmlns:a16="http://schemas.microsoft.com/office/drawing/2014/main" id="{C6CCC4BB-35BA-498F-89E9-B1385BBB0FE4}"/>
               </a:ext>
             </a:extLst>
           </p:cNvPr>
@@ -13649,7 +13649,7 @@
           <p:cNvPr id="10" name="">
             <a:extLst xmlns:a="http://schemas.openxmlformats.org/drawingml/2006/main">
               <a:ext uri="{FF2B5EF4-FFF2-40B4-BE49-F238E27FC236}">
-                <a16:creationId xmlns:a16="http://schemas.microsoft.com/office/drawing/2014/main" id="{923A3D92-11D4-44B3-AB00-7887A7B56232}"/>
+                <a16:creationId xmlns:a16="http://schemas.microsoft.com/office/drawing/2014/main" id="{22316746-D53A-4CAC-846E-8A3E6E208BD0}"/>
               </a:ext>
             </a:extLst>
           </p:cNvPr>
@@ -13684,7 +13684,7 @@
           <p:cNvPr id="11" name="">
             <a:extLst xmlns:a="http://schemas.openxmlformats.org/drawingml/2006/main">
               <a:ext uri="{FF2B5EF4-FFF2-40B4-BE49-F238E27FC236}">
-                <a16:creationId xmlns:a16="http://schemas.microsoft.com/office/drawing/2014/main" id="{5F88FE74-6722-4744-85DC-5FD2E7C10BFF}"/>
+                <a16:creationId xmlns:a16="http://schemas.microsoft.com/office/drawing/2014/main" id="{F30EDC50-2665-4915-B163-9EEC5685B27D}"/>
               </a:ext>
             </a:extLst>
           </p:cNvPr>
@@ -13717,7 +13717,7 @@
           <p:cNvPr id="12" name="">
             <a:extLst xmlns:a="http://schemas.openxmlformats.org/drawingml/2006/main">
               <a:ext uri="{FF2B5EF4-FFF2-40B4-BE49-F238E27FC236}">
-                <a16:creationId xmlns:a16="http://schemas.microsoft.com/office/drawing/2014/main" id="{5B0B3BC7-7575-4B2F-B8D0-1548D79CD794}"/>
+                <a16:creationId xmlns:a16="http://schemas.microsoft.com/office/drawing/2014/main" id="{41CBBA8B-35FA-40C1-8680-3B1FD89589BC}"/>
               </a:ext>
             </a:extLst>
           </p:cNvPr>
@@ -13775,7 +13775,7 @@
           <p:cNvPr id="13" name="">
             <a:extLst xmlns:a="http://schemas.openxmlformats.org/drawingml/2006/main">
               <a:ext uri="{FF2B5EF4-FFF2-40B4-BE49-F238E27FC236}">
-                <a16:creationId xmlns:a16="http://schemas.microsoft.com/office/drawing/2014/main" id="{CD4EEE56-096E-4B92-8921-5AC6F6F386DC}"/>
+                <a16:creationId xmlns:a16="http://schemas.microsoft.com/office/drawing/2014/main" id="{1A50AA0D-B7B8-4C92-A635-FB1F2BBBC8B4}"/>
               </a:ext>
             </a:extLst>
           </p:cNvPr>
@@ -13833,7 +13833,7 @@
           <p:cNvPr id="14" name="">
             <a:extLst xmlns:a="http://schemas.openxmlformats.org/drawingml/2006/main">
               <a:ext uri="{FF2B5EF4-FFF2-40B4-BE49-F238E27FC236}">
-                <a16:creationId xmlns:a16="http://schemas.microsoft.com/office/drawing/2014/main" id="{44406EF8-C98A-4874-80F5-963C514CD1BA}"/>
+                <a16:creationId xmlns:a16="http://schemas.microsoft.com/office/drawing/2014/main" id="{45F0A0D4-3015-4451-8845-D5040655F8AA}"/>
               </a:ext>
             </a:extLst>
           </p:cNvPr>
@@ -13868,7 +13868,7 @@
           <p:cNvPr id="15" name="">
             <a:extLst xmlns:a="http://schemas.openxmlformats.org/drawingml/2006/main">
               <a:ext uri="{FF2B5EF4-FFF2-40B4-BE49-F238E27FC236}">
-                <a16:creationId xmlns:a16="http://schemas.microsoft.com/office/drawing/2014/main" id="{504E2AC2-98E4-4FC7-A183-566244DC6FC6}"/>
+                <a16:creationId xmlns:a16="http://schemas.microsoft.com/office/drawing/2014/main" id="{277410DD-70F3-4E14-8E62-34168519CACA}"/>
               </a:ext>
             </a:extLst>
           </p:cNvPr>
@@ -13901,7 +13901,7 @@
           <p:cNvPr id="16" name="">
             <a:extLst xmlns:a="http://schemas.openxmlformats.org/drawingml/2006/main">
               <a:ext uri="{FF2B5EF4-FFF2-40B4-BE49-F238E27FC236}">
-                <a16:creationId xmlns:a16="http://schemas.microsoft.com/office/drawing/2014/main" id="{1F8FF1B3-2255-4C01-8994-1379AA4CE317}"/>
+                <a16:creationId xmlns:a16="http://schemas.microsoft.com/office/drawing/2014/main" id="{4C928A23-03B5-430E-8D80-1A7F80FE1D7F}"/>
               </a:ext>
             </a:extLst>
           </p:cNvPr>
@@ -13959,7 +13959,7 @@
           <p:cNvPr id="17" name="">
             <a:extLst xmlns:a="http://schemas.openxmlformats.org/drawingml/2006/main">
               <a:ext uri="{FF2B5EF4-FFF2-40B4-BE49-F238E27FC236}">
-                <a16:creationId xmlns:a16="http://schemas.microsoft.com/office/drawing/2014/main" id="{BA68C034-E3F4-4C90-AE9B-91B858ECE5F1}"/>
+                <a16:creationId xmlns:a16="http://schemas.microsoft.com/office/drawing/2014/main" id="{BDDBAF5E-9347-4FB2-BC64-E4E2240D0573}"/>
               </a:ext>
             </a:extLst>
           </p:cNvPr>
@@ -14017,7 +14017,7 @@
           <p:cNvPr id="18" name="">
             <a:extLst xmlns:a="http://schemas.openxmlformats.org/drawingml/2006/main">
               <a:ext uri="{FF2B5EF4-FFF2-40B4-BE49-F238E27FC236}">
-                <a16:creationId xmlns:a16="http://schemas.microsoft.com/office/drawing/2014/main" id="{098EDE03-012E-4F14-9E7B-88A0ED5EB5B7}"/>
+                <a16:creationId xmlns:a16="http://schemas.microsoft.com/office/drawing/2014/main" id="{8A4AEB42-9A91-4A99-B1CE-95B054AF1AD8}"/>
               </a:ext>
             </a:extLst>
           </p:cNvPr>
@@ -14052,7 +14052,7 @@
           <p:cNvPr id="19" name="">
             <a:extLst xmlns:a="http://schemas.openxmlformats.org/drawingml/2006/main">
               <a:ext uri="{FF2B5EF4-FFF2-40B4-BE49-F238E27FC236}">
-                <a16:creationId xmlns:a16="http://schemas.microsoft.com/office/drawing/2014/main" id="{8B57CD7A-05AA-47D6-8717-0E9796480421}"/>
+                <a16:creationId xmlns:a16="http://schemas.microsoft.com/office/drawing/2014/main" id="{155DA248-D529-4303-A363-115E2AF7D3A3}"/>
               </a:ext>
             </a:extLst>
           </p:cNvPr>
@@ -14085,7 +14085,7 @@
           <p:cNvPr id="20" name="">
             <a:extLst xmlns:a="http://schemas.openxmlformats.org/drawingml/2006/main">
               <a:ext uri="{FF2B5EF4-FFF2-40B4-BE49-F238E27FC236}">
-                <a16:creationId xmlns:a16="http://schemas.microsoft.com/office/drawing/2014/main" id="{951C719A-65B5-4A15-9545-B74F2754BD3A}"/>
+                <a16:creationId xmlns:a16="http://schemas.microsoft.com/office/drawing/2014/main" id="{665773B2-DFF8-4777-BFC3-08E9EECFCBAA}"/>
               </a:ext>
             </a:extLst>
           </p:cNvPr>
@@ -14143,7 +14143,7 @@
           <p:cNvPr id="21" name="">
             <a:extLst xmlns:a="http://schemas.openxmlformats.org/drawingml/2006/main">
               <a:ext uri="{FF2B5EF4-FFF2-40B4-BE49-F238E27FC236}">
-                <a16:creationId xmlns:a16="http://schemas.microsoft.com/office/drawing/2014/main" id="{059D2F7E-B74D-40B3-B36C-52708178AB45}"/>
+                <a16:creationId xmlns:a16="http://schemas.microsoft.com/office/drawing/2014/main" id="{0F9315C7-E774-4789-9252-C58197F330CE}"/>
               </a:ext>
             </a:extLst>
           </p:cNvPr>
@@ -14216,7 +14216,7 @@
     </p:spTree>
     <p:extLst>
       <p:ext uri="{BB962C8B-B14F-4D97-AF65-F5344CB8AC3E}">
-        <p14:creationId xmlns:p14="http://schemas.microsoft.com/office/powerpoint/2010/main" val="104724685"/>
+        <p14:creationId xmlns:p14="http://schemas.microsoft.com/office/powerpoint/2010/main" val="1907954273"/>
       </p:ext>
     </p:extLst>
   </p:cSld>
@@ -14247,7 +14247,7 @@
           <p:cNvPr id="19" name="">
             <a:extLst xmlns:a="http://schemas.openxmlformats.org/drawingml/2006/main">
               <a:ext uri="{FF2B5EF4-FFF2-40B4-BE49-F238E27FC236}">
-                <a16:creationId xmlns:a16="http://schemas.microsoft.com/office/drawing/2014/main" id="{7292057E-601C-4DB9-A095-414E206BEAA3}"/>
+                <a16:creationId xmlns:a16="http://schemas.microsoft.com/office/drawing/2014/main" id="{7335E1AD-B721-4D9E-A145-6AFEC6881A29}"/>
               </a:ext>
             </a:extLst>
           </p:cNvPr>
@@ -14305,7 +14305,7 @@
           <p:cNvPr id="2" name="">
             <a:extLst xmlns:a="http://schemas.openxmlformats.org/drawingml/2006/main">
               <a:ext uri="{FF2B5EF4-FFF2-40B4-BE49-F238E27FC236}">
-                <a16:creationId xmlns:a16="http://schemas.microsoft.com/office/drawing/2014/main" id="{2FB1A5C5-CC1C-4C3B-BD82-ED5DCBB53948}"/>
+                <a16:creationId xmlns:a16="http://schemas.microsoft.com/office/drawing/2014/main" id="{AD1C722F-1077-4886-AF99-A55C85B261A2}"/>
               </a:ext>
             </a:extLst>
           </p:cNvPr>
@@ -14353,7 +14353,7 @@
                   <a:srgbClr val="16202A"/>
                 </a:solidFill>
               </a:rPr>
-              <a:t>Demostración de errores controlados</a:t>
+              <a:t>Errores y caídas controladas</a:t>
             </a:r>
           </a:p>
         </p:txBody>
@@ -14363,7 +14363,7 @@
           <p:cNvPr id="3" name="">
             <a:extLst xmlns:a="http://schemas.openxmlformats.org/drawingml/2006/main">
               <a:ext uri="{FF2B5EF4-FFF2-40B4-BE49-F238E27FC236}">
-                <a16:creationId xmlns:a16="http://schemas.microsoft.com/office/drawing/2014/main" id="{AFB3FECF-69FA-41E5-B019-78A300225250}"/>
+                <a16:creationId xmlns:a16="http://schemas.microsoft.com/office/drawing/2014/main" id="{052786D8-8F9A-4849-9F10-61371E9EBF09}"/>
               </a:ext>
             </a:extLst>
           </p:cNvPr>
@@ -14396,7 +14396,7 @@
           <p:cNvPr id="4" name="">
             <a:extLst xmlns:a="http://schemas.openxmlformats.org/drawingml/2006/main">
               <a:ext uri="{FF2B5EF4-FFF2-40B4-BE49-F238E27FC236}">
-                <a16:creationId xmlns:a16="http://schemas.microsoft.com/office/drawing/2014/main" id="{50C92133-16FF-4747-A445-F9455A740494}"/>
+                <a16:creationId xmlns:a16="http://schemas.microsoft.com/office/drawing/2014/main" id="{319C030A-A175-4521-88D3-E59D0016188A}"/>
               </a:ext>
             </a:extLst>
           </p:cNvPr>
@@ -14454,7 +14454,7 @@
           <p:cNvPr id="5" name="">
             <a:extLst xmlns:a="http://schemas.openxmlformats.org/drawingml/2006/main">
               <a:ext uri="{FF2B5EF4-FFF2-40B4-BE49-F238E27FC236}">
-                <a16:creationId xmlns:a16="http://schemas.microsoft.com/office/drawing/2014/main" id="{DEAC0AD2-E35D-4B36-AEAE-F29F099DC8E7}"/>
+                <a16:creationId xmlns:a16="http://schemas.microsoft.com/office/drawing/2014/main" id="{918D9A08-3494-4259-B43B-1B00763B5443}"/>
               </a:ext>
             </a:extLst>
           </p:cNvPr>
@@ -14512,7 +14512,7 @@
           <p:cNvPr id="6" name="">
             <a:extLst xmlns:a="http://schemas.openxmlformats.org/drawingml/2006/main">
               <a:ext uri="{FF2B5EF4-FFF2-40B4-BE49-F238E27FC236}">
-                <a16:creationId xmlns:a16="http://schemas.microsoft.com/office/drawing/2014/main" id="{1279DB77-F0ED-4013-84D1-8F0692F52890}"/>
+                <a16:creationId xmlns:a16="http://schemas.microsoft.com/office/drawing/2014/main" id="{3630E620-5516-4DF4-9B33-772F21933602}"/>
               </a:ext>
             </a:extLst>
           </p:cNvPr>
@@ -14547,7 +14547,7 @@
           <p:cNvPr id="7" name="">
             <a:extLst xmlns:a="http://schemas.openxmlformats.org/drawingml/2006/main">
               <a:ext uri="{FF2B5EF4-FFF2-40B4-BE49-F238E27FC236}">
-                <a16:creationId xmlns:a16="http://schemas.microsoft.com/office/drawing/2014/main" id="{10DF16F7-59D4-4A51-9C5D-D0D201217BE7}"/>
+                <a16:creationId xmlns:a16="http://schemas.microsoft.com/office/drawing/2014/main" id="{734BF0B9-B6E6-4F3D-BDA8-10CE13DEC781}"/>
               </a:ext>
             </a:extLst>
           </p:cNvPr>
@@ -14605,7 +14605,7 @@
           <p:cNvPr id="8" name="">
             <a:extLst xmlns:a="http://schemas.openxmlformats.org/drawingml/2006/main">
               <a:ext uri="{FF2B5EF4-FFF2-40B4-BE49-F238E27FC236}">
-                <a16:creationId xmlns:a16="http://schemas.microsoft.com/office/drawing/2014/main" id="{208E333D-15E9-4464-AF66-B746B7FC0A0F}"/>
+                <a16:creationId xmlns:a16="http://schemas.microsoft.com/office/drawing/2014/main" id="{647A568B-6ED5-497C-924E-8023828DFACF}"/>
               </a:ext>
             </a:extLst>
           </p:cNvPr>
@@ -14653,7 +14653,7 @@
                   <a:srgbClr val="52606D"/>
                 </a:solidFill>
               </a:rPr>
-              <a:t>Comando inexistente</a:t>
+              <a:t>Rechaza la orden sin modificar datos</a:t>
             </a:r>
           </a:p>
         </p:txBody>
@@ -14663,7 +14663,7 @@
           <p:cNvPr id="9" name="">
             <a:extLst xmlns:a="http://schemas.openxmlformats.org/drawingml/2006/main">
               <a:ext uri="{FF2B5EF4-FFF2-40B4-BE49-F238E27FC236}">
-                <a16:creationId xmlns:a16="http://schemas.microsoft.com/office/drawing/2014/main" id="{83CCC72C-DAE6-4049-9519-F4407B4F840D}"/>
+                <a16:creationId xmlns:a16="http://schemas.microsoft.com/office/drawing/2014/main" id="{D55A0CDE-071D-4A09-9F81-7721383A3DE5}"/>
               </a:ext>
             </a:extLst>
           </p:cNvPr>
@@ -14698,7 +14698,7 @@
           <p:cNvPr id="10" name="">
             <a:extLst xmlns:a="http://schemas.openxmlformats.org/drawingml/2006/main">
               <a:ext uri="{FF2B5EF4-FFF2-40B4-BE49-F238E27FC236}">
-                <a16:creationId xmlns:a16="http://schemas.microsoft.com/office/drawing/2014/main" id="{B9F1A020-D872-4663-8B18-034375E93DFF}"/>
+                <a16:creationId xmlns:a16="http://schemas.microsoft.com/office/drawing/2014/main" id="{0B218930-9C77-4A2A-BA3B-F300E3F0E8A4}"/>
               </a:ext>
             </a:extLst>
           </p:cNvPr>
@@ -14746,7 +14746,7 @@
                   <a:srgbClr val="B42318"/>
                 </a:solidFill>
               </a:rPr>
-              <a:t>REGEXA["1","120","nota"]</a:t>
+              <a:t>PostgreSQL fuera de línea</a:t>
             </a:r>
           </a:p>
         </p:txBody>
@@ -14756,7 +14756,7 @@
           <p:cNvPr id="11" name="">
             <a:extLst xmlns:a="http://schemas.openxmlformats.org/drawingml/2006/main">
               <a:ext uri="{FF2B5EF4-FFF2-40B4-BE49-F238E27FC236}">
-                <a16:creationId xmlns:a16="http://schemas.microsoft.com/office/drawing/2014/main" id="{6CCF3C91-59C5-4AA0-BD34-9BB8F8EE5590}"/>
+                <a16:creationId xmlns:a16="http://schemas.microsoft.com/office/drawing/2014/main" id="{D35C0E2B-423C-4F63-9417-43E73BD3C25C}"/>
               </a:ext>
             </a:extLst>
           </p:cNvPr>
@@ -14804,7 +14804,7 @@
                   <a:srgbClr val="52606D"/>
                 </a:solidFill>
               </a:rPr>
-              <a:t>Puntaje fuera de 0 a 100</a:t>
+              <a:t>Conserva el correo y reintenta con espera creciente</a:t>
             </a:r>
           </a:p>
         </p:txBody>
@@ -14814,7 +14814,7 @@
           <p:cNvPr id="12" name="">
             <a:extLst xmlns:a="http://schemas.openxmlformats.org/drawingml/2006/main">
               <a:ext uri="{FF2B5EF4-FFF2-40B4-BE49-F238E27FC236}">
-                <a16:creationId xmlns:a16="http://schemas.microsoft.com/office/drawing/2014/main" id="{35F33DB6-1EA8-4B84-A4C3-0E147A58C1CF}"/>
+                <a16:creationId xmlns:a16="http://schemas.microsoft.com/office/drawing/2014/main" id="{CEAC496E-2759-49CE-9BAE-087F9AC1A3EF}"/>
               </a:ext>
             </a:extLst>
           </p:cNvPr>
@@ -14849,7 +14849,7 @@
           <p:cNvPr id="13" name="">
             <a:extLst xmlns:a="http://schemas.openxmlformats.org/drawingml/2006/main">
               <a:ext uri="{FF2B5EF4-FFF2-40B4-BE49-F238E27FC236}">
-                <a16:creationId xmlns:a16="http://schemas.microsoft.com/office/drawing/2014/main" id="{35115611-8AC6-404C-B318-E1ED000B3FB1}"/>
+                <a16:creationId xmlns:a16="http://schemas.microsoft.com/office/drawing/2014/main" id="{970C7662-C1D2-4FF5-980C-E28775A1AF26}"/>
               </a:ext>
             </a:extLst>
           </p:cNvPr>
@@ -14897,7 +14897,7 @@
                   <a:srgbClr val="B42318"/>
                 </a:solidFill>
               </a:rPr>
-              <a:t>INSCON con fecha final anterior</a:t>
+              <a:t>POP3 fuera de línea</a:t>
             </a:r>
           </a:p>
         </p:txBody>
@@ -14907,7 +14907,7 @@
           <p:cNvPr id="14" name="">
             <a:extLst xmlns:a="http://schemas.openxmlformats.org/drawingml/2006/main">
               <a:ext uri="{FF2B5EF4-FFF2-40B4-BE49-F238E27FC236}">
-                <a16:creationId xmlns:a16="http://schemas.microsoft.com/office/drawing/2014/main" id="{59C25409-5B4A-48BF-9792-CA0EE53AEE72}"/>
+                <a16:creationId xmlns:a16="http://schemas.microsoft.com/office/drawing/2014/main" id="{E9794AA8-7766-423F-83CD-E1301F1BC7AD}"/>
               </a:ext>
             </a:extLst>
           </p:cNvPr>
@@ -14955,7 +14955,7 @@
                   <a:srgbClr val="52606D"/>
                 </a:solidFill>
               </a:rPr>
-              <a:t>Periodo inválido</a:t>
+              <a:t>El proceso sigue activo y reconecta automáticamente</a:t>
             </a:r>
           </a:p>
         </p:txBody>
@@ -14965,7 +14965,7 @@
           <p:cNvPr id="15" name="">
             <a:extLst xmlns:a="http://schemas.openxmlformats.org/drawingml/2006/main">
               <a:ext uri="{FF2B5EF4-FFF2-40B4-BE49-F238E27FC236}">
-                <a16:creationId xmlns:a16="http://schemas.microsoft.com/office/drawing/2014/main" id="{458EA4DC-99B0-450D-8EB9-8C476E021FD2}"/>
+                <a16:creationId xmlns:a16="http://schemas.microsoft.com/office/drawing/2014/main" id="{15172930-6EF6-4350-A7BF-BD4B07D4A4B7}"/>
               </a:ext>
             </a:extLst>
           </p:cNvPr>
@@ -15000,7 +15000,7 @@
           <p:cNvPr id="16" name="">
             <a:extLst xmlns:a="http://schemas.openxmlformats.org/drawingml/2006/main">
               <a:ext uri="{FF2B5EF4-FFF2-40B4-BE49-F238E27FC236}">
-                <a16:creationId xmlns:a16="http://schemas.microsoft.com/office/drawing/2014/main" id="{9D972AB9-557E-492B-9319-D8FA4BB7E33E}"/>
+                <a16:creationId xmlns:a16="http://schemas.microsoft.com/office/drawing/2014/main" id="{79AB1332-A641-4C88-9455-5A63FEE05BE6}"/>
               </a:ext>
             </a:extLst>
           </p:cNvPr>
@@ -15048,7 +15048,7 @@
                   <a:srgbClr val="B42318"/>
                 </a:solidFill>
               </a:rPr>
-              <a:t>Orden privada desde correo no registrado</a:t>
+              <a:t>Correo repetido</a:t>
             </a:r>
           </a:p>
         </p:txBody>
@@ -15058,7 +15058,7 @@
           <p:cNvPr id="17" name="">
             <a:extLst xmlns:a="http://schemas.openxmlformats.org/drawingml/2006/main">
               <a:ext uri="{FF2B5EF4-FFF2-40B4-BE49-F238E27FC236}">
-                <a16:creationId xmlns:a16="http://schemas.microsoft.com/office/drawing/2014/main" id="{923EE56B-7FB1-4D0D-A3B8-DC2264BD55C0}"/>
+                <a16:creationId xmlns:a16="http://schemas.microsoft.com/office/drawing/2014/main" id="{B508A5E2-A9C1-409C-90D1-63E85B0F2FC8}"/>
               </a:ext>
             </a:extLst>
           </p:cNvPr>
@@ -15106,7 +15106,7 @@
                   <a:srgbClr val="52606D"/>
                 </a:solidFill>
               </a:rPr>
-              <a:t>Rol insuficiente</a:t>
+              <a:t>El identificador evita ejecutar dos veces la operación</a:t>
             </a:r>
           </a:p>
         </p:txBody>
@@ -15116,19 +15116,19 @@
           <p:cNvPr id="18" name="">
             <a:extLst xmlns:a="http://schemas.openxmlformats.org/drawingml/2006/main">
               <a:ext uri="{FF2B5EF4-FFF2-40B4-BE49-F238E27FC236}">
-                <a16:creationId xmlns:a16="http://schemas.microsoft.com/office/drawing/2014/main" id="{88793FC9-0C91-4B51-A946-0A1340AF35DF}"/>
-              </a:ext>
-            </a:extLst>
-          </p:cNvPr>
-          <p:cNvSpPr>
-            <a:spLocks xmlns:a="http://schemas.openxmlformats.org/drawingml/2006/main" noGrp="1"/>
-          </p:cNvSpPr>
-          <p:nvPr/>
-        </p:nvSpPr>
-        <p:spPr>
-          <a:xfrm xmlns:a="http://schemas.openxmlformats.org/drawingml/2006/main">
-            <a:off x="1714500" y="5857875"/>
-            <a:ext cx="8763000" cy="333375"/>
+                <a16:creationId xmlns:a16="http://schemas.microsoft.com/office/drawing/2014/main" id="{F1B0A759-86C5-47B3-A796-9F4EF384691E}"/>
+              </a:ext>
+            </a:extLst>
+          </p:cNvPr>
+          <p:cNvSpPr>
+            <a:spLocks xmlns:a="http://schemas.openxmlformats.org/drawingml/2006/main" noGrp="1"/>
+          </p:cNvSpPr>
+          <p:nvPr/>
+        </p:nvSpPr>
+        <p:spPr>
+          <a:xfrm xmlns:a="http://schemas.openxmlformats.org/drawingml/2006/main">
+            <a:off x="1381125" y="5857875"/>
+            <a:ext cx="9429750" cy="333375"/>
           </a:xfrm>
           <a:prstGeom xmlns:a="http://schemas.openxmlformats.org/drawingml/2006/main" prst="rect">
             <a:avLst/>
@@ -15164,7 +15164,7 @@
                   <a:srgbClr val="17365D"/>
                 </a:solidFill>
               </a:rPr>
-              <a:t>Cada error produce una respuesta explicativa y evita modificar la base de datos.</a:t>
+              <a:t>Pruebas automatizadas: 13 aprobadas. Los cortes simulados no detuvieron el servicio.</a:t>
             </a:r>
           </a:p>
         </p:txBody>
@@ -15172,7 +15172,7 @@
     </p:spTree>
     <p:extLst>
       <p:ext uri="{BB962C8B-B14F-4D97-AF65-F5344CB8AC3E}">
-        <p14:creationId xmlns:p14="http://schemas.microsoft.com/office/powerpoint/2010/main" val="1837870734"/>
+        <p14:creationId xmlns:p14="http://schemas.microsoft.com/office/powerpoint/2010/main" val="1827227323"/>
       </p:ext>
     </p:extLst>
   </p:cSld>

</xml_diff>

<commit_message>
Endurecer transporte HTTPS y pruebas de resiliencia
</commit_message>
<xml_diff>
--- a/entrega/Presentacion_INF513_P1_Grupo09SA.pptx
+++ b/entrega/Presentacion_INF513_P1_Grupo09SA.pptx
@@ -2,22 +2,22 @@
 <file path=ppt/presentation.xml><?xml version="1.0" encoding="utf-8"?>
 <p:presentation xmlns:p="http://schemas.openxmlformats.org/presentationml/2006/main">
   <p:sldMasterIdLst>
-    <p:sldMasterId xmlns:r="http://schemas.openxmlformats.org/officeDocument/2006/relationships" id="2147483648" r:id="R0629df0b0d8644d6"/>
+    <p:sldMasterId xmlns:r="http://schemas.openxmlformats.org/officeDocument/2006/relationships" id="2147483648" r:id="Re817ce7c3c434844"/>
   </p:sldMasterIdLst>
   <p:notesMasterIdLst>
-    <p:notesMasterId xmlns:r="http://schemas.openxmlformats.org/officeDocument/2006/relationships" r:id="Ra533003d3f1c42fa"/>
+    <p:notesMasterId xmlns:r="http://schemas.openxmlformats.org/officeDocument/2006/relationships" r:id="Rf5bc71f68c514403"/>
   </p:notesMasterIdLst>
   <p:sldIdLst>
-    <p:sldId xmlns:r="http://schemas.openxmlformats.org/officeDocument/2006/relationships" id="256" r:id="Rd590515aa1844d8b"/>
-    <p:sldId xmlns:r="http://schemas.openxmlformats.org/officeDocument/2006/relationships" id="257" r:id="R79cadbc2cd234713"/>
-    <p:sldId xmlns:r="http://schemas.openxmlformats.org/officeDocument/2006/relationships" id="258" r:id="R496e503f9a3044a1"/>
-    <p:sldId xmlns:r="http://schemas.openxmlformats.org/officeDocument/2006/relationships" id="259" r:id="R7200763feb3242ae"/>
-    <p:sldId xmlns:r="http://schemas.openxmlformats.org/officeDocument/2006/relationships" id="260" r:id="R11c2b42dcec04fc2"/>
-    <p:sldId xmlns:r="http://schemas.openxmlformats.org/officeDocument/2006/relationships" id="261" r:id="Rb915c16a25bd4289"/>
-    <p:sldId xmlns:r="http://schemas.openxmlformats.org/officeDocument/2006/relationships" id="262" r:id="R2f20edea218f4583"/>
-    <p:sldId xmlns:r="http://schemas.openxmlformats.org/officeDocument/2006/relationships" id="263" r:id="R33a3e0d3ab984270"/>
-    <p:sldId xmlns:r="http://schemas.openxmlformats.org/officeDocument/2006/relationships" id="264" r:id="Rd1c96349caa1434b"/>
-    <p:sldId xmlns:r="http://schemas.openxmlformats.org/officeDocument/2006/relationships" id="265" r:id="R34c32c1b723a4cce"/>
+    <p:sldId xmlns:r="http://schemas.openxmlformats.org/officeDocument/2006/relationships" id="256" r:id="Rf21bca018b424a3d"/>
+    <p:sldId xmlns:r="http://schemas.openxmlformats.org/officeDocument/2006/relationships" id="257" r:id="R673c47f8b81b4f6d"/>
+    <p:sldId xmlns:r="http://schemas.openxmlformats.org/officeDocument/2006/relationships" id="258" r:id="Rb5a429d4ea48467f"/>
+    <p:sldId xmlns:r="http://schemas.openxmlformats.org/officeDocument/2006/relationships" id="259" r:id="R80272860448747c0"/>
+    <p:sldId xmlns:r="http://schemas.openxmlformats.org/officeDocument/2006/relationships" id="260" r:id="R45d687d142d74d85"/>
+    <p:sldId xmlns:r="http://schemas.openxmlformats.org/officeDocument/2006/relationships" id="261" r:id="R504b662e8e8242c6"/>
+    <p:sldId xmlns:r="http://schemas.openxmlformats.org/officeDocument/2006/relationships" id="262" r:id="Raabe08925980494b"/>
+    <p:sldId xmlns:r="http://schemas.openxmlformats.org/officeDocument/2006/relationships" id="263" r:id="Rdbe5e2f95419456c"/>
+    <p:sldId xmlns:r="http://schemas.openxmlformats.org/officeDocument/2006/relationships" id="264" r:id="Re9518aa1cb434295"/>
+    <p:sldId xmlns:r="http://schemas.openxmlformats.org/officeDocument/2006/relationships" id="265" r:id="R1ea8f75785604adc"/>
   </p:sldIdLst>
   <p:sldSz cx="12192000" cy="6858000"/>
   <p:notesSz cx="6858000" cy="9144000"/>
@@ -1088,7 +1088,7 @@
           <p:cNvPr id="3" name="Title">
             <a:extLst xmlns:a="http://schemas.openxmlformats.org/drawingml/2006/main">
               <a:ext uri="{FF2B5EF4-FFF2-40B4-BE49-F238E27FC236}">
-                <a16:creationId xmlns:a16="http://schemas.microsoft.com/office/drawing/2014/main" id="{6DA8EA78-0CE2-4C3F-9434-5BE4D7465951}"/>
+                <a16:creationId xmlns:a16="http://schemas.microsoft.com/office/drawing/2014/main" id="{AD9D4D95-C33F-47B4-ACE9-63D0C7BD3CF7}"/>
               </a:ext>
             </a:extLst>
           </p:cNvPr>
@@ -1245,7 +1245,7 @@
           <p:cNvPr id="2" name="Subtitle">
             <a:extLst xmlns:a="http://schemas.openxmlformats.org/drawingml/2006/main">
               <a:ext uri="{FF2B5EF4-FFF2-40B4-BE49-F238E27FC236}">
-                <a16:creationId xmlns:a16="http://schemas.microsoft.com/office/drawing/2014/main" id="{FAA2046B-D013-4F7A-BCC6-2FBB3BF6A23E}"/>
+                <a16:creationId xmlns:a16="http://schemas.microsoft.com/office/drawing/2014/main" id="{5789EFE3-51EA-4195-9E3F-41DC960B7CE7}"/>
               </a:ext>
             </a:extLst>
           </p:cNvPr>
@@ -1419,7 +1419,7 @@
           <p:cNvPr id="2" name="Section title">
             <a:extLst xmlns:a="http://schemas.openxmlformats.org/drawingml/2006/main">
               <a:ext uri="{FF2B5EF4-FFF2-40B4-BE49-F238E27FC236}">
-                <a16:creationId xmlns:a16="http://schemas.microsoft.com/office/drawing/2014/main" id="{3718BB34-B0D7-4E81-B74B-0A5E8044EF9B}"/>
+                <a16:creationId xmlns:a16="http://schemas.microsoft.com/office/drawing/2014/main" id="{4ECF06F8-590E-4649-BC64-2A90B68C3176}"/>
               </a:ext>
             </a:extLst>
           </p:cNvPr>
@@ -1593,7 +1593,7 @@
           <p:cNvPr id="3" name="Title">
             <a:extLst xmlns:a="http://schemas.openxmlformats.org/drawingml/2006/main">
               <a:ext uri="{FF2B5EF4-FFF2-40B4-BE49-F238E27FC236}">
-                <a16:creationId xmlns:a16="http://schemas.microsoft.com/office/drawing/2014/main" id="{22087808-EC31-413D-BC12-796964FAA8D1}"/>
+                <a16:creationId xmlns:a16="http://schemas.microsoft.com/office/drawing/2014/main" id="{F9B8FD58-75C7-4716-B6EF-883BF70EB1F8}"/>
               </a:ext>
             </a:extLst>
           </p:cNvPr>
@@ -1750,7 +1750,7 @@
           <p:cNvPr id="2" name="Body">
             <a:extLst xmlns:a="http://schemas.openxmlformats.org/drawingml/2006/main">
               <a:ext uri="{FF2B5EF4-FFF2-40B4-BE49-F238E27FC236}">
-                <a16:creationId xmlns:a16="http://schemas.microsoft.com/office/drawing/2014/main" id="{15516AC3-B69F-4DAE-9DAA-2AD880F68BBC}"/>
+                <a16:creationId xmlns:a16="http://schemas.microsoft.com/office/drawing/2014/main" id="{66BC1DE8-0A72-4B5F-A122-8FAE7F303AF2}"/>
               </a:ext>
             </a:extLst>
           </p:cNvPr>
@@ -1924,7 +1924,7 @@
           <p:cNvPr id="4" name="Title">
             <a:extLst xmlns:a="http://schemas.openxmlformats.org/drawingml/2006/main">
               <a:ext uri="{FF2B5EF4-FFF2-40B4-BE49-F238E27FC236}">
-                <a16:creationId xmlns:a16="http://schemas.microsoft.com/office/drawing/2014/main" id="{4C32F8F5-AB41-4AB1-9E2D-675966E93BF2}"/>
+                <a16:creationId xmlns:a16="http://schemas.microsoft.com/office/drawing/2014/main" id="{68919E19-7132-4916-81E9-56EB2CC820AB}"/>
               </a:ext>
             </a:extLst>
           </p:cNvPr>
@@ -2081,7 +2081,7 @@
           <p:cNvPr id="2" name="Left column">
             <a:extLst xmlns:a="http://schemas.openxmlformats.org/drawingml/2006/main">
               <a:ext uri="{FF2B5EF4-FFF2-40B4-BE49-F238E27FC236}">
-                <a16:creationId xmlns:a16="http://schemas.microsoft.com/office/drawing/2014/main" id="{D8E5012C-669E-4C33-AE61-884F8727A12D}"/>
+                <a16:creationId xmlns:a16="http://schemas.microsoft.com/office/drawing/2014/main" id="{937E1E8B-465B-4050-AF22-83D02CC8B26F}"/>
               </a:ext>
             </a:extLst>
           </p:cNvPr>
@@ -2238,7 +2238,7 @@
           <p:cNvPr id="3" name="Right column">
             <a:extLst xmlns:a="http://schemas.openxmlformats.org/drawingml/2006/main">
               <a:ext uri="{FF2B5EF4-FFF2-40B4-BE49-F238E27FC236}">
-                <a16:creationId xmlns:a16="http://schemas.microsoft.com/office/drawing/2014/main" id="{2FCA2C27-2A16-4758-AEDF-B545389DF332}"/>
+                <a16:creationId xmlns:a16="http://schemas.microsoft.com/office/drawing/2014/main" id="{42765CE8-2DAE-4696-8F43-1B5B4C25794C}"/>
               </a:ext>
             </a:extLst>
           </p:cNvPr>
@@ -2412,7 +2412,7 @@
           <p:cNvPr id="3" name="Title">
             <a:extLst xmlns:a="http://schemas.openxmlformats.org/drawingml/2006/main">
               <a:ext uri="{FF2B5EF4-FFF2-40B4-BE49-F238E27FC236}">
-                <a16:creationId xmlns:a16="http://schemas.microsoft.com/office/drawing/2014/main" id="{B83CD5ED-37B9-440B-B3FF-0FDB95ED93BA}"/>
+                <a16:creationId xmlns:a16="http://schemas.microsoft.com/office/drawing/2014/main" id="{D2F4F3FA-D846-412C-BDC4-6FF0966820BC}"/>
               </a:ext>
             </a:extLst>
           </p:cNvPr>
@@ -2569,7 +2569,7 @@
           <p:cNvPr id="2" name="Left column">
             <a:extLst xmlns:a="http://schemas.openxmlformats.org/drawingml/2006/main">
               <a:ext uri="{FF2B5EF4-FFF2-40B4-BE49-F238E27FC236}">
-                <a16:creationId xmlns:a16="http://schemas.microsoft.com/office/drawing/2014/main" id="{7001CD12-22EC-49AA-ABA6-70AE4914FC14}"/>
+                <a16:creationId xmlns:a16="http://schemas.microsoft.com/office/drawing/2014/main" id="{04045F75-F41D-4CC6-813C-BF752B192A8E}"/>
               </a:ext>
             </a:extLst>
           </p:cNvPr>
@@ -2764,12 +2764,12 @@
   </p:cSld>
   <p:clrMap bg1="lt1" tx1="dk1" bg2="lt2" tx2="dk2" accent1="accent1" accent2="accent2" accent3="accent3" accent4="accent4" accent5="accent5" accent6="accent6" hlink="hlink" folHlink="folHlink"/>
   <p:sldLayoutIdLst>
-    <p:sldLayoutId xmlns:r="http://schemas.openxmlformats.org/officeDocument/2006/relationships" id="2147483649" r:id="Rc7e9adf8be1a4c1f"/>
-    <p:sldLayoutId xmlns:r="http://schemas.openxmlformats.org/officeDocument/2006/relationships" id="2147483650" r:id="Rf2982ac9aec2450e"/>
-    <p:sldLayoutId xmlns:r="http://schemas.openxmlformats.org/officeDocument/2006/relationships" id="2147483651" r:id="Rf8e34fba80af491e"/>
-    <p:sldLayoutId xmlns:r="http://schemas.openxmlformats.org/officeDocument/2006/relationships" id="2147483652" r:id="R26201e9782594e06"/>
-    <p:sldLayoutId xmlns:r="http://schemas.openxmlformats.org/officeDocument/2006/relationships" id="2147483653" r:id="Reaae6e4da1d24f6e"/>
-    <p:sldLayoutId xmlns:r="http://schemas.openxmlformats.org/officeDocument/2006/relationships" id="2147483654" r:id="R00f851c5b7e84c03"/>
+    <p:sldLayoutId xmlns:r="http://schemas.openxmlformats.org/officeDocument/2006/relationships" id="2147483649" r:id="Rd84cf4c612f14982"/>
+    <p:sldLayoutId xmlns:r="http://schemas.openxmlformats.org/officeDocument/2006/relationships" id="2147483650" r:id="Rb93b4aaf8dec41c2"/>
+    <p:sldLayoutId xmlns:r="http://schemas.openxmlformats.org/officeDocument/2006/relationships" id="2147483651" r:id="R4f0205588a014d37"/>
+    <p:sldLayoutId xmlns:r="http://schemas.openxmlformats.org/officeDocument/2006/relationships" id="2147483652" r:id="R06cc1f38ec6945ae"/>
+    <p:sldLayoutId xmlns:r="http://schemas.openxmlformats.org/officeDocument/2006/relationships" id="2147483653" r:id="R356d89b409834f07"/>
+    <p:sldLayoutId xmlns:r="http://schemas.openxmlformats.org/officeDocument/2006/relationships" id="2147483654" r:id="R7e354dea86b340ea"/>
   </p:sldLayoutIdLst>
   <p:txStyles>
     <p:titleStyle>
@@ -3320,7 +3320,7 @@
           <p:cNvPr id="8" name="">
             <a:extLst xmlns:a="http://schemas.openxmlformats.org/drawingml/2006/main">
               <a:ext uri="{FF2B5EF4-FFF2-40B4-BE49-F238E27FC236}">
-                <a16:creationId xmlns:a16="http://schemas.microsoft.com/office/drawing/2014/main" id="{4828A0FE-A209-4451-91B9-6D76FAA4B179}"/>
+                <a16:creationId xmlns:a16="http://schemas.microsoft.com/office/drawing/2014/main" id="{199E1D81-E505-419A-A365-11E5C097BB0D}"/>
               </a:ext>
             </a:extLst>
           </p:cNvPr>
@@ -3378,7 +3378,7 @@
           <p:cNvPr id="2" name="">
             <a:extLst xmlns:a="http://schemas.openxmlformats.org/drawingml/2006/main">
               <a:ext uri="{FF2B5EF4-FFF2-40B4-BE49-F238E27FC236}">
-                <a16:creationId xmlns:a16="http://schemas.microsoft.com/office/drawing/2014/main" id="{125F1C1B-2BAA-4769-AAF5-AA1696336931}"/>
+                <a16:creationId xmlns:a16="http://schemas.microsoft.com/office/drawing/2014/main" id="{EAEB58D4-D280-4EA7-89CF-2DDF26C77DF1}"/>
               </a:ext>
             </a:extLst>
           </p:cNvPr>
@@ -3436,7 +3436,7 @@
           <p:cNvPr id="3" name="">
             <a:extLst xmlns:a="http://schemas.openxmlformats.org/drawingml/2006/main">
               <a:ext uri="{FF2B5EF4-FFF2-40B4-BE49-F238E27FC236}">
-                <a16:creationId xmlns:a16="http://schemas.microsoft.com/office/drawing/2014/main" id="{CE34522E-DE1C-474C-BB01-8269345CE43C}"/>
+                <a16:creationId xmlns:a16="http://schemas.microsoft.com/office/drawing/2014/main" id="{1F8F932C-ADAD-4B01-A629-0AA53FA3B917}"/>
               </a:ext>
             </a:extLst>
           </p:cNvPr>
@@ -3494,7 +3494,7 @@
           <p:cNvPr id="4" name="">
             <a:extLst xmlns:a="http://schemas.openxmlformats.org/drawingml/2006/main">
               <a:ext uri="{FF2B5EF4-FFF2-40B4-BE49-F238E27FC236}">
-                <a16:creationId xmlns:a16="http://schemas.microsoft.com/office/drawing/2014/main" id="{1D9AFED4-D59D-4C59-B935-9966EBA32660}"/>
+                <a16:creationId xmlns:a16="http://schemas.microsoft.com/office/drawing/2014/main" id="{75A724F7-1332-4B17-ACE6-0E7E0317654B}"/>
               </a:ext>
             </a:extLst>
           </p:cNvPr>
@@ -3529,7 +3529,7 @@
           <p:cNvPr id="5" name="">
             <a:extLst xmlns:a="http://schemas.openxmlformats.org/drawingml/2006/main">
               <a:ext uri="{FF2B5EF4-FFF2-40B4-BE49-F238E27FC236}">
-                <a16:creationId xmlns:a16="http://schemas.microsoft.com/office/drawing/2014/main" id="{D67866E6-CC43-4CC5-A7CB-2A5ECEBC8659}"/>
+                <a16:creationId xmlns:a16="http://schemas.microsoft.com/office/drawing/2014/main" id="{06E22811-96BE-41BF-8286-9AF9BF857997}"/>
               </a:ext>
             </a:extLst>
           </p:cNvPr>
@@ -3587,7 +3587,7 @@
           <p:cNvPr id="6" name="">
             <a:extLst xmlns:a="http://schemas.openxmlformats.org/drawingml/2006/main">
               <a:ext uri="{FF2B5EF4-FFF2-40B4-BE49-F238E27FC236}">
-                <a16:creationId xmlns:a16="http://schemas.microsoft.com/office/drawing/2014/main" id="{6A844D15-74A1-4BD3-9369-5B15A8C81F22}"/>
+                <a16:creationId xmlns:a16="http://schemas.microsoft.com/office/drawing/2014/main" id="{246E1B2E-9E80-4048-8102-66ECD8D3EA55}"/>
               </a:ext>
             </a:extLst>
           </p:cNvPr>
@@ -3740,7 +3740,7 @@
           <p:cNvPr id="7" name="">
             <a:extLst xmlns:a="http://schemas.openxmlformats.org/drawingml/2006/main">
               <a:ext uri="{FF2B5EF4-FFF2-40B4-BE49-F238E27FC236}">
-                <a16:creationId xmlns:a16="http://schemas.microsoft.com/office/drawing/2014/main" id="{FEFD6691-5E4A-4551-BF64-9731062DC181}"/>
+                <a16:creationId xmlns:a16="http://schemas.microsoft.com/office/drawing/2014/main" id="{0710E5AA-C02B-4BFD-8FD4-82B69E5420BF}"/>
               </a:ext>
             </a:extLst>
           </p:cNvPr>
@@ -3813,7 +3813,7 @@
     </p:spTree>
     <p:extLst>
       <p:ext uri="{BB962C8B-B14F-4D97-AF65-F5344CB8AC3E}">
-        <p14:creationId xmlns:p14="http://schemas.microsoft.com/office/powerpoint/2010/main" val="234085056"/>
+        <p14:creationId xmlns:p14="http://schemas.microsoft.com/office/powerpoint/2010/main" val="58640641"/>
       </p:ext>
     </p:extLst>
   </p:cSld>
@@ -3844,7 +3844,7 @@
           <p:cNvPr id="17" name="">
             <a:extLst xmlns:a="http://schemas.openxmlformats.org/drawingml/2006/main">
               <a:ext uri="{FF2B5EF4-FFF2-40B4-BE49-F238E27FC236}">
-                <a16:creationId xmlns:a16="http://schemas.microsoft.com/office/drawing/2014/main" id="{28989F8A-673D-4E35-AF21-C8EE4290CD03}"/>
+                <a16:creationId xmlns:a16="http://schemas.microsoft.com/office/drawing/2014/main" id="{32346DE9-DE6C-4DF4-8709-EF7EE3B43133}"/>
               </a:ext>
             </a:extLst>
           </p:cNvPr>
@@ -3902,7 +3902,7 @@
           <p:cNvPr id="2" name="">
             <a:extLst xmlns:a="http://schemas.openxmlformats.org/drawingml/2006/main">
               <a:ext uri="{FF2B5EF4-FFF2-40B4-BE49-F238E27FC236}">
-                <a16:creationId xmlns:a16="http://schemas.microsoft.com/office/drawing/2014/main" id="{342B7A07-EDB2-43E4-AF49-8AEB5B4B0253}"/>
+                <a16:creationId xmlns:a16="http://schemas.microsoft.com/office/drawing/2014/main" id="{70E658EB-8FD3-4DB0-8AD8-FA01666B4B06}"/>
               </a:ext>
             </a:extLst>
           </p:cNvPr>
@@ -3960,7 +3960,7 @@
           <p:cNvPr id="3" name="">
             <a:extLst xmlns:a="http://schemas.openxmlformats.org/drawingml/2006/main">
               <a:ext uri="{FF2B5EF4-FFF2-40B4-BE49-F238E27FC236}">
-                <a16:creationId xmlns:a16="http://schemas.microsoft.com/office/drawing/2014/main" id="{B99B661E-5551-4679-818B-E677F8F6ED9B}"/>
+                <a16:creationId xmlns:a16="http://schemas.microsoft.com/office/drawing/2014/main" id="{E807F60B-FDE8-4011-9724-3E9173A3C285}"/>
               </a:ext>
             </a:extLst>
           </p:cNvPr>
@@ -3993,7 +3993,7 @@
           <p:cNvPr id="4" name="">
             <a:extLst xmlns:a="http://schemas.openxmlformats.org/drawingml/2006/main">
               <a:ext uri="{FF2B5EF4-FFF2-40B4-BE49-F238E27FC236}">
-                <a16:creationId xmlns:a16="http://schemas.microsoft.com/office/drawing/2014/main" id="{01BCCAFF-11CC-4E1A-9B90-218E256EF7C8}"/>
+                <a16:creationId xmlns:a16="http://schemas.microsoft.com/office/drawing/2014/main" id="{4B522D5C-942F-40A8-8ED0-05E020DF5DE0}"/>
               </a:ext>
             </a:extLst>
           </p:cNvPr>
@@ -4051,7 +4051,7 @@
           <p:cNvPr id="5" name="">
             <a:extLst xmlns:a="http://schemas.openxmlformats.org/drawingml/2006/main">
               <a:ext uri="{FF2B5EF4-FFF2-40B4-BE49-F238E27FC236}">
-                <a16:creationId xmlns:a16="http://schemas.microsoft.com/office/drawing/2014/main" id="{423FB7D1-DEE4-4F39-AA25-5C69DE6F4274}"/>
+                <a16:creationId xmlns:a16="http://schemas.microsoft.com/office/drawing/2014/main" id="{23391DC9-293E-48F0-A2BC-665A0A13B0BF}"/>
               </a:ext>
             </a:extLst>
           </p:cNvPr>
@@ -4109,7 +4109,7 @@
           <p:cNvPr id="6" name="">
             <a:extLst xmlns:a="http://schemas.openxmlformats.org/drawingml/2006/main">
               <a:ext uri="{FF2B5EF4-FFF2-40B4-BE49-F238E27FC236}">
-                <a16:creationId xmlns:a16="http://schemas.microsoft.com/office/drawing/2014/main" id="{07C72917-457E-4820-B3A0-F5B2515449EB}"/>
+                <a16:creationId xmlns:a16="http://schemas.microsoft.com/office/drawing/2014/main" id="{9251C792-E574-47CE-8B17-CDF9A6C1C84B}"/>
               </a:ext>
             </a:extLst>
           </p:cNvPr>
@@ -4167,7 +4167,7 @@
           <p:cNvPr id="7" name="">
             <a:extLst xmlns:a="http://schemas.openxmlformats.org/drawingml/2006/main">
               <a:ext uri="{FF2B5EF4-FFF2-40B4-BE49-F238E27FC236}">
-                <a16:creationId xmlns:a16="http://schemas.microsoft.com/office/drawing/2014/main" id="{7A4CC6CF-DCA2-4027-89B3-61A1E077E779}"/>
+                <a16:creationId xmlns:a16="http://schemas.microsoft.com/office/drawing/2014/main" id="{A68FF28B-84DB-4636-8FE7-39F26E14C7AA}"/>
               </a:ext>
             </a:extLst>
           </p:cNvPr>
@@ -4225,7 +4225,7 @@
           <p:cNvPr id="8" name="">
             <a:extLst xmlns:a="http://schemas.openxmlformats.org/drawingml/2006/main">
               <a:ext uri="{FF2B5EF4-FFF2-40B4-BE49-F238E27FC236}">
-                <a16:creationId xmlns:a16="http://schemas.microsoft.com/office/drawing/2014/main" id="{A8280A19-9E51-4392-812B-03EC71BEC970}"/>
+                <a16:creationId xmlns:a16="http://schemas.microsoft.com/office/drawing/2014/main" id="{6427546A-52CC-4B9F-9D09-67F6F7DC4328}"/>
               </a:ext>
             </a:extLst>
           </p:cNvPr>
@@ -4260,7 +4260,7 @@
           <p:cNvPr id="9" name="">
             <a:extLst xmlns:a="http://schemas.openxmlformats.org/drawingml/2006/main">
               <a:ext uri="{FF2B5EF4-FFF2-40B4-BE49-F238E27FC236}">
-                <a16:creationId xmlns:a16="http://schemas.microsoft.com/office/drawing/2014/main" id="{6794031E-607B-47EF-9978-E78A0F3D6E14}"/>
+                <a16:creationId xmlns:a16="http://schemas.microsoft.com/office/drawing/2014/main" id="{C9094FAA-2662-4297-A53A-7BA456F3A638}"/>
               </a:ext>
             </a:extLst>
           </p:cNvPr>
@@ -4293,7 +4293,7 @@
           <p:cNvPr id="10" name="">
             <a:extLst xmlns:a="http://schemas.openxmlformats.org/drawingml/2006/main">
               <a:ext uri="{FF2B5EF4-FFF2-40B4-BE49-F238E27FC236}">
-                <a16:creationId xmlns:a16="http://schemas.microsoft.com/office/drawing/2014/main" id="{8B0D0754-1E78-4E56-85CA-C77B0CA93950}"/>
+                <a16:creationId xmlns:a16="http://schemas.microsoft.com/office/drawing/2014/main" id="{83E76C7E-02F7-4ABB-A9A2-54EF954EDFEC}"/>
               </a:ext>
             </a:extLst>
           </p:cNvPr>
@@ -4351,7 +4351,7 @@
           <p:cNvPr id="11" name="">
             <a:extLst xmlns:a="http://schemas.openxmlformats.org/drawingml/2006/main">
               <a:ext uri="{FF2B5EF4-FFF2-40B4-BE49-F238E27FC236}">
-                <a16:creationId xmlns:a16="http://schemas.microsoft.com/office/drawing/2014/main" id="{99DAEF72-7792-4B18-8334-2A9FBDD54DC4}"/>
+                <a16:creationId xmlns:a16="http://schemas.microsoft.com/office/drawing/2014/main" id="{0A4C2006-10EC-4111-8371-32BE767AA6CA}"/>
               </a:ext>
             </a:extLst>
           </p:cNvPr>
@@ -4460,7 +4460,7 @@
           <p:cNvPr id="12" name="">
             <a:extLst xmlns:a="http://schemas.openxmlformats.org/drawingml/2006/main">
               <a:ext uri="{FF2B5EF4-FFF2-40B4-BE49-F238E27FC236}">
-                <a16:creationId xmlns:a16="http://schemas.microsoft.com/office/drawing/2014/main" id="{972D25D5-B977-410B-ABB0-C4B4E47F8EED}"/>
+                <a16:creationId xmlns:a16="http://schemas.microsoft.com/office/drawing/2014/main" id="{F306F82C-0428-44D1-895C-369E82E4FCEC}"/>
               </a:ext>
             </a:extLst>
           </p:cNvPr>
@@ -4495,7 +4495,7 @@
           <p:cNvPr id="13" name="">
             <a:extLst xmlns:a="http://schemas.openxmlformats.org/drawingml/2006/main">
               <a:ext uri="{FF2B5EF4-FFF2-40B4-BE49-F238E27FC236}">
-                <a16:creationId xmlns:a16="http://schemas.microsoft.com/office/drawing/2014/main" id="{20C312D9-40F8-4C44-8B69-147DC3E5E4D6}"/>
+                <a16:creationId xmlns:a16="http://schemas.microsoft.com/office/drawing/2014/main" id="{4CC4B2B2-E436-4EB4-8C5E-259C8F24427E}"/>
               </a:ext>
             </a:extLst>
           </p:cNvPr>
@@ -4528,7 +4528,7 @@
           <p:cNvPr id="14" name="">
             <a:extLst xmlns:a="http://schemas.openxmlformats.org/drawingml/2006/main">
               <a:ext uri="{FF2B5EF4-FFF2-40B4-BE49-F238E27FC236}">
-                <a16:creationId xmlns:a16="http://schemas.microsoft.com/office/drawing/2014/main" id="{833C3A95-EB0F-4BF8-BA98-E2C46E5FE642}"/>
+                <a16:creationId xmlns:a16="http://schemas.microsoft.com/office/drawing/2014/main" id="{FC311616-BB01-440E-8DC0-765FE244FE65}"/>
               </a:ext>
             </a:extLst>
           </p:cNvPr>
@@ -4586,7 +4586,7 @@
           <p:cNvPr id="15" name="">
             <a:extLst xmlns:a="http://schemas.openxmlformats.org/drawingml/2006/main">
               <a:ext uri="{FF2B5EF4-FFF2-40B4-BE49-F238E27FC236}">
-                <a16:creationId xmlns:a16="http://schemas.microsoft.com/office/drawing/2014/main" id="{675206A2-E514-4E46-9A44-1C1B23436C6C}"/>
+                <a16:creationId xmlns:a16="http://schemas.microsoft.com/office/drawing/2014/main" id="{7AEFAD8B-9FE5-4C4A-8090-55620EFEB24E}"/>
               </a:ext>
             </a:extLst>
           </p:cNvPr>
@@ -4712,7 +4712,7 @@
           <p:cNvPr id="16" name="">
             <a:extLst xmlns:a="http://schemas.openxmlformats.org/drawingml/2006/main">
               <a:ext uri="{FF2B5EF4-FFF2-40B4-BE49-F238E27FC236}">
-                <a16:creationId xmlns:a16="http://schemas.microsoft.com/office/drawing/2014/main" id="{3057C647-C2D9-40D5-B65C-49C92ADB7AB5}"/>
+                <a16:creationId xmlns:a16="http://schemas.microsoft.com/office/drawing/2014/main" id="{8C08FCB2-C018-497F-96AF-11B1C361B13C}"/>
               </a:ext>
             </a:extLst>
           </p:cNvPr>
@@ -4768,7 +4768,7 @@
     </p:spTree>
     <p:extLst>
       <p:ext uri="{BB962C8B-B14F-4D97-AF65-F5344CB8AC3E}">
-        <p14:creationId xmlns:p14="http://schemas.microsoft.com/office/powerpoint/2010/main" val="580839039"/>
+        <p14:creationId xmlns:p14="http://schemas.microsoft.com/office/powerpoint/2010/main" val="1097273559"/>
       </p:ext>
     </p:extLst>
   </p:cSld>
@@ -4799,7 +4799,7 @@
           <p:cNvPr id="22" name="">
             <a:extLst xmlns:a="http://schemas.openxmlformats.org/drawingml/2006/main">
               <a:ext uri="{FF2B5EF4-FFF2-40B4-BE49-F238E27FC236}">
-                <a16:creationId xmlns:a16="http://schemas.microsoft.com/office/drawing/2014/main" id="{9E2D003F-92F2-49BF-AC79-418130D5956C}"/>
+                <a16:creationId xmlns:a16="http://schemas.microsoft.com/office/drawing/2014/main" id="{62FE14EB-5660-43DD-9243-627C9826AD76}"/>
               </a:ext>
             </a:extLst>
           </p:cNvPr>
@@ -4857,7 +4857,7 @@
           <p:cNvPr id="2" name="">
             <a:extLst xmlns:a="http://schemas.openxmlformats.org/drawingml/2006/main">
               <a:ext uri="{FF2B5EF4-FFF2-40B4-BE49-F238E27FC236}">
-                <a16:creationId xmlns:a16="http://schemas.microsoft.com/office/drawing/2014/main" id="{9713BC3A-1A66-41F6-9FFB-D725B35855C7}"/>
+                <a16:creationId xmlns:a16="http://schemas.microsoft.com/office/drawing/2014/main" id="{5B5C636B-AB02-4C13-AAB9-3C1B138399ED}"/>
               </a:ext>
             </a:extLst>
           </p:cNvPr>
@@ -4915,7 +4915,7 @@
           <p:cNvPr id="3" name="">
             <a:extLst xmlns:a="http://schemas.openxmlformats.org/drawingml/2006/main">
               <a:ext uri="{FF2B5EF4-FFF2-40B4-BE49-F238E27FC236}">
-                <a16:creationId xmlns:a16="http://schemas.microsoft.com/office/drawing/2014/main" id="{00A84730-BFAA-4B4A-842C-C38670D11F99}"/>
+                <a16:creationId xmlns:a16="http://schemas.microsoft.com/office/drawing/2014/main" id="{0729872A-F59F-4841-80A9-02BD42F73637}"/>
               </a:ext>
             </a:extLst>
           </p:cNvPr>
@@ -4948,7 +4948,7 @@
           <p:cNvPr id="4" name="">
             <a:extLst xmlns:a="http://schemas.openxmlformats.org/drawingml/2006/main">
               <a:ext uri="{FF2B5EF4-FFF2-40B4-BE49-F238E27FC236}">
-                <a16:creationId xmlns:a16="http://schemas.microsoft.com/office/drawing/2014/main" id="{567014CC-2734-4936-8C68-2E7DAA50CB8A}"/>
+                <a16:creationId xmlns:a16="http://schemas.microsoft.com/office/drawing/2014/main" id="{E2F9043A-6CF7-499B-86A9-6CED8474BB0F}"/>
               </a:ext>
             </a:extLst>
           </p:cNvPr>
@@ -5006,7 +5006,7 @@
           <p:cNvPr id="5" name="">
             <a:extLst xmlns:a="http://schemas.openxmlformats.org/drawingml/2006/main">
               <a:ext uri="{FF2B5EF4-FFF2-40B4-BE49-F238E27FC236}">
-                <a16:creationId xmlns:a16="http://schemas.microsoft.com/office/drawing/2014/main" id="{C355407C-DBB9-4AD6-8593-10B6A6E7B534}"/>
+                <a16:creationId xmlns:a16="http://schemas.microsoft.com/office/drawing/2014/main" id="{48F35454-4F20-4A24-A12C-9CF7A58A3D70}"/>
               </a:ext>
             </a:extLst>
           </p:cNvPr>
@@ -5064,7 +5064,7 @@
           <p:cNvPr id="6" name="">
             <a:extLst xmlns:a="http://schemas.openxmlformats.org/drawingml/2006/main">
               <a:ext uri="{FF2B5EF4-FFF2-40B4-BE49-F238E27FC236}">
-                <a16:creationId xmlns:a16="http://schemas.microsoft.com/office/drawing/2014/main" id="{2A8981D8-BFEC-4631-9B73-02A5B7B449ED}"/>
+                <a16:creationId xmlns:a16="http://schemas.microsoft.com/office/drawing/2014/main" id="{A4A4294F-B930-4EAC-9EF1-6D94E5286035}"/>
               </a:ext>
             </a:extLst>
           </p:cNvPr>
@@ -5099,7 +5099,7 @@
           <p:cNvPr id="7" name="">
             <a:extLst xmlns:a="http://schemas.openxmlformats.org/drawingml/2006/main">
               <a:ext uri="{FF2B5EF4-FFF2-40B4-BE49-F238E27FC236}">
-                <a16:creationId xmlns:a16="http://schemas.microsoft.com/office/drawing/2014/main" id="{3699823A-33F9-4B92-BF22-3CFA2190B36A}"/>
+                <a16:creationId xmlns:a16="http://schemas.microsoft.com/office/drawing/2014/main" id="{3DC0F169-4F72-44FC-B1B3-6BF7BC2DB538}"/>
               </a:ext>
             </a:extLst>
           </p:cNvPr>
@@ -5132,7 +5132,7 @@
           <p:cNvPr id="8" name="">
             <a:extLst xmlns:a="http://schemas.openxmlformats.org/drawingml/2006/main">
               <a:ext uri="{FF2B5EF4-FFF2-40B4-BE49-F238E27FC236}">
-                <a16:creationId xmlns:a16="http://schemas.microsoft.com/office/drawing/2014/main" id="{CD0F273C-D186-4547-9918-75580D38EC10}"/>
+                <a16:creationId xmlns:a16="http://schemas.microsoft.com/office/drawing/2014/main" id="{45CCB36A-B9CB-4956-B768-30D0289B5A9F}"/>
               </a:ext>
             </a:extLst>
           </p:cNvPr>
@@ -5190,7 +5190,7 @@
           <p:cNvPr id="9" name="">
             <a:extLst xmlns:a="http://schemas.openxmlformats.org/drawingml/2006/main">
               <a:ext uri="{FF2B5EF4-FFF2-40B4-BE49-F238E27FC236}">
-                <a16:creationId xmlns:a16="http://schemas.microsoft.com/office/drawing/2014/main" id="{19032391-CAC1-4A78-AB36-04AE593036BB}"/>
+                <a16:creationId xmlns:a16="http://schemas.microsoft.com/office/drawing/2014/main" id="{A872C8CC-7BFA-4AE9-A83C-7D0734FF9146}"/>
               </a:ext>
             </a:extLst>
           </p:cNvPr>
@@ -5248,7 +5248,7 @@
           <p:cNvPr id="10" name="">
             <a:extLst xmlns:a="http://schemas.openxmlformats.org/drawingml/2006/main">
               <a:ext uri="{FF2B5EF4-FFF2-40B4-BE49-F238E27FC236}">
-                <a16:creationId xmlns:a16="http://schemas.microsoft.com/office/drawing/2014/main" id="{F663F1EF-F857-4AEA-A9C1-84CDEF404F60}"/>
+                <a16:creationId xmlns:a16="http://schemas.microsoft.com/office/drawing/2014/main" id="{458A155C-8D1D-4557-B92D-CABB4E9DD2E2}"/>
               </a:ext>
             </a:extLst>
           </p:cNvPr>
@@ -5283,7 +5283,7 @@
           <p:cNvPr id="11" name="">
             <a:extLst xmlns:a="http://schemas.openxmlformats.org/drawingml/2006/main">
               <a:ext uri="{FF2B5EF4-FFF2-40B4-BE49-F238E27FC236}">
-                <a16:creationId xmlns:a16="http://schemas.microsoft.com/office/drawing/2014/main" id="{E4D69EBD-E041-4FAA-BDD8-E5976D4E7A12}"/>
+                <a16:creationId xmlns:a16="http://schemas.microsoft.com/office/drawing/2014/main" id="{28736FBE-3F92-4221-9015-D73A6CEA533B}"/>
               </a:ext>
             </a:extLst>
           </p:cNvPr>
@@ -5316,7 +5316,7 @@
           <p:cNvPr id="12" name="">
             <a:extLst xmlns:a="http://schemas.openxmlformats.org/drawingml/2006/main">
               <a:ext uri="{FF2B5EF4-FFF2-40B4-BE49-F238E27FC236}">
-                <a16:creationId xmlns:a16="http://schemas.microsoft.com/office/drawing/2014/main" id="{AE2AFC75-EAB5-46B0-AAA6-4724DCBF2E7D}"/>
+                <a16:creationId xmlns:a16="http://schemas.microsoft.com/office/drawing/2014/main" id="{77968602-46C5-4D12-B5F4-7061A6302AFC}"/>
               </a:ext>
             </a:extLst>
           </p:cNvPr>
@@ -5374,7 +5374,7 @@
           <p:cNvPr id="13" name="">
             <a:extLst xmlns:a="http://schemas.openxmlformats.org/drawingml/2006/main">
               <a:ext uri="{FF2B5EF4-FFF2-40B4-BE49-F238E27FC236}">
-                <a16:creationId xmlns:a16="http://schemas.microsoft.com/office/drawing/2014/main" id="{DAB71C21-31EE-4456-BD92-EB086C32EA08}"/>
+                <a16:creationId xmlns:a16="http://schemas.microsoft.com/office/drawing/2014/main" id="{12A1B2CA-9A6D-4EFA-B52A-7AE566A52AB7}"/>
               </a:ext>
             </a:extLst>
           </p:cNvPr>
@@ -5432,7 +5432,7 @@
           <p:cNvPr id="14" name="">
             <a:extLst xmlns:a="http://schemas.openxmlformats.org/drawingml/2006/main">
               <a:ext uri="{FF2B5EF4-FFF2-40B4-BE49-F238E27FC236}">
-                <a16:creationId xmlns:a16="http://schemas.microsoft.com/office/drawing/2014/main" id="{374E3EC9-B3D3-4483-8566-E690C15D91BB}"/>
+                <a16:creationId xmlns:a16="http://schemas.microsoft.com/office/drawing/2014/main" id="{BAE4F6CC-F83D-44D4-A5D4-4E1CE29A3AED}"/>
               </a:ext>
             </a:extLst>
           </p:cNvPr>
@@ -5467,7 +5467,7 @@
           <p:cNvPr id="15" name="">
             <a:extLst xmlns:a="http://schemas.openxmlformats.org/drawingml/2006/main">
               <a:ext uri="{FF2B5EF4-FFF2-40B4-BE49-F238E27FC236}">
-                <a16:creationId xmlns:a16="http://schemas.microsoft.com/office/drawing/2014/main" id="{826D07BD-2008-46C2-AE2A-4D1E7A755AF1}"/>
+                <a16:creationId xmlns:a16="http://schemas.microsoft.com/office/drawing/2014/main" id="{36FF5009-869B-4334-96CA-622C235F5E3E}"/>
               </a:ext>
             </a:extLst>
           </p:cNvPr>
@@ -5500,7 +5500,7 @@
           <p:cNvPr id="16" name="">
             <a:extLst xmlns:a="http://schemas.openxmlformats.org/drawingml/2006/main">
               <a:ext uri="{FF2B5EF4-FFF2-40B4-BE49-F238E27FC236}">
-                <a16:creationId xmlns:a16="http://schemas.microsoft.com/office/drawing/2014/main" id="{9932C5FB-1909-4299-8C02-4EECBACF6C62}"/>
+                <a16:creationId xmlns:a16="http://schemas.microsoft.com/office/drawing/2014/main" id="{68D62673-6AA7-4215-864F-7C608141D057}"/>
               </a:ext>
             </a:extLst>
           </p:cNvPr>
@@ -5558,7 +5558,7 @@
           <p:cNvPr id="17" name="">
             <a:extLst xmlns:a="http://schemas.openxmlformats.org/drawingml/2006/main">
               <a:ext uri="{FF2B5EF4-FFF2-40B4-BE49-F238E27FC236}">
-                <a16:creationId xmlns:a16="http://schemas.microsoft.com/office/drawing/2014/main" id="{98C5EF12-0D6C-4DAF-A4EC-0F9F86D0B951}"/>
+                <a16:creationId xmlns:a16="http://schemas.microsoft.com/office/drawing/2014/main" id="{43D6F1B7-81B7-4019-8759-B3DE471D76ED}"/>
               </a:ext>
             </a:extLst>
           </p:cNvPr>
@@ -5616,7 +5616,7 @@
           <p:cNvPr id="18" name="">
             <a:extLst xmlns:a="http://schemas.openxmlformats.org/drawingml/2006/main">
               <a:ext uri="{FF2B5EF4-FFF2-40B4-BE49-F238E27FC236}">
-                <a16:creationId xmlns:a16="http://schemas.microsoft.com/office/drawing/2014/main" id="{34B9BD21-BEC7-402C-A454-0CCD825E4961}"/>
+                <a16:creationId xmlns:a16="http://schemas.microsoft.com/office/drawing/2014/main" id="{35E4D7E6-F474-434F-9F74-B584BEFC30BC}"/>
               </a:ext>
             </a:extLst>
           </p:cNvPr>
@@ -5674,7 +5674,7 @@
           <p:cNvPr id="19" name="">
             <a:extLst xmlns:a="http://schemas.openxmlformats.org/drawingml/2006/main">
               <a:ext uri="{FF2B5EF4-FFF2-40B4-BE49-F238E27FC236}">
-                <a16:creationId xmlns:a16="http://schemas.microsoft.com/office/drawing/2014/main" id="{0ABC1957-6D97-4CB8-A76E-28A2EC2BC82F}"/>
+                <a16:creationId xmlns:a16="http://schemas.microsoft.com/office/drawing/2014/main" id="{264DCDB4-8261-4B0B-A8FB-1EE855B6E381}"/>
               </a:ext>
             </a:extLst>
           </p:cNvPr>
@@ -5709,7 +5709,7 @@
           <p:cNvPr id="20" name="">
             <a:extLst xmlns:a="http://schemas.openxmlformats.org/drawingml/2006/main">
               <a:ext uri="{FF2B5EF4-FFF2-40B4-BE49-F238E27FC236}">
-                <a16:creationId xmlns:a16="http://schemas.microsoft.com/office/drawing/2014/main" id="{F9F9AD53-3AAD-417B-93EF-5729B6D365D0}"/>
+                <a16:creationId xmlns:a16="http://schemas.microsoft.com/office/drawing/2014/main" id="{AA1178C0-635A-43A6-8775-2320D6807CF5}"/>
               </a:ext>
             </a:extLst>
           </p:cNvPr>
@@ -5767,7 +5767,7 @@
           <p:cNvPr id="21" name="">
             <a:extLst xmlns:a="http://schemas.openxmlformats.org/drawingml/2006/main">
               <a:ext uri="{FF2B5EF4-FFF2-40B4-BE49-F238E27FC236}">
-                <a16:creationId xmlns:a16="http://schemas.microsoft.com/office/drawing/2014/main" id="{E7F2D38F-5B33-4322-8364-E66743A70284}"/>
+                <a16:creationId xmlns:a16="http://schemas.microsoft.com/office/drawing/2014/main" id="{9F5A2BAD-A0B4-4A7B-B1CA-96468065224D}"/>
               </a:ext>
             </a:extLst>
           </p:cNvPr>
@@ -5823,7 +5823,7 @@
     </p:spTree>
     <p:extLst>
       <p:ext uri="{BB962C8B-B14F-4D97-AF65-F5344CB8AC3E}">
-        <p14:creationId xmlns:p14="http://schemas.microsoft.com/office/powerpoint/2010/main" val="1060750720"/>
+        <p14:creationId xmlns:p14="http://schemas.microsoft.com/office/powerpoint/2010/main" val="1983680666"/>
       </p:ext>
     </p:extLst>
   </p:cSld>
@@ -5854,7 +5854,7 @@
           <p:cNvPr id="36" name="">
             <a:extLst xmlns:a="http://schemas.openxmlformats.org/drawingml/2006/main">
               <a:ext uri="{FF2B5EF4-FFF2-40B4-BE49-F238E27FC236}">
-                <a16:creationId xmlns:a16="http://schemas.microsoft.com/office/drawing/2014/main" id="{F3EB1B66-2B98-4BFD-B244-F34E56CF8A0C}"/>
+                <a16:creationId xmlns:a16="http://schemas.microsoft.com/office/drawing/2014/main" id="{094A1660-7BA5-4E6B-BAED-4D47ED1DDE36}"/>
               </a:ext>
             </a:extLst>
           </p:cNvPr>
@@ -5912,7 +5912,7 @@
           <p:cNvPr id="2" name="">
             <a:extLst xmlns:a="http://schemas.openxmlformats.org/drawingml/2006/main">
               <a:ext uri="{FF2B5EF4-FFF2-40B4-BE49-F238E27FC236}">
-                <a16:creationId xmlns:a16="http://schemas.microsoft.com/office/drawing/2014/main" id="{0CB2C13B-6A9F-4E40-A71A-A38371870773}"/>
+                <a16:creationId xmlns:a16="http://schemas.microsoft.com/office/drawing/2014/main" id="{DBB1F74C-3087-4452-9177-10BDBF2C2E5E}"/>
               </a:ext>
             </a:extLst>
           </p:cNvPr>
@@ -5970,7 +5970,7 @@
           <p:cNvPr id="3" name="">
             <a:extLst xmlns:a="http://schemas.openxmlformats.org/drawingml/2006/main">
               <a:ext uri="{FF2B5EF4-FFF2-40B4-BE49-F238E27FC236}">
-                <a16:creationId xmlns:a16="http://schemas.microsoft.com/office/drawing/2014/main" id="{9ED09B74-7FD2-41B9-AD71-945CC2C3006C}"/>
+                <a16:creationId xmlns:a16="http://schemas.microsoft.com/office/drawing/2014/main" id="{2B38DF56-81FA-4DF7-9577-4EAD09FE7D9E}"/>
               </a:ext>
             </a:extLst>
           </p:cNvPr>
@@ -6003,7 +6003,7 @@
           <p:cNvPr id="4" name="">
             <a:extLst xmlns:a="http://schemas.openxmlformats.org/drawingml/2006/main">
               <a:ext uri="{FF2B5EF4-FFF2-40B4-BE49-F238E27FC236}">
-                <a16:creationId xmlns:a16="http://schemas.microsoft.com/office/drawing/2014/main" id="{B6C5CBA9-1553-4053-B4BF-E82B37135363}"/>
+                <a16:creationId xmlns:a16="http://schemas.microsoft.com/office/drawing/2014/main" id="{6CF4CA63-6D47-460D-9D41-339BDAEE3A93}"/>
               </a:ext>
             </a:extLst>
           </p:cNvPr>
@@ -6061,7 +6061,7 @@
           <p:cNvPr id="5" name="">
             <a:extLst xmlns:a="http://schemas.openxmlformats.org/drawingml/2006/main">
               <a:ext uri="{FF2B5EF4-FFF2-40B4-BE49-F238E27FC236}">
-                <a16:creationId xmlns:a16="http://schemas.microsoft.com/office/drawing/2014/main" id="{88870EF0-AC92-428D-BBA4-4DAC2F11D2C8}"/>
+                <a16:creationId xmlns:a16="http://schemas.microsoft.com/office/drawing/2014/main" id="{4DC54F4E-F2C1-43B5-A04D-EDF84AD36E39}"/>
               </a:ext>
             </a:extLst>
           </p:cNvPr>
@@ -6119,7 +6119,7 @@
           <p:cNvPr id="6" name="">
             <a:extLst xmlns:a="http://schemas.openxmlformats.org/drawingml/2006/main">
               <a:ext uri="{FF2B5EF4-FFF2-40B4-BE49-F238E27FC236}">
-                <a16:creationId xmlns:a16="http://schemas.microsoft.com/office/drawing/2014/main" id="{BCAE6F09-70C3-448E-8B7A-4953731166FD}"/>
+                <a16:creationId xmlns:a16="http://schemas.microsoft.com/office/drawing/2014/main" id="{3A1EFDEF-3662-40F8-988C-76EEE8FAEA62}"/>
               </a:ext>
             </a:extLst>
           </p:cNvPr>
@@ -6154,7 +6154,7 @@
           <p:cNvPr id="7" name="">
             <a:extLst xmlns:a="http://schemas.openxmlformats.org/drawingml/2006/main">
               <a:ext uri="{FF2B5EF4-FFF2-40B4-BE49-F238E27FC236}">
-                <a16:creationId xmlns:a16="http://schemas.microsoft.com/office/drawing/2014/main" id="{F5FCA550-8B99-4F9D-9B73-4DD4A0B6BD43}"/>
+                <a16:creationId xmlns:a16="http://schemas.microsoft.com/office/drawing/2014/main" id="{36AD78FF-2B12-40E6-A01B-6BE2578B8AF3}"/>
               </a:ext>
             </a:extLst>
           </p:cNvPr>
@@ -6212,7 +6212,7 @@
           <p:cNvPr id="8" name="">
             <a:extLst xmlns:a="http://schemas.openxmlformats.org/drawingml/2006/main">
               <a:ext uri="{FF2B5EF4-FFF2-40B4-BE49-F238E27FC236}">
-                <a16:creationId xmlns:a16="http://schemas.microsoft.com/office/drawing/2014/main" id="{FB97C33E-3C6A-407D-9CBD-A3AE9A757DD6}"/>
+                <a16:creationId xmlns:a16="http://schemas.microsoft.com/office/drawing/2014/main" id="{D850F610-630D-4536-BE97-FC963168AC3C}"/>
               </a:ext>
             </a:extLst>
           </p:cNvPr>
@@ -6243,7 +6243,7 @@
           <p:cNvPr id="9" name="">
             <a:extLst xmlns:a="http://schemas.openxmlformats.org/drawingml/2006/main">
               <a:ext uri="{FF2B5EF4-FFF2-40B4-BE49-F238E27FC236}">
-                <a16:creationId xmlns:a16="http://schemas.microsoft.com/office/drawing/2014/main" id="{288BF864-5645-4447-937A-DA3A01B41E4D}"/>
+                <a16:creationId xmlns:a16="http://schemas.microsoft.com/office/drawing/2014/main" id="{C9A7B50D-2281-4F3C-9BA6-F8BB58088060}"/>
               </a:ext>
             </a:extLst>
           </p:cNvPr>
@@ -6301,7 +6301,7 @@
           <p:cNvPr id="10" name="">
             <a:extLst xmlns:a="http://schemas.openxmlformats.org/drawingml/2006/main">
               <a:ext uri="{FF2B5EF4-FFF2-40B4-BE49-F238E27FC236}">
-                <a16:creationId xmlns:a16="http://schemas.microsoft.com/office/drawing/2014/main" id="{A3EA273E-9F32-4B5D-A596-B57E04289545}"/>
+                <a16:creationId xmlns:a16="http://schemas.microsoft.com/office/drawing/2014/main" id="{093F1E44-7747-4135-8C0F-F1CAE9C074D4}"/>
               </a:ext>
             </a:extLst>
           </p:cNvPr>
@@ -6359,7 +6359,7 @@
           <p:cNvPr id="11" name="">
             <a:extLst xmlns:a="http://schemas.openxmlformats.org/drawingml/2006/main">
               <a:ext uri="{FF2B5EF4-FFF2-40B4-BE49-F238E27FC236}">
-                <a16:creationId xmlns:a16="http://schemas.microsoft.com/office/drawing/2014/main" id="{ACF0AF1E-ED0C-42F5-8B1E-6A2D9E65B84F}"/>
+                <a16:creationId xmlns:a16="http://schemas.microsoft.com/office/drawing/2014/main" id="{368344CE-6727-49FC-AC2E-6F2FA7B84D43}"/>
               </a:ext>
             </a:extLst>
           </p:cNvPr>
@@ -6417,7 +6417,7 @@
           <p:cNvPr id="12" name="">
             <a:extLst xmlns:a="http://schemas.openxmlformats.org/drawingml/2006/main">
               <a:ext uri="{FF2B5EF4-FFF2-40B4-BE49-F238E27FC236}">
-                <a16:creationId xmlns:a16="http://schemas.microsoft.com/office/drawing/2014/main" id="{89B92AAB-EC21-4ADB-A84F-3C7A4F79B852}"/>
+                <a16:creationId xmlns:a16="http://schemas.microsoft.com/office/drawing/2014/main" id="{467EE909-43A1-4B4E-8529-F57B3339CFDC}"/>
               </a:ext>
             </a:extLst>
           </p:cNvPr>
@@ -6452,7 +6452,7 @@
           <p:cNvPr id="13" name="">
             <a:extLst xmlns:a="http://schemas.openxmlformats.org/drawingml/2006/main">
               <a:ext uri="{FF2B5EF4-FFF2-40B4-BE49-F238E27FC236}">
-                <a16:creationId xmlns:a16="http://schemas.microsoft.com/office/drawing/2014/main" id="{01FB8E7F-4F18-40B9-94BB-51953CD22F77}"/>
+                <a16:creationId xmlns:a16="http://schemas.microsoft.com/office/drawing/2014/main" id="{4F074EA4-3844-4E37-B7B0-FB4702441FB0}"/>
               </a:ext>
             </a:extLst>
           </p:cNvPr>
@@ -6510,7 +6510,7 @@
           <p:cNvPr id="14" name="">
             <a:extLst xmlns:a="http://schemas.openxmlformats.org/drawingml/2006/main">
               <a:ext uri="{FF2B5EF4-FFF2-40B4-BE49-F238E27FC236}">
-                <a16:creationId xmlns:a16="http://schemas.microsoft.com/office/drawing/2014/main" id="{59653A80-E8B2-4571-9AAF-0610996B9C3B}"/>
+                <a16:creationId xmlns:a16="http://schemas.microsoft.com/office/drawing/2014/main" id="{EE99528F-0C3D-4A7D-B294-2254F7C9A719}"/>
               </a:ext>
             </a:extLst>
           </p:cNvPr>
@@ -6541,7 +6541,7 @@
           <p:cNvPr id="15" name="">
             <a:extLst xmlns:a="http://schemas.openxmlformats.org/drawingml/2006/main">
               <a:ext uri="{FF2B5EF4-FFF2-40B4-BE49-F238E27FC236}">
-                <a16:creationId xmlns:a16="http://schemas.microsoft.com/office/drawing/2014/main" id="{A7172E06-56AE-489E-AD44-F7AD1B92ACCE}"/>
+                <a16:creationId xmlns:a16="http://schemas.microsoft.com/office/drawing/2014/main" id="{D7AFCA8F-8F50-428B-A4E5-C34DB1CD19DB}"/>
               </a:ext>
             </a:extLst>
           </p:cNvPr>
@@ -6589,7 +6589,7 @@
                   <a:srgbClr val="16202A"/>
                 </a:solidFill>
               </a:rPr>
-              <a:t>POP3</a:t>
+              <a:t>Roundcube HTTPS</a:t>
             </a:r>
           </a:p>
         </p:txBody>
@@ -6599,7 +6599,7 @@
           <p:cNvPr id="16" name="">
             <a:extLst xmlns:a="http://schemas.openxmlformats.org/drawingml/2006/main">
               <a:ext uri="{FF2B5EF4-FFF2-40B4-BE49-F238E27FC236}">
-                <a16:creationId xmlns:a16="http://schemas.microsoft.com/office/drawing/2014/main" id="{F1E8BE6F-AF84-429D-992E-16E4E0EC6B7D}"/>
+                <a16:creationId xmlns:a16="http://schemas.microsoft.com/office/drawing/2014/main" id="{5810CA8D-A758-4540-8BF8-386514459F9E}"/>
               </a:ext>
             </a:extLst>
           </p:cNvPr>
@@ -6647,7 +6647,7 @@
                   <a:srgbClr val="52606D"/>
                 </a:solidFill>
               </a:rPr>
-              <a:t>Solo mensajes nuevos</a:t>
+              <a:t>Lectura cifrada</a:t>
             </a:r>
           </a:p>
         </p:txBody>
@@ -6657,7 +6657,7 @@
           <p:cNvPr id="17" name="">
             <a:extLst xmlns:a="http://schemas.openxmlformats.org/drawingml/2006/main">
               <a:ext uri="{FF2B5EF4-FFF2-40B4-BE49-F238E27FC236}">
-                <a16:creationId xmlns:a16="http://schemas.microsoft.com/office/drawing/2014/main" id="{AC9EE931-2356-4590-A214-559C07CD2F7A}"/>
+                <a16:creationId xmlns:a16="http://schemas.microsoft.com/office/drawing/2014/main" id="{931558AD-2DD3-487E-8810-CF4B9B55A277}"/>
               </a:ext>
             </a:extLst>
           </p:cNvPr>
@@ -6715,7 +6715,7 @@
           <p:cNvPr id="18" name="">
             <a:extLst xmlns:a="http://schemas.openxmlformats.org/drawingml/2006/main">
               <a:ext uri="{FF2B5EF4-FFF2-40B4-BE49-F238E27FC236}">
-                <a16:creationId xmlns:a16="http://schemas.microsoft.com/office/drawing/2014/main" id="{3CF553A9-A6C7-4806-BBB0-BCED4978F039}"/>
+                <a16:creationId xmlns:a16="http://schemas.microsoft.com/office/drawing/2014/main" id="{9A715C3D-ABA8-4CC2-8AC3-59FB74142CEB}"/>
               </a:ext>
             </a:extLst>
           </p:cNvPr>
@@ -6750,7 +6750,7 @@
           <p:cNvPr id="19" name="">
             <a:extLst xmlns:a="http://schemas.openxmlformats.org/drawingml/2006/main">
               <a:ext uri="{FF2B5EF4-FFF2-40B4-BE49-F238E27FC236}">
-                <a16:creationId xmlns:a16="http://schemas.microsoft.com/office/drawing/2014/main" id="{79950233-C7A2-41A2-8E1E-BC5A85FD3346}"/>
+                <a16:creationId xmlns:a16="http://schemas.microsoft.com/office/drawing/2014/main" id="{FCF4A08F-A4AA-4492-94FA-E78E3A7534FA}"/>
               </a:ext>
             </a:extLst>
           </p:cNvPr>
@@ -6808,7 +6808,7 @@
           <p:cNvPr id="20" name="">
             <a:extLst xmlns:a="http://schemas.openxmlformats.org/drawingml/2006/main">
               <a:ext uri="{FF2B5EF4-FFF2-40B4-BE49-F238E27FC236}">
-                <a16:creationId xmlns:a16="http://schemas.microsoft.com/office/drawing/2014/main" id="{817D3DC3-4514-4ED0-B530-CF8650FE4A1D}"/>
+                <a16:creationId xmlns:a16="http://schemas.microsoft.com/office/drawing/2014/main" id="{DE48C606-C0FA-48CA-8EC1-92F87050B730}"/>
               </a:ext>
             </a:extLst>
           </p:cNvPr>
@@ -6839,7 +6839,7 @@
           <p:cNvPr id="21" name="">
             <a:extLst xmlns:a="http://schemas.openxmlformats.org/drawingml/2006/main">
               <a:ext uri="{FF2B5EF4-FFF2-40B4-BE49-F238E27FC236}">
-                <a16:creationId xmlns:a16="http://schemas.microsoft.com/office/drawing/2014/main" id="{ED831D55-7B7B-4FC0-BAB7-8D92472E1DB8}"/>
+                <a16:creationId xmlns:a16="http://schemas.microsoft.com/office/drawing/2014/main" id="{41F323FC-3828-4744-BF26-B86C0483C7E5}"/>
               </a:ext>
             </a:extLst>
           </p:cNvPr>
@@ -6897,7 +6897,7 @@
           <p:cNvPr id="22" name="">
             <a:extLst xmlns:a="http://schemas.openxmlformats.org/drawingml/2006/main">
               <a:ext uri="{FF2B5EF4-FFF2-40B4-BE49-F238E27FC236}">
-                <a16:creationId xmlns:a16="http://schemas.microsoft.com/office/drawing/2014/main" id="{FC30DBB9-49F2-4495-9B44-6DE8F2FC1F3E}"/>
+                <a16:creationId xmlns:a16="http://schemas.microsoft.com/office/drawing/2014/main" id="{D2236BAB-F1FD-49AB-8458-1C04BD89E0E9}"/>
               </a:ext>
             </a:extLst>
           </p:cNvPr>
@@ -6955,7 +6955,7 @@
           <p:cNvPr id="23" name="">
             <a:extLst xmlns:a="http://schemas.openxmlformats.org/drawingml/2006/main">
               <a:ext uri="{FF2B5EF4-FFF2-40B4-BE49-F238E27FC236}">
-                <a16:creationId xmlns:a16="http://schemas.microsoft.com/office/drawing/2014/main" id="{0AB84646-3466-46D4-9CB1-8B5C22935DD0}"/>
+                <a16:creationId xmlns:a16="http://schemas.microsoft.com/office/drawing/2014/main" id="{D6FC3F15-5448-41AD-9F04-6F2D3F624CA7}"/>
               </a:ext>
             </a:extLst>
           </p:cNvPr>
@@ -7013,7 +7013,7 @@
           <p:cNvPr id="24" name="">
             <a:extLst xmlns:a="http://schemas.openxmlformats.org/drawingml/2006/main">
               <a:ext uri="{FF2B5EF4-FFF2-40B4-BE49-F238E27FC236}">
-                <a16:creationId xmlns:a16="http://schemas.microsoft.com/office/drawing/2014/main" id="{FC040C9A-2350-44FC-8419-231E86017C81}"/>
+                <a16:creationId xmlns:a16="http://schemas.microsoft.com/office/drawing/2014/main" id="{55FC3DCF-C899-4004-B6DB-8C16277664E5}"/>
               </a:ext>
             </a:extLst>
           </p:cNvPr>
@@ -7048,7 +7048,7 @@
           <p:cNvPr id="25" name="">
             <a:extLst xmlns:a="http://schemas.openxmlformats.org/drawingml/2006/main">
               <a:ext uri="{FF2B5EF4-FFF2-40B4-BE49-F238E27FC236}">
-                <a16:creationId xmlns:a16="http://schemas.microsoft.com/office/drawing/2014/main" id="{E35563A5-95DB-48FB-B278-A7504CBA7E59}"/>
+                <a16:creationId xmlns:a16="http://schemas.microsoft.com/office/drawing/2014/main" id="{54B50362-7806-4DD7-AD73-DF7ED3575ACD}"/>
               </a:ext>
             </a:extLst>
           </p:cNvPr>
@@ -7106,7 +7106,7 @@
           <p:cNvPr id="26" name="">
             <a:extLst xmlns:a="http://schemas.openxmlformats.org/drawingml/2006/main">
               <a:ext uri="{FF2B5EF4-FFF2-40B4-BE49-F238E27FC236}">
-                <a16:creationId xmlns:a16="http://schemas.microsoft.com/office/drawing/2014/main" id="{321BAD9A-F7AD-446B-84FC-38C028A28BC5}"/>
+                <a16:creationId xmlns:a16="http://schemas.microsoft.com/office/drawing/2014/main" id="{3F02DD53-538A-466E-87A9-679D249C6BC8}"/>
               </a:ext>
             </a:extLst>
           </p:cNvPr>
@@ -7137,7 +7137,7 @@
           <p:cNvPr id="27" name="">
             <a:extLst xmlns:a="http://schemas.openxmlformats.org/drawingml/2006/main">
               <a:ext uri="{FF2B5EF4-FFF2-40B4-BE49-F238E27FC236}">
-                <a16:creationId xmlns:a16="http://schemas.microsoft.com/office/drawing/2014/main" id="{C6CEC038-6BC4-43FC-BF3D-FB518CB4716F}"/>
+                <a16:creationId xmlns:a16="http://schemas.microsoft.com/office/drawing/2014/main" id="{358E95F6-961E-4658-AA14-D290A18749A1}"/>
               </a:ext>
             </a:extLst>
           </p:cNvPr>
@@ -7195,7 +7195,7 @@
           <p:cNvPr id="28" name="">
             <a:extLst xmlns:a="http://schemas.openxmlformats.org/drawingml/2006/main">
               <a:ext uri="{FF2B5EF4-FFF2-40B4-BE49-F238E27FC236}">
-                <a16:creationId xmlns:a16="http://schemas.microsoft.com/office/drawing/2014/main" id="{92BFAF3F-C847-46B5-98AC-40A3AF6ACCE6}"/>
+                <a16:creationId xmlns:a16="http://schemas.microsoft.com/office/drawing/2014/main" id="{733E8E6B-7B58-42AA-A61C-8E5F1D7B9946}"/>
               </a:ext>
             </a:extLst>
           </p:cNvPr>
@@ -7253,7 +7253,7 @@
           <p:cNvPr id="29" name="">
             <a:extLst xmlns:a="http://schemas.openxmlformats.org/drawingml/2006/main">
               <a:ext uri="{FF2B5EF4-FFF2-40B4-BE49-F238E27FC236}">
-                <a16:creationId xmlns:a16="http://schemas.microsoft.com/office/drawing/2014/main" id="{ABAE2C46-E503-4848-B3F6-A3E373C5E04B}"/>
+                <a16:creationId xmlns:a16="http://schemas.microsoft.com/office/drawing/2014/main" id="{9D209F91-E767-4286-86AF-FE97F5B9E5ED}"/>
               </a:ext>
             </a:extLst>
           </p:cNvPr>
@@ -7311,7 +7311,7 @@
           <p:cNvPr id="30" name="">
             <a:extLst xmlns:a="http://schemas.openxmlformats.org/drawingml/2006/main">
               <a:ext uri="{FF2B5EF4-FFF2-40B4-BE49-F238E27FC236}">
-                <a16:creationId xmlns:a16="http://schemas.microsoft.com/office/drawing/2014/main" id="{2282FBC2-1D55-47E5-836F-FEEEA04E2058}"/>
+                <a16:creationId xmlns:a16="http://schemas.microsoft.com/office/drawing/2014/main" id="{0FB1E7B7-0C4C-4520-9102-57C2C3573CCC}"/>
               </a:ext>
             </a:extLst>
           </p:cNvPr>
@@ -7346,7 +7346,7 @@
           <p:cNvPr id="31" name="">
             <a:extLst xmlns:a="http://schemas.openxmlformats.org/drawingml/2006/main">
               <a:ext uri="{FF2B5EF4-FFF2-40B4-BE49-F238E27FC236}">
-                <a16:creationId xmlns:a16="http://schemas.microsoft.com/office/drawing/2014/main" id="{80F2BE2A-E45E-49FF-87BB-0F91C6819693}"/>
+                <a16:creationId xmlns:a16="http://schemas.microsoft.com/office/drawing/2014/main" id="{699D80F0-2F91-456C-9190-2E2EB69BD7ED}"/>
               </a:ext>
             </a:extLst>
           </p:cNvPr>
@@ -7404,7 +7404,7 @@
           <p:cNvPr id="32" name="">
             <a:extLst xmlns:a="http://schemas.openxmlformats.org/drawingml/2006/main">
               <a:ext uri="{FF2B5EF4-FFF2-40B4-BE49-F238E27FC236}">
-                <a16:creationId xmlns:a16="http://schemas.microsoft.com/office/drawing/2014/main" id="{04B5EBF1-CB24-4D90-9829-24E25E2CA344}"/>
+                <a16:creationId xmlns:a16="http://schemas.microsoft.com/office/drawing/2014/main" id="{0E655B3E-F0CB-4322-B679-C0F0A98201D0}"/>
               </a:ext>
             </a:extLst>
           </p:cNvPr>
@@ -7435,7 +7435,7 @@
           <p:cNvPr id="33" name="">
             <a:extLst xmlns:a="http://schemas.openxmlformats.org/drawingml/2006/main">
               <a:ext uri="{FF2B5EF4-FFF2-40B4-BE49-F238E27FC236}">
-                <a16:creationId xmlns:a16="http://schemas.microsoft.com/office/drawing/2014/main" id="{FCCC0DE6-9000-477F-9C0B-A659E3915DAD}"/>
+                <a16:creationId xmlns:a16="http://schemas.microsoft.com/office/drawing/2014/main" id="{F2AE35E8-66A5-4F6D-AEF8-F0EDDE38B4D3}"/>
               </a:ext>
             </a:extLst>
           </p:cNvPr>
@@ -7493,7 +7493,7 @@
           <p:cNvPr id="34" name="">
             <a:extLst xmlns:a="http://schemas.openxmlformats.org/drawingml/2006/main">
               <a:ext uri="{FF2B5EF4-FFF2-40B4-BE49-F238E27FC236}">
-                <a16:creationId xmlns:a16="http://schemas.microsoft.com/office/drawing/2014/main" id="{F920C3F6-6A26-43E9-BE2E-8ECD47EBF825}"/>
+                <a16:creationId xmlns:a16="http://schemas.microsoft.com/office/drawing/2014/main" id="{7BF47D1F-8BD4-45FF-8D6C-EA7B5C850F9A}"/>
               </a:ext>
             </a:extLst>
           </p:cNvPr>
@@ -7551,7 +7551,7 @@
           <p:cNvPr id="35" name="">
             <a:extLst xmlns:a="http://schemas.openxmlformats.org/drawingml/2006/main">
               <a:ext uri="{FF2B5EF4-FFF2-40B4-BE49-F238E27FC236}">
-                <a16:creationId xmlns:a16="http://schemas.microsoft.com/office/drawing/2014/main" id="{D874E36D-DAAB-4B8D-B013-A67AD9882901}"/>
+                <a16:creationId xmlns:a16="http://schemas.microsoft.com/office/drawing/2014/main" id="{4AC190A3-8025-4083-A67A-1A3A0460C94D}"/>
               </a:ext>
             </a:extLst>
           </p:cNvPr>
@@ -7607,7 +7607,7 @@
     </p:spTree>
     <p:extLst>
       <p:ext uri="{BB962C8B-B14F-4D97-AF65-F5344CB8AC3E}">
-        <p14:creationId xmlns:p14="http://schemas.microsoft.com/office/powerpoint/2010/main" val="1826262715"/>
+        <p14:creationId xmlns:p14="http://schemas.microsoft.com/office/powerpoint/2010/main" val="274194634"/>
       </p:ext>
     </p:extLst>
   </p:cSld>
@@ -7638,7 +7638,7 @@
           <p:cNvPr id="38" name="">
             <a:extLst xmlns:a="http://schemas.openxmlformats.org/drawingml/2006/main">
               <a:ext uri="{FF2B5EF4-FFF2-40B4-BE49-F238E27FC236}">
-                <a16:creationId xmlns:a16="http://schemas.microsoft.com/office/drawing/2014/main" id="{EF541904-FBA1-41CF-97AA-EC4981361D50}"/>
+                <a16:creationId xmlns:a16="http://schemas.microsoft.com/office/drawing/2014/main" id="{FA4B26DB-6294-4552-961A-ED52F354935E}"/>
               </a:ext>
             </a:extLst>
           </p:cNvPr>
@@ -7696,7 +7696,7 @@
           <p:cNvPr id="2" name="">
             <a:extLst xmlns:a="http://schemas.openxmlformats.org/drawingml/2006/main">
               <a:ext uri="{FF2B5EF4-FFF2-40B4-BE49-F238E27FC236}">
-                <a16:creationId xmlns:a16="http://schemas.microsoft.com/office/drawing/2014/main" id="{7928FEA8-B289-40E3-A798-8751A0C3718B}"/>
+                <a16:creationId xmlns:a16="http://schemas.microsoft.com/office/drawing/2014/main" id="{74C4E902-B975-4DE5-BDDC-494B09770ADF}"/>
               </a:ext>
             </a:extLst>
           </p:cNvPr>
@@ -7754,7 +7754,7 @@
           <p:cNvPr id="3" name="">
             <a:extLst xmlns:a="http://schemas.openxmlformats.org/drawingml/2006/main">
               <a:ext uri="{FF2B5EF4-FFF2-40B4-BE49-F238E27FC236}">
-                <a16:creationId xmlns:a16="http://schemas.microsoft.com/office/drawing/2014/main" id="{3C8086D6-110C-4682-99E2-66E704A220CC}"/>
+                <a16:creationId xmlns:a16="http://schemas.microsoft.com/office/drawing/2014/main" id="{76A0EF88-12FB-4799-82A0-4BA278C88DD5}"/>
               </a:ext>
             </a:extLst>
           </p:cNvPr>
@@ -7787,7 +7787,7 @@
           <p:cNvPr id="4" name="">
             <a:extLst xmlns:a="http://schemas.openxmlformats.org/drawingml/2006/main">
               <a:ext uri="{FF2B5EF4-FFF2-40B4-BE49-F238E27FC236}">
-                <a16:creationId xmlns:a16="http://schemas.microsoft.com/office/drawing/2014/main" id="{153206B8-6603-414B-9236-44C7DACE5294}"/>
+                <a16:creationId xmlns:a16="http://schemas.microsoft.com/office/drawing/2014/main" id="{E8E05BB1-4A44-4994-9452-FDBFEA73BB84}"/>
               </a:ext>
             </a:extLst>
           </p:cNvPr>
@@ -7845,7 +7845,7 @@
           <p:cNvPr id="5" name="">
             <a:extLst xmlns:a="http://schemas.openxmlformats.org/drawingml/2006/main">
               <a:ext uri="{FF2B5EF4-FFF2-40B4-BE49-F238E27FC236}">
-                <a16:creationId xmlns:a16="http://schemas.microsoft.com/office/drawing/2014/main" id="{B4E438EA-1E84-4AA1-AEAF-0640A597C877}"/>
+                <a16:creationId xmlns:a16="http://schemas.microsoft.com/office/drawing/2014/main" id="{D980EE28-4FAE-4B39-9BEB-3E4F21F53BE6}"/>
               </a:ext>
             </a:extLst>
           </p:cNvPr>
@@ -7903,7 +7903,7 @@
           <p:cNvPr id="6" name="">
             <a:extLst xmlns:a="http://schemas.openxmlformats.org/drawingml/2006/main">
               <a:ext uri="{FF2B5EF4-FFF2-40B4-BE49-F238E27FC236}">
-                <a16:creationId xmlns:a16="http://schemas.microsoft.com/office/drawing/2014/main" id="{3D9E3E3D-4883-414B-9CAF-E2466A1FEB25}"/>
+                <a16:creationId xmlns:a16="http://schemas.microsoft.com/office/drawing/2014/main" id="{790D96F2-C904-4FAF-900C-2D990C9A3CEB}"/>
               </a:ext>
             </a:extLst>
           </p:cNvPr>
@@ -7938,7 +7938,7 @@
           <p:cNvPr id="7" name="">
             <a:extLst xmlns:a="http://schemas.openxmlformats.org/drawingml/2006/main">
               <a:ext uri="{FF2B5EF4-FFF2-40B4-BE49-F238E27FC236}">
-                <a16:creationId xmlns:a16="http://schemas.microsoft.com/office/drawing/2014/main" id="{DA9AF76A-9DB6-46E2-8A1D-CDD5E007155B}"/>
+                <a16:creationId xmlns:a16="http://schemas.microsoft.com/office/drawing/2014/main" id="{CFA16039-82F6-4A14-A275-273B5E189F73}"/>
               </a:ext>
             </a:extLst>
           </p:cNvPr>
@@ -7996,7 +7996,7 @@
           <p:cNvPr id="8" name="">
             <a:extLst xmlns:a="http://schemas.openxmlformats.org/drawingml/2006/main">
               <a:ext uri="{FF2B5EF4-FFF2-40B4-BE49-F238E27FC236}">
-                <a16:creationId xmlns:a16="http://schemas.microsoft.com/office/drawing/2014/main" id="{8353CD9C-140C-4D70-8781-C41FB346E982}"/>
+                <a16:creationId xmlns:a16="http://schemas.microsoft.com/office/drawing/2014/main" id="{E315B0C3-63CA-40C7-9098-68787DB8F498}"/>
               </a:ext>
             </a:extLst>
           </p:cNvPr>
@@ -8054,7 +8054,7 @@
           <p:cNvPr id="9" name="">
             <a:extLst xmlns:a="http://schemas.openxmlformats.org/drawingml/2006/main">
               <a:ext uri="{FF2B5EF4-FFF2-40B4-BE49-F238E27FC236}">
-                <a16:creationId xmlns:a16="http://schemas.microsoft.com/office/drawing/2014/main" id="{BD90653B-2F24-4E87-ACC7-A3B6B14BEC3B}"/>
+                <a16:creationId xmlns:a16="http://schemas.microsoft.com/office/drawing/2014/main" id="{969A03B9-3310-4DC0-87E8-ABF33DA474F8}"/>
               </a:ext>
             </a:extLst>
           </p:cNvPr>
@@ -8112,7 +8112,7 @@
           <p:cNvPr id="10" name="">
             <a:extLst xmlns:a="http://schemas.openxmlformats.org/drawingml/2006/main">
               <a:ext uri="{FF2B5EF4-FFF2-40B4-BE49-F238E27FC236}">
-                <a16:creationId xmlns:a16="http://schemas.microsoft.com/office/drawing/2014/main" id="{8B19B79C-742D-4E64-9622-60318561243D}"/>
+                <a16:creationId xmlns:a16="http://schemas.microsoft.com/office/drawing/2014/main" id="{98FEA81A-4021-484C-BE50-A4B3F7CD2747}"/>
               </a:ext>
             </a:extLst>
           </p:cNvPr>
@@ -8147,7 +8147,7 @@
           <p:cNvPr id="11" name="">
             <a:extLst xmlns:a="http://schemas.openxmlformats.org/drawingml/2006/main">
               <a:ext uri="{FF2B5EF4-FFF2-40B4-BE49-F238E27FC236}">
-                <a16:creationId xmlns:a16="http://schemas.microsoft.com/office/drawing/2014/main" id="{8DF74DC9-05DE-42CD-A3FA-1526DE5EBDB1}"/>
+                <a16:creationId xmlns:a16="http://schemas.microsoft.com/office/drawing/2014/main" id="{7C0A93D4-8EE4-4FE4-ADD9-04CDAB64B4C9}"/>
               </a:ext>
             </a:extLst>
           </p:cNvPr>
@@ -8205,7 +8205,7 @@
           <p:cNvPr id="12" name="">
             <a:extLst xmlns:a="http://schemas.openxmlformats.org/drawingml/2006/main">
               <a:ext uri="{FF2B5EF4-FFF2-40B4-BE49-F238E27FC236}">
-                <a16:creationId xmlns:a16="http://schemas.microsoft.com/office/drawing/2014/main" id="{DB16EA55-12EA-43AF-B7EA-8FB381A39AA6}"/>
+                <a16:creationId xmlns:a16="http://schemas.microsoft.com/office/drawing/2014/main" id="{2D867AF7-DE24-4B83-9478-B259AE8EEFBB}"/>
               </a:ext>
             </a:extLst>
           </p:cNvPr>
@@ -8263,7 +8263,7 @@
           <p:cNvPr id="13" name="">
             <a:extLst xmlns:a="http://schemas.openxmlformats.org/drawingml/2006/main">
               <a:ext uri="{FF2B5EF4-FFF2-40B4-BE49-F238E27FC236}">
-                <a16:creationId xmlns:a16="http://schemas.microsoft.com/office/drawing/2014/main" id="{83EFAFCB-374B-4F63-B833-0EBB9C436166}"/>
+                <a16:creationId xmlns:a16="http://schemas.microsoft.com/office/drawing/2014/main" id="{09AC06AE-B339-420E-B247-147882E91159}"/>
               </a:ext>
             </a:extLst>
           </p:cNvPr>
@@ -8321,7 +8321,7 @@
           <p:cNvPr id="14" name="">
             <a:extLst xmlns:a="http://schemas.openxmlformats.org/drawingml/2006/main">
               <a:ext uri="{FF2B5EF4-FFF2-40B4-BE49-F238E27FC236}">
-                <a16:creationId xmlns:a16="http://schemas.microsoft.com/office/drawing/2014/main" id="{7AA8C41D-F30A-48E3-A9DD-588899C50B4B}"/>
+                <a16:creationId xmlns:a16="http://schemas.microsoft.com/office/drawing/2014/main" id="{09C4A0CD-1F0B-406D-A63D-0E317829E5EC}"/>
               </a:ext>
             </a:extLst>
           </p:cNvPr>
@@ -8356,7 +8356,7 @@
           <p:cNvPr id="15" name="">
             <a:extLst xmlns:a="http://schemas.openxmlformats.org/drawingml/2006/main">
               <a:ext uri="{FF2B5EF4-FFF2-40B4-BE49-F238E27FC236}">
-                <a16:creationId xmlns:a16="http://schemas.microsoft.com/office/drawing/2014/main" id="{1ADE9B8C-A9EA-4186-9BE7-3ED0182437E7}"/>
+                <a16:creationId xmlns:a16="http://schemas.microsoft.com/office/drawing/2014/main" id="{C340D783-D350-4658-BA45-35E5DB1DA951}"/>
               </a:ext>
             </a:extLst>
           </p:cNvPr>
@@ -8414,7 +8414,7 @@
           <p:cNvPr id="16" name="">
             <a:extLst xmlns:a="http://schemas.openxmlformats.org/drawingml/2006/main">
               <a:ext uri="{FF2B5EF4-FFF2-40B4-BE49-F238E27FC236}">
-                <a16:creationId xmlns:a16="http://schemas.microsoft.com/office/drawing/2014/main" id="{F20CFDAC-D28D-422A-804D-476C9A7BDB97}"/>
+                <a16:creationId xmlns:a16="http://schemas.microsoft.com/office/drawing/2014/main" id="{DE217FDE-8E7E-4004-9295-FC3028B5BC7B}"/>
               </a:ext>
             </a:extLst>
           </p:cNvPr>
@@ -8472,7 +8472,7 @@
           <p:cNvPr id="17" name="">
             <a:extLst xmlns:a="http://schemas.openxmlformats.org/drawingml/2006/main">
               <a:ext uri="{FF2B5EF4-FFF2-40B4-BE49-F238E27FC236}">
-                <a16:creationId xmlns:a16="http://schemas.microsoft.com/office/drawing/2014/main" id="{5D910620-724D-4AE6-A025-46C5602A45A1}"/>
+                <a16:creationId xmlns:a16="http://schemas.microsoft.com/office/drawing/2014/main" id="{F9C4EE54-098A-4967-B50F-23FF71FBFA0E}"/>
               </a:ext>
             </a:extLst>
           </p:cNvPr>
@@ -8530,7 +8530,7 @@
           <p:cNvPr id="18" name="">
             <a:extLst xmlns:a="http://schemas.openxmlformats.org/drawingml/2006/main">
               <a:ext uri="{FF2B5EF4-FFF2-40B4-BE49-F238E27FC236}">
-                <a16:creationId xmlns:a16="http://schemas.microsoft.com/office/drawing/2014/main" id="{7DB0DD4F-0B24-4772-B648-CEAD7AD7E475}"/>
+                <a16:creationId xmlns:a16="http://schemas.microsoft.com/office/drawing/2014/main" id="{2B225409-4709-4F18-8173-0020FA38E1E8}"/>
               </a:ext>
             </a:extLst>
           </p:cNvPr>
@@ -8565,7 +8565,7 @@
           <p:cNvPr id="19" name="">
             <a:extLst xmlns:a="http://schemas.openxmlformats.org/drawingml/2006/main">
               <a:ext uri="{FF2B5EF4-FFF2-40B4-BE49-F238E27FC236}">
-                <a16:creationId xmlns:a16="http://schemas.microsoft.com/office/drawing/2014/main" id="{E2D4D796-38D8-4F08-B58B-69EC7D00AD75}"/>
+                <a16:creationId xmlns:a16="http://schemas.microsoft.com/office/drawing/2014/main" id="{CFD9192F-2BB8-482E-9EF5-3228A455847F}"/>
               </a:ext>
             </a:extLst>
           </p:cNvPr>
@@ -8623,7 +8623,7 @@
           <p:cNvPr id="20" name="">
             <a:extLst xmlns:a="http://schemas.openxmlformats.org/drawingml/2006/main">
               <a:ext uri="{FF2B5EF4-FFF2-40B4-BE49-F238E27FC236}">
-                <a16:creationId xmlns:a16="http://schemas.microsoft.com/office/drawing/2014/main" id="{1CD2E6C6-B6C6-4722-A6EC-84209DF3B942}"/>
+                <a16:creationId xmlns:a16="http://schemas.microsoft.com/office/drawing/2014/main" id="{F5FA5394-7DED-426F-B603-90E66EC8723E}"/>
               </a:ext>
             </a:extLst>
           </p:cNvPr>
@@ -8681,7 +8681,7 @@
           <p:cNvPr id="21" name="">
             <a:extLst xmlns:a="http://schemas.openxmlformats.org/drawingml/2006/main">
               <a:ext uri="{FF2B5EF4-FFF2-40B4-BE49-F238E27FC236}">
-                <a16:creationId xmlns:a16="http://schemas.microsoft.com/office/drawing/2014/main" id="{04F14DC6-8BB1-4F56-90D1-A875FE11BD4D}"/>
+                <a16:creationId xmlns:a16="http://schemas.microsoft.com/office/drawing/2014/main" id="{621983B1-1542-4008-8AB2-1624060AFE45}"/>
               </a:ext>
             </a:extLst>
           </p:cNvPr>
@@ -8739,7 +8739,7 @@
           <p:cNvPr id="22" name="">
             <a:extLst xmlns:a="http://schemas.openxmlformats.org/drawingml/2006/main">
               <a:ext uri="{FF2B5EF4-FFF2-40B4-BE49-F238E27FC236}">
-                <a16:creationId xmlns:a16="http://schemas.microsoft.com/office/drawing/2014/main" id="{2EA2E9D9-2C23-47E0-BB9C-92CAAA229C24}"/>
+                <a16:creationId xmlns:a16="http://schemas.microsoft.com/office/drawing/2014/main" id="{81A84F9C-B6D1-4F41-A4AA-317A3777E4B8}"/>
               </a:ext>
             </a:extLst>
           </p:cNvPr>
@@ -8774,7 +8774,7 @@
           <p:cNvPr id="23" name="">
             <a:extLst xmlns:a="http://schemas.openxmlformats.org/drawingml/2006/main">
               <a:ext uri="{FF2B5EF4-FFF2-40B4-BE49-F238E27FC236}">
-                <a16:creationId xmlns:a16="http://schemas.microsoft.com/office/drawing/2014/main" id="{6A4B3856-62DB-417F-82BD-0106EF656851}"/>
+                <a16:creationId xmlns:a16="http://schemas.microsoft.com/office/drawing/2014/main" id="{77F22D33-3E6E-496D-AE4A-480E348A750D}"/>
               </a:ext>
             </a:extLst>
           </p:cNvPr>
@@ -8832,7 +8832,7 @@
           <p:cNvPr id="24" name="">
             <a:extLst xmlns:a="http://schemas.openxmlformats.org/drawingml/2006/main">
               <a:ext uri="{FF2B5EF4-FFF2-40B4-BE49-F238E27FC236}">
-                <a16:creationId xmlns:a16="http://schemas.microsoft.com/office/drawing/2014/main" id="{6058A94E-F665-42F5-8D9C-30A8271C881E}"/>
+                <a16:creationId xmlns:a16="http://schemas.microsoft.com/office/drawing/2014/main" id="{5EFF6A1C-A4A2-497D-825C-BF735767122A}"/>
               </a:ext>
             </a:extLst>
           </p:cNvPr>
@@ -8890,7 +8890,7 @@
           <p:cNvPr id="25" name="">
             <a:extLst xmlns:a="http://schemas.openxmlformats.org/drawingml/2006/main">
               <a:ext uri="{FF2B5EF4-FFF2-40B4-BE49-F238E27FC236}">
-                <a16:creationId xmlns:a16="http://schemas.microsoft.com/office/drawing/2014/main" id="{E80BB833-8D32-4174-A0DC-69DE0E45CA00}"/>
+                <a16:creationId xmlns:a16="http://schemas.microsoft.com/office/drawing/2014/main" id="{27F68C1B-454E-453A-9B74-5DA409DB4A25}"/>
               </a:ext>
             </a:extLst>
           </p:cNvPr>
@@ -8948,7 +8948,7 @@
           <p:cNvPr id="26" name="">
             <a:extLst xmlns:a="http://schemas.openxmlformats.org/drawingml/2006/main">
               <a:ext uri="{FF2B5EF4-FFF2-40B4-BE49-F238E27FC236}">
-                <a16:creationId xmlns:a16="http://schemas.microsoft.com/office/drawing/2014/main" id="{B923F47E-1932-45F8-A376-F144D077977A}"/>
+                <a16:creationId xmlns:a16="http://schemas.microsoft.com/office/drawing/2014/main" id="{7AC64BB7-D1A1-4749-B527-41AA132B6A09}"/>
               </a:ext>
             </a:extLst>
           </p:cNvPr>
@@ -8983,7 +8983,7 @@
           <p:cNvPr id="27" name="">
             <a:extLst xmlns:a="http://schemas.openxmlformats.org/drawingml/2006/main">
               <a:ext uri="{FF2B5EF4-FFF2-40B4-BE49-F238E27FC236}">
-                <a16:creationId xmlns:a16="http://schemas.microsoft.com/office/drawing/2014/main" id="{6F688B49-88D4-4A40-87C5-855168559538}"/>
+                <a16:creationId xmlns:a16="http://schemas.microsoft.com/office/drawing/2014/main" id="{B1306AA8-DB3C-4962-948F-55130E136760}"/>
               </a:ext>
             </a:extLst>
           </p:cNvPr>
@@ -9041,7 +9041,7 @@
           <p:cNvPr id="28" name="">
             <a:extLst xmlns:a="http://schemas.openxmlformats.org/drawingml/2006/main">
               <a:ext uri="{FF2B5EF4-FFF2-40B4-BE49-F238E27FC236}">
-                <a16:creationId xmlns:a16="http://schemas.microsoft.com/office/drawing/2014/main" id="{97D6417D-9FAC-42A5-BF3A-943F0B9CD657}"/>
+                <a16:creationId xmlns:a16="http://schemas.microsoft.com/office/drawing/2014/main" id="{634DE117-A861-496C-9676-05B45450A683}"/>
               </a:ext>
             </a:extLst>
           </p:cNvPr>
@@ -9099,7 +9099,7 @@
           <p:cNvPr id="29" name="">
             <a:extLst xmlns:a="http://schemas.openxmlformats.org/drawingml/2006/main">
               <a:ext uri="{FF2B5EF4-FFF2-40B4-BE49-F238E27FC236}">
-                <a16:creationId xmlns:a16="http://schemas.microsoft.com/office/drawing/2014/main" id="{BB30EA44-9CF9-4ED9-9927-6C9525889F65}"/>
+                <a16:creationId xmlns:a16="http://schemas.microsoft.com/office/drawing/2014/main" id="{AA191009-0301-4C4C-B6B9-D596F6C1895A}"/>
               </a:ext>
             </a:extLst>
           </p:cNvPr>
@@ -9157,7 +9157,7 @@
           <p:cNvPr id="30" name="">
             <a:extLst xmlns:a="http://schemas.openxmlformats.org/drawingml/2006/main">
               <a:ext uri="{FF2B5EF4-FFF2-40B4-BE49-F238E27FC236}">
-                <a16:creationId xmlns:a16="http://schemas.microsoft.com/office/drawing/2014/main" id="{4F576A46-1AA1-4C06-A6A3-CF1EEF333C87}"/>
+                <a16:creationId xmlns:a16="http://schemas.microsoft.com/office/drawing/2014/main" id="{89C4DE95-7219-41A2-B58E-7955FB1CB535}"/>
               </a:ext>
             </a:extLst>
           </p:cNvPr>
@@ -9192,7 +9192,7 @@
           <p:cNvPr id="31" name="">
             <a:extLst xmlns:a="http://schemas.openxmlformats.org/drawingml/2006/main">
               <a:ext uri="{FF2B5EF4-FFF2-40B4-BE49-F238E27FC236}">
-                <a16:creationId xmlns:a16="http://schemas.microsoft.com/office/drawing/2014/main" id="{CD966FE8-A3E3-4A98-953B-0B4E0889E991}"/>
+                <a16:creationId xmlns:a16="http://schemas.microsoft.com/office/drawing/2014/main" id="{0039F57D-AE35-48A5-9E84-DA1BB4930A8C}"/>
               </a:ext>
             </a:extLst>
           </p:cNvPr>
@@ -9250,7 +9250,7 @@
           <p:cNvPr id="32" name="">
             <a:extLst xmlns:a="http://schemas.openxmlformats.org/drawingml/2006/main">
               <a:ext uri="{FF2B5EF4-FFF2-40B4-BE49-F238E27FC236}">
-                <a16:creationId xmlns:a16="http://schemas.microsoft.com/office/drawing/2014/main" id="{707F69B1-FD64-42A9-A410-6A111D6C62C9}"/>
+                <a16:creationId xmlns:a16="http://schemas.microsoft.com/office/drawing/2014/main" id="{84288DC9-3496-45DB-AF3B-F472AB39CEEF}"/>
               </a:ext>
             </a:extLst>
           </p:cNvPr>
@@ -9308,7 +9308,7 @@
           <p:cNvPr id="33" name="">
             <a:extLst xmlns:a="http://schemas.openxmlformats.org/drawingml/2006/main">
               <a:ext uri="{FF2B5EF4-FFF2-40B4-BE49-F238E27FC236}">
-                <a16:creationId xmlns:a16="http://schemas.microsoft.com/office/drawing/2014/main" id="{F48E8897-E490-49FE-9EAD-E6D4897D21AD}"/>
+                <a16:creationId xmlns:a16="http://schemas.microsoft.com/office/drawing/2014/main" id="{86DB760F-2285-425D-8DE6-3BEAF39487FD}"/>
               </a:ext>
             </a:extLst>
           </p:cNvPr>
@@ -9366,7 +9366,7 @@
           <p:cNvPr id="34" name="">
             <a:extLst xmlns:a="http://schemas.openxmlformats.org/drawingml/2006/main">
               <a:ext uri="{FF2B5EF4-FFF2-40B4-BE49-F238E27FC236}">
-                <a16:creationId xmlns:a16="http://schemas.microsoft.com/office/drawing/2014/main" id="{99DF5432-A61E-4E36-AD6F-72E891A2461D}"/>
+                <a16:creationId xmlns:a16="http://schemas.microsoft.com/office/drawing/2014/main" id="{EB83874E-66F0-4546-826D-5BDB1EBBAF74}"/>
               </a:ext>
             </a:extLst>
           </p:cNvPr>
@@ -9401,7 +9401,7 @@
           <p:cNvPr id="35" name="">
             <a:extLst xmlns:a="http://schemas.openxmlformats.org/drawingml/2006/main">
               <a:ext uri="{FF2B5EF4-FFF2-40B4-BE49-F238E27FC236}">
-                <a16:creationId xmlns:a16="http://schemas.microsoft.com/office/drawing/2014/main" id="{E7D695D1-5218-400A-81BF-90A05C687375}"/>
+                <a16:creationId xmlns:a16="http://schemas.microsoft.com/office/drawing/2014/main" id="{C9E77ED6-2883-4F73-B330-58346EE04222}"/>
               </a:ext>
             </a:extLst>
           </p:cNvPr>
@@ -9459,7 +9459,7 @@
           <p:cNvPr id="36" name="">
             <a:extLst xmlns:a="http://schemas.openxmlformats.org/drawingml/2006/main">
               <a:ext uri="{FF2B5EF4-FFF2-40B4-BE49-F238E27FC236}">
-                <a16:creationId xmlns:a16="http://schemas.microsoft.com/office/drawing/2014/main" id="{965E6EF9-E7F2-4E66-BB7C-81C7D06B56D9}"/>
+                <a16:creationId xmlns:a16="http://schemas.microsoft.com/office/drawing/2014/main" id="{7539231F-D194-4C0A-8F58-8AC73A14D4FA}"/>
               </a:ext>
             </a:extLst>
           </p:cNvPr>
@@ -9517,7 +9517,7 @@
           <p:cNvPr id="37" name="">
             <a:extLst xmlns:a="http://schemas.openxmlformats.org/drawingml/2006/main">
               <a:ext uri="{FF2B5EF4-FFF2-40B4-BE49-F238E27FC236}">
-                <a16:creationId xmlns:a16="http://schemas.microsoft.com/office/drawing/2014/main" id="{FE965FA0-933C-4577-9A38-DBFE37D9D2AA}"/>
+                <a16:creationId xmlns:a16="http://schemas.microsoft.com/office/drawing/2014/main" id="{C3F3918C-D46C-4661-AF8A-6DAAC514EB79}"/>
               </a:ext>
             </a:extLst>
           </p:cNvPr>
@@ -9573,7 +9573,7 @@
     </p:spTree>
     <p:extLst>
       <p:ext uri="{BB962C8B-B14F-4D97-AF65-F5344CB8AC3E}">
-        <p14:creationId xmlns:p14="http://schemas.microsoft.com/office/powerpoint/2010/main" val="1012619998"/>
+        <p14:creationId xmlns:p14="http://schemas.microsoft.com/office/powerpoint/2010/main" val="1337140563"/>
       </p:ext>
     </p:extLst>
   </p:cSld>
@@ -9604,7 +9604,7 @@
           <p:cNvPr id="19" name="">
             <a:extLst xmlns:a="http://schemas.openxmlformats.org/drawingml/2006/main">
               <a:ext uri="{FF2B5EF4-FFF2-40B4-BE49-F238E27FC236}">
-                <a16:creationId xmlns:a16="http://schemas.microsoft.com/office/drawing/2014/main" id="{8B15F01F-043C-4971-A670-DD7EDDD5BE87}"/>
+                <a16:creationId xmlns:a16="http://schemas.microsoft.com/office/drawing/2014/main" id="{124633F0-1114-4D2D-B256-FB64F85EC27E}"/>
               </a:ext>
             </a:extLst>
           </p:cNvPr>
@@ -9662,7 +9662,7 @@
           <p:cNvPr id="2" name="">
             <a:extLst xmlns:a="http://schemas.openxmlformats.org/drawingml/2006/main">
               <a:ext uri="{FF2B5EF4-FFF2-40B4-BE49-F238E27FC236}">
-                <a16:creationId xmlns:a16="http://schemas.microsoft.com/office/drawing/2014/main" id="{92B6A1BE-AEF9-4029-8A79-C0D10766A4F6}"/>
+                <a16:creationId xmlns:a16="http://schemas.microsoft.com/office/drawing/2014/main" id="{8B3ABC40-3C51-4568-87B1-8ADDA027D754}"/>
               </a:ext>
             </a:extLst>
           </p:cNvPr>
@@ -9720,7 +9720,7 @@
           <p:cNvPr id="3" name="">
             <a:extLst xmlns:a="http://schemas.openxmlformats.org/drawingml/2006/main">
               <a:ext uri="{FF2B5EF4-FFF2-40B4-BE49-F238E27FC236}">
-                <a16:creationId xmlns:a16="http://schemas.microsoft.com/office/drawing/2014/main" id="{767349FF-48C3-414C-8462-7E214CFEA3C0}"/>
+                <a16:creationId xmlns:a16="http://schemas.microsoft.com/office/drawing/2014/main" id="{EFA03EAE-0962-4436-8DFD-659595ABC318}"/>
               </a:ext>
             </a:extLst>
           </p:cNvPr>
@@ -9753,7 +9753,7 @@
           <p:cNvPr id="4" name="">
             <a:extLst xmlns:a="http://schemas.openxmlformats.org/drawingml/2006/main">
               <a:ext uri="{FF2B5EF4-FFF2-40B4-BE49-F238E27FC236}">
-                <a16:creationId xmlns:a16="http://schemas.microsoft.com/office/drawing/2014/main" id="{3CA4BE3C-CBD3-4D83-830B-D1BCE5F51D71}"/>
+                <a16:creationId xmlns:a16="http://schemas.microsoft.com/office/drawing/2014/main" id="{64A87FFD-EEFB-46DD-87B1-DCF4B84079E0}"/>
               </a:ext>
             </a:extLst>
           </p:cNvPr>
@@ -9811,7 +9811,7 @@
           <p:cNvPr id="5" name="">
             <a:extLst xmlns:a="http://schemas.openxmlformats.org/drawingml/2006/main">
               <a:ext uri="{FF2B5EF4-FFF2-40B4-BE49-F238E27FC236}">
-                <a16:creationId xmlns:a16="http://schemas.microsoft.com/office/drawing/2014/main" id="{ADDB6AFA-FCAA-4E88-A0FF-9F551DE4774A}"/>
+                <a16:creationId xmlns:a16="http://schemas.microsoft.com/office/drawing/2014/main" id="{3DFBEA56-3AAC-4DB5-ABF8-A9868E983231}"/>
               </a:ext>
             </a:extLst>
           </p:cNvPr>
@@ -9869,7 +9869,7 @@
           <p:cNvPr id="6" name="">
             <a:extLst xmlns:a="http://schemas.openxmlformats.org/drawingml/2006/main">
               <a:ext uri="{FF2B5EF4-FFF2-40B4-BE49-F238E27FC236}">
-                <a16:creationId xmlns:a16="http://schemas.microsoft.com/office/drawing/2014/main" id="{75E6A92E-6C9E-4068-B88B-121A4CC6E92B}"/>
+                <a16:creationId xmlns:a16="http://schemas.microsoft.com/office/drawing/2014/main" id="{978167F9-237B-42E0-A4D6-504B83BA95AF}"/>
               </a:ext>
             </a:extLst>
           </p:cNvPr>
@@ -9904,7 +9904,7 @@
           <p:cNvPr id="7" name="">
             <a:extLst xmlns:a="http://schemas.openxmlformats.org/drawingml/2006/main">
               <a:ext uri="{FF2B5EF4-FFF2-40B4-BE49-F238E27FC236}">
-                <a16:creationId xmlns:a16="http://schemas.microsoft.com/office/drawing/2014/main" id="{0AB01E39-39C6-4F0D-9614-1315FBE71335}"/>
+                <a16:creationId xmlns:a16="http://schemas.microsoft.com/office/drawing/2014/main" id="{476CF79D-6BDC-4490-80F1-7A746D33A4C6}"/>
               </a:ext>
             </a:extLst>
           </p:cNvPr>
@@ -9937,7 +9937,7 @@
           <p:cNvPr id="8" name="">
             <a:extLst xmlns:a="http://schemas.openxmlformats.org/drawingml/2006/main">
               <a:ext uri="{FF2B5EF4-FFF2-40B4-BE49-F238E27FC236}">
-                <a16:creationId xmlns:a16="http://schemas.microsoft.com/office/drawing/2014/main" id="{AFE1882D-30CA-4E31-B0EE-4E0E29AD26E2}"/>
+                <a16:creationId xmlns:a16="http://schemas.microsoft.com/office/drawing/2014/main" id="{5AF8BFF1-40B5-48B6-A2BD-936932B90D52}"/>
               </a:ext>
             </a:extLst>
           </p:cNvPr>
@@ -9995,7 +9995,7 @@
           <p:cNvPr id="9" name="">
             <a:extLst xmlns:a="http://schemas.openxmlformats.org/drawingml/2006/main">
               <a:ext uri="{FF2B5EF4-FFF2-40B4-BE49-F238E27FC236}">
-                <a16:creationId xmlns:a16="http://schemas.microsoft.com/office/drawing/2014/main" id="{C1B91042-28D5-4AC5-9EBA-698511F09AA5}"/>
+                <a16:creationId xmlns:a16="http://schemas.microsoft.com/office/drawing/2014/main" id="{42A7A7F5-0CDB-4928-9E5C-9CCD07BF765F}"/>
               </a:ext>
             </a:extLst>
           </p:cNvPr>
@@ -10070,7 +10070,7 @@
           <p:cNvPr id="10" name="">
             <a:extLst xmlns:a="http://schemas.openxmlformats.org/drawingml/2006/main">
               <a:ext uri="{FF2B5EF4-FFF2-40B4-BE49-F238E27FC236}">
-                <a16:creationId xmlns:a16="http://schemas.microsoft.com/office/drawing/2014/main" id="{65F7E0C6-9B21-42A7-9A5D-AE44BA591C54}"/>
+                <a16:creationId xmlns:a16="http://schemas.microsoft.com/office/drawing/2014/main" id="{44992474-0BDD-4C0E-804D-50D0295949E9}"/>
               </a:ext>
             </a:extLst>
           </p:cNvPr>
@@ -10105,7 +10105,7 @@
           <p:cNvPr id="11" name="">
             <a:extLst xmlns:a="http://schemas.openxmlformats.org/drawingml/2006/main">
               <a:ext uri="{FF2B5EF4-FFF2-40B4-BE49-F238E27FC236}">
-                <a16:creationId xmlns:a16="http://schemas.microsoft.com/office/drawing/2014/main" id="{A1F0D155-76BB-4FA1-BB28-7A5464D41D56}"/>
+                <a16:creationId xmlns:a16="http://schemas.microsoft.com/office/drawing/2014/main" id="{BC8DF44A-8718-4ABB-B6EB-3EF7ABE792DC}"/>
               </a:ext>
             </a:extLst>
           </p:cNvPr>
@@ -10138,7 +10138,7 @@
           <p:cNvPr id="12" name="">
             <a:extLst xmlns:a="http://schemas.openxmlformats.org/drawingml/2006/main">
               <a:ext uri="{FF2B5EF4-FFF2-40B4-BE49-F238E27FC236}">
-                <a16:creationId xmlns:a16="http://schemas.microsoft.com/office/drawing/2014/main" id="{4B337F14-449A-46D1-BA08-C5C78EB540E6}"/>
+                <a16:creationId xmlns:a16="http://schemas.microsoft.com/office/drawing/2014/main" id="{C06DC152-20E8-424D-8624-427428B930F2}"/>
               </a:ext>
             </a:extLst>
           </p:cNvPr>
@@ -10196,7 +10196,7 @@
           <p:cNvPr id="13" name="">
             <a:extLst xmlns:a="http://schemas.openxmlformats.org/drawingml/2006/main">
               <a:ext uri="{FF2B5EF4-FFF2-40B4-BE49-F238E27FC236}">
-                <a16:creationId xmlns:a16="http://schemas.microsoft.com/office/drawing/2014/main" id="{2AE943EE-C175-4D5C-8D89-900589424BB3}"/>
+                <a16:creationId xmlns:a16="http://schemas.microsoft.com/office/drawing/2014/main" id="{124F380F-787E-4761-AFCD-B24DDA412181}"/>
               </a:ext>
             </a:extLst>
           </p:cNvPr>
@@ -10254,7 +10254,7 @@
           <p:cNvPr id="14" name="">
             <a:extLst xmlns:a="http://schemas.openxmlformats.org/drawingml/2006/main">
               <a:ext uri="{FF2B5EF4-FFF2-40B4-BE49-F238E27FC236}">
-                <a16:creationId xmlns:a16="http://schemas.microsoft.com/office/drawing/2014/main" id="{B479A875-CE50-4EB0-8843-A48D29AF96ED}"/>
+                <a16:creationId xmlns:a16="http://schemas.microsoft.com/office/drawing/2014/main" id="{6703BA86-4F35-43A2-9B11-876880AB0EC6}"/>
               </a:ext>
             </a:extLst>
           </p:cNvPr>
@@ -10289,7 +10289,7 @@
           <p:cNvPr id="15" name="">
             <a:extLst xmlns:a="http://schemas.openxmlformats.org/drawingml/2006/main">
               <a:ext uri="{FF2B5EF4-FFF2-40B4-BE49-F238E27FC236}">
-                <a16:creationId xmlns:a16="http://schemas.microsoft.com/office/drawing/2014/main" id="{735FE1A1-B586-4105-94B2-09E2E5FC8F0A}"/>
+                <a16:creationId xmlns:a16="http://schemas.microsoft.com/office/drawing/2014/main" id="{5FF6AB8D-77F6-4F4E-8905-62BAC84FD3DE}"/>
               </a:ext>
             </a:extLst>
           </p:cNvPr>
@@ -10322,7 +10322,7 @@
           <p:cNvPr id="16" name="">
             <a:extLst xmlns:a="http://schemas.openxmlformats.org/drawingml/2006/main">
               <a:ext uri="{FF2B5EF4-FFF2-40B4-BE49-F238E27FC236}">
-                <a16:creationId xmlns:a16="http://schemas.microsoft.com/office/drawing/2014/main" id="{C088DB37-D329-4DD2-93CA-BAB69FF68C22}"/>
+                <a16:creationId xmlns:a16="http://schemas.microsoft.com/office/drawing/2014/main" id="{EFD12CB0-5DED-422C-ADCA-86728FB93FD1}"/>
               </a:ext>
             </a:extLst>
           </p:cNvPr>
@@ -10380,7 +10380,7 @@
           <p:cNvPr id="17" name="">
             <a:extLst xmlns:a="http://schemas.openxmlformats.org/drawingml/2006/main">
               <a:ext uri="{FF2B5EF4-FFF2-40B4-BE49-F238E27FC236}">
-                <a16:creationId xmlns:a16="http://schemas.microsoft.com/office/drawing/2014/main" id="{129D8175-4EFB-4C5C-9FD5-E5D88932FFF7}"/>
+                <a16:creationId xmlns:a16="http://schemas.microsoft.com/office/drawing/2014/main" id="{D14199C4-C50B-41F9-A740-99AAF9227DCC}"/>
               </a:ext>
             </a:extLst>
           </p:cNvPr>
@@ -10438,7 +10438,7 @@
           <p:cNvPr id="18" name="">
             <a:extLst xmlns:a="http://schemas.openxmlformats.org/drawingml/2006/main">
               <a:ext uri="{FF2B5EF4-FFF2-40B4-BE49-F238E27FC236}">
-                <a16:creationId xmlns:a16="http://schemas.microsoft.com/office/drawing/2014/main" id="{BC3A27AD-117C-411F-A0D1-3980610DA1ED}"/>
+                <a16:creationId xmlns:a16="http://schemas.microsoft.com/office/drawing/2014/main" id="{B7168AD6-01F2-45E7-941D-226611E2B834}"/>
               </a:ext>
             </a:extLst>
           </p:cNvPr>
@@ -10494,7 +10494,7 @@
     </p:spTree>
     <p:extLst>
       <p:ext uri="{BB962C8B-B14F-4D97-AF65-F5344CB8AC3E}">
-        <p14:creationId xmlns:p14="http://schemas.microsoft.com/office/powerpoint/2010/main" val="865381573"/>
+        <p14:creationId xmlns:p14="http://schemas.microsoft.com/office/powerpoint/2010/main" val="1497453836"/>
       </p:ext>
     </p:extLst>
   </p:cSld>
@@ -10525,7 +10525,7 @@
           <p:cNvPr id="28" name="">
             <a:extLst xmlns:a="http://schemas.openxmlformats.org/drawingml/2006/main">
               <a:ext uri="{FF2B5EF4-FFF2-40B4-BE49-F238E27FC236}">
-                <a16:creationId xmlns:a16="http://schemas.microsoft.com/office/drawing/2014/main" id="{E3EDC77F-97AB-47CC-81C6-DBB34119EDA8}"/>
+                <a16:creationId xmlns:a16="http://schemas.microsoft.com/office/drawing/2014/main" id="{EAB4715B-5FA5-4AB3-9044-EE9215C78C95}"/>
               </a:ext>
             </a:extLst>
           </p:cNvPr>
@@ -10583,7 +10583,7 @@
           <p:cNvPr id="2" name="">
             <a:extLst xmlns:a="http://schemas.openxmlformats.org/drawingml/2006/main">
               <a:ext uri="{FF2B5EF4-FFF2-40B4-BE49-F238E27FC236}">
-                <a16:creationId xmlns:a16="http://schemas.microsoft.com/office/drawing/2014/main" id="{D66F53CC-ADD4-4A2A-9600-2E8D1F6FEF95}"/>
+                <a16:creationId xmlns:a16="http://schemas.microsoft.com/office/drawing/2014/main" id="{D76F7DDF-3A40-4175-867A-52B7994E8828}"/>
               </a:ext>
             </a:extLst>
           </p:cNvPr>
@@ -10641,7 +10641,7 @@
           <p:cNvPr id="3" name="">
             <a:extLst xmlns:a="http://schemas.openxmlformats.org/drawingml/2006/main">
               <a:ext uri="{FF2B5EF4-FFF2-40B4-BE49-F238E27FC236}">
-                <a16:creationId xmlns:a16="http://schemas.microsoft.com/office/drawing/2014/main" id="{D633D72E-8544-44DE-BA73-7DC9AFFFCA80}"/>
+                <a16:creationId xmlns:a16="http://schemas.microsoft.com/office/drawing/2014/main" id="{F41111EA-D8F8-4E66-9FB6-D32B30647742}"/>
               </a:ext>
             </a:extLst>
           </p:cNvPr>
@@ -10674,7 +10674,7 @@
           <p:cNvPr id="4" name="">
             <a:extLst xmlns:a="http://schemas.openxmlformats.org/drawingml/2006/main">
               <a:ext uri="{FF2B5EF4-FFF2-40B4-BE49-F238E27FC236}">
-                <a16:creationId xmlns:a16="http://schemas.microsoft.com/office/drawing/2014/main" id="{D1B76DC9-E407-46DF-9971-072482BFCD9A}"/>
+                <a16:creationId xmlns:a16="http://schemas.microsoft.com/office/drawing/2014/main" id="{724F61F6-1B96-4324-8BC2-745959CAFA97}"/>
               </a:ext>
             </a:extLst>
           </p:cNvPr>
@@ -10732,7 +10732,7 @@
           <p:cNvPr id="5" name="">
             <a:extLst xmlns:a="http://schemas.openxmlformats.org/drawingml/2006/main">
               <a:ext uri="{FF2B5EF4-FFF2-40B4-BE49-F238E27FC236}">
-                <a16:creationId xmlns:a16="http://schemas.microsoft.com/office/drawing/2014/main" id="{55A9EC91-D228-435F-A1AB-2ABEE24E5620}"/>
+                <a16:creationId xmlns:a16="http://schemas.microsoft.com/office/drawing/2014/main" id="{40FE9F15-E0B7-4E9C-9251-6A77EE84882E}"/>
               </a:ext>
             </a:extLst>
           </p:cNvPr>
@@ -10790,7 +10790,7 @@
           <p:cNvPr id="6" name="">
             <a:extLst xmlns:a="http://schemas.openxmlformats.org/drawingml/2006/main">
               <a:ext uri="{FF2B5EF4-FFF2-40B4-BE49-F238E27FC236}">
-                <a16:creationId xmlns:a16="http://schemas.microsoft.com/office/drawing/2014/main" id="{AFE7E534-153E-4589-9300-57DF8CAD1CA9}"/>
+                <a16:creationId xmlns:a16="http://schemas.microsoft.com/office/drawing/2014/main" id="{A87F2E4F-7121-4B0F-B28C-C507C5DA2701}"/>
               </a:ext>
             </a:extLst>
           </p:cNvPr>
@@ -10825,7 +10825,7 @@
           <p:cNvPr id="7" name="">
             <a:extLst xmlns:a="http://schemas.openxmlformats.org/drawingml/2006/main">
               <a:ext uri="{FF2B5EF4-FFF2-40B4-BE49-F238E27FC236}">
-                <a16:creationId xmlns:a16="http://schemas.microsoft.com/office/drawing/2014/main" id="{9CCB34F4-73B6-4A41-B6D3-0DAB9E4930A6}"/>
+                <a16:creationId xmlns:a16="http://schemas.microsoft.com/office/drawing/2014/main" id="{80A1D1FC-29B6-4F1D-B42B-DE396ADB96D4}"/>
               </a:ext>
             </a:extLst>
           </p:cNvPr>
@@ -10883,7 +10883,7 @@
           <p:cNvPr id="8" name="">
             <a:extLst xmlns:a="http://schemas.openxmlformats.org/drawingml/2006/main">
               <a:ext uri="{FF2B5EF4-FFF2-40B4-BE49-F238E27FC236}">
-                <a16:creationId xmlns:a16="http://schemas.microsoft.com/office/drawing/2014/main" id="{C49A6199-B294-43FB-93F5-B7A1185A9027}"/>
+                <a16:creationId xmlns:a16="http://schemas.microsoft.com/office/drawing/2014/main" id="{C4F126A2-AF6C-4399-8A34-3C9F69251208}"/>
               </a:ext>
             </a:extLst>
           </p:cNvPr>
@@ -10918,7 +10918,7 @@
           <p:cNvPr id="9" name="">
             <a:extLst xmlns:a="http://schemas.openxmlformats.org/drawingml/2006/main">
               <a:ext uri="{FF2B5EF4-FFF2-40B4-BE49-F238E27FC236}">
-                <a16:creationId xmlns:a16="http://schemas.microsoft.com/office/drawing/2014/main" id="{141D96E4-EA5C-4287-90BE-DF999D5B2CBD}"/>
+                <a16:creationId xmlns:a16="http://schemas.microsoft.com/office/drawing/2014/main" id="{1AFD7ECF-7663-4D89-AA4D-BCB1F9862F32}"/>
               </a:ext>
             </a:extLst>
           </p:cNvPr>
@@ -10976,7 +10976,7 @@
           <p:cNvPr id="10" name="">
             <a:extLst xmlns:a="http://schemas.openxmlformats.org/drawingml/2006/main">
               <a:ext uri="{FF2B5EF4-FFF2-40B4-BE49-F238E27FC236}">
-                <a16:creationId xmlns:a16="http://schemas.microsoft.com/office/drawing/2014/main" id="{9E332692-BF35-42FC-BB06-163CF97D2FF1}"/>
+                <a16:creationId xmlns:a16="http://schemas.microsoft.com/office/drawing/2014/main" id="{F60DB806-71D4-46F4-9EFD-AF6D9321EAB8}"/>
               </a:ext>
             </a:extLst>
           </p:cNvPr>
@@ -11011,7 +11011,7 @@
           <p:cNvPr id="11" name="">
             <a:extLst xmlns:a="http://schemas.openxmlformats.org/drawingml/2006/main">
               <a:ext uri="{FF2B5EF4-FFF2-40B4-BE49-F238E27FC236}">
-                <a16:creationId xmlns:a16="http://schemas.microsoft.com/office/drawing/2014/main" id="{617F7A8B-AA07-4EF6-B26E-3C83CA24CDCA}"/>
+                <a16:creationId xmlns:a16="http://schemas.microsoft.com/office/drawing/2014/main" id="{9ED5DD67-8E4E-4118-8296-738C90558C10}"/>
               </a:ext>
             </a:extLst>
           </p:cNvPr>
@@ -11069,7 +11069,7 @@
           <p:cNvPr id="12" name="">
             <a:extLst xmlns:a="http://schemas.openxmlformats.org/drawingml/2006/main">
               <a:ext uri="{FF2B5EF4-FFF2-40B4-BE49-F238E27FC236}">
-                <a16:creationId xmlns:a16="http://schemas.microsoft.com/office/drawing/2014/main" id="{42268A1A-3D2B-43B7-99C6-A607B6C89750}"/>
+                <a16:creationId xmlns:a16="http://schemas.microsoft.com/office/drawing/2014/main" id="{CC336482-1927-433C-8C8F-DBBCFCD264D3}"/>
               </a:ext>
             </a:extLst>
           </p:cNvPr>
@@ -11104,7 +11104,7 @@
           <p:cNvPr id="13" name="">
             <a:extLst xmlns:a="http://schemas.openxmlformats.org/drawingml/2006/main">
               <a:ext uri="{FF2B5EF4-FFF2-40B4-BE49-F238E27FC236}">
-                <a16:creationId xmlns:a16="http://schemas.microsoft.com/office/drawing/2014/main" id="{05862B89-A322-4968-887B-5D9530FFEFEB}"/>
+                <a16:creationId xmlns:a16="http://schemas.microsoft.com/office/drawing/2014/main" id="{B68922C1-C4A4-421D-8C0E-82BCDDFB1396}"/>
               </a:ext>
             </a:extLst>
           </p:cNvPr>
@@ -11162,7 +11162,7 @@
           <p:cNvPr id="14" name="">
             <a:extLst xmlns:a="http://schemas.openxmlformats.org/drawingml/2006/main">
               <a:ext uri="{FF2B5EF4-FFF2-40B4-BE49-F238E27FC236}">
-                <a16:creationId xmlns:a16="http://schemas.microsoft.com/office/drawing/2014/main" id="{7944DD58-D358-486D-BCE1-4DB569DB5CB4}"/>
+                <a16:creationId xmlns:a16="http://schemas.microsoft.com/office/drawing/2014/main" id="{AF4DED00-B2D1-4A5D-B197-06C8336BC421}"/>
               </a:ext>
             </a:extLst>
           </p:cNvPr>
@@ -11197,7 +11197,7 @@
           <p:cNvPr id="15" name="">
             <a:extLst xmlns:a="http://schemas.openxmlformats.org/drawingml/2006/main">
               <a:ext uri="{FF2B5EF4-FFF2-40B4-BE49-F238E27FC236}">
-                <a16:creationId xmlns:a16="http://schemas.microsoft.com/office/drawing/2014/main" id="{897F3A1F-26D3-4557-96D1-1E18B343E411}"/>
+                <a16:creationId xmlns:a16="http://schemas.microsoft.com/office/drawing/2014/main" id="{E3B201BC-67D7-4E81-A1DA-56973B7083AE}"/>
               </a:ext>
             </a:extLst>
           </p:cNvPr>
@@ -11255,7 +11255,7 @@
           <p:cNvPr id="16" name="">
             <a:extLst xmlns:a="http://schemas.openxmlformats.org/drawingml/2006/main">
               <a:ext uri="{FF2B5EF4-FFF2-40B4-BE49-F238E27FC236}">
-                <a16:creationId xmlns:a16="http://schemas.microsoft.com/office/drawing/2014/main" id="{A90ABC0E-11AB-42D2-B068-FF7B2F268415}"/>
+                <a16:creationId xmlns:a16="http://schemas.microsoft.com/office/drawing/2014/main" id="{0BCE6B48-C087-4D68-9CC3-348EDEBBCCAF}"/>
               </a:ext>
             </a:extLst>
           </p:cNvPr>
@@ -11290,7 +11290,7 @@
           <p:cNvPr id="17" name="">
             <a:extLst xmlns:a="http://schemas.openxmlformats.org/drawingml/2006/main">
               <a:ext uri="{FF2B5EF4-FFF2-40B4-BE49-F238E27FC236}">
-                <a16:creationId xmlns:a16="http://schemas.microsoft.com/office/drawing/2014/main" id="{0517B109-DE35-424E-8C9F-5E28310EB0BA}"/>
+                <a16:creationId xmlns:a16="http://schemas.microsoft.com/office/drawing/2014/main" id="{7991268A-A6B1-4B36-8F90-ACAC574C76DD}"/>
               </a:ext>
             </a:extLst>
           </p:cNvPr>
@@ -11348,7 +11348,7 @@
           <p:cNvPr id="18" name="">
             <a:extLst xmlns:a="http://schemas.openxmlformats.org/drawingml/2006/main">
               <a:ext uri="{FF2B5EF4-FFF2-40B4-BE49-F238E27FC236}">
-                <a16:creationId xmlns:a16="http://schemas.microsoft.com/office/drawing/2014/main" id="{430C60D9-0CA0-4CFA-9792-8FA229D94127}"/>
+                <a16:creationId xmlns:a16="http://schemas.microsoft.com/office/drawing/2014/main" id="{D1329EFB-0A10-4903-9206-CF4C085BD6F8}"/>
               </a:ext>
             </a:extLst>
           </p:cNvPr>
@@ -11383,7 +11383,7 @@
           <p:cNvPr id="19" name="">
             <a:extLst xmlns:a="http://schemas.openxmlformats.org/drawingml/2006/main">
               <a:ext uri="{FF2B5EF4-FFF2-40B4-BE49-F238E27FC236}">
-                <a16:creationId xmlns:a16="http://schemas.microsoft.com/office/drawing/2014/main" id="{5AE7FAB3-25BB-482D-AAD8-D404A6C9D315}"/>
+                <a16:creationId xmlns:a16="http://schemas.microsoft.com/office/drawing/2014/main" id="{87D4E7DE-2C38-415B-8A0F-A461F58C8817}"/>
               </a:ext>
             </a:extLst>
           </p:cNvPr>
@@ -11441,7 +11441,7 @@
           <p:cNvPr id="20" name="">
             <a:extLst xmlns:a="http://schemas.openxmlformats.org/drawingml/2006/main">
               <a:ext uri="{FF2B5EF4-FFF2-40B4-BE49-F238E27FC236}">
-                <a16:creationId xmlns:a16="http://schemas.microsoft.com/office/drawing/2014/main" id="{4338DECF-3034-4153-95C1-8CD17039A9A3}"/>
+                <a16:creationId xmlns:a16="http://schemas.microsoft.com/office/drawing/2014/main" id="{7323A28D-2A29-43C6-ADDE-0C483185BB58}"/>
               </a:ext>
             </a:extLst>
           </p:cNvPr>
@@ -11476,7 +11476,7 @@
           <p:cNvPr id="21" name="">
             <a:extLst xmlns:a="http://schemas.openxmlformats.org/drawingml/2006/main">
               <a:ext uri="{FF2B5EF4-FFF2-40B4-BE49-F238E27FC236}">
-                <a16:creationId xmlns:a16="http://schemas.microsoft.com/office/drawing/2014/main" id="{D3D3F47E-2FE8-4159-8068-332009B6F41D}"/>
+                <a16:creationId xmlns:a16="http://schemas.microsoft.com/office/drawing/2014/main" id="{FEC27672-E092-474F-9C63-9A153D51C014}"/>
               </a:ext>
             </a:extLst>
           </p:cNvPr>
@@ -11534,7 +11534,7 @@
           <p:cNvPr id="22" name="">
             <a:extLst xmlns:a="http://schemas.openxmlformats.org/drawingml/2006/main">
               <a:ext uri="{FF2B5EF4-FFF2-40B4-BE49-F238E27FC236}">
-                <a16:creationId xmlns:a16="http://schemas.microsoft.com/office/drawing/2014/main" id="{947BC645-5DB9-4DD8-B324-248A2D7A925C}"/>
+                <a16:creationId xmlns:a16="http://schemas.microsoft.com/office/drawing/2014/main" id="{7BEED5C7-953A-4B7F-93C4-363B2186D049}"/>
               </a:ext>
             </a:extLst>
           </p:cNvPr>
@@ -11569,7 +11569,7 @@
           <p:cNvPr id="23" name="">
             <a:extLst xmlns:a="http://schemas.openxmlformats.org/drawingml/2006/main">
               <a:ext uri="{FF2B5EF4-FFF2-40B4-BE49-F238E27FC236}">
-                <a16:creationId xmlns:a16="http://schemas.microsoft.com/office/drawing/2014/main" id="{377C25ED-E680-4B5A-9359-61FB26F85706}"/>
+                <a16:creationId xmlns:a16="http://schemas.microsoft.com/office/drawing/2014/main" id="{245E0ECE-61BA-413F-B042-272F0D764D00}"/>
               </a:ext>
             </a:extLst>
           </p:cNvPr>
@@ -11627,7 +11627,7 @@
           <p:cNvPr id="24" name="">
             <a:extLst xmlns:a="http://schemas.openxmlformats.org/drawingml/2006/main">
               <a:ext uri="{FF2B5EF4-FFF2-40B4-BE49-F238E27FC236}">
-                <a16:creationId xmlns:a16="http://schemas.microsoft.com/office/drawing/2014/main" id="{1F5B35EF-2B62-4888-BE38-42890AAF1A6D}"/>
+                <a16:creationId xmlns:a16="http://schemas.microsoft.com/office/drawing/2014/main" id="{7CB5962C-3927-4FFE-BD1C-923552390734}"/>
               </a:ext>
             </a:extLst>
           </p:cNvPr>
@@ -11685,7 +11685,7 @@
           <p:cNvPr id="25" name="">
             <a:extLst xmlns:a="http://schemas.openxmlformats.org/drawingml/2006/main">
               <a:ext uri="{FF2B5EF4-FFF2-40B4-BE49-F238E27FC236}">
-                <a16:creationId xmlns:a16="http://schemas.microsoft.com/office/drawing/2014/main" id="{739404C3-50FA-4D76-82C9-5B190D3A9EFE}"/>
+                <a16:creationId xmlns:a16="http://schemas.microsoft.com/office/drawing/2014/main" id="{71A18678-12A6-4C01-BD8A-0B07B0BED1A1}"/>
               </a:ext>
             </a:extLst>
           </p:cNvPr>
@@ -11714,7 +11714,7 @@
             <a:defPPr>
               <a:defRPr sz="975" b="1">
                 <a:solidFill>
-                  <a:srgbClr val="FFFFFF"/>
+                  <a:srgbClr val="17365D"/>
                 </a:solidFill>
               </a:defRPr>
             </a:defPPr>
@@ -11723,14 +11723,14 @@
             <a:pPr>
               <a:defRPr sz="975" b="1">
                 <a:solidFill>
-                  <a:srgbClr val="FFFFFF"/>
+                  <a:srgbClr val="17365D"/>
                 </a:solidFill>
               </a:defRPr>
             </a:pPr>
             <a:r>
               <a:rPr sz="975" b="1">
                 <a:solidFill>
-                  <a:srgbClr val="FFFFFF"/>
+                  <a:srgbClr val="17365D"/>
                 </a:solidFill>
               </a:rPr>
               <a:t>postulación central</a:t>
@@ -11743,7 +11743,7 @@
           <p:cNvPr id="26" name="">
             <a:extLst xmlns:a="http://schemas.openxmlformats.org/drawingml/2006/main">
               <a:ext uri="{FF2B5EF4-FFF2-40B4-BE49-F238E27FC236}">
-                <a16:creationId xmlns:a16="http://schemas.microsoft.com/office/drawing/2014/main" id="{0A7132CC-A740-47B6-B13A-40BFF7BE0FC5}"/>
+                <a16:creationId xmlns:a16="http://schemas.microsoft.com/office/drawing/2014/main" id="{9084C15A-6942-47ED-A333-8C6C85F79564}"/>
               </a:ext>
             </a:extLst>
           </p:cNvPr>
@@ -11801,7 +11801,7 @@
           <p:cNvPr id="27" name="">
             <a:extLst xmlns:a="http://schemas.openxmlformats.org/drawingml/2006/main">
               <a:ext uri="{FF2B5EF4-FFF2-40B4-BE49-F238E27FC236}">
-                <a16:creationId xmlns:a16="http://schemas.microsoft.com/office/drawing/2014/main" id="{186CAFEB-3204-4741-926E-B2852775B3DC}"/>
+                <a16:creationId xmlns:a16="http://schemas.microsoft.com/office/drawing/2014/main" id="{1C8D85E6-4155-448C-AD7E-5E10D7F85E2F}"/>
               </a:ext>
             </a:extLst>
           </p:cNvPr>
@@ -11857,7 +11857,7 @@
     </p:spTree>
     <p:extLst>
       <p:ext uri="{BB962C8B-B14F-4D97-AF65-F5344CB8AC3E}">
-        <p14:creationId xmlns:p14="http://schemas.microsoft.com/office/powerpoint/2010/main" val="58822680"/>
+        <p14:creationId xmlns:p14="http://schemas.microsoft.com/office/powerpoint/2010/main" val="1333036210"/>
       </p:ext>
     </p:extLst>
   </p:cSld>
@@ -11888,7 +11888,7 @@
           <p:cNvPr id="27" name="">
             <a:extLst xmlns:a="http://schemas.openxmlformats.org/drawingml/2006/main">
               <a:ext uri="{FF2B5EF4-FFF2-40B4-BE49-F238E27FC236}">
-                <a16:creationId xmlns:a16="http://schemas.microsoft.com/office/drawing/2014/main" id="{AC28AFD6-514B-42E3-955D-1DC20844DB69}"/>
+                <a16:creationId xmlns:a16="http://schemas.microsoft.com/office/drawing/2014/main" id="{97D4B503-0E9C-4811-8A03-35554B397BED}"/>
               </a:ext>
             </a:extLst>
           </p:cNvPr>
@@ -11946,7 +11946,7 @@
           <p:cNvPr id="2" name="">
             <a:extLst xmlns:a="http://schemas.openxmlformats.org/drawingml/2006/main">
               <a:ext uri="{FF2B5EF4-FFF2-40B4-BE49-F238E27FC236}">
-                <a16:creationId xmlns:a16="http://schemas.microsoft.com/office/drawing/2014/main" id="{6064CE29-900A-41A3-8422-7D65C89CF3AB}"/>
+                <a16:creationId xmlns:a16="http://schemas.microsoft.com/office/drawing/2014/main" id="{9D483A54-2F48-4D2F-A8E8-580B48EABC6D}"/>
               </a:ext>
             </a:extLst>
           </p:cNvPr>
@@ -12004,7 +12004,7 @@
           <p:cNvPr id="3" name="">
             <a:extLst xmlns:a="http://schemas.openxmlformats.org/drawingml/2006/main">
               <a:ext uri="{FF2B5EF4-FFF2-40B4-BE49-F238E27FC236}">
-                <a16:creationId xmlns:a16="http://schemas.microsoft.com/office/drawing/2014/main" id="{9DE5D5DE-1EC5-43B3-A4A9-195C578DB5F9}"/>
+                <a16:creationId xmlns:a16="http://schemas.microsoft.com/office/drawing/2014/main" id="{285C12B2-6E3C-448C-8B04-81CD2610AD6A}"/>
               </a:ext>
             </a:extLst>
           </p:cNvPr>
@@ -12037,7 +12037,7 @@
           <p:cNvPr id="4" name="">
             <a:extLst xmlns:a="http://schemas.openxmlformats.org/drawingml/2006/main">
               <a:ext uri="{FF2B5EF4-FFF2-40B4-BE49-F238E27FC236}">
-                <a16:creationId xmlns:a16="http://schemas.microsoft.com/office/drawing/2014/main" id="{633F57C0-A8AA-42B6-B7DE-2C808165576C}"/>
+                <a16:creationId xmlns:a16="http://schemas.microsoft.com/office/drawing/2014/main" id="{759D859F-C478-4362-A032-A42FF49621D7}"/>
               </a:ext>
             </a:extLst>
           </p:cNvPr>
@@ -12095,7 +12095,7 @@
           <p:cNvPr id="5" name="">
             <a:extLst xmlns:a="http://schemas.openxmlformats.org/drawingml/2006/main">
               <a:ext uri="{FF2B5EF4-FFF2-40B4-BE49-F238E27FC236}">
-                <a16:creationId xmlns:a16="http://schemas.microsoft.com/office/drawing/2014/main" id="{712A5CB0-9446-4629-AE4E-B965811776F3}"/>
+                <a16:creationId xmlns:a16="http://schemas.microsoft.com/office/drawing/2014/main" id="{E8FC80B4-A93A-4C4D-A903-E44A327E1673}"/>
               </a:ext>
             </a:extLst>
           </p:cNvPr>
@@ -12153,7 +12153,7 @@
           <p:cNvPr id="6" name="">
             <a:extLst xmlns:a="http://schemas.openxmlformats.org/drawingml/2006/main">
               <a:ext uri="{FF2B5EF4-FFF2-40B4-BE49-F238E27FC236}">
-                <a16:creationId xmlns:a16="http://schemas.microsoft.com/office/drawing/2014/main" id="{FFDB09D1-8DDF-428A-A623-0CBBB2F4ACB1}"/>
+                <a16:creationId xmlns:a16="http://schemas.microsoft.com/office/drawing/2014/main" id="{EAB310EC-D6FE-4C8F-9904-888DAAF93A85}"/>
               </a:ext>
             </a:extLst>
           </p:cNvPr>
@@ -12188,7 +12188,7 @@
           <p:cNvPr id="7" name="">
             <a:extLst xmlns:a="http://schemas.openxmlformats.org/drawingml/2006/main">
               <a:ext uri="{FF2B5EF4-FFF2-40B4-BE49-F238E27FC236}">
-                <a16:creationId xmlns:a16="http://schemas.microsoft.com/office/drawing/2014/main" id="{2A54841F-6013-46D9-89DC-AFF22898DA46}"/>
+                <a16:creationId xmlns:a16="http://schemas.microsoft.com/office/drawing/2014/main" id="{018FFA2C-F70A-4EC0-879C-6FB3CE17BEDA}"/>
               </a:ext>
             </a:extLst>
           </p:cNvPr>
@@ -12246,7 +12246,7 @@
           <p:cNvPr id="8" name="">
             <a:extLst xmlns:a="http://schemas.openxmlformats.org/drawingml/2006/main">
               <a:ext uri="{FF2B5EF4-FFF2-40B4-BE49-F238E27FC236}">
-                <a16:creationId xmlns:a16="http://schemas.microsoft.com/office/drawing/2014/main" id="{77F63F55-B983-4C7B-94A1-CAC375301E67}"/>
+                <a16:creationId xmlns:a16="http://schemas.microsoft.com/office/drawing/2014/main" id="{8CFC4F2D-E3DB-470D-B4C3-A5760B6CF747}"/>
               </a:ext>
             </a:extLst>
           </p:cNvPr>
@@ -12277,7 +12277,7 @@
           <p:cNvPr id="9" name="">
             <a:extLst xmlns:a="http://schemas.openxmlformats.org/drawingml/2006/main">
               <a:ext uri="{FF2B5EF4-FFF2-40B4-BE49-F238E27FC236}">
-                <a16:creationId xmlns:a16="http://schemas.microsoft.com/office/drawing/2014/main" id="{FD1EDE22-D017-48E3-AA15-F360A25BC019}"/>
+                <a16:creationId xmlns:a16="http://schemas.microsoft.com/office/drawing/2014/main" id="{055C6F7B-70D3-45C9-A4E2-CDD72A3A30C0}"/>
               </a:ext>
             </a:extLst>
           </p:cNvPr>
@@ -12335,7 +12335,7 @@
           <p:cNvPr id="10" name="">
             <a:extLst xmlns:a="http://schemas.openxmlformats.org/drawingml/2006/main">
               <a:ext uri="{FF2B5EF4-FFF2-40B4-BE49-F238E27FC236}">
-                <a16:creationId xmlns:a16="http://schemas.microsoft.com/office/drawing/2014/main" id="{E98B3EE1-375E-4B1B-99F8-5269017F1B89}"/>
+                <a16:creationId xmlns:a16="http://schemas.microsoft.com/office/drawing/2014/main" id="{1FDC6712-6BDC-4626-B9F4-05AC244EF6BD}"/>
               </a:ext>
             </a:extLst>
           </p:cNvPr>
@@ -12393,7 +12393,7 @@
           <p:cNvPr id="11" name="">
             <a:extLst xmlns:a="http://schemas.openxmlformats.org/drawingml/2006/main">
               <a:ext uri="{FF2B5EF4-FFF2-40B4-BE49-F238E27FC236}">
-                <a16:creationId xmlns:a16="http://schemas.microsoft.com/office/drawing/2014/main" id="{18033517-6B22-4216-814D-A37A337E7C04}"/>
+                <a16:creationId xmlns:a16="http://schemas.microsoft.com/office/drawing/2014/main" id="{6EE29B61-51B8-4139-A097-CE04CBE154E4}"/>
               </a:ext>
             </a:extLst>
           </p:cNvPr>
@@ -12428,7 +12428,7 @@
           <p:cNvPr id="12" name="">
             <a:extLst xmlns:a="http://schemas.openxmlformats.org/drawingml/2006/main">
               <a:ext uri="{FF2B5EF4-FFF2-40B4-BE49-F238E27FC236}">
-                <a16:creationId xmlns:a16="http://schemas.microsoft.com/office/drawing/2014/main" id="{0B7BFD1E-99A1-490E-BFCC-6E3C4BD9EF40}"/>
+                <a16:creationId xmlns:a16="http://schemas.microsoft.com/office/drawing/2014/main" id="{B3A417D0-6077-4A04-BA3D-7E1E98AA503A}"/>
               </a:ext>
             </a:extLst>
           </p:cNvPr>
@@ -12486,7 +12486,7 @@
           <p:cNvPr id="13" name="">
             <a:extLst xmlns:a="http://schemas.openxmlformats.org/drawingml/2006/main">
               <a:ext uri="{FF2B5EF4-FFF2-40B4-BE49-F238E27FC236}">
-                <a16:creationId xmlns:a16="http://schemas.microsoft.com/office/drawing/2014/main" id="{860FDDE8-F54C-4B00-A797-C33078F7E0E4}"/>
+                <a16:creationId xmlns:a16="http://schemas.microsoft.com/office/drawing/2014/main" id="{97254932-5B34-4388-9A54-3092E390EC2F}"/>
               </a:ext>
             </a:extLst>
           </p:cNvPr>
@@ -12517,7 +12517,7 @@
           <p:cNvPr id="14" name="">
             <a:extLst xmlns:a="http://schemas.openxmlformats.org/drawingml/2006/main">
               <a:ext uri="{FF2B5EF4-FFF2-40B4-BE49-F238E27FC236}">
-                <a16:creationId xmlns:a16="http://schemas.microsoft.com/office/drawing/2014/main" id="{4F50E9DE-2D62-48F0-9AEA-E98A40565A76}"/>
+                <a16:creationId xmlns:a16="http://schemas.microsoft.com/office/drawing/2014/main" id="{16820E39-CD92-45A7-ADFA-40B041B1CB60}"/>
               </a:ext>
             </a:extLst>
           </p:cNvPr>
@@ -12575,7 +12575,7 @@
           <p:cNvPr id="15" name="">
             <a:extLst xmlns:a="http://schemas.openxmlformats.org/drawingml/2006/main">
               <a:ext uri="{FF2B5EF4-FFF2-40B4-BE49-F238E27FC236}">
-                <a16:creationId xmlns:a16="http://schemas.microsoft.com/office/drawing/2014/main" id="{E4040895-35FE-490A-91AA-DD04AB814805}"/>
+                <a16:creationId xmlns:a16="http://schemas.microsoft.com/office/drawing/2014/main" id="{009C6CA7-8DC5-4F88-BE3D-B8A32866966C}"/>
               </a:ext>
             </a:extLst>
           </p:cNvPr>
@@ -12633,7 +12633,7 @@
           <p:cNvPr id="16" name="">
             <a:extLst xmlns:a="http://schemas.openxmlformats.org/drawingml/2006/main">
               <a:ext uri="{FF2B5EF4-FFF2-40B4-BE49-F238E27FC236}">
-                <a16:creationId xmlns:a16="http://schemas.microsoft.com/office/drawing/2014/main" id="{62BF8BD1-9A0C-4F27-953D-D7F5AE8BE607}"/>
+                <a16:creationId xmlns:a16="http://schemas.microsoft.com/office/drawing/2014/main" id="{A6068692-3E12-4623-BFFB-B09562DDCC90}"/>
               </a:ext>
             </a:extLst>
           </p:cNvPr>
@@ -12668,7 +12668,7 @@
           <p:cNvPr id="17" name="">
             <a:extLst xmlns:a="http://schemas.openxmlformats.org/drawingml/2006/main">
               <a:ext uri="{FF2B5EF4-FFF2-40B4-BE49-F238E27FC236}">
-                <a16:creationId xmlns:a16="http://schemas.microsoft.com/office/drawing/2014/main" id="{0A03C5D6-C8A7-4F57-8F68-CFD78DCC409A}"/>
+                <a16:creationId xmlns:a16="http://schemas.microsoft.com/office/drawing/2014/main" id="{97CCAA87-228F-4CE8-8984-F433C85EFD9E}"/>
               </a:ext>
             </a:extLst>
           </p:cNvPr>
@@ -12726,7 +12726,7 @@
           <p:cNvPr id="18" name="">
             <a:extLst xmlns:a="http://schemas.openxmlformats.org/drawingml/2006/main">
               <a:ext uri="{FF2B5EF4-FFF2-40B4-BE49-F238E27FC236}">
-                <a16:creationId xmlns:a16="http://schemas.microsoft.com/office/drawing/2014/main" id="{22DC80D0-1BE2-4817-9DE2-6284F7F3993F}"/>
+                <a16:creationId xmlns:a16="http://schemas.microsoft.com/office/drawing/2014/main" id="{580BCEA2-D68E-4605-9713-9AF3BCE49D45}"/>
               </a:ext>
             </a:extLst>
           </p:cNvPr>
@@ -12757,7 +12757,7 @@
           <p:cNvPr id="19" name="">
             <a:extLst xmlns:a="http://schemas.openxmlformats.org/drawingml/2006/main">
               <a:ext uri="{FF2B5EF4-FFF2-40B4-BE49-F238E27FC236}">
-                <a16:creationId xmlns:a16="http://schemas.microsoft.com/office/drawing/2014/main" id="{0020AD70-7B50-4A54-8522-52960B30E041}"/>
+                <a16:creationId xmlns:a16="http://schemas.microsoft.com/office/drawing/2014/main" id="{C6F100DA-2006-49B6-88BC-E5823C067CE2}"/>
               </a:ext>
             </a:extLst>
           </p:cNvPr>
@@ -12815,7 +12815,7 @@
           <p:cNvPr id="20" name="">
             <a:extLst xmlns:a="http://schemas.openxmlformats.org/drawingml/2006/main">
               <a:ext uri="{FF2B5EF4-FFF2-40B4-BE49-F238E27FC236}">
-                <a16:creationId xmlns:a16="http://schemas.microsoft.com/office/drawing/2014/main" id="{0A12E4EF-2ABD-4977-9704-ACFE5232625D}"/>
+                <a16:creationId xmlns:a16="http://schemas.microsoft.com/office/drawing/2014/main" id="{F8CF12D9-7390-4F6B-9DCC-6D6B19D96D5A}"/>
               </a:ext>
             </a:extLst>
           </p:cNvPr>
@@ -12873,7 +12873,7 @@
           <p:cNvPr id="21" name="">
             <a:extLst xmlns:a="http://schemas.openxmlformats.org/drawingml/2006/main">
               <a:ext uri="{FF2B5EF4-FFF2-40B4-BE49-F238E27FC236}">
-                <a16:creationId xmlns:a16="http://schemas.microsoft.com/office/drawing/2014/main" id="{007C6C53-8592-426D-8FC1-CE704BCD38B0}"/>
+                <a16:creationId xmlns:a16="http://schemas.microsoft.com/office/drawing/2014/main" id="{B2DE228E-0CDA-4022-94F1-AF7113B1E484}"/>
               </a:ext>
             </a:extLst>
           </p:cNvPr>
@@ -12908,7 +12908,7 @@
           <p:cNvPr id="22" name="">
             <a:extLst xmlns:a="http://schemas.openxmlformats.org/drawingml/2006/main">
               <a:ext uri="{FF2B5EF4-FFF2-40B4-BE49-F238E27FC236}">
-                <a16:creationId xmlns:a16="http://schemas.microsoft.com/office/drawing/2014/main" id="{52E9127F-6C6A-4D82-A15B-0AE955F29032}"/>
+                <a16:creationId xmlns:a16="http://schemas.microsoft.com/office/drawing/2014/main" id="{AD99C237-DFF6-4343-89D2-7719104C10AC}"/>
               </a:ext>
             </a:extLst>
           </p:cNvPr>
@@ -12966,7 +12966,7 @@
           <p:cNvPr id="23" name="">
             <a:extLst xmlns:a="http://schemas.openxmlformats.org/drawingml/2006/main">
               <a:ext uri="{FF2B5EF4-FFF2-40B4-BE49-F238E27FC236}">
-                <a16:creationId xmlns:a16="http://schemas.microsoft.com/office/drawing/2014/main" id="{9C5C341E-C19F-4DE3-A417-3746AE89EE2D}"/>
+                <a16:creationId xmlns:a16="http://schemas.microsoft.com/office/drawing/2014/main" id="{17B0DFA2-573D-44B1-AB02-F325DCA7E628}"/>
               </a:ext>
             </a:extLst>
           </p:cNvPr>
@@ -12997,7 +12997,7 @@
           <p:cNvPr id="24" name="">
             <a:extLst xmlns:a="http://schemas.openxmlformats.org/drawingml/2006/main">
               <a:ext uri="{FF2B5EF4-FFF2-40B4-BE49-F238E27FC236}">
-                <a16:creationId xmlns:a16="http://schemas.microsoft.com/office/drawing/2014/main" id="{E1D103C5-F02B-4E5C-A60E-F3DDC304ED4F}"/>
+                <a16:creationId xmlns:a16="http://schemas.microsoft.com/office/drawing/2014/main" id="{239EE784-EA9D-4768-A350-FA54D2EEFDD7}"/>
               </a:ext>
             </a:extLst>
           </p:cNvPr>
@@ -13055,7 +13055,7 @@
           <p:cNvPr id="25" name="">
             <a:extLst xmlns:a="http://schemas.openxmlformats.org/drawingml/2006/main">
               <a:ext uri="{FF2B5EF4-FFF2-40B4-BE49-F238E27FC236}">
-                <a16:creationId xmlns:a16="http://schemas.microsoft.com/office/drawing/2014/main" id="{334F504F-A118-4BC1-B9B1-E17FF32301CE}"/>
+                <a16:creationId xmlns:a16="http://schemas.microsoft.com/office/drawing/2014/main" id="{23F25096-094E-4709-BA4E-6A114C24DF6D}"/>
               </a:ext>
             </a:extLst>
           </p:cNvPr>
@@ -13113,7 +13113,7 @@
           <p:cNvPr id="26" name="">
             <a:extLst xmlns:a="http://schemas.openxmlformats.org/drawingml/2006/main">
               <a:ext uri="{FF2B5EF4-FFF2-40B4-BE49-F238E27FC236}">
-                <a16:creationId xmlns:a16="http://schemas.microsoft.com/office/drawing/2014/main" id="{FB623F5D-5724-45C1-9511-0AE5EF9EA6B4}"/>
+                <a16:creationId xmlns:a16="http://schemas.microsoft.com/office/drawing/2014/main" id="{137AD444-BFAD-4AAD-9FC4-D75EFEF6C1F7}"/>
               </a:ext>
             </a:extLst>
           </p:cNvPr>
@@ -13169,7 +13169,7 @@
     </p:spTree>
     <p:extLst>
       <p:ext uri="{BB962C8B-B14F-4D97-AF65-F5344CB8AC3E}">
-        <p14:creationId xmlns:p14="http://schemas.microsoft.com/office/powerpoint/2010/main" val="1129788133"/>
+        <p14:creationId xmlns:p14="http://schemas.microsoft.com/office/powerpoint/2010/main" val="327706379"/>
       </p:ext>
     </p:extLst>
   </p:cSld>
@@ -13200,7 +13200,7 @@
           <p:cNvPr id="22" name="">
             <a:extLst xmlns:a="http://schemas.openxmlformats.org/drawingml/2006/main">
               <a:ext uri="{FF2B5EF4-FFF2-40B4-BE49-F238E27FC236}">
-                <a16:creationId xmlns:a16="http://schemas.microsoft.com/office/drawing/2014/main" id="{649974C4-AA35-4CBB-A8DA-586BD7688DB6}"/>
+                <a16:creationId xmlns:a16="http://schemas.microsoft.com/office/drawing/2014/main" id="{32F46F4B-D135-46F9-B7CB-63E32F0CB067}"/>
               </a:ext>
             </a:extLst>
           </p:cNvPr>
@@ -13258,7 +13258,7 @@
           <p:cNvPr id="2" name="">
             <a:extLst xmlns:a="http://schemas.openxmlformats.org/drawingml/2006/main">
               <a:ext uri="{FF2B5EF4-FFF2-40B4-BE49-F238E27FC236}">
-                <a16:creationId xmlns:a16="http://schemas.microsoft.com/office/drawing/2014/main" id="{39C0213C-FEBA-4569-BDBC-3388A75929A6}"/>
+                <a16:creationId xmlns:a16="http://schemas.microsoft.com/office/drawing/2014/main" id="{3C2AB724-7E34-483A-A829-90A0C7029681}"/>
               </a:ext>
             </a:extLst>
           </p:cNvPr>
@@ -13316,7 +13316,7 @@
           <p:cNvPr id="3" name="">
             <a:extLst xmlns:a="http://schemas.openxmlformats.org/drawingml/2006/main">
               <a:ext uri="{FF2B5EF4-FFF2-40B4-BE49-F238E27FC236}">
-                <a16:creationId xmlns:a16="http://schemas.microsoft.com/office/drawing/2014/main" id="{DC7CE6E9-D2DF-4F0B-8A5B-AFD7A60A35C5}"/>
+                <a16:creationId xmlns:a16="http://schemas.microsoft.com/office/drawing/2014/main" id="{650DC558-2DD1-4101-BE67-158C5CC6803B}"/>
               </a:ext>
             </a:extLst>
           </p:cNvPr>
@@ -13349,7 +13349,7 @@
           <p:cNvPr id="4" name="">
             <a:extLst xmlns:a="http://schemas.openxmlformats.org/drawingml/2006/main">
               <a:ext uri="{FF2B5EF4-FFF2-40B4-BE49-F238E27FC236}">
-                <a16:creationId xmlns:a16="http://schemas.microsoft.com/office/drawing/2014/main" id="{F3C107F4-B8E5-4A39-B053-0417F9E9257F}"/>
+                <a16:creationId xmlns:a16="http://schemas.microsoft.com/office/drawing/2014/main" id="{9B302E13-B6A4-4943-B2FA-945F8A60847B}"/>
               </a:ext>
             </a:extLst>
           </p:cNvPr>
@@ -13407,7 +13407,7 @@
           <p:cNvPr id="5" name="">
             <a:extLst xmlns:a="http://schemas.openxmlformats.org/drawingml/2006/main">
               <a:ext uri="{FF2B5EF4-FFF2-40B4-BE49-F238E27FC236}">
-                <a16:creationId xmlns:a16="http://schemas.microsoft.com/office/drawing/2014/main" id="{D4BE66B8-DBFA-413E-9FF3-42370994F560}"/>
+                <a16:creationId xmlns:a16="http://schemas.microsoft.com/office/drawing/2014/main" id="{B84999DE-7C53-4906-9845-0A760AA6BDF2}"/>
               </a:ext>
             </a:extLst>
           </p:cNvPr>
@@ -13465,7 +13465,7 @@
           <p:cNvPr id="6" name="">
             <a:extLst xmlns:a="http://schemas.openxmlformats.org/drawingml/2006/main">
               <a:ext uri="{FF2B5EF4-FFF2-40B4-BE49-F238E27FC236}">
-                <a16:creationId xmlns:a16="http://schemas.microsoft.com/office/drawing/2014/main" id="{C6295B62-781F-462E-A4A3-910CED171AAE}"/>
+                <a16:creationId xmlns:a16="http://schemas.microsoft.com/office/drawing/2014/main" id="{57F0ED5F-C640-4C26-9187-9A65B074CCC5}"/>
               </a:ext>
             </a:extLst>
           </p:cNvPr>
@@ -13500,7 +13500,7 @@
           <p:cNvPr id="7" name="">
             <a:extLst xmlns:a="http://schemas.openxmlformats.org/drawingml/2006/main">
               <a:ext uri="{FF2B5EF4-FFF2-40B4-BE49-F238E27FC236}">
-                <a16:creationId xmlns:a16="http://schemas.microsoft.com/office/drawing/2014/main" id="{848115B8-A678-4721-8CDB-EE0F81814F89}"/>
+                <a16:creationId xmlns:a16="http://schemas.microsoft.com/office/drawing/2014/main" id="{5B27C58B-D002-4298-BC13-0236F3890457}"/>
               </a:ext>
             </a:extLst>
           </p:cNvPr>
@@ -13533,7 +13533,7 @@
           <p:cNvPr id="8" name="">
             <a:extLst xmlns:a="http://schemas.openxmlformats.org/drawingml/2006/main">
               <a:ext uri="{FF2B5EF4-FFF2-40B4-BE49-F238E27FC236}">
-                <a16:creationId xmlns:a16="http://schemas.microsoft.com/office/drawing/2014/main" id="{1441BFF6-61C4-42A2-83C8-A3AF8211F67C}"/>
+                <a16:creationId xmlns:a16="http://schemas.microsoft.com/office/drawing/2014/main" id="{22BA9DD6-AF91-46E4-84B2-BCAAB68CE64D}"/>
               </a:ext>
             </a:extLst>
           </p:cNvPr>
@@ -13591,7 +13591,7 @@
           <p:cNvPr id="9" name="">
             <a:extLst xmlns:a="http://schemas.openxmlformats.org/drawingml/2006/main">
               <a:ext uri="{FF2B5EF4-FFF2-40B4-BE49-F238E27FC236}">
-                <a16:creationId xmlns:a16="http://schemas.microsoft.com/office/drawing/2014/main" id="{C6CCC4BB-35BA-498F-89E9-B1385BBB0FE4}"/>
+                <a16:creationId xmlns:a16="http://schemas.microsoft.com/office/drawing/2014/main" id="{3D394856-5E69-471C-9007-8C48C6A6FFA2}"/>
               </a:ext>
             </a:extLst>
           </p:cNvPr>
@@ -13649,7 +13649,7 @@
           <p:cNvPr id="10" name="">
             <a:extLst xmlns:a="http://schemas.openxmlformats.org/drawingml/2006/main">
               <a:ext uri="{FF2B5EF4-FFF2-40B4-BE49-F238E27FC236}">
-                <a16:creationId xmlns:a16="http://schemas.microsoft.com/office/drawing/2014/main" id="{22316746-D53A-4CAC-846E-8A3E6E208BD0}"/>
+                <a16:creationId xmlns:a16="http://schemas.microsoft.com/office/drawing/2014/main" id="{B9474AF5-6916-48EA-9FA2-34BA8481FE85}"/>
               </a:ext>
             </a:extLst>
           </p:cNvPr>
@@ -13684,7 +13684,7 @@
           <p:cNvPr id="11" name="">
             <a:extLst xmlns:a="http://schemas.openxmlformats.org/drawingml/2006/main">
               <a:ext uri="{FF2B5EF4-FFF2-40B4-BE49-F238E27FC236}">
-                <a16:creationId xmlns:a16="http://schemas.microsoft.com/office/drawing/2014/main" id="{F30EDC50-2665-4915-B163-9EEC5685B27D}"/>
+                <a16:creationId xmlns:a16="http://schemas.microsoft.com/office/drawing/2014/main" id="{F672A68E-619F-41DD-B76A-DFBB6300D812}"/>
               </a:ext>
             </a:extLst>
           </p:cNvPr>
@@ -13717,7 +13717,7 @@
           <p:cNvPr id="12" name="">
             <a:extLst xmlns:a="http://schemas.openxmlformats.org/drawingml/2006/main">
               <a:ext uri="{FF2B5EF4-FFF2-40B4-BE49-F238E27FC236}">
-                <a16:creationId xmlns:a16="http://schemas.microsoft.com/office/drawing/2014/main" id="{41CBBA8B-35FA-40C1-8680-3B1FD89589BC}"/>
+                <a16:creationId xmlns:a16="http://schemas.microsoft.com/office/drawing/2014/main" id="{9040084E-34E7-4376-9C2E-CDBFEED3D99D}"/>
               </a:ext>
             </a:extLst>
           </p:cNvPr>
@@ -13775,7 +13775,7 @@
           <p:cNvPr id="13" name="">
             <a:extLst xmlns:a="http://schemas.openxmlformats.org/drawingml/2006/main">
               <a:ext uri="{FF2B5EF4-FFF2-40B4-BE49-F238E27FC236}">
-                <a16:creationId xmlns:a16="http://schemas.microsoft.com/office/drawing/2014/main" id="{1A50AA0D-B7B8-4C92-A635-FB1F2BBBC8B4}"/>
+                <a16:creationId xmlns:a16="http://schemas.microsoft.com/office/drawing/2014/main" id="{4BEA3C62-D92F-4F6F-8768-45600B0F95B8}"/>
               </a:ext>
             </a:extLst>
           </p:cNvPr>
@@ -13833,7 +13833,7 @@
           <p:cNvPr id="14" name="">
             <a:extLst xmlns:a="http://schemas.openxmlformats.org/drawingml/2006/main">
               <a:ext uri="{FF2B5EF4-FFF2-40B4-BE49-F238E27FC236}">
-                <a16:creationId xmlns:a16="http://schemas.microsoft.com/office/drawing/2014/main" id="{45F0A0D4-3015-4451-8845-D5040655F8AA}"/>
+                <a16:creationId xmlns:a16="http://schemas.microsoft.com/office/drawing/2014/main" id="{7B08E5B9-5749-4439-8EEC-C6EB6621E866}"/>
               </a:ext>
             </a:extLst>
           </p:cNvPr>
@@ -13868,7 +13868,7 @@
           <p:cNvPr id="15" name="">
             <a:extLst xmlns:a="http://schemas.openxmlformats.org/drawingml/2006/main">
               <a:ext uri="{FF2B5EF4-FFF2-40B4-BE49-F238E27FC236}">
-                <a16:creationId xmlns:a16="http://schemas.microsoft.com/office/drawing/2014/main" id="{277410DD-70F3-4E14-8E62-34168519CACA}"/>
+                <a16:creationId xmlns:a16="http://schemas.microsoft.com/office/drawing/2014/main" id="{D1C9A8DB-643A-40FE-8390-5BC10AFAA9B1}"/>
               </a:ext>
             </a:extLst>
           </p:cNvPr>
@@ -13901,7 +13901,7 @@
           <p:cNvPr id="16" name="">
             <a:extLst xmlns:a="http://schemas.openxmlformats.org/drawingml/2006/main">
               <a:ext uri="{FF2B5EF4-FFF2-40B4-BE49-F238E27FC236}">
-                <a16:creationId xmlns:a16="http://schemas.microsoft.com/office/drawing/2014/main" id="{4C928A23-03B5-430E-8D80-1A7F80FE1D7F}"/>
+                <a16:creationId xmlns:a16="http://schemas.microsoft.com/office/drawing/2014/main" id="{1F78A55B-2438-407B-912D-A114B91F3313}"/>
               </a:ext>
             </a:extLst>
           </p:cNvPr>
@@ -13959,7 +13959,7 @@
           <p:cNvPr id="17" name="">
             <a:extLst xmlns:a="http://schemas.openxmlformats.org/drawingml/2006/main">
               <a:ext uri="{FF2B5EF4-FFF2-40B4-BE49-F238E27FC236}">
-                <a16:creationId xmlns:a16="http://schemas.microsoft.com/office/drawing/2014/main" id="{BDDBAF5E-9347-4FB2-BC64-E4E2240D0573}"/>
+                <a16:creationId xmlns:a16="http://schemas.microsoft.com/office/drawing/2014/main" id="{C2EE61F6-6DDC-4EF2-819B-3A0BAEEBB2FE}"/>
               </a:ext>
             </a:extLst>
           </p:cNvPr>
@@ -14017,7 +14017,7 @@
           <p:cNvPr id="18" name="">
             <a:extLst xmlns:a="http://schemas.openxmlformats.org/drawingml/2006/main">
               <a:ext uri="{FF2B5EF4-FFF2-40B4-BE49-F238E27FC236}">
-                <a16:creationId xmlns:a16="http://schemas.microsoft.com/office/drawing/2014/main" id="{8A4AEB42-9A91-4A99-B1CE-95B054AF1AD8}"/>
+                <a16:creationId xmlns:a16="http://schemas.microsoft.com/office/drawing/2014/main" id="{B428670B-1AFF-4542-87FC-E28EA302A1EF}"/>
               </a:ext>
             </a:extLst>
           </p:cNvPr>
@@ -14052,7 +14052,7 @@
           <p:cNvPr id="19" name="">
             <a:extLst xmlns:a="http://schemas.openxmlformats.org/drawingml/2006/main">
               <a:ext uri="{FF2B5EF4-FFF2-40B4-BE49-F238E27FC236}">
-                <a16:creationId xmlns:a16="http://schemas.microsoft.com/office/drawing/2014/main" id="{155DA248-D529-4303-A363-115E2AF7D3A3}"/>
+                <a16:creationId xmlns:a16="http://schemas.microsoft.com/office/drawing/2014/main" id="{048D114B-81B7-4F9E-92F0-0C9261B07909}"/>
               </a:ext>
             </a:extLst>
           </p:cNvPr>
@@ -14085,7 +14085,7 @@
           <p:cNvPr id="20" name="">
             <a:extLst xmlns:a="http://schemas.openxmlformats.org/drawingml/2006/main">
               <a:ext uri="{FF2B5EF4-FFF2-40B4-BE49-F238E27FC236}">
-                <a16:creationId xmlns:a16="http://schemas.microsoft.com/office/drawing/2014/main" id="{665773B2-DFF8-4777-BFC3-08E9EECFCBAA}"/>
+                <a16:creationId xmlns:a16="http://schemas.microsoft.com/office/drawing/2014/main" id="{4B104550-7FD8-4F2A-9476-ABF4DEAC2E93}"/>
               </a:ext>
             </a:extLst>
           </p:cNvPr>
@@ -14143,7 +14143,7 @@
           <p:cNvPr id="21" name="">
             <a:extLst xmlns:a="http://schemas.openxmlformats.org/drawingml/2006/main">
               <a:ext uri="{FF2B5EF4-FFF2-40B4-BE49-F238E27FC236}">
-                <a16:creationId xmlns:a16="http://schemas.microsoft.com/office/drawing/2014/main" id="{0F9315C7-E774-4789-9252-C58197F330CE}"/>
+                <a16:creationId xmlns:a16="http://schemas.microsoft.com/office/drawing/2014/main" id="{1D2F8F0D-85CE-4121-AA22-EC542B7968C4}"/>
               </a:ext>
             </a:extLst>
           </p:cNvPr>
@@ -14216,7 +14216,7 @@
     </p:spTree>
     <p:extLst>
       <p:ext uri="{BB962C8B-B14F-4D97-AF65-F5344CB8AC3E}">
-        <p14:creationId xmlns:p14="http://schemas.microsoft.com/office/powerpoint/2010/main" val="1907954273"/>
+        <p14:creationId xmlns:p14="http://schemas.microsoft.com/office/powerpoint/2010/main" val="204919713"/>
       </p:ext>
     </p:extLst>
   </p:cSld>
@@ -14247,7 +14247,7 @@
           <p:cNvPr id="19" name="">
             <a:extLst xmlns:a="http://schemas.openxmlformats.org/drawingml/2006/main">
               <a:ext uri="{FF2B5EF4-FFF2-40B4-BE49-F238E27FC236}">
-                <a16:creationId xmlns:a16="http://schemas.microsoft.com/office/drawing/2014/main" id="{7335E1AD-B721-4D9E-A145-6AFEC6881A29}"/>
+                <a16:creationId xmlns:a16="http://schemas.microsoft.com/office/drawing/2014/main" id="{91135AC0-659C-4A9C-B470-0B8BF43129FE}"/>
               </a:ext>
             </a:extLst>
           </p:cNvPr>
@@ -14305,7 +14305,7 @@
           <p:cNvPr id="2" name="">
             <a:extLst xmlns:a="http://schemas.openxmlformats.org/drawingml/2006/main">
               <a:ext uri="{FF2B5EF4-FFF2-40B4-BE49-F238E27FC236}">
-                <a16:creationId xmlns:a16="http://schemas.microsoft.com/office/drawing/2014/main" id="{AD1C722F-1077-4886-AF99-A55C85B261A2}"/>
+                <a16:creationId xmlns:a16="http://schemas.microsoft.com/office/drawing/2014/main" id="{6AA9606A-4282-4FC8-A6EB-9EE69ED01266}"/>
               </a:ext>
             </a:extLst>
           </p:cNvPr>
@@ -14363,7 +14363,7 @@
           <p:cNvPr id="3" name="">
             <a:extLst xmlns:a="http://schemas.openxmlformats.org/drawingml/2006/main">
               <a:ext uri="{FF2B5EF4-FFF2-40B4-BE49-F238E27FC236}">
-                <a16:creationId xmlns:a16="http://schemas.microsoft.com/office/drawing/2014/main" id="{052786D8-8F9A-4849-9F10-61371E9EBF09}"/>
+                <a16:creationId xmlns:a16="http://schemas.microsoft.com/office/drawing/2014/main" id="{973CD573-4E80-4A1F-BF39-1E51DA0F2985}"/>
               </a:ext>
             </a:extLst>
           </p:cNvPr>
@@ -14396,7 +14396,7 @@
           <p:cNvPr id="4" name="">
             <a:extLst xmlns:a="http://schemas.openxmlformats.org/drawingml/2006/main">
               <a:ext uri="{FF2B5EF4-FFF2-40B4-BE49-F238E27FC236}">
-                <a16:creationId xmlns:a16="http://schemas.microsoft.com/office/drawing/2014/main" id="{319C030A-A175-4521-88D3-E59D0016188A}"/>
+                <a16:creationId xmlns:a16="http://schemas.microsoft.com/office/drawing/2014/main" id="{B3158574-ACAD-486E-B837-381729BC6176}"/>
               </a:ext>
             </a:extLst>
           </p:cNvPr>
@@ -14454,7 +14454,7 @@
           <p:cNvPr id="5" name="">
             <a:extLst xmlns:a="http://schemas.openxmlformats.org/drawingml/2006/main">
               <a:ext uri="{FF2B5EF4-FFF2-40B4-BE49-F238E27FC236}">
-                <a16:creationId xmlns:a16="http://schemas.microsoft.com/office/drawing/2014/main" id="{918D9A08-3494-4259-B43B-1B00763B5443}"/>
+                <a16:creationId xmlns:a16="http://schemas.microsoft.com/office/drawing/2014/main" id="{B38B35A6-90C5-4ABB-8D0B-B91001CCC418}"/>
               </a:ext>
             </a:extLst>
           </p:cNvPr>
@@ -14512,7 +14512,7 @@
           <p:cNvPr id="6" name="">
             <a:extLst xmlns:a="http://schemas.openxmlformats.org/drawingml/2006/main">
               <a:ext uri="{FF2B5EF4-FFF2-40B4-BE49-F238E27FC236}">
-                <a16:creationId xmlns:a16="http://schemas.microsoft.com/office/drawing/2014/main" id="{3630E620-5516-4DF4-9B33-772F21933602}"/>
+                <a16:creationId xmlns:a16="http://schemas.microsoft.com/office/drawing/2014/main" id="{6713A565-9FD0-4807-B150-E493BBC1333A}"/>
               </a:ext>
             </a:extLst>
           </p:cNvPr>
@@ -14547,7 +14547,7 @@
           <p:cNvPr id="7" name="">
             <a:extLst xmlns:a="http://schemas.openxmlformats.org/drawingml/2006/main">
               <a:ext uri="{FF2B5EF4-FFF2-40B4-BE49-F238E27FC236}">
-                <a16:creationId xmlns:a16="http://schemas.microsoft.com/office/drawing/2014/main" id="{734BF0B9-B6E6-4F3D-BDA8-10CE13DEC781}"/>
+                <a16:creationId xmlns:a16="http://schemas.microsoft.com/office/drawing/2014/main" id="{2B1F601F-FEEE-4787-B39B-D1E4800A1E26}"/>
               </a:ext>
             </a:extLst>
           </p:cNvPr>
@@ -14605,7 +14605,7 @@
           <p:cNvPr id="8" name="">
             <a:extLst xmlns:a="http://schemas.openxmlformats.org/drawingml/2006/main">
               <a:ext uri="{FF2B5EF4-FFF2-40B4-BE49-F238E27FC236}">
-                <a16:creationId xmlns:a16="http://schemas.microsoft.com/office/drawing/2014/main" id="{647A568B-6ED5-497C-924E-8023828DFACF}"/>
+                <a16:creationId xmlns:a16="http://schemas.microsoft.com/office/drawing/2014/main" id="{2A09E29E-06EB-4CD1-8F6A-5068A2D21D54}"/>
               </a:ext>
             </a:extLst>
           </p:cNvPr>
@@ -14663,7 +14663,7 @@
           <p:cNvPr id="9" name="">
             <a:extLst xmlns:a="http://schemas.openxmlformats.org/drawingml/2006/main">
               <a:ext uri="{FF2B5EF4-FFF2-40B4-BE49-F238E27FC236}">
-                <a16:creationId xmlns:a16="http://schemas.microsoft.com/office/drawing/2014/main" id="{D55A0CDE-071D-4A09-9F81-7721383A3DE5}"/>
+                <a16:creationId xmlns:a16="http://schemas.microsoft.com/office/drawing/2014/main" id="{37DF5904-174F-4196-8ED4-7A69FD243757}"/>
               </a:ext>
             </a:extLst>
           </p:cNvPr>
@@ -14698,7 +14698,7 @@
           <p:cNvPr id="10" name="">
             <a:extLst xmlns:a="http://schemas.openxmlformats.org/drawingml/2006/main">
               <a:ext uri="{FF2B5EF4-FFF2-40B4-BE49-F238E27FC236}">
-                <a16:creationId xmlns:a16="http://schemas.microsoft.com/office/drawing/2014/main" id="{0B218930-9C77-4A2A-BA3B-F300E3F0E8A4}"/>
+                <a16:creationId xmlns:a16="http://schemas.microsoft.com/office/drawing/2014/main" id="{0697DE95-8958-4DCA-9AD4-AD73525B5846}"/>
               </a:ext>
             </a:extLst>
           </p:cNvPr>
@@ -14756,7 +14756,7 @@
           <p:cNvPr id="11" name="">
             <a:extLst xmlns:a="http://schemas.openxmlformats.org/drawingml/2006/main">
               <a:ext uri="{FF2B5EF4-FFF2-40B4-BE49-F238E27FC236}">
-                <a16:creationId xmlns:a16="http://schemas.microsoft.com/office/drawing/2014/main" id="{D35C0E2B-423C-4F63-9417-43E73BD3C25C}"/>
+                <a16:creationId xmlns:a16="http://schemas.microsoft.com/office/drawing/2014/main" id="{849FB25D-5C0C-48A8-ABFA-B78E88904BFB}"/>
               </a:ext>
             </a:extLst>
           </p:cNvPr>
@@ -14814,7 +14814,7 @@
           <p:cNvPr id="12" name="">
             <a:extLst xmlns:a="http://schemas.openxmlformats.org/drawingml/2006/main">
               <a:ext uri="{FF2B5EF4-FFF2-40B4-BE49-F238E27FC236}">
-                <a16:creationId xmlns:a16="http://schemas.microsoft.com/office/drawing/2014/main" id="{CEAC496E-2759-49CE-9BAE-087F9AC1A3EF}"/>
+                <a16:creationId xmlns:a16="http://schemas.microsoft.com/office/drawing/2014/main" id="{0C75709F-C434-4C3B-9C5B-7C0AE7E6771A}"/>
               </a:ext>
             </a:extLst>
           </p:cNvPr>
@@ -14849,7 +14849,7 @@
           <p:cNvPr id="13" name="">
             <a:extLst xmlns:a="http://schemas.openxmlformats.org/drawingml/2006/main">
               <a:ext uri="{FF2B5EF4-FFF2-40B4-BE49-F238E27FC236}">
-                <a16:creationId xmlns:a16="http://schemas.microsoft.com/office/drawing/2014/main" id="{970C7662-C1D2-4FF5-980C-E28775A1AF26}"/>
+                <a16:creationId xmlns:a16="http://schemas.microsoft.com/office/drawing/2014/main" id="{765F8E5F-DC18-4B88-B5C6-A3D0AB3FC782}"/>
               </a:ext>
             </a:extLst>
           </p:cNvPr>
@@ -14897,7 +14897,7 @@
                   <a:srgbClr val="B42318"/>
                 </a:solidFill>
               </a:rPr>
-              <a:t>POP3 fuera de línea</a:t>
+              <a:t>Internet o Roundcube caído</a:t>
             </a:r>
           </a:p>
         </p:txBody>
@@ -14907,7 +14907,7 @@
           <p:cNvPr id="14" name="">
             <a:extLst xmlns:a="http://schemas.openxmlformats.org/drawingml/2006/main">
               <a:ext uri="{FF2B5EF4-FFF2-40B4-BE49-F238E27FC236}">
-                <a16:creationId xmlns:a16="http://schemas.microsoft.com/office/drawing/2014/main" id="{E9794AA8-7766-423F-83CD-E1301F1BC7AD}"/>
+                <a16:creationId xmlns:a16="http://schemas.microsoft.com/office/drawing/2014/main" id="{82EAB345-51D9-4FD3-AD4F-E8DC4EBF7A48}"/>
               </a:ext>
             </a:extLst>
           </p:cNvPr>
@@ -14965,7 +14965,7 @@
           <p:cNvPr id="15" name="">
             <a:extLst xmlns:a="http://schemas.openxmlformats.org/drawingml/2006/main">
               <a:ext uri="{FF2B5EF4-FFF2-40B4-BE49-F238E27FC236}">
-                <a16:creationId xmlns:a16="http://schemas.microsoft.com/office/drawing/2014/main" id="{15172930-6EF6-4350-A7BF-BD4B07D4A4B7}"/>
+                <a16:creationId xmlns:a16="http://schemas.microsoft.com/office/drawing/2014/main" id="{57FD9167-F5F9-4DFE-BB6A-33F9E558CF72}"/>
               </a:ext>
             </a:extLst>
           </p:cNvPr>
@@ -15000,7 +15000,7 @@
           <p:cNvPr id="16" name="">
             <a:extLst xmlns:a="http://schemas.openxmlformats.org/drawingml/2006/main">
               <a:ext uri="{FF2B5EF4-FFF2-40B4-BE49-F238E27FC236}">
-                <a16:creationId xmlns:a16="http://schemas.microsoft.com/office/drawing/2014/main" id="{79AB1332-A641-4C88-9455-5A63FEE05BE6}"/>
+                <a16:creationId xmlns:a16="http://schemas.microsoft.com/office/drawing/2014/main" id="{1AC38B76-D041-45F1-98BA-37ED8F8EEBC6}"/>
               </a:ext>
             </a:extLst>
           </p:cNvPr>
@@ -15058,7 +15058,7 @@
           <p:cNvPr id="17" name="">
             <a:extLst xmlns:a="http://schemas.openxmlformats.org/drawingml/2006/main">
               <a:ext uri="{FF2B5EF4-FFF2-40B4-BE49-F238E27FC236}">
-                <a16:creationId xmlns:a16="http://schemas.microsoft.com/office/drawing/2014/main" id="{B508A5E2-A9C1-409C-90D1-63E85B0F2FC8}"/>
+                <a16:creationId xmlns:a16="http://schemas.microsoft.com/office/drawing/2014/main" id="{E5CAD0D6-0555-43E7-A6A1-24BF9FE2540B}"/>
               </a:ext>
             </a:extLst>
           </p:cNvPr>
@@ -15116,19 +15116,19 @@
           <p:cNvPr id="18" name="">
             <a:extLst xmlns:a="http://schemas.openxmlformats.org/drawingml/2006/main">
               <a:ext uri="{FF2B5EF4-FFF2-40B4-BE49-F238E27FC236}">
-                <a16:creationId xmlns:a16="http://schemas.microsoft.com/office/drawing/2014/main" id="{F1B0A759-86C5-47B3-A796-9F4EF384691E}"/>
-              </a:ext>
-            </a:extLst>
-          </p:cNvPr>
-          <p:cNvSpPr>
-            <a:spLocks xmlns:a="http://schemas.openxmlformats.org/drawingml/2006/main" noGrp="1"/>
-          </p:cNvSpPr>
-          <p:nvPr/>
-        </p:nvSpPr>
-        <p:spPr>
-          <a:xfrm xmlns:a="http://schemas.openxmlformats.org/drawingml/2006/main">
-            <a:off x="1381125" y="5857875"/>
-            <a:ext cx="9429750" cy="333375"/>
+                <a16:creationId xmlns:a16="http://schemas.microsoft.com/office/drawing/2014/main" id="{21753F27-43FE-4FF3-B545-91F6742A4B2E}"/>
+              </a:ext>
+            </a:extLst>
+          </p:cNvPr>
+          <p:cNvSpPr>
+            <a:spLocks xmlns:a="http://schemas.openxmlformats.org/drawingml/2006/main" noGrp="1"/>
+          </p:cNvSpPr>
+          <p:nvPr/>
+        </p:nvSpPr>
+        <p:spPr>
+          <a:xfrm xmlns:a="http://schemas.openxmlformats.org/drawingml/2006/main">
+            <a:off x="1095375" y="5857875"/>
+            <a:ext cx="10001250" cy="333375"/>
           </a:xfrm>
           <a:prstGeom xmlns:a="http://schemas.openxmlformats.org/drawingml/2006/main" prst="rect">
             <a:avLst/>
@@ -15143,7 +15143,7 @@
           <a:bodyPr xmlns:a="http://schemas.openxmlformats.org/drawingml/2006/main" anchor="ctr"/>
           <a:lstStyle xmlns:a="http://schemas.openxmlformats.org/drawingml/2006/main">
             <a:defPPr>
-              <a:defRPr sz="1425" b="1">
+              <a:defRPr sz="1350" b="1">
                 <a:solidFill>
                   <a:srgbClr val="17365D"/>
                 </a:solidFill>
@@ -15152,19 +15152,19 @@
           </a:lstStyle>
           <a:p xmlns:a="http://schemas.openxmlformats.org/drawingml/2006/main">
             <a:pPr>
-              <a:defRPr sz="1425" b="1">
+              <a:defRPr sz="1350" b="1">
                 <a:solidFill>
                   <a:srgbClr val="17365D"/>
                 </a:solidFill>
               </a:defRPr>
             </a:pPr>
             <a:r>
-              <a:rPr sz="1425" b="1">
+              <a:rPr sz="1350" b="1">
                 <a:solidFill>
                   <a:srgbClr val="17365D"/>
                 </a:solidFill>
               </a:rPr>
-              <a:t>Pruebas automatizadas: 13 aprobadas. Los cortes simulados no detuvieron el servicio.</a:t>
+              <a:t>Pruebas automatizadas y 1.000.000 de asuntos aleatorios. Los cortes simulados no detuvieron el servicio.</a:t>
             </a:r>
           </a:p>
         </p:txBody>
@@ -15172,7 +15172,7 @@
     </p:spTree>
     <p:extLst>
       <p:ext uri="{BB962C8B-B14F-4D97-AF65-F5344CB8AC3E}">
-        <p14:creationId xmlns:p14="http://schemas.microsoft.com/office/powerpoint/2010/main" val="1827227323"/>
+        <p14:creationId xmlns:p14="http://schemas.microsoft.com/office/powerpoint/2010/main" val="648331121"/>
       </p:ext>
     </p:extLst>
   </p:cSld>

</xml_diff>

<commit_message>
Cerrar casos límite y reforzar integridad
</commit_message>
<xml_diff>
--- a/entrega/Presentacion_INF513_P1_Grupo09SA.pptx
+++ b/entrega/Presentacion_INF513_P1_Grupo09SA.pptx
@@ -2,22 +2,22 @@
 <file path=ppt/presentation.xml><?xml version="1.0" encoding="utf-8"?>
 <p:presentation xmlns:p="http://schemas.openxmlformats.org/presentationml/2006/main">
   <p:sldMasterIdLst>
-    <p:sldMasterId xmlns:r="http://schemas.openxmlformats.org/officeDocument/2006/relationships" id="2147483648" r:id="Re817ce7c3c434844"/>
+    <p:sldMasterId xmlns:r="http://schemas.openxmlformats.org/officeDocument/2006/relationships" id="2147483648" r:id="R066872b7830241ff"/>
   </p:sldMasterIdLst>
   <p:notesMasterIdLst>
-    <p:notesMasterId xmlns:r="http://schemas.openxmlformats.org/officeDocument/2006/relationships" r:id="Rf5bc71f68c514403"/>
+    <p:notesMasterId xmlns:r="http://schemas.openxmlformats.org/officeDocument/2006/relationships" r:id="R8580fa7c7c84473f"/>
   </p:notesMasterIdLst>
   <p:sldIdLst>
-    <p:sldId xmlns:r="http://schemas.openxmlformats.org/officeDocument/2006/relationships" id="256" r:id="Rf21bca018b424a3d"/>
-    <p:sldId xmlns:r="http://schemas.openxmlformats.org/officeDocument/2006/relationships" id="257" r:id="R673c47f8b81b4f6d"/>
-    <p:sldId xmlns:r="http://schemas.openxmlformats.org/officeDocument/2006/relationships" id="258" r:id="Rb5a429d4ea48467f"/>
-    <p:sldId xmlns:r="http://schemas.openxmlformats.org/officeDocument/2006/relationships" id="259" r:id="R80272860448747c0"/>
-    <p:sldId xmlns:r="http://schemas.openxmlformats.org/officeDocument/2006/relationships" id="260" r:id="R45d687d142d74d85"/>
-    <p:sldId xmlns:r="http://schemas.openxmlformats.org/officeDocument/2006/relationships" id="261" r:id="R504b662e8e8242c6"/>
-    <p:sldId xmlns:r="http://schemas.openxmlformats.org/officeDocument/2006/relationships" id="262" r:id="Raabe08925980494b"/>
-    <p:sldId xmlns:r="http://schemas.openxmlformats.org/officeDocument/2006/relationships" id="263" r:id="Rdbe5e2f95419456c"/>
-    <p:sldId xmlns:r="http://schemas.openxmlformats.org/officeDocument/2006/relationships" id="264" r:id="Re9518aa1cb434295"/>
-    <p:sldId xmlns:r="http://schemas.openxmlformats.org/officeDocument/2006/relationships" id="265" r:id="R1ea8f75785604adc"/>
+    <p:sldId xmlns:r="http://schemas.openxmlformats.org/officeDocument/2006/relationships" id="256" r:id="R6d47736bad234681"/>
+    <p:sldId xmlns:r="http://schemas.openxmlformats.org/officeDocument/2006/relationships" id="257" r:id="Rc3ef72e73acb4012"/>
+    <p:sldId xmlns:r="http://schemas.openxmlformats.org/officeDocument/2006/relationships" id="258" r:id="R282a8075622041f9"/>
+    <p:sldId xmlns:r="http://schemas.openxmlformats.org/officeDocument/2006/relationships" id="259" r:id="Ra30a9662a5b1494e"/>
+    <p:sldId xmlns:r="http://schemas.openxmlformats.org/officeDocument/2006/relationships" id="260" r:id="R013ef88977824481"/>
+    <p:sldId xmlns:r="http://schemas.openxmlformats.org/officeDocument/2006/relationships" id="261" r:id="R55c9d4e71b9b4090"/>
+    <p:sldId xmlns:r="http://schemas.openxmlformats.org/officeDocument/2006/relationships" id="262" r:id="Rad0374df1b7f4b09"/>
+    <p:sldId xmlns:r="http://schemas.openxmlformats.org/officeDocument/2006/relationships" id="263" r:id="R15ae765fc6c54cea"/>
+    <p:sldId xmlns:r="http://schemas.openxmlformats.org/officeDocument/2006/relationships" id="264" r:id="R83b738cd9afb487e"/>
+    <p:sldId xmlns:r="http://schemas.openxmlformats.org/officeDocument/2006/relationships" id="265" r:id="R1bc05ec5f3224e0d"/>
   </p:sldIdLst>
   <p:sldSz cx="12192000" cy="6858000"/>
   <p:notesSz cx="6858000" cy="9144000"/>
@@ -1088,7 +1088,7 @@
           <p:cNvPr id="3" name="Title">
             <a:extLst xmlns:a="http://schemas.openxmlformats.org/drawingml/2006/main">
               <a:ext uri="{FF2B5EF4-FFF2-40B4-BE49-F238E27FC236}">
-                <a16:creationId xmlns:a16="http://schemas.microsoft.com/office/drawing/2014/main" id="{AD9D4D95-C33F-47B4-ACE9-63D0C7BD3CF7}"/>
+                <a16:creationId xmlns:a16="http://schemas.microsoft.com/office/drawing/2014/main" id="{91E04EB8-FC28-4AA4-BBCD-D0A51A927953}"/>
               </a:ext>
             </a:extLst>
           </p:cNvPr>
@@ -1245,7 +1245,7 @@
           <p:cNvPr id="2" name="Subtitle">
             <a:extLst xmlns:a="http://schemas.openxmlformats.org/drawingml/2006/main">
               <a:ext uri="{FF2B5EF4-FFF2-40B4-BE49-F238E27FC236}">
-                <a16:creationId xmlns:a16="http://schemas.microsoft.com/office/drawing/2014/main" id="{5789EFE3-51EA-4195-9E3F-41DC960B7CE7}"/>
+                <a16:creationId xmlns:a16="http://schemas.microsoft.com/office/drawing/2014/main" id="{6EA61950-467C-4514-902A-53447A7E2211}"/>
               </a:ext>
             </a:extLst>
           </p:cNvPr>
@@ -1419,7 +1419,7 @@
           <p:cNvPr id="2" name="Section title">
             <a:extLst xmlns:a="http://schemas.openxmlformats.org/drawingml/2006/main">
               <a:ext uri="{FF2B5EF4-FFF2-40B4-BE49-F238E27FC236}">
-                <a16:creationId xmlns:a16="http://schemas.microsoft.com/office/drawing/2014/main" id="{4ECF06F8-590E-4649-BC64-2A90B68C3176}"/>
+                <a16:creationId xmlns:a16="http://schemas.microsoft.com/office/drawing/2014/main" id="{BAAD203C-1F1D-4F25-B8C8-379F0A869D96}"/>
               </a:ext>
             </a:extLst>
           </p:cNvPr>
@@ -1593,7 +1593,7 @@
           <p:cNvPr id="3" name="Title">
             <a:extLst xmlns:a="http://schemas.openxmlformats.org/drawingml/2006/main">
               <a:ext uri="{FF2B5EF4-FFF2-40B4-BE49-F238E27FC236}">
-                <a16:creationId xmlns:a16="http://schemas.microsoft.com/office/drawing/2014/main" id="{F9B8FD58-75C7-4716-B6EF-883BF70EB1F8}"/>
+                <a16:creationId xmlns:a16="http://schemas.microsoft.com/office/drawing/2014/main" id="{1505E63F-8E40-4B32-93B2-E618DE04D5A8}"/>
               </a:ext>
             </a:extLst>
           </p:cNvPr>
@@ -1750,7 +1750,7 @@
           <p:cNvPr id="2" name="Body">
             <a:extLst xmlns:a="http://schemas.openxmlformats.org/drawingml/2006/main">
               <a:ext uri="{FF2B5EF4-FFF2-40B4-BE49-F238E27FC236}">
-                <a16:creationId xmlns:a16="http://schemas.microsoft.com/office/drawing/2014/main" id="{66BC1DE8-0A72-4B5F-A122-8FAE7F303AF2}"/>
+                <a16:creationId xmlns:a16="http://schemas.microsoft.com/office/drawing/2014/main" id="{D6D199AD-EA2A-4740-9693-98E0D4BD968B}"/>
               </a:ext>
             </a:extLst>
           </p:cNvPr>
@@ -1924,7 +1924,7 @@
           <p:cNvPr id="4" name="Title">
             <a:extLst xmlns:a="http://schemas.openxmlformats.org/drawingml/2006/main">
               <a:ext uri="{FF2B5EF4-FFF2-40B4-BE49-F238E27FC236}">
-                <a16:creationId xmlns:a16="http://schemas.microsoft.com/office/drawing/2014/main" id="{68919E19-7132-4916-81E9-56EB2CC820AB}"/>
+                <a16:creationId xmlns:a16="http://schemas.microsoft.com/office/drawing/2014/main" id="{53458DEC-04B7-40E9-B431-D47FDC9D88E9}"/>
               </a:ext>
             </a:extLst>
           </p:cNvPr>
@@ -2081,7 +2081,7 @@
           <p:cNvPr id="2" name="Left column">
             <a:extLst xmlns:a="http://schemas.openxmlformats.org/drawingml/2006/main">
               <a:ext uri="{FF2B5EF4-FFF2-40B4-BE49-F238E27FC236}">
-                <a16:creationId xmlns:a16="http://schemas.microsoft.com/office/drawing/2014/main" id="{937E1E8B-465B-4050-AF22-83D02CC8B26F}"/>
+                <a16:creationId xmlns:a16="http://schemas.microsoft.com/office/drawing/2014/main" id="{85006D41-6463-413F-9655-3CA2D8AB4D60}"/>
               </a:ext>
             </a:extLst>
           </p:cNvPr>
@@ -2238,7 +2238,7 @@
           <p:cNvPr id="3" name="Right column">
             <a:extLst xmlns:a="http://schemas.openxmlformats.org/drawingml/2006/main">
               <a:ext uri="{FF2B5EF4-FFF2-40B4-BE49-F238E27FC236}">
-                <a16:creationId xmlns:a16="http://schemas.microsoft.com/office/drawing/2014/main" id="{42765CE8-2DAE-4696-8F43-1B5B4C25794C}"/>
+                <a16:creationId xmlns:a16="http://schemas.microsoft.com/office/drawing/2014/main" id="{F1490181-C331-455D-A473-B8CB2D0C361C}"/>
               </a:ext>
             </a:extLst>
           </p:cNvPr>
@@ -2412,7 +2412,7 @@
           <p:cNvPr id="3" name="Title">
             <a:extLst xmlns:a="http://schemas.openxmlformats.org/drawingml/2006/main">
               <a:ext uri="{FF2B5EF4-FFF2-40B4-BE49-F238E27FC236}">
-                <a16:creationId xmlns:a16="http://schemas.microsoft.com/office/drawing/2014/main" id="{D2F4F3FA-D846-412C-BDC4-6FF0966820BC}"/>
+                <a16:creationId xmlns:a16="http://schemas.microsoft.com/office/drawing/2014/main" id="{FE14EE39-C2F3-42E0-8808-D3CFF68888FF}"/>
               </a:ext>
             </a:extLst>
           </p:cNvPr>
@@ -2569,7 +2569,7 @@
           <p:cNvPr id="2" name="Left column">
             <a:extLst xmlns:a="http://schemas.openxmlformats.org/drawingml/2006/main">
               <a:ext uri="{FF2B5EF4-FFF2-40B4-BE49-F238E27FC236}">
-                <a16:creationId xmlns:a16="http://schemas.microsoft.com/office/drawing/2014/main" id="{04045F75-F41D-4CC6-813C-BF752B192A8E}"/>
+                <a16:creationId xmlns:a16="http://schemas.microsoft.com/office/drawing/2014/main" id="{10C5825C-5C55-4152-9D77-F088319D0E46}"/>
               </a:ext>
             </a:extLst>
           </p:cNvPr>
@@ -2764,12 +2764,12 @@
   </p:cSld>
   <p:clrMap bg1="lt1" tx1="dk1" bg2="lt2" tx2="dk2" accent1="accent1" accent2="accent2" accent3="accent3" accent4="accent4" accent5="accent5" accent6="accent6" hlink="hlink" folHlink="folHlink"/>
   <p:sldLayoutIdLst>
-    <p:sldLayoutId xmlns:r="http://schemas.openxmlformats.org/officeDocument/2006/relationships" id="2147483649" r:id="Rd84cf4c612f14982"/>
-    <p:sldLayoutId xmlns:r="http://schemas.openxmlformats.org/officeDocument/2006/relationships" id="2147483650" r:id="Rb93b4aaf8dec41c2"/>
-    <p:sldLayoutId xmlns:r="http://schemas.openxmlformats.org/officeDocument/2006/relationships" id="2147483651" r:id="R4f0205588a014d37"/>
-    <p:sldLayoutId xmlns:r="http://schemas.openxmlformats.org/officeDocument/2006/relationships" id="2147483652" r:id="R06cc1f38ec6945ae"/>
-    <p:sldLayoutId xmlns:r="http://schemas.openxmlformats.org/officeDocument/2006/relationships" id="2147483653" r:id="R356d89b409834f07"/>
-    <p:sldLayoutId xmlns:r="http://schemas.openxmlformats.org/officeDocument/2006/relationships" id="2147483654" r:id="R7e354dea86b340ea"/>
+    <p:sldLayoutId xmlns:r="http://schemas.openxmlformats.org/officeDocument/2006/relationships" id="2147483649" r:id="Rce662ff308d342db"/>
+    <p:sldLayoutId xmlns:r="http://schemas.openxmlformats.org/officeDocument/2006/relationships" id="2147483650" r:id="R9023993254e94013"/>
+    <p:sldLayoutId xmlns:r="http://schemas.openxmlformats.org/officeDocument/2006/relationships" id="2147483651" r:id="R11d841e0ed534b3d"/>
+    <p:sldLayoutId xmlns:r="http://schemas.openxmlformats.org/officeDocument/2006/relationships" id="2147483652" r:id="R22af9a892e0146d5"/>
+    <p:sldLayoutId xmlns:r="http://schemas.openxmlformats.org/officeDocument/2006/relationships" id="2147483653" r:id="R4a3b18c936e54826"/>
+    <p:sldLayoutId xmlns:r="http://schemas.openxmlformats.org/officeDocument/2006/relationships" id="2147483654" r:id="Ree22d68525f94fa7"/>
   </p:sldLayoutIdLst>
   <p:txStyles>
     <p:titleStyle>
@@ -3320,7 +3320,7 @@
           <p:cNvPr id="8" name="">
             <a:extLst xmlns:a="http://schemas.openxmlformats.org/drawingml/2006/main">
               <a:ext uri="{FF2B5EF4-FFF2-40B4-BE49-F238E27FC236}">
-                <a16:creationId xmlns:a16="http://schemas.microsoft.com/office/drawing/2014/main" id="{199E1D81-E505-419A-A365-11E5C097BB0D}"/>
+                <a16:creationId xmlns:a16="http://schemas.microsoft.com/office/drawing/2014/main" id="{3987C03B-568D-4A09-AE04-4BD667B8C4AA}"/>
               </a:ext>
             </a:extLst>
           </p:cNvPr>
@@ -3378,7 +3378,7 @@
           <p:cNvPr id="2" name="">
             <a:extLst xmlns:a="http://schemas.openxmlformats.org/drawingml/2006/main">
               <a:ext uri="{FF2B5EF4-FFF2-40B4-BE49-F238E27FC236}">
-                <a16:creationId xmlns:a16="http://schemas.microsoft.com/office/drawing/2014/main" id="{EAEB58D4-D280-4EA7-89CF-2DDF26C77DF1}"/>
+                <a16:creationId xmlns:a16="http://schemas.microsoft.com/office/drawing/2014/main" id="{8C8AF614-A14B-471C-BCB2-C446D48FF49C}"/>
               </a:ext>
             </a:extLst>
           </p:cNvPr>
@@ -3436,7 +3436,7 @@
           <p:cNvPr id="3" name="">
             <a:extLst xmlns:a="http://schemas.openxmlformats.org/drawingml/2006/main">
               <a:ext uri="{FF2B5EF4-FFF2-40B4-BE49-F238E27FC236}">
-                <a16:creationId xmlns:a16="http://schemas.microsoft.com/office/drawing/2014/main" id="{1F8F932C-ADAD-4B01-A629-0AA53FA3B917}"/>
+                <a16:creationId xmlns:a16="http://schemas.microsoft.com/office/drawing/2014/main" id="{9A6C60B4-B459-4A61-98D7-15CD7F7AF009}"/>
               </a:ext>
             </a:extLst>
           </p:cNvPr>
@@ -3494,7 +3494,7 @@
           <p:cNvPr id="4" name="">
             <a:extLst xmlns:a="http://schemas.openxmlformats.org/drawingml/2006/main">
               <a:ext uri="{FF2B5EF4-FFF2-40B4-BE49-F238E27FC236}">
-                <a16:creationId xmlns:a16="http://schemas.microsoft.com/office/drawing/2014/main" id="{75A724F7-1332-4B17-ACE6-0E7E0317654B}"/>
+                <a16:creationId xmlns:a16="http://schemas.microsoft.com/office/drawing/2014/main" id="{45AE0D15-2CA3-477C-BE28-92C82A4FCA3A}"/>
               </a:ext>
             </a:extLst>
           </p:cNvPr>
@@ -3529,7 +3529,7 @@
           <p:cNvPr id="5" name="">
             <a:extLst xmlns:a="http://schemas.openxmlformats.org/drawingml/2006/main">
               <a:ext uri="{FF2B5EF4-FFF2-40B4-BE49-F238E27FC236}">
-                <a16:creationId xmlns:a16="http://schemas.microsoft.com/office/drawing/2014/main" id="{06E22811-96BE-41BF-8286-9AF9BF857997}"/>
+                <a16:creationId xmlns:a16="http://schemas.microsoft.com/office/drawing/2014/main" id="{745BD320-C2C3-4B07-842C-6C21C66D3FCD}"/>
               </a:ext>
             </a:extLst>
           </p:cNvPr>
@@ -3587,7 +3587,7 @@
           <p:cNvPr id="6" name="">
             <a:extLst xmlns:a="http://schemas.openxmlformats.org/drawingml/2006/main">
               <a:ext uri="{FF2B5EF4-FFF2-40B4-BE49-F238E27FC236}">
-                <a16:creationId xmlns:a16="http://schemas.microsoft.com/office/drawing/2014/main" id="{246E1B2E-9E80-4048-8102-66ECD8D3EA55}"/>
+                <a16:creationId xmlns:a16="http://schemas.microsoft.com/office/drawing/2014/main" id="{9AE8CED3-E03E-4163-8FCB-3B1607D83318}"/>
               </a:ext>
             </a:extLst>
           </p:cNvPr>
@@ -3740,7 +3740,7 @@
           <p:cNvPr id="7" name="">
             <a:extLst xmlns:a="http://schemas.openxmlformats.org/drawingml/2006/main">
               <a:ext uri="{FF2B5EF4-FFF2-40B4-BE49-F238E27FC236}">
-                <a16:creationId xmlns:a16="http://schemas.microsoft.com/office/drawing/2014/main" id="{0710E5AA-C02B-4BFD-8FD4-82B69E5420BF}"/>
+                <a16:creationId xmlns:a16="http://schemas.microsoft.com/office/drawing/2014/main" id="{58BF6AA8-4C4C-4B59-BD7D-F99DF94A4D24}"/>
               </a:ext>
             </a:extLst>
           </p:cNvPr>
@@ -3813,7 +3813,7 @@
     </p:spTree>
     <p:extLst>
       <p:ext uri="{BB962C8B-B14F-4D97-AF65-F5344CB8AC3E}">
-        <p14:creationId xmlns:p14="http://schemas.microsoft.com/office/powerpoint/2010/main" val="58640641"/>
+        <p14:creationId xmlns:p14="http://schemas.microsoft.com/office/powerpoint/2010/main" val="243343377"/>
       </p:ext>
     </p:extLst>
   </p:cSld>
@@ -3844,7 +3844,7 @@
           <p:cNvPr id="17" name="">
             <a:extLst xmlns:a="http://schemas.openxmlformats.org/drawingml/2006/main">
               <a:ext uri="{FF2B5EF4-FFF2-40B4-BE49-F238E27FC236}">
-                <a16:creationId xmlns:a16="http://schemas.microsoft.com/office/drawing/2014/main" id="{32346DE9-DE6C-4DF4-8709-EF7EE3B43133}"/>
+                <a16:creationId xmlns:a16="http://schemas.microsoft.com/office/drawing/2014/main" id="{D1703E61-80BF-4BAD-819B-144A224996D6}"/>
               </a:ext>
             </a:extLst>
           </p:cNvPr>
@@ -3902,7 +3902,7 @@
           <p:cNvPr id="2" name="">
             <a:extLst xmlns:a="http://schemas.openxmlformats.org/drawingml/2006/main">
               <a:ext uri="{FF2B5EF4-FFF2-40B4-BE49-F238E27FC236}">
-                <a16:creationId xmlns:a16="http://schemas.microsoft.com/office/drawing/2014/main" id="{70E658EB-8FD3-4DB0-8AD8-FA01666B4B06}"/>
+                <a16:creationId xmlns:a16="http://schemas.microsoft.com/office/drawing/2014/main" id="{E3FF9F5D-563C-48B1-AB3B-A9552C85F784}"/>
               </a:ext>
             </a:extLst>
           </p:cNvPr>
@@ -3960,7 +3960,7 @@
           <p:cNvPr id="3" name="">
             <a:extLst xmlns:a="http://schemas.openxmlformats.org/drawingml/2006/main">
               <a:ext uri="{FF2B5EF4-FFF2-40B4-BE49-F238E27FC236}">
-                <a16:creationId xmlns:a16="http://schemas.microsoft.com/office/drawing/2014/main" id="{E807F60B-FDE8-4011-9724-3E9173A3C285}"/>
+                <a16:creationId xmlns:a16="http://schemas.microsoft.com/office/drawing/2014/main" id="{5895F3FD-881B-476D-BC98-6B8892526E06}"/>
               </a:ext>
             </a:extLst>
           </p:cNvPr>
@@ -3993,7 +3993,7 @@
           <p:cNvPr id="4" name="">
             <a:extLst xmlns:a="http://schemas.openxmlformats.org/drawingml/2006/main">
               <a:ext uri="{FF2B5EF4-FFF2-40B4-BE49-F238E27FC236}">
-                <a16:creationId xmlns:a16="http://schemas.microsoft.com/office/drawing/2014/main" id="{4B522D5C-942F-40A8-8ED0-05E020DF5DE0}"/>
+                <a16:creationId xmlns:a16="http://schemas.microsoft.com/office/drawing/2014/main" id="{E11522A2-41BE-45C9-BA87-235A074C5D6B}"/>
               </a:ext>
             </a:extLst>
           </p:cNvPr>
@@ -4051,7 +4051,7 @@
           <p:cNvPr id="5" name="">
             <a:extLst xmlns:a="http://schemas.openxmlformats.org/drawingml/2006/main">
               <a:ext uri="{FF2B5EF4-FFF2-40B4-BE49-F238E27FC236}">
-                <a16:creationId xmlns:a16="http://schemas.microsoft.com/office/drawing/2014/main" id="{23391DC9-293E-48F0-A2BC-665A0A13B0BF}"/>
+                <a16:creationId xmlns:a16="http://schemas.microsoft.com/office/drawing/2014/main" id="{7F559A0B-8F08-4386-9CEB-E74797D4C2B9}"/>
               </a:ext>
             </a:extLst>
           </p:cNvPr>
@@ -4109,7 +4109,7 @@
           <p:cNvPr id="6" name="">
             <a:extLst xmlns:a="http://schemas.openxmlformats.org/drawingml/2006/main">
               <a:ext uri="{FF2B5EF4-FFF2-40B4-BE49-F238E27FC236}">
-                <a16:creationId xmlns:a16="http://schemas.microsoft.com/office/drawing/2014/main" id="{9251C792-E574-47CE-8B17-CDF9A6C1C84B}"/>
+                <a16:creationId xmlns:a16="http://schemas.microsoft.com/office/drawing/2014/main" id="{1F3CF64A-1855-4343-ADE8-529EC2E0B8EC}"/>
               </a:ext>
             </a:extLst>
           </p:cNvPr>
@@ -4167,7 +4167,7 @@
           <p:cNvPr id="7" name="">
             <a:extLst xmlns:a="http://schemas.openxmlformats.org/drawingml/2006/main">
               <a:ext uri="{FF2B5EF4-FFF2-40B4-BE49-F238E27FC236}">
-                <a16:creationId xmlns:a16="http://schemas.microsoft.com/office/drawing/2014/main" id="{A68FF28B-84DB-4636-8FE7-39F26E14C7AA}"/>
+                <a16:creationId xmlns:a16="http://schemas.microsoft.com/office/drawing/2014/main" id="{649242E2-ED11-423F-9554-6DB85324B495}"/>
               </a:ext>
             </a:extLst>
           </p:cNvPr>
@@ -4225,7 +4225,7 @@
           <p:cNvPr id="8" name="">
             <a:extLst xmlns:a="http://schemas.openxmlformats.org/drawingml/2006/main">
               <a:ext uri="{FF2B5EF4-FFF2-40B4-BE49-F238E27FC236}">
-                <a16:creationId xmlns:a16="http://schemas.microsoft.com/office/drawing/2014/main" id="{6427546A-52CC-4B9F-9D09-67F6F7DC4328}"/>
+                <a16:creationId xmlns:a16="http://schemas.microsoft.com/office/drawing/2014/main" id="{D72A8565-33C6-40C1-B008-1D979266CC5C}"/>
               </a:ext>
             </a:extLst>
           </p:cNvPr>
@@ -4260,7 +4260,7 @@
           <p:cNvPr id="9" name="">
             <a:extLst xmlns:a="http://schemas.openxmlformats.org/drawingml/2006/main">
               <a:ext uri="{FF2B5EF4-FFF2-40B4-BE49-F238E27FC236}">
-                <a16:creationId xmlns:a16="http://schemas.microsoft.com/office/drawing/2014/main" id="{C9094FAA-2662-4297-A53A-7BA456F3A638}"/>
+                <a16:creationId xmlns:a16="http://schemas.microsoft.com/office/drawing/2014/main" id="{81576BCA-C6A5-4B67-AAFA-F54D3899363E}"/>
               </a:ext>
             </a:extLst>
           </p:cNvPr>
@@ -4293,7 +4293,7 @@
           <p:cNvPr id="10" name="">
             <a:extLst xmlns:a="http://schemas.openxmlformats.org/drawingml/2006/main">
               <a:ext uri="{FF2B5EF4-FFF2-40B4-BE49-F238E27FC236}">
-                <a16:creationId xmlns:a16="http://schemas.microsoft.com/office/drawing/2014/main" id="{83E76C7E-02F7-4ABB-A9A2-54EF954EDFEC}"/>
+                <a16:creationId xmlns:a16="http://schemas.microsoft.com/office/drawing/2014/main" id="{6D682677-3239-4DE8-B789-0170BC31849E}"/>
               </a:ext>
             </a:extLst>
           </p:cNvPr>
@@ -4351,7 +4351,7 @@
           <p:cNvPr id="11" name="">
             <a:extLst xmlns:a="http://schemas.openxmlformats.org/drawingml/2006/main">
               <a:ext uri="{FF2B5EF4-FFF2-40B4-BE49-F238E27FC236}">
-                <a16:creationId xmlns:a16="http://schemas.microsoft.com/office/drawing/2014/main" id="{0A4C2006-10EC-4111-8371-32BE767AA6CA}"/>
+                <a16:creationId xmlns:a16="http://schemas.microsoft.com/office/drawing/2014/main" id="{DFF83A25-3C52-46C9-9C72-03A51821EB5F}"/>
               </a:ext>
             </a:extLst>
           </p:cNvPr>
@@ -4460,7 +4460,7 @@
           <p:cNvPr id="12" name="">
             <a:extLst xmlns:a="http://schemas.openxmlformats.org/drawingml/2006/main">
               <a:ext uri="{FF2B5EF4-FFF2-40B4-BE49-F238E27FC236}">
-                <a16:creationId xmlns:a16="http://schemas.microsoft.com/office/drawing/2014/main" id="{F306F82C-0428-44D1-895C-369E82E4FCEC}"/>
+                <a16:creationId xmlns:a16="http://schemas.microsoft.com/office/drawing/2014/main" id="{016452B7-EDDF-4804-9203-B6268F243721}"/>
               </a:ext>
             </a:extLst>
           </p:cNvPr>
@@ -4495,7 +4495,7 @@
           <p:cNvPr id="13" name="">
             <a:extLst xmlns:a="http://schemas.openxmlformats.org/drawingml/2006/main">
               <a:ext uri="{FF2B5EF4-FFF2-40B4-BE49-F238E27FC236}">
-                <a16:creationId xmlns:a16="http://schemas.microsoft.com/office/drawing/2014/main" id="{4CC4B2B2-E436-4EB4-8C5E-259C8F24427E}"/>
+                <a16:creationId xmlns:a16="http://schemas.microsoft.com/office/drawing/2014/main" id="{B2AAE692-426F-44FB-81BA-03CDB94E63B6}"/>
               </a:ext>
             </a:extLst>
           </p:cNvPr>
@@ -4528,7 +4528,7 @@
           <p:cNvPr id="14" name="">
             <a:extLst xmlns:a="http://schemas.openxmlformats.org/drawingml/2006/main">
               <a:ext uri="{FF2B5EF4-FFF2-40B4-BE49-F238E27FC236}">
-                <a16:creationId xmlns:a16="http://schemas.microsoft.com/office/drawing/2014/main" id="{FC311616-BB01-440E-8DC0-765FE244FE65}"/>
+                <a16:creationId xmlns:a16="http://schemas.microsoft.com/office/drawing/2014/main" id="{76AFC27F-A073-48CC-8D30-73731012715E}"/>
               </a:ext>
             </a:extLst>
           </p:cNvPr>
@@ -4586,7 +4586,7 @@
           <p:cNvPr id="15" name="">
             <a:extLst xmlns:a="http://schemas.openxmlformats.org/drawingml/2006/main">
               <a:ext uri="{FF2B5EF4-FFF2-40B4-BE49-F238E27FC236}">
-                <a16:creationId xmlns:a16="http://schemas.microsoft.com/office/drawing/2014/main" id="{7AEFAD8B-9FE5-4C4A-8090-55620EFEB24E}"/>
+                <a16:creationId xmlns:a16="http://schemas.microsoft.com/office/drawing/2014/main" id="{444E5E72-F195-48F1-A893-73B01A4071A0}"/>
               </a:ext>
             </a:extLst>
           </p:cNvPr>
@@ -4712,7 +4712,7 @@
           <p:cNvPr id="16" name="">
             <a:extLst xmlns:a="http://schemas.openxmlformats.org/drawingml/2006/main">
               <a:ext uri="{FF2B5EF4-FFF2-40B4-BE49-F238E27FC236}">
-                <a16:creationId xmlns:a16="http://schemas.microsoft.com/office/drawing/2014/main" id="{8C08FCB2-C018-497F-96AF-11B1C361B13C}"/>
+                <a16:creationId xmlns:a16="http://schemas.microsoft.com/office/drawing/2014/main" id="{0EE2CA44-F6DC-4EE1-8D9A-E18D1018F2DE}"/>
               </a:ext>
             </a:extLst>
           </p:cNvPr>
@@ -4768,7 +4768,7 @@
     </p:spTree>
     <p:extLst>
       <p:ext uri="{BB962C8B-B14F-4D97-AF65-F5344CB8AC3E}">
-        <p14:creationId xmlns:p14="http://schemas.microsoft.com/office/powerpoint/2010/main" val="1097273559"/>
+        <p14:creationId xmlns:p14="http://schemas.microsoft.com/office/powerpoint/2010/main" val="1352583175"/>
       </p:ext>
     </p:extLst>
   </p:cSld>
@@ -4799,7 +4799,7 @@
           <p:cNvPr id="22" name="">
             <a:extLst xmlns:a="http://schemas.openxmlformats.org/drawingml/2006/main">
               <a:ext uri="{FF2B5EF4-FFF2-40B4-BE49-F238E27FC236}">
-                <a16:creationId xmlns:a16="http://schemas.microsoft.com/office/drawing/2014/main" id="{62FE14EB-5660-43DD-9243-627C9826AD76}"/>
+                <a16:creationId xmlns:a16="http://schemas.microsoft.com/office/drawing/2014/main" id="{7E41AD39-0C80-4C82-B82F-75B251F162DA}"/>
               </a:ext>
             </a:extLst>
           </p:cNvPr>
@@ -4857,7 +4857,7 @@
           <p:cNvPr id="2" name="">
             <a:extLst xmlns:a="http://schemas.openxmlformats.org/drawingml/2006/main">
               <a:ext uri="{FF2B5EF4-FFF2-40B4-BE49-F238E27FC236}">
-                <a16:creationId xmlns:a16="http://schemas.microsoft.com/office/drawing/2014/main" id="{5B5C636B-AB02-4C13-AAB9-3C1B138399ED}"/>
+                <a16:creationId xmlns:a16="http://schemas.microsoft.com/office/drawing/2014/main" id="{2F474BE7-1DDD-4DD0-9124-0EEE714FA9CE}"/>
               </a:ext>
             </a:extLst>
           </p:cNvPr>
@@ -4915,7 +4915,7 @@
           <p:cNvPr id="3" name="">
             <a:extLst xmlns:a="http://schemas.openxmlformats.org/drawingml/2006/main">
               <a:ext uri="{FF2B5EF4-FFF2-40B4-BE49-F238E27FC236}">
-                <a16:creationId xmlns:a16="http://schemas.microsoft.com/office/drawing/2014/main" id="{0729872A-F59F-4841-80A9-02BD42F73637}"/>
+                <a16:creationId xmlns:a16="http://schemas.microsoft.com/office/drawing/2014/main" id="{C67BFD60-87EA-4C05-9332-6D0BEDA1A6D3}"/>
               </a:ext>
             </a:extLst>
           </p:cNvPr>
@@ -4948,7 +4948,7 @@
           <p:cNvPr id="4" name="">
             <a:extLst xmlns:a="http://schemas.openxmlformats.org/drawingml/2006/main">
               <a:ext uri="{FF2B5EF4-FFF2-40B4-BE49-F238E27FC236}">
-                <a16:creationId xmlns:a16="http://schemas.microsoft.com/office/drawing/2014/main" id="{E2F9043A-6CF7-499B-86A9-6CED8474BB0F}"/>
+                <a16:creationId xmlns:a16="http://schemas.microsoft.com/office/drawing/2014/main" id="{15A84123-90DF-48CD-B2AF-9139E2E11F52}"/>
               </a:ext>
             </a:extLst>
           </p:cNvPr>
@@ -5006,7 +5006,7 @@
           <p:cNvPr id="5" name="">
             <a:extLst xmlns:a="http://schemas.openxmlformats.org/drawingml/2006/main">
               <a:ext uri="{FF2B5EF4-FFF2-40B4-BE49-F238E27FC236}">
-                <a16:creationId xmlns:a16="http://schemas.microsoft.com/office/drawing/2014/main" id="{48F35454-4F20-4A24-A12C-9CF7A58A3D70}"/>
+                <a16:creationId xmlns:a16="http://schemas.microsoft.com/office/drawing/2014/main" id="{9105E219-2EFB-40A3-863F-98E047E4F5BC}"/>
               </a:ext>
             </a:extLst>
           </p:cNvPr>
@@ -5064,7 +5064,7 @@
           <p:cNvPr id="6" name="">
             <a:extLst xmlns:a="http://schemas.openxmlformats.org/drawingml/2006/main">
               <a:ext uri="{FF2B5EF4-FFF2-40B4-BE49-F238E27FC236}">
-                <a16:creationId xmlns:a16="http://schemas.microsoft.com/office/drawing/2014/main" id="{A4A4294F-B930-4EAC-9EF1-6D94E5286035}"/>
+                <a16:creationId xmlns:a16="http://schemas.microsoft.com/office/drawing/2014/main" id="{34C5D217-CF17-4047-AC53-09B11127A796}"/>
               </a:ext>
             </a:extLst>
           </p:cNvPr>
@@ -5099,7 +5099,7 @@
           <p:cNvPr id="7" name="">
             <a:extLst xmlns:a="http://schemas.openxmlformats.org/drawingml/2006/main">
               <a:ext uri="{FF2B5EF4-FFF2-40B4-BE49-F238E27FC236}">
-                <a16:creationId xmlns:a16="http://schemas.microsoft.com/office/drawing/2014/main" id="{3DC0F169-4F72-44FC-B1B3-6BF7BC2DB538}"/>
+                <a16:creationId xmlns:a16="http://schemas.microsoft.com/office/drawing/2014/main" id="{D7B82861-1A75-48BC-BBD7-875BC8FC8958}"/>
               </a:ext>
             </a:extLst>
           </p:cNvPr>
@@ -5132,7 +5132,7 @@
           <p:cNvPr id="8" name="">
             <a:extLst xmlns:a="http://schemas.openxmlformats.org/drawingml/2006/main">
               <a:ext uri="{FF2B5EF4-FFF2-40B4-BE49-F238E27FC236}">
-                <a16:creationId xmlns:a16="http://schemas.microsoft.com/office/drawing/2014/main" id="{45CCB36A-B9CB-4956-B768-30D0289B5A9F}"/>
+                <a16:creationId xmlns:a16="http://schemas.microsoft.com/office/drawing/2014/main" id="{EDD991A2-66B4-41D0-B427-1981F2BDCB96}"/>
               </a:ext>
             </a:extLst>
           </p:cNvPr>
@@ -5190,7 +5190,7 @@
           <p:cNvPr id="9" name="">
             <a:extLst xmlns:a="http://schemas.openxmlformats.org/drawingml/2006/main">
               <a:ext uri="{FF2B5EF4-FFF2-40B4-BE49-F238E27FC236}">
-                <a16:creationId xmlns:a16="http://schemas.microsoft.com/office/drawing/2014/main" id="{A872C8CC-7BFA-4AE9-A83C-7D0734FF9146}"/>
+                <a16:creationId xmlns:a16="http://schemas.microsoft.com/office/drawing/2014/main" id="{001E32D4-B19E-4CF6-869E-74827679697C}"/>
               </a:ext>
             </a:extLst>
           </p:cNvPr>
@@ -5248,7 +5248,7 @@
           <p:cNvPr id="10" name="">
             <a:extLst xmlns:a="http://schemas.openxmlformats.org/drawingml/2006/main">
               <a:ext uri="{FF2B5EF4-FFF2-40B4-BE49-F238E27FC236}">
-                <a16:creationId xmlns:a16="http://schemas.microsoft.com/office/drawing/2014/main" id="{458A155C-8D1D-4557-B92D-CABB4E9DD2E2}"/>
+                <a16:creationId xmlns:a16="http://schemas.microsoft.com/office/drawing/2014/main" id="{EFA3C8BD-24B9-4408-B999-2C4B77BD32B6}"/>
               </a:ext>
             </a:extLst>
           </p:cNvPr>
@@ -5283,7 +5283,7 @@
           <p:cNvPr id="11" name="">
             <a:extLst xmlns:a="http://schemas.openxmlformats.org/drawingml/2006/main">
               <a:ext uri="{FF2B5EF4-FFF2-40B4-BE49-F238E27FC236}">
-                <a16:creationId xmlns:a16="http://schemas.microsoft.com/office/drawing/2014/main" id="{28736FBE-3F92-4221-9015-D73A6CEA533B}"/>
+                <a16:creationId xmlns:a16="http://schemas.microsoft.com/office/drawing/2014/main" id="{BC7F9AFB-434A-48AB-9073-9C4C8F4CEDEA}"/>
               </a:ext>
             </a:extLst>
           </p:cNvPr>
@@ -5316,7 +5316,7 @@
           <p:cNvPr id="12" name="">
             <a:extLst xmlns:a="http://schemas.openxmlformats.org/drawingml/2006/main">
               <a:ext uri="{FF2B5EF4-FFF2-40B4-BE49-F238E27FC236}">
-                <a16:creationId xmlns:a16="http://schemas.microsoft.com/office/drawing/2014/main" id="{77968602-46C5-4D12-B5F4-7061A6302AFC}"/>
+                <a16:creationId xmlns:a16="http://schemas.microsoft.com/office/drawing/2014/main" id="{9DEAD6C4-14AE-4844-8099-EB44E40970BF}"/>
               </a:ext>
             </a:extLst>
           </p:cNvPr>
@@ -5374,7 +5374,7 @@
           <p:cNvPr id="13" name="">
             <a:extLst xmlns:a="http://schemas.openxmlformats.org/drawingml/2006/main">
               <a:ext uri="{FF2B5EF4-FFF2-40B4-BE49-F238E27FC236}">
-                <a16:creationId xmlns:a16="http://schemas.microsoft.com/office/drawing/2014/main" id="{12A1B2CA-9A6D-4EFA-B52A-7AE566A52AB7}"/>
+                <a16:creationId xmlns:a16="http://schemas.microsoft.com/office/drawing/2014/main" id="{443DE1C6-D693-4FC4-BE6E-395630094388}"/>
               </a:ext>
             </a:extLst>
           </p:cNvPr>
@@ -5432,7 +5432,7 @@
           <p:cNvPr id="14" name="">
             <a:extLst xmlns:a="http://schemas.openxmlformats.org/drawingml/2006/main">
               <a:ext uri="{FF2B5EF4-FFF2-40B4-BE49-F238E27FC236}">
-                <a16:creationId xmlns:a16="http://schemas.microsoft.com/office/drawing/2014/main" id="{BAE4F6CC-F83D-44D4-A5D4-4E1CE29A3AED}"/>
+                <a16:creationId xmlns:a16="http://schemas.microsoft.com/office/drawing/2014/main" id="{00D6A2E7-006B-4073-B215-B06A80D3B932}"/>
               </a:ext>
             </a:extLst>
           </p:cNvPr>
@@ -5467,7 +5467,7 @@
           <p:cNvPr id="15" name="">
             <a:extLst xmlns:a="http://schemas.openxmlformats.org/drawingml/2006/main">
               <a:ext uri="{FF2B5EF4-FFF2-40B4-BE49-F238E27FC236}">
-                <a16:creationId xmlns:a16="http://schemas.microsoft.com/office/drawing/2014/main" id="{36FF5009-869B-4334-96CA-622C235F5E3E}"/>
+                <a16:creationId xmlns:a16="http://schemas.microsoft.com/office/drawing/2014/main" id="{75199286-508E-455D-9648-82DE45F57133}"/>
               </a:ext>
             </a:extLst>
           </p:cNvPr>
@@ -5500,7 +5500,7 @@
           <p:cNvPr id="16" name="">
             <a:extLst xmlns:a="http://schemas.openxmlformats.org/drawingml/2006/main">
               <a:ext uri="{FF2B5EF4-FFF2-40B4-BE49-F238E27FC236}">
-                <a16:creationId xmlns:a16="http://schemas.microsoft.com/office/drawing/2014/main" id="{68D62673-6AA7-4215-864F-7C608141D057}"/>
+                <a16:creationId xmlns:a16="http://schemas.microsoft.com/office/drawing/2014/main" id="{2A8D5327-8901-45F3-8694-AFD28436B7D9}"/>
               </a:ext>
             </a:extLst>
           </p:cNvPr>
@@ -5558,7 +5558,7 @@
           <p:cNvPr id="17" name="">
             <a:extLst xmlns:a="http://schemas.openxmlformats.org/drawingml/2006/main">
               <a:ext uri="{FF2B5EF4-FFF2-40B4-BE49-F238E27FC236}">
-                <a16:creationId xmlns:a16="http://schemas.microsoft.com/office/drawing/2014/main" id="{43D6F1B7-81B7-4019-8759-B3DE471D76ED}"/>
+                <a16:creationId xmlns:a16="http://schemas.microsoft.com/office/drawing/2014/main" id="{C063CB57-AB4D-4765-AA6F-2B668373A314}"/>
               </a:ext>
             </a:extLst>
           </p:cNvPr>
@@ -5616,7 +5616,7 @@
           <p:cNvPr id="18" name="">
             <a:extLst xmlns:a="http://schemas.openxmlformats.org/drawingml/2006/main">
               <a:ext uri="{FF2B5EF4-FFF2-40B4-BE49-F238E27FC236}">
-                <a16:creationId xmlns:a16="http://schemas.microsoft.com/office/drawing/2014/main" id="{35E4D7E6-F474-434F-9F74-B584BEFC30BC}"/>
+                <a16:creationId xmlns:a16="http://schemas.microsoft.com/office/drawing/2014/main" id="{F40875B0-4D1D-4AEF-B7B8-1CADF013A037}"/>
               </a:ext>
             </a:extLst>
           </p:cNvPr>
@@ -5674,7 +5674,7 @@
           <p:cNvPr id="19" name="">
             <a:extLst xmlns:a="http://schemas.openxmlformats.org/drawingml/2006/main">
               <a:ext uri="{FF2B5EF4-FFF2-40B4-BE49-F238E27FC236}">
-                <a16:creationId xmlns:a16="http://schemas.microsoft.com/office/drawing/2014/main" id="{264DCDB4-8261-4B0B-A8FB-1EE855B6E381}"/>
+                <a16:creationId xmlns:a16="http://schemas.microsoft.com/office/drawing/2014/main" id="{931EAA3A-9FDD-43F8-A03D-6BB24D269B17}"/>
               </a:ext>
             </a:extLst>
           </p:cNvPr>
@@ -5709,7 +5709,7 @@
           <p:cNvPr id="20" name="">
             <a:extLst xmlns:a="http://schemas.openxmlformats.org/drawingml/2006/main">
               <a:ext uri="{FF2B5EF4-FFF2-40B4-BE49-F238E27FC236}">
-                <a16:creationId xmlns:a16="http://schemas.microsoft.com/office/drawing/2014/main" id="{AA1178C0-635A-43A6-8775-2320D6807CF5}"/>
+                <a16:creationId xmlns:a16="http://schemas.microsoft.com/office/drawing/2014/main" id="{F9580B28-A5F6-4AF1-A98B-10E9F3D70775}"/>
               </a:ext>
             </a:extLst>
           </p:cNvPr>
@@ -5767,7 +5767,7 @@
           <p:cNvPr id="21" name="">
             <a:extLst xmlns:a="http://schemas.openxmlformats.org/drawingml/2006/main">
               <a:ext uri="{FF2B5EF4-FFF2-40B4-BE49-F238E27FC236}">
-                <a16:creationId xmlns:a16="http://schemas.microsoft.com/office/drawing/2014/main" id="{9F5A2BAD-A0B4-4A7B-B1CA-96468065224D}"/>
+                <a16:creationId xmlns:a16="http://schemas.microsoft.com/office/drawing/2014/main" id="{A45B684C-6435-48A8-A8BC-A6AAF4B8D264}"/>
               </a:ext>
             </a:extLst>
           </p:cNvPr>
@@ -5823,7 +5823,7 @@
     </p:spTree>
     <p:extLst>
       <p:ext uri="{BB962C8B-B14F-4D97-AF65-F5344CB8AC3E}">
-        <p14:creationId xmlns:p14="http://schemas.microsoft.com/office/powerpoint/2010/main" val="1983680666"/>
+        <p14:creationId xmlns:p14="http://schemas.microsoft.com/office/powerpoint/2010/main" val="1293887237"/>
       </p:ext>
     </p:extLst>
   </p:cSld>
@@ -5854,7 +5854,7 @@
           <p:cNvPr id="36" name="">
             <a:extLst xmlns:a="http://schemas.openxmlformats.org/drawingml/2006/main">
               <a:ext uri="{FF2B5EF4-FFF2-40B4-BE49-F238E27FC236}">
-                <a16:creationId xmlns:a16="http://schemas.microsoft.com/office/drawing/2014/main" id="{094A1660-7BA5-4E6B-BAED-4D47ED1DDE36}"/>
+                <a16:creationId xmlns:a16="http://schemas.microsoft.com/office/drawing/2014/main" id="{E1A20B6B-5284-4552-A810-739C3ED11E86}"/>
               </a:ext>
             </a:extLst>
           </p:cNvPr>
@@ -5912,7 +5912,7 @@
           <p:cNvPr id="2" name="">
             <a:extLst xmlns:a="http://schemas.openxmlformats.org/drawingml/2006/main">
               <a:ext uri="{FF2B5EF4-FFF2-40B4-BE49-F238E27FC236}">
-                <a16:creationId xmlns:a16="http://schemas.microsoft.com/office/drawing/2014/main" id="{DBB1F74C-3087-4452-9177-10BDBF2C2E5E}"/>
+                <a16:creationId xmlns:a16="http://schemas.microsoft.com/office/drawing/2014/main" id="{28A1B94C-05C4-4A97-9A7B-41095EF2D2E0}"/>
               </a:ext>
             </a:extLst>
           </p:cNvPr>
@@ -5970,7 +5970,7 @@
           <p:cNvPr id="3" name="">
             <a:extLst xmlns:a="http://schemas.openxmlformats.org/drawingml/2006/main">
               <a:ext uri="{FF2B5EF4-FFF2-40B4-BE49-F238E27FC236}">
-                <a16:creationId xmlns:a16="http://schemas.microsoft.com/office/drawing/2014/main" id="{2B38DF56-81FA-4DF7-9577-4EAD09FE7D9E}"/>
+                <a16:creationId xmlns:a16="http://schemas.microsoft.com/office/drawing/2014/main" id="{472981BC-0BDD-4DEA-9F5B-6EBEC7EDEF58}"/>
               </a:ext>
             </a:extLst>
           </p:cNvPr>
@@ -6003,7 +6003,7 @@
           <p:cNvPr id="4" name="">
             <a:extLst xmlns:a="http://schemas.openxmlformats.org/drawingml/2006/main">
               <a:ext uri="{FF2B5EF4-FFF2-40B4-BE49-F238E27FC236}">
-                <a16:creationId xmlns:a16="http://schemas.microsoft.com/office/drawing/2014/main" id="{6CF4CA63-6D47-460D-9D41-339BDAEE3A93}"/>
+                <a16:creationId xmlns:a16="http://schemas.microsoft.com/office/drawing/2014/main" id="{88673F7C-2C91-4865-8A58-8E775525977B}"/>
               </a:ext>
             </a:extLst>
           </p:cNvPr>
@@ -6061,7 +6061,7 @@
           <p:cNvPr id="5" name="">
             <a:extLst xmlns:a="http://schemas.openxmlformats.org/drawingml/2006/main">
               <a:ext uri="{FF2B5EF4-FFF2-40B4-BE49-F238E27FC236}">
-                <a16:creationId xmlns:a16="http://schemas.microsoft.com/office/drawing/2014/main" id="{4DC54F4E-F2C1-43B5-A04D-EDF84AD36E39}"/>
+                <a16:creationId xmlns:a16="http://schemas.microsoft.com/office/drawing/2014/main" id="{EBA217EC-E718-4E50-BBA8-BA5508F940E7}"/>
               </a:ext>
             </a:extLst>
           </p:cNvPr>
@@ -6119,7 +6119,7 @@
           <p:cNvPr id="6" name="">
             <a:extLst xmlns:a="http://schemas.openxmlformats.org/drawingml/2006/main">
               <a:ext uri="{FF2B5EF4-FFF2-40B4-BE49-F238E27FC236}">
-                <a16:creationId xmlns:a16="http://schemas.microsoft.com/office/drawing/2014/main" id="{3A1EFDEF-3662-40F8-988C-76EEE8FAEA62}"/>
+                <a16:creationId xmlns:a16="http://schemas.microsoft.com/office/drawing/2014/main" id="{B248FABA-4AC6-4BD3-81CC-EB5FF295D7AF}"/>
               </a:ext>
             </a:extLst>
           </p:cNvPr>
@@ -6154,7 +6154,7 @@
           <p:cNvPr id="7" name="">
             <a:extLst xmlns:a="http://schemas.openxmlformats.org/drawingml/2006/main">
               <a:ext uri="{FF2B5EF4-FFF2-40B4-BE49-F238E27FC236}">
-                <a16:creationId xmlns:a16="http://schemas.microsoft.com/office/drawing/2014/main" id="{36AD78FF-2B12-40E6-A01B-6BE2578B8AF3}"/>
+                <a16:creationId xmlns:a16="http://schemas.microsoft.com/office/drawing/2014/main" id="{61D892F5-239C-4064-9036-89A6FF6108F6}"/>
               </a:ext>
             </a:extLst>
           </p:cNvPr>
@@ -6212,7 +6212,7 @@
           <p:cNvPr id="8" name="">
             <a:extLst xmlns:a="http://schemas.openxmlformats.org/drawingml/2006/main">
               <a:ext uri="{FF2B5EF4-FFF2-40B4-BE49-F238E27FC236}">
-                <a16:creationId xmlns:a16="http://schemas.microsoft.com/office/drawing/2014/main" id="{D850F610-630D-4536-BE97-FC963168AC3C}"/>
+                <a16:creationId xmlns:a16="http://schemas.microsoft.com/office/drawing/2014/main" id="{3CFE9B3E-42D1-4E6E-BDE7-19CA15816620}"/>
               </a:ext>
             </a:extLst>
           </p:cNvPr>
@@ -6243,7 +6243,7 @@
           <p:cNvPr id="9" name="">
             <a:extLst xmlns:a="http://schemas.openxmlformats.org/drawingml/2006/main">
               <a:ext uri="{FF2B5EF4-FFF2-40B4-BE49-F238E27FC236}">
-                <a16:creationId xmlns:a16="http://schemas.microsoft.com/office/drawing/2014/main" id="{C9A7B50D-2281-4F3C-9BA6-F8BB58088060}"/>
+                <a16:creationId xmlns:a16="http://schemas.microsoft.com/office/drawing/2014/main" id="{485CCC89-AEBE-4AE6-8398-C7E7A394F4C8}"/>
               </a:ext>
             </a:extLst>
           </p:cNvPr>
@@ -6301,7 +6301,7 @@
           <p:cNvPr id="10" name="">
             <a:extLst xmlns:a="http://schemas.openxmlformats.org/drawingml/2006/main">
               <a:ext uri="{FF2B5EF4-FFF2-40B4-BE49-F238E27FC236}">
-                <a16:creationId xmlns:a16="http://schemas.microsoft.com/office/drawing/2014/main" id="{093F1E44-7747-4135-8C0F-F1CAE9C074D4}"/>
+                <a16:creationId xmlns:a16="http://schemas.microsoft.com/office/drawing/2014/main" id="{865980DD-A5C3-41D4-AC5B-56E5F2C24609}"/>
               </a:ext>
             </a:extLst>
           </p:cNvPr>
@@ -6359,7 +6359,7 @@
           <p:cNvPr id="11" name="">
             <a:extLst xmlns:a="http://schemas.openxmlformats.org/drawingml/2006/main">
               <a:ext uri="{FF2B5EF4-FFF2-40B4-BE49-F238E27FC236}">
-                <a16:creationId xmlns:a16="http://schemas.microsoft.com/office/drawing/2014/main" id="{368344CE-6727-49FC-AC2E-6F2FA7B84D43}"/>
+                <a16:creationId xmlns:a16="http://schemas.microsoft.com/office/drawing/2014/main" id="{6AED3527-CD4B-4A60-859A-899393C36292}"/>
               </a:ext>
             </a:extLst>
           </p:cNvPr>
@@ -6417,7 +6417,7 @@
           <p:cNvPr id="12" name="">
             <a:extLst xmlns:a="http://schemas.openxmlformats.org/drawingml/2006/main">
               <a:ext uri="{FF2B5EF4-FFF2-40B4-BE49-F238E27FC236}">
-                <a16:creationId xmlns:a16="http://schemas.microsoft.com/office/drawing/2014/main" id="{467EE909-43A1-4B4E-8529-F57B3339CFDC}"/>
+                <a16:creationId xmlns:a16="http://schemas.microsoft.com/office/drawing/2014/main" id="{1C50F6E9-24E7-4AB8-A579-7AFAD38E8866}"/>
               </a:ext>
             </a:extLst>
           </p:cNvPr>
@@ -6452,7 +6452,7 @@
           <p:cNvPr id="13" name="">
             <a:extLst xmlns:a="http://schemas.openxmlformats.org/drawingml/2006/main">
               <a:ext uri="{FF2B5EF4-FFF2-40B4-BE49-F238E27FC236}">
-                <a16:creationId xmlns:a16="http://schemas.microsoft.com/office/drawing/2014/main" id="{4F074EA4-3844-4E37-B7B0-FB4702441FB0}"/>
+                <a16:creationId xmlns:a16="http://schemas.microsoft.com/office/drawing/2014/main" id="{ACCC35FB-7F17-441E-B04A-D508E773C303}"/>
               </a:ext>
             </a:extLst>
           </p:cNvPr>
@@ -6510,7 +6510,7 @@
           <p:cNvPr id="14" name="">
             <a:extLst xmlns:a="http://schemas.openxmlformats.org/drawingml/2006/main">
               <a:ext uri="{FF2B5EF4-FFF2-40B4-BE49-F238E27FC236}">
-                <a16:creationId xmlns:a16="http://schemas.microsoft.com/office/drawing/2014/main" id="{EE99528F-0C3D-4A7D-B294-2254F7C9A719}"/>
+                <a16:creationId xmlns:a16="http://schemas.microsoft.com/office/drawing/2014/main" id="{999D7897-79A8-4308-A325-79316059E8AC}"/>
               </a:ext>
             </a:extLst>
           </p:cNvPr>
@@ -6541,7 +6541,7 @@
           <p:cNvPr id="15" name="">
             <a:extLst xmlns:a="http://schemas.openxmlformats.org/drawingml/2006/main">
               <a:ext uri="{FF2B5EF4-FFF2-40B4-BE49-F238E27FC236}">
-                <a16:creationId xmlns:a16="http://schemas.microsoft.com/office/drawing/2014/main" id="{D7AFCA8F-8F50-428B-A4E5-C34DB1CD19DB}"/>
+                <a16:creationId xmlns:a16="http://schemas.microsoft.com/office/drawing/2014/main" id="{168E1129-649C-407D-A11C-55EF289394EF}"/>
               </a:ext>
             </a:extLst>
           </p:cNvPr>
@@ -6599,7 +6599,7 @@
           <p:cNvPr id="16" name="">
             <a:extLst xmlns:a="http://schemas.openxmlformats.org/drawingml/2006/main">
               <a:ext uri="{FF2B5EF4-FFF2-40B4-BE49-F238E27FC236}">
-                <a16:creationId xmlns:a16="http://schemas.microsoft.com/office/drawing/2014/main" id="{5810CA8D-A758-4540-8BF8-386514459F9E}"/>
+                <a16:creationId xmlns:a16="http://schemas.microsoft.com/office/drawing/2014/main" id="{3928CB73-BFDB-48BF-B693-7E91F18BB3A9}"/>
               </a:ext>
             </a:extLst>
           </p:cNvPr>
@@ -6657,7 +6657,7 @@
           <p:cNvPr id="17" name="">
             <a:extLst xmlns:a="http://schemas.openxmlformats.org/drawingml/2006/main">
               <a:ext uri="{FF2B5EF4-FFF2-40B4-BE49-F238E27FC236}">
-                <a16:creationId xmlns:a16="http://schemas.microsoft.com/office/drawing/2014/main" id="{931558AD-2DD3-487E-8810-CF4B9B55A277}"/>
+                <a16:creationId xmlns:a16="http://schemas.microsoft.com/office/drawing/2014/main" id="{51DB0CDD-FFA5-4112-A54D-6B6635793BF0}"/>
               </a:ext>
             </a:extLst>
           </p:cNvPr>
@@ -6715,7 +6715,7 @@
           <p:cNvPr id="18" name="">
             <a:extLst xmlns:a="http://schemas.openxmlformats.org/drawingml/2006/main">
               <a:ext uri="{FF2B5EF4-FFF2-40B4-BE49-F238E27FC236}">
-                <a16:creationId xmlns:a16="http://schemas.microsoft.com/office/drawing/2014/main" id="{9A715C3D-ABA8-4CC2-8AC3-59FB74142CEB}"/>
+                <a16:creationId xmlns:a16="http://schemas.microsoft.com/office/drawing/2014/main" id="{0CD1A792-D2E5-4959-94E2-5330BF53404E}"/>
               </a:ext>
             </a:extLst>
           </p:cNvPr>
@@ -6750,7 +6750,7 @@
           <p:cNvPr id="19" name="">
             <a:extLst xmlns:a="http://schemas.openxmlformats.org/drawingml/2006/main">
               <a:ext uri="{FF2B5EF4-FFF2-40B4-BE49-F238E27FC236}">
-                <a16:creationId xmlns:a16="http://schemas.microsoft.com/office/drawing/2014/main" id="{FCF4A08F-A4AA-4492-94FA-E78E3A7534FA}"/>
+                <a16:creationId xmlns:a16="http://schemas.microsoft.com/office/drawing/2014/main" id="{EECCBA16-E9EF-43C2-8B6B-69DCB98707F1}"/>
               </a:ext>
             </a:extLst>
           </p:cNvPr>
@@ -6808,7 +6808,7 @@
           <p:cNvPr id="20" name="">
             <a:extLst xmlns:a="http://schemas.openxmlformats.org/drawingml/2006/main">
               <a:ext uri="{FF2B5EF4-FFF2-40B4-BE49-F238E27FC236}">
-                <a16:creationId xmlns:a16="http://schemas.microsoft.com/office/drawing/2014/main" id="{DE48C606-C0FA-48CA-8EC1-92F87050B730}"/>
+                <a16:creationId xmlns:a16="http://schemas.microsoft.com/office/drawing/2014/main" id="{62475683-CE05-48D7-AE9A-E64843A3E91E}"/>
               </a:ext>
             </a:extLst>
           </p:cNvPr>
@@ -6839,7 +6839,7 @@
           <p:cNvPr id="21" name="">
             <a:extLst xmlns:a="http://schemas.openxmlformats.org/drawingml/2006/main">
               <a:ext uri="{FF2B5EF4-FFF2-40B4-BE49-F238E27FC236}">
-                <a16:creationId xmlns:a16="http://schemas.microsoft.com/office/drawing/2014/main" id="{41F323FC-3828-4744-BF26-B86C0483C7E5}"/>
+                <a16:creationId xmlns:a16="http://schemas.microsoft.com/office/drawing/2014/main" id="{0B78D946-78DB-4038-A74D-7D508DAD6CCF}"/>
               </a:ext>
             </a:extLst>
           </p:cNvPr>
@@ -6897,7 +6897,7 @@
           <p:cNvPr id="22" name="">
             <a:extLst xmlns:a="http://schemas.openxmlformats.org/drawingml/2006/main">
               <a:ext uri="{FF2B5EF4-FFF2-40B4-BE49-F238E27FC236}">
-                <a16:creationId xmlns:a16="http://schemas.microsoft.com/office/drawing/2014/main" id="{D2236BAB-F1FD-49AB-8458-1C04BD89E0E9}"/>
+                <a16:creationId xmlns:a16="http://schemas.microsoft.com/office/drawing/2014/main" id="{A765B0D7-7408-4478-ABFC-81F1AF551E36}"/>
               </a:ext>
             </a:extLst>
           </p:cNvPr>
@@ -6955,7 +6955,7 @@
           <p:cNvPr id="23" name="">
             <a:extLst xmlns:a="http://schemas.openxmlformats.org/drawingml/2006/main">
               <a:ext uri="{FF2B5EF4-FFF2-40B4-BE49-F238E27FC236}">
-                <a16:creationId xmlns:a16="http://schemas.microsoft.com/office/drawing/2014/main" id="{D6FC3F15-5448-41AD-9F04-6F2D3F624CA7}"/>
+                <a16:creationId xmlns:a16="http://schemas.microsoft.com/office/drawing/2014/main" id="{06B5C546-475D-4283-80B9-E684453A22AE}"/>
               </a:ext>
             </a:extLst>
           </p:cNvPr>
@@ -7013,7 +7013,7 @@
           <p:cNvPr id="24" name="">
             <a:extLst xmlns:a="http://schemas.openxmlformats.org/drawingml/2006/main">
               <a:ext uri="{FF2B5EF4-FFF2-40B4-BE49-F238E27FC236}">
-                <a16:creationId xmlns:a16="http://schemas.microsoft.com/office/drawing/2014/main" id="{55FC3DCF-C899-4004-B6DB-8C16277664E5}"/>
+                <a16:creationId xmlns:a16="http://schemas.microsoft.com/office/drawing/2014/main" id="{CB2BC4B6-90EE-4417-9943-39625023521C}"/>
               </a:ext>
             </a:extLst>
           </p:cNvPr>
@@ -7048,7 +7048,7 @@
           <p:cNvPr id="25" name="">
             <a:extLst xmlns:a="http://schemas.openxmlformats.org/drawingml/2006/main">
               <a:ext uri="{FF2B5EF4-FFF2-40B4-BE49-F238E27FC236}">
-                <a16:creationId xmlns:a16="http://schemas.microsoft.com/office/drawing/2014/main" id="{54B50362-7806-4DD7-AD73-DF7ED3575ACD}"/>
+                <a16:creationId xmlns:a16="http://schemas.microsoft.com/office/drawing/2014/main" id="{042D8358-C0E3-4996-839C-EC2C9D46DAE9}"/>
               </a:ext>
             </a:extLst>
           </p:cNvPr>
@@ -7106,7 +7106,7 @@
           <p:cNvPr id="26" name="">
             <a:extLst xmlns:a="http://schemas.openxmlformats.org/drawingml/2006/main">
               <a:ext uri="{FF2B5EF4-FFF2-40B4-BE49-F238E27FC236}">
-                <a16:creationId xmlns:a16="http://schemas.microsoft.com/office/drawing/2014/main" id="{3F02DD53-538A-466E-87A9-679D249C6BC8}"/>
+                <a16:creationId xmlns:a16="http://schemas.microsoft.com/office/drawing/2014/main" id="{15D1F787-A0A4-4CCD-A31C-972CC91CE770}"/>
               </a:ext>
             </a:extLst>
           </p:cNvPr>
@@ -7137,7 +7137,7 @@
           <p:cNvPr id="27" name="">
             <a:extLst xmlns:a="http://schemas.openxmlformats.org/drawingml/2006/main">
               <a:ext uri="{FF2B5EF4-FFF2-40B4-BE49-F238E27FC236}">
-                <a16:creationId xmlns:a16="http://schemas.microsoft.com/office/drawing/2014/main" id="{358E95F6-961E-4658-AA14-D290A18749A1}"/>
+                <a16:creationId xmlns:a16="http://schemas.microsoft.com/office/drawing/2014/main" id="{C837C9CB-D7A5-41B8-9565-A0B3C51C9B3A}"/>
               </a:ext>
             </a:extLst>
           </p:cNvPr>
@@ -7195,7 +7195,7 @@
           <p:cNvPr id="28" name="">
             <a:extLst xmlns:a="http://schemas.openxmlformats.org/drawingml/2006/main">
               <a:ext uri="{FF2B5EF4-FFF2-40B4-BE49-F238E27FC236}">
-                <a16:creationId xmlns:a16="http://schemas.microsoft.com/office/drawing/2014/main" id="{733E8E6B-7B58-42AA-A61C-8E5F1D7B9946}"/>
+                <a16:creationId xmlns:a16="http://schemas.microsoft.com/office/drawing/2014/main" id="{FA388B30-B13D-4AD1-81B1-EC8D2EBD3EDC}"/>
               </a:ext>
             </a:extLst>
           </p:cNvPr>
@@ -7253,7 +7253,7 @@
           <p:cNvPr id="29" name="">
             <a:extLst xmlns:a="http://schemas.openxmlformats.org/drawingml/2006/main">
               <a:ext uri="{FF2B5EF4-FFF2-40B4-BE49-F238E27FC236}">
-                <a16:creationId xmlns:a16="http://schemas.microsoft.com/office/drawing/2014/main" id="{9D209F91-E767-4286-86AF-FE97F5B9E5ED}"/>
+                <a16:creationId xmlns:a16="http://schemas.microsoft.com/office/drawing/2014/main" id="{6F8C8A98-4E9F-4FBD-AF4C-F11036B49F4D}"/>
               </a:ext>
             </a:extLst>
           </p:cNvPr>
@@ -7311,7 +7311,7 @@
           <p:cNvPr id="30" name="">
             <a:extLst xmlns:a="http://schemas.openxmlformats.org/drawingml/2006/main">
               <a:ext uri="{FF2B5EF4-FFF2-40B4-BE49-F238E27FC236}">
-                <a16:creationId xmlns:a16="http://schemas.microsoft.com/office/drawing/2014/main" id="{0FB1E7B7-0C4C-4520-9102-57C2C3573CCC}"/>
+                <a16:creationId xmlns:a16="http://schemas.microsoft.com/office/drawing/2014/main" id="{0E581D20-4B26-478A-9715-C5A48BEA92DA}"/>
               </a:ext>
             </a:extLst>
           </p:cNvPr>
@@ -7346,7 +7346,7 @@
           <p:cNvPr id="31" name="">
             <a:extLst xmlns:a="http://schemas.openxmlformats.org/drawingml/2006/main">
               <a:ext uri="{FF2B5EF4-FFF2-40B4-BE49-F238E27FC236}">
-                <a16:creationId xmlns:a16="http://schemas.microsoft.com/office/drawing/2014/main" id="{699D80F0-2F91-456C-9190-2E2EB69BD7ED}"/>
+                <a16:creationId xmlns:a16="http://schemas.microsoft.com/office/drawing/2014/main" id="{BA453B76-F4F6-4F31-8FB4-7BB045AABE60}"/>
               </a:ext>
             </a:extLst>
           </p:cNvPr>
@@ -7404,7 +7404,7 @@
           <p:cNvPr id="32" name="">
             <a:extLst xmlns:a="http://schemas.openxmlformats.org/drawingml/2006/main">
               <a:ext uri="{FF2B5EF4-FFF2-40B4-BE49-F238E27FC236}">
-                <a16:creationId xmlns:a16="http://schemas.microsoft.com/office/drawing/2014/main" id="{0E655B3E-F0CB-4322-B679-C0F0A98201D0}"/>
+                <a16:creationId xmlns:a16="http://schemas.microsoft.com/office/drawing/2014/main" id="{4CD9F3D0-B0AD-4366-91EB-7A8561EE3980}"/>
               </a:ext>
             </a:extLst>
           </p:cNvPr>
@@ -7435,7 +7435,7 @@
           <p:cNvPr id="33" name="">
             <a:extLst xmlns:a="http://schemas.openxmlformats.org/drawingml/2006/main">
               <a:ext uri="{FF2B5EF4-FFF2-40B4-BE49-F238E27FC236}">
-                <a16:creationId xmlns:a16="http://schemas.microsoft.com/office/drawing/2014/main" id="{F2AE35E8-66A5-4F6D-AEF8-F0EDDE38B4D3}"/>
+                <a16:creationId xmlns:a16="http://schemas.microsoft.com/office/drawing/2014/main" id="{58480633-83BC-4E51-999A-F2A6E997A53B}"/>
               </a:ext>
             </a:extLst>
           </p:cNvPr>
@@ -7493,7 +7493,7 @@
           <p:cNvPr id="34" name="">
             <a:extLst xmlns:a="http://schemas.openxmlformats.org/drawingml/2006/main">
               <a:ext uri="{FF2B5EF4-FFF2-40B4-BE49-F238E27FC236}">
-                <a16:creationId xmlns:a16="http://schemas.microsoft.com/office/drawing/2014/main" id="{7BF47D1F-8BD4-45FF-8D6C-EA7B5C850F9A}"/>
+                <a16:creationId xmlns:a16="http://schemas.microsoft.com/office/drawing/2014/main" id="{31037D0C-6E71-4279-8D4C-5F47E309565E}"/>
               </a:ext>
             </a:extLst>
           </p:cNvPr>
@@ -7551,7 +7551,7 @@
           <p:cNvPr id="35" name="">
             <a:extLst xmlns:a="http://schemas.openxmlformats.org/drawingml/2006/main">
               <a:ext uri="{FF2B5EF4-FFF2-40B4-BE49-F238E27FC236}">
-                <a16:creationId xmlns:a16="http://schemas.microsoft.com/office/drawing/2014/main" id="{4AC190A3-8025-4083-A67A-1A3A0460C94D}"/>
+                <a16:creationId xmlns:a16="http://schemas.microsoft.com/office/drawing/2014/main" id="{1F61DD27-A395-4DD3-BF20-616C5179C09A}"/>
               </a:ext>
             </a:extLst>
           </p:cNvPr>
@@ -7607,7 +7607,7 @@
     </p:spTree>
     <p:extLst>
       <p:ext uri="{BB962C8B-B14F-4D97-AF65-F5344CB8AC3E}">
-        <p14:creationId xmlns:p14="http://schemas.microsoft.com/office/powerpoint/2010/main" val="274194634"/>
+        <p14:creationId xmlns:p14="http://schemas.microsoft.com/office/powerpoint/2010/main" val="1509539380"/>
       </p:ext>
     </p:extLst>
   </p:cSld>
@@ -7638,7 +7638,7 @@
           <p:cNvPr id="38" name="">
             <a:extLst xmlns:a="http://schemas.openxmlformats.org/drawingml/2006/main">
               <a:ext uri="{FF2B5EF4-FFF2-40B4-BE49-F238E27FC236}">
-                <a16:creationId xmlns:a16="http://schemas.microsoft.com/office/drawing/2014/main" id="{FA4B26DB-6294-4552-961A-ED52F354935E}"/>
+                <a16:creationId xmlns:a16="http://schemas.microsoft.com/office/drawing/2014/main" id="{BB102B5A-6976-477C-8869-FDED7F275DD7}"/>
               </a:ext>
             </a:extLst>
           </p:cNvPr>
@@ -7696,7 +7696,7 @@
           <p:cNvPr id="2" name="">
             <a:extLst xmlns:a="http://schemas.openxmlformats.org/drawingml/2006/main">
               <a:ext uri="{FF2B5EF4-FFF2-40B4-BE49-F238E27FC236}">
-                <a16:creationId xmlns:a16="http://schemas.microsoft.com/office/drawing/2014/main" id="{74C4E902-B975-4DE5-BDDC-494B09770ADF}"/>
+                <a16:creationId xmlns:a16="http://schemas.microsoft.com/office/drawing/2014/main" id="{024D82B1-115F-4503-B831-5B5175543A08}"/>
               </a:ext>
             </a:extLst>
           </p:cNvPr>
@@ -7754,7 +7754,7 @@
           <p:cNvPr id="3" name="">
             <a:extLst xmlns:a="http://schemas.openxmlformats.org/drawingml/2006/main">
               <a:ext uri="{FF2B5EF4-FFF2-40B4-BE49-F238E27FC236}">
-                <a16:creationId xmlns:a16="http://schemas.microsoft.com/office/drawing/2014/main" id="{76A0EF88-12FB-4799-82A0-4BA278C88DD5}"/>
+                <a16:creationId xmlns:a16="http://schemas.microsoft.com/office/drawing/2014/main" id="{9B51DAF0-D738-4DFA-B2D4-F56CDB8B1E49}"/>
               </a:ext>
             </a:extLst>
           </p:cNvPr>
@@ -7787,7 +7787,7 @@
           <p:cNvPr id="4" name="">
             <a:extLst xmlns:a="http://schemas.openxmlformats.org/drawingml/2006/main">
               <a:ext uri="{FF2B5EF4-FFF2-40B4-BE49-F238E27FC236}">
-                <a16:creationId xmlns:a16="http://schemas.microsoft.com/office/drawing/2014/main" id="{E8E05BB1-4A44-4994-9452-FDBFEA73BB84}"/>
+                <a16:creationId xmlns:a16="http://schemas.microsoft.com/office/drawing/2014/main" id="{1C34256E-5312-4B58-B4F4-50F5196F57F6}"/>
               </a:ext>
             </a:extLst>
           </p:cNvPr>
@@ -7845,7 +7845,7 @@
           <p:cNvPr id="5" name="">
             <a:extLst xmlns:a="http://schemas.openxmlformats.org/drawingml/2006/main">
               <a:ext uri="{FF2B5EF4-FFF2-40B4-BE49-F238E27FC236}">
-                <a16:creationId xmlns:a16="http://schemas.microsoft.com/office/drawing/2014/main" id="{D980EE28-4FAE-4B39-9BEB-3E4F21F53BE6}"/>
+                <a16:creationId xmlns:a16="http://schemas.microsoft.com/office/drawing/2014/main" id="{E66685B9-4E11-470B-8F97-B17800D0C0F9}"/>
               </a:ext>
             </a:extLst>
           </p:cNvPr>
@@ -7903,7 +7903,7 @@
           <p:cNvPr id="6" name="">
             <a:extLst xmlns:a="http://schemas.openxmlformats.org/drawingml/2006/main">
               <a:ext uri="{FF2B5EF4-FFF2-40B4-BE49-F238E27FC236}">
-                <a16:creationId xmlns:a16="http://schemas.microsoft.com/office/drawing/2014/main" id="{790D96F2-C904-4FAF-900C-2D990C9A3CEB}"/>
+                <a16:creationId xmlns:a16="http://schemas.microsoft.com/office/drawing/2014/main" id="{8BBB418E-DD44-4D5F-B11C-6CF182502E86}"/>
               </a:ext>
             </a:extLst>
           </p:cNvPr>
@@ -7938,7 +7938,7 @@
           <p:cNvPr id="7" name="">
             <a:extLst xmlns:a="http://schemas.openxmlformats.org/drawingml/2006/main">
               <a:ext uri="{FF2B5EF4-FFF2-40B4-BE49-F238E27FC236}">
-                <a16:creationId xmlns:a16="http://schemas.microsoft.com/office/drawing/2014/main" id="{CFA16039-82F6-4A14-A275-273B5E189F73}"/>
+                <a16:creationId xmlns:a16="http://schemas.microsoft.com/office/drawing/2014/main" id="{3CFBBADB-1D9D-4F39-A474-7F9BEEEAD5BD}"/>
               </a:ext>
             </a:extLst>
           </p:cNvPr>
@@ -7996,7 +7996,7 @@
           <p:cNvPr id="8" name="">
             <a:extLst xmlns:a="http://schemas.openxmlformats.org/drawingml/2006/main">
               <a:ext uri="{FF2B5EF4-FFF2-40B4-BE49-F238E27FC236}">
-                <a16:creationId xmlns:a16="http://schemas.microsoft.com/office/drawing/2014/main" id="{E315B0C3-63CA-40C7-9098-68787DB8F498}"/>
+                <a16:creationId xmlns:a16="http://schemas.microsoft.com/office/drawing/2014/main" id="{7D90BDC3-6C4A-437E-8A5F-80121E5F6904}"/>
               </a:ext>
             </a:extLst>
           </p:cNvPr>
@@ -8054,7 +8054,7 @@
           <p:cNvPr id="9" name="">
             <a:extLst xmlns:a="http://schemas.openxmlformats.org/drawingml/2006/main">
               <a:ext uri="{FF2B5EF4-FFF2-40B4-BE49-F238E27FC236}">
-                <a16:creationId xmlns:a16="http://schemas.microsoft.com/office/drawing/2014/main" id="{969A03B9-3310-4DC0-87E8-ABF33DA474F8}"/>
+                <a16:creationId xmlns:a16="http://schemas.microsoft.com/office/drawing/2014/main" id="{940D7FC9-7BBF-4D06-BD10-5A3798BF35FE}"/>
               </a:ext>
             </a:extLst>
           </p:cNvPr>
@@ -8112,7 +8112,7 @@
           <p:cNvPr id="10" name="">
             <a:extLst xmlns:a="http://schemas.openxmlformats.org/drawingml/2006/main">
               <a:ext uri="{FF2B5EF4-FFF2-40B4-BE49-F238E27FC236}">
-                <a16:creationId xmlns:a16="http://schemas.microsoft.com/office/drawing/2014/main" id="{98FEA81A-4021-484C-BE50-A4B3F7CD2747}"/>
+                <a16:creationId xmlns:a16="http://schemas.microsoft.com/office/drawing/2014/main" id="{480F1DFA-D512-44AE-97AB-29CFCE363EA6}"/>
               </a:ext>
             </a:extLst>
           </p:cNvPr>
@@ -8147,7 +8147,7 @@
           <p:cNvPr id="11" name="">
             <a:extLst xmlns:a="http://schemas.openxmlformats.org/drawingml/2006/main">
               <a:ext uri="{FF2B5EF4-FFF2-40B4-BE49-F238E27FC236}">
-                <a16:creationId xmlns:a16="http://schemas.microsoft.com/office/drawing/2014/main" id="{7C0A93D4-8EE4-4FE4-ADD9-04CDAB64B4C9}"/>
+                <a16:creationId xmlns:a16="http://schemas.microsoft.com/office/drawing/2014/main" id="{57DA53BA-C29B-4805-BC96-EA8C6DF9C727}"/>
               </a:ext>
             </a:extLst>
           </p:cNvPr>
@@ -8205,7 +8205,7 @@
           <p:cNvPr id="12" name="">
             <a:extLst xmlns:a="http://schemas.openxmlformats.org/drawingml/2006/main">
               <a:ext uri="{FF2B5EF4-FFF2-40B4-BE49-F238E27FC236}">
-                <a16:creationId xmlns:a16="http://schemas.microsoft.com/office/drawing/2014/main" id="{2D867AF7-DE24-4B83-9478-B259AE8EEFBB}"/>
+                <a16:creationId xmlns:a16="http://schemas.microsoft.com/office/drawing/2014/main" id="{194CF80B-BD06-4143-BF2F-3610C2ACCC8E}"/>
               </a:ext>
             </a:extLst>
           </p:cNvPr>
@@ -8263,7 +8263,7 @@
           <p:cNvPr id="13" name="">
             <a:extLst xmlns:a="http://schemas.openxmlformats.org/drawingml/2006/main">
               <a:ext uri="{FF2B5EF4-FFF2-40B4-BE49-F238E27FC236}">
-                <a16:creationId xmlns:a16="http://schemas.microsoft.com/office/drawing/2014/main" id="{09AC06AE-B339-420E-B247-147882E91159}"/>
+                <a16:creationId xmlns:a16="http://schemas.microsoft.com/office/drawing/2014/main" id="{48BBC127-A624-45F3-A18E-B8D7AF767429}"/>
               </a:ext>
             </a:extLst>
           </p:cNvPr>
@@ -8321,7 +8321,7 @@
           <p:cNvPr id="14" name="">
             <a:extLst xmlns:a="http://schemas.openxmlformats.org/drawingml/2006/main">
               <a:ext uri="{FF2B5EF4-FFF2-40B4-BE49-F238E27FC236}">
-                <a16:creationId xmlns:a16="http://schemas.microsoft.com/office/drawing/2014/main" id="{09C4A0CD-1F0B-406D-A63D-0E317829E5EC}"/>
+                <a16:creationId xmlns:a16="http://schemas.microsoft.com/office/drawing/2014/main" id="{1C57840D-B584-4788-8A99-EF0E59B1029D}"/>
               </a:ext>
             </a:extLst>
           </p:cNvPr>
@@ -8356,7 +8356,7 @@
           <p:cNvPr id="15" name="">
             <a:extLst xmlns:a="http://schemas.openxmlformats.org/drawingml/2006/main">
               <a:ext uri="{FF2B5EF4-FFF2-40B4-BE49-F238E27FC236}">
-                <a16:creationId xmlns:a16="http://schemas.microsoft.com/office/drawing/2014/main" id="{C340D783-D350-4658-BA45-35E5DB1DA951}"/>
+                <a16:creationId xmlns:a16="http://schemas.microsoft.com/office/drawing/2014/main" id="{F7F66795-1A87-4691-9A69-4144F928E1C3}"/>
               </a:ext>
             </a:extLst>
           </p:cNvPr>
@@ -8414,7 +8414,7 @@
           <p:cNvPr id="16" name="">
             <a:extLst xmlns:a="http://schemas.openxmlformats.org/drawingml/2006/main">
               <a:ext uri="{FF2B5EF4-FFF2-40B4-BE49-F238E27FC236}">
-                <a16:creationId xmlns:a16="http://schemas.microsoft.com/office/drawing/2014/main" id="{DE217FDE-8E7E-4004-9295-FC3028B5BC7B}"/>
+                <a16:creationId xmlns:a16="http://schemas.microsoft.com/office/drawing/2014/main" id="{F91A1510-1866-4F3B-8FFC-DFD32E43CD66}"/>
               </a:ext>
             </a:extLst>
           </p:cNvPr>
@@ -8472,7 +8472,7 @@
           <p:cNvPr id="17" name="">
             <a:extLst xmlns:a="http://schemas.openxmlformats.org/drawingml/2006/main">
               <a:ext uri="{FF2B5EF4-FFF2-40B4-BE49-F238E27FC236}">
-                <a16:creationId xmlns:a16="http://schemas.microsoft.com/office/drawing/2014/main" id="{F9C4EE54-098A-4967-B50F-23FF71FBFA0E}"/>
+                <a16:creationId xmlns:a16="http://schemas.microsoft.com/office/drawing/2014/main" id="{DCF84106-BB8E-4DF1-B08F-103C6335A285}"/>
               </a:ext>
             </a:extLst>
           </p:cNvPr>
@@ -8530,7 +8530,7 @@
           <p:cNvPr id="18" name="">
             <a:extLst xmlns:a="http://schemas.openxmlformats.org/drawingml/2006/main">
               <a:ext uri="{FF2B5EF4-FFF2-40B4-BE49-F238E27FC236}">
-                <a16:creationId xmlns:a16="http://schemas.microsoft.com/office/drawing/2014/main" id="{2B225409-4709-4F18-8173-0020FA38E1E8}"/>
+                <a16:creationId xmlns:a16="http://schemas.microsoft.com/office/drawing/2014/main" id="{3AA6C76A-54DD-4A61-BAA5-CC0CA32E32D5}"/>
               </a:ext>
             </a:extLst>
           </p:cNvPr>
@@ -8565,7 +8565,7 @@
           <p:cNvPr id="19" name="">
             <a:extLst xmlns:a="http://schemas.openxmlformats.org/drawingml/2006/main">
               <a:ext uri="{FF2B5EF4-FFF2-40B4-BE49-F238E27FC236}">
-                <a16:creationId xmlns:a16="http://schemas.microsoft.com/office/drawing/2014/main" id="{CFD9192F-2BB8-482E-9EF5-3228A455847F}"/>
+                <a16:creationId xmlns:a16="http://schemas.microsoft.com/office/drawing/2014/main" id="{9510BCA3-4F3B-40CC-87E0-5DA662B6A1D2}"/>
               </a:ext>
             </a:extLst>
           </p:cNvPr>
@@ -8623,7 +8623,7 @@
           <p:cNvPr id="20" name="">
             <a:extLst xmlns:a="http://schemas.openxmlformats.org/drawingml/2006/main">
               <a:ext uri="{FF2B5EF4-FFF2-40B4-BE49-F238E27FC236}">
-                <a16:creationId xmlns:a16="http://schemas.microsoft.com/office/drawing/2014/main" id="{F5FA5394-7DED-426F-B603-90E66EC8723E}"/>
+                <a16:creationId xmlns:a16="http://schemas.microsoft.com/office/drawing/2014/main" id="{9B127364-B064-425A-81DA-C75AC536C46A}"/>
               </a:ext>
             </a:extLst>
           </p:cNvPr>
@@ -8681,7 +8681,7 @@
           <p:cNvPr id="21" name="">
             <a:extLst xmlns:a="http://schemas.openxmlformats.org/drawingml/2006/main">
               <a:ext uri="{FF2B5EF4-FFF2-40B4-BE49-F238E27FC236}">
-                <a16:creationId xmlns:a16="http://schemas.microsoft.com/office/drawing/2014/main" id="{621983B1-1542-4008-8AB2-1624060AFE45}"/>
+                <a16:creationId xmlns:a16="http://schemas.microsoft.com/office/drawing/2014/main" id="{3CAED4D1-B311-4AF5-9192-15E74A93F8BB}"/>
               </a:ext>
             </a:extLst>
           </p:cNvPr>
@@ -8739,7 +8739,7 @@
           <p:cNvPr id="22" name="">
             <a:extLst xmlns:a="http://schemas.openxmlformats.org/drawingml/2006/main">
               <a:ext uri="{FF2B5EF4-FFF2-40B4-BE49-F238E27FC236}">
-                <a16:creationId xmlns:a16="http://schemas.microsoft.com/office/drawing/2014/main" id="{81A84F9C-B6D1-4F41-A4AA-317A3777E4B8}"/>
+                <a16:creationId xmlns:a16="http://schemas.microsoft.com/office/drawing/2014/main" id="{B55D8717-EC6B-4B09-B780-C57187709444}"/>
               </a:ext>
             </a:extLst>
           </p:cNvPr>
@@ -8774,7 +8774,7 @@
           <p:cNvPr id="23" name="">
             <a:extLst xmlns:a="http://schemas.openxmlformats.org/drawingml/2006/main">
               <a:ext uri="{FF2B5EF4-FFF2-40B4-BE49-F238E27FC236}">
-                <a16:creationId xmlns:a16="http://schemas.microsoft.com/office/drawing/2014/main" id="{77F22D33-3E6E-496D-AE4A-480E348A750D}"/>
+                <a16:creationId xmlns:a16="http://schemas.microsoft.com/office/drawing/2014/main" id="{F4C4D0D1-9729-4FEC-BA69-A11FF0D9B117}"/>
               </a:ext>
             </a:extLst>
           </p:cNvPr>
@@ -8832,7 +8832,7 @@
           <p:cNvPr id="24" name="">
             <a:extLst xmlns:a="http://schemas.openxmlformats.org/drawingml/2006/main">
               <a:ext uri="{FF2B5EF4-FFF2-40B4-BE49-F238E27FC236}">
-                <a16:creationId xmlns:a16="http://schemas.microsoft.com/office/drawing/2014/main" id="{5EFF6A1C-A4A2-497D-825C-BF735767122A}"/>
+                <a16:creationId xmlns:a16="http://schemas.microsoft.com/office/drawing/2014/main" id="{726C9CAD-8486-41F8-B309-C11CCA9137B8}"/>
               </a:ext>
             </a:extLst>
           </p:cNvPr>
@@ -8890,7 +8890,7 @@
           <p:cNvPr id="25" name="">
             <a:extLst xmlns:a="http://schemas.openxmlformats.org/drawingml/2006/main">
               <a:ext uri="{FF2B5EF4-FFF2-40B4-BE49-F238E27FC236}">
-                <a16:creationId xmlns:a16="http://schemas.microsoft.com/office/drawing/2014/main" id="{27F68C1B-454E-453A-9B74-5DA409DB4A25}"/>
+                <a16:creationId xmlns:a16="http://schemas.microsoft.com/office/drawing/2014/main" id="{A06FC428-40A1-43E0-B951-ED02F9590E06}"/>
               </a:ext>
             </a:extLst>
           </p:cNvPr>
@@ -8948,7 +8948,7 @@
           <p:cNvPr id="26" name="">
             <a:extLst xmlns:a="http://schemas.openxmlformats.org/drawingml/2006/main">
               <a:ext uri="{FF2B5EF4-FFF2-40B4-BE49-F238E27FC236}">
-                <a16:creationId xmlns:a16="http://schemas.microsoft.com/office/drawing/2014/main" id="{7AC64BB7-D1A1-4749-B527-41AA132B6A09}"/>
+                <a16:creationId xmlns:a16="http://schemas.microsoft.com/office/drawing/2014/main" id="{243AE7E3-4F29-4411-87B7-5B4C7584AE03}"/>
               </a:ext>
             </a:extLst>
           </p:cNvPr>
@@ -8983,7 +8983,7 @@
           <p:cNvPr id="27" name="">
             <a:extLst xmlns:a="http://schemas.openxmlformats.org/drawingml/2006/main">
               <a:ext uri="{FF2B5EF4-FFF2-40B4-BE49-F238E27FC236}">
-                <a16:creationId xmlns:a16="http://schemas.microsoft.com/office/drawing/2014/main" id="{B1306AA8-DB3C-4962-948F-55130E136760}"/>
+                <a16:creationId xmlns:a16="http://schemas.microsoft.com/office/drawing/2014/main" id="{859882F5-64E7-46B8-B3DC-10D5DE377429}"/>
               </a:ext>
             </a:extLst>
           </p:cNvPr>
@@ -9041,7 +9041,7 @@
           <p:cNvPr id="28" name="">
             <a:extLst xmlns:a="http://schemas.openxmlformats.org/drawingml/2006/main">
               <a:ext uri="{FF2B5EF4-FFF2-40B4-BE49-F238E27FC236}">
-                <a16:creationId xmlns:a16="http://schemas.microsoft.com/office/drawing/2014/main" id="{634DE117-A861-496C-9676-05B45450A683}"/>
+                <a16:creationId xmlns:a16="http://schemas.microsoft.com/office/drawing/2014/main" id="{15C85EDD-E68F-4004-B8D9-DE1E257F49A9}"/>
               </a:ext>
             </a:extLst>
           </p:cNvPr>
@@ -9099,7 +9099,7 @@
           <p:cNvPr id="29" name="">
             <a:extLst xmlns:a="http://schemas.openxmlformats.org/drawingml/2006/main">
               <a:ext uri="{FF2B5EF4-FFF2-40B4-BE49-F238E27FC236}">
-                <a16:creationId xmlns:a16="http://schemas.microsoft.com/office/drawing/2014/main" id="{AA191009-0301-4C4C-B6B9-D596F6C1895A}"/>
+                <a16:creationId xmlns:a16="http://schemas.microsoft.com/office/drawing/2014/main" id="{67233884-C7C6-4DC9-A92F-D7335923BD4C}"/>
               </a:ext>
             </a:extLst>
           </p:cNvPr>
@@ -9157,7 +9157,7 @@
           <p:cNvPr id="30" name="">
             <a:extLst xmlns:a="http://schemas.openxmlformats.org/drawingml/2006/main">
               <a:ext uri="{FF2B5EF4-FFF2-40B4-BE49-F238E27FC236}">
-                <a16:creationId xmlns:a16="http://schemas.microsoft.com/office/drawing/2014/main" id="{89C4DE95-7219-41A2-B58E-7955FB1CB535}"/>
+                <a16:creationId xmlns:a16="http://schemas.microsoft.com/office/drawing/2014/main" id="{CC5F1CDE-CA31-479D-BC05-5C80CCB70C94}"/>
               </a:ext>
             </a:extLst>
           </p:cNvPr>
@@ -9192,7 +9192,7 @@
           <p:cNvPr id="31" name="">
             <a:extLst xmlns:a="http://schemas.openxmlformats.org/drawingml/2006/main">
               <a:ext uri="{FF2B5EF4-FFF2-40B4-BE49-F238E27FC236}">
-                <a16:creationId xmlns:a16="http://schemas.microsoft.com/office/drawing/2014/main" id="{0039F57D-AE35-48A5-9E84-DA1BB4930A8C}"/>
+                <a16:creationId xmlns:a16="http://schemas.microsoft.com/office/drawing/2014/main" id="{99052EFA-C4B4-40D3-B64C-B84E42E6C206}"/>
               </a:ext>
             </a:extLst>
           </p:cNvPr>
@@ -9250,7 +9250,7 @@
           <p:cNvPr id="32" name="">
             <a:extLst xmlns:a="http://schemas.openxmlformats.org/drawingml/2006/main">
               <a:ext uri="{FF2B5EF4-FFF2-40B4-BE49-F238E27FC236}">
-                <a16:creationId xmlns:a16="http://schemas.microsoft.com/office/drawing/2014/main" id="{84288DC9-3496-45DB-AF3B-F472AB39CEEF}"/>
+                <a16:creationId xmlns:a16="http://schemas.microsoft.com/office/drawing/2014/main" id="{95B44D76-A3E2-4EC7-A650-C00217A11964}"/>
               </a:ext>
             </a:extLst>
           </p:cNvPr>
@@ -9308,7 +9308,7 @@
           <p:cNvPr id="33" name="">
             <a:extLst xmlns:a="http://schemas.openxmlformats.org/drawingml/2006/main">
               <a:ext uri="{FF2B5EF4-FFF2-40B4-BE49-F238E27FC236}">
-                <a16:creationId xmlns:a16="http://schemas.microsoft.com/office/drawing/2014/main" id="{86DB760F-2285-425D-8DE6-3BEAF39487FD}"/>
+                <a16:creationId xmlns:a16="http://schemas.microsoft.com/office/drawing/2014/main" id="{909ECD61-DEEB-4851-AC16-910B09925227}"/>
               </a:ext>
             </a:extLst>
           </p:cNvPr>
@@ -9366,7 +9366,7 @@
           <p:cNvPr id="34" name="">
             <a:extLst xmlns:a="http://schemas.openxmlformats.org/drawingml/2006/main">
               <a:ext uri="{FF2B5EF4-FFF2-40B4-BE49-F238E27FC236}">
-                <a16:creationId xmlns:a16="http://schemas.microsoft.com/office/drawing/2014/main" id="{EB83874E-66F0-4546-826D-5BDB1EBBAF74}"/>
+                <a16:creationId xmlns:a16="http://schemas.microsoft.com/office/drawing/2014/main" id="{21F16FB8-8721-4010-A617-8E0A085B5000}"/>
               </a:ext>
             </a:extLst>
           </p:cNvPr>
@@ -9401,7 +9401,7 @@
           <p:cNvPr id="35" name="">
             <a:extLst xmlns:a="http://schemas.openxmlformats.org/drawingml/2006/main">
               <a:ext uri="{FF2B5EF4-FFF2-40B4-BE49-F238E27FC236}">
-                <a16:creationId xmlns:a16="http://schemas.microsoft.com/office/drawing/2014/main" id="{C9E77ED6-2883-4F73-B330-58346EE04222}"/>
+                <a16:creationId xmlns:a16="http://schemas.microsoft.com/office/drawing/2014/main" id="{765B2AF4-A179-4C70-9EDB-3B2BA42B12EF}"/>
               </a:ext>
             </a:extLst>
           </p:cNvPr>
@@ -9459,7 +9459,7 @@
           <p:cNvPr id="36" name="">
             <a:extLst xmlns:a="http://schemas.openxmlformats.org/drawingml/2006/main">
               <a:ext uri="{FF2B5EF4-FFF2-40B4-BE49-F238E27FC236}">
-                <a16:creationId xmlns:a16="http://schemas.microsoft.com/office/drawing/2014/main" id="{7539231F-D194-4C0A-8F58-8AC73A14D4FA}"/>
+                <a16:creationId xmlns:a16="http://schemas.microsoft.com/office/drawing/2014/main" id="{3D83DC96-95B5-487D-B168-9D6DA8CE04E7}"/>
               </a:ext>
             </a:extLst>
           </p:cNvPr>
@@ -9517,7 +9517,7 @@
           <p:cNvPr id="37" name="">
             <a:extLst xmlns:a="http://schemas.openxmlformats.org/drawingml/2006/main">
               <a:ext uri="{FF2B5EF4-FFF2-40B4-BE49-F238E27FC236}">
-                <a16:creationId xmlns:a16="http://schemas.microsoft.com/office/drawing/2014/main" id="{C3F3918C-D46C-4661-AF8A-6DAAC514EB79}"/>
+                <a16:creationId xmlns:a16="http://schemas.microsoft.com/office/drawing/2014/main" id="{E7B7C21E-8AFD-4F5A-8197-3FA400671798}"/>
               </a:ext>
             </a:extLst>
           </p:cNvPr>
@@ -9573,7 +9573,7 @@
     </p:spTree>
     <p:extLst>
       <p:ext uri="{BB962C8B-B14F-4D97-AF65-F5344CB8AC3E}">
-        <p14:creationId xmlns:p14="http://schemas.microsoft.com/office/powerpoint/2010/main" val="1337140563"/>
+        <p14:creationId xmlns:p14="http://schemas.microsoft.com/office/powerpoint/2010/main" val="1971407041"/>
       </p:ext>
     </p:extLst>
   </p:cSld>
@@ -9604,7 +9604,7 @@
           <p:cNvPr id="19" name="">
             <a:extLst xmlns:a="http://schemas.openxmlformats.org/drawingml/2006/main">
               <a:ext uri="{FF2B5EF4-FFF2-40B4-BE49-F238E27FC236}">
-                <a16:creationId xmlns:a16="http://schemas.microsoft.com/office/drawing/2014/main" id="{124633F0-1114-4D2D-B256-FB64F85EC27E}"/>
+                <a16:creationId xmlns:a16="http://schemas.microsoft.com/office/drawing/2014/main" id="{CA8555E8-2310-43B7-9DB3-882F40EB0451}"/>
               </a:ext>
             </a:extLst>
           </p:cNvPr>
@@ -9662,7 +9662,7 @@
           <p:cNvPr id="2" name="">
             <a:extLst xmlns:a="http://schemas.openxmlformats.org/drawingml/2006/main">
               <a:ext uri="{FF2B5EF4-FFF2-40B4-BE49-F238E27FC236}">
-                <a16:creationId xmlns:a16="http://schemas.microsoft.com/office/drawing/2014/main" id="{8B3ABC40-3C51-4568-87B1-8ADDA027D754}"/>
+                <a16:creationId xmlns:a16="http://schemas.microsoft.com/office/drawing/2014/main" id="{88189914-9802-4B73-BC11-1FC3504AA432}"/>
               </a:ext>
             </a:extLst>
           </p:cNvPr>
@@ -9720,7 +9720,7 @@
           <p:cNvPr id="3" name="">
             <a:extLst xmlns:a="http://schemas.openxmlformats.org/drawingml/2006/main">
               <a:ext uri="{FF2B5EF4-FFF2-40B4-BE49-F238E27FC236}">
-                <a16:creationId xmlns:a16="http://schemas.microsoft.com/office/drawing/2014/main" id="{EFA03EAE-0962-4436-8DFD-659595ABC318}"/>
+                <a16:creationId xmlns:a16="http://schemas.microsoft.com/office/drawing/2014/main" id="{934F7224-A6C4-4E05-9B83-844C2776987F}"/>
               </a:ext>
             </a:extLst>
           </p:cNvPr>
@@ -9753,7 +9753,7 @@
           <p:cNvPr id="4" name="">
             <a:extLst xmlns:a="http://schemas.openxmlformats.org/drawingml/2006/main">
               <a:ext uri="{FF2B5EF4-FFF2-40B4-BE49-F238E27FC236}">
-                <a16:creationId xmlns:a16="http://schemas.microsoft.com/office/drawing/2014/main" id="{64A87FFD-EEFB-46DD-87B1-DCF4B84079E0}"/>
+                <a16:creationId xmlns:a16="http://schemas.microsoft.com/office/drawing/2014/main" id="{AABF45AB-8850-43FD-9ACD-CA765B5DBF73}"/>
               </a:ext>
             </a:extLst>
           </p:cNvPr>
@@ -9811,7 +9811,7 @@
           <p:cNvPr id="5" name="">
             <a:extLst xmlns:a="http://schemas.openxmlformats.org/drawingml/2006/main">
               <a:ext uri="{FF2B5EF4-FFF2-40B4-BE49-F238E27FC236}">
-                <a16:creationId xmlns:a16="http://schemas.microsoft.com/office/drawing/2014/main" id="{3DFBEA56-3AAC-4DB5-ABF8-A9868E983231}"/>
+                <a16:creationId xmlns:a16="http://schemas.microsoft.com/office/drawing/2014/main" id="{AC01F47F-56DB-4F3C-97FC-182FEDF3DE53}"/>
               </a:ext>
             </a:extLst>
           </p:cNvPr>
@@ -9869,7 +9869,7 @@
           <p:cNvPr id="6" name="">
             <a:extLst xmlns:a="http://schemas.openxmlformats.org/drawingml/2006/main">
               <a:ext uri="{FF2B5EF4-FFF2-40B4-BE49-F238E27FC236}">
-                <a16:creationId xmlns:a16="http://schemas.microsoft.com/office/drawing/2014/main" id="{978167F9-237B-42E0-A4D6-504B83BA95AF}"/>
+                <a16:creationId xmlns:a16="http://schemas.microsoft.com/office/drawing/2014/main" id="{5023C3AB-455C-483E-B8CD-1079D55D8D1D}"/>
               </a:ext>
             </a:extLst>
           </p:cNvPr>
@@ -9904,7 +9904,7 @@
           <p:cNvPr id="7" name="">
             <a:extLst xmlns:a="http://schemas.openxmlformats.org/drawingml/2006/main">
               <a:ext uri="{FF2B5EF4-FFF2-40B4-BE49-F238E27FC236}">
-                <a16:creationId xmlns:a16="http://schemas.microsoft.com/office/drawing/2014/main" id="{476CF79D-6BDC-4490-80F1-7A746D33A4C6}"/>
+                <a16:creationId xmlns:a16="http://schemas.microsoft.com/office/drawing/2014/main" id="{0C3926D6-ABE2-477F-8B2A-A5FF7D0D2777}"/>
               </a:ext>
             </a:extLst>
           </p:cNvPr>
@@ -9937,7 +9937,7 @@
           <p:cNvPr id="8" name="">
             <a:extLst xmlns:a="http://schemas.openxmlformats.org/drawingml/2006/main">
               <a:ext uri="{FF2B5EF4-FFF2-40B4-BE49-F238E27FC236}">
-                <a16:creationId xmlns:a16="http://schemas.microsoft.com/office/drawing/2014/main" id="{5AF8BFF1-40B5-48B6-A2BD-936932B90D52}"/>
+                <a16:creationId xmlns:a16="http://schemas.microsoft.com/office/drawing/2014/main" id="{3C950129-476A-4A48-9AE7-B300D89F9020}"/>
               </a:ext>
             </a:extLst>
           </p:cNvPr>
@@ -9995,7 +9995,7 @@
           <p:cNvPr id="9" name="">
             <a:extLst xmlns:a="http://schemas.openxmlformats.org/drawingml/2006/main">
               <a:ext uri="{FF2B5EF4-FFF2-40B4-BE49-F238E27FC236}">
-                <a16:creationId xmlns:a16="http://schemas.microsoft.com/office/drawing/2014/main" id="{42A7A7F5-0CDB-4928-9E5C-9CCD07BF765F}"/>
+                <a16:creationId xmlns:a16="http://schemas.microsoft.com/office/drawing/2014/main" id="{0C951EC7-C236-4BE6-B9D0-E1B6608B6885}"/>
               </a:ext>
             </a:extLst>
           </p:cNvPr>
@@ -10070,7 +10070,7 @@
           <p:cNvPr id="10" name="">
             <a:extLst xmlns:a="http://schemas.openxmlformats.org/drawingml/2006/main">
               <a:ext uri="{FF2B5EF4-FFF2-40B4-BE49-F238E27FC236}">
-                <a16:creationId xmlns:a16="http://schemas.microsoft.com/office/drawing/2014/main" id="{44992474-0BDD-4C0E-804D-50D0295949E9}"/>
+                <a16:creationId xmlns:a16="http://schemas.microsoft.com/office/drawing/2014/main" id="{1A2A72E6-1738-4201-A255-82A5B6CDAF8D}"/>
               </a:ext>
             </a:extLst>
           </p:cNvPr>
@@ -10105,7 +10105,7 @@
           <p:cNvPr id="11" name="">
             <a:extLst xmlns:a="http://schemas.openxmlformats.org/drawingml/2006/main">
               <a:ext uri="{FF2B5EF4-FFF2-40B4-BE49-F238E27FC236}">
-                <a16:creationId xmlns:a16="http://schemas.microsoft.com/office/drawing/2014/main" id="{BC8DF44A-8718-4ABB-B6EB-3EF7ABE792DC}"/>
+                <a16:creationId xmlns:a16="http://schemas.microsoft.com/office/drawing/2014/main" id="{58139AAE-C6F9-4E29-A628-7168E4939C6F}"/>
               </a:ext>
             </a:extLst>
           </p:cNvPr>
@@ -10138,7 +10138,7 @@
           <p:cNvPr id="12" name="">
             <a:extLst xmlns:a="http://schemas.openxmlformats.org/drawingml/2006/main">
               <a:ext uri="{FF2B5EF4-FFF2-40B4-BE49-F238E27FC236}">
-                <a16:creationId xmlns:a16="http://schemas.microsoft.com/office/drawing/2014/main" id="{C06DC152-20E8-424D-8624-427428B930F2}"/>
+                <a16:creationId xmlns:a16="http://schemas.microsoft.com/office/drawing/2014/main" id="{28F136EB-1D8E-47AD-A7CB-2671195FEA05}"/>
               </a:ext>
             </a:extLst>
           </p:cNvPr>
@@ -10196,7 +10196,7 @@
           <p:cNvPr id="13" name="">
             <a:extLst xmlns:a="http://schemas.openxmlformats.org/drawingml/2006/main">
               <a:ext uri="{FF2B5EF4-FFF2-40B4-BE49-F238E27FC236}">
-                <a16:creationId xmlns:a16="http://schemas.microsoft.com/office/drawing/2014/main" id="{124F380F-787E-4761-AFCD-B24DDA412181}"/>
+                <a16:creationId xmlns:a16="http://schemas.microsoft.com/office/drawing/2014/main" id="{5BA79CAC-A540-4419-9EC9-0E6B171B4C44}"/>
               </a:ext>
             </a:extLst>
           </p:cNvPr>
@@ -10254,7 +10254,7 @@
           <p:cNvPr id="14" name="">
             <a:extLst xmlns:a="http://schemas.openxmlformats.org/drawingml/2006/main">
               <a:ext uri="{FF2B5EF4-FFF2-40B4-BE49-F238E27FC236}">
-                <a16:creationId xmlns:a16="http://schemas.microsoft.com/office/drawing/2014/main" id="{6703BA86-4F35-43A2-9B11-876880AB0EC6}"/>
+                <a16:creationId xmlns:a16="http://schemas.microsoft.com/office/drawing/2014/main" id="{F4AAE801-19D2-431C-B3D1-33E5F3952698}"/>
               </a:ext>
             </a:extLst>
           </p:cNvPr>
@@ -10289,7 +10289,7 @@
           <p:cNvPr id="15" name="">
             <a:extLst xmlns:a="http://schemas.openxmlformats.org/drawingml/2006/main">
               <a:ext uri="{FF2B5EF4-FFF2-40B4-BE49-F238E27FC236}">
-                <a16:creationId xmlns:a16="http://schemas.microsoft.com/office/drawing/2014/main" id="{5FF6AB8D-77F6-4F4E-8905-62BAC84FD3DE}"/>
+                <a16:creationId xmlns:a16="http://schemas.microsoft.com/office/drawing/2014/main" id="{021C4FE2-C61C-42E1-9754-EE6C9DE7DA14}"/>
               </a:ext>
             </a:extLst>
           </p:cNvPr>
@@ -10322,7 +10322,7 @@
           <p:cNvPr id="16" name="">
             <a:extLst xmlns:a="http://schemas.openxmlformats.org/drawingml/2006/main">
               <a:ext uri="{FF2B5EF4-FFF2-40B4-BE49-F238E27FC236}">
-                <a16:creationId xmlns:a16="http://schemas.microsoft.com/office/drawing/2014/main" id="{EFD12CB0-5DED-422C-ADCA-86728FB93FD1}"/>
+                <a16:creationId xmlns:a16="http://schemas.microsoft.com/office/drawing/2014/main" id="{2FA13EA5-D328-4DAF-BE3C-6D4AFAEF57EC}"/>
               </a:ext>
             </a:extLst>
           </p:cNvPr>
@@ -10380,7 +10380,7 @@
           <p:cNvPr id="17" name="">
             <a:extLst xmlns:a="http://schemas.openxmlformats.org/drawingml/2006/main">
               <a:ext uri="{FF2B5EF4-FFF2-40B4-BE49-F238E27FC236}">
-                <a16:creationId xmlns:a16="http://schemas.microsoft.com/office/drawing/2014/main" id="{D14199C4-C50B-41F9-A740-99AAF9227DCC}"/>
+                <a16:creationId xmlns:a16="http://schemas.microsoft.com/office/drawing/2014/main" id="{8BEA95B8-7941-45CF-87CF-E91778354F8B}"/>
               </a:ext>
             </a:extLst>
           </p:cNvPr>
@@ -10438,7 +10438,7 @@
           <p:cNvPr id="18" name="">
             <a:extLst xmlns:a="http://schemas.openxmlformats.org/drawingml/2006/main">
               <a:ext uri="{FF2B5EF4-FFF2-40B4-BE49-F238E27FC236}">
-                <a16:creationId xmlns:a16="http://schemas.microsoft.com/office/drawing/2014/main" id="{B7168AD6-01F2-45E7-941D-226611E2B834}"/>
+                <a16:creationId xmlns:a16="http://schemas.microsoft.com/office/drawing/2014/main" id="{5E9565B3-A005-4D7A-8DC8-9B9002D89DB9}"/>
               </a:ext>
             </a:extLst>
           </p:cNvPr>
@@ -10494,7 +10494,7 @@
     </p:spTree>
     <p:extLst>
       <p:ext uri="{BB962C8B-B14F-4D97-AF65-F5344CB8AC3E}">
-        <p14:creationId xmlns:p14="http://schemas.microsoft.com/office/powerpoint/2010/main" val="1497453836"/>
+        <p14:creationId xmlns:p14="http://schemas.microsoft.com/office/powerpoint/2010/main" val="484540256"/>
       </p:ext>
     </p:extLst>
   </p:cSld>
@@ -10525,7 +10525,7 @@
           <p:cNvPr id="28" name="">
             <a:extLst xmlns:a="http://schemas.openxmlformats.org/drawingml/2006/main">
               <a:ext uri="{FF2B5EF4-FFF2-40B4-BE49-F238E27FC236}">
-                <a16:creationId xmlns:a16="http://schemas.microsoft.com/office/drawing/2014/main" id="{EAB4715B-5FA5-4AB3-9044-EE9215C78C95}"/>
+                <a16:creationId xmlns:a16="http://schemas.microsoft.com/office/drawing/2014/main" id="{52BF67A6-17C1-4E07-8742-50AEC0742314}"/>
               </a:ext>
             </a:extLst>
           </p:cNvPr>
@@ -10583,7 +10583,7 @@
           <p:cNvPr id="2" name="">
             <a:extLst xmlns:a="http://schemas.openxmlformats.org/drawingml/2006/main">
               <a:ext uri="{FF2B5EF4-FFF2-40B4-BE49-F238E27FC236}">
-                <a16:creationId xmlns:a16="http://schemas.microsoft.com/office/drawing/2014/main" id="{D76F7DDF-3A40-4175-867A-52B7994E8828}"/>
+                <a16:creationId xmlns:a16="http://schemas.microsoft.com/office/drawing/2014/main" id="{7E8BAC6C-8BEA-4215-93C7-BFEC447D9A9E}"/>
               </a:ext>
             </a:extLst>
           </p:cNvPr>
@@ -10641,7 +10641,7 @@
           <p:cNvPr id="3" name="">
             <a:extLst xmlns:a="http://schemas.openxmlformats.org/drawingml/2006/main">
               <a:ext uri="{FF2B5EF4-FFF2-40B4-BE49-F238E27FC236}">
-                <a16:creationId xmlns:a16="http://schemas.microsoft.com/office/drawing/2014/main" id="{F41111EA-D8F8-4E66-9FB6-D32B30647742}"/>
+                <a16:creationId xmlns:a16="http://schemas.microsoft.com/office/drawing/2014/main" id="{DE472C1E-DD34-4F88-8335-4B7F4BF53F9C}"/>
               </a:ext>
             </a:extLst>
           </p:cNvPr>
@@ -10674,7 +10674,7 @@
           <p:cNvPr id="4" name="">
             <a:extLst xmlns:a="http://schemas.openxmlformats.org/drawingml/2006/main">
               <a:ext uri="{FF2B5EF4-FFF2-40B4-BE49-F238E27FC236}">
-                <a16:creationId xmlns:a16="http://schemas.microsoft.com/office/drawing/2014/main" id="{724F61F6-1B96-4324-8BC2-745959CAFA97}"/>
+                <a16:creationId xmlns:a16="http://schemas.microsoft.com/office/drawing/2014/main" id="{FB357774-14D1-4E93-A966-1030CC3518AB}"/>
               </a:ext>
             </a:extLst>
           </p:cNvPr>
@@ -10732,7 +10732,7 @@
           <p:cNvPr id="5" name="">
             <a:extLst xmlns:a="http://schemas.openxmlformats.org/drawingml/2006/main">
               <a:ext uri="{FF2B5EF4-FFF2-40B4-BE49-F238E27FC236}">
-                <a16:creationId xmlns:a16="http://schemas.microsoft.com/office/drawing/2014/main" id="{40FE9F15-E0B7-4E9C-9251-6A77EE84882E}"/>
+                <a16:creationId xmlns:a16="http://schemas.microsoft.com/office/drawing/2014/main" id="{ECE60E9A-0985-49C4-8029-F000517881F1}"/>
               </a:ext>
             </a:extLst>
           </p:cNvPr>
@@ -10790,7 +10790,7 @@
           <p:cNvPr id="6" name="">
             <a:extLst xmlns:a="http://schemas.openxmlformats.org/drawingml/2006/main">
               <a:ext uri="{FF2B5EF4-FFF2-40B4-BE49-F238E27FC236}">
-                <a16:creationId xmlns:a16="http://schemas.microsoft.com/office/drawing/2014/main" id="{A87F2E4F-7121-4B0F-B28C-C507C5DA2701}"/>
+                <a16:creationId xmlns:a16="http://schemas.microsoft.com/office/drawing/2014/main" id="{02B08C9E-4ADC-4AE3-ADFC-0377B5D46966}"/>
               </a:ext>
             </a:extLst>
           </p:cNvPr>
@@ -10825,7 +10825,7 @@
           <p:cNvPr id="7" name="">
             <a:extLst xmlns:a="http://schemas.openxmlformats.org/drawingml/2006/main">
               <a:ext uri="{FF2B5EF4-FFF2-40B4-BE49-F238E27FC236}">
-                <a16:creationId xmlns:a16="http://schemas.microsoft.com/office/drawing/2014/main" id="{80A1D1FC-29B6-4F1D-B42B-DE396ADB96D4}"/>
+                <a16:creationId xmlns:a16="http://schemas.microsoft.com/office/drawing/2014/main" id="{7029F22B-363D-47DF-B54F-289307A0081D}"/>
               </a:ext>
             </a:extLst>
           </p:cNvPr>
@@ -10883,7 +10883,7 @@
           <p:cNvPr id="8" name="">
             <a:extLst xmlns:a="http://schemas.openxmlformats.org/drawingml/2006/main">
               <a:ext uri="{FF2B5EF4-FFF2-40B4-BE49-F238E27FC236}">
-                <a16:creationId xmlns:a16="http://schemas.microsoft.com/office/drawing/2014/main" id="{C4F126A2-AF6C-4399-8A34-3C9F69251208}"/>
+                <a16:creationId xmlns:a16="http://schemas.microsoft.com/office/drawing/2014/main" id="{8E94079B-3FDD-4954-AE90-0FF8BF1B8888}"/>
               </a:ext>
             </a:extLst>
           </p:cNvPr>
@@ -10918,7 +10918,7 @@
           <p:cNvPr id="9" name="">
             <a:extLst xmlns:a="http://schemas.openxmlformats.org/drawingml/2006/main">
               <a:ext uri="{FF2B5EF4-FFF2-40B4-BE49-F238E27FC236}">
-                <a16:creationId xmlns:a16="http://schemas.microsoft.com/office/drawing/2014/main" id="{1AFD7ECF-7663-4D89-AA4D-BCB1F9862F32}"/>
+                <a16:creationId xmlns:a16="http://schemas.microsoft.com/office/drawing/2014/main" id="{2CC9B9D9-7C43-4BBE-9D96-C6BE9A9FC1E5}"/>
               </a:ext>
             </a:extLst>
           </p:cNvPr>
@@ -10976,7 +10976,7 @@
           <p:cNvPr id="10" name="">
             <a:extLst xmlns:a="http://schemas.openxmlformats.org/drawingml/2006/main">
               <a:ext uri="{FF2B5EF4-FFF2-40B4-BE49-F238E27FC236}">
-                <a16:creationId xmlns:a16="http://schemas.microsoft.com/office/drawing/2014/main" id="{F60DB806-71D4-46F4-9EFD-AF6D9321EAB8}"/>
+                <a16:creationId xmlns:a16="http://schemas.microsoft.com/office/drawing/2014/main" id="{E20A5551-87EF-4CCB-BB80-3FD9E467887D}"/>
               </a:ext>
             </a:extLst>
           </p:cNvPr>
@@ -11011,7 +11011,7 @@
           <p:cNvPr id="11" name="">
             <a:extLst xmlns:a="http://schemas.openxmlformats.org/drawingml/2006/main">
               <a:ext uri="{FF2B5EF4-FFF2-40B4-BE49-F238E27FC236}">
-                <a16:creationId xmlns:a16="http://schemas.microsoft.com/office/drawing/2014/main" id="{9ED5DD67-8E4E-4118-8296-738C90558C10}"/>
+                <a16:creationId xmlns:a16="http://schemas.microsoft.com/office/drawing/2014/main" id="{70AFAC29-E332-45EE-B1C4-E4DFB7B63F75}"/>
               </a:ext>
             </a:extLst>
           </p:cNvPr>
@@ -11069,7 +11069,7 @@
           <p:cNvPr id="12" name="">
             <a:extLst xmlns:a="http://schemas.openxmlformats.org/drawingml/2006/main">
               <a:ext uri="{FF2B5EF4-FFF2-40B4-BE49-F238E27FC236}">
-                <a16:creationId xmlns:a16="http://schemas.microsoft.com/office/drawing/2014/main" id="{CC336482-1927-433C-8C8F-DBBCFCD264D3}"/>
+                <a16:creationId xmlns:a16="http://schemas.microsoft.com/office/drawing/2014/main" id="{1C08B2B4-8087-4BC6-A95C-4EF090018078}"/>
               </a:ext>
             </a:extLst>
           </p:cNvPr>
@@ -11104,7 +11104,7 @@
           <p:cNvPr id="13" name="">
             <a:extLst xmlns:a="http://schemas.openxmlformats.org/drawingml/2006/main">
               <a:ext uri="{FF2B5EF4-FFF2-40B4-BE49-F238E27FC236}">
-                <a16:creationId xmlns:a16="http://schemas.microsoft.com/office/drawing/2014/main" id="{B68922C1-C4A4-421D-8C0E-82BCDDFB1396}"/>
+                <a16:creationId xmlns:a16="http://schemas.microsoft.com/office/drawing/2014/main" id="{0A46981C-707D-4486-97B5-F5B07C80738B}"/>
               </a:ext>
             </a:extLst>
           </p:cNvPr>
@@ -11162,7 +11162,7 @@
           <p:cNvPr id="14" name="">
             <a:extLst xmlns:a="http://schemas.openxmlformats.org/drawingml/2006/main">
               <a:ext uri="{FF2B5EF4-FFF2-40B4-BE49-F238E27FC236}">
-                <a16:creationId xmlns:a16="http://schemas.microsoft.com/office/drawing/2014/main" id="{AF4DED00-B2D1-4A5D-B197-06C8336BC421}"/>
+                <a16:creationId xmlns:a16="http://schemas.microsoft.com/office/drawing/2014/main" id="{E076CA2B-F4C2-4342-A67B-538DC2B8136B}"/>
               </a:ext>
             </a:extLst>
           </p:cNvPr>
@@ -11197,7 +11197,7 @@
           <p:cNvPr id="15" name="">
             <a:extLst xmlns:a="http://schemas.openxmlformats.org/drawingml/2006/main">
               <a:ext uri="{FF2B5EF4-FFF2-40B4-BE49-F238E27FC236}">
-                <a16:creationId xmlns:a16="http://schemas.microsoft.com/office/drawing/2014/main" id="{E3B201BC-67D7-4E81-A1DA-56973B7083AE}"/>
+                <a16:creationId xmlns:a16="http://schemas.microsoft.com/office/drawing/2014/main" id="{604FA6C3-190B-45E0-B427-16BE1FFCA1BD}"/>
               </a:ext>
             </a:extLst>
           </p:cNvPr>
@@ -11255,7 +11255,7 @@
           <p:cNvPr id="16" name="">
             <a:extLst xmlns:a="http://schemas.openxmlformats.org/drawingml/2006/main">
               <a:ext uri="{FF2B5EF4-FFF2-40B4-BE49-F238E27FC236}">
-                <a16:creationId xmlns:a16="http://schemas.microsoft.com/office/drawing/2014/main" id="{0BCE6B48-C087-4D68-9CC3-348EDEBBCCAF}"/>
+                <a16:creationId xmlns:a16="http://schemas.microsoft.com/office/drawing/2014/main" id="{DC9C08D0-A568-4AD5-9DE4-416C11B81D7C}"/>
               </a:ext>
             </a:extLst>
           </p:cNvPr>
@@ -11290,7 +11290,7 @@
           <p:cNvPr id="17" name="">
             <a:extLst xmlns:a="http://schemas.openxmlformats.org/drawingml/2006/main">
               <a:ext uri="{FF2B5EF4-FFF2-40B4-BE49-F238E27FC236}">
-                <a16:creationId xmlns:a16="http://schemas.microsoft.com/office/drawing/2014/main" id="{7991268A-A6B1-4B36-8F90-ACAC574C76DD}"/>
+                <a16:creationId xmlns:a16="http://schemas.microsoft.com/office/drawing/2014/main" id="{2591D3B3-990A-4B2E-A169-B857B3CB3E49}"/>
               </a:ext>
             </a:extLst>
           </p:cNvPr>
@@ -11348,7 +11348,7 @@
           <p:cNvPr id="18" name="">
             <a:extLst xmlns:a="http://schemas.openxmlformats.org/drawingml/2006/main">
               <a:ext uri="{FF2B5EF4-FFF2-40B4-BE49-F238E27FC236}">
-                <a16:creationId xmlns:a16="http://schemas.microsoft.com/office/drawing/2014/main" id="{D1329EFB-0A10-4903-9206-CF4C085BD6F8}"/>
+                <a16:creationId xmlns:a16="http://schemas.microsoft.com/office/drawing/2014/main" id="{94D8C66C-DBA6-4331-AF52-77BE965DCD77}"/>
               </a:ext>
             </a:extLst>
           </p:cNvPr>
@@ -11383,7 +11383,7 @@
           <p:cNvPr id="19" name="">
             <a:extLst xmlns:a="http://schemas.openxmlformats.org/drawingml/2006/main">
               <a:ext uri="{FF2B5EF4-FFF2-40B4-BE49-F238E27FC236}">
-                <a16:creationId xmlns:a16="http://schemas.microsoft.com/office/drawing/2014/main" id="{87D4E7DE-2C38-415B-8A0F-A461F58C8817}"/>
+                <a16:creationId xmlns:a16="http://schemas.microsoft.com/office/drawing/2014/main" id="{4CF54693-3D6F-4E17-805D-2B7CA1807807}"/>
               </a:ext>
             </a:extLst>
           </p:cNvPr>
@@ -11441,7 +11441,7 @@
           <p:cNvPr id="20" name="">
             <a:extLst xmlns:a="http://schemas.openxmlformats.org/drawingml/2006/main">
               <a:ext uri="{FF2B5EF4-FFF2-40B4-BE49-F238E27FC236}">
-                <a16:creationId xmlns:a16="http://schemas.microsoft.com/office/drawing/2014/main" id="{7323A28D-2A29-43C6-ADDE-0C483185BB58}"/>
+                <a16:creationId xmlns:a16="http://schemas.microsoft.com/office/drawing/2014/main" id="{BF8F3323-0BB7-4343-ADCE-48478FFC9C4E}"/>
               </a:ext>
             </a:extLst>
           </p:cNvPr>
@@ -11476,7 +11476,7 @@
           <p:cNvPr id="21" name="">
             <a:extLst xmlns:a="http://schemas.openxmlformats.org/drawingml/2006/main">
               <a:ext uri="{FF2B5EF4-FFF2-40B4-BE49-F238E27FC236}">
-                <a16:creationId xmlns:a16="http://schemas.microsoft.com/office/drawing/2014/main" id="{FEC27672-E092-474F-9C63-9A153D51C014}"/>
+                <a16:creationId xmlns:a16="http://schemas.microsoft.com/office/drawing/2014/main" id="{04F25944-3D90-4AEA-B881-635F87FAF607}"/>
               </a:ext>
             </a:extLst>
           </p:cNvPr>
@@ -11534,7 +11534,7 @@
           <p:cNvPr id="22" name="">
             <a:extLst xmlns:a="http://schemas.openxmlformats.org/drawingml/2006/main">
               <a:ext uri="{FF2B5EF4-FFF2-40B4-BE49-F238E27FC236}">
-                <a16:creationId xmlns:a16="http://schemas.microsoft.com/office/drawing/2014/main" id="{7BEED5C7-953A-4B7F-93C4-363B2186D049}"/>
+                <a16:creationId xmlns:a16="http://schemas.microsoft.com/office/drawing/2014/main" id="{FA31F7C8-FE23-4418-95B0-F7617CA11E6F}"/>
               </a:ext>
             </a:extLst>
           </p:cNvPr>
@@ -11569,7 +11569,7 @@
           <p:cNvPr id="23" name="">
             <a:extLst xmlns:a="http://schemas.openxmlformats.org/drawingml/2006/main">
               <a:ext uri="{FF2B5EF4-FFF2-40B4-BE49-F238E27FC236}">
-                <a16:creationId xmlns:a16="http://schemas.microsoft.com/office/drawing/2014/main" id="{245E0ECE-61BA-413F-B042-272F0D764D00}"/>
+                <a16:creationId xmlns:a16="http://schemas.microsoft.com/office/drawing/2014/main" id="{C4E18976-0876-40FD-BE8C-7289B8ADEE2C}"/>
               </a:ext>
             </a:extLst>
           </p:cNvPr>
@@ -11627,7 +11627,7 @@
           <p:cNvPr id="24" name="">
             <a:extLst xmlns:a="http://schemas.openxmlformats.org/drawingml/2006/main">
               <a:ext uri="{FF2B5EF4-FFF2-40B4-BE49-F238E27FC236}">
-                <a16:creationId xmlns:a16="http://schemas.microsoft.com/office/drawing/2014/main" id="{7CB5962C-3927-4FFE-BD1C-923552390734}"/>
+                <a16:creationId xmlns:a16="http://schemas.microsoft.com/office/drawing/2014/main" id="{D081C471-0CC4-4F76-85C1-8B3830DF7015}"/>
               </a:ext>
             </a:extLst>
           </p:cNvPr>
@@ -11685,7 +11685,7 @@
           <p:cNvPr id="25" name="">
             <a:extLst xmlns:a="http://schemas.openxmlformats.org/drawingml/2006/main">
               <a:ext uri="{FF2B5EF4-FFF2-40B4-BE49-F238E27FC236}">
-                <a16:creationId xmlns:a16="http://schemas.microsoft.com/office/drawing/2014/main" id="{71A18678-12A6-4C01-BD8A-0B07B0BED1A1}"/>
+                <a16:creationId xmlns:a16="http://schemas.microsoft.com/office/drawing/2014/main" id="{0662AE24-9C5D-4A5C-87A0-273CA486CA3E}"/>
               </a:ext>
             </a:extLst>
           </p:cNvPr>
@@ -11743,7 +11743,7 @@
           <p:cNvPr id="26" name="">
             <a:extLst xmlns:a="http://schemas.openxmlformats.org/drawingml/2006/main">
               <a:ext uri="{FF2B5EF4-FFF2-40B4-BE49-F238E27FC236}">
-                <a16:creationId xmlns:a16="http://schemas.microsoft.com/office/drawing/2014/main" id="{9084C15A-6942-47ED-A333-8C6C85F79564}"/>
+                <a16:creationId xmlns:a16="http://schemas.microsoft.com/office/drawing/2014/main" id="{21404B4B-F60E-4ED5-A75F-B8D08E58437D}"/>
               </a:ext>
             </a:extLst>
           </p:cNvPr>
@@ -11801,7 +11801,7 @@
           <p:cNvPr id="27" name="">
             <a:extLst xmlns:a="http://schemas.openxmlformats.org/drawingml/2006/main">
               <a:ext uri="{FF2B5EF4-FFF2-40B4-BE49-F238E27FC236}">
-                <a16:creationId xmlns:a16="http://schemas.microsoft.com/office/drawing/2014/main" id="{1C8D85E6-4155-448C-AD7E-5E10D7F85E2F}"/>
+                <a16:creationId xmlns:a16="http://schemas.microsoft.com/office/drawing/2014/main" id="{38BA8AED-BD43-4707-B923-03201FF2EB53}"/>
               </a:ext>
             </a:extLst>
           </p:cNvPr>
@@ -11857,7 +11857,7 @@
     </p:spTree>
     <p:extLst>
       <p:ext uri="{BB962C8B-B14F-4D97-AF65-F5344CB8AC3E}">
-        <p14:creationId xmlns:p14="http://schemas.microsoft.com/office/powerpoint/2010/main" val="1333036210"/>
+        <p14:creationId xmlns:p14="http://schemas.microsoft.com/office/powerpoint/2010/main" val="472288746"/>
       </p:ext>
     </p:extLst>
   </p:cSld>
@@ -11888,7 +11888,7 @@
           <p:cNvPr id="27" name="">
             <a:extLst xmlns:a="http://schemas.openxmlformats.org/drawingml/2006/main">
               <a:ext uri="{FF2B5EF4-FFF2-40B4-BE49-F238E27FC236}">
-                <a16:creationId xmlns:a16="http://schemas.microsoft.com/office/drawing/2014/main" id="{97D4B503-0E9C-4811-8A03-35554B397BED}"/>
+                <a16:creationId xmlns:a16="http://schemas.microsoft.com/office/drawing/2014/main" id="{63EE1C6D-85D7-41D1-8A17-2A7B5ED75FE4}"/>
               </a:ext>
             </a:extLst>
           </p:cNvPr>
@@ -11946,7 +11946,7 @@
           <p:cNvPr id="2" name="">
             <a:extLst xmlns:a="http://schemas.openxmlformats.org/drawingml/2006/main">
               <a:ext uri="{FF2B5EF4-FFF2-40B4-BE49-F238E27FC236}">
-                <a16:creationId xmlns:a16="http://schemas.microsoft.com/office/drawing/2014/main" id="{9D483A54-2F48-4D2F-A8E8-580B48EABC6D}"/>
+                <a16:creationId xmlns:a16="http://schemas.microsoft.com/office/drawing/2014/main" id="{052F09CE-9277-4479-9341-E45C28C6B213}"/>
               </a:ext>
             </a:extLst>
           </p:cNvPr>
@@ -12004,7 +12004,7 @@
           <p:cNvPr id="3" name="">
             <a:extLst xmlns:a="http://schemas.openxmlformats.org/drawingml/2006/main">
               <a:ext uri="{FF2B5EF4-FFF2-40B4-BE49-F238E27FC236}">
-                <a16:creationId xmlns:a16="http://schemas.microsoft.com/office/drawing/2014/main" id="{285C12B2-6E3C-448C-8B04-81CD2610AD6A}"/>
+                <a16:creationId xmlns:a16="http://schemas.microsoft.com/office/drawing/2014/main" id="{3CC55FAB-D16A-4F0A-9F34-FC66098964A9}"/>
               </a:ext>
             </a:extLst>
           </p:cNvPr>
@@ -12037,7 +12037,7 @@
           <p:cNvPr id="4" name="">
             <a:extLst xmlns:a="http://schemas.openxmlformats.org/drawingml/2006/main">
               <a:ext uri="{FF2B5EF4-FFF2-40B4-BE49-F238E27FC236}">
-                <a16:creationId xmlns:a16="http://schemas.microsoft.com/office/drawing/2014/main" id="{759D859F-C478-4362-A032-A42FF49621D7}"/>
+                <a16:creationId xmlns:a16="http://schemas.microsoft.com/office/drawing/2014/main" id="{7998E5F1-31A8-4394-BEDE-1FC58445CCF6}"/>
               </a:ext>
             </a:extLst>
           </p:cNvPr>
@@ -12095,7 +12095,7 @@
           <p:cNvPr id="5" name="">
             <a:extLst xmlns:a="http://schemas.openxmlformats.org/drawingml/2006/main">
               <a:ext uri="{FF2B5EF4-FFF2-40B4-BE49-F238E27FC236}">
-                <a16:creationId xmlns:a16="http://schemas.microsoft.com/office/drawing/2014/main" id="{E8FC80B4-A93A-4C4D-A903-E44A327E1673}"/>
+                <a16:creationId xmlns:a16="http://schemas.microsoft.com/office/drawing/2014/main" id="{C50C3452-556B-41AF-8E44-54197D939E08}"/>
               </a:ext>
             </a:extLst>
           </p:cNvPr>
@@ -12153,7 +12153,7 @@
           <p:cNvPr id="6" name="">
             <a:extLst xmlns:a="http://schemas.openxmlformats.org/drawingml/2006/main">
               <a:ext uri="{FF2B5EF4-FFF2-40B4-BE49-F238E27FC236}">
-                <a16:creationId xmlns:a16="http://schemas.microsoft.com/office/drawing/2014/main" id="{EAB310EC-D6FE-4C8F-9904-888DAAF93A85}"/>
+                <a16:creationId xmlns:a16="http://schemas.microsoft.com/office/drawing/2014/main" id="{12064D8E-6EFF-41C9-9D54-59269D20697A}"/>
               </a:ext>
             </a:extLst>
           </p:cNvPr>
@@ -12188,7 +12188,7 @@
           <p:cNvPr id="7" name="">
             <a:extLst xmlns:a="http://schemas.openxmlformats.org/drawingml/2006/main">
               <a:ext uri="{FF2B5EF4-FFF2-40B4-BE49-F238E27FC236}">
-                <a16:creationId xmlns:a16="http://schemas.microsoft.com/office/drawing/2014/main" id="{018FFA2C-F70A-4EC0-879C-6FB3CE17BEDA}"/>
+                <a16:creationId xmlns:a16="http://schemas.microsoft.com/office/drawing/2014/main" id="{F37CC875-203E-4DB7-8ABD-DC52F39E95B3}"/>
               </a:ext>
             </a:extLst>
           </p:cNvPr>
@@ -12246,7 +12246,7 @@
           <p:cNvPr id="8" name="">
             <a:extLst xmlns:a="http://schemas.openxmlformats.org/drawingml/2006/main">
               <a:ext uri="{FF2B5EF4-FFF2-40B4-BE49-F238E27FC236}">
-                <a16:creationId xmlns:a16="http://schemas.microsoft.com/office/drawing/2014/main" id="{8CFC4F2D-E3DB-470D-B4C3-A5760B6CF747}"/>
+                <a16:creationId xmlns:a16="http://schemas.microsoft.com/office/drawing/2014/main" id="{4AE573E6-F4E5-45ED-B932-C00896A91099}"/>
               </a:ext>
             </a:extLst>
           </p:cNvPr>
@@ -12277,7 +12277,7 @@
           <p:cNvPr id="9" name="">
             <a:extLst xmlns:a="http://schemas.openxmlformats.org/drawingml/2006/main">
               <a:ext uri="{FF2B5EF4-FFF2-40B4-BE49-F238E27FC236}">
-                <a16:creationId xmlns:a16="http://schemas.microsoft.com/office/drawing/2014/main" id="{055C6F7B-70D3-45C9-A4E2-CDD72A3A30C0}"/>
+                <a16:creationId xmlns:a16="http://schemas.microsoft.com/office/drawing/2014/main" id="{FC3D9141-1732-435D-BA49-0CB7EC1AE498}"/>
               </a:ext>
             </a:extLst>
           </p:cNvPr>
@@ -12335,7 +12335,7 @@
           <p:cNvPr id="10" name="">
             <a:extLst xmlns:a="http://schemas.openxmlformats.org/drawingml/2006/main">
               <a:ext uri="{FF2B5EF4-FFF2-40B4-BE49-F238E27FC236}">
-                <a16:creationId xmlns:a16="http://schemas.microsoft.com/office/drawing/2014/main" id="{1FDC6712-6BDC-4626-B9F4-05AC244EF6BD}"/>
+                <a16:creationId xmlns:a16="http://schemas.microsoft.com/office/drawing/2014/main" id="{91AA63A9-452F-4460-9C5B-EC07E03019A0}"/>
               </a:ext>
             </a:extLst>
           </p:cNvPr>
@@ -12393,7 +12393,7 @@
           <p:cNvPr id="11" name="">
             <a:extLst xmlns:a="http://schemas.openxmlformats.org/drawingml/2006/main">
               <a:ext uri="{FF2B5EF4-FFF2-40B4-BE49-F238E27FC236}">
-                <a16:creationId xmlns:a16="http://schemas.microsoft.com/office/drawing/2014/main" id="{6EE29B61-51B8-4139-A097-CE04CBE154E4}"/>
+                <a16:creationId xmlns:a16="http://schemas.microsoft.com/office/drawing/2014/main" id="{EDF998DA-656D-470B-A2D1-8E9CAD3F8AE0}"/>
               </a:ext>
             </a:extLst>
           </p:cNvPr>
@@ -12428,7 +12428,7 @@
           <p:cNvPr id="12" name="">
             <a:extLst xmlns:a="http://schemas.openxmlformats.org/drawingml/2006/main">
               <a:ext uri="{FF2B5EF4-FFF2-40B4-BE49-F238E27FC236}">
-                <a16:creationId xmlns:a16="http://schemas.microsoft.com/office/drawing/2014/main" id="{B3A417D0-6077-4A04-BA3D-7E1E98AA503A}"/>
+                <a16:creationId xmlns:a16="http://schemas.microsoft.com/office/drawing/2014/main" id="{F4642A1E-031E-4EEF-9C9B-B819C96E2F50}"/>
               </a:ext>
             </a:extLst>
           </p:cNvPr>
@@ -12486,7 +12486,7 @@
           <p:cNvPr id="13" name="">
             <a:extLst xmlns:a="http://schemas.openxmlformats.org/drawingml/2006/main">
               <a:ext uri="{FF2B5EF4-FFF2-40B4-BE49-F238E27FC236}">
-                <a16:creationId xmlns:a16="http://schemas.microsoft.com/office/drawing/2014/main" id="{97254932-5B34-4388-9A54-3092E390EC2F}"/>
+                <a16:creationId xmlns:a16="http://schemas.microsoft.com/office/drawing/2014/main" id="{88E73252-3678-4317-9311-6F0CA60E1AAA}"/>
               </a:ext>
             </a:extLst>
           </p:cNvPr>
@@ -12517,7 +12517,7 @@
           <p:cNvPr id="14" name="">
             <a:extLst xmlns:a="http://schemas.openxmlformats.org/drawingml/2006/main">
               <a:ext uri="{FF2B5EF4-FFF2-40B4-BE49-F238E27FC236}">
-                <a16:creationId xmlns:a16="http://schemas.microsoft.com/office/drawing/2014/main" id="{16820E39-CD92-45A7-ADFA-40B041B1CB60}"/>
+                <a16:creationId xmlns:a16="http://schemas.microsoft.com/office/drawing/2014/main" id="{7F95EE5D-34D9-4444-980F-B679E296714B}"/>
               </a:ext>
             </a:extLst>
           </p:cNvPr>
@@ -12575,7 +12575,7 @@
           <p:cNvPr id="15" name="">
             <a:extLst xmlns:a="http://schemas.openxmlformats.org/drawingml/2006/main">
               <a:ext uri="{FF2B5EF4-FFF2-40B4-BE49-F238E27FC236}">
-                <a16:creationId xmlns:a16="http://schemas.microsoft.com/office/drawing/2014/main" id="{009C6CA7-8DC5-4F88-BE3D-B8A32866966C}"/>
+                <a16:creationId xmlns:a16="http://schemas.microsoft.com/office/drawing/2014/main" id="{F4772A7D-6E19-497F-B847-8D9BD1DB0230}"/>
               </a:ext>
             </a:extLst>
           </p:cNvPr>
@@ -12633,7 +12633,7 @@
           <p:cNvPr id="16" name="">
             <a:extLst xmlns:a="http://schemas.openxmlformats.org/drawingml/2006/main">
               <a:ext uri="{FF2B5EF4-FFF2-40B4-BE49-F238E27FC236}">
-                <a16:creationId xmlns:a16="http://schemas.microsoft.com/office/drawing/2014/main" id="{A6068692-3E12-4623-BFFB-B09562DDCC90}"/>
+                <a16:creationId xmlns:a16="http://schemas.microsoft.com/office/drawing/2014/main" id="{13C0D0A9-CF78-485C-BD0E-E5DB0DA91418}"/>
               </a:ext>
             </a:extLst>
           </p:cNvPr>
@@ -12668,7 +12668,7 @@
           <p:cNvPr id="17" name="">
             <a:extLst xmlns:a="http://schemas.openxmlformats.org/drawingml/2006/main">
               <a:ext uri="{FF2B5EF4-FFF2-40B4-BE49-F238E27FC236}">
-                <a16:creationId xmlns:a16="http://schemas.microsoft.com/office/drawing/2014/main" id="{97CCAA87-228F-4CE8-8984-F433C85EFD9E}"/>
+                <a16:creationId xmlns:a16="http://schemas.microsoft.com/office/drawing/2014/main" id="{450A6AA0-6770-4653-A91C-E5040108D03B}"/>
               </a:ext>
             </a:extLst>
           </p:cNvPr>
@@ -12726,7 +12726,7 @@
           <p:cNvPr id="18" name="">
             <a:extLst xmlns:a="http://schemas.openxmlformats.org/drawingml/2006/main">
               <a:ext uri="{FF2B5EF4-FFF2-40B4-BE49-F238E27FC236}">
-                <a16:creationId xmlns:a16="http://schemas.microsoft.com/office/drawing/2014/main" id="{580BCEA2-D68E-4605-9713-9AF3BCE49D45}"/>
+                <a16:creationId xmlns:a16="http://schemas.microsoft.com/office/drawing/2014/main" id="{3D5B32E8-7A93-4E69-979B-4E6E869CD6EA}"/>
               </a:ext>
             </a:extLst>
           </p:cNvPr>
@@ -12757,7 +12757,7 @@
           <p:cNvPr id="19" name="">
             <a:extLst xmlns:a="http://schemas.openxmlformats.org/drawingml/2006/main">
               <a:ext uri="{FF2B5EF4-FFF2-40B4-BE49-F238E27FC236}">
-                <a16:creationId xmlns:a16="http://schemas.microsoft.com/office/drawing/2014/main" id="{C6F100DA-2006-49B6-88BC-E5823C067CE2}"/>
+                <a16:creationId xmlns:a16="http://schemas.microsoft.com/office/drawing/2014/main" id="{3F37109D-2330-4F7B-9980-AB3361220B70}"/>
               </a:ext>
             </a:extLst>
           </p:cNvPr>
@@ -12815,7 +12815,7 @@
           <p:cNvPr id="20" name="">
             <a:extLst xmlns:a="http://schemas.openxmlformats.org/drawingml/2006/main">
               <a:ext uri="{FF2B5EF4-FFF2-40B4-BE49-F238E27FC236}">
-                <a16:creationId xmlns:a16="http://schemas.microsoft.com/office/drawing/2014/main" id="{F8CF12D9-7390-4F6B-9DCC-6D6B19D96D5A}"/>
+                <a16:creationId xmlns:a16="http://schemas.microsoft.com/office/drawing/2014/main" id="{7E45BB5E-727E-4FAD-9DAF-75FD1C824AAB}"/>
               </a:ext>
             </a:extLst>
           </p:cNvPr>
@@ -12873,7 +12873,7 @@
           <p:cNvPr id="21" name="">
             <a:extLst xmlns:a="http://schemas.openxmlformats.org/drawingml/2006/main">
               <a:ext uri="{FF2B5EF4-FFF2-40B4-BE49-F238E27FC236}">
-                <a16:creationId xmlns:a16="http://schemas.microsoft.com/office/drawing/2014/main" id="{B2DE228E-0CDA-4022-94F1-AF7113B1E484}"/>
+                <a16:creationId xmlns:a16="http://schemas.microsoft.com/office/drawing/2014/main" id="{5D2A85B0-7EEB-4083-A61A-ED22E82FB92B}"/>
               </a:ext>
             </a:extLst>
           </p:cNvPr>
@@ -12908,7 +12908,7 @@
           <p:cNvPr id="22" name="">
             <a:extLst xmlns:a="http://schemas.openxmlformats.org/drawingml/2006/main">
               <a:ext uri="{FF2B5EF4-FFF2-40B4-BE49-F238E27FC236}">
-                <a16:creationId xmlns:a16="http://schemas.microsoft.com/office/drawing/2014/main" id="{AD99C237-DFF6-4343-89D2-7719104C10AC}"/>
+                <a16:creationId xmlns:a16="http://schemas.microsoft.com/office/drawing/2014/main" id="{5E82B86F-725D-4461-A19C-332EA290B7D7}"/>
               </a:ext>
             </a:extLst>
           </p:cNvPr>
@@ -12966,7 +12966,7 @@
           <p:cNvPr id="23" name="">
             <a:extLst xmlns:a="http://schemas.openxmlformats.org/drawingml/2006/main">
               <a:ext uri="{FF2B5EF4-FFF2-40B4-BE49-F238E27FC236}">
-                <a16:creationId xmlns:a16="http://schemas.microsoft.com/office/drawing/2014/main" id="{17B0DFA2-573D-44B1-AB02-F325DCA7E628}"/>
+                <a16:creationId xmlns:a16="http://schemas.microsoft.com/office/drawing/2014/main" id="{878FB2B0-9F7B-4495-95E4-DA2C6B8E13F6}"/>
               </a:ext>
             </a:extLst>
           </p:cNvPr>
@@ -12997,7 +12997,7 @@
           <p:cNvPr id="24" name="">
             <a:extLst xmlns:a="http://schemas.openxmlformats.org/drawingml/2006/main">
               <a:ext uri="{FF2B5EF4-FFF2-40B4-BE49-F238E27FC236}">
-                <a16:creationId xmlns:a16="http://schemas.microsoft.com/office/drawing/2014/main" id="{239EE784-EA9D-4768-A350-FA54D2EEFDD7}"/>
+                <a16:creationId xmlns:a16="http://schemas.microsoft.com/office/drawing/2014/main" id="{75BA9053-6031-49C7-BCD4-3CB9BDBEC839}"/>
               </a:ext>
             </a:extLst>
           </p:cNvPr>
@@ -13055,7 +13055,7 @@
           <p:cNvPr id="25" name="">
             <a:extLst xmlns:a="http://schemas.openxmlformats.org/drawingml/2006/main">
               <a:ext uri="{FF2B5EF4-FFF2-40B4-BE49-F238E27FC236}">
-                <a16:creationId xmlns:a16="http://schemas.microsoft.com/office/drawing/2014/main" id="{23F25096-094E-4709-BA4E-6A114C24DF6D}"/>
+                <a16:creationId xmlns:a16="http://schemas.microsoft.com/office/drawing/2014/main" id="{F47EBE48-78B8-4796-A96B-67064AEC4EB7}"/>
               </a:ext>
             </a:extLst>
           </p:cNvPr>
@@ -13113,7 +13113,7 @@
           <p:cNvPr id="26" name="">
             <a:extLst xmlns:a="http://schemas.openxmlformats.org/drawingml/2006/main">
               <a:ext uri="{FF2B5EF4-FFF2-40B4-BE49-F238E27FC236}">
-                <a16:creationId xmlns:a16="http://schemas.microsoft.com/office/drawing/2014/main" id="{137AD444-BFAD-4AAD-9FC4-D75EFEF6C1F7}"/>
+                <a16:creationId xmlns:a16="http://schemas.microsoft.com/office/drawing/2014/main" id="{72334E68-09BB-4D00-B338-5990E246432B}"/>
               </a:ext>
             </a:extLst>
           </p:cNvPr>
@@ -13169,7 +13169,7 @@
     </p:spTree>
     <p:extLst>
       <p:ext uri="{BB962C8B-B14F-4D97-AF65-F5344CB8AC3E}">
-        <p14:creationId xmlns:p14="http://schemas.microsoft.com/office/powerpoint/2010/main" val="327706379"/>
+        <p14:creationId xmlns:p14="http://schemas.microsoft.com/office/powerpoint/2010/main" val="1680042441"/>
       </p:ext>
     </p:extLst>
   </p:cSld>
@@ -13200,7 +13200,7 @@
           <p:cNvPr id="22" name="">
             <a:extLst xmlns:a="http://schemas.openxmlformats.org/drawingml/2006/main">
               <a:ext uri="{FF2B5EF4-FFF2-40B4-BE49-F238E27FC236}">
-                <a16:creationId xmlns:a16="http://schemas.microsoft.com/office/drawing/2014/main" id="{32F46F4B-D135-46F9-B7CB-63E32F0CB067}"/>
+                <a16:creationId xmlns:a16="http://schemas.microsoft.com/office/drawing/2014/main" id="{A1210975-4D5F-496C-97D0-C6BD4530CB87}"/>
               </a:ext>
             </a:extLst>
           </p:cNvPr>
@@ -13258,7 +13258,7 @@
           <p:cNvPr id="2" name="">
             <a:extLst xmlns:a="http://schemas.openxmlformats.org/drawingml/2006/main">
               <a:ext uri="{FF2B5EF4-FFF2-40B4-BE49-F238E27FC236}">
-                <a16:creationId xmlns:a16="http://schemas.microsoft.com/office/drawing/2014/main" id="{3C2AB724-7E34-483A-A829-90A0C7029681}"/>
+                <a16:creationId xmlns:a16="http://schemas.microsoft.com/office/drawing/2014/main" id="{1F355F9C-6A45-4882-B9C7-417C39AE6A58}"/>
               </a:ext>
             </a:extLst>
           </p:cNvPr>
@@ -13316,7 +13316,7 @@
           <p:cNvPr id="3" name="">
             <a:extLst xmlns:a="http://schemas.openxmlformats.org/drawingml/2006/main">
               <a:ext uri="{FF2B5EF4-FFF2-40B4-BE49-F238E27FC236}">
-                <a16:creationId xmlns:a16="http://schemas.microsoft.com/office/drawing/2014/main" id="{650DC558-2DD1-4101-BE67-158C5CC6803B}"/>
+                <a16:creationId xmlns:a16="http://schemas.microsoft.com/office/drawing/2014/main" id="{E07CAFDC-8B9E-4754-96F2-9879007374ED}"/>
               </a:ext>
             </a:extLst>
           </p:cNvPr>
@@ -13349,7 +13349,7 @@
           <p:cNvPr id="4" name="">
             <a:extLst xmlns:a="http://schemas.openxmlformats.org/drawingml/2006/main">
               <a:ext uri="{FF2B5EF4-FFF2-40B4-BE49-F238E27FC236}">
-                <a16:creationId xmlns:a16="http://schemas.microsoft.com/office/drawing/2014/main" id="{9B302E13-B6A4-4943-B2FA-945F8A60847B}"/>
+                <a16:creationId xmlns:a16="http://schemas.microsoft.com/office/drawing/2014/main" id="{D914EAD5-6002-4F30-BFBF-6FACBE470733}"/>
               </a:ext>
             </a:extLst>
           </p:cNvPr>
@@ -13407,7 +13407,7 @@
           <p:cNvPr id="5" name="">
             <a:extLst xmlns:a="http://schemas.openxmlformats.org/drawingml/2006/main">
               <a:ext uri="{FF2B5EF4-FFF2-40B4-BE49-F238E27FC236}">
-                <a16:creationId xmlns:a16="http://schemas.microsoft.com/office/drawing/2014/main" id="{B84999DE-7C53-4906-9845-0A760AA6BDF2}"/>
+                <a16:creationId xmlns:a16="http://schemas.microsoft.com/office/drawing/2014/main" id="{4F073C3E-86A7-46DF-91D6-FE7D262EF142}"/>
               </a:ext>
             </a:extLst>
           </p:cNvPr>
@@ -13465,7 +13465,7 @@
           <p:cNvPr id="6" name="">
             <a:extLst xmlns:a="http://schemas.openxmlformats.org/drawingml/2006/main">
               <a:ext uri="{FF2B5EF4-FFF2-40B4-BE49-F238E27FC236}">
-                <a16:creationId xmlns:a16="http://schemas.microsoft.com/office/drawing/2014/main" id="{57F0ED5F-C640-4C26-9187-9A65B074CCC5}"/>
+                <a16:creationId xmlns:a16="http://schemas.microsoft.com/office/drawing/2014/main" id="{97FE4158-1BCB-4942-90B5-D92A7B6A909D}"/>
               </a:ext>
             </a:extLst>
           </p:cNvPr>
@@ -13500,7 +13500,7 @@
           <p:cNvPr id="7" name="">
             <a:extLst xmlns:a="http://schemas.openxmlformats.org/drawingml/2006/main">
               <a:ext uri="{FF2B5EF4-FFF2-40B4-BE49-F238E27FC236}">
-                <a16:creationId xmlns:a16="http://schemas.microsoft.com/office/drawing/2014/main" id="{5B27C58B-D002-4298-BC13-0236F3890457}"/>
+                <a16:creationId xmlns:a16="http://schemas.microsoft.com/office/drawing/2014/main" id="{07446184-650E-44D2-AC6F-A23DC8A6571E}"/>
               </a:ext>
             </a:extLst>
           </p:cNvPr>
@@ -13533,7 +13533,7 @@
           <p:cNvPr id="8" name="">
             <a:extLst xmlns:a="http://schemas.openxmlformats.org/drawingml/2006/main">
               <a:ext uri="{FF2B5EF4-FFF2-40B4-BE49-F238E27FC236}">
-                <a16:creationId xmlns:a16="http://schemas.microsoft.com/office/drawing/2014/main" id="{22BA9DD6-AF91-46E4-84B2-BCAAB68CE64D}"/>
+                <a16:creationId xmlns:a16="http://schemas.microsoft.com/office/drawing/2014/main" id="{C1AEA51E-2BEC-415A-879E-33B2FD8E309E}"/>
               </a:ext>
             </a:extLst>
           </p:cNvPr>
@@ -13591,7 +13591,7 @@
           <p:cNvPr id="9" name="">
             <a:extLst xmlns:a="http://schemas.openxmlformats.org/drawingml/2006/main">
               <a:ext uri="{FF2B5EF4-FFF2-40B4-BE49-F238E27FC236}">
-                <a16:creationId xmlns:a16="http://schemas.microsoft.com/office/drawing/2014/main" id="{3D394856-5E69-471C-9007-8C48C6A6FFA2}"/>
+                <a16:creationId xmlns:a16="http://schemas.microsoft.com/office/drawing/2014/main" id="{14478468-FEDB-4B14-80EB-FB7F73FC76DF}"/>
               </a:ext>
             </a:extLst>
           </p:cNvPr>
@@ -13649,7 +13649,7 @@
           <p:cNvPr id="10" name="">
             <a:extLst xmlns:a="http://schemas.openxmlformats.org/drawingml/2006/main">
               <a:ext uri="{FF2B5EF4-FFF2-40B4-BE49-F238E27FC236}">
-                <a16:creationId xmlns:a16="http://schemas.microsoft.com/office/drawing/2014/main" id="{B9474AF5-6916-48EA-9FA2-34BA8481FE85}"/>
+                <a16:creationId xmlns:a16="http://schemas.microsoft.com/office/drawing/2014/main" id="{BA5D1167-8F01-4E91-BFF0-69E7407A7F7E}"/>
               </a:ext>
             </a:extLst>
           </p:cNvPr>
@@ -13684,7 +13684,7 @@
           <p:cNvPr id="11" name="">
             <a:extLst xmlns:a="http://schemas.openxmlformats.org/drawingml/2006/main">
               <a:ext uri="{FF2B5EF4-FFF2-40B4-BE49-F238E27FC236}">
-                <a16:creationId xmlns:a16="http://schemas.microsoft.com/office/drawing/2014/main" id="{F672A68E-619F-41DD-B76A-DFBB6300D812}"/>
+                <a16:creationId xmlns:a16="http://schemas.microsoft.com/office/drawing/2014/main" id="{C160F9E0-0E8B-45D7-BE51-7788BD852726}"/>
               </a:ext>
             </a:extLst>
           </p:cNvPr>
@@ -13717,7 +13717,7 @@
           <p:cNvPr id="12" name="">
             <a:extLst xmlns:a="http://schemas.openxmlformats.org/drawingml/2006/main">
               <a:ext uri="{FF2B5EF4-FFF2-40B4-BE49-F238E27FC236}">
-                <a16:creationId xmlns:a16="http://schemas.microsoft.com/office/drawing/2014/main" id="{9040084E-34E7-4376-9C2E-CDBFEED3D99D}"/>
+                <a16:creationId xmlns:a16="http://schemas.microsoft.com/office/drawing/2014/main" id="{089C1D0C-8DAD-4DAF-8249-68F48DCBFD9D}"/>
               </a:ext>
             </a:extLst>
           </p:cNvPr>
@@ -13775,7 +13775,7 @@
           <p:cNvPr id="13" name="">
             <a:extLst xmlns:a="http://schemas.openxmlformats.org/drawingml/2006/main">
               <a:ext uri="{FF2B5EF4-FFF2-40B4-BE49-F238E27FC236}">
-                <a16:creationId xmlns:a16="http://schemas.microsoft.com/office/drawing/2014/main" id="{4BEA3C62-D92F-4F6F-8768-45600B0F95B8}"/>
+                <a16:creationId xmlns:a16="http://schemas.microsoft.com/office/drawing/2014/main" id="{E88C2EC9-4F14-46BF-9F64-BA80B46BCD7A}"/>
               </a:ext>
             </a:extLst>
           </p:cNvPr>
@@ -13833,7 +13833,7 @@
           <p:cNvPr id="14" name="">
             <a:extLst xmlns:a="http://schemas.openxmlformats.org/drawingml/2006/main">
               <a:ext uri="{FF2B5EF4-FFF2-40B4-BE49-F238E27FC236}">
-                <a16:creationId xmlns:a16="http://schemas.microsoft.com/office/drawing/2014/main" id="{7B08E5B9-5749-4439-8EEC-C6EB6621E866}"/>
+                <a16:creationId xmlns:a16="http://schemas.microsoft.com/office/drawing/2014/main" id="{B729CBC3-9AF4-4944-A037-2F6C3AB43AB2}"/>
               </a:ext>
             </a:extLst>
           </p:cNvPr>
@@ -13868,7 +13868,7 @@
           <p:cNvPr id="15" name="">
             <a:extLst xmlns:a="http://schemas.openxmlformats.org/drawingml/2006/main">
               <a:ext uri="{FF2B5EF4-FFF2-40B4-BE49-F238E27FC236}">
-                <a16:creationId xmlns:a16="http://schemas.microsoft.com/office/drawing/2014/main" id="{D1C9A8DB-643A-40FE-8390-5BC10AFAA9B1}"/>
+                <a16:creationId xmlns:a16="http://schemas.microsoft.com/office/drawing/2014/main" id="{95D553E2-A9E0-4C29-9CCF-B74610164E47}"/>
               </a:ext>
             </a:extLst>
           </p:cNvPr>
@@ -13901,7 +13901,7 @@
           <p:cNvPr id="16" name="">
             <a:extLst xmlns:a="http://schemas.openxmlformats.org/drawingml/2006/main">
               <a:ext uri="{FF2B5EF4-FFF2-40B4-BE49-F238E27FC236}">
-                <a16:creationId xmlns:a16="http://schemas.microsoft.com/office/drawing/2014/main" id="{1F78A55B-2438-407B-912D-A114B91F3313}"/>
+                <a16:creationId xmlns:a16="http://schemas.microsoft.com/office/drawing/2014/main" id="{0D2F3DFC-92C9-4D5F-B659-410CB0DF83C5}"/>
               </a:ext>
             </a:extLst>
           </p:cNvPr>
@@ -13959,7 +13959,7 @@
           <p:cNvPr id="17" name="">
             <a:extLst xmlns:a="http://schemas.openxmlformats.org/drawingml/2006/main">
               <a:ext uri="{FF2B5EF4-FFF2-40B4-BE49-F238E27FC236}">
-                <a16:creationId xmlns:a16="http://schemas.microsoft.com/office/drawing/2014/main" id="{C2EE61F6-6DDC-4EF2-819B-3A0BAEEBB2FE}"/>
+                <a16:creationId xmlns:a16="http://schemas.microsoft.com/office/drawing/2014/main" id="{BE8B91CA-9562-498C-B1BB-D258A119DF76}"/>
               </a:ext>
             </a:extLst>
           </p:cNvPr>
@@ -14017,7 +14017,7 @@
           <p:cNvPr id="18" name="">
             <a:extLst xmlns:a="http://schemas.openxmlformats.org/drawingml/2006/main">
               <a:ext uri="{FF2B5EF4-FFF2-40B4-BE49-F238E27FC236}">
-                <a16:creationId xmlns:a16="http://schemas.microsoft.com/office/drawing/2014/main" id="{B428670B-1AFF-4542-87FC-E28EA302A1EF}"/>
+                <a16:creationId xmlns:a16="http://schemas.microsoft.com/office/drawing/2014/main" id="{FC16ACFD-8F70-4A93-85DF-407CA5EF0AC9}"/>
               </a:ext>
             </a:extLst>
           </p:cNvPr>
@@ -14052,7 +14052,7 @@
           <p:cNvPr id="19" name="">
             <a:extLst xmlns:a="http://schemas.openxmlformats.org/drawingml/2006/main">
               <a:ext uri="{FF2B5EF4-FFF2-40B4-BE49-F238E27FC236}">
-                <a16:creationId xmlns:a16="http://schemas.microsoft.com/office/drawing/2014/main" id="{048D114B-81B7-4F9E-92F0-0C9261B07909}"/>
+                <a16:creationId xmlns:a16="http://schemas.microsoft.com/office/drawing/2014/main" id="{FBC0AEF6-FFB9-4310-BBD7-EC27D2F8CABB}"/>
               </a:ext>
             </a:extLst>
           </p:cNvPr>
@@ -14085,7 +14085,7 @@
           <p:cNvPr id="20" name="">
             <a:extLst xmlns:a="http://schemas.openxmlformats.org/drawingml/2006/main">
               <a:ext uri="{FF2B5EF4-FFF2-40B4-BE49-F238E27FC236}">
-                <a16:creationId xmlns:a16="http://schemas.microsoft.com/office/drawing/2014/main" id="{4B104550-7FD8-4F2A-9476-ABF4DEAC2E93}"/>
+                <a16:creationId xmlns:a16="http://schemas.microsoft.com/office/drawing/2014/main" id="{DAFADF8E-7EC7-4308-9D70-CA3A7AFBE6F2}"/>
               </a:ext>
             </a:extLst>
           </p:cNvPr>
@@ -14143,7 +14143,7 @@
           <p:cNvPr id="21" name="">
             <a:extLst xmlns:a="http://schemas.openxmlformats.org/drawingml/2006/main">
               <a:ext uri="{FF2B5EF4-FFF2-40B4-BE49-F238E27FC236}">
-                <a16:creationId xmlns:a16="http://schemas.microsoft.com/office/drawing/2014/main" id="{1D2F8F0D-85CE-4121-AA22-EC542B7968C4}"/>
+                <a16:creationId xmlns:a16="http://schemas.microsoft.com/office/drawing/2014/main" id="{03B88493-726F-4259-921F-930A10CB9A51}"/>
               </a:ext>
             </a:extLst>
           </p:cNvPr>
@@ -14216,7 +14216,7 @@
     </p:spTree>
     <p:extLst>
       <p:ext uri="{BB962C8B-B14F-4D97-AF65-F5344CB8AC3E}">
-        <p14:creationId xmlns:p14="http://schemas.microsoft.com/office/powerpoint/2010/main" val="204919713"/>
+        <p14:creationId xmlns:p14="http://schemas.microsoft.com/office/powerpoint/2010/main" val="11751153"/>
       </p:ext>
     </p:extLst>
   </p:cSld>
@@ -14247,7 +14247,7 @@
           <p:cNvPr id="19" name="">
             <a:extLst xmlns:a="http://schemas.openxmlformats.org/drawingml/2006/main">
               <a:ext uri="{FF2B5EF4-FFF2-40B4-BE49-F238E27FC236}">
-                <a16:creationId xmlns:a16="http://schemas.microsoft.com/office/drawing/2014/main" id="{91135AC0-659C-4A9C-B470-0B8BF43129FE}"/>
+                <a16:creationId xmlns:a16="http://schemas.microsoft.com/office/drawing/2014/main" id="{0F597EB6-0935-484B-8A76-AD4FE0812D52}"/>
               </a:ext>
             </a:extLst>
           </p:cNvPr>
@@ -14305,7 +14305,7 @@
           <p:cNvPr id="2" name="">
             <a:extLst xmlns:a="http://schemas.openxmlformats.org/drawingml/2006/main">
               <a:ext uri="{FF2B5EF4-FFF2-40B4-BE49-F238E27FC236}">
-                <a16:creationId xmlns:a16="http://schemas.microsoft.com/office/drawing/2014/main" id="{6AA9606A-4282-4FC8-A6EB-9EE69ED01266}"/>
+                <a16:creationId xmlns:a16="http://schemas.microsoft.com/office/drawing/2014/main" id="{51DD31EC-4D2C-4DED-BA9A-ABAB15FB41ED}"/>
               </a:ext>
             </a:extLst>
           </p:cNvPr>
@@ -14363,7 +14363,7 @@
           <p:cNvPr id="3" name="">
             <a:extLst xmlns:a="http://schemas.openxmlformats.org/drawingml/2006/main">
               <a:ext uri="{FF2B5EF4-FFF2-40B4-BE49-F238E27FC236}">
-                <a16:creationId xmlns:a16="http://schemas.microsoft.com/office/drawing/2014/main" id="{973CD573-4E80-4A1F-BF39-1E51DA0F2985}"/>
+                <a16:creationId xmlns:a16="http://schemas.microsoft.com/office/drawing/2014/main" id="{BFE9AEB4-AB77-44D5-915F-5998BC36B54C}"/>
               </a:ext>
             </a:extLst>
           </p:cNvPr>
@@ -14396,7 +14396,7 @@
           <p:cNvPr id="4" name="">
             <a:extLst xmlns:a="http://schemas.openxmlformats.org/drawingml/2006/main">
               <a:ext uri="{FF2B5EF4-FFF2-40B4-BE49-F238E27FC236}">
-                <a16:creationId xmlns:a16="http://schemas.microsoft.com/office/drawing/2014/main" id="{B3158574-ACAD-486E-B837-381729BC6176}"/>
+                <a16:creationId xmlns:a16="http://schemas.microsoft.com/office/drawing/2014/main" id="{1898BF52-83B4-4E87-9056-3210AB2FE3E6}"/>
               </a:ext>
             </a:extLst>
           </p:cNvPr>
@@ -14454,7 +14454,7 @@
           <p:cNvPr id="5" name="">
             <a:extLst xmlns:a="http://schemas.openxmlformats.org/drawingml/2006/main">
               <a:ext uri="{FF2B5EF4-FFF2-40B4-BE49-F238E27FC236}">
-                <a16:creationId xmlns:a16="http://schemas.microsoft.com/office/drawing/2014/main" id="{B38B35A6-90C5-4ABB-8D0B-B91001CCC418}"/>
+                <a16:creationId xmlns:a16="http://schemas.microsoft.com/office/drawing/2014/main" id="{38C08208-F0B3-466B-BF59-BCE2E00C9990}"/>
               </a:ext>
             </a:extLst>
           </p:cNvPr>
@@ -14512,7 +14512,7 @@
           <p:cNvPr id="6" name="">
             <a:extLst xmlns:a="http://schemas.openxmlformats.org/drawingml/2006/main">
               <a:ext uri="{FF2B5EF4-FFF2-40B4-BE49-F238E27FC236}">
-                <a16:creationId xmlns:a16="http://schemas.microsoft.com/office/drawing/2014/main" id="{6713A565-9FD0-4807-B150-E493BBC1333A}"/>
+                <a16:creationId xmlns:a16="http://schemas.microsoft.com/office/drawing/2014/main" id="{9A1D87EF-05A6-43DE-92FE-C258E826766C}"/>
               </a:ext>
             </a:extLst>
           </p:cNvPr>
@@ -14547,7 +14547,7 @@
           <p:cNvPr id="7" name="">
             <a:extLst xmlns:a="http://schemas.openxmlformats.org/drawingml/2006/main">
               <a:ext uri="{FF2B5EF4-FFF2-40B4-BE49-F238E27FC236}">
-                <a16:creationId xmlns:a16="http://schemas.microsoft.com/office/drawing/2014/main" id="{2B1F601F-FEEE-4787-B39B-D1E4800A1E26}"/>
+                <a16:creationId xmlns:a16="http://schemas.microsoft.com/office/drawing/2014/main" id="{DBEEB4DE-512E-48D3-B544-4ECE4A170900}"/>
               </a:ext>
             </a:extLst>
           </p:cNvPr>
@@ -14595,7 +14595,7 @@
                   <a:srgbClr val="B42318"/>
                 </a:solidFill>
               </a:rPr>
-              <a:t>COMANDO[]</a:t>
+              <a:t>Letra, NaN o dato fuera de rango</a:t>
             </a:r>
           </a:p>
         </p:txBody>
@@ -14605,7 +14605,7 @@
           <p:cNvPr id="8" name="">
             <a:extLst xmlns:a="http://schemas.openxmlformats.org/drawingml/2006/main">
               <a:ext uri="{FF2B5EF4-FFF2-40B4-BE49-F238E27FC236}">
-                <a16:creationId xmlns:a16="http://schemas.microsoft.com/office/drawing/2014/main" id="{2A09E29E-06EB-4CD1-8F6A-5068A2D21D54}"/>
+                <a16:creationId xmlns:a16="http://schemas.microsoft.com/office/drawing/2014/main" id="{8059123C-FD74-497A-9310-3F7E9FFFF137}"/>
               </a:ext>
             </a:extLst>
           </p:cNvPr>
@@ -14653,7 +14653,7 @@
                   <a:srgbClr val="52606D"/>
                 </a:solidFill>
               </a:rPr>
-              <a:t>Rechaza la orden sin modificar datos</a:t>
+              <a:t>Rechaza la orden antes de ejecutar SQL</a:t>
             </a:r>
           </a:p>
         </p:txBody>
@@ -14663,7 +14663,7 @@
           <p:cNvPr id="9" name="">
             <a:extLst xmlns:a="http://schemas.openxmlformats.org/drawingml/2006/main">
               <a:ext uri="{FF2B5EF4-FFF2-40B4-BE49-F238E27FC236}">
-                <a16:creationId xmlns:a16="http://schemas.microsoft.com/office/drawing/2014/main" id="{37DF5904-174F-4196-8ED4-7A69FD243757}"/>
+                <a16:creationId xmlns:a16="http://schemas.microsoft.com/office/drawing/2014/main" id="{EFD56676-F140-4FDB-94BE-FA91E0D15052}"/>
               </a:ext>
             </a:extLst>
           </p:cNvPr>
@@ -14698,7 +14698,7 @@
           <p:cNvPr id="10" name="">
             <a:extLst xmlns:a="http://schemas.openxmlformats.org/drawingml/2006/main">
               <a:ext uri="{FF2B5EF4-FFF2-40B4-BE49-F238E27FC236}">
-                <a16:creationId xmlns:a16="http://schemas.microsoft.com/office/drawing/2014/main" id="{0697DE95-8958-4DCA-9AD4-AD73525B5846}"/>
+                <a16:creationId xmlns:a16="http://schemas.microsoft.com/office/drawing/2014/main" id="{7A7AA7F4-04B9-4D4F-A060-C433EC3D233F}"/>
               </a:ext>
             </a:extLst>
           </p:cNvPr>
@@ -14756,7 +14756,7 @@
           <p:cNvPr id="11" name="">
             <a:extLst xmlns:a="http://schemas.openxmlformats.org/drawingml/2006/main">
               <a:ext uri="{FF2B5EF4-FFF2-40B4-BE49-F238E27FC236}">
-                <a16:creationId xmlns:a16="http://schemas.microsoft.com/office/drawing/2014/main" id="{849FB25D-5C0C-48A8-ABFA-B78E88904BFB}"/>
+                <a16:creationId xmlns:a16="http://schemas.microsoft.com/office/drawing/2014/main" id="{B4F6D857-94EF-4CA6-96F2-95F6AEE7B9B3}"/>
               </a:ext>
             </a:extLst>
           </p:cNvPr>
@@ -14814,7 +14814,7 @@
           <p:cNvPr id="12" name="">
             <a:extLst xmlns:a="http://schemas.openxmlformats.org/drawingml/2006/main">
               <a:ext uri="{FF2B5EF4-FFF2-40B4-BE49-F238E27FC236}">
-                <a16:creationId xmlns:a16="http://schemas.microsoft.com/office/drawing/2014/main" id="{0C75709F-C434-4C3B-9C5B-7C0AE7E6771A}"/>
+                <a16:creationId xmlns:a16="http://schemas.microsoft.com/office/drawing/2014/main" id="{8C92BE74-DA96-4263-8CED-2EDB3217DE6A}"/>
               </a:ext>
             </a:extLst>
           </p:cNvPr>
@@ -14849,7 +14849,7 @@
           <p:cNvPr id="13" name="">
             <a:extLst xmlns:a="http://schemas.openxmlformats.org/drawingml/2006/main">
               <a:ext uri="{FF2B5EF4-FFF2-40B4-BE49-F238E27FC236}">
-                <a16:creationId xmlns:a16="http://schemas.microsoft.com/office/drawing/2014/main" id="{765F8E5F-DC18-4B88-B5C6-A3D0AB3FC782}"/>
+                <a16:creationId xmlns:a16="http://schemas.microsoft.com/office/drawing/2014/main" id="{36CB1A66-F6A0-4A36-BA49-9A8CF5154B41}"/>
               </a:ext>
             </a:extLst>
           </p:cNvPr>
@@ -14897,7 +14897,7 @@
                   <a:srgbClr val="B42318"/>
                 </a:solidFill>
               </a:rPr>
-              <a:t>Internet o Roundcube caído</a:t>
+              <a:t>Dos instancias activas</a:t>
             </a:r>
           </a:p>
         </p:txBody>
@@ -14907,7 +14907,7 @@
           <p:cNvPr id="14" name="">
             <a:extLst xmlns:a="http://schemas.openxmlformats.org/drawingml/2006/main">
               <a:ext uri="{FF2B5EF4-FFF2-40B4-BE49-F238E27FC236}">
-                <a16:creationId xmlns:a16="http://schemas.microsoft.com/office/drawing/2014/main" id="{82EAB345-51D9-4FD3-AD4F-E8DC4EBF7A48}"/>
+                <a16:creationId xmlns:a16="http://schemas.microsoft.com/office/drawing/2014/main" id="{DB068352-00D1-4EDB-9F03-A75D45E6AFE8}"/>
               </a:ext>
             </a:extLst>
           </p:cNvPr>
@@ -14955,7 +14955,7 @@
                   <a:srgbClr val="52606D"/>
                 </a:solidFill>
               </a:rPr>
-              <a:t>El proceso sigue activo y reconecta automáticamente</a:t>
+              <a:t>PostgreSQL concede el procesamiento a una sola</a:t>
             </a:r>
           </a:p>
         </p:txBody>
@@ -14965,7 +14965,7 @@
           <p:cNvPr id="15" name="">
             <a:extLst xmlns:a="http://schemas.openxmlformats.org/drawingml/2006/main">
               <a:ext uri="{FF2B5EF4-FFF2-40B4-BE49-F238E27FC236}">
-                <a16:creationId xmlns:a16="http://schemas.microsoft.com/office/drawing/2014/main" id="{57FD9167-F5F9-4DFE-BB6A-33F9E558CF72}"/>
+                <a16:creationId xmlns:a16="http://schemas.microsoft.com/office/drawing/2014/main" id="{19085886-803C-41D7-8DE4-5F1AECE00B13}"/>
               </a:ext>
             </a:extLst>
           </p:cNvPr>
@@ -15000,7 +15000,7 @@
           <p:cNvPr id="16" name="">
             <a:extLst xmlns:a="http://schemas.openxmlformats.org/drawingml/2006/main">
               <a:ext uri="{FF2B5EF4-FFF2-40B4-BE49-F238E27FC236}">
-                <a16:creationId xmlns:a16="http://schemas.microsoft.com/office/drawing/2014/main" id="{1AC38B76-D041-45F1-98BA-37ED8F8EEBC6}"/>
+                <a16:creationId xmlns:a16="http://schemas.microsoft.com/office/drawing/2014/main" id="{6FA2630A-7E2F-42E2-9C88-B0FB16383DE5}"/>
               </a:ext>
             </a:extLst>
           </p:cNvPr>
@@ -15058,7 +15058,7 @@
           <p:cNvPr id="17" name="">
             <a:extLst xmlns:a="http://schemas.openxmlformats.org/drawingml/2006/main">
               <a:ext uri="{FF2B5EF4-FFF2-40B4-BE49-F238E27FC236}">
-                <a16:creationId xmlns:a16="http://schemas.microsoft.com/office/drawing/2014/main" id="{E5CAD0D6-0555-43E7-A6A1-24BF9FE2540B}"/>
+                <a16:creationId xmlns:a16="http://schemas.microsoft.com/office/drawing/2014/main" id="{D57C48B8-272C-4CED-A5E2-1FF357DA2F05}"/>
               </a:ext>
             </a:extLst>
           </p:cNvPr>
@@ -15116,7 +15116,7 @@
           <p:cNvPr id="18" name="">
             <a:extLst xmlns:a="http://schemas.openxmlformats.org/drawingml/2006/main">
               <a:ext uri="{FF2B5EF4-FFF2-40B4-BE49-F238E27FC236}">
-                <a16:creationId xmlns:a16="http://schemas.microsoft.com/office/drawing/2014/main" id="{21753F27-43FE-4FF3-B545-91F6742A4B2E}"/>
+                <a16:creationId xmlns:a16="http://schemas.microsoft.com/office/drawing/2014/main" id="{05C9ABDD-E407-49D5-9843-ED633E1989C0}"/>
               </a:ext>
             </a:extLst>
           </p:cNvPr>
@@ -15164,7 +15164,7 @@
                   <a:srgbClr val="17365D"/>
                 </a:solidFill>
               </a:rPr>
-              <a:t>Pruebas automatizadas y 1.000.000 de asuntos aleatorios. Los cortes simulados no detuvieron el servicio.</a:t>
+              <a:t>18 pruebas automatizadas y 1.000.000 de asuntos aleatorios. Java y PostgreSQL validan rangos.</a:t>
             </a:r>
           </a:p>
         </p:txBody>
@@ -15172,7 +15172,7 @@
     </p:spTree>
     <p:extLst>
       <p:ext uri="{BB962C8B-B14F-4D97-AF65-F5344CB8AC3E}">
-        <p14:creationId xmlns:p14="http://schemas.microsoft.com/office/powerpoint/2010/main" val="648331121"/>
+        <p14:creationId xmlns:p14="http://schemas.microsoft.com/office/powerpoint/2010/main" val="1412230496"/>
       </p:ext>
     </p:extLst>
   </p:cSld>

</xml_diff>

<commit_message>
Acotar recursos y ampliar pruebas de estrés
</commit_message>
<xml_diff>
--- a/entrega/Presentacion_INF513_P1_Grupo09SA.pptx
+++ b/entrega/Presentacion_INF513_P1_Grupo09SA.pptx
@@ -2,22 +2,22 @@
 <file path=ppt/presentation.xml><?xml version="1.0" encoding="utf-8"?>
 <p:presentation xmlns:p="http://schemas.openxmlformats.org/presentationml/2006/main">
   <p:sldMasterIdLst>
-    <p:sldMasterId xmlns:r="http://schemas.openxmlformats.org/officeDocument/2006/relationships" id="2147483648" r:id="R066872b7830241ff"/>
+    <p:sldMasterId xmlns:r="http://schemas.openxmlformats.org/officeDocument/2006/relationships" id="2147483648" r:id="Ra5080a062dc643b6"/>
   </p:sldMasterIdLst>
   <p:notesMasterIdLst>
-    <p:notesMasterId xmlns:r="http://schemas.openxmlformats.org/officeDocument/2006/relationships" r:id="R8580fa7c7c84473f"/>
+    <p:notesMasterId xmlns:r="http://schemas.openxmlformats.org/officeDocument/2006/relationships" r:id="Rbcf9415d1b884040"/>
   </p:notesMasterIdLst>
   <p:sldIdLst>
-    <p:sldId xmlns:r="http://schemas.openxmlformats.org/officeDocument/2006/relationships" id="256" r:id="R6d47736bad234681"/>
-    <p:sldId xmlns:r="http://schemas.openxmlformats.org/officeDocument/2006/relationships" id="257" r:id="Rc3ef72e73acb4012"/>
-    <p:sldId xmlns:r="http://schemas.openxmlformats.org/officeDocument/2006/relationships" id="258" r:id="R282a8075622041f9"/>
-    <p:sldId xmlns:r="http://schemas.openxmlformats.org/officeDocument/2006/relationships" id="259" r:id="Ra30a9662a5b1494e"/>
-    <p:sldId xmlns:r="http://schemas.openxmlformats.org/officeDocument/2006/relationships" id="260" r:id="R013ef88977824481"/>
-    <p:sldId xmlns:r="http://schemas.openxmlformats.org/officeDocument/2006/relationships" id="261" r:id="R55c9d4e71b9b4090"/>
-    <p:sldId xmlns:r="http://schemas.openxmlformats.org/officeDocument/2006/relationships" id="262" r:id="Rad0374df1b7f4b09"/>
-    <p:sldId xmlns:r="http://schemas.openxmlformats.org/officeDocument/2006/relationships" id="263" r:id="R15ae765fc6c54cea"/>
-    <p:sldId xmlns:r="http://schemas.openxmlformats.org/officeDocument/2006/relationships" id="264" r:id="R83b738cd9afb487e"/>
-    <p:sldId xmlns:r="http://schemas.openxmlformats.org/officeDocument/2006/relationships" id="265" r:id="R1bc05ec5f3224e0d"/>
+    <p:sldId xmlns:r="http://schemas.openxmlformats.org/officeDocument/2006/relationships" id="256" r:id="R8d36b752e6994c7a"/>
+    <p:sldId xmlns:r="http://schemas.openxmlformats.org/officeDocument/2006/relationships" id="257" r:id="R89e0bd32c532418d"/>
+    <p:sldId xmlns:r="http://schemas.openxmlformats.org/officeDocument/2006/relationships" id="258" r:id="R650735b7f6df4001"/>
+    <p:sldId xmlns:r="http://schemas.openxmlformats.org/officeDocument/2006/relationships" id="259" r:id="R7a4899ad65c646a7"/>
+    <p:sldId xmlns:r="http://schemas.openxmlformats.org/officeDocument/2006/relationships" id="260" r:id="R6921345436b14b13"/>
+    <p:sldId xmlns:r="http://schemas.openxmlformats.org/officeDocument/2006/relationships" id="261" r:id="R5817e283715444fc"/>
+    <p:sldId xmlns:r="http://schemas.openxmlformats.org/officeDocument/2006/relationships" id="262" r:id="R1ab615ef0dc4455d"/>
+    <p:sldId xmlns:r="http://schemas.openxmlformats.org/officeDocument/2006/relationships" id="263" r:id="Ree6085a4d40f4791"/>
+    <p:sldId xmlns:r="http://schemas.openxmlformats.org/officeDocument/2006/relationships" id="264" r:id="Ra53348566781433d"/>
+    <p:sldId xmlns:r="http://schemas.openxmlformats.org/officeDocument/2006/relationships" id="265" r:id="R89603e93adfa4add"/>
   </p:sldIdLst>
   <p:sldSz cx="12192000" cy="6858000"/>
   <p:notesSz cx="6858000" cy="9144000"/>
@@ -1088,7 +1088,7 @@
           <p:cNvPr id="3" name="Title">
             <a:extLst xmlns:a="http://schemas.openxmlformats.org/drawingml/2006/main">
               <a:ext uri="{FF2B5EF4-FFF2-40B4-BE49-F238E27FC236}">
-                <a16:creationId xmlns:a16="http://schemas.microsoft.com/office/drawing/2014/main" id="{91E04EB8-FC28-4AA4-BBCD-D0A51A927953}"/>
+                <a16:creationId xmlns:a16="http://schemas.microsoft.com/office/drawing/2014/main" id="{D4820BDF-846D-4F40-90A8-4223F0077F07}"/>
               </a:ext>
             </a:extLst>
           </p:cNvPr>
@@ -1245,7 +1245,7 @@
           <p:cNvPr id="2" name="Subtitle">
             <a:extLst xmlns:a="http://schemas.openxmlformats.org/drawingml/2006/main">
               <a:ext uri="{FF2B5EF4-FFF2-40B4-BE49-F238E27FC236}">
-                <a16:creationId xmlns:a16="http://schemas.microsoft.com/office/drawing/2014/main" id="{6EA61950-467C-4514-902A-53447A7E2211}"/>
+                <a16:creationId xmlns:a16="http://schemas.microsoft.com/office/drawing/2014/main" id="{4877A4A7-E046-4603-A0D6-1ABF4ACCB05A}"/>
               </a:ext>
             </a:extLst>
           </p:cNvPr>
@@ -1419,7 +1419,7 @@
           <p:cNvPr id="2" name="Section title">
             <a:extLst xmlns:a="http://schemas.openxmlformats.org/drawingml/2006/main">
               <a:ext uri="{FF2B5EF4-FFF2-40B4-BE49-F238E27FC236}">
-                <a16:creationId xmlns:a16="http://schemas.microsoft.com/office/drawing/2014/main" id="{BAAD203C-1F1D-4F25-B8C8-379F0A869D96}"/>
+                <a16:creationId xmlns:a16="http://schemas.microsoft.com/office/drawing/2014/main" id="{67617022-C720-43D5-87DC-BB5608F30676}"/>
               </a:ext>
             </a:extLst>
           </p:cNvPr>
@@ -1593,7 +1593,7 @@
           <p:cNvPr id="3" name="Title">
             <a:extLst xmlns:a="http://schemas.openxmlformats.org/drawingml/2006/main">
               <a:ext uri="{FF2B5EF4-FFF2-40B4-BE49-F238E27FC236}">
-                <a16:creationId xmlns:a16="http://schemas.microsoft.com/office/drawing/2014/main" id="{1505E63F-8E40-4B32-93B2-E618DE04D5A8}"/>
+                <a16:creationId xmlns:a16="http://schemas.microsoft.com/office/drawing/2014/main" id="{0F4A41CB-6BDF-4521-B262-45EF4003DB2F}"/>
               </a:ext>
             </a:extLst>
           </p:cNvPr>
@@ -1750,7 +1750,7 @@
           <p:cNvPr id="2" name="Body">
             <a:extLst xmlns:a="http://schemas.openxmlformats.org/drawingml/2006/main">
               <a:ext uri="{FF2B5EF4-FFF2-40B4-BE49-F238E27FC236}">
-                <a16:creationId xmlns:a16="http://schemas.microsoft.com/office/drawing/2014/main" id="{D6D199AD-EA2A-4740-9693-98E0D4BD968B}"/>
+                <a16:creationId xmlns:a16="http://schemas.microsoft.com/office/drawing/2014/main" id="{C4F0D242-81D8-4693-95FD-E7CFBE5B9575}"/>
               </a:ext>
             </a:extLst>
           </p:cNvPr>
@@ -1924,7 +1924,7 @@
           <p:cNvPr id="4" name="Title">
             <a:extLst xmlns:a="http://schemas.openxmlformats.org/drawingml/2006/main">
               <a:ext uri="{FF2B5EF4-FFF2-40B4-BE49-F238E27FC236}">
-                <a16:creationId xmlns:a16="http://schemas.microsoft.com/office/drawing/2014/main" id="{53458DEC-04B7-40E9-B431-D47FDC9D88E9}"/>
+                <a16:creationId xmlns:a16="http://schemas.microsoft.com/office/drawing/2014/main" id="{094D57E3-E6C6-4AFA-82AC-D43065C800F3}"/>
               </a:ext>
             </a:extLst>
           </p:cNvPr>
@@ -2081,7 +2081,7 @@
           <p:cNvPr id="2" name="Left column">
             <a:extLst xmlns:a="http://schemas.openxmlformats.org/drawingml/2006/main">
               <a:ext uri="{FF2B5EF4-FFF2-40B4-BE49-F238E27FC236}">
-                <a16:creationId xmlns:a16="http://schemas.microsoft.com/office/drawing/2014/main" id="{85006D41-6463-413F-9655-3CA2D8AB4D60}"/>
+                <a16:creationId xmlns:a16="http://schemas.microsoft.com/office/drawing/2014/main" id="{13D50B89-523C-456C-8897-6703584B1784}"/>
               </a:ext>
             </a:extLst>
           </p:cNvPr>
@@ -2238,7 +2238,7 @@
           <p:cNvPr id="3" name="Right column">
             <a:extLst xmlns:a="http://schemas.openxmlformats.org/drawingml/2006/main">
               <a:ext uri="{FF2B5EF4-FFF2-40B4-BE49-F238E27FC236}">
-                <a16:creationId xmlns:a16="http://schemas.microsoft.com/office/drawing/2014/main" id="{F1490181-C331-455D-A473-B8CB2D0C361C}"/>
+                <a16:creationId xmlns:a16="http://schemas.microsoft.com/office/drawing/2014/main" id="{9047C631-D09B-4A56-B2C3-B3CC47A7B3AD}"/>
               </a:ext>
             </a:extLst>
           </p:cNvPr>
@@ -2412,7 +2412,7 @@
           <p:cNvPr id="3" name="Title">
             <a:extLst xmlns:a="http://schemas.openxmlformats.org/drawingml/2006/main">
               <a:ext uri="{FF2B5EF4-FFF2-40B4-BE49-F238E27FC236}">
-                <a16:creationId xmlns:a16="http://schemas.microsoft.com/office/drawing/2014/main" id="{FE14EE39-C2F3-42E0-8808-D3CFF68888FF}"/>
+                <a16:creationId xmlns:a16="http://schemas.microsoft.com/office/drawing/2014/main" id="{B216B4EB-A511-4EB1-9DD0-F992EFF08CFC}"/>
               </a:ext>
             </a:extLst>
           </p:cNvPr>
@@ -2569,7 +2569,7 @@
           <p:cNvPr id="2" name="Left column">
             <a:extLst xmlns:a="http://schemas.openxmlformats.org/drawingml/2006/main">
               <a:ext uri="{FF2B5EF4-FFF2-40B4-BE49-F238E27FC236}">
-                <a16:creationId xmlns:a16="http://schemas.microsoft.com/office/drawing/2014/main" id="{10C5825C-5C55-4152-9D77-F088319D0E46}"/>
+                <a16:creationId xmlns:a16="http://schemas.microsoft.com/office/drawing/2014/main" id="{272805F1-15FF-4148-A466-2C537359D813}"/>
               </a:ext>
             </a:extLst>
           </p:cNvPr>
@@ -2764,12 +2764,12 @@
   </p:cSld>
   <p:clrMap bg1="lt1" tx1="dk1" bg2="lt2" tx2="dk2" accent1="accent1" accent2="accent2" accent3="accent3" accent4="accent4" accent5="accent5" accent6="accent6" hlink="hlink" folHlink="folHlink"/>
   <p:sldLayoutIdLst>
-    <p:sldLayoutId xmlns:r="http://schemas.openxmlformats.org/officeDocument/2006/relationships" id="2147483649" r:id="Rce662ff308d342db"/>
-    <p:sldLayoutId xmlns:r="http://schemas.openxmlformats.org/officeDocument/2006/relationships" id="2147483650" r:id="R9023993254e94013"/>
-    <p:sldLayoutId xmlns:r="http://schemas.openxmlformats.org/officeDocument/2006/relationships" id="2147483651" r:id="R11d841e0ed534b3d"/>
-    <p:sldLayoutId xmlns:r="http://schemas.openxmlformats.org/officeDocument/2006/relationships" id="2147483652" r:id="R22af9a892e0146d5"/>
-    <p:sldLayoutId xmlns:r="http://schemas.openxmlformats.org/officeDocument/2006/relationships" id="2147483653" r:id="R4a3b18c936e54826"/>
-    <p:sldLayoutId xmlns:r="http://schemas.openxmlformats.org/officeDocument/2006/relationships" id="2147483654" r:id="Ree22d68525f94fa7"/>
+    <p:sldLayoutId xmlns:r="http://schemas.openxmlformats.org/officeDocument/2006/relationships" id="2147483649" r:id="R5ca931aac7b54f03"/>
+    <p:sldLayoutId xmlns:r="http://schemas.openxmlformats.org/officeDocument/2006/relationships" id="2147483650" r:id="R844910c62cb548a9"/>
+    <p:sldLayoutId xmlns:r="http://schemas.openxmlformats.org/officeDocument/2006/relationships" id="2147483651" r:id="R741e64ce8aa94be5"/>
+    <p:sldLayoutId xmlns:r="http://schemas.openxmlformats.org/officeDocument/2006/relationships" id="2147483652" r:id="R1aa6cd1ae95b4164"/>
+    <p:sldLayoutId xmlns:r="http://schemas.openxmlformats.org/officeDocument/2006/relationships" id="2147483653" r:id="R7fcf658fd4f44416"/>
+    <p:sldLayoutId xmlns:r="http://schemas.openxmlformats.org/officeDocument/2006/relationships" id="2147483654" r:id="R085859db01e746ab"/>
   </p:sldLayoutIdLst>
   <p:txStyles>
     <p:titleStyle>
@@ -3320,7 +3320,7 @@
           <p:cNvPr id="8" name="">
             <a:extLst xmlns:a="http://schemas.openxmlformats.org/drawingml/2006/main">
               <a:ext uri="{FF2B5EF4-FFF2-40B4-BE49-F238E27FC236}">
-                <a16:creationId xmlns:a16="http://schemas.microsoft.com/office/drawing/2014/main" id="{3987C03B-568D-4A09-AE04-4BD667B8C4AA}"/>
+                <a16:creationId xmlns:a16="http://schemas.microsoft.com/office/drawing/2014/main" id="{CDA3A719-5390-444D-85D4-B50120F8453E}"/>
               </a:ext>
             </a:extLst>
           </p:cNvPr>
@@ -3378,7 +3378,7 @@
           <p:cNvPr id="2" name="">
             <a:extLst xmlns:a="http://schemas.openxmlformats.org/drawingml/2006/main">
               <a:ext uri="{FF2B5EF4-FFF2-40B4-BE49-F238E27FC236}">
-                <a16:creationId xmlns:a16="http://schemas.microsoft.com/office/drawing/2014/main" id="{8C8AF614-A14B-471C-BCB2-C446D48FF49C}"/>
+                <a16:creationId xmlns:a16="http://schemas.microsoft.com/office/drawing/2014/main" id="{B04A22FE-6C3C-4D99-912A-F32D31957C1F}"/>
               </a:ext>
             </a:extLst>
           </p:cNvPr>
@@ -3436,7 +3436,7 @@
           <p:cNvPr id="3" name="">
             <a:extLst xmlns:a="http://schemas.openxmlformats.org/drawingml/2006/main">
               <a:ext uri="{FF2B5EF4-FFF2-40B4-BE49-F238E27FC236}">
-                <a16:creationId xmlns:a16="http://schemas.microsoft.com/office/drawing/2014/main" id="{9A6C60B4-B459-4A61-98D7-15CD7F7AF009}"/>
+                <a16:creationId xmlns:a16="http://schemas.microsoft.com/office/drawing/2014/main" id="{4CBECBB5-90EE-4650-B577-39DDE60CA743}"/>
               </a:ext>
             </a:extLst>
           </p:cNvPr>
@@ -3494,7 +3494,7 @@
           <p:cNvPr id="4" name="">
             <a:extLst xmlns:a="http://schemas.openxmlformats.org/drawingml/2006/main">
               <a:ext uri="{FF2B5EF4-FFF2-40B4-BE49-F238E27FC236}">
-                <a16:creationId xmlns:a16="http://schemas.microsoft.com/office/drawing/2014/main" id="{45AE0D15-2CA3-477C-BE28-92C82A4FCA3A}"/>
+                <a16:creationId xmlns:a16="http://schemas.microsoft.com/office/drawing/2014/main" id="{67D6334D-A6C1-4CBF-BD5F-6123D1F56096}"/>
               </a:ext>
             </a:extLst>
           </p:cNvPr>
@@ -3529,7 +3529,7 @@
           <p:cNvPr id="5" name="">
             <a:extLst xmlns:a="http://schemas.openxmlformats.org/drawingml/2006/main">
               <a:ext uri="{FF2B5EF4-FFF2-40B4-BE49-F238E27FC236}">
-                <a16:creationId xmlns:a16="http://schemas.microsoft.com/office/drawing/2014/main" id="{745BD320-C2C3-4B07-842C-6C21C66D3FCD}"/>
+                <a16:creationId xmlns:a16="http://schemas.microsoft.com/office/drawing/2014/main" id="{159CA441-7D2F-4942-B7C9-6BE698D52DD5}"/>
               </a:ext>
             </a:extLst>
           </p:cNvPr>
@@ -3587,7 +3587,7 @@
           <p:cNvPr id="6" name="">
             <a:extLst xmlns:a="http://schemas.openxmlformats.org/drawingml/2006/main">
               <a:ext uri="{FF2B5EF4-FFF2-40B4-BE49-F238E27FC236}">
-                <a16:creationId xmlns:a16="http://schemas.microsoft.com/office/drawing/2014/main" id="{9AE8CED3-E03E-4163-8FCB-3B1607D83318}"/>
+                <a16:creationId xmlns:a16="http://schemas.microsoft.com/office/drawing/2014/main" id="{FDBA9D62-1EB6-4FAD-91A5-D3010023EB38}"/>
               </a:ext>
             </a:extLst>
           </p:cNvPr>
@@ -3740,7 +3740,7 @@
           <p:cNvPr id="7" name="">
             <a:extLst xmlns:a="http://schemas.openxmlformats.org/drawingml/2006/main">
               <a:ext uri="{FF2B5EF4-FFF2-40B4-BE49-F238E27FC236}">
-                <a16:creationId xmlns:a16="http://schemas.microsoft.com/office/drawing/2014/main" id="{58BF6AA8-4C4C-4B59-BD7D-F99DF94A4D24}"/>
+                <a16:creationId xmlns:a16="http://schemas.microsoft.com/office/drawing/2014/main" id="{5B9EDB9D-4DCD-4F4F-B8B1-7D45BA535B0F}"/>
               </a:ext>
             </a:extLst>
           </p:cNvPr>
@@ -3813,7 +3813,7 @@
     </p:spTree>
     <p:extLst>
       <p:ext uri="{BB962C8B-B14F-4D97-AF65-F5344CB8AC3E}">
-        <p14:creationId xmlns:p14="http://schemas.microsoft.com/office/powerpoint/2010/main" val="243343377"/>
+        <p14:creationId xmlns:p14="http://schemas.microsoft.com/office/powerpoint/2010/main" val="1513496132"/>
       </p:ext>
     </p:extLst>
   </p:cSld>
@@ -3844,7 +3844,7 @@
           <p:cNvPr id="17" name="">
             <a:extLst xmlns:a="http://schemas.openxmlformats.org/drawingml/2006/main">
               <a:ext uri="{FF2B5EF4-FFF2-40B4-BE49-F238E27FC236}">
-                <a16:creationId xmlns:a16="http://schemas.microsoft.com/office/drawing/2014/main" id="{D1703E61-80BF-4BAD-819B-144A224996D6}"/>
+                <a16:creationId xmlns:a16="http://schemas.microsoft.com/office/drawing/2014/main" id="{CEEF1AA9-0BB7-4750-9BE4-739FEFBEB825}"/>
               </a:ext>
             </a:extLst>
           </p:cNvPr>
@@ -3902,7 +3902,7 @@
           <p:cNvPr id="2" name="">
             <a:extLst xmlns:a="http://schemas.openxmlformats.org/drawingml/2006/main">
               <a:ext uri="{FF2B5EF4-FFF2-40B4-BE49-F238E27FC236}">
-                <a16:creationId xmlns:a16="http://schemas.microsoft.com/office/drawing/2014/main" id="{E3FF9F5D-563C-48B1-AB3B-A9552C85F784}"/>
+                <a16:creationId xmlns:a16="http://schemas.microsoft.com/office/drawing/2014/main" id="{801DD063-42AD-48BF-AC19-19C6AB040E72}"/>
               </a:ext>
             </a:extLst>
           </p:cNvPr>
@@ -3960,7 +3960,7 @@
           <p:cNvPr id="3" name="">
             <a:extLst xmlns:a="http://schemas.openxmlformats.org/drawingml/2006/main">
               <a:ext uri="{FF2B5EF4-FFF2-40B4-BE49-F238E27FC236}">
-                <a16:creationId xmlns:a16="http://schemas.microsoft.com/office/drawing/2014/main" id="{5895F3FD-881B-476D-BC98-6B8892526E06}"/>
+                <a16:creationId xmlns:a16="http://schemas.microsoft.com/office/drawing/2014/main" id="{075C3689-3616-4B78-BA4F-0EDC02AD646B}"/>
               </a:ext>
             </a:extLst>
           </p:cNvPr>
@@ -3993,7 +3993,7 @@
           <p:cNvPr id="4" name="">
             <a:extLst xmlns:a="http://schemas.openxmlformats.org/drawingml/2006/main">
               <a:ext uri="{FF2B5EF4-FFF2-40B4-BE49-F238E27FC236}">
-                <a16:creationId xmlns:a16="http://schemas.microsoft.com/office/drawing/2014/main" id="{E11522A2-41BE-45C9-BA87-235A074C5D6B}"/>
+                <a16:creationId xmlns:a16="http://schemas.microsoft.com/office/drawing/2014/main" id="{EC1422AD-2126-4C45-8B3E-71A8F17B7E77}"/>
               </a:ext>
             </a:extLst>
           </p:cNvPr>
@@ -4051,7 +4051,7 @@
           <p:cNvPr id="5" name="">
             <a:extLst xmlns:a="http://schemas.openxmlformats.org/drawingml/2006/main">
               <a:ext uri="{FF2B5EF4-FFF2-40B4-BE49-F238E27FC236}">
-                <a16:creationId xmlns:a16="http://schemas.microsoft.com/office/drawing/2014/main" id="{7F559A0B-8F08-4386-9CEB-E74797D4C2B9}"/>
+                <a16:creationId xmlns:a16="http://schemas.microsoft.com/office/drawing/2014/main" id="{4B13A0BF-C812-4355-8FF6-66CE054B55BF}"/>
               </a:ext>
             </a:extLst>
           </p:cNvPr>
@@ -4109,7 +4109,7 @@
           <p:cNvPr id="6" name="">
             <a:extLst xmlns:a="http://schemas.openxmlformats.org/drawingml/2006/main">
               <a:ext uri="{FF2B5EF4-FFF2-40B4-BE49-F238E27FC236}">
-                <a16:creationId xmlns:a16="http://schemas.microsoft.com/office/drawing/2014/main" id="{1F3CF64A-1855-4343-ADE8-529EC2E0B8EC}"/>
+                <a16:creationId xmlns:a16="http://schemas.microsoft.com/office/drawing/2014/main" id="{159427EF-AF1D-48DD-8790-3077FD1BEE50}"/>
               </a:ext>
             </a:extLst>
           </p:cNvPr>
@@ -4167,7 +4167,7 @@
           <p:cNvPr id="7" name="">
             <a:extLst xmlns:a="http://schemas.openxmlformats.org/drawingml/2006/main">
               <a:ext uri="{FF2B5EF4-FFF2-40B4-BE49-F238E27FC236}">
-                <a16:creationId xmlns:a16="http://schemas.microsoft.com/office/drawing/2014/main" id="{649242E2-ED11-423F-9554-6DB85324B495}"/>
+                <a16:creationId xmlns:a16="http://schemas.microsoft.com/office/drawing/2014/main" id="{F0395808-2DF6-4A2A-8584-1A0C0C768215}"/>
               </a:ext>
             </a:extLst>
           </p:cNvPr>
@@ -4225,7 +4225,7 @@
           <p:cNvPr id="8" name="">
             <a:extLst xmlns:a="http://schemas.openxmlformats.org/drawingml/2006/main">
               <a:ext uri="{FF2B5EF4-FFF2-40B4-BE49-F238E27FC236}">
-                <a16:creationId xmlns:a16="http://schemas.microsoft.com/office/drawing/2014/main" id="{D72A8565-33C6-40C1-B008-1D979266CC5C}"/>
+                <a16:creationId xmlns:a16="http://schemas.microsoft.com/office/drawing/2014/main" id="{FD000889-E8FE-428E-8309-4FE355408C40}"/>
               </a:ext>
             </a:extLst>
           </p:cNvPr>
@@ -4260,7 +4260,7 @@
           <p:cNvPr id="9" name="">
             <a:extLst xmlns:a="http://schemas.openxmlformats.org/drawingml/2006/main">
               <a:ext uri="{FF2B5EF4-FFF2-40B4-BE49-F238E27FC236}">
-                <a16:creationId xmlns:a16="http://schemas.microsoft.com/office/drawing/2014/main" id="{81576BCA-C6A5-4B67-AAFA-F54D3899363E}"/>
+                <a16:creationId xmlns:a16="http://schemas.microsoft.com/office/drawing/2014/main" id="{A038DB89-F011-4164-86DE-481C56D0161B}"/>
               </a:ext>
             </a:extLst>
           </p:cNvPr>
@@ -4293,7 +4293,7 @@
           <p:cNvPr id="10" name="">
             <a:extLst xmlns:a="http://schemas.openxmlformats.org/drawingml/2006/main">
               <a:ext uri="{FF2B5EF4-FFF2-40B4-BE49-F238E27FC236}">
-                <a16:creationId xmlns:a16="http://schemas.microsoft.com/office/drawing/2014/main" id="{6D682677-3239-4DE8-B789-0170BC31849E}"/>
+                <a16:creationId xmlns:a16="http://schemas.microsoft.com/office/drawing/2014/main" id="{B10107A3-F17B-437D-9822-30B2E251B453}"/>
               </a:ext>
             </a:extLst>
           </p:cNvPr>
@@ -4351,7 +4351,7 @@
           <p:cNvPr id="11" name="">
             <a:extLst xmlns:a="http://schemas.openxmlformats.org/drawingml/2006/main">
               <a:ext uri="{FF2B5EF4-FFF2-40B4-BE49-F238E27FC236}">
-                <a16:creationId xmlns:a16="http://schemas.microsoft.com/office/drawing/2014/main" id="{DFF83A25-3C52-46C9-9C72-03A51821EB5F}"/>
+                <a16:creationId xmlns:a16="http://schemas.microsoft.com/office/drawing/2014/main" id="{20C93905-AA54-451B-AE60-C8EEBFCC73BC}"/>
               </a:ext>
             </a:extLst>
           </p:cNvPr>
@@ -4460,7 +4460,7 @@
           <p:cNvPr id="12" name="">
             <a:extLst xmlns:a="http://schemas.openxmlformats.org/drawingml/2006/main">
               <a:ext uri="{FF2B5EF4-FFF2-40B4-BE49-F238E27FC236}">
-                <a16:creationId xmlns:a16="http://schemas.microsoft.com/office/drawing/2014/main" id="{016452B7-EDDF-4804-9203-B6268F243721}"/>
+                <a16:creationId xmlns:a16="http://schemas.microsoft.com/office/drawing/2014/main" id="{E37C9C02-6492-41E6-A3DA-7B1EB32B08AB}"/>
               </a:ext>
             </a:extLst>
           </p:cNvPr>
@@ -4495,7 +4495,7 @@
           <p:cNvPr id="13" name="">
             <a:extLst xmlns:a="http://schemas.openxmlformats.org/drawingml/2006/main">
               <a:ext uri="{FF2B5EF4-FFF2-40B4-BE49-F238E27FC236}">
-                <a16:creationId xmlns:a16="http://schemas.microsoft.com/office/drawing/2014/main" id="{B2AAE692-426F-44FB-81BA-03CDB94E63B6}"/>
+                <a16:creationId xmlns:a16="http://schemas.microsoft.com/office/drawing/2014/main" id="{B1AB796D-DD79-4F3C-9DA0-3B00159C5D70}"/>
               </a:ext>
             </a:extLst>
           </p:cNvPr>
@@ -4528,7 +4528,7 @@
           <p:cNvPr id="14" name="">
             <a:extLst xmlns:a="http://schemas.openxmlformats.org/drawingml/2006/main">
               <a:ext uri="{FF2B5EF4-FFF2-40B4-BE49-F238E27FC236}">
-                <a16:creationId xmlns:a16="http://schemas.microsoft.com/office/drawing/2014/main" id="{76AFC27F-A073-48CC-8D30-73731012715E}"/>
+                <a16:creationId xmlns:a16="http://schemas.microsoft.com/office/drawing/2014/main" id="{62F9FAF9-3C0B-4885-87EE-7BBEE6B5871D}"/>
               </a:ext>
             </a:extLst>
           </p:cNvPr>
@@ -4586,7 +4586,7 @@
           <p:cNvPr id="15" name="">
             <a:extLst xmlns:a="http://schemas.openxmlformats.org/drawingml/2006/main">
               <a:ext uri="{FF2B5EF4-FFF2-40B4-BE49-F238E27FC236}">
-                <a16:creationId xmlns:a16="http://schemas.microsoft.com/office/drawing/2014/main" id="{444E5E72-F195-48F1-A893-73B01A4071A0}"/>
+                <a16:creationId xmlns:a16="http://schemas.microsoft.com/office/drawing/2014/main" id="{EDDFD418-3318-4CA3-9893-917F68A356EF}"/>
               </a:ext>
             </a:extLst>
           </p:cNvPr>
@@ -4712,7 +4712,7 @@
           <p:cNvPr id="16" name="">
             <a:extLst xmlns:a="http://schemas.openxmlformats.org/drawingml/2006/main">
               <a:ext uri="{FF2B5EF4-FFF2-40B4-BE49-F238E27FC236}">
-                <a16:creationId xmlns:a16="http://schemas.microsoft.com/office/drawing/2014/main" id="{0EE2CA44-F6DC-4EE1-8D9A-E18D1018F2DE}"/>
+                <a16:creationId xmlns:a16="http://schemas.microsoft.com/office/drawing/2014/main" id="{3362BA11-9B5D-496F-98BC-07F98CADDBC3}"/>
               </a:ext>
             </a:extLst>
           </p:cNvPr>
@@ -4768,7 +4768,7 @@
     </p:spTree>
     <p:extLst>
       <p:ext uri="{BB962C8B-B14F-4D97-AF65-F5344CB8AC3E}">
-        <p14:creationId xmlns:p14="http://schemas.microsoft.com/office/powerpoint/2010/main" val="1352583175"/>
+        <p14:creationId xmlns:p14="http://schemas.microsoft.com/office/powerpoint/2010/main" val="340537492"/>
       </p:ext>
     </p:extLst>
   </p:cSld>
@@ -4799,7 +4799,7 @@
           <p:cNvPr id="22" name="">
             <a:extLst xmlns:a="http://schemas.openxmlformats.org/drawingml/2006/main">
               <a:ext uri="{FF2B5EF4-FFF2-40B4-BE49-F238E27FC236}">
-                <a16:creationId xmlns:a16="http://schemas.microsoft.com/office/drawing/2014/main" id="{7E41AD39-0C80-4C82-B82F-75B251F162DA}"/>
+                <a16:creationId xmlns:a16="http://schemas.microsoft.com/office/drawing/2014/main" id="{A2BB5492-7C7D-4BF2-BBBA-37B04FDD613F}"/>
               </a:ext>
             </a:extLst>
           </p:cNvPr>
@@ -4857,7 +4857,7 @@
           <p:cNvPr id="2" name="">
             <a:extLst xmlns:a="http://schemas.openxmlformats.org/drawingml/2006/main">
               <a:ext uri="{FF2B5EF4-FFF2-40B4-BE49-F238E27FC236}">
-                <a16:creationId xmlns:a16="http://schemas.microsoft.com/office/drawing/2014/main" id="{2F474BE7-1DDD-4DD0-9124-0EEE714FA9CE}"/>
+                <a16:creationId xmlns:a16="http://schemas.microsoft.com/office/drawing/2014/main" id="{1BFF12EF-E601-4094-9109-4759FDC807BD}"/>
               </a:ext>
             </a:extLst>
           </p:cNvPr>
@@ -4915,7 +4915,7 @@
           <p:cNvPr id="3" name="">
             <a:extLst xmlns:a="http://schemas.openxmlformats.org/drawingml/2006/main">
               <a:ext uri="{FF2B5EF4-FFF2-40B4-BE49-F238E27FC236}">
-                <a16:creationId xmlns:a16="http://schemas.microsoft.com/office/drawing/2014/main" id="{C67BFD60-87EA-4C05-9332-6D0BEDA1A6D3}"/>
+                <a16:creationId xmlns:a16="http://schemas.microsoft.com/office/drawing/2014/main" id="{96C408B5-CE99-4780-B7FE-F4ED375EB8DE}"/>
               </a:ext>
             </a:extLst>
           </p:cNvPr>
@@ -4948,7 +4948,7 @@
           <p:cNvPr id="4" name="">
             <a:extLst xmlns:a="http://schemas.openxmlformats.org/drawingml/2006/main">
               <a:ext uri="{FF2B5EF4-FFF2-40B4-BE49-F238E27FC236}">
-                <a16:creationId xmlns:a16="http://schemas.microsoft.com/office/drawing/2014/main" id="{15A84123-90DF-48CD-B2AF-9139E2E11F52}"/>
+                <a16:creationId xmlns:a16="http://schemas.microsoft.com/office/drawing/2014/main" id="{E755233A-3E0F-44E5-B23F-E1636E97B151}"/>
               </a:ext>
             </a:extLst>
           </p:cNvPr>
@@ -5006,7 +5006,7 @@
           <p:cNvPr id="5" name="">
             <a:extLst xmlns:a="http://schemas.openxmlformats.org/drawingml/2006/main">
               <a:ext uri="{FF2B5EF4-FFF2-40B4-BE49-F238E27FC236}">
-                <a16:creationId xmlns:a16="http://schemas.microsoft.com/office/drawing/2014/main" id="{9105E219-2EFB-40A3-863F-98E047E4F5BC}"/>
+                <a16:creationId xmlns:a16="http://schemas.microsoft.com/office/drawing/2014/main" id="{126106CF-5055-42DA-9669-17D383FD2B5B}"/>
               </a:ext>
             </a:extLst>
           </p:cNvPr>
@@ -5064,7 +5064,7 @@
           <p:cNvPr id="6" name="">
             <a:extLst xmlns:a="http://schemas.openxmlformats.org/drawingml/2006/main">
               <a:ext uri="{FF2B5EF4-FFF2-40B4-BE49-F238E27FC236}">
-                <a16:creationId xmlns:a16="http://schemas.microsoft.com/office/drawing/2014/main" id="{34C5D217-CF17-4047-AC53-09B11127A796}"/>
+                <a16:creationId xmlns:a16="http://schemas.microsoft.com/office/drawing/2014/main" id="{332665F3-89B0-41C0-87CB-0940A9DCF31A}"/>
               </a:ext>
             </a:extLst>
           </p:cNvPr>
@@ -5099,7 +5099,7 @@
           <p:cNvPr id="7" name="">
             <a:extLst xmlns:a="http://schemas.openxmlformats.org/drawingml/2006/main">
               <a:ext uri="{FF2B5EF4-FFF2-40B4-BE49-F238E27FC236}">
-                <a16:creationId xmlns:a16="http://schemas.microsoft.com/office/drawing/2014/main" id="{D7B82861-1A75-48BC-BBD7-875BC8FC8958}"/>
+                <a16:creationId xmlns:a16="http://schemas.microsoft.com/office/drawing/2014/main" id="{AD8266B0-6FDD-46D5-981A-D8E9739A2C79}"/>
               </a:ext>
             </a:extLst>
           </p:cNvPr>
@@ -5132,7 +5132,7 @@
           <p:cNvPr id="8" name="">
             <a:extLst xmlns:a="http://schemas.openxmlformats.org/drawingml/2006/main">
               <a:ext uri="{FF2B5EF4-FFF2-40B4-BE49-F238E27FC236}">
-                <a16:creationId xmlns:a16="http://schemas.microsoft.com/office/drawing/2014/main" id="{EDD991A2-66B4-41D0-B427-1981F2BDCB96}"/>
+                <a16:creationId xmlns:a16="http://schemas.microsoft.com/office/drawing/2014/main" id="{D1E6CAC8-D9EB-4BE2-A8EF-78D59C6D4395}"/>
               </a:ext>
             </a:extLst>
           </p:cNvPr>
@@ -5190,7 +5190,7 @@
           <p:cNvPr id="9" name="">
             <a:extLst xmlns:a="http://schemas.openxmlformats.org/drawingml/2006/main">
               <a:ext uri="{FF2B5EF4-FFF2-40B4-BE49-F238E27FC236}">
-                <a16:creationId xmlns:a16="http://schemas.microsoft.com/office/drawing/2014/main" id="{001E32D4-B19E-4CF6-869E-74827679697C}"/>
+                <a16:creationId xmlns:a16="http://schemas.microsoft.com/office/drawing/2014/main" id="{1A8DCDA9-C888-4994-A8EE-367E7050D2CA}"/>
               </a:ext>
             </a:extLst>
           </p:cNvPr>
@@ -5248,7 +5248,7 @@
           <p:cNvPr id="10" name="">
             <a:extLst xmlns:a="http://schemas.openxmlformats.org/drawingml/2006/main">
               <a:ext uri="{FF2B5EF4-FFF2-40B4-BE49-F238E27FC236}">
-                <a16:creationId xmlns:a16="http://schemas.microsoft.com/office/drawing/2014/main" id="{EFA3C8BD-24B9-4408-B999-2C4B77BD32B6}"/>
+                <a16:creationId xmlns:a16="http://schemas.microsoft.com/office/drawing/2014/main" id="{11F37093-AC1C-49DF-BC30-C24E17EED420}"/>
               </a:ext>
             </a:extLst>
           </p:cNvPr>
@@ -5283,7 +5283,7 @@
           <p:cNvPr id="11" name="">
             <a:extLst xmlns:a="http://schemas.openxmlformats.org/drawingml/2006/main">
               <a:ext uri="{FF2B5EF4-FFF2-40B4-BE49-F238E27FC236}">
-                <a16:creationId xmlns:a16="http://schemas.microsoft.com/office/drawing/2014/main" id="{BC7F9AFB-434A-48AB-9073-9C4C8F4CEDEA}"/>
+                <a16:creationId xmlns:a16="http://schemas.microsoft.com/office/drawing/2014/main" id="{E2D3176C-27A9-4BD0-A840-085F02C74BCA}"/>
               </a:ext>
             </a:extLst>
           </p:cNvPr>
@@ -5316,7 +5316,7 @@
           <p:cNvPr id="12" name="">
             <a:extLst xmlns:a="http://schemas.openxmlformats.org/drawingml/2006/main">
               <a:ext uri="{FF2B5EF4-FFF2-40B4-BE49-F238E27FC236}">
-                <a16:creationId xmlns:a16="http://schemas.microsoft.com/office/drawing/2014/main" id="{9DEAD6C4-14AE-4844-8099-EB44E40970BF}"/>
+                <a16:creationId xmlns:a16="http://schemas.microsoft.com/office/drawing/2014/main" id="{9819F1F7-19A0-407E-9E2D-8C5807234422}"/>
               </a:ext>
             </a:extLst>
           </p:cNvPr>
@@ -5374,7 +5374,7 @@
           <p:cNvPr id="13" name="">
             <a:extLst xmlns:a="http://schemas.openxmlformats.org/drawingml/2006/main">
               <a:ext uri="{FF2B5EF4-FFF2-40B4-BE49-F238E27FC236}">
-                <a16:creationId xmlns:a16="http://schemas.microsoft.com/office/drawing/2014/main" id="{443DE1C6-D693-4FC4-BE6E-395630094388}"/>
+                <a16:creationId xmlns:a16="http://schemas.microsoft.com/office/drawing/2014/main" id="{2AB8AC88-E608-417F-8C68-2FB8C9CD9F5E}"/>
               </a:ext>
             </a:extLst>
           </p:cNvPr>
@@ -5432,7 +5432,7 @@
           <p:cNvPr id="14" name="">
             <a:extLst xmlns:a="http://schemas.openxmlformats.org/drawingml/2006/main">
               <a:ext uri="{FF2B5EF4-FFF2-40B4-BE49-F238E27FC236}">
-                <a16:creationId xmlns:a16="http://schemas.microsoft.com/office/drawing/2014/main" id="{00D6A2E7-006B-4073-B215-B06A80D3B932}"/>
+                <a16:creationId xmlns:a16="http://schemas.microsoft.com/office/drawing/2014/main" id="{2F9720F1-6C14-44A1-85FB-AAD00A3339A3}"/>
               </a:ext>
             </a:extLst>
           </p:cNvPr>
@@ -5467,7 +5467,7 @@
           <p:cNvPr id="15" name="">
             <a:extLst xmlns:a="http://schemas.openxmlformats.org/drawingml/2006/main">
               <a:ext uri="{FF2B5EF4-FFF2-40B4-BE49-F238E27FC236}">
-                <a16:creationId xmlns:a16="http://schemas.microsoft.com/office/drawing/2014/main" id="{75199286-508E-455D-9648-82DE45F57133}"/>
+                <a16:creationId xmlns:a16="http://schemas.microsoft.com/office/drawing/2014/main" id="{75BC6EC6-0E11-49EB-B762-4E51D5CA3A76}"/>
               </a:ext>
             </a:extLst>
           </p:cNvPr>
@@ -5500,7 +5500,7 @@
           <p:cNvPr id="16" name="">
             <a:extLst xmlns:a="http://schemas.openxmlformats.org/drawingml/2006/main">
               <a:ext uri="{FF2B5EF4-FFF2-40B4-BE49-F238E27FC236}">
-                <a16:creationId xmlns:a16="http://schemas.microsoft.com/office/drawing/2014/main" id="{2A8D5327-8901-45F3-8694-AFD28436B7D9}"/>
+                <a16:creationId xmlns:a16="http://schemas.microsoft.com/office/drawing/2014/main" id="{7C7DFD51-A916-4066-97C3-93B25E11C7F5}"/>
               </a:ext>
             </a:extLst>
           </p:cNvPr>
@@ -5558,7 +5558,7 @@
           <p:cNvPr id="17" name="">
             <a:extLst xmlns:a="http://schemas.openxmlformats.org/drawingml/2006/main">
               <a:ext uri="{FF2B5EF4-FFF2-40B4-BE49-F238E27FC236}">
-                <a16:creationId xmlns:a16="http://schemas.microsoft.com/office/drawing/2014/main" id="{C063CB57-AB4D-4765-AA6F-2B668373A314}"/>
+                <a16:creationId xmlns:a16="http://schemas.microsoft.com/office/drawing/2014/main" id="{9D286FBE-993D-447F-9CC3-DD298DECEE1E}"/>
               </a:ext>
             </a:extLst>
           </p:cNvPr>
@@ -5616,7 +5616,7 @@
           <p:cNvPr id="18" name="">
             <a:extLst xmlns:a="http://schemas.openxmlformats.org/drawingml/2006/main">
               <a:ext uri="{FF2B5EF4-FFF2-40B4-BE49-F238E27FC236}">
-                <a16:creationId xmlns:a16="http://schemas.microsoft.com/office/drawing/2014/main" id="{F40875B0-4D1D-4AEF-B7B8-1CADF013A037}"/>
+                <a16:creationId xmlns:a16="http://schemas.microsoft.com/office/drawing/2014/main" id="{016CE6C2-2BE5-43B3-8A2A-D8336BA07EBB}"/>
               </a:ext>
             </a:extLst>
           </p:cNvPr>
@@ -5674,7 +5674,7 @@
           <p:cNvPr id="19" name="">
             <a:extLst xmlns:a="http://schemas.openxmlformats.org/drawingml/2006/main">
               <a:ext uri="{FF2B5EF4-FFF2-40B4-BE49-F238E27FC236}">
-                <a16:creationId xmlns:a16="http://schemas.microsoft.com/office/drawing/2014/main" id="{931EAA3A-9FDD-43F8-A03D-6BB24D269B17}"/>
+                <a16:creationId xmlns:a16="http://schemas.microsoft.com/office/drawing/2014/main" id="{ABB0A8BF-47B9-4CC5-8B56-7E6D9D3B126A}"/>
               </a:ext>
             </a:extLst>
           </p:cNvPr>
@@ -5709,7 +5709,7 @@
           <p:cNvPr id="20" name="">
             <a:extLst xmlns:a="http://schemas.openxmlformats.org/drawingml/2006/main">
               <a:ext uri="{FF2B5EF4-FFF2-40B4-BE49-F238E27FC236}">
-                <a16:creationId xmlns:a16="http://schemas.microsoft.com/office/drawing/2014/main" id="{F9580B28-A5F6-4AF1-A98B-10E9F3D70775}"/>
+                <a16:creationId xmlns:a16="http://schemas.microsoft.com/office/drawing/2014/main" id="{AFB3FEC2-B17B-4300-ACCC-9D560DBC162D}"/>
               </a:ext>
             </a:extLst>
           </p:cNvPr>
@@ -5767,7 +5767,7 @@
           <p:cNvPr id="21" name="">
             <a:extLst xmlns:a="http://schemas.openxmlformats.org/drawingml/2006/main">
               <a:ext uri="{FF2B5EF4-FFF2-40B4-BE49-F238E27FC236}">
-                <a16:creationId xmlns:a16="http://schemas.microsoft.com/office/drawing/2014/main" id="{A45B684C-6435-48A8-A8BC-A6AAF4B8D264}"/>
+                <a16:creationId xmlns:a16="http://schemas.microsoft.com/office/drawing/2014/main" id="{E7E033A1-1E44-4D57-986A-B24709150BB3}"/>
               </a:ext>
             </a:extLst>
           </p:cNvPr>
@@ -5823,7 +5823,7 @@
     </p:spTree>
     <p:extLst>
       <p:ext uri="{BB962C8B-B14F-4D97-AF65-F5344CB8AC3E}">
-        <p14:creationId xmlns:p14="http://schemas.microsoft.com/office/powerpoint/2010/main" val="1293887237"/>
+        <p14:creationId xmlns:p14="http://schemas.microsoft.com/office/powerpoint/2010/main" val="1118268925"/>
       </p:ext>
     </p:extLst>
   </p:cSld>
@@ -5854,7 +5854,7 @@
           <p:cNvPr id="36" name="">
             <a:extLst xmlns:a="http://schemas.openxmlformats.org/drawingml/2006/main">
               <a:ext uri="{FF2B5EF4-FFF2-40B4-BE49-F238E27FC236}">
-                <a16:creationId xmlns:a16="http://schemas.microsoft.com/office/drawing/2014/main" id="{E1A20B6B-5284-4552-A810-739C3ED11E86}"/>
+                <a16:creationId xmlns:a16="http://schemas.microsoft.com/office/drawing/2014/main" id="{3BEB110D-5ED3-4FCC-B3EE-A5C0486E6AB3}"/>
               </a:ext>
             </a:extLst>
           </p:cNvPr>
@@ -5912,7 +5912,7 @@
           <p:cNvPr id="2" name="">
             <a:extLst xmlns:a="http://schemas.openxmlformats.org/drawingml/2006/main">
               <a:ext uri="{FF2B5EF4-FFF2-40B4-BE49-F238E27FC236}">
-                <a16:creationId xmlns:a16="http://schemas.microsoft.com/office/drawing/2014/main" id="{28A1B94C-05C4-4A97-9A7B-41095EF2D2E0}"/>
+                <a16:creationId xmlns:a16="http://schemas.microsoft.com/office/drawing/2014/main" id="{FD67C727-7008-4E3D-8499-0AFB5545312D}"/>
               </a:ext>
             </a:extLst>
           </p:cNvPr>
@@ -5970,7 +5970,7 @@
           <p:cNvPr id="3" name="">
             <a:extLst xmlns:a="http://schemas.openxmlformats.org/drawingml/2006/main">
               <a:ext uri="{FF2B5EF4-FFF2-40B4-BE49-F238E27FC236}">
-                <a16:creationId xmlns:a16="http://schemas.microsoft.com/office/drawing/2014/main" id="{472981BC-0BDD-4DEA-9F5B-6EBEC7EDEF58}"/>
+                <a16:creationId xmlns:a16="http://schemas.microsoft.com/office/drawing/2014/main" id="{C53C908F-BAD4-4E6A-8F7E-220F5EE77BBE}"/>
               </a:ext>
             </a:extLst>
           </p:cNvPr>
@@ -6003,7 +6003,7 @@
           <p:cNvPr id="4" name="">
             <a:extLst xmlns:a="http://schemas.openxmlformats.org/drawingml/2006/main">
               <a:ext uri="{FF2B5EF4-FFF2-40B4-BE49-F238E27FC236}">
-                <a16:creationId xmlns:a16="http://schemas.microsoft.com/office/drawing/2014/main" id="{88673F7C-2C91-4865-8A58-8E775525977B}"/>
+                <a16:creationId xmlns:a16="http://schemas.microsoft.com/office/drawing/2014/main" id="{6F1499C4-946B-4D1C-8E24-D2A431318EE4}"/>
               </a:ext>
             </a:extLst>
           </p:cNvPr>
@@ -6061,7 +6061,7 @@
           <p:cNvPr id="5" name="">
             <a:extLst xmlns:a="http://schemas.openxmlformats.org/drawingml/2006/main">
               <a:ext uri="{FF2B5EF4-FFF2-40B4-BE49-F238E27FC236}">
-                <a16:creationId xmlns:a16="http://schemas.microsoft.com/office/drawing/2014/main" id="{EBA217EC-E718-4E50-BBA8-BA5508F940E7}"/>
+                <a16:creationId xmlns:a16="http://schemas.microsoft.com/office/drawing/2014/main" id="{152EE2C9-8FB2-472D-AEFE-30B0AE44CB91}"/>
               </a:ext>
             </a:extLst>
           </p:cNvPr>
@@ -6119,7 +6119,7 @@
           <p:cNvPr id="6" name="">
             <a:extLst xmlns:a="http://schemas.openxmlformats.org/drawingml/2006/main">
               <a:ext uri="{FF2B5EF4-FFF2-40B4-BE49-F238E27FC236}">
-                <a16:creationId xmlns:a16="http://schemas.microsoft.com/office/drawing/2014/main" id="{B248FABA-4AC6-4BD3-81CC-EB5FF295D7AF}"/>
+                <a16:creationId xmlns:a16="http://schemas.microsoft.com/office/drawing/2014/main" id="{EACEFDE3-CB75-49B4-A04C-235D8F59AC5E}"/>
               </a:ext>
             </a:extLst>
           </p:cNvPr>
@@ -6154,7 +6154,7 @@
           <p:cNvPr id="7" name="">
             <a:extLst xmlns:a="http://schemas.openxmlformats.org/drawingml/2006/main">
               <a:ext uri="{FF2B5EF4-FFF2-40B4-BE49-F238E27FC236}">
-                <a16:creationId xmlns:a16="http://schemas.microsoft.com/office/drawing/2014/main" id="{61D892F5-239C-4064-9036-89A6FF6108F6}"/>
+                <a16:creationId xmlns:a16="http://schemas.microsoft.com/office/drawing/2014/main" id="{16A26C74-F04E-4B7E-B2EA-F2F325D18F87}"/>
               </a:ext>
             </a:extLst>
           </p:cNvPr>
@@ -6212,7 +6212,7 @@
           <p:cNvPr id="8" name="">
             <a:extLst xmlns:a="http://schemas.openxmlformats.org/drawingml/2006/main">
               <a:ext uri="{FF2B5EF4-FFF2-40B4-BE49-F238E27FC236}">
-                <a16:creationId xmlns:a16="http://schemas.microsoft.com/office/drawing/2014/main" id="{3CFE9B3E-42D1-4E6E-BDE7-19CA15816620}"/>
+                <a16:creationId xmlns:a16="http://schemas.microsoft.com/office/drawing/2014/main" id="{4FDC0F03-54B7-4058-88E8-E3DEB6F74414}"/>
               </a:ext>
             </a:extLst>
           </p:cNvPr>
@@ -6243,7 +6243,7 @@
           <p:cNvPr id="9" name="">
             <a:extLst xmlns:a="http://schemas.openxmlformats.org/drawingml/2006/main">
               <a:ext uri="{FF2B5EF4-FFF2-40B4-BE49-F238E27FC236}">
-                <a16:creationId xmlns:a16="http://schemas.microsoft.com/office/drawing/2014/main" id="{485CCC89-AEBE-4AE6-8398-C7E7A394F4C8}"/>
+                <a16:creationId xmlns:a16="http://schemas.microsoft.com/office/drawing/2014/main" id="{313A9F87-272B-49D7-92C7-6D18200D7590}"/>
               </a:ext>
             </a:extLst>
           </p:cNvPr>
@@ -6301,7 +6301,7 @@
           <p:cNvPr id="10" name="">
             <a:extLst xmlns:a="http://schemas.openxmlformats.org/drawingml/2006/main">
               <a:ext uri="{FF2B5EF4-FFF2-40B4-BE49-F238E27FC236}">
-                <a16:creationId xmlns:a16="http://schemas.microsoft.com/office/drawing/2014/main" id="{865980DD-A5C3-41D4-AC5B-56E5F2C24609}"/>
+                <a16:creationId xmlns:a16="http://schemas.microsoft.com/office/drawing/2014/main" id="{2CE516E5-90AC-4D5C-90EA-B103D61DA9FD}"/>
               </a:ext>
             </a:extLst>
           </p:cNvPr>
@@ -6359,7 +6359,7 @@
           <p:cNvPr id="11" name="">
             <a:extLst xmlns:a="http://schemas.openxmlformats.org/drawingml/2006/main">
               <a:ext uri="{FF2B5EF4-FFF2-40B4-BE49-F238E27FC236}">
-                <a16:creationId xmlns:a16="http://schemas.microsoft.com/office/drawing/2014/main" id="{6AED3527-CD4B-4A60-859A-899393C36292}"/>
+                <a16:creationId xmlns:a16="http://schemas.microsoft.com/office/drawing/2014/main" id="{902EF850-E0E8-4E30-B08F-DD675B9D8C4B}"/>
               </a:ext>
             </a:extLst>
           </p:cNvPr>
@@ -6417,7 +6417,7 @@
           <p:cNvPr id="12" name="">
             <a:extLst xmlns:a="http://schemas.openxmlformats.org/drawingml/2006/main">
               <a:ext uri="{FF2B5EF4-FFF2-40B4-BE49-F238E27FC236}">
-                <a16:creationId xmlns:a16="http://schemas.microsoft.com/office/drawing/2014/main" id="{1C50F6E9-24E7-4AB8-A579-7AFAD38E8866}"/>
+                <a16:creationId xmlns:a16="http://schemas.microsoft.com/office/drawing/2014/main" id="{D1B5069B-4CB8-4DA4-B18B-26556C5923EA}"/>
               </a:ext>
             </a:extLst>
           </p:cNvPr>
@@ -6452,7 +6452,7 @@
           <p:cNvPr id="13" name="">
             <a:extLst xmlns:a="http://schemas.openxmlformats.org/drawingml/2006/main">
               <a:ext uri="{FF2B5EF4-FFF2-40B4-BE49-F238E27FC236}">
-                <a16:creationId xmlns:a16="http://schemas.microsoft.com/office/drawing/2014/main" id="{ACCC35FB-7F17-441E-B04A-D508E773C303}"/>
+                <a16:creationId xmlns:a16="http://schemas.microsoft.com/office/drawing/2014/main" id="{3F11C108-CC97-46D8-9811-C2ED8ED3CCE6}"/>
               </a:ext>
             </a:extLst>
           </p:cNvPr>
@@ -6510,7 +6510,7 @@
           <p:cNvPr id="14" name="">
             <a:extLst xmlns:a="http://schemas.openxmlformats.org/drawingml/2006/main">
               <a:ext uri="{FF2B5EF4-FFF2-40B4-BE49-F238E27FC236}">
-                <a16:creationId xmlns:a16="http://schemas.microsoft.com/office/drawing/2014/main" id="{999D7897-79A8-4308-A325-79316059E8AC}"/>
+                <a16:creationId xmlns:a16="http://schemas.microsoft.com/office/drawing/2014/main" id="{38AE27CE-408F-44B3-824B-71D45E4D1FF9}"/>
               </a:ext>
             </a:extLst>
           </p:cNvPr>
@@ -6541,7 +6541,7 @@
           <p:cNvPr id="15" name="">
             <a:extLst xmlns:a="http://schemas.openxmlformats.org/drawingml/2006/main">
               <a:ext uri="{FF2B5EF4-FFF2-40B4-BE49-F238E27FC236}">
-                <a16:creationId xmlns:a16="http://schemas.microsoft.com/office/drawing/2014/main" id="{168E1129-649C-407D-A11C-55EF289394EF}"/>
+                <a16:creationId xmlns:a16="http://schemas.microsoft.com/office/drawing/2014/main" id="{6C40B7C8-5FE4-4D6C-A657-FA6402DA17D9}"/>
               </a:ext>
             </a:extLst>
           </p:cNvPr>
@@ -6599,7 +6599,7 @@
           <p:cNvPr id="16" name="">
             <a:extLst xmlns:a="http://schemas.openxmlformats.org/drawingml/2006/main">
               <a:ext uri="{FF2B5EF4-FFF2-40B4-BE49-F238E27FC236}">
-                <a16:creationId xmlns:a16="http://schemas.microsoft.com/office/drawing/2014/main" id="{3928CB73-BFDB-48BF-B693-7E91F18BB3A9}"/>
+                <a16:creationId xmlns:a16="http://schemas.microsoft.com/office/drawing/2014/main" id="{6BBD1E16-528A-455E-89C2-14AB7E8FCCBB}"/>
               </a:ext>
             </a:extLst>
           </p:cNvPr>
@@ -6657,7 +6657,7 @@
           <p:cNvPr id="17" name="">
             <a:extLst xmlns:a="http://schemas.openxmlformats.org/drawingml/2006/main">
               <a:ext uri="{FF2B5EF4-FFF2-40B4-BE49-F238E27FC236}">
-                <a16:creationId xmlns:a16="http://schemas.microsoft.com/office/drawing/2014/main" id="{51DB0CDD-FFA5-4112-A54D-6B6635793BF0}"/>
+                <a16:creationId xmlns:a16="http://schemas.microsoft.com/office/drawing/2014/main" id="{F2A57E5E-3E70-4543-A320-D973693BE131}"/>
               </a:ext>
             </a:extLst>
           </p:cNvPr>
@@ -6715,7 +6715,7 @@
           <p:cNvPr id="18" name="">
             <a:extLst xmlns:a="http://schemas.openxmlformats.org/drawingml/2006/main">
               <a:ext uri="{FF2B5EF4-FFF2-40B4-BE49-F238E27FC236}">
-                <a16:creationId xmlns:a16="http://schemas.microsoft.com/office/drawing/2014/main" id="{0CD1A792-D2E5-4959-94E2-5330BF53404E}"/>
+                <a16:creationId xmlns:a16="http://schemas.microsoft.com/office/drawing/2014/main" id="{6F95463D-F0F4-4B49-A967-D6665C0D7DF1}"/>
               </a:ext>
             </a:extLst>
           </p:cNvPr>
@@ -6750,7 +6750,7 @@
           <p:cNvPr id="19" name="">
             <a:extLst xmlns:a="http://schemas.openxmlformats.org/drawingml/2006/main">
               <a:ext uri="{FF2B5EF4-FFF2-40B4-BE49-F238E27FC236}">
-                <a16:creationId xmlns:a16="http://schemas.microsoft.com/office/drawing/2014/main" id="{EECCBA16-E9EF-43C2-8B6B-69DCB98707F1}"/>
+                <a16:creationId xmlns:a16="http://schemas.microsoft.com/office/drawing/2014/main" id="{4D79FADA-5CC5-476F-8945-6BE5186634A0}"/>
               </a:ext>
             </a:extLst>
           </p:cNvPr>
@@ -6808,7 +6808,7 @@
           <p:cNvPr id="20" name="">
             <a:extLst xmlns:a="http://schemas.openxmlformats.org/drawingml/2006/main">
               <a:ext uri="{FF2B5EF4-FFF2-40B4-BE49-F238E27FC236}">
-                <a16:creationId xmlns:a16="http://schemas.microsoft.com/office/drawing/2014/main" id="{62475683-CE05-48D7-AE9A-E64843A3E91E}"/>
+                <a16:creationId xmlns:a16="http://schemas.microsoft.com/office/drawing/2014/main" id="{42C8C122-1160-44F7-9CB1-731814A02178}"/>
               </a:ext>
             </a:extLst>
           </p:cNvPr>
@@ -6839,7 +6839,7 @@
           <p:cNvPr id="21" name="">
             <a:extLst xmlns:a="http://schemas.openxmlformats.org/drawingml/2006/main">
               <a:ext uri="{FF2B5EF4-FFF2-40B4-BE49-F238E27FC236}">
-                <a16:creationId xmlns:a16="http://schemas.microsoft.com/office/drawing/2014/main" id="{0B78D946-78DB-4038-A74D-7D508DAD6CCF}"/>
+                <a16:creationId xmlns:a16="http://schemas.microsoft.com/office/drawing/2014/main" id="{96FF646E-CAEF-43B3-AD54-1D52E33E5672}"/>
               </a:ext>
             </a:extLst>
           </p:cNvPr>
@@ -6897,7 +6897,7 @@
           <p:cNvPr id="22" name="">
             <a:extLst xmlns:a="http://schemas.openxmlformats.org/drawingml/2006/main">
               <a:ext uri="{FF2B5EF4-FFF2-40B4-BE49-F238E27FC236}">
-                <a16:creationId xmlns:a16="http://schemas.microsoft.com/office/drawing/2014/main" id="{A765B0D7-7408-4478-ABFC-81F1AF551E36}"/>
+                <a16:creationId xmlns:a16="http://schemas.microsoft.com/office/drawing/2014/main" id="{D98AA185-0972-4871-8402-0353C66A7965}"/>
               </a:ext>
             </a:extLst>
           </p:cNvPr>
@@ -6955,7 +6955,7 @@
           <p:cNvPr id="23" name="">
             <a:extLst xmlns:a="http://schemas.openxmlformats.org/drawingml/2006/main">
               <a:ext uri="{FF2B5EF4-FFF2-40B4-BE49-F238E27FC236}">
-                <a16:creationId xmlns:a16="http://schemas.microsoft.com/office/drawing/2014/main" id="{06B5C546-475D-4283-80B9-E684453A22AE}"/>
+                <a16:creationId xmlns:a16="http://schemas.microsoft.com/office/drawing/2014/main" id="{CD6EE76D-DA3F-42AA-BC6B-C5234580C4B7}"/>
               </a:ext>
             </a:extLst>
           </p:cNvPr>
@@ -7013,7 +7013,7 @@
           <p:cNvPr id="24" name="">
             <a:extLst xmlns:a="http://schemas.openxmlformats.org/drawingml/2006/main">
               <a:ext uri="{FF2B5EF4-FFF2-40B4-BE49-F238E27FC236}">
-                <a16:creationId xmlns:a16="http://schemas.microsoft.com/office/drawing/2014/main" id="{CB2BC4B6-90EE-4417-9943-39625023521C}"/>
+                <a16:creationId xmlns:a16="http://schemas.microsoft.com/office/drawing/2014/main" id="{FA63AC2B-3586-41E7-AF88-AFD7860AEA57}"/>
               </a:ext>
             </a:extLst>
           </p:cNvPr>
@@ -7048,7 +7048,7 @@
           <p:cNvPr id="25" name="">
             <a:extLst xmlns:a="http://schemas.openxmlformats.org/drawingml/2006/main">
               <a:ext uri="{FF2B5EF4-FFF2-40B4-BE49-F238E27FC236}">
-                <a16:creationId xmlns:a16="http://schemas.microsoft.com/office/drawing/2014/main" id="{042D8358-C0E3-4996-839C-EC2C9D46DAE9}"/>
+                <a16:creationId xmlns:a16="http://schemas.microsoft.com/office/drawing/2014/main" id="{8D8CED88-A1F5-4F71-AD95-54A0FBDB4718}"/>
               </a:ext>
             </a:extLst>
           </p:cNvPr>
@@ -7106,7 +7106,7 @@
           <p:cNvPr id="26" name="">
             <a:extLst xmlns:a="http://schemas.openxmlformats.org/drawingml/2006/main">
               <a:ext uri="{FF2B5EF4-FFF2-40B4-BE49-F238E27FC236}">
-                <a16:creationId xmlns:a16="http://schemas.microsoft.com/office/drawing/2014/main" id="{15D1F787-A0A4-4CCD-A31C-972CC91CE770}"/>
+                <a16:creationId xmlns:a16="http://schemas.microsoft.com/office/drawing/2014/main" id="{D2D9A347-E616-4471-B496-28E4944BC527}"/>
               </a:ext>
             </a:extLst>
           </p:cNvPr>
@@ -7137,7 +7137,7 @@
           <p:cNvPr id="27" name="">
             <a:extLst xmlns:a="http://schemas.openxmlformats.org/drawingml/2006/main">
               <a:ext uri="{FF2B5EF4-FFF2-40B4-BE49-F238E27FC236}">
-                <a16:creationId xmlns:a16="http://schemas.microsoft.com/office/drawing/2014/main" id="{C837C9CB-D7A5-41B8-9565-A0B3C51C9B3A}"/>
+                <a16:creationId xmlns:a16="http://schemas.microsoft.com/office/drawing/2014/main" id="{2FB48DB6-9CEB-4A4A-80E2-AF3951D6A69C}"/>
               </a:ext>
             </a:extLst>
           </p:cNvPr>
@@ -7195,7 +7195,7 @@
           <p:cNvPr id="28" name="">
             <a:extLst xmlns:a="http://schemas.openxmlformats.org/drawingml/2006/main">
               <a:ext uri="{FF2B5EF4-FFF2-40B4-BE49-F238E27FC236}">
-                <a16:creationId xmlns:a16="http://schemas.microsoft.com/office/drawing/2014/main" id="{FA388B30-B13D-4AD1-81B1-EC8D2EBD3EDC}"/>
+                <a16:creationId xmlns:a16="http://schemas.microsoft.com/office/drawing/2014/main" id="{D3AA5976-2F0C-4F6C-BCEA-B96CBDE03472}"/>
               </a:ext>
             </a:extLst>
           </p:cNvPr>
@@ -7253,7 +7253,7 @@
           <p:cNvPr id="29" name="">
             <a:extLst xmlns:a="http://schemas.openxmlformats.org/drawingml/2006/main">
               <a:ext uri="{FF2B5EF4-FFF2-40B4-BE49-F238E27FC236}">
-                <a16:creationId xmlns:a16="http://schemas.microsoft.com/office/drawing/2014/main" id="{6F8C8A98-4E9F-4FBD-AF4C-F11036B49F4D}"/>
+                <a16:creationId xmlns:a16="http://schemas.microsoft.com/office/drawing/2014/main" id="{B2195EA8-D3D1-45CF-8B7B-94E75A526A21}"/>
               </a:ext>
             </a:extLst>
           </p:cNvPr>
@@ -7311,7 +7311,7 @@
           <p:cNvPr id="30" name="">
             <a:extLst xmlns:a="http://schemas.openxmlformats.org/drawingml/2006/main">
               <a:ext uri="{FF2B5EF4-FFF2-40B4-BE49-F238E27FC236}">
-                <a16:creationId xmlns:a16="http://schemas.microsoft.com/office/drawing/2014/main" id="{0E581D20-4B26-478A-9715-C5A48BEA92DA}"/>
+                <a16:creationId xmlns:a16="http://schemas.microsoft.com/office/drawing/2014/main" id="{61098FC5-10B0-47EF-8FD7-B1EE1DB74015}"/>
               </a:ext>
             </a:extLst>
           </p:cNvPr>
@@ -7346,7 +7346,7 @@
           <p:cNvPr id="31" name="">
             <a:extLst xmlns:a="http://schemas.openxmlformats.org/drawingml/2006/main">
               <a:ext uri="{FF2B5EF4-FFF2-40B4-BE49-F238E27FC236}">
-                <a16:creationId xmlns:a16="http://schemas.microsoft.com/office/drawing/2014/main" id="{BA453B76-F4F6-4F31-8FB4-7BB045AABE60}"/>
+                <a16:creationId xmlns:a16="http://schemas.microsoft.com/office/drawing/2014/main" id="{5E5E1BF6-7CED-4BBC-9C6F-94B92EC5DBCC}"/>
               </a:ext>
             </a:extLst>
           </p:cNvPr>
@@ -7404,7 +7404,7 @@
           <p:cNvPr id="32" name="">
             <a:extLst xmlns:a="http://schemas.openxmlformats.org/drawingml/2006/main">
               <a:ext uri="{FF2B5EF4-FFF2-40B4-BE49-F238E27FC236}">
-                <a16:creationId xmlns:a16="http://schemas.microsoft.com/office/drawing/2014/main" id="{4CD9F3D0-B0AD-4366-91EB-7A8561EE3980}"/>
+                <a16:creationId xmlns:a16="http://schemas.microsoft.com/office/drawing/2014/main" id="{B498171D-B871-4D94-82D5-9A9D6A72ABD2}"/>
               </a:ext>
             </a:extLst>
           </p:cNvPr>
@@ -7435,7 +7435,7 @@
           <p:cNvPr id="33" name="">
             <a:extLst xmlns:a="http://schemas.openxmlformats.org/drawingml/2006/main">
               <a:ext uri="{FF2B5EF4-FFF2-40B4-BE49-F238E27FC236}">
-                <a16:creationId xmlns:a16="http://schemas.microsoft.com/office/drawing/2014/main" id="{58480633-83BC-4E51-999A-F2A6E997A53B}"/>
+                <a16:creationId xmlns:a16="http://schemas.microsoft.com/office/drawing/2014/main" id="{88C7C19C-F1BA-4D8B-81C9-AB672466593B}"/>
               </a:ext>
             </a:extLst>
           </p:cNvPr>
@@ -7493,7 +7493,7 @@
           <p:cNvPr id="34" name="">
             <a:extLst xmlns:a="http://schemas.openxmlformats.org/drawingml/2006/main">
               <a:ext uri="{FF2B5EF4-FFF2-40B4-BE49-F238E27FC236}">
-                <a16:creationId xmlns:a16="http://schemas.microsoft.com/office/drawing/2014/main" id="{31037D0C-6E71-4279-8D4C-5F47E309565E}"/>
+                <a16:creationId xmlns:a16="http://schemas.microsoft.com/office/drawing/2014/main" id="{99F1186E-AA62-477D-B555-98F69E060AE7}"/>
               </a:ext>
             </a:extLst>
           </p:cNvPr>
@@ -7551,7 +7551,7 @@
           <p:cNvPr id="35" name="">
             <a:extLst xmlns:a="http://schemas.openxmlformats.org/drawingml/2006/main">
               <a:ext uri="{FF2B5EF4-FFF2-40B4-BE49-F238E27FC236}">
-                <a16:creationId xmlns:a16="http://schemas.microsoft.com/office/drawing/2014/main" id="{1F61DD27-A395-4DD3-BF20-616C5179C09A}"/>
+                <a16:creationId xmlns:a16="http://schemas.microsoft.com/office/drawing/2014/main" id="{2A0A8EC1-7F16-4D9C-AE41-85DD486AC6E3}"/>
               </a:ext>
             </a:extLst>
           </p:cNvPr>
@@ -7607,7 +7607,7 @@
     </p:spTree>
     <p:extLst>
       <p:ext uri="{BB962C8B-B14F-4D97-AF65-F5344CB8AC3E}">
-        <p14:creationId xmlns:p14="http://schemas.microsoft.com/office/powerpoint/2010/main" val="1509539380"/>
+        <p14:creationId xmlns:p14="http://schemas.microsoft.com/office/powerpoint/2010/main" val="791511663"/>
       </p:ext>
     </p:extLst>
   </p:cSld>
@@ -7638,7 +7638,7 @@
           <p:cNvPr id="38" name="">
             <a:extLst xmlns:a="http://schemas.openxmlformats.org/drawingml/2006/main">
               <a:ext uri="{FF2B5EF4-FFF2-40B4-BE49-F238E27FC236}">
-                <a16:creationId xmlns:a16="http://schemas.microsoft.com/office/drawing/2014/main" id="{BB102B5A-6976-477C-8869-FDED7F275DD7}"/>
+                <a16:creationId xmlns:a16="http://schemas.microsoft.com/office/drawing/2014/main" id="{F194442B-FF42-465C-B0C5-C73A6F0645CB}"/>
               </a:ext>
             </a:extLst>
           </p:cNvPr>
@@ -7696,7 +7696,7 @@
           <p:cNvPr id="2" name="">
             <a:extLst xmlns:a="http://schemas.openxmlformats.org/drawingml/2006/main">
               <a:ext uri="{FF2B5EF4-FFF2-40B4-BE49-F238E27FC236}">
-                <a16:creationId xmlns:a16="http://schemas.microsoft.com/office/drawing/2014/main" id="{024D82B1-115F-4503-B831-5B5175543A08}"/>
+                <a16:creationId xmlns:a16="http://schemas.microsoft.com/office/drawing/2014/main" id="{65B22BF4-E78C-4736-8B5E-4A4795FD75FE}"/>
               </a:ext>
             </a:extLst>
           </p:cNvPr>
@@ -7754,7 +7754,7 @@
           <p:cNvPr id="3" name="">
             <a:extLst xmlns:a="http://schemas.openxmlformats.org/drawingml/2006/main">
               <a:ext uri="{FF2B5EF4-FFF2-40B4-BE49-F238E27FC236}">
-                <a16:creationId xmlns:a16="http://schemas.microsoft.com/office/drawing/2014/main" id="{9B51DAF0-D738-4DFA-B2D4-F56CDB8B1E49}"/>
+                <a16:creationId xmlns:a16="http://schemas.microsoft.com/office/drawing/2014/main" id="{712070CD-3689-4F48-914E-5F615FF6D6BB}"/>
               </a:ext>
             </a:extLst>
           </p:cNvPr>
@@ -7787,7 +7787,7 @@
           <p:cNvPr id="4" name="">
             <a:extLst xmlns:a="http://schemas.openxmlformats.org/drawingml/2006/main">
               <a:ext uri="{FF2B5EF4-FFF2-40B4-BE49-F238E27FC236}">
-                <a16:creationId xmlns:a16="http://schemas.microsoft.com/office/drawing/2014/main" id="{1C34256E-5312-4B58-B4F4-50F5196F57F6}"/>
+                <a16:creationId xmlns:a16="http://schemas.microsoft.com/office/drawing/2014/main" id="{13C3F611-CB4A-4EB4-BF45-B1AEAD8F688F}"/>
               </a:ext>
             </a:extLst>
           </p:cNvPr>
@@ -7845,7 +7845,7 @@
           <p:cNvPr id="5" name="">
             <a:extLst xmlns:a="http://schemas.openxmlformats.org/drawingml/2006/main">
               <a:ext uri="{FF2B5EF4-FFF2-40B4-BE49-F238E27FC236}">
-                <a16:creationId xmlns:a16="http://schemas.microsoft.com/office/drawing/2014/main" id="{E66685B9-4E11-470B-8F97-B17800D0C0F9}"/>
+                <a16:creationId xmlns:a16="http://schemas.microsoft.com/office/drawing/2014/main" id="{3AB9431E-0AD1-4382-8AEE-E61D44E46569}"/>
               </a:ext>
             </a:extLst>
           </p:cNvPr>
@@ -7903,7 +7903,7 @@
           <p:cNvPr id="6" name="">
             <a:extLst xmlns:a="http://schemas.openxmlformats.org/drawingml/2006/main">
               <a:ext uri="{FF2B5EF4-FFF2-40B4-BE49-F238E27FC236}">
-                <a16:creationId xmlns:a16="http://schemas.microsoft.com/office/drawing/2014/main" id="{8BBB418E-DD44-4D5F-B11C-6CF182502E86}"/>
+                <a16:creationId xmlns:a16="http://schemas.microsoft.com/office/drawing/2014/main" id="{5B12D7A5-0F64-4372-8BDF-A277164B2072}"/>
               </a:ext>
             </a:extLst>
           </p:cNvPr>
@@ -7938,7 +7938,7 @@
           <p:cNvPr id="7" name="">
             <a:extLst xmlns:a="http://schemas.openxmlformats.org/drawingml/2006/main">
               <a:ext uri="{FF2B5EF4-FFF2-40B4-BE49-F238E27FC236}">
-                <a16:creationId xmlns:a16="http://schemas.microsoft.com/office/drawing/2014/main" id="{3CFBBADB-1D9D-4F39-A474-7F9BEEEAD5BD}"/>
+                <a16:creationId xmlns:a16="http://schemas.microsoft.com/office/drawing/2014/main" id="{A0051F7B-A89B-4922-8D74-5C9A3E2EE486}"/>
               </a:ext>
             </a:extLst>
           </p:cNvPr>
@@ -7996,7 +7996,7 @@
           <p:cNvPr id="8" name="">
             <a:extLst xmlns:a="http://schemas.openxmlformats.org/drawingml/2006/main">
               <a:ext uri="{FF2B5EF4-FFF2-40B4-BE49-F238E27FC236}">
-                <a16:creationId xmlns:a16="http://schemas.microsoft.com/office/drawing/2014/main" id="{7D90BDC3-6C4A-437E-8A5F-80121E5F6904}"/>
+                <a16:creationId xmlns:a16="http://schemas.microsoft.com/office/drawing/2014/main" id="{8CA6D3EB-D3F5-4EE1-9D93-C36E69C57D86}"/>
               </a:ext>
             </a:extLst>
           </p:cNvPr>
@@ -8054,7 +8054,7 @@
           <p:cNvPr id="9" name="">
             <a:extLst xmlns:a="http://schemas.openxmlformats.org/drawingml/2006/main">
               <a:ext uri="{FF2B5EF4-FFF2-40B4-BE49-F238E27FC236}">
-                <a16:creationId xmlns:a16="http://schemas.microsoft.com/office/drawing/2014/main" id="{940D7FC9-7BBF-4D06-BD10-5A3798BF35FE}"/>
+                <a16:creationId xmlns:a16="http://schemas.microsoft.com/office/drawing/2014/main" id="{68C0E1F2-1DDE-4B08-AAA4-0912521EE3A3}"/>
               </a:ext>
             </a:extLst>
           </p:cNvPr>
@@ -8112,7 +8112,7 @@
           <p:cNvPr id="10" name="">
             <a:extLst xmlns:a="http://schemas.openxmlformats.org/drawingml/2006/main">
               <a:ext uri="{FF2B5EF4-FFF2-40B4-BE49-F238E27FC236}">
-                <a16:creationId xmlns:a16="http://schemas.microsoft.com/office/drawing/2014/main" id="{480F1DFA-D512-44AE-97AB-29CFCE363EA6}"/>
+                <a16:creationId xmlns:a16="http://schemas.microsoft.com/office/drawing/2014/main" id="{D7AF4605-1E89-471C-936C-E45092309A9B}"/>
               </a:ext>
             </a:extLst>
           </p:cNvPr>
@@ -8147,7 +8147,7 @@
           <p:cNvPr id="11" name="">
             <a:extLst xmlns:a="http://schemas.openxmlformats.org/drawingml/2006/main">
               <a:ext uri="{FF2B5EF4-FFF2-40B4-BE49-F238E27FC236}">
-                <a16:creationId xmlns:a16="http://schemas.microsoft.com/office/drawing/2014/main" id="{57DA53BA-C29B-4805-BC96-EA8C6DF9C727}"/>
+                <a16:creationId xmlns:a16="http://schemas.microsoft.com/office/drawing/2014/main" id="{5BBEB97B-4DC5-47AC-9564-3EBA9275E27D}"/>
               </a:ext>
             </a:extLst>
           </p:cNvPr>
@@ -8205,7 +8205,7 @@
           <p:cNvPr id="12" name="">
             <a:extLst xmlns:a="http://schemas.openxmlformats.org/drawingml/2006/main">
               <a:ext uri="{FF2B5EF4-FFF2-40B4-BE49-F238E27FC236}">
-                <a16:creationId xmlns:a16="http://schemas.microsoft.com/office/drawing/2014/main" id="{194CF80B-BD06-4143-BF2F-3610C2ACCC8E}"/>
+                <a16:creationId xmlns:a16="http://schemas.microsoft.com/office/drawing/2014/main" id="{580750B0-E32D-4320-BF7D-B545B65926AD}"/>
               </a:ext>
             </a:extLst>
           </p:cNvPr>
@@ -8263,7 +8263,7 @@
           <p:cNvPr id="13" name="">
             <a:extLst xmlns:a="http://schemas.openxmlformats.org/drawingml/2006/main">
               <a:ext uri="{FF2B5EF4-FFF2-40B4-BE49-F238E27FC236}">
-                <a16:creationId xmlns:a16="http://schemas.microsoft.com/office/drawing/2014/main" id="{48BBC127-A624-45F3-A18E-B8D7AF767429}"/>
+                <a16:creationId xmlns:a16="http://schemas.microsoft.com/office/drawing/2014/main" id="{05FA55BD-67DA-4E0F-8DAC-1DBF23EFFF7F}"/>
               </a:ext>
             </a:extLst>
           </p:cNvPr>
@@ -8321,7 +8321,7 @@
           <p:cNvPr id="14" name="">
             <a:extLst xmlns:a="http://schemas.openxmlformats.org/drawingml/2006/main">
               <a:ext uri="{FF2B5EF4-FFF2-40B4-BE49-F238E27FC236}">
-                <a16:creationId xmlns:a16="http://schemas.microsoft.com/office/drawing/2014/main" id="{1C57840D-B584-4788-8A99-EF0E59B1029D}"/>
+                <a16:creationId xmlns:a16="http://schemas.microsoft.com/office/drawing/2014/main" id="{DBE85D3A-F024-4178-A55E-9B9301C432D2}"/>
               </a:ext>
             </a:extLst>
           </p:cNvPr>
@@ -8356,7 +8356,7 @@
           <p:cNvPr id="15" name="">
             <a:extLst xmlns:a="http://schemas.openxmlformats.org/drawingml/2006/main">
               <a:ext uri="{FF2B5EF4-FFF2-40B4-BE49-F238E27FC236}">
-                <a16:creationId xmlns:a16="http://schemas.microsoft.com/office/drawing/2014/main" id="{F7F66795-1A87-4691-9A69-4144F928E1C3}"/>
+                <a16:creationId xmlns:a16="http://schemas.microsoft.com/office/drawing/2014/main" id="{24694AD7-24D8-4D53-B1A5-434452AAC09E}"/>
               </a:ext>
             </a:extLst>
           </p:cNvPr>
@@ -8414,7 +8414,7 @@
           <p:cNvPr id="16" name="">
             <a:extLst xmlns:a="http://schemas.openxmlformats.org/drawingml/2006/main">
               <a:ext uri="{FF2B5EF4-FFF2-40B4-BE49-F238E27FC236}">
-                <a16:creationId xmlns:a16="http://schemas.microsoft.com/office/drawing/2014/main" id="{F91A1510-1866-4F3B-8FFC-DFD32E43CD66}"/>
+                <a16:creationId xmlns:a16="http://schemas.microsoft.com/office/drawing/2014/main" id="{21F10727-ED98-4965-A7E5-133BBE577F92}"/>
               </a:ext>
             </a:extLst>
           </p:cNvPr>
@@ -8472,7 +8472,7 @@
           <p:cNvPr id="17" name="">
             <a:extLst xmlns:a="http://schemas.openxmlformats.org/drawingml/2006/main">
               <a:ext uri="{FF2B5EF4-FFF2-40B4-BE49-F238E27FC236}">
-                <a16:creationId xmlns:a16="http://schemas.microsoft.com/office/drawing/2014/main" id="{DCF84106-BB8E-4DF1-B08F-103C6335A285}"/>
+                <a16:creationId xmlns:a16="http://schemas.microsoft.com/office/drawing/2014/main" id="{84EFA18A-F8DF-4126-84C3-BA11B7950895}"/>
               </a:ext>
             </a:extLst>
           </p:cNvPr>
@@ -8530,7 +8530,7 @@
           <p:cNvPr id="18" name="">
             <a:extLst xmlns:a="http://schemas.openxmlformats.org/drawingml/2006/main">
               <a:ext uri="{FF2B5EF4-FFF2-40B4-BE49-F238E27FC236}">
-                <a16:creationId xmlns:a16="http://schemas.microsoft.com/office/drawing/2014/main" id="{3AA6C76A-54DD-4A61-BAA5-CC0CA32E32D5}"/>
+                <a16:creationId xmlns:a16="http://schemas.microsoft.com/office/drawing/2014/main" id="{13400944-4946-40CE-B2E6-C0F2AA111DF4}"/>
               </a:ext>
             </a:extLst>
           </p:cNvPr>
@@ -8565,7 +8565,7 @@
           <p:cNvPr id="19" name="">
             <a:extLst xmlns:a="http://schemas.openxmlformats.org/drawingml/2006/main">
               <a:ext uri="{FF2B5EF4-FFF2-40B4-BE49-F238E27FC236}">
-                <a16:creationId xmlns:a16="http://schemas.microsoft.com/office/drawing/2014/main" id="{9510BCA3-4F3B-40CC-87E0-5DA662B6A1D2}"/>
+                <a16:creationId xmlns:a16="http://schemas.microsoft.com/office/drawing/2014/main" id="{45183E8F-0D11-4CB4-9FDE-BE02BF59CAEF}"/>
               </a:ext>
             </a:extLst>
           </p:cNvPr>
@@ -8623,7 +8623,7 @@
           <p:cNvPr id="20" name="">
             <a:extLst xmlns:a="http://schemas.openxmlformats.org/drawingml/2006/main">
               <a:ext uri="{FF2B5EF4-FFF2-40B4-BE49-F238E27FC236}">
-                <a16:creationId xmlns:a16="http://schemas.microsoft.com/office/drawing/2014/main" id="{9B127364-B064-425A-81DA-C75AC536C46A}"/>
+                <a16:creationId xmlns:a16="http://schemas.microsoft.com/office/drawing/2014/main" id="{81963739-0422-4B66-B247-BA8DBD846202}"/>
               </a:ext>
             </a:extLst>
           </p:cNvPr>
@@ -8681,7 +8681,7 @@
           <p:cNvPr id="21" name="">
             <a:extLst xmlns:a="http://schemas.openxmlformats.org/drawingml/2006/main">
               <a:ext uri="{FF2B5EF4-FFF2-40B4-BE49-F238E27FC236}">
-                <a16:creationId xmlns:a16="http://schemas.microsoft.com/office/drawing/2014/main" id="{3CAED4D1-B311-4AF5-9192-15E74A93F8BB}"/>
+                <a16:creationId xmlns:a16="http://schemas.microsoft.com/office/drawing/2014/main" id="{1CE88807-6852-410F-8274-D9049B1B6A15}"/>
               </a:ext>
             </a:extLst>
           </p:cNvPr>
@@ -8739,7 +8739,7 @@
           <p:cNvPr id="22" name="">
             <a:extLst xmlns:a="http://schemas.openxmlformats.org/drawingml/2006/main">
               <a:ext uri="{FF2B5EF4-FFF2-40B4-BE49-F238E27FC236}">
-                <a16:creationId xmlns:a16="http://schemas.microsoft.com/office/drawing/2014/main" id="{B55D8717-EC6B-4B09-B780-C57187709444}"/>
+                <a16:creationId xmlns:a16="http://schemas.microsoft.com/office/drawing/2014/main" id="{3BDF37A0-E997-47BD-AF5B-D8C3973BE2DB}"/>
               </a:ext>
             </a:extLst>
           </p:cNvPr>
@@ -8774,7 +8774,7 @@
           <p:cNvPr id="23" name="">
             <a:extLst xmlns:a="http://schemas.openxmlformats.org/drawingml/2006/main">
               <a:ext uri="{FF2B5EF4-FFF2-40B4-BE49-F238E27FC236}">
-                <a16:creationId xmlns:a16="http://schemas.microsoft.com/office/drawing/2014/main" id="{F4C4D0D1-9729-4FEC-BA69-A11FF0D9B117}"/>
+                <a16:creationId xmlns:a16="http://schemas.microsoft.com/office/drawing/2014/main" id="{7B3CDECD-DFEA-4F66-9399-CF9507985907}"/>
               </a:ext>
             </a:extLst>
           </p:cNvPr>
@@ -8832,7 +8832,7 @@
           <p:cNvPr id="24" name="">
             <a:extLst xmlns:a="http://schemas.openxmlformats.org/drawingml/2006/main">
               <a:ext uri="{FF2B5EF4-FFF2-40B4-BE49-F238E27FC236}">
-                <a16:creationId xmlns:a16="http://schemas.microsoft.com/office/drawing/2014/main" id="{726C9CAD-8486-41F8-B309-C11CCA9137B8}"/>
+                <a16:creationId xmlns:a16="http://schemas.microsoft.com/office/drawing/2014/main" id="{BD12EC40-EABD-42A8-99BB-8B497F400BE9}"/>
               </a:ext>
             </a:extLst>
           </p:cNvPr>
@@ -8890,7 +8890,7 @@
           <p:cNvPr id="25" name="">
             <a:extLst xmlns:a="http://schemas.openxmlformats.org/drawingml/2006/main">
               <a:ext uri="{FF2B5EF4-FFF2-40B4-BE49-F238E27FC236}">
-                <a16:creationId xmlns:a16="http://schemas.microsoft.com/office/drawing/2014/main" id="{A06FC428-40A1-43E0-B951-ED02F9590E06}"/>
+                <a16:creationId xmlns:a16="http://schemas.microsoft.com/office/drawing/2014/main" id="{2C27D37D-4173-442C-AFE4-7DB5AB5E5699}"/>
               </a:ext>
             </a:extLst>
           </p:cNvPr>
@@ -8948,7 +8948,7 @@
           <p:cNvPr id="26" name="">
             <a:extLst xmlns:a="http://schemas.openxmlformats.org/drawingml/2006/main">
               <a:ext uri="{FF2B5EF4-FFF2-40B4-BE49-F238E27FC236}">
-                <a16:creationId xmlns:a16="http://schemas.microsoft.com/office/drawing/2014/main" id="{243AE7E3-4F29-4411-87B7-5B4C7584AE03}"/>
+                <a16:creationId xmlns:a16="http://schemas.microsoft.com/office/drawing/2014/main" id="{E1E61EE3-FBDA-48D0-AEC4-ED57F088FD14}"/>
               </a:ext>
             </a:extLst>
           </p:cNvPr>
@@ -8983,7 +8983,7 @@
           <p:cNvPr id="27" name="">
             <a:extLst xmlns:a="http://schemas.openxmlformats.org/drawingml/2006/main">
               <a:ext uri="{FF2B5EF4-FFF2-40B4-BE49-F238E27FC236}">
-                <a16:creationId xmlns:a16="http://schemas.microsoft.com/office/drawing/2014/main" id="{859882F5-64E7-46B8-B3DC-10D5DE377429}"/>
+                <a16:creationId xmlns:a16="http://schemas.microsoft.com/office/drawing/2014/main" id="{4409565E-AA43-4172-8E55-EACA02F76ADE}"/>
               </a:ext>
             </a:extLst>
           </p:cNvPr>
@@ -9041,7 +9041,7 @@
           <p:cNvPr id="28" name="">
             <a:extLst xmlns:a="http://schemas.openxmlformats.org/drawingml/2006/main">
               <a:ext uri="{FF2B5EF4-FFF2-40B4-BE49-F238E27FC236}">
-                <a16:creationId xmlns:a16="http://schemas.microsoft.com/office/drawing/2014/main" id="{15C85EDD-E68F-4004-B8D9-DE1E257F49A9}"/>
+                <a16:creationId xmlns:a16="http://schemas.microsoft.com/office/drawing/2014/main" id="{CFE234A7-27A3-44CA-9B26-7047F2EF485E}"/>
               </a:ext>
             </a:extLst>
           </p:cNvPr>
@@ -9099,7 +9099,7 @@
           <p:cNvPr id="29" name="">
             <a:extLst xmlns:a="http://schemas.openxmlformats.org/drawingml/2006/main">
               <a:ext uri="{FF2B5EF4-FFF2-40B4-BE49-F238E27FC236}">
-                <a16:creationId xmlns:a16="http://schemas.microsoft.com/office/drawing/2014/main" id="{67233884-C7C6-4DC9-A92F-D7335923BD4C}"/>
+                <a16:creationId xmlns:a16="http://schemas.microsoft.com/office/drawing/2014/main" id="{1AA1218F-E5BC-4B55-A0E6-2C119F728F29}"/>
               </a:ext>
             </a:extLst>
           </p:cNvPr>
@@ -9157,7 +9157,7 @@
           <p:cNvPr id="30" name="">
             <a:extLst xmlns:a="http://schemas.openxmlformats.org/drawingml/2006/main">
               <a:ext uri="{FF2B5EF4-FFF2-40B4-BE49-F238E27FC236}">
-                <a16:creationId xmlns:a16="http://schemas.microsoft.com/office/drawing/2014/main" id="{CC5F1CDE-CA31-479D-BC05-5C80CCB70C94}"/>
+                <a16:creationId xmlns:a16="http://schemas.microsoft.com/office/drawing/2014/main" id="{DC83FE25-8B90-46F7-AE36-A57CB834AA04}"/>
               </a:ext>
             </a:extLst>
           </p:cNvPr>
@@ -9192,7 +9192,7 @@
           <p:cNvPr id="31" name="">
             <a:extLst xmlns:a="http://schemas.openxmlformats.org/drawingml/2006/main">
               <a:ext uri="{FF2B5EF4-FFF2-40B4-BE49-F238E27FC236}">
-                <a16:creationId xmlns:a16="http://schemas.microsoft.com/office/drawing/2014/main" id="{99052EFA-C4B4-40D3-B64C-B84E42E6C206}"/>
+                <a16:creationId xmlns:a16="http://schemas.microsoft.com/office/drawing/2014/main" id="{592D2ACF-9E3E-47EC-9FA2-754B4207C42F}"/>
               </a:ext>
             </a:extLst>
           </p:cNvPr>
@@ -9250,7 +9250,7 @@
           <p:cNvPr id="32" name="">
             <a:extLst xmlns:a="http://schemas.openxmlformats.org/drawingml/2006/main">
               <a:ext uri="{FF2B5EF4-FFF2-40B4-BE49-F238E27FC236}">
-                <a16:creationId xmlns:a16="http://schemas.microsoft.com/office/drawing/2014/main" id="{95B44D76-A3E2-4EC7-A650-C00217A11964}"/>
+                <a16:creationId xmlns:a16="http://schemas.microsoft.com/office/drawing/2014/main" id="{B5D2F292-5604-4676-BD79-7BE1C090854F}"/>
               </a:ext>
             </a:extLst>
           </p:cNvPr>
@@ -9308,7 +9308,7 @@
           <p:cNvPr id="33" name="">
             <a:extLst xmlns:a="http://schemas.openxmlformats.org/drawingml/2006/main">
               <a:ext uri="{FF2B5EF4-FFF2-40B4-BE49-F238E27FC236}">
-                <a16:creationId xmlns:a16="http://schemas.microsoft.com/office/drawing/2014/main" id="{909ECD61-DEEB-4851-AC16-910B09925227}"/>
+                <a16:creationId xmlns:a16="http://schemas.microsoft.com/office/drawing/2014/main" id="{401DB4E4-A939-46DD-9AE3-CCE5C38B7152}"/>
               </a:ext>
             </a:extLst>
           </p:cNvPr>
@@ -9366,7 +9366,7 @@
           <p:cNvPr id="34" name="">
             <a:extLst xmlns:a="http://schemas.openxmlformats.org/drawingml/2006/main">
               <a:ext uri="{FF2B5EF4-FFF2-40B4-BE49-F238E27FC236}">
-                <a16:creationId xmlns:a16="http://schemas.microsoft.com/office/drawing/2014/main" id="{21F16FB8-8721-4010-A617-8E0A085B5000}"/>
+                <a16:creationId xmlns:a16="http://schemas.microsoft.com/office/drawing/2014/main" id="{C2AB0412-4EDC-4272-8EAE-745143DB4EC7}"/>
               </a:ext>
             </a:extLst>
           </p:cNvPr>
@@ -9401,7 +9401,7 @@
           <p:cNvPr id="35" name="">
             <a:extLst xmlns:a="http://schemas.openxmlformats.org/drawingml/2006/main">
               <a:ext uri="{FF2B5EF4-FFF2-40B4-BE49-F238E27FC236}">
-                <a16:creationId xmlns:a16="http://schemas.microsoft.com/office/drawing/2014/main" id="{765B2AF4-A179-4C70-9EDB-3B2BA42B12EF}"/>
+                <a16:creationId xmlns:a16="http://schemas.microsoft.com/office/drawing/2014/main" id="{F5488B4B-CD56-48C2-9622-31E32CA06D02}"/>
               </a:ext>
             </a:extLst>
           </p:cNvPr>
@@ -9459,7 +9459,7 @@
           <p:cNvPr id="36" name="">
             <a:extLst xmlns:a="http://schemas.openxmlformats.org/drawingml/2006/main">
               <a:ext uri="{FF2B5EF4-FFF2-40B4-BE49-F238E27FC236}">
-                <a16:creationId xmlns:a16="http://schemas.microsoft.com/office/drawing/2014/main" id="{3D83DC96-95B5-487D-B168-9D6DA8CE04E7}"/>
+                <a16:creationId xmlns:a16="http://schemas.microsoft.com/office/drawing/2014/main" id="{3461AE90-7421-46C5-BE58-5E1E2CE23864}"/>
               </a:ext>
             </a:extLst>
           </p:cNvPr>
@@ -9517,7 +9517,7 @@
           <p:cNvPr id="37" name="">
             <a:extLst xmlns:a="http://schemas.openxmlformats.org/drawingml/2006/main">
               <a:ext uri="{FF2B5EF4-FFF2-40B4-BE49-F238E27FC236}">
-                <a16:creationId xmlns:a16="http://schemas.microsoft.com/office/drawing/2014/main" id="{E7B7C21E-8AFD-4F5A-8197-3FA400671798}"/>
+                <a16:creationId xmlns:a16="http://schemas.microsoft.com/office/drawing/2014/main" id="{9DB2F312-9D15-4ACC-9160-FFE098CCA07B}"/>
               </a:ext>
             </a:extLst>
           </p:cNvPr>
@@ -9573,7 +9573,7 @@
     </p:spTree>
     <p:extLst>
       <p:ext uri="{BB962C8B-B14F-4D97-AF65-F5344CB8AC3E}">
-        <p14:creationId xmlns:p14="http://schemas.microsoft.com/office/powerpoint/2010/main" val="1971407041"/>
+        <p14:creationId xmlns:p14="http://schemas.microsoft.com/office/powerpoint/2010/main" val="2100173088"/>
       </p:ext>
     </p:extLst>
   </p:cSld>
@@ -9604,7 +9604,7 @@
           <p:cNvPr id="19" name="">
             <a:extLst xmlns:a="http://schemas.openxmlformats.org/drawingml/2006/main">
               <a:ext uri="{FF2B5EF4-FFF2-40B4-BE49-F238E27FC236}">
-                <a16:creationId xmlns:a16="http://schemas.microsoft.com/office/drawing/2014/main" id="{CA8555E8-2310-43B7-9DB3-882F40EB0451}"/>
+                <a16:creationId xmlns:a16="http://schemas.microsoft.com/office/drawing/2014/main" id="{54A30224-62AE-433D-AF16-DAC1E3EF8388}"/>
               </a:ext>
             </a:extLst>
           </p:cNvPr>
@@ -9662,7 +9662,7 @@
           <p:cNvPr id="2" name="">
             <a:extLst xmlns:a="http://schemas.openxmlformats.org/drawingml/2006/main">
               <a:ext uri="{FF2B5EF4-FFF2-40B4-BE49-F238E27FC236}">
-                <a16:creationId xmlns:a16="http://schemas.microsoft.com/office/drawing/2014/main" id="{88189914-9802-4B73-BC11-1FC3504AA432}"/>
+                <a16:creationId xmlns:a16="http://schemas.microsoft.com/office/drawing/2014/main" id="{81E11450-AC91-4809-B29F-D82C8C2475A8}"/>
               </a:ext>
             </a:extLst>
           </p:cNvPr>
@@ -9720,7 +9720,7 @@
           <p:cNvPr id="3" name="">
             <a:extLst xmlns:a="http://schemas.openxmlformats.org/drawingml/2006/main">
               <a:ext uri="{FF2B5EF4-FFF2-40B4-BE49-F238E27FC236}">
-                <a16:creationId xmlns:a16="http://schemas.microsoft.com/office/drawing/2014/main" id="{934F7224-A6C4-4E05-9B83-844C2776987F}"/>
+                <a16:creationId xmlns:a16="http://schemas.microsoft.com/office/drawing/2014/main" id="{70E3289D-659B-4139-AB1A-C42D4441C0AE}"/>
               </a:ext>
             </a:extLst>
           </p:cNvPr>
@@ -9753,7 +9753,7 @@
           <p:cNvPr id="4" name="">
             <a:extLst xmlns:a="http://schemas.openxmlformats.org/drawingml/2006/main">
               <a:ext uri="{FF2B5EF4-FFF2-40B4-BE49-F238E27FC236}">
-                <a16:creationId xmlns:a16="http://schemas.microsoft.com/office/drawing/2014/main" id="{AABF45AB-8850-43FD-9ACD-CA765B5DBF73}"/>
+                <a16:creationId xmlns:a16="http://schemas.microsoft.com/office/drawing/2014/main" id="{3ACBED6E-93FC-43DF-861C-3D97F2E544E1}"/>
               </a:ext>
             </a:extLst>
           </p:cNvPr>
@@ -9811,7 +9811,7 @@
           <p:cNvPr id="5" name="">
             <a:extLst xmlns:a="http://schemas.openxmlformats.org/drawingml/2006/main">
               <a:ext uri="{FF2B5EF4-FFF2-40B4-BE49-F238E27FC236}">
-                <a16:creationId xmlns:a16="http://schemas.microsoft.com/office/drawing/2014/main" id="{AC01F47F-56DB-4F3C-97FC-182FEDF3DE53}"/>
+                <a16:creationId xmlns:a16="http://schemas.microsoft.com/office/drawing/2014/main" id="{F90F093A-388B-46E0-AAAB-D8B6B428A093}"/>
               </a:ext>
             </a:extLst>
           </p:cNvPr>
@@ -9869,7 +9869,7 @@
           <p:cNvPr id="6" name="">
             <a:extLst xmlns:a="http://schemas.openxmlformats.org/drawingml/2006/main">
               <a:ext uri="{FF2B5EF4-FFF2-40B4-BE49-F238E27FC236}">
-                <a16:creationId xmlns:a16="http://schemas.microsoft.com/office/drawing/2014/main" id="{5023C3AB-455C-483E-B8CD-1079D55D8D1D}"/>
+                <a16:creationId xmlns:a16="http://schemas.microsoft.com/office/drawing/2014/main" id="{DD307F61-1442-46BF-B3C8-8CEB74630C0C}"/>
               </a:ext>
             </a:extLst>
           </p:cNvPr>
@@ -9904,7 +9904,7 @@
           <p:cNvPr id="7" name="">
             <a:extLst xmlns:a="http://schemas.openxmlformats.org/drawingml/2006/main">
               <a:ext uri="{FF2B5EF4-FFF2-40B4-BE49-F238E27FC236}">
-                <a16:creationId xmlns:a16="http://schemas.microsoft.com/office/drawing/2014/main" id="{0C3926D6-ABE2-477F-8B2A-A5FF7D0D2777}"/>
+                <a16:creationId xmlns:a16="http://schemas.microsoft.com/office/drawing/2014/main" id="{3C7321B4-0433-4388-BECC-9CE98E1E733F}"/>
               </a:ext>
             </a:extLst>
           </p:cNvPr>
@@ -9937,7 +9937,7 @@
           <p:cNvPr id="8" name="">
             <a:extLst xmlns:a="http://schemas.openxmlformats.org/drawingml/2006/main">
               <a:ext uri="{FF2B5EF4-FFF2-40B4-BE49-F238E27FC236}">
-                <a16:creationId xmlns:a16="http://schemas.microsoft.com/office/drawing/2014/main" id="{3C950129-476A-4A48-9AE7-B300D89F9020}"/>
+                <a16:creationId xmlns:a16="http://schemas.microsoft.com/office/drawing/2014/main" id="{A1338E85-4616-41E8-86E1-F2EC338252D8}"/>
               </a:ext>
             </a:extLst>
           </p:cNvPr>
@@ -9995,7 +9995,7 @@
           <p:cNvPr id="9" name="">
             <a:extLst xmlns:a="http://schemas.openxmlformats.org/drawingml/2006/main">
               <a:ext uri="{FF2B5EF4-FFF2-40B4-BE49-F238E27FC236}">
-                <a16:creationId xmlns:a16="http://schemas.microsoft.com/office/drawing/2014/main" id="{0C951EC7-C236-4BE6-B9D0-E1B6608B6885}"/>
+                <a16:creationId xmlns:a16="http://schemas.microsoft.com/office/drawing/2014/main" id="{1576859C-4D8A-495C-ACC7-CCE0239C4704}"/>
               </a:ext>
             </a:extLst>
           </p:cNvPr>
@@ -10070,7 +10070,7 @@
           <p:cNvPr id="10" name="">
             <a:extLst xmlns:a="http://schemas.openxmlformats.org/drawingml/2006/main">
               <a:ext uri="{FF2B5EF4-FFF2-40B4-BE49-F238E27FC236}">
-                <a16:creationId xmlns:a16="http://schemas.microsoft.com/office/drawing/2014/main" id="{1A2A72E6-1738-4201-A255-82A5B6CDAF8D}"/>
+                <a16:creationId xmlns:a16="http://schemas.microsoft.com/office/drawing/2014/main" id="{62B0CBA4-187C-412B-A3EF-7D7D1BD0E20F}"/>
               </a:ext>
             </a:extLst>
           </p:cNvPr>
@@ -10105,7 +10105,7 @@
           <p:cNvPr id="11" name="">
             <a:extLst xmlns:a="http://schemas.openxmlformats.org/drawingml/2006/main">
               <a:ext uri="{FF2B5EF4-FFF2-40B4-BE49-F238E27FC236}">
-                <a16:creationId xmlns:a16="http://schemas.microsoft.com/office/drawing/2014/main" id="{58139AAE-C6F9-4E29-A628-7168E4939C6F}"/>
+                <a16:creationId xmlns:a16="http://schemas.microsoft.com/office/drawing/2014/main" id="{CC96ADD1-DFD8-4750-BE36-61A9B9EF7031}"/>
               </a:ext>
             </a:extLst>
           </p:cNvPr>
@@ -10138,7 +10138,7 @@
           <p:cNvPr id="12" name="">
             <a:extLst xmlns:a="http://schemas.openxmlformats.org/drawingml/2006/main">
               <a:ext uri="{FF2B5EF4-FFF2-40B4-BE49-F238E27FC236}">
-                <a16:creationId xmlns:a16="http://schemas.microsoft.com/office/drawing/2014/main" id="{28F136EB-1D8E-47AD-A7CB-2671195FEA05}"/>
+                <a16:creationId xmlns:a16="http://schemas.microsoft.com/office/drawing/2014/main" id="{785B24DF-A4FC-4D72-91DA-BEA9DA55585F}"/>
               </a:ext>
             </a:extLst>
           </p:cNvPr>
@@ -10196,7 +10196,7 @@
           <p:cNvPr id="13" name="">
             <a:extLst xmlns:a="http://schemas.openxmlformats.org/drawingml/2006/main">
               <a:ext uri="{FF2B5EF4-FFF2-40B4-BE49-F238E27FC236}">
-                <a16:creationId xmlns:a16="http://schemas.microsoft.com/office/drawing/2014/main" id="{5BA79CAC-A540-4419-9EC9-0E6B171B4C44}"/>
+                <a16:creationId xmlns:a16="http://schemas.microsoft.com/office/drawing/2014/main" id="{D5EEF78F-C5C7-4E61-B442-B230916E71BA}"/>
               </a:ext>
             </a:extLst>
           </p:cNvPr>
@@ -10254,7 +10254,7 @@
           <p:cNvPr id="14" name="">
             <a:extLst xmlns:a="http://schemas.openxmlformats.org/drawingml/2006/main">
               <a:ext uri="{FF2B5EF4-FFF2-40B4-BE49-F238E27FC236}">
-                <a16:creationId xmlns:a16="http://schemas.microsoft.com/office/drawing/2014/main" id="{F4AAE801-19D2-431C-B3D1-33E5F3952698}"/>
+                <a16:creationId xmlns:a16="http://schemas.microsoft.com/office/drawing/2014/main" id="{2AF381E3-E872-4A7D-80B3-F68B5FD5BED0}"/>
               </a:ext>
             </a:extLst>
           </p:cNvPr>
@@ -10289,7 +10289,7 @@
           <p:cNvPr id="15" name="">
             <a:extLst xmlns:a="http://schemas.openxmlformats.org/drawingml/2006/main">
               <a:ext uri="{FF2B5EF4-FFF2-40B4-BE49-F238E27FC236}">
-                <a16:creationId xmlns:a16="http://schemas.microsoft.com/office/drawing/2014/main" id="{021C4FE2-C61C-42E1-9754-EE6C9DE7DA14}"/>
+                <a16:creationId xmlns:a16="http://schemas.microsoft.com/office/drawing/2014/main" id="{D33F1179-CDF1-403A-B44F-FC73C0609206}"/>
               </a:ext>
             </a:extLst>
           </p:cNvPr>
@@ -10322,7 +10322,7 @@
           <p:cNvPr id="16" name="">
             <a:extLst xmlns:a="http://schemas.openxmlformats.org/drawingml/2006/main">
               <a:ext uri="{FF2B5EF4-FFF2-40B4-BE49-F238E27FC236}">
-                <a16:creationId xmlns:a16="http://schemas.microsoft.com/office/drawing/2014/main" id="{2FA13EA5-D328-4DAF-BE3C-6D4AFAEF57EC}"/>
+                <a16:creationId xmlns:a16="http://schemas.microsoft.com/office/drawing/2014/main" id="{020472D1-ED61-4B04-91DC-4EFC6A5D046A}"/>
               </a:ext>
             </a:extLst>
           </p:cNvPr>
@@ -10380,7 +10380,7 @@
           <p:cNvPr id="17" name="">
             <a:extLst xmlns:a="http://schemas.openxmlformats.org/drawingml/2006/main">
               <a:ext uri="{FF2B5EF4-FFF2-40B4-BE49-F238E27FC236}">
-                <a16:creationId xmlns:a16="http://schemas.microsoft.com/office/drawing/2014/main" id="{8BEA95B8-7941-45CF-87CF-E91778354F8B}"/>
+                <a16:creationId xmlns:a16="http://schemas.microsoft.com/office/drawing/2014/main" id="{FBFF4803-6411-4F47-A7E8-5A74DDF5DEB0}"/>
               </a:ext>
             </a:extLst>
           </p:cNvPr>
@@ -10438,7 +10438,7 @@
           <p:cNvPr id="18" name="">
             <a:extLst xmlns:a="http://schemas.openxmlformats.org/drawingml/2006/main">
               <a:ext uri="{FF2B5EF4-FFF2-40B4-BE49-F238E27FC236}">
-                <a16:creationId xmlns:a16="http://schemas.microsoft.com/office/drawing/2014/main" id="{5E9565B3-A005-4D7A-8DC8-9B9002D89DB9}"/>
+                <a16:creationId xmlns:a16="http://schemas.microsoft.com/office/drawing/2014/main" id="{533B6DAF-4A61-4C24-873D-A4806EDAFD47}"/>
               </a:ext>
             </a:extLst>
           </p:cNvPr>
@@ -10494,7 +10494,7 @@
     </p:spTree>
     <p:extLst>
       <p:ext uri="{BB962C8B-B14F-4D97-AF65-F5344CB8AC3E}">
-        <p14:creationId xmlns:p14="http://schemas.microsoft.com/office/powerpoint/2010/main" val="484540256"/>
+        <p14:creationId xmlns:p14="http://schemas.microsoft.com/office/powerpoint/2010/main" val="92706990"/>
       </p:ext>
     </p:extLst>
   </p:cSld>
@@ -10525,7 +10525,7 @@
           <p:cNvPr id="28" name="">
             <a:extLst xmlns:a="http://schemas.openxmlformats.org/drawingml/2006/main">
               <a:ext uri="{FF2B5EF4-FFF2-40B4-BE49-F238E27FC236}">
-                <a16:creationId xmlns:a16="http://schemas.microsoft.com/office/drawing/2014/main" id="{52BF67A6-17C1-4E07-8742-50AEC0742314}"/>
+                <a16:creationId xmlns:a16="http://schemas.microsoft.com/office/drawing/2014/main" id="{32A5D573-E700-4670-8798-F8FD0DAF6BFB}"/>
               </a:ext>
             </a:extLst>
           </p:cNvPr>
@@ -10583,7 +10583,7 @@
           <p:cNvPr id="2" name="">
             <a:extLst xmlns:a="http://schemas.openxmlformats.org/drawingml/2006/main">
               <a:ext uri="{FF2B5EF4-FFF2-40B4-BE49-F238E27FC236}">
-                <a16:creationId xmlns:a16="http://schemas.microsoft.com/office/drawing/2014/main" id="{7E8BAC6C-8BEA-4215-93C7-BFEC447D9A9E}"/>
+                <a16:creationId xmlns:a16="http://schemas.microsoft.com/office/drawing/2014/main" id="{D537E06B-C5FB-44C3-A96F-568AEEBE5BEB}"/>
               </a:ext>
             </a:extLst>
           </p:cNvPr>
@@ -10641,7 +10641,7 @@
           <p:cNvPr id="3" name="">
             <a:extLst xmlns:a="http://schemas.openxmlformats.org/drawingml/2006/main">
               <a:ext uri="{FF2B5EF4-FFF2-40B4-BE49-F238E27FC236}">
-                <a16:creationId xmlns:a16="http://schemas.microsoft.com/office/drawing/2014/main" id="{DE472C1E-DD34-4F88-8335-4B7F4BF53F9C}"/>
+                <a16:creationId xmlns:a16="http://schemas.microsoft.com/office/drawing/2014/main" id="{69D00ED6-E3E9-4E4D-96AE-2882098E16BA}"/>
               </a:ext>
             </a:extLst>
           </p:cNvPr>
@@ -10674,7 +10674,7 @@
           <p:cNvPr id="4" name="">
             <a:extLst xmlns:a="http://schemas.openxmlformats.org/drawingml/2006/main">
               <a:ext uri="{FF2B5EF4-FFF2-40B4-BE49-F238E27FC236}">
-                <a16:creationId xmlns:a16="http://schemas.microsoft.com/office/drawing/2014/main" id="{FB357774-14D1-4E93-A966-1030CC3518AB}"/>
+                <a16:creationId xmlns:a16="http://schemas.microsoft.com/office/drawing/2014/main" id="{65C0A502-2AB9-41D4-8B46-C789A20CA31E}"/>
               </a:ext>
             </a:extLst>
           </p:cNvPr>
@@ -10732,7 +10732,7 @@
           <p:cNvPr id="5" name="">
             <a:extLst xmlns:a="http://schemas.openxmlformats.org/drawingml/2006/main">
               <a:ext uri="{FF2B5EF4-FFF2-40B4-BE49-F238E27FC236}">
-                <a16:creationId xmlns:a16="http://schemas.microsoft.com/office/drawing/2014/main" id="{ECE60E9A-0985-49C4-8029-F000517881F1}"/>
+                <a16:creationId xmlns:a16="http://schemas.microsoft.com/office/drawing/2014/main" id="{631A3DB8-0004-43B8-9800-8ECBEAF17E11}"/>
               </a:ext>
             </a:extLst>
           </p:cNvPr>
@@ -10790,7 +10790,7 @@
           <p:cNvPr id="6" name="">
             <a:extLst xmlns:a="http://schemas.openxmlformats.org/drawingml/2006/main">
               <a:ext uri="{FF2B5EF4-FFF2-40B4-BE49-F238E27FC236}">
-                <a16:creationId xmlns:a16="http://schemas.microsoft.com/office/drawing/2014/main" id="{02B08C9E-4ADC-4AE3-ADFC-0377B5D46966}"/>
+                <a16:creationId xmlns:a16="http://schemas.microsoft.com/office/drawing/2014/main" id="{84AA39BD-4937-4204-986B-1520A2F46357}"/>
               </a:ext>
             </a:extLst>
           </p:cNvPr>
@@ -10825,7 +10825,7 @@
           <p:cNvPr id="7" name="">
             <a:extLst xmlns:a="http://schemas.openxmlformats.org/drawingml/2006/main">
               <a:ext uri="{FF2B5EF4-FFF2-40B4-BE49-F238E27FC236}">
-                <a16:creationId xmlns:a16="http://schemas.microsoft.com/office/drawing/2014/main" id="{7029F22B-363D-47DF-B54F-289307A0081D}"/>
+                <a16:creationId xmlns:a16="http://schemas.microsoft.com/office/drawing/2014/main" id="{9368CDA9-5433-4115-A9CA-A0FFC5A1E781}"/>
               </a:ext>
             </a:extLst>
           </p:cNvPr>
@@ -10883,7 +10883,7 @@
           <p:cNvPr id="8" name="">
             <a:extLst xmlns:a="http://schemas.openxmlformats.org/drawingml/2006/main">
               <a:ext uri="{FF2B5EF4-FFF2-40B4-BE49-F238E27FC236}">
-                <a16:creationId xmlns:a16="http://schemas.microsoft.com/office/drawing/2014/main" id="{8E94079B-3FDD-4954-AE90-0FF8BF1B8888}"/>
+                <a16:creationId xmlns:a16="http://schemas.microsoft.com/office/drawing/2014/main" id="{195354CD-85FD-42C9-A1FD-3960A4B4A2FE}"/>
               </a:ext>
             </a:extLst>
           </p:cNvPr>
@@ -10918,7 +10918,7 @@
           <p:cNvPr id="9" name="">
             <a:extLst xmlns:a="http://schemas.openxmlformats.org/drawingml/2006/main">
               <a:ext uri="{FF2B5EF4-FFF2-40B4-BE49-F238E27FC236}">
-                <a16:creationId xmlns:a16="http://schemas.microsoft.com/office/drawing/2014/main" id="{2CC9B9D9-7C43-4BBE-9D96-C6BE9A9FC1E5}"/>
+                <a16:creationId xmlns:a16="http://schemas.microsoft.com/office/drawing/2014/main" id="{3574053D-5533-4991-8656-B937CCDA2A1B}"/>
               </a:ext>
             </a:extLst>
           </p:cNvPr>
@@ -10976,7 +10976,7 @@
           <p:cNvPr id="10" name="">
             <a:extLst xmlns:a="http://schemas.openxmlformats.org/drawingml/2006/main">
               <a:ext uri="{FF2B5EF4-FFF2-40B4-BE49-F238E27FC236}">
-                <a16:creationId xmlns:a16="http://schemas.microsoft.com/office/drawing/2014/main" id="{E20A5551-87EF-4CCB-BB80-3FD9E467887D}"/>
+                <a16:creationId xmlns:a16="http://schemas.microsoft.com/office/drawing/2014/main" id="{698EED8F-329D-4C3D-8607-ED680DB92584}"/>
               </a:ext>
             </a:extLst>
           </p:cNvPr>
@@ -11011,7 +11011,7 @@
           <p:cNvPr id="11" name="">
             <a:extLst xmlns:a="http://schemas.openxmlformats.org/drawingml/2006/main">
               <a:ext uri="{FF2B5EF4-FFF2-40B4-BE49-F238E27FC236}">
-                <a16:creationId xmlns:a16="http://schemas.microsoft.com/office/drawing/2014/main" id="{70AFAC29-E332-45EE-B1C4-E4DFB7B63F75}"/>
+                <a16:creationId xmlns:a16="http://schemas.microsoft.com/office/drawing/2014/main" id="{6425CFA7-A776-4573-A341-0907FB22F956}"/>
               </a:ext>
             </a:extLst>
           </p:cNvPr>
@@ -11069,7 +11069,7 @@
           <p:cNvPr id="12" name="">
             <a:extLst xmlns:a="http://schemas.openxmlformats.org/drawingml/2006/main">
               <a:ext uri="{FF2B5EF4-FFF2-40B4-BE49-F238E27FC236}">
-                <a16:creationId xmlns:a16="http://schemas.microsoft.com/office/drawing/2014/main" id="{1C08B2B4-8087-4BC6-A95C-4EF090018078}"/>
+                <a16:creationId xmlns:a16="http://schemas.microsoft.com/office/drawing/2014/main" id="{D9CAFB31-FB47-49AE-B478-CD8CB03CEBE5}"/>
               </a:ext>
             </a:extLst>
           </p:cNvPr>
@@ -11104,7 +11104,7 @@
           <p:cNvPr id="13" name="">
             <a:extLst xmlns:a="http://schemas.openxmlformats.org/drawingml/2006/main">
               <a:ext uri="{FF2B5EF4-FFF2-40B4-BE49-F238E27FC236}">
-                <a16:creationId xmlns:a16="http://schemas.microsoft.com/office/drawing/2014/main" id="{0A46981C-707D-4486-97B5-F5B07C80738B}"/>
+                <a16:creationId xmlns:a16="http://schemas.microsoft.com/office/drawing/2014/main" id="{63C3B459-BB59-49F4-9AE7-BF3842485D45}"/>
               </a:ext>
             </a:extLst>
           </p:cNvPr>
@@ -11162,7 +11162,7 @@
           <p:cNvPr id="14" name="">
             <a:extLst xmlns:a="http://schemas.openxmlformats.org/drawingml/2006/main">
               <a:ext uri="{FF2B5EF4-FFF2-40B4-BE49-F238E27FC236}">
-                <a16:creationId xmlns:a16="http://schemas.microsoft.com/office/drawing/2014/main" id="{E076CA2B-F4C2-4342-A67B-538DC2B8136B}"/>
+                <a16:creationId xmlns:a16="http://schemas.microsoft.com/office/drawing/2014/main" id="{BD84E74E-178E-4C5B-AD7F-C02E9A3A04C1}"/>
               </a:ext>
             </a:extLst>
           </p:cNvPr>
@@ -11197,7 +11197,7 @@
           <p:cNvPr id="15" name="">
             <a:extLst xmlns:a="http://schemas.openxmlformats.org/drawingml/2006/main">
               <a:ext uri="{FF2B5EF4-FFF2-40B4-BE49-F238E27FC236}">
-                <a16:creationId xmlns:a16="http://schemas.microsoft.com/office/drawing/2014/main" id="{604FA6C3-190B-45E0-B427-16BE1FFCA1BD}"/>
+                <a16:creationId xmlns:a16="http://schemas.microsoft.com/office/drawing/2014/main" id="{0DFD19C2-42F7-472C-893E-7A7B38B8EA05}"/>
               </a:ext>
             </a:extLst>
           </p:cNvPr>
@@ -11255,7 +11255,7 @@
           <p:cNvPr id="16" name="">
             <a:extLst xmlns:a="http://schemas.openxmlformats.org/drawingml/2006/main">
               <a:ext uri="{FF2B5EF4-FFF2-40B4-BE49-F238E27FC236}">
-                <a16:creationId xmlns:a16="http://schemas.microsoft.com/office/drawing/2014/main" id="{DC9C08D0-A568-4AD5-9DE4-416C11B81D7C}"/>
+                <a16:creationId xmlns:a16="http://schemas.microsoft.com/office/drawing/2014/main" id="{F927D4B5-B446-49B7-99DE-7F2F56253569}"/>
               </a:ext>
             </a:extLst>
           </p:cNvPr>
@@ -11290,7 +11290,7 @@
           <p:cNvPr id="17" name="">
             <a:extLst xmlns:a="http://schemas.openxmlformats.org/drawingml/2006/main">
               <a:ext uri="{FF2B5EF4-FFF2-40B4-BE49-F238E27FC236}">
-                <a16:creationId xmlns:a16="http://schemas.microsoft.com/office/drawing/2014/main" id="{2591D3B3-990A-4B2E-A169-B857B3CB3E49}"/>
+                <a16:creationId xmlns:a16="http://schemas.microsoft.com/office/drawing/2014/main" id="{81A8F3C2-D85A-4B34-97E1-00B865F66D03}"/>
               </a:ext>
             </a:extLst>
           </p:cNvPr>
@@ -11348,7 +11348,7 @@
           <p:cNvPr id="18" name="">
             <a:extLst xmlns:a="http://schemas.openxmlformats.org/drawingml/2006/main">
               <a:ext uri="{FF2B5EF4-FFF2-40B4-BE49-F238E27FC236}">
-                <a16:creationId xmlns:a16="http://schemas.microsoft.com/office/drawing/2014/main" id="{94D8C66C-DBA6-4331-AF52-77BE965DCD77}"/>
+                <a16:creationId xmlns:a16="http://schemas.microsoft.com/office/drawing/2014/main" id="{9AD8558E-129E-45E1-8814-CF4CC258A9D7}"/>
               </a:ext>
             </a:extLst>
           </p:cNvPr>
@@ -11383,7 +11383,7 @@
           <p:cNvPr id="19" name="">
             <a:extLst xmlns:a="http://schemas.openxmlformats.org/drawingml/2006/main">
               <a:ext uri="{FF2B5EF4-FFF2-40B4-BE49-F238E27FC236}">
-                <a16:creationId xmlns:a16="http://schemas.microsoft.com/office/drawing/2014/main" id="{4CF54693-3D6F-4E17-805D-2B7CA1807807}"/>
+                <a16:creationId xmlns:a16="http://schemas.microsoft.com/office/drawing/2014/main" id="{39DDFA05-DEB2-4F70-908A-6B8ED7FB6F05}"/>
               </a:ext>
             </a:extLst>
           </p:cNvPr>
@@ -11441,7 +11441,7 @@
           <p:cNvPr id="20" name="">
             <a:extLst xmlns:a="http://schemas.openxmlformats.org/drawingml/2006/main">
               <a:ext uri="{FF2B5EF4-FFF2-40B4-BE49-F238E27FC236}">
-                <a16:creationId xmlns:a16="http://schemas.microsoft.com/office/drawing/2014/main" id="{BF8F3323-0BB7-4343-ADCE-48478FFC9C4E}"/>
+                <a16:creationId xmlns:a16="http://schemas.microsoft.com/office/drawing/2014/main" id="{E4F1CD7D-6D23-4A95-9660-D9C4091FC522}"/>
               </a:ext>
             </a:extLst>
           </p:cNvPr>
@@ -11476,7 +11476,7 @@
           <p:cNvPr id="21" name="">
             <a:extLst xmlns:a="http://schemas.openxmlformats.org/drawingml/2006/main">
               <a:ext uri="{FF2B5EF4-FFF2-40B4-BE49-F238E27FC236}">
-                <a16:creationId xmlns:a16="http://schemas.microsoft.com/office/drawing/2014/main" id="{04F25944-3D90-4AEA-B881-635F87FAF607}"/>
+                <a16:creationId xmlns:a16="http://schemas.microsoft.com/office/drawing/2014/main" id="{AEB49629-8396-4AB0-B41A-64DE8540BC6E}"/>
               </a:ext>
             </a:extLst>
           </p:cNvPr>
@@ -11534,7 +11534,7 @@
           <p:cNvPr id="22" name="">
             <a:extLst xmlns:a="http://schemas.openxmlformats.org/drawingml/2006/main">
               <a:ext uri="{FF2B5EF4-FFF2-40B4-BE49-F238E27FC236}">
-                <a16:creationId xmlns:a16="http://schemas.microsoft.com/office/drawing/2014/main" id="{FA31F7C8-FE23-4418-95B0-F7617CA11E6F}"/>
+                <a16:creationId xmlns:a16="http://schemas.microsoft.com/office/drawing/2014/main" id="{0292F852-E855-4DF3-BF65-FB99BA9E34E0}"/>
               </a:ext>
             </a:extLst>
           </p:cNvPr>
@@ -11569,7 +11569,7 @@
           <p:cNvPr id="23" name="">
             <a:extLst xmlns:a="http://schemas.openxmlformats.org/drawingml/2006/main">
               <a:ext uri="{FF2B5EF4-FFF2-40B4-BE49-F238E27FC236}">
-                <a16:creationId xmlns:a16="http://schemas.microsoft.com/office/drawing/2014/main" id="{C4E18976-0876-40FD-BE8C-7289B8ADEE2C}"/>
+                <a16:creationId xmlns:a16="http://schemas.microsoft.com/office/drawing/2014/main" id="{50AD1F34-D6C4-49B2-8589-F0CA3B4A1179}"/>
               </a:ext>
             </a:extLst>
           </p:cNvPr>
@@ -11627,7 +11627,7 @@
           <p:cNvPr id="24" name="">
             <a:extLst xmlns:a="http://schemas.openxmlformats.org/drawingml/2006/main">
               <a:ext uri="{FF2B5EF4-FFF2-40B4-BE49-F238E27FC236}">
-                <a16:creationId xmlns:a16="http://schemas.microsoft.com/office/drawing/2014/main" id="{D081C471-0CC4-4F76-85C1-8B3830DF7015}"/>
+                <a16:creationId xmlns:a16="http://schemas.microsoft.com/office/drawing/2014/main" id="{2C43181B-6B00-4079-B74D-8D2C0F37EB5E}"/>
               </a:ext>
             </a:extLst>
           </p:cNvPr>
@@ -11685,7 +11685,7 @@
           <p:cNvPr id="25" name="">
             <a:extLst xmlns:a="http://schemas.openxmlformats.org/drawingml/2006/main">
               <a:ext uri="{FF2B5EF4-FFF2-40B4-BE49-F238E27FC236}">
-                <a16:creationId xmlns:a16="http://schemas.microsoft.com/office/drawing/2014/main" id="{0662AE24-9C5D-4A5C-87A0-273CA486CA3E}"/>
+                <a16:creationId xmlns:a16="http://schemas.microsoft.com/office/drawing/2014/main" id="{963A8B64-FABA-4A25-8ABC-A742F977A9EE}"/>
               </a:ext>
             </a:extLst>
           </p:cNvPr>
@@ -11743,7 +11743,7 @@
           <p:cNvPr id="26" name="">
             <a:extLst xmlns:a="http://schemas.openxmlformats.org/drawingml/2006/main">
               <a:ext uri="{FF2B5EF4-FFF2-40B4-BE49-F238E27FC236}">
-                <a16:creationId xmlns:a16="http://schemas.microsoft.com/office/drawing/2014/main" id="{21404B4B-F60E-4ED5-A75F-B8D08E58437D}"/>
+                <a16:creationId xmlns:a16="http://schemas.microsoft.com/office/drawing/2014/main" id="{D78E9755-3E04-4642-BA8A-F33871C13EA0}"/>
               </a:ext>
             </a:extLst>
           </p:cNvPr>
@@ -11801,7 +11801,7 @@
           <p:cNvPr id="27" name="">
             <a:extLst xmlns:a="http://schemas.openxmlformats.org/drawingml/2006/main">
               <a:ext uri="{FF2B5EF4-FFF2-40B4-BE49-F238E27FC236}">
-                <a16:creationId xmlns:a16="http://schemas.microsoft.com/office/drawing/2014/main" id="{38BA8AED-BD43-4707-B923-03201FF2EB53}"/>
+                <a16:creationId xmlns:a16="http://schemas.microsoft.com/office/drawing/2014/main" id="{6EE43D43-2823-4FF0-A066-C02EE81CC971}"/>
               </a:ext>
             </a:extLst>
           </p:cNvPr>
@@ -11857,7 +11857,7 @@
     </p:spTree>
     <p:extLst>
       <p:ext uri="{BB962C8B-B14F-4D97-AF65-F5344CB8AC3E}">
-        <p14:creationId xmlns:p14="http://schemas.microsoft.com/office/powerpoint/2010/main" val="472288746"/>
+        <p14:creationId xmlns:p14="http://schemas.microsoft.com/office/powerpoint/2010/main" val="821564048"/>
       </p:ext>
     </p:extLst>
   </p:cSld>
@@ -11888,7 +11888,7 @@
           <p:cNvPr id="27" name="">
             <a:extLst xmlns:a="http://schemas.openxmlformats.org/drawingml/2006/main">
               <a:ext uri="{FF2B5EF4-FFF2-40B4-BE49-F238E27FC236}">
-                <a16:creationId xmlns:a16="http://schemas.microsoft.com/office/drawing/2014/main" id="{63EE1C6D-85D7-41D1-8A17-2A7B5ED75FE4}"/>
+                <a16:creationId xmlns:a16="http://schemas.microsoft.com/office/drawing/2014/main" id="{E82DAA6B-5B25-4926-AE02-E4B5CADA74CB}"/>
               </a:ext>
             </a:extLst>
           </p:cNvPr>
@@ -11946,7 +11946,7 @@
           <p:cNvPr id="2" name="">
             <a:extLst xmlns:a="http://schemas.openxmlformats.org/drawingml/2006/main">
               <a:ext uri="{FF2B5EF4-FFF2-40B4-BE49-F238E27FC236}">
-                <a16:creationId xmlns:a16="http://schemas.microsoft.com/office/drawing/2014/main" id="{052F09CE-9277-4479-9341-E45C28C6B213}"/>
+                <a16:creationId xmlns:a16="http://schemas.microsoft.com/office/drawing/2014/main" id="{CA7BEBD5-708B-44C3-879C-22B7E4C44A3C}"/>
               </a:ext>
             </a:extLst>
           </p:cNvPr>
@@ -12004,7 +12004,7 @@
           <p:cNvPr id="3" name="">
             <a:extLst xmlns:a="http://schemas.openxmlformats.org/drawingml/2006/main">
               <a:ext uri="{FF2B5EF4-FFF2-40B4-BE49-F238E27FC236}">
-                <a16:creationId xmlns:a16="http://schemas.microsoft.com/office/drawing/2014/main" id="{3CC55FAB-D16A-4F0A-9F34-FC66098964A9}"/>
+                <a16:creationId xmlns:a16="http://schemas.microsoft.com/office/drawing/2014/main" id="{34E947FF-1D2B-4553-A04C-34EC45F073B3}"/>
               </a:ext>
             </a:extLst>
           </p:cNvPr>
@@ -12037,7 +12037,7 @@
           <p:cNvPr id="4" name="">
             <a:extLst xmlns:a="http://schemas.openxmlformats.org/drawingml/2006/main">
               <a:ext uri="{FF2B5EF4-FFF2-40B4-BE49-F238E27FC236}">
-                <a16:creationId xmlns:a16="http://schemas.microsoft.com/office/drawing/2014/main" id="{7998E5F1-31A8-4394-BEDE-1FC58445CCF6}"/>
+                <a16:creationId xmlns:a16="http://schemas.microsoft.com/office/drawing/2014/main" id="{66941578-3722-4E84-A0E7-BE17E45C797C}"/>
               </a:ext>
             </a:extLst>
           </p:cNvPr>
@@ -12095,7 +12095,7 @@
           <p:cNvPr id="5" name="">
             <a:extLst xmlns:a="http://schemas.openxmlformats.org/drawingml/2006/main">
               <a:ext uri="{FF2B5EF4-FFF2-40B4-BE49-F238E27FC236}">
-                <a16:creationId xmlns:a16="http://schemas.microsoft.com/office/drawing/2014/main" id="{C50C3452-556B-41AF-8E44-54197D939E08}"/>
+                <a16:creationId xmlns:a16="http://schemas.microsoft.com/office/drawing/2014/main" id="{ADD224E6-9CAA-46B6-9406-BDAC64C360BC}"/>
               </a:ext>
             </a:extLst>
           </p:cNvPr>
@@ -12153,7 +12153,7 @@
           <p:cNvPr id="6" name="">
             <a:extLst xmlns:a="http://schemas.openxmlformats.org/drawingml/2006/main">
               <a:ext uri="{FF2B5EF4-FFF2-40B4-BE49-F238E27FC236}">
-                <a16:creationId xmlns:a16="http://schemas.microsoft.com/office/drawing/2014/main" id="{12064D8E-6EFF-41C9-9D54-59269D20697A}"/>
+                <a16:creationId xmlns:a16="http://schemas.microsoft.com/office/drawing/2014/main" id="{F6479973-E168-42E4-9B47-9CA7A66A59DF}"/>
               </a:ext>
             </a:extLst>
           </p:cNvPr>
@@ -12188,7 +12188,7 @@
           <p:cNvPr id="7" name="">
             <a:extLst xmlns:a="http://schemas.openxmlformats.org/drawingml/2006/main">
               <a:ext uri="{FF2B5EF4-FFF2-40B4-BE49-F238E27FC236}">
-                <a16:creationId xmlns:a16="http://schemas.microsoft.com/office/drawing/2014/main" id="{F37CC875-203E-4DB7-8ABD-DC52F39E95B3}"/>
+                <a16:creationId xmlns:a16="http://schemas.microsoft.com/office/drawing/2014/main" id="{A11E6567-EC5E-4F4E-A1FC-FA24065600D1}"/>
               </a:ext>
             </a:extLst>
           </p:cNvPr>
@@ -12246,7 +12246,7 @@
           <p:cNvPr id="8" name="">
             <a:extLst xmlns:a="http://schemas.openxmlformats.org/drawingml/2006/main">
               <a:ext uri="{FF2B5EF4-FFF2-40B4-BE49-F238E27FC236}">
-                <a16:creationId xmlns:a16="http://schemas.microsoft.com/office/drawing/2014/main" id="{4AE573E6-F4E5-45ED-B932-C00896A91099}"/>
+                <a16:creationId xmlns:a16="http://schemas.microsoft.com/office/drawing/2014/main" id="{B0479564-1C4E-42B7-9BEE-7F9A267069CE}"/>
               </a:ext>
             </a:extLst>
           </p:cNvPr>
@@ -12277,7 +12277,7 @@
           <p:cNvPr id="9" name="">
             <a:extLst xmlns:a="http://schemas.openxmlformats.org/drawingml/2006/main">
               <a:ext uri="{FF2B5EF4-FFF2-40B4-BE49-F238E27FC236}">
-                <a16:creationId xmlns:a16="http://schemas.microsoft.com/office/drawing/2014/main" id="{FC3D9141-1732-435D-BA49-0CB7EC1AE498}"/>
+                <a16:creationId xmlns:a16="http://schemas.microsoft.com/office/drawing/2014/main" id="{F9859E06-9F57-4B7A-90AE-D1191E7515D9}"/>
               </a:ext>
             </a:extLst>
           </p:cNvPr>
@@ -12335,7 +12335,7 @@
           <p:cNvPr id="10" name="">
             <a:extLst xmlns:a="http://schemas.openxmlformats.org/drawingml/2006/main">
               <a:ext uri="{FF2B5EF4-FFF2-40B4-BE49-F238E27FC236}">
-                <a16:creationId xmlns:a16="http://schemas.microsoft.com/office/drawing/2014/main" id="{91AA63A9-452F-4460-9C5B-EC07E03019A0}"/>
+                <a16:creationId xmlns:a16="http://schemas.microsoft.com/office/drawing/2014/main" id="{B501CE8A-A1D6-4C3D-A7FD-210EF2AD4CD1}"/>
               </a:ext>
             </a:extLst>
           </p:cNvPr>
@@ -12393,7 +12393,7 @@
           <p:cNvPr id="11" name="">
             <a:extLst xmlns:a="http://schemas.openxmlformats.org/drawingml/2006/main">
               <a:ext uri="{FF2B5EF4-FFF2-40B4-BE49-F238E27FC236}">
-                <a16:creationId xmlns:a16="http://schemas.microsoft.com/office/drawing/2014/main" id="{EDF998DA-656D-470B-A2D1-8E9CAD3F8AE0}"/>
+                <a16:creationId xmlns:a16="http://schemas.microsoft.com/office/drawing/2014/main" id="{ECA32358-59F3-456C-B170-98C7CEB919B0}"/>
               </a:ext>
             </a:extLst>
           </p:cNvPr>
@@ -12428,7 +12428,7 @@
           <p:cNvPr id="12" name="">
             <a:extLst xmlns:a="http://schemas.openxmlformats.org/drawingml/2006/main">
               <a:ext uri="{FF2B5EF4-FFF2-40B4-BE49-F238E27FC236}">
-                <a16:creationId xmlns:a16="http://schemas.microsoft.com/office/drawing/2014/main" id="{F4642A1E-031E-4EEF-9C9B-B819C96E2F50}"/>
+                <a16:creationId xmlns:a16="http://schemas.microsoft.com/office/drawing/2014/main" id="{85D21143-053E-43FC-B872-A4B930A1D1F4}"/>
               </a:ext>
             </a:extLst>
           </p:cNvPr>
@@ -12486,7 +12486,7 @@
           <p:cNvPr id="13" name="">
             <a:extLst xmlns:a="http://schemas.openxmlformats.org/drawingml/2006/main">
               <a:ext uri="{FF2B5EF4-FFF2-40B4-BE49-F238E27FC236}">
-                <a16:creationId xmlns:a16="http://schemas.microsoft.com/office/drawing/2014/main" id="{88E73252-3678-4317-9311-6F0CA60E1AAA}"/>
+                <a16:creationId xmlns:a16="http://schemas.microsoft.com/office/drawing/2014/main" id="{604754E9-824F-442F-A6FE-2DACD568AFBD}"/>
               </a:ext>
             </a:extLst>
           </p:cNvPr>
@@ -12517,7 +12517,7 @@
           <p:cNvPr id="14" name="">
             <a:extLst xmlns:a="http://schemas.openxmlformats.org/drawingml/2006/main">
               <a:ext uri="{FF2B5EF4-FFF2-40B4-BE49-F238E27FC236}">
-                <a16:creationId xmlns:a16="http://schemas.microsoft.com/office/drawing/2014/main" id="{7F95EE5D-34D9-4444-980F-B679E296714B}"/>
+                <a16:creationId xmlns:a16="http://schemas.microsoft.com/office/drawing/2014/main" id="{6A92B000-4252-4718-9698-CA1881F10745}"/>
               </a:ext>
             </a:extLst>
           </p:cNvPr>
@@ -12575,7 +12575,7 @@
           <p:cNvPr id="15" name="">
             <a:extLst xmlns:a="http://schemas.openxmlformats.org/drawingml/2006/main">
               <a:ext uri="{FF2B5EF4-FFF2-40B4-BE49-F238E27FC236}">
-                <a16:creationId xmlns:a16="http://schemas.microsoft.com/office/drawing/2014/main" id="{F4772A7D-6E19-497F-B847-8D9BD1DB0230}"/>
+                <a16:creationId xmlns:a16="http://schemas.microsoft.com/office/drawing/2014/main" id="{D764C2A8-EE93-4EC3-9BD5-DAA5AE4A62E7}"/>
               </a:ext>
             </a:extLst>
           </p:cNvPr>
@@ -12633,7 +12633,7 @@
           <p:cNvPr id="16" name="">
             <a:extLst xmlns:a="http://schemas.openxmlformats.org/drawingml/2006/main">
               <a:ext uri="{FF2B5EF4-FFF2-40B4-BE49-F238E27FC236}">
-                <a16:creationId xmlns:a16="http://schemas.microsoft.com/office/drawing/2014/main" id="{13C0D0A9-CF78-485C-BD0E-E5DB0DA91418}"/>
+                <a16:creationId xmlns:a16="http://schemas.microsoft.com/office/drawing/2014/main" id="{990CE891-6035-4A01-A27C-DA75FD559671}"/>
               </a:ext>
             </a:extLst>
           </p:cNvPr>
@@ -12668,7 +12668,7 @@
           <p:cNvPr id="17" name="">
             <a:extLst xmlns:a="http://schemas.openxmlformats.org/drawingml/2006/main">
               <a:ext uri="{FF2B5EF4-FFF2-40B4-BE49-F238E27FC236}">
-                <a16:creationId xmlns:a16="http://schemas.microsoft.com/office/drawing/2014/main" id="{450A6AA0-6770-4653-A91C-E5040108D03B}"/>
+                <a16:creationId xmlns:a16="http://schemas.microsoft.com/office/drawing/2014/main" id="{D30CB912-06E2-4E8C-ADB1-1A55E295CE0D}"/>
               </a:ext>
             </a:extLst>
           </p:cNvPr>
@@ -12726,7 +12726,7 @@
           <p:cNvPr id="18" name="">
             <a:extLst xmlns:a="http://schemas.openxmlformats.org/drawingml/2006/main">
               <a:ext uri="{FF2B5EF4-FFF2-40B4-BE49-F238E27FC236}">
-                <a16:creationId xmlns:a16="http://schemas.microsoft.com/office/drawing/2014/main" id="{3D5B32E8-7A93-4E69-979B-4E6E869CD6EA}"/>
+                <a16:creationId xmlns:a16="http://schemas.microsoft.com/office/drawing/2014/main" id="{824C8C58-9FAF-4A7B-A0D8-29D40433DB88}"/>
               </a:ext>
             </a:extLst>
           </p:cNvPr>
@@ -12757,7 +12757,7 @@
           <p:cNvPr id="19" name="">
             <a:extLst xmlns:a="http://schemas.openxmlformats.org/drawingml/2006/main">
               <a:ext uri="{FF2B5EF4-FFF2-40B4-BE49-F238E27FC236}">
-                <a16:creationId xmlns:a16="http://schemas.microsoft.com/office/drawing/2014/main" id="{3F37109D-2330-4F7B-9980-AB3361220B70}"/>
+                <a16:creationId xmlns:a16="http://schemas.microsoft.com/office/drawing/2014/main" id="{D90202CB-B77E-40EB-AC2F-06128CCFB1B8}"/>
               </a:ext>
             </a:extLst>
           </p:cNvPr>
@@ -12815,7 +12815,7 @@
           <p:cNvPr id="20" name="">
             <a:extLst xmlns:a="http://schemas.openxmlformats.org/drawingml/2006/main">
               <a:ext uri="{FF2B5EF4-FFF2-40B4-BE49-F238E27FC236}">
-                <a16:creationId xmlns:a16="http://schemas.microsoft.com/office/drawing/2014/main" id="{7E45BB5E-727E-4FAD-9DAF-75FD1C824AAB}"/>
+                <a16:creationId xmlns:a16="http://schemas.microsoft.com/office/drawing/2014/main" id="{D9FDE6FE-A084-4792-8EC0-30BE25CD17A5}"/>
               </a:ext>
             </a:extLst>
           </p:cNvPr>
@@ -12873,7 +12873,7 @@
           <p:cNvPr id="21" name="">
             <a:extLst xmlns:a="http://schemas.openxmlformats.org/drawingml/2006/main">
               <a:ext uri="{FF2B5EF4-FFF2-40B4-BE49-F238E27FC236}">
-                <a16:creationId xmlns:a16="http://schemas.microsoft.com/office/drawing/2014/main" id="{5D2A85B0-7EEB-4083-A61A-ED22E82FB92B}"/>
+                <a16:creationId xmlns:a16="http://schemas.microsoft.com/office/drawing/2014/main" id="{FA2A17A2-9BBD-4D7A-8C83-915943096A6C}"/>
               </a:ext>
             </a:extLst>
           </p:cNvPr>
@@ -12908,7 +12908,7 @@
           <p:cNvPr id="22" name="">
             <a:extLst xmlns:a="http://schemas.openxmlformats.org/drawingml/2006/main">
               <a:ext uri="{FF2B5EF4-FFF2-40B4-BE49-F238E27FC236}">
-                <a16:creationId xmlns:a16="http://schemas.microsoft.com/office/drawing/2014/main" id="{5E82B86F-725D-4461-A19C-332EA290B7D7}"/>
+                <a16:creationId xmlns:a16="http://schemas.microsoft.com/office/drawing/2014/main" id="{3979852F-73D2-406C-9EB9-5D732D95BDCE}"/>
               </a:ext>
             </a:extLst>
           </p:cNvPr>
@@ -12966,7 +12966,7 @@
           <p:cNvPr id="23" name="">
             <a:extLst xmlns:a="http://schemas.openxmlformats.org/drawingml/2006/main">
               <a:ext uri="{FF2B5EF4-FFF2-40B4-BE49-F238E27FC236}">
-                <a16:creationId xmlns:a16="http://schemas.microsoft.com/office/drawing/2014/main" id="{878FB2B0-9F7B-4495-95E4-DA2C6B8E13F6}"/>
+                <a16:creationId xmlns:a16="http://schemas.microsoft.com/office/drawing/2014/main" id="{CFB7EE71-7810-482C-8302-E6E40A493D40}"/>
               </a:ext>
             </a:extLst>
           </p:cNvPr>
@@ -12997,7 +12997,7 @@
           <p:cNvPr id="24" name="">
             <a:extLst xmlns:a="http://schemas.openxmlformats.org/drawingml/2006/main">
               <a:ext uri="{FF2B5EF4-FFF2-40B4-BE49-F238E27FC236}">
-                <a16:creationId xmlns:a16="http://schemas.microsoft.com/office/drawing/2014/main" id="{75BA9053-6031-49C7-BCD4-3CB9BDBEC839}"/>
+                <a16:creationId xmlns:a16="http://schemas.microsoft.com/office/drawing/2014/main" id="{993DDD04-58F0-4BE4-8465-D4D81016AE7D}"/>
               </a:ext>
             </a:extLst>
           </p:cNvPr>
@@ -13055,7 +13055,7 @@
           <p:cNvPr id="25" name="">
             <a:extLst xmlns:a="http://schemas.openxmlformats.org/drawingml/2006/main">
               <a:ext uri="{FF2B5EF4-FFF2-40B4-BE49-F238E27FC236}">
-                <a16:creationId xmlns:a16="http://schemas.microsoft.com/office/drawing/2014/main" id="{F47EBE48-78B8-4796-A96B-67064AEC4EB7}"/>
+                <a16:creationId xmlns:a16="http://schemas.microsoft.com/office/drawing/2014/main" id="{62395A94-21EB-4718-AC93-8F4F9F270299}"/>
               </a:ext>
             </a:extLst>
           </p:cNvPr>
@@ -13113,7 +13113,7 @@
           <p:cNvPr id="26" name="">
             <a:extLst xmlns:a="http://schemas.openxmlformats.org/drawingml/2006/main">
               <a:ext uri="{FF2B5EF4-FFF2-40B4-BE49-F238E27FC236}">
-                <a16:creationId xmlns:a16="http://schemas.microsoft.com/office/drawing/2014/main" id="{72334E68-09BB-4D00-B338-5990E246432B}"/>
+                <a16:creationId xmlns:a16="http://schemas.microsoft.com/office/drawing/2014/main" id="{14114C34-2504-45C9-AD6A-3C91D8F39496}"/>
               </a:ext>
             </a:extLst>
           </p:cNvPr>
@@ -13169,7 +13169,7 @@
     </p:spTree>
     <p:extLst>
       <p:ext uri="{BB962C8B-B14F-4D97-AF65-F5344CB8AC3E}">
-        <p14:creationId xmlns:p14="http://schemas.microsoft.com/office/powerpoint/2010/main" val="1680042441"/>
+        <p14:creationId xmlns:p14="http://schemas.microsoft.com/office/powerpoint/2010/main" val="462009437"/>
       </p:ext>
     </p:extLst>
   </p:cSld>
@@ -13200,7 +13200,7 @@
           <p:cNvPr id="22" name="">
             <a:extLst xmlns:a="http://schemas.openxmlformats.org/drawingml/2006/main">
               <a:ext uri="{FF2B5EF4-FFF2-40B4-BE49-F238E27FC236}">
-                <a16:creationId xmlns:a16="http://schemas.microsoft.com/office/drawing/2014/main" id="{A1210975-4D5F-496C-97D0-C6BD4530CB87}"/>
+                <a16:creationId xmlns:a16="http://schemas.microsoft.com/office/drawing/2014/main" id="{1527A2DF-CEB8-40F8-919C-B0A19726E7DB}"/>
               </a:ext>
             </a:extLst>
           </p:cNvPr>
@@ -13258,7 +13258,7 @@
           <p:cNvPr id="2" name="">
             <a:extLst xmlns:a="http://schemas.openxmlformats.org/drawingml/2006/main">
               <a:ext uri="{FF2B5EF4-FFF2-40B4-BE49-F238E27FC236}">
-                <a16:creationId xmlns:a16="http://schemas.microsoft.com/office/drawing/2014/main" id="{1F355F9C-6A45-4882-B9C7-417C39AE6A58}"/>
+                <a16:creationId xmlns:a16="http://schemas.microsoft.com/office/drawing/2014/main" id="{6BD06311-7B87-4667-8F1D-684276048951}"/>
               </a:ext>
             </a:extLst>
           </p:cNvPr>
@@ -13316,7 +13316,7 @@
           <p:cNvPr id="3" name="">
             <a:extLst xmlns:a="http://schemas.openxmlformats.org/drawingml/2006/main">
               <a:ext uri="{FF2B5EF4-FFF2-40B4-BE49-F238E27FC236}">
-                <a16:creationId xmlns:a16="http://schemas.microsoft.com/office/drawing/2014/main" id="{E07CAFDC-8B9E-4754-96F2-9879007374ED}"/>
+                <a16:creationId xmlns:a16="http://schemas.microsoft.com/office/drawing/2014/main" id="{BC4A05F9-CD8F-4657-898B-F29726DB3BF7}"/>
               </a:ext>
             </a:extLst>
           </p:cNvPr>
@@ -13349,7 +13349,7 @@
           <p:cNvPr id="4" name="">
             <a:extLst xmlns:a="http://schemas.openxmlformats.org/drawingml/2006/main">
               <a:ext uri="{FF2B5EF4-FFF2-40B4-BE49-F238E27FC236}">
-                <a16:creationId xmlns:a16="http://schemas.microsoft.com/office/drawing/2014/main" id="{D914EAD5-6002-4F30-BFBF-6FACBE470733}"/>
+                <a16:creationId xmlns:a16="http://schemas.microsoft.com/office/drawing/2014/main" id="{60778AF7-7769-4F6A-B035-56F2EDF68764}"/>
               </a:ext>
             </a:extLst>
           </p:cNvPr>
@@ -13407,7 +13407,7 @@
           <p:cNvPr id="5" name="">
             <a:extLst xmlns:a="http://schemas.openxmlformats.org/drawingml/2006/main">
               <a:ext uri="{FF2B5EF4-FFF2-40B4-BE49-F238E27FC236}">
-                <a16:creationId xmlns:a16="http://schemas.microsoft.com/office/drawing/2014/main" id="{4F073C3E-86A7-46DF-91D6-FE7D262EF142}"/>
+                <a16:creationId xmlns:a16="http://schemas.microsoft.com/office/drawing/2014/main" id="{E77DAFEC-98E0-40B9-A1AC-23F473727730}"/>
               </a:ext>
             </a:extLst>
           </p:cNvPr>
@@ -13465,7 +13465,7 @@
           <p:cNvPr id="6" name="">
             <a:extLst xmlns:a="http://schemas.openxmlformats.org/drawingml/2006/main">
               <a:ext uri="{FF2B5EF4-FFF2-40B4-BE49-F238E27FC236}">
-                <a16:creationId xmlns:a16="http://schemas.microsoft.com/office/drawing/2014/main" id="{97FE4158-1BCB-4942-90B5-D92A7B6A909D}"/>
+                <a16:creationId xmlns:a16="http://schemas.microsoft.com/office/drawing/2014/main" id="{12C029C6-F095-4501-A436-BABA1D360A08}"/>
               </a:ext>
             </a:extLst>
           </p:cNvPr>
@@ -13500,7 +13500,7 @@
           <p:cNvPr id="7" name="">
             <a:extLst xmlns:a="http://schemas.openxmlformats.org/drawingml/2006/main">
               <a:ext uri="{FF2B5EF4-FFF2-40B4-BE49-F238E27FC236}">
-                <a16:creationId xmlns:a16="http://schemas.microsoft.com/office/drawing/2014/main" id="{07446184-650E-44D2-AC6F-A23DC8A6571E}"/>
+                <a16:creationId xmlns:a16="http://schemas.microsoft.com/office/drawing/2014/main" id="{844CD6E1-DFC8-4991-A2A7-2930B068D6D9}"/>
               </a:ext>
             </a:extLst>
           </p:cNvPr>
@@ -13533,7 +13533,7 @@
           <p:cNvPr id="8" name="">
             <a:extLst xmlns:a="http://schemas.openxmlformats.org/drawingml/2006/main">
               <a:ext uri="{FF2B5EF4-FFF2-40B4-BE49-F238E27FC236}">
-                <a16:creationId xmlns:a16="http://schemas.microsoft.com/office/drawing/2014/main" id="{C1AEA51E-2BEC-415A-879E-33B2FD8E309E}"/>
+                <a16:creationId xmlns:a16="http://schemas.microsoft.com/office/drawing/2014/main" id="{4BB669BB-CFBB-4AD9-9D80-F91C3D192C80}"/>
               </a:ext>
             </a:extLst>
           </p:cNvPr>
@@ -13591,7 +13591,7 @@
           <p:cNvPr id="9" name="">
             <a:extLst xmlns:a="http://schemas.openxmlformats.org/drawingml/2006/main">
               <a:ext uri="{FF2B5EF4-FFF2-40B4-BE49-F238E27FC236}">
-                <a16:creationId xmlns:a16="http://schemas.microsoft.com/office/drawing/2014/main" id="{14478468-FEDB-4B14-80EB-FB7F73FC76DF}"/>
+                <a16:creationId xmlns:a16="http://schemas.microsoft.com/office/drawing/2014/main" id="{80D3C77F-B31C-4B2F-8AAF-2299239A58F5}"/>
               </a:ext>
             </a:extLst>
           </p:cNvPr>
@@ -13649,7 +13649,7 @@
           <p:cNvPr id="10" name="">
             <a:extLst xmlns:a="http://schemas.openxmlformats.org/drawingml/2006/main">
               <a:ext uri="{FF2B5EF4-FFF2-40B4-BE49-F238E27FC236}">
-                <a16:creationId xmlns:a16="http://schemas.microsoft.com/office/drawing/2014/main" id="{BA5D1167-8F01-4E91-BFF0-69E7407A7F7E}"/>
+                <a16:creationId xmlns:a16="http://schemas.microsoft.com/office/drawing/2014/main" id="{AF0D1163-6644-4EF5-AFE1-D7854B869A1C}"/>
               </a:ext>
             </a:extLst>
           </p:cNvPr>
@@ -13684,7 +13684,7 @@
           <p:cNvPr id="11" name="">
             <a:extLst xmlns:a="http://schemas.openxmlformats.org/drawingml/2006/main">
               <a:ext uri="{FF2B5EF4-FFF2-40B4-BE49-F238E27FC236}">
-                <a16:creationId xmlns:a16="http://schemas.microsoft.com/office/drawing/2014/main" id="{C160F9E0-0E8B-45D7-BE51-7788BD852726}"/>
+                <a16:creationId xmlns:a16="http://schemas.microsoft.com/office/drawing/2014/main" id="{43A56457-C64E-42D0-BA52-D811A1F88734}"/>
               </a:ext>
             </a:extLst>
           </p:cNvPr>
@@ -13717,7 +13717,7 @@
           <p:cNvPr id="12" name="">
             <a:extLst xmlns:a="http://schemas.openxmlformats.org/drawingml/2006/main">
               <a:ext uri="{FF2B5EF4-FFF2-40B4-BE49-F238E27FC236}">
-                <a16:creationId xmlns:a16="http://schemas.microsoft.com/office/drawing/2014/main" id="{089C1D0C-8DAD-4DAF-8249-68F48DCBFD9D}"/>
+                <a16:creationId xmlns:a16="http://schemas.microsoft.com/office/drawing/2014/main" id="{52F68599-12FA-40DF-923A-5570C8D40518}"/>
               </a:ext>
             </a:extLst>
           </p:cNvPr>
@@ -13775,7 +13775,7 @@
           <p:cNvPr id="13" name="">
             <a:extLst xmlns:a="http://schemas.openxmlformats.org/drawingml/2006/main">
               <a:ext uri="{FF2B5EF4-FFF2-40B4-BE49-F238E27FC236}">
-                <a16:creationId xmlns:a16="http://schemas.microsoft.com/office/drawing/2014/main" id="{E88C2EC9-4F14-46BF-9F64-BA80B46BCD7A}"/>
+                <a16:creationId xmlns:a16="http://schemas.microsoft.com/office/drawing/2014/main" id="{CDB603BC-79F0-4803-82C6-7E6D3E49D8F0}"/>
               </a:ext>
             </a:extLst>
           </p:cNvPr>
@@ -13833,7 +13833,7 @@
           <p:cNvPr id="14" name="">
             <a:extLst xmlns:a="http://schemas.openxmlformats.org/drawingml/2006/main">
               <a:ext uri="{FF2B5EF4-FFF2-40B4-BE49-F238E27FC236}">
-                <a16:creationId xmlns:a16="http://schemas.microsoft.com/office/drawing/2014/main" id="{B729CBC3-9AF4-4944-A037-2F6C3AB43AB2}"/>
+                <a16:creationId xmlns:a16="http://schemas.microsoft.com/office/drawing/2014/main" id="{EB21E3B7-CA09-4C9C-82FB-FBFA3D18AD66}"/>
               </a:ext>
             </a:extLst>
           </p:cNvPr>
@@ -13868,7 +13868,7 @@
           <p:cNvPr id="15" name="">
             <a:extLst xmlns:a="http://schemas.openxmlformats.org/drawingml/2006/main">
               <a:ext uri="{FF2B5EF4-FFF2-40B4-BE49-F238E27FC236}">
-                <a16:creationId xmlns:a16="http://schemas.microsoft.com/office/drawing/2014/main" id="{95D553E2-A9E0-4C29-9CCF-B74610164E47}"/>
+                <a16:creationId xmlns:a16="http://schemas.microsoft.com/office/drawing/2014/main" id="{730AE1AA-DF38-4152-9699-ABD25AC7E559}"/>
               </a:ext>
             </a:extLst>
           </p:cNvPr>
@@ -13901,7 +13901,7 @@
           <p:cNvPr id="16" name="">
             <a:extLst xmlns:a="http://schemas.openxmlformats.org/drawingml/2006/main">
               <a:ext uri="{FF2B5EF4-FFF2-40B4-BE49-F238E27FC236}">
-                <a16:creationId xmlns:a16="http://schemas.microsoft.com/office/drawing/2014/main" id="{0D2F3DFC-92C9-4D5F-B659-410CB0DF83C5}"/>
+                <a16:creationId xmlns:a16="http://schemas.microsoft.com/office/drawing/2014/main" id="{57710E7D-64AB-41B3-B8D9-6901670833DB}"/>
               </a:ext>
             </a:extLst>
           </p:cNvPr>
@@ -13959,7 +13959,7 @@
           <p:cNvPr id="17" name="">
             <a:extLst xmlns:a="http://schemas.openxmlformats.org/drawingml/2006/main">
               <a:ext uri="{FF2B5EF4-FFF2-40B4-BE49-F238E27FC236}">
-                <a16:creationId xmlns:a16="http://schemas.microsoft.com/office/drawing/2014/main" id="{BE8B91CA-9562-498C-B1BB-D258A119DF76}"/>
+                <a16:creationId xmlns:a16="http://schemas.microsoft.com/office/drawing/2014/main" id="{A1C04FFC-C16E-4A6B-9E41-3C424ABD9C40}"/>
               </a:ext>
             </a:extLst>
           </p:cNvPr>
@@ -14017,7 +14017,7 @@
           <p:cNvPr id="18" name="">
             <a:extLst xmlns:a="http://schemas.openxmlformats.org/drawingml/2006/main">
               <a:ext uri="{FF2B5EF4-FFF2-40B4-BE49-F238E27FC236}">
-                <a16:creationId xmlns:a16="http://schemas.microsoft.com/office/drawing/2014/main" id="{FC16ACFD-8F70-4A93-85DF-407CA5EF0AC9}"/>
+                <a16:creationId xmlns:a16="http://schemas.microsoft.com/office/drawing/2014/main" id="{65A6BCB9-88F4-4BB7-A514-6B85B67C0BBC}"/>
               </a:ext>
             </a:extLst>
           </p:cNvPr>
@@ -14052,7 +14052,7 @@
           <p:cNvPr id="19" name="">
             <a:extLst xmlns:a="http://schemas.openxmlformats.org/drawingml/2006/main">
               <a:ext uri="{FF2B5EF4-FFF2-40B4-BE49-F238E27FC236}">
-                <a16:creationId xmlns:a16="http://schemas.microsoft.com/office/drawing/2014/main" id="{FBC0AEF6-FFB9-4310-BBD7-EC27D2F8CABB}"/>
+                <a16:creationId xmlns:a16="http://schemas.microsoft.com/office/drawing/2014/main" id="{BE84875D-FE89-4A57-8E2C-FCB9D2C899A3}"/>
               </a:ext>
             </a:extLst>
           </p:cNvPr>
@@ -14085,7 +14085,7 @@
           <p:cNvPr id="20" name="">
             <a:extLst xmlns:a="http://schemas.openxmlformats.org/drawingml/2006/main">
               <a:ext uri="{FF2B5EF4-FFF2-40B4-BE49-F238E27FC236}">
-                <a16:creationId xmlns:a16="http://schemas.microsoft.com/office/drawing/2014/main" id="{DAFADF8E-7EC7-4308-9D70-CA3A7AFBE6F2}"/>
+                <a16:creationId xmlns:a16="http://schemas.microsoft.com/office/drawing/2014/main" id="{0327FADE-8671-44C0-BF09-B25B11D50A26}"/>
               </a:ext>
             </a:extLst>
           </p:cNvPr>
@@ -14143,7 +14143,7 @@
           <p:cNvPr id="21" name="">
             <a:extLst xmlns:a="http://schemas.openxmlformats.org/drawingml/2006/main">
               <a:ext uri="{FF2B5EF4-FFF2-40B4-BE49-F238E27FC236}">
-                <a16:creationId xmlns:a16="http://schemas.microsoft.com/office/drawing/2014/main" id="{03B88493-726F-4259-921F-930A10CB9A51}"/>
+                <a16:creationId xmlns:a16="http://schemas.microsoft.com/office/drawing/2014/main" id="{332DDEBC-13B2-4931-A6F7-E511577D288F}"/>
               </a:ext>
             </a:extLst>
           </p:cNvPr>
@@ -14216,7 +14216,7 @@
     </p:spTree>
     <p:extLst>
       <p:ext uri="{BB962C8B-B14F-4D97-AF65-F5344CB8AC3E}">
-        <p14:creationId xmlns:p14="http://schemas.microsoft.com/office/powerpoint/2010/main" val="11751153"/>
+        <p14:creationId xmlns:p14="http://schemas.microsoft.com/office/powerpoint/2010/main" val="1962554046"/>
       </p:ext>
     </p:extLst>
   </p:cSld>
@@ -14247,7 +14247,7 @@
           <p:cNvPr id="19" name="">
             <a:extLst xmlns:a="http://schemas.openxmlformats.org/drawingml/2006/main">
               <a:ext uri="{FF2B5EF4-FFF2-40B4-BE49-F238E27FC236}">
-                <a16:creationId xmlns:a16="http://schemas.microsoft.com/office/drawing/2014/main" id="{0F597EB6-0935-484B-8A76-AD4FE0812D52}"/>
+                <a16:creationId xmlns:a16="http://schemas.microsoft.com/office/drawing/2014/main" id="{858A17BE-56E1-4234-B2FD-60C500EF0810}"/>
               </a:ext>
             </a:extLst>
           </p:cNvPr>
@@ -14305,7 +14305,7 @@
           <p:cNvPr id="2" name="">
             <a:extLst xmlns:a="http://schemas.openxmlformats.org/drawingml/2006/main">
               <a:ext uri="{FF2B5EF4-FFF2-40B4-BE49-F238E27FC236}">
-                <a16:creationId xmlns:a16="http://schemas.microsoft.com/office/drawing/2014/main" id="{51DD31EC-4D2C-4DED-BA9A-ABAB15FB41ED}"/>
+                <a16:creationId xmlns:a16="http://schemas.microsoft.com/office/drawing/2014/main" id="{A8AEC6BA-4166-4B85-8E0B-15A600748427}"/>
               </a:ext>
             </a:extLst>
           </p:cNvPr>
@@ -14363,7 +14363,7 @@
           <p:cNvPr id="3" name="">
             <a:extLst xmlns:a="http://schemas.openxmlformats.org/drawingml/2006/main">
               <a:ext uri="{FF2B5EF4-FFF2-40B4-BE49-F238E27FC236}">
-                <a16:creationId xmlns:a16="http://schemas.microsoft.com/office/drawing/2014/main" id="{BFE9AEB4-AB77-44D5-915F-5998BC36B54C}"/>
+                <a16:creationId xmlns:a16="http://schemas.microsoft.com/office/drawing/2014/main" id="{D347A7A7-79F4-4C43-8583-EE561F412363}"/>
               </a:ext>
             </a:extLst>
           </p:cNvPr>
@@ -14396,7 +14396,7 @@
           <p:cNvPr id="4" name="">
             <a:extLst xmlns:a="http://schemas.openxmlformats.org/drawingml/2006/main">
               <a:ext uri="{FF2B5EF4-FFF2-40B4-BE49-F238E27FC236}">
-                <a16:creationId xmlns:a16="http://schemas.microsoft.com/office/drawing/2014/main" id="{1898BF52-83B4-4E87-9056-3210AB2FE3E6}"/>
+                <a16:creationId xmlns:a16="http://schemas.microsoft.com/office/drawing/2014/main" id="{DB7FFF32-A129-4E7C-B554-BFD83D856BAF}"/>
               </a:ext>
             </a:extLst>
           </p:cNvPr>
@@ -14454,7 +14454,7 @@
           <p:cNvPr id="5" name="">
             <a:extLst xmlns:a="http://schemas.openxmlformats.org/drawingml/2006/main">
               <a:ext uri="{FF2B5EF4-FFF2-40B4-BE49-F238E27FC236}">
-                <a16:creationId xmlns:a16="http://schemas.microsoft.com/office/drawing/2014/main" id="{38C08208-F0B3-466B-BF59-BCE2E00C9990}"/>
+                <a16:creationId xmlns:a16="http://schemas.microsoft.com/office/drawing/2014/main" id="{D9DC5016-2111-45C9-A8DD-9B7BD5E39F84}"/>
               </a:ext>
             </a:extLst>
           </p:cNvPr>
@@ -14512,7 +14512,7 @@
           <p:cNvPr id="6" name="">
             <a:extLst xmlns:a="http://schemas.openxmlformats.org/drawingml/2006/main">
               <a:ext uri="{FF2B5EF4-FFF2-40B4-BE49-F238E27FC236}">
-                <a16:creationId xmlns:a16="http://schemas.microsoft.com/office/drawing/2014/main" id="{9A1D87EF-05A6-43DE-92FE-C258E826766C}"/>
+                <a16:creationId xmlns:a16="http://schemas.microsoft.com/office/drawing/2014/main" id="{1CD26037-43D6-41A7-A43F-90853337AD7B}"/>
               </a:ext>
             </a:extLst>
           </p:cNvPr>
@@ -14547,7 +14547,7 @@
           <p:cNvPr id="7" name="">
             <a:extLst xmlns:a="http://schemas.openxmlformats.org/drawingml/2006/main">
               <a:ext uri="{FF2B5EF4-FFF2-40B4-BE49-F238E27FC236}">
-                <a16:creationId xmlns:a16="http://schemas.microsoft.com/office/drawing/2014/main" id="{DBEEB4DE-512E-48D3-B544-4ECE4A170900}"/>
+                <a16:creationId xmlns:a16="http://schemas.microsoft.com/office/drawing/2014/main" id="{F0E774B3-6D6A-41DD-8AB4-253EAA0C5D0B}"/>
               </a:ext>
             </a:extLst>
           </p:cNvPr>
@@ -14605,7 +14605,7 @@
           <p:cNvPr id="8" name="">
             <a:extLst xmlns:a="http://schemas.openxmlformats.org/drawingml/2006/main">
               <a:ext uri="{FF2B5EF4-FFF2-40B4-BE49-F238E27FC236}">
-                <a16:creationId xmlns:a16="http://schemas.microsoft.com/office/drawing/2014/main" id="{8059123C-FD74-497A-9310-3F7E9FFFF137}"/>
+                <a16:creationId xmlns:a16="http://schemas.microsoft.com/office/drawing/2014/main" id="{C61BAA10-43A3-46FA-AA10-94E9D9480589}"/>
               </a:ext>
             </a:extLst>
           </p:cNvPr>
@@ -14663,7 +14663,7 @@
           <p:cNvPr id="9" name="">
             <a:extLst xmlns:a="http://schemas.openxmlformats.org/drawingml/2006/main">
               <a:ext uri="{FF2B5EF4-FFF2-40B4-BE49-F238E27FC236}">
-                <a16:creationId xmlns:a16="http://schemas.microsoft.com/office/drawing/2014/main" id="{EFD56676-F140-4FDB-94BE-FA91E0D15052}"/>
+                <a16:creationId xmlns:a16="http://schemas.microsoft.com/office/drawing/2014/main" id="{D43EE301-93B5-43D9-9648-9D44DA770574}"/>
               </a:ext>
             </a:extLst>
           </p:cNvPr>
@@ -14698,7 +14698,7 @@
           <p:cNvPr id="10" name="">
             <a:extLst xmlns:a="http://schemas.openxmlformats.org/drawingml/2006/main">
               <a:ext uri="{FF2B5EF4-FFF2-40B4-BE49-F238E27FC236}">
-                <a16:creationId xmlns:a16="http://schemas.microsoft.com/office/drawing/2014/main" id="{7A7AA7F4-04B9-4D4F-A060-C433EC3D233F}"/>
+                <a16:creationId xmlns:a16="http://schemas.microsoft.com/office/drawing/2014/main" id="{FF354491-3FB4-4525-AE87-A22A014F46F3}"/>
               </a:ext>
             </a:extLst>
           </p:cNvPr>
@@ -14756,7 +14756,7 @@
           <p:cNvPr id="11" name="">
             <a:extLst xmlns:a="http://schemas.openxmlformats.org/drawingml/2006/main">
               <a:ext uri="{FF2B5EF4-FFF2-40B4-BE49-F238E27FC236}">
-                <a16:creationId xmlns:a16="http://schemas.microsoft.com/office/drawing/2014/main" id="{B4F6D857-94EF-4CA6-96F2-95F6AEE7B9B3}"/>
+                <a16:creationId xmlns:a16="http://schemas.microsoft.com/office/drawing/2014/main" id="{DBE8E13D-8FAD-47FE-9349-AE280F6FF6B1}"/>
               </a:ext>
             </a:extLst>
           </p:cNvPr>
@@ -14814,7 +14814,7 @@
           <p:cNvPr id="12" name="">
             <a:extLst xmlns:a="http://schemas.openxmlformats.org/drawingml/2006/main">
               <a:ext uri="{FF2B5EF4-FFF2-40B4-BE49-F238E27FC236}">
-                <a16:creationId xmlns:a16="http://schemas.microsoft.com/office/drawing/2014/main" id="{8C92BE74-DA96-4263-8CED-2EDB3217DE6A}"/>
+                <a16:creationId xmlns:a16="http://schemas.microsoft.com/office/drawing/2014/main" id="{89FCC0FC-DF0C-4AD2-970F-9B137346FCA7}"/>
               </a:ext>
             </a:extLst>
           </p:cNvPr>
@@ -14849,7 +14849,7 @@
           <p:cNvPr id="13" name="">
             <a:extLst xmlns:a="http://schemas.openxmlformats.org/drawingml/2006/main">
               <a:ext uri="{FF2B5EF4-FFF2-40B4-BE49-F238E27FC236}">
-                <a16:creationId xmlns:a16="http://schemas.microsoft.com/office/drawing/2014/main" id="{36CB1A66-F6A0-4A36-BA49-9A8CF5154B41}"/>
+                <a16:creationId xmlns:a16="http://schemas.microsoft.com/office/drawing/2014/main" id="{2C310574-2AE1-4FB8-9CFD-AB9DD276FF1D}"/>
               </a:ext>
             </a:extLst>
           </p:cNvPr>
@@ -14907,7 +14907,7 @@
           <p:cNvPr id="14" name="">
             <a:extLst xmlns:a="http://schemas.openxmlformats.org/drawingml/2006/main">
               <a:ext uri="{FF2B5EF4-FFF2-40B4-BE49-F238E27FC236}">
-                <a16:creationId xmlns:a16="http://schemas.microsoft.com/office/drawing/2014/main" id="{DB068352-00D1-4EDB-9F03-A75D45E6AFE8}"/>
+                <a16:creationId xmlns:a16="http://schemas.microsoft.com/office/drawing/2014/main" id="{D03F8625-B38B-455E-9668-3261277316F6}"/>
               </a:ext>
             </a:extLst>
           </p:cNvPr>
@@ -14965,7 +14965,7 @@
           <p:cNvPr id="15" name="">
             <a:extLst xmlns:a="http://schemas.openxmlformats.org/drawingml/2006/main">
               <a:ext uri="{FF2B5EF4-FFF2-40B4-BE49-F238E27FC236}">
-                <a16:creationId xmlns:a16="http://schemas.microsoft.com/office/drawing/2014/main" id="{19085886-803C-41D7-8DE4-5F1AECE00B13}"/>
+                <a16:creationId xmlns:a16="http://schemas.microsoft.com/office/drawing/2014/main" id="{8854DAD9-6F45-4647-BA8A-8FD24B9E2EF2}"/>
               </a:ext>
             </a:extLst>
           </p:cNvPr>
@@ -15000,7 +15000,7 @@
           <p:cNvPr id="16" name="">
             <a:extLst xmlns:a="http://schemas.openxmlformats.org/drawingml/2006/main">
               <a:ext uri="{FF2B5EF4-FFF2-40B4-BE49-F238E27FC236}">
-                <a16:creationId xmlns:a16="http://schemas.microsoft.com/office/drawing/2014/main" id="{6FA2630A-7E2F-42E2-9C88-B0FB16383DE5}"/>
+                <a16:creationId xmlns:a16="http://schemas.microsoft.com/office/drawing/2014/main" id="{8171E8D4-00B9-4BC3-BD9D-B9154E5C9BF2}"/>
               </a:ext>
             </a:extLst>
           </p:cNvPr>
@@ -15058,7 +15058,7 @@
           <p:cNvPr id="17" name="">
             <a:extLst xmlns:a="http://schemas.openxmlformats.org/drawingml/2006/main">
               <a:ext uri="{FF2B5EF4-FFF2-40B4-BE49-F238E27FC236}">
-                <a16:creationId xmlns:a16="http://schemas.microsoft.com/office/drawing/2014/main" id="{D57C48B8-272C-4CED-A5E2-1FF357DA2F05}"/>
+                <a16:creationId xmlns:a16="http://schemas.microsoft.com/office/drawing/2014/main" id="{DE8B5C2E-2DBC-4852-8522-02CF699558E2}"/>
               </a:ext>
             </a:extLst>
           </p:cNvPr>
@@ -15116,7 +15116,7 @@
           <p:cNvPr id="18" name="">
             <a:extLst xmlns:a="http://schemas.openxmlformats.org/drawingml/2006/main">
               <a:ext uri="{FF2B5EF4-FFF2-40B4-BE49-F238E27FC236}">
-                <a16:creationId xmlns:a16="http://schemas.microsoft.com/office/drawing/2014/main" id="{05C9ABDD-E407-49D5-9843-ED633E1989C0}"/>
+                <a16:creationId xmlns:a16="http://schemas.microsoft.com/office/drawing/2014/main" id="{9207329C-E26F-4C72-BEB5-AA2032579549}"/>
               </a:ext>
             </a:extLst>
           </p:cNvPr>
@@ -15164,7 +15164,7 @@
                   <a:srgbClr val="17365D"/>
                 </a:solidFill>
               </a:rPr>
-              <a:t>18 pruebas automatizadas y 1.000.000 de asuntos aleatorios. Java y PostgreSQL validan rangos.</a:t>
+              <a:t>22 pruebas, 10.000.000 de asuntos y 320.000 análisis concurrentes. Sin caídas.</a:t>
             </a:r>
           </a:p>
         </p:txBody>
@@ -15172,7 +15172,7 @@
     </p:spTree>
     <p:extLst>
       <p:ext uri="{BB962C8B-B14F-4D97-AF65-F5344CB8AC3E}">
-        <p14:creationId xmlns:p14="http://schemas.microsoft.com/office/powerpoint/2010/main" val="1412230496"/>
+        <p14:creationId xmlns:p14="http://schemas.microsoft.com/office/powerpoint/2010/main" val="717857675"/>
       </p:ext>
     </p:extLst>
   </p:cSld>

</xml_diff>

<commit_message>
Hardening integral de seguridad y reglas de negocio
</commit_message>
<xml_diff>
--- a/entrega/Presentacion_INF513_P1_Grupo09SA.pptx
+++ b/entrega/Presentacion_INF513_P1_Grupo09SA.pptx
@@ -2,22 +2,22 @@
 <file path=ppt/presentation.xml><?xml version="1.0" encoding="utf-8"?>
 <p:presentation xmlns:p="http://schemas.openxmlformats.org/presentationml/2006/main">
   <p:sldMasterIdLst>
-    <p:sldMasterId xmlns:r="http://schemas.openxmlformats.org/officeDocument/2006/relationships" id="2147483648" r:id="Ra5080a062dc643b6"/>
+    <p:sldMasterId xmlns:r="http://schemas.openxmlformats.org/officeDocument/2006/relationships" id="2147483648" r:id="R183afeff50024fd0"/>
   </p:sldMasterIdLst>
   <p:notesMasterIdLst>
-    <p:notesMasterId xmlns:r="http://schemas.openxmlformats.org/officeDocument/2006/relationships" r:id="Rbcf9415d1b884040"/>
+    <p:notesMasterId xmlns:r="http://schemas.openxmlformats.org/officeDocument/2006/relationships" r:id="Rbd3c606ae14643c7"/>
   </p:notesMasterIdLst>
   <p:sldIdLst>
-    <p:sldId xmlns:r="http://schemas.openxmlformats.org/officeDocument/2006/relationships" id="256" r:id="R8d36b752e6994c7a"/>
-    <p:sldId xmlns:r="http://schemas.openxmlformats.org/officeDocument/2006/relationships" id="257" r:id="R89e0bd32c532418d"/>
-    <p:sldId xmlns:r="http://schemas.openxmlformats.org/officeDocument/2006/relationships" id="258" r:id="R650735b7f6df4001"/>
-    <p:sldId xmlns:r="http://schemas.openxmlformats.org/officeDocument/2006/relationships" id="259" r:id="R7a4899ad65c646a7"/>
-    <p:sldId xmlns:r="http://schemas.openxmlformats.org/officeDocument/2006/relationships" id="260" r:id="R6921345436b14b13"/>
-    <p:sldId xmlns:r="http://schemas.openxmlformats.org/officeDocument/2006/relationships" id="261" r:id="R5817e283715444fc"/>
-    <p:sldId xmlns:r="http://schemas.openxmlformats.org/officeDocument/2006/relationships" id="262" r:id="R1ab615ef0dc4455d"/>
-    <p:sldId xmlns:r="http://schemas.openxmlformats.org/officeDocument/2006/relationships" id="263" r:id="Ree6085a4d40f4791"/>
-    <p:sldId xmlns:r="http://schemas.openxmlformats.org/officeDocument/2006/relationships" id="264" r:id="Ra53348566781433d"/>
-    <p:sldId xmlns:r="http://schemas.openxmlformats.org/officeDocument/2006/relationships" id="265" r:id="R89603e93adfa4add"/>
+    <p:sldId xmlns:r="http://schemas.openxmlformats.org/officeDocument/2006/relationships" id="256" r:id="R420c54f92e54425a"/>
+    <p:sldId xmlns:r="http://schemas.openxmlformats.org/officeDocument/2006/relationships" id="257" r:id="R9caada273cfc4b9f"/>
+    <p:sldId xmlns:r="http://schemas.openxmlformats.org/officeDocument/2006/relationships" id="258" r:id="R4d01ad2977b74c44"/>
+    <p:sldId xmlns:r="http://schemas.openxmlformats.org/officeDocument/2006/relationships" id="259" r:id="R3ad3a4a63d5047b2"/>
+    <p:sldId xmlns:r="http://schemas.openxmlformats.org/officeDocument/2006/relationships" id="260" r:id="Ra0d68437449b439f"/>
+    <p:sldId xmlns:r="http://schemas.openxmlformats.org/officeDocument/2006/relationships" id="261" r:id="R6b7dc8aae6ce4ba5"/>
+    <p:sldId xmlns:r="http://schemas.openxmlformats.org/officeDocument/2006/relationships" id="262" r:id="R8cb5ae4ec2924e97"/>
+    <p:sldId xmlns:r="http://schemas.openxmlformats.org/officeDocument/2006/relationships" id="263" r:id="Rf514cec670164025"/>
+    <p:sldId xmlns:r="http://schemas.openxmlformats.org/officeDocument/2006/relationships" id="264" r:id="R84a6e119479f42f4"/>
+    <p:sldId xmlns:r="http://schemas.openxmlformats.org/officeDocument/2006/relationships" id="265" r:id="R8fe62bcc405b40ea"/>
   </p:sldIdLst>
   <p:sldSz cx="12192000" cy="6858000"/>
   <p:notesSz cx="6858000" cy="9144000"/>
@@ -1088,7 +1088,7 @@
           <p:cNvPr id="3" name="Title">
             <a:extLst xmlns:a="http://schemas.openxmlformats.org/drawingml/2006/main">
               <a:ext uri="{FF2B5EF4-FFF2-40B4-BE49-F238E27FC236}">
-                <a16:creationId xmlns:a16="http://schemas.microsoft.com/office/drawing/2014/main" id="{D4820BDF-846D-4F40-90A8-4223F0077F07}"/>
+                <a16:creationId xmlns:a16="http://schemas.microsoft.com/office/drawing/2014/main" id="{D97CED6D-E1D8-4017-9E55-841DCFB8730B}"/>
               </a:ext>
             </a:extLst>
           </p:cNvPr>
@@ -1245,7 +1245,7 @@
           <p:cNvPr id="2" name="Subtitle">
             <a:extLst xmlns:a="http://schemas.openxmlformats.org/drawingml/2006/main">
               <a:ext uri="{FF2B5EF4-FFF2-40B4-BE49-F238E27FC236}">
-                <a16:creationId xmlns:a16="http://schemas.microsoft.com/office/drawing/2014/main" id="{4877A4A7-E046-4603-A0D6-1ABF4ACCB05A}"/>
+                <a16:creationId xmlns:a16="http://schemas.microsoft.com/office/drawing/2014/main" id="{B37AE387-3D5E-486A-84F4-482F797AD931}"/>
               </a:ext>
             </a:extLst>
           </p:cNvPr>
@@ -1419,7 +1419,7 @@
           <p:cNvPr id="2" name="Section title">
             <a:extLst xmlns:a="http://schemas.openxmlformats.org/drawingml/2006/main">
               <a:ext uri="{FF2B5EF4-FFF2-40B4-BE49-F238E27FC236}">
-                <a16:creationId xmlns:a16="http://schemas.microsoft.com/office/drawing/2014/main" id="{67617022-C720-43D5-87DC-BB5608F30676}"/>
+                <a16:creationId xmlns:a16="http://schemas.microsoft.com/office/drawing/2014/main" id="{FF3C1A3D-B524-46C4-8E66-E3A0A25785B4}"/>
               </a:ext>
             </a:extLst>
           </p:cNvPr>
@@ -1593,7 +1593,7 @@
           <p:cNvPr id="3" name="Title">
             <a:extLst xmlns:a="http://schemas.openxmlformats.org/drawingml/2006/main">
               <a:ext uri="{FF2B5EF4-FFF2-40B4-BE49-F238E27FC236}">
-                <a16:creationId xmlns:a16="http://schemas.microsoft.com/office/drawing/2014/main" id="{0F4A41CB-6BDF-4521-B262-45EF4003DB2F}"/>
+                <a16:creationId xmlns:a16="http://schemas.microsoft.com/office/drawing/2014/main" id="{3B78918C-034F-4623-8156-6C02F7DB59F9}"/>
               </a:ext>
             </a:extLst>
           </p:cNvPr>
@@ -1750,7 +1750,7 @@
           <p:cNvPr id="2" name="Body">
             <a:extLst xmlns:a="http://schemas.openxmlformats.org/drawingml/2006/main">
               <a:ext uri="{FF2B5EF4-FFF2-40B4-BE49-F238E27FC236}">
-                <a16:creationId xmlns:a16="http://schemas.microsoft.com/office/drawing/2014/main" id="{C4F0D242-81D8-4693-95FD-E7CFBE5B9575}"/>
+                <a16:creationId xmlns:a16="http://schemas.microsoft.com/office/drawing/2014/main" id="{9B5B5FDF-7BBE-4206-9B36-E4CBFB8A5951}"/>
               </a:ext>
             </a:extLst>
           </p:cNvPr>
@@ -1924,7 +1924,7 @@
           <p:cNvPr id="4" name="Title">
             <a:extLst xmlns:a="http://schemas.openxmlformats.org/drawingml/2006/main">
               <a:ext uri="{FF2B5EF4-FFF2-40B4-BE49-F238E27FC236}">
-                <a16:creationId xmlns:a16="http://schemas.microsoft.com/office/drawing/2014/main" id="{094D57E3-E6C6-4AFA-82AC-D43065C800F3}"/>
+                <a16:creationId xmlns:a16="http://schemas.microsoft.com/office/drawing/2014/main" id="{B49F453B-1040-4F3F-BF68-1B4CF402B263}"/>
               </a:ext>
             </a:extLst>
           </p:cNvPr>
@@ -2081,7 +2081,7 @@
           <p:cNvPr id="2" name="Left column">
             <a:extLst xmlns:a="http://schemas.openxmlformats.org/drawingml/2006/main">
               <a:ext uri="{FF2B5EF4-FFF2-40B4-BE49-F238E27FC236}">
-                <a16:creationId xmlns:a16="http://schemas.microsoft.com/office/drawing/2014/main" id="{13D50B89-523C-456C-8897-6703584B1784}"/>
+                <a16:creationId xmlns:a16="http://schemas.microsoft.com/office/drawing/2014/main" id="{D46AD891-EDAF-48E0-B5A2-D29C232B2F9A}"/>
               </a:ext>
             </a:extLst>
           </p:cNvPr>
@@ -2238,7 +2238,7 @@
           <p:cNvPr id="3" name="Right column">
             <a:extLst xmlns:a="http://schemas.openxmlformats.org/drawingml/2006/main">
               <a:ext uri="{FF2B5EF4-FFF2-40B4-BE49-F238E27FC236}">
-                <a16:creationId xmlns:a16="http://schemas.microsoft.com/office/drawing/2014/main" id="{9047C631-D09B-4A56-B2C3-B3CC47A7B3AD}"/>
+                <a16:creationId xmlns:a16="http://schemas.microsoft.com/office/drawing/2014/main" id="{E6DAD21D-970B-42C2-9D24-3D2048619DAE}"/>
               </a:ext>
             </a:extLst>
           </p:cNvPr>
@@ -2412,7 +2412,7 @@
           <p:cNvPr id="3" name="Title">
             <a:extLst xmlns:a="http://schemas.openxmlformats.org/drawingml/2006/main">
               <a:ext uri="{FF2B5EF4-FFF2-40B4-BE49-F238E27FC236}">
-                <a16:creationId xmlns:a16="http://schemas.microsoft.com/office/drawing/2014/main" id="{B216B4EB-A511-4EB1-9DD0-F992EFF08CFC}"/>
+                <a16:creationId xmlns:a16="http://schemas.microsoft.com/office/drawing/2014/main" id="{5C2D87CF-4516-4556-B796-5C001B3F4948}"/>
               </a:ext>
             </a:extLst>
           </p:cNvPr>
@@ -2569,7 +2569,7 @@
           <p:cNvPr id="2" name="Left column">
             <a:extLst xmlns:a="http://schemas.openxmlformats.org/drawingml/2006/main">
               <a:ext uri="{FF2B5EF4-FFF2-40B4-BE49-F238E27FC236}">
-                <a16:creationId xmlns:a16="http://schemas.microsoft.com/office/drawing/2014/main" id="{272805F1-15FF-4148-A466-2C537359D813}"/>
+                <a16:creationId xmlns:a16="http://schemas.microsoft.com/office/drawing/2014/main" id="{1AD9227D-7108-4621-9ED3-CFBAF250034D}"/>
               </a:ext>
             </a:extLst>
           </p:cNvPr>
@@ -2764,12 +2764,12 @@
   </p:cSld>
   <p:clrMap bg1="lt1" tx1="dk1" bg2="lt2" tx2="dk2" accent1="accent1" accent2="accent2" accent3="accent3" accent4="accent4" accent5="accent5" accent6="accent6" hlink="hlink" folHlink="folHlink"/>
   <p:sldLayoutIdLst>
-    <p:sldLayoutId xmlns:r="http://schemas.openxmlformats.org/officeDocument/2006/relationships" id="2147483649" r:id="R5ca931aac7b54f03"/>
-    <p:sldLayoutId xmlns:r="http://schemas.openxmlformats.org/officeDocument/2006/relationships" id="2147483650" r:id="R844910c62cb548a9"/>
-    <p:sldLayoutId xmlns:r="http://schemas.openxmlformats.org/officeDocument/2006/relationships" id="2147483651" r:id="R741e64ce8aa94be5"/>
-    <p:sldLayoutId xmlns:r="http://schemas.openxmlformats.org/officeDocument/2006/relationships" id="2147483652" r:id="R1aa6cd1ae95b4164"/>
-    <p:sldLayoutId xmlns:r="http://schemas.openxmlformats.org/officeDocument/2006/relationships" id="2147483653" r:id="R7fcf658fd4f44416"/>
-    <p:sldLayoutId xmlns:r="http://schemas.openxmlformats.org/officeDocument/2006/relationships" id="2147483654" r:id="R085859db01e746ab"/>
+    <p:sldLayoutId xmlns:r="http://schemas.openxmlformats.org/officeDocument/2006/relationships" id="2147483649" r:id="Rc11bb933e4fa4ae3"/>
+    <p:sldLayoutId xmlns:r="http://schemas.openxmlformats.org/officeDocument/2006/relationships" id="2147483650" r:id="Ra4a80b84e41d4ec3"/>
+    <p:sldLayoutId xmlns:r="http://schemas.openxmlformats.org/officeDocument/2006/relationships" id="2147483651" r:id="R7a229c219a1b4386"/>
+    <p:sldLayoutId xmlns:r="http://schemas.openxmlformats.org/officeDocument/2006/relationships" id="2147483652" r:id="Refdd83a9a9634b94"/>
+    <p:sldLayoutId xmlns:r="http://schemas.openxmlformats.org/officeDocument/2006/relationships" id="2147483653" r:id="R3d5496c736474d35"/>
+    <p:sldLayoutId xmlns:r="http://schemas.openxmlformats.org/officeDocument/2006/relationships" id="2147483654" r:id="Re168382099c64249"/>
   </p:sldLayoutIdLst>
   <p:txStyles>
     <p:titleStyle>
@@ -3320,7 +3320,7 @@
           <p:cNvPr id="8" name="">
             <a:extLst xmlns:a="http://schemas.openxmlformats.org/drawingml/2006/main">
               <a:ext uri="{FF2B5EF4-FFF2-40B4-BE49-F238E27FC236}">
-                <a16:creationId xmlns:a16="http://schemas.microsoft.com/office/drawing/2014/main" id="{CDA3A719-5390-444D-85D4-B50120F8453E}"/>
+                <a16:creationId xmlns:a16="http://schemas.microsoft.com/office/drawing/2014/main" id="{37181EE4-0665-4E4D-BD12-D5D30202392C}"/>
               </a:ext>
             </a:extLst>
           </p:cNvPr>
@@ -3378,7 +3378,7 @@
           <p:cNvPr id="2" name="">
             <a:extLst xmlns:a="http://schemas.openxmlformats.org/drawingml/2006/main">
               <a:ext uri="{FF2B5EF4-FFF2-40B4-BE49-F238E27FC236}">
-                <a16:creationId xmlns:a16="http://schemas.microsoft.com/office/drawing/2014/main" id="{B04A22FE-6C3C-4D99-912A-F32D31957C1F}"/>
+                <a16:creationId xmlns:a16="http://schemas.microsoft.com/office/drawing/2014/main" id="{A4A1ACA4-C318-431A-83A6-78213E529A52}"/>
               </a:ext>
             </a:extLst>
           </p:cNvPr>
@@ -3436,7 +3436,7 @@
           <p:cNvPr id="3" name="">
             <a:extLst xmlns:a="http://schemas.openxmlformats.org/drawingml/2006/main">
               <a:ext uri="{FF2B5EF4-FFF2-40B4-BE49-F238E27FC236}">
-                <a16:creationId xmlns:a16="http://schemas.microsoft.com/office/drawing/2014/main" id="{4CBECBB5-90EE-4650-B577-39DDE60CA743}"/>
+                <a16:creationId xmlns:a16="http://schemas.microsoft.com/office/drawing/2014/main" id="{11F0FD37-A4B6-4D6C-BD4F-0E017E486F8B}"/>
               </a:ext>
             </a:extLst>
           </p:cNvPr>
@@ -3494,7 +3494,7 @@
           <p:cNvPr id="4" name="">
             <a:extLst xmlns:a="http://schemas.openxmlformats.org/drawingml/2006/main">
               <a:ext uri="{FF2B5EF4-FFF2-40B4-BE49-F238E27FC236}">
-                <a16:creationId xmlns:a16="http://schemas.microsoft.com/office/drawing/2014/main" id="{67D6334D-A6C1-4CBF-BD5F-6123D1F56096}"/>
+                <a16:creationId xmlns:a16="http://schemas.microsoft.com/office/drawing/2014/main" id="{38C63BF3-4683-4730-A26E-BC018869B402}"/>
               </a:ext>
             </a:extLst>
           </p:cNvPr>
@@ -3529,7 +3529,7 @@
           <p:cNvPr id="5" name="">
             <a:extLst xmlns:a="http://schemas.openxmlformats.org/drawingml/2006/main">
               <a:ext uri="{FF2B5EF4-FFF2-40B4-BE49-F238E27FC236}">
-                <a16:creationId xmlns:a16="http://schemas.microsoft.com/office/drawing/2014/main" id="{159CA441-7D2F-4942-B7C9-6BE698D52DD5}"/>
+                <a16:creationId xmlns:a16="http://schemas.microsoft.com/office/drawing/2014/main" id="{61069828-5029-4865-BD44-C43E944CA0C9}"/>
               </a:ext>
             </a:extLst>
           </p:cNvPr>
@@ -3587,7 +3587,7 @@
           <p:cNvPr id="6" name="">
             <a:extLst xmlns:a="http://schemas.openxmlformats.org/drawingml/2006/main">
               <a:ext uri="{FF2B5EF4-FFF2-40B4-BE49-F238E27FC236}">
-                <a16:creationId xmlns:a16="http://schemas.microsoft.com/office/drawing/2014/main" id="{FDBA9D62-1EB6-4FAD-91A5-D3010023EB38}"/>
+                <a16:creationId xmlns:a16="http://schemas.microsoft.com/office/drawing/2014/main" id="{B70E70F1-F4B4-437E-9CD6-5614A7F44D95}"/>
               </a:ext>
             </a:extLst>
           </p:cNvPr>
@@ -3740,7 +3740,7 @@
           <p:cNvPr id="7" name="">
             <a:extLst xmlns:a="http://schemas.openxmlformats.org/drawingml/2006/main">
               <a:ext uri="{FF2B5EF4-FFF2-40B4-BE49-F238E27FC236}">
-                <a16:creationId xmlns:a16="http://schemas.microsoft.com/office/drawing/2014/main" id="{5B9EDB9D-4DCD-4F4F-B8B1-7D45BA535B0F}"/>
+                <a16:creationId xmlns:a16="http://schemas.microsoft.com/office/drawing/2014/main" id="{12EE2B65-6B8A-44A8-829B-62036EA0D0DB}"/>
               </a:ext>
             </a:extLst>
           </p:cNvPr>
@@ -3813,7 +3813,7 @@
     </p:spTree>
     <p:extLst>
       <p:ext uri="{BB962C8B-B14F-4D97-AF65-F5344CB8AC3E}">
-        <p14:creationId xmlns:p14="http://schemas.microsoft.com/office/powerpoint/2010/main" val="1513496132"/>
+        <p14:creationId xmlns:p14="http://schemas.microsoft.com/office/powerpoint/2010/main" val="855304297"/>
       </p:ext>
     </p:extLst>
   </p:cSld>
@@ -3844,7 +3844,7 @@
           <p:cNvPr id="17" name="">
             <a:extLst xmlns:a="http://schemas.openxmlformats.org/drawingml/2006/main">
               <a:ext uri="{FF2B5EF4-FFF2-40B4-BE49-F238E27FC236}">
-                <a16:creationId xmlns:a16="http://schemas.microsoft.com/office/drawing/2014/main" id="{CEEF1AA9-0BB7-4750-9BE4-739FEFBEB825}"/>
+                <a16:creationId xmlns:a16="http://schemas.microsoft.com/office/drawing/2014/main" id="{56C28401-136F-470A-9EDB-244B346175FC}"/>
               </a:ext>
             </a:extLst>
           </p:cNvPr>
@@ -3902,7 +3902,7 @@
           <p:cNvPr id="2" name="">
             <a:extLst xmlns:a="http://schemas.openxmlformats.org/drawingml/2006/main">
               <a:ext uri="{FF2B5EF4-FFF2-40B4-BE49-F238E27FC236}">
-                <a16:creationId xmlns:a16="http://schemas.microsoft.com/office/drawing/2014/main" id="{801DD063-42AD-48BF-AC19-19C6AB040E72}"/>
+                <a16:creationId xmlns:a16="http://schemas.microsoft.com/office/drawing/2014/main" id="{35C87C48-1CFF-44E6-9257-F2B3D0D39CDC}"/>
               </a:ext>
             </a:extLst>
           </p:cNvPr>
@@ -3960,7 +3960,7 @@
           <p:cNvPr id="3" name="">
             <a:extLst xmlns:a="http://schemas.openxmlformats.org/drawingml/2006/main">
               <a:ext uri="{FF2B5EF4-FFF2-40B4-BE49-F238E27FC236}">
-                <a16:creationId xmlns:a16="http://schemas.microsoft.com/office/drawing/2014/main" id="{075C3689-3616-4B78-BA4F-0EDC02AD646B}"/>
+                <a16:creationId xmlns:a16="http://schemas.microsoft.com/office/drawing/2014/main" id="{A6FB1768-FF92-4819-A590-7DB78065CCDA}"/>
               </a:ext>
             </a:extLst>
           </p:cNvPr>
@@ -3993,7 +3993,7 @@
           <p:cNvPr id="4" name="">
             <a:extLst xmlns:a="http://schemas.openxmlformats.org/drawingml/2006/main">
               <a:ext uri="{FF2B5EF4-FFF2-40B4-BE49-F238E27FC236}">
-                <a16:creationId xmlns:a16="http://schemas.microsoft.com/office/drawing/2014/main" id="{EC1422AD-2126-4C45-8B3E-71A8F17B7E77}"/>
+                <a16:creationId xmlns:a16="http://schemas.microsoft.com/office/drawing/2014/main" id="{6A023A35-297C-4926-B594-1B721A9C510C}"/>
               </a:ext>
             </a:extLst>
           </p:cNvPr>
@@ -4051,7 +4051,7 @@
           <p:cNvPr id="5" name="">
             <a:extLst xmlns:a="http://schemas.openxmlformats.org/drawingml/2006/main">
               <a:ext uri="{FF2B5EF4-FFF2-40B4-BE49-F238E27FC236}">
-                <a16:creationId xmlns:a16="http://schemas.microsoft.com/office/drawing/2014/main" id="{4B13A0BF-C812-4355-8FF6-66CE054B55BF}"/>
+                <a16:creationId xmlns:a16="http://schemas.microsoft.com/office/drawing/2014/main" id="{91875987-0F22-4DEE-983B-6A17D08E95A9}"/>
               </a:ext>
             </a:extLst>
           </p:cNvPr>
@@ -4109,7 +4109,7 @@
           <p:cNvPr id="6" name="">
             <a:extLst xmlns:a="http://schemas.openxmlformats.org/drawingml/2006/main">
               <a:ext uri="{FF2B5EF4-FFF2-40B4-BE49-F238E27FC236}">
-                <a16:creationId xmlns:a16="http://schemas.microsoft.com/office/drawing/2014/main" id="{159427EF-AF1D-48DD-8790-3077FD1BEE50}"/>
+                <a16:creationId xmlns:a16="http://schemas.microsoft.com/office/drawing/2014/main" id="{F683E2BF-FADD-443F-BC43-079AF39F9DB9}"/>
               </a:ext>
             </a:extLst>
           </p:cNvPr>
@@ -4167,7 +4167,7 @@
           <p:cNvPr id="7" name="">
             <a:extLst xmlns:a="http://schemas.openxmlformats.org/drawingml/2006/main">
               <a:ext uri="{FF2B5EF4-FFF2-40B4-BE49-F238E27FC236}">
-                <a16:creationId xmlns:a16="http://schemas.microsoft.com/office/drawing/2014/main" id="{F0395808-2DF6-4A2A-8584-1A0C0C768215}"/>
+                <a16:creationId xmlns:a16="http://schemas.microsoft.com/office/drawing/2014/main" id="{D10CBD83-57C3-4D94-ABC3-33839BA03E91}"/>
               </a:ext>
             </a:extLst>
           </p:cNvPr>
@@ -4225,7 +4225,7 @@
           <p:cNvPr id="8" name="">
             <a:extLst xmlns:a="http://schemas.openxmlformats.org/drawingml/2006/main">
               <a:ext uri="{FF2B5EF4-FFF2-40B4-BE49-F238E27FC236}">
-                <a16:creationId xmlns:a16="http://schemas.microsoft.com/office/drawing/2014/main" id="{FD000889-E8FE-428E-8309-4FE355408C40}"/>
+                <a16:creationId xmlns:a16="http://schemas.microsoft.com/office/drawing/2014/main" id="{31774198-7519-4A81-99CD-6D67DEC282BD}"/>
               </a:ext>
             </a:extLst>
           </p:cNvPr>
@@ -4260,7 +4260,7 @@
           <p:cNvPr id="9" name="">
             <a:extLst xmlns:a="http://schemas.openxmlformats.org/drawingml/2006/main">
               <a:ext uri="{FF2B5EF4-FFF2-40B4-BE49-F238E27FC236}">
-                <a16:creationId xmlns:a16="http://schemas.microsoft.com/office/drawing/2014/main" id="{A038DB89-F011-4164-86DE-481C56D0161B}"/>
+                <a16:creationId xmlns:a16="http://schemas.microsoft.com/office/drawing/2014/main" id="{0D2AE05D-B677-4931-8973-116440F7AC18}"/>
               </a:ext>
             </a:extLst>
           </p:cNvPr>
@@ -4293,7 +4293,7 @@
           <p:cNvPr id="10" name="">
             <a:extLst xmlns:a="http://schemas.openxmlformats.org/drawingml/2006/main">
               <a:ext uri="{FF2B5EF4-FFF2-40B4-BE49-F238E27FC236}">
-                <a16:creationId xmlns:a16="http://schemas.microsoft.com/office/drawing/2014/main" id="{B10107A3-F17B-437D-9822-30B2E251B453}"/>
+                <a16:creationId xmlns:a16="http://schemas.microsoft.com/office/drawing/2014/main" id="{920B8828-F469-4965-999D-C6386666AF7A}"/>
               </a:ext>
             </a:extLst>
           </p:cNvPr>
@@ -4351,7 +4351,7 @@
           <p:cNvPr id="11" name="">
             <a:extLst xmlns:a="http://schemas.openxmlformats.org/drawingml/2006/main">
               <a:ext uri="{FF2B5EF4-FFF2-40B4-BE49-F238E27FC236}">
-                <a16:creationId xmlns:a16="http://schemas.microsoft.com/office/drawing/2014/main" id="{20C93905-AA54-451B-AE60-C8EEBFCC73BC}"/>
+                <a16:creationId xmlns:a16="http://schemas.microsoft.com/office/drawing/2014/main" id="{5880B69D-7203-4700-9EA7-CB3CE67D3942}"/>
               </a:ext>
             </a:extLst>
           </p:cNvPr>
@@ -4460,7 +4460,7 @@
           <p:cNvPr id="12" name="">
             <a:extLst xmlns:a="http://schemas.openxmlformats.org/drawingml/2006/main">
               <a:ext uri="{FF2B5EF4-FFF2-40B4-BE49-F238E27FC236}">
-                <a16:creationId xmlns:a16="http://schemas.microsoft.com/office/drawing/2014/main" id="{E37C9C02-6492-41E6-A3DA-7B1EB32B08AB}"/>
+                <a16:creationId xmlns:a16="http://schemas.microsoft.com/office/drawing/2014/main" id="{D21B67C5-D9D7-4150-AF6E-F242CFA3C86F}"/>
               </a:ext>
             </a:extLst>
           </p:cNvPr>
@@ -4495,7 +4495,7 @@
           <p:cNvPr id="13" name="">
             <a:extLst xmlns:a="http://schemas.openxmlformats.org/drawingml/2006/main">
               <a:ext uri="{FF2B5EF4-FFF2-40B4-BE49-F238E27FC236}">
-                <a16:creationId xmlns:a16="http://schemas.microsoft.com/office/drawing/2014/main" id="{B1AB796D-DD79-4F3C-9DA0-3B00159C5D70}"/>
+                <a16:creationId xmlns:a16="http://schemas.microsoft.com/office/drawing/2014/main" id="{4D11DE34-3D0D-4A30-9032-A779801F8D40}"/>
               </a:ext>
             </a:extLst>
           </p:cNvPr>
@@ -4528,7 +4528,7 @@
           <p:cNvPr id="14" name="">
             <a:extLst xmlns:a="http://schemas.openxmlformats.org/drawingml/2006/main">
               <a:ext uri="{FF2B5EF4-FFF2-40B4-BE49-F238E27FC236}">
-                <a16:creationId xmlns:a16="http://schemas.microsoft.com/office/drawing/2014/main" id="{62F9FAF9-3C0B-4885-87EE-7BBEE6B5871D}"/>
+                <a16:creationId xmlns:a16="http://schemas.microsoft.com/office/drawing/2014/main" id="{E08AF1C5-D7FC-44AC-B272-E893153E3203}"/>
               </a:ext>
             </a:extLst>
           </p:cNvPr>
@@ -4586,7 +4586,7 @@
           <p:cNvPr id="15" name="">
             <a:extLst xmlns:a="http://schemas.openxmlformats.org/drawingml/2006/main">
               <a:ext uri="{FF2B5EF4-FFF2-40B4-BE49-F238E27FC236}">
-                <a16:creationId xmlns:a16="http://schemas.microsoft.com/office/drawing/2014/main" id="{EDDFD418-3318-4CA3-9893-917F68A356EF}"/>
+                <a16:creationId xmlns:a16="http://schemas.microsoft.com/office/drawing/2014/main" id="{511D6172-A226-408B-9AA4-E8FEEFC5B5E6}"/>
               </a:ext>
             </a:extLst>
           </p:cNvPr>
@@ -4712,7 +4712,7 @@
           <p:cNvPr id="16" name="">
             <a:extLst xmlns:a="http://schemas.openxmlformats.org/drawingml/2006/main">
               <a:ext uri="{FF2B5EF4-FFF2-40B4-BE49-F238E27FC236}">
-                <a16:creationId xmlns:a16="http://schemas.microsoft.com/office/drawing/2014/main" id="{3362BA11-9B5D-496F-98BC-07F98CADDBC3}"/>
+                <a16:creationId xmlns:a16="http://schemas.microsoft.com/office/drawing/2014/main" id="{D2C53E6F-D993-4A3D-AFE5-7FE2E43BCD11}"/>
               </a:ext>
             </a:extLst>
           </p:cNvPr>
@@ -4768,7 +4768,7 @@
     </p:spTree>
     <p:extLst>
       <p:ext uri="{BB962C8B-B14F-4D97-AF65-F5344CB8AC3E}">
-        <p14:creationId xmlns:p14="http://schemas.microsoft.com/office/powerpoint/2010/main" val="340537492"/>
+        <p14:creationId xmlns:p14="http://schemas.microsoft.com/office/powerpoint/2010/main" val="416532239"/>
       </p:ext>
     </p:extLst>
   </p:cSld>
@@ -4799,7 +4799,7 @@
           <p:cNvPr id="22" name="">
             <a:extLst xmlns:a="http://schemas.openxmlformats.org/drawingml/2006/main">
               <a:ext uri="{FF2B5EF4-FFF2-40B4-BE49-F238E27FC236}">
-                <a16:creationId xmlns:a16="http://schemas.microsoft.com/office/drawing/2014/main" id="{A2BB5492-7C7D-4BF2-BBBA-37B04FDD613F}"/>
+                <a16:creationId xmlns:a16="http://schemas.microsoft.com/office/drawing/2014/main" id="{02456448-5529-4BB5-A1A2-69E5EC7F8251}"/>
               </a:ext>
             </a:extLst>
           </p:cNvPr>
@@ -4857,7 +4857,7 @@
           <p:cNvPr id="2" name="">
             <a:extLst xmlns:a="http://schemas.openxmlformats.org/drawingml/2006/main">
               <a:ext uri="{FF2B5EF4-FFF2-40B4-BE49-F238E27FC236}">
-                <a16:creationId xmlns:a16="http://schemas.microsoft.com/office/drawing/2014/main" id="{1BFF12EF-E601-4094-9109-4759FDC807BD}"/>
+                <a16:creationId xmlns:a16="http://schemas.microsoft.com/office/drawing/2014/main" id="{CD2F0E7F-79E7-4C92-BFF1-C9CF0C72AA1B}"/>
               </a:ext>
             </a:extLst>
           </p:cNvPr>
@@ -4915,7 +4915,7 @@
           <p:cNvPr id="3" name="">
             <a:extLst xmlns:a="http://schemas.openxmlformats.org/drawingml/2006/main">
               <a:ext uri="{FF2B5EF4-FFF2-40B4-BE49-F238E27FC236}">
-                <a16:creationId xmlns:a16="http://schemas.microsoft.com/office/drawing/2014/main" id="{96C408B5-CE99-4780-B7FE-F4ED375EB8DE}"/>
+                <a16:creationId xmlns:a16="http://schemas.microsoft.com/office/drawing/2014/main" id="{D8228C1C-83B4-4A25-A0B6-24F84A6E910F}"/>
               </a:ext>
             </a:extLst>
           </p:cNvPr>
@@ -4948,7 +4948,7 @@
           <p:cNvPr id="4" name="">
             <a:extLst xmlns:a="http://schemas.openxmlformats.org/drawingml/2006/main">
               <a:ext uri="{FF2B5EF4-FFF2-40B4-BE49-F238E27FC236}">
-                <a16:creationId xmlns:a16="http://schemas.microsoft.com/office/drawing/2014/main" id="{E755233A-3E0F-44E5-B23F-E1636E97B151}"/>
+                <a16:creationId xmlns:a16="http://schemas.microsoft.com/office/drawing/2014/main" id="{BFE0F461-3F78-459B-BF1F-7B61A81CD4E2}"/>
               </a:ext>
             </a:extLst>
           </p:cNvPr>
@@ -5006,7 +5006,7 @@
           <p:cNvPr id="5" name="">
             <a:extLst xmlns:a="http://schemas.openxmlformats.org/drawingml/2006/main">
               <a:ext uri="{FF2B5EF4-FFF2-40B4-BE49-F238E27FC236}">
-                <a16:creationId xmlns:a16="http://schemas.microsoft.com/office/drawing/2014/main" id="{126106CF-5055-42DA-9669-17D383FD2B5B}"/>
+                <a16:creationId xmlns:a16="http://schemas.microsoft.com/office/drawing/2014/main" id="{C067DE00-E325-46BB-B15C-9D9B693BFC73}"/>
               </a:ext>
             </a:extLst>
           </p:cNvPr>
@@ -5064,7 +5064,7 @@
           <p:cNvPr id="6" name="">
             <a:extLst xmlns:a="http://schemas.openxmlformats.org/drawingml/2006/main">
               <a:ext uri="{FF2B5EF4-FFF2-40B4-BE49-F238E27FC236}">
-                <a16:creationId xmlns:a16="http://schemas.microsoft.com/office/drawing/2014/main" id="{332665F3-89B0-41C0-87CB-0940A9DCF31A}"/>
+                <a16:creationId xmlns:a16="http://schemas.microsoft.com/office/drawing/2014/main" id="{AE885A97-8AAA-4FF3-BBD9-75A494D2007D}"/>
               </a:ext>
             </a:extLst>
           </p:cNvPr>
@@ -5099,7 +5099,7 @@
           <p:cNvPr id="7" name="">
             <a:extLst xmlns:a="http://schemas.openxmlformats.org/drawingml/2006/main">
               <a:ext uri="{FF2B5EF4-FFF2-40B4-BE49-F238E27FC236}">
-                <a16:creationId xmlns:a16="http://schemas.microsoft.com/office/drawing/2014/main" id="{AD8266B0-6FDD-46D5-981A-D8E9739A2C79}"/>
+                <a16:creationId xmlns:a16="http://schemas.microsoft.com/office/drawing/2014/main" id="{1F492153-3FA1-4DB1-B710-F9022F3B44EA}"/>
               </a:ext>
             </a:extLst>
           </p:cNvPr>
@@ -5132,7 +5132,7 @@
           <p:cNvPr id="8" name="">
             <a:extLst xmlns:a="http://schemas.openxmlformats.org/drawingml/2006/main">
               <a:ext uri="{FF2B5EF4-FFF2-40B4-BE49-F238E27FC236}">
-                <a16:creationId xmlns:a16="http://schemas.microsoft.com/office/drawing/2014/main" id="{D1E6CAC8-D9EB-4BE2-A8EF-78D59C6D4395}"/>
+                <a16:creationId xmlns:a16="http://schemas.microsoft.com/office/drawing/2014/main" id="{BEF2E673-0B4C-4CA5-BA5D-D3055AC871E8}"/>
               </a:ext>
             </a:extLst>
           </p:cNvPr>
@@ -5190,7 +5190,7 @@
           <p:cNvPr id="9" name="">
             <a:extLst xmlns:a="http://schemas.openxmlformats.org/drawingml/2006/main">
               <a:ext uri="{FF2B5EF4-FFF2-40B4-BE49-F238E27FC236}">
-                <a16:creationId xmlns:a16="http://schemas.microsoft.com/office/drawing/2014/main" id="{1A8DCDA9-C888-4994-A8EE-367E7050D2CA}"/>
+                <a16:creationId xmlns:a16="http://schemas.microsoft.com/office/drawing/2014/main" id="{65CA21C6-93AB-43AB-9FFC-89CC9B9D4B98}"/>
               </a:ext>
             </a:extLst>
           </p:cNvPr>
@@ -5248,7 +5248,7 @@
           <p:cNvPr id="10" name="">
             <a:extLst xmlns:a="http://schemas.openxmlformats.org/drawingml/2006/main">
               <a:ext uri="{FF2B5EF4-FFF2-40B4-BE49-F238E27FC236}">
-                <a16:creationId xmlns:a16="http://schemas.microsoft.com/office/drawing/2014/main" id="{11F37093-AC1C-49DF-BC30-C24E17EED420}"/>
+                <a16:creationId xmlns:a16="http://schemas.microsoft.com/office/drawing/2014/main" id="{F0464236-AD93-465D-8160-9CA78F162F43}"/>
               </a:ext>
             </a:extLst>
           </p:cNvPr>
@@ -5283,7 +5283,7 @@
           <p:cNvPr id="11" name="">
             <a:extLst xmlns:a="http://schemas.openxmlformats.org/drawingml/2006/main">
               <a:ext uri="{FF2B5EF4-FFF2-40B4-BE49-F238E27FC236}">
-                <a16:creationId xmlns:a16="http://schemas.microsoft.com/office/drawing/2014/main" id="{E2D3176C-27A9-4BD0-A840-085F02C74BCA}"/>
+                <a16:creationId xmlns:a16="http://schemas.microsoft.com/office/drawing/2014/main" id="{B50A670F-5065-4B4A-9F8B-1B62EE44B087}"/>
               </a:ext>
             </a:extLst>
           </p:cNvPr>
@@ -5316,7 +5316,7 @@
           <p:cNvPr id="12" name="">
             <a:extLst xmlns:a="http://schemas.openxmlformats.org/drawingml/2006/main">
               <a:ext uri="{FF2B5EF4-FFF2-40B4-BE49-F238E27FC236}">
-                <a16:creationId xmlns:a16="http://schemas.microsoft.com/office/drawing/2014/main" id="{9819F1F7-19A0-407E-9E2D-8C5807234422}"/>
+                <a16:creationId xmlns:a16="http://schemas.microsoft.com/office/drawing/2014/main" id="{BC03CF45-08B8-4518-A561-A76813071E60}"/>
               </a:ext>
             </a:extLst>
           </p:cNvPr>
@@ -5374,7 +5374,7 @@
           <p:cNvPr id="13" name="">
             <a:extLst xmlns:a="http://schemas.openxmlformats.org/drawingml/2006/main">
               <a:ext uri="{FF2B5EF4-FFF2-40B4-BE49-F238E27FC236}">
-                <a16:creationId xmlns:a16="http://schemas.microsoft.com/office/drawing/2014/main" id="{2AB8AC88-E608-417F-8C68-2FB8C9CD9F5E}"/>
+                <a16:creationId xmlns:a16="http://schemas.microsoft.com/office/drawing/2014/main" id="{B8132253-31C9-494D-B292-B0AD79AE3A6A}"/>
               </a:ext>
             </a:extLst>
           </p:cNvPr>
@@ -5432,7 +5432,7 @@
           <p:cNvPr id="14" name="">
             <a:extLst xmlns:a="http://schemas.openxmlformats.org/drawingml/2006/main">
               <a:ext uri="{FF2B5EF4-FFF2-40B4-BE49-F238E27FC236}">
-                <a16:creationId xmlns:a16="http://schemas.microsoft.com/office/drawing/2014/main" id="{2F9720F1-6C14-44A1-85FB-AAD00A3339A3}"/>
+                <a16:creationId xmlns:a16="http://schemas.microsoft.com/office/drawing/2014/main" id="{16C15B70-A666-4441-9FCB-AF7F5D8916EA}"/>
               </a:ext>
             </a:extLst>
           </p:cNvPr>
@@ -5467,7 +5467,7 @@
           <p:cNvPr id="15" name="">
             <a:extLst xmlns:a="http://schemas.openxmlformats.org/drawingml/2006/main">
               <a:ext uri="{FF2B5EF4-FFF2-40B4-BE49-F238E27FC236}">
-                <a16:creationId xmlns:a16="http://schemas.microsoft.com/office/drawing/2014/main" id="{75BC6EC6-0E11-49EB-B762-4E51D5CA3A76}"/>
+                <a16:creationId xmlns:a16="http://schemas.microsoft.com/office/drawing/2014/main" id="{B3AD0954-310E-45A1-ADF7-EE8687E75DDC}"/>
               </a:ext>
             </a:extLst>
           </p:cNvPr>
@@ -5500,7 +5500,7 @@
           <p:cNvPr id="16" name="">
             <a:extLst xmlns:a="http://schemas.openxmlformats.org/drawingml/2006/main">
               <a:ext uri="{FF2B5EF4-FFF2-40B4-BE49-F238E27FC236}">
-                <a16:creationId xmlns:a16="http://schemas.microsoft.com/office/drawing/2014/main" id="{7C7DFD51-A916-4066-97C3-93B25E11C7F5}"/>
+                <a16:creationId xmlns:a16="http://schemas.microsoft.com/office/drawing/2014/main" id="{4403879C-C068-4491-B035-3EBA5941DA03}"/>
               </a:ext>
             </a:extLst>
           </p:cNvPr>
@@ -5558,7 +5558,7 @@
           <p:cNvPr id="17" name="">
             <a:extLst xmlns:a="http://schemas.openxmlformats.org/drawingml/2006/main">
               <a:ext uri="{FF2B5EF4-FFF2-40B4-BE49-F238E27FC236}">
-                <a16:creationId xmlns:a16="http://schemas.microsoft.com/office/drawing/2014/main" id="{9D286FBE-993D-447F-9CC3-DD298DECEE1E}"/>
+                <a16:creationId xmlns:a16="http://schemas.microsoft.com/office/drawing/2014/main" id="{576FAFCB-5193-4D43-90CE-E1FCE2A143E9}"/>
               </a:ext>
             </a:extLst>
           </p:cNvPr>
@@ -5616,7 +5616,7 @@
           <p:cNvPr id="18" name="">
             <a:extLst xmlns:a="http://schemas.openxmlformats.org/drawingml/2006/main">
               <a:ext uri="{FF2B5EF4-FFF2-40B4-BE49-F238E27FC236}">
-                <a16:creationId xmlns:a16="http://schemas.microsoft.com/office/drawing/2014/main" id="{016CE6C2-2BE5-43B3-8A2A-D8336BA07EBB}"/>
+                <a16:creationId xmlns:a16="http://schemas.microsoft.com/office/drawing/2014/main" id="{A4C597E2-E858-4C63-BDB4-A902F0EA3039}"/>
               </a:ext>
             </a:extLst>
           </p:cNvPr>
@@ -5674,7 +5674,7 @@
           <p:cNvPr id="19" name="">
             <a:extLst xmlns:a="http://schemas.openxmlformats.org/drawingml/2006/main">
               <a:ext uri="{FF2B5EF4-FFF2-40B4-BE49-F238E27FC236}">
-                <a16:creationId xmlns:a16="http://schemas.microsoft.com/office/drawing/2014/main" id="{ABB0A8BF-47B9-4CC5-8B56-7E6D9D3B126A}"/>
+                <a16:creationId xmlns:a16="http://schemas.microsoft.com/office/drawing/2014/main" id="{17D7A8D7-E3C6-4B73-AE69-72EF9C53C3FA}"/>
               </a:ext>
             </a:extLst>
           </p:cNvPr>
@@ -5709,7 +5709,7 @@
           <p:cNvPr id="20" name="">
             <a:extLst xmlns:a="http://schemas.openxmlformats.org/drawingml/2006/main">
               <a:ext uri="{FF2B5EF4-FFF2-40B4-BE49-F238E27FC236}">
-                <a16:creationId xmlns:a16="http://schemas.microsoft.com/office/drawing/2014/main" id="{AFB3FEC2-B17B-4300-ACCC-9D560DBC162D}"/>
+                <a16:creationId xmlns:a16="http://schemas.microsoft.com/office/drawing/2014/main" id="{F95A8E3D-B580-4B48-8BA3-D658E2B870CC}"/>
               </a:ext>
             </a:extLst>
           </p:cNvPr>
@@ -5767,7 +5767,7 @@
           <p:cNvPr id="21" name="">
             <a:extLst xmlns:a="http://schemas.openxmlformats.org/drawingml/2006/main">
               <a:ext uri="{FF2B5EF4-FFF2-40B4-BE49-F238E27FC236}">
-                <a16:creationId xmlns:a16="http://schemas.microsoft.com/office/drawing/2014/main" id="{E7E033A1-1E44-4D57-986A-B24709150BB3}"/>
+                <a16:creationId xmlns:a16="http://schemas.microsoft.com/office/drawing/2014/main" id="{90A75326-FA3E-4C3E-8330-55302496FBEE}"/>
               </a:ext>
             </a:extLst>
           </p:cNvPr>
@@ -5823,7 +5823,7 @@
     </p:spTree>
     <p:extLst>
       <p:ext uri="{BB962C8B-B14F-4D97-AF65-F5344CB8AC3E}">
-        <p14:creationId xmlns:p14="http://schemas.microsoft.com/office/powerpoint/2010/main" val="1118268925"/>
+        <p14:creationId xmlns:p14="http://schemas.microsoft.com/office/powerpoint/2010/main" val="59883213"/>
       </p:ext>
     </p:extLst>
   </p:cSld>
@@ -5854,7 +5854,7 @@
           <p:cNvPr id="36" name="">
             <a:extLst xmlns:a="http://schemas.openxmlformats.org/drawingml/2006/main">
               <a:ext uri="{FF2B5EF4-FFF2-40B4-BE49-F238E27FC236}">
-                <a16:creationId xmlns:a16="http://schemas.microsoft.com/office/drawing/2014/main" id="{3BEB110D-5ED3-4FCC-B3EE-A5C0486E6AB3}"/>
+                <a16:creationId xmlns:a16="http://schemas.microsoft.com/office/drawing/2014/main" id="{3681415A-C47B-48CF-B349-C9710A200553}"/>
               </a:ext>
             </a:extLst>
           </p:cNvPr>
@@ -5912,7 +5912,7 @@
           <p:cNvPr id="2" name="">
             <a:extLst xmlns:a="http://schemas.openxmlformats.org/drawingml/2006/main">
               <a:ext uri="{FF2B5EF4-FFF2-40B4-BE49-F238E27FC236}">
-                <a16:creationId xmlns:a16="http://schemas.microsoft.com/office/drawing/2014/main" id="{FD67C727-7008-4E3D-8499-0AFB5545312D}"/>
+                <a16:creationId xmlns:a16="http://schemas.microsoft.com/office/drawing/2014/main" id="{5B628B63-F986-4497-888E-EA7124175F51}"/>
               </a:ext>
             </a:extLst>
           </p:cNvPr>
@@ -5970,7 +5970,7 @@
           <p:cNvPr id="3" name="">
             <a:extLst xmlns:a="http://schemas.openxmlformats.org/drawingml/2006/main">
               <a:ext uri="{FF2B5EF4-FFF2-40B4-BE49-F238E27FC236}">
-                <a16:creationId xmlns:a16="http://schemas.microsoft.com/office/drawing/2014/main" id="{C53C908F-BAD4-4E6A-8F7E-220F5EE77BBE}"/>
+                <a16:creationId xmlns:a16="http://schemas.microsoft.com/office/drawing/2014/main" id="{969BA578-FAC1-49AD-B602-D21053B82596}"/>
               </a:ext>
             </a:extLst>
           </p:cNvPr>
@@ -6003,7 +6003,7 @@
           <p:cNvPr id="4" name="">
             <a:extLst xmlns:a="http://schemas.openxmlformats.org/drawingml/2006/main">
               <a:ext uri="{FF2B5EF4-FFF2-40B4-BE49-F238E27FC236}">
-                <a16:creationId xmlns:a16="http://schemas.microsoft.com/office/drawing/2014/main" id="{6F1499C4-946B-4D1C-8E24-D2A431318EE4}"/>
+                <a16:creationId xmlns:a16="http://schemas.microsoft.com/office/drawing/2014/main" id="{3E187B89-FC14-46AF-8FF8-24CF71EB5E74}"/>
               </a:ext>
             </a:extLst>
           </p:cNvPr>
@@ -6061,7 +6061,7 @@
           <p:cNvPr id="5" name="">
             <a:extLst xmlns:a="http://schemas.openxmlformats.org/drawingml/2006/main">
               <a:ext uri="{FF2B5EF4-FFF2-40B4-BE49-F238E27FC236}">
-                <a16:creationId xmlns:a16="http://schemas.microsoft.com/office/drawing/2014/main" id="{152EE2C9-8FB2-472D-AEFE-30B0AE44CB91}"/>
+                <a16:creationId xmlns:a16="http://schemas.microsoft.com/office/drawing/2014/main" id="{4B3E23F5-20A3-4E17-9A1B-979BD71D4EDB}"/>
               </a:ext>
             </a:extLst>
           </p:cNvPr>
@@ -6119,7 +6119,7 @@
           <p:cNvPr id="6" name="">
             <a:extLst xmlns:a="http://schemas.openxmlformats.org/drawingml/2006/main">
               <a:ext uri="{FF2B5EF4-FFF2-40B4-BE49-F238E27FC236}">
-                <a16:creationId xmlns:a16="http://schemas.microsoft.com/office/drawing/2014/main" id="{EACEFDE3-CB75-49B4-A04C-235D8F59AC5E}"/>
+                <a16:creationId xmlns:a16="http://schemas.microsoft.com/office/drawing/2014/main" id="{D8C63759-AE50-4E1E-87A3-BD0B9EB1C81C}"/>
               </a:ext>
             </a:extLst>
           </p:cNvPr>
@@ -6154,7 +6154,7 @@
           <p:cNvPr id="7" name="">
             <a:extLst xmlns:a="http://schemas.openxmlformats.org/drawingml/2006/main">
               <a:ext uri="{FF2B5EF4-FFF2-40B4-BE49-F238E27FC236}">
-                <a16:creationId xmlns:a16="http://schemas.microsoft.com/office/drawing/2014/main" id="{16A26C74-F04E-4B7E-B2EA-F2F325D18F87}"/>
+                <a16:creationId xmlns:a16="http://schemas.microsoft.com/office/drawing/2014/main" id="{8E6DCBFF-837B-41BF-9E9C-80A693135E2B}"/>
               </a:ext>
             </a:extLst>
           </p:cNvPr>
@@ -6212,7 +6212,7 @@
           <p:cNvPr id="8" name="">
             <a:extLst xmlns:a="http://schemas.openxmlformats.org/drawingml/2006/main">
               <a:ext uri="{FF2B5EF4-FFF2-40B4-BE49-F238E27FC236}">
-                <a16:creationId xmlns:a16="http://schemas.microsoft.com/office/drawing/2014/main" id="{4FDC0F03-54B7-4058-88E8-E3DEB6F74414}"/>
+                <a16:creationId xmlns:a16="http://schemas.microsoft.com/office/drawing/2014/main" id="{19F4A6F4-36C3-4153-A870-E51CE9FD9CCE}"/>
               </a:ext>
             </a:extLst>
           </p:cNvPr>
@@ -6243,7 +6243,7 @@
           <p:cNvPr id="9" name="">
             <a:extLst xmlns:a="http://schemas.openxmlformats.org/drawingml/2006/main">
               <a:ext uri="{FF2B5EF4-FFF2-40B4-BE49-F238E27FC236}">
-                <a16:creationId xmlns:a16="http://schemas.microsoft.com/office/drawing/2014/main" id="{313A9F87-272B-49D7-92C7-6D18200D7590}"/>
+                <a16:creationId xmlns:a16="http://schemas.microsoft.com/office/drawing/2014/main" id="{411D4C54-7EFE-4A9D-95E5-D3A6F3D0E452}"/>
               </a:ext>
             </a:extLst>
           </p:cNvPr>
@@ -6301,7 +6301,7 @@
           <p:cNvPr id="10" name="">
             <a:extLst xmlns:a="http://schemas.openxmlformats.org/drawingml/2006/main">
               <a:ext uri="{FF2B5EF4-FFF2-40B4-BE49-F238E27FC236}">
-                <a16:creationId xmlns:a16="http://schemas.microsoft.com/office/drawing/2014/main" id="{2CE516E5-90AC-4D5C-90EA-B103D61DA9FD}"/>
+                <a16:creationId xmlns:a16="http://schemas.microsoft.com/office/drawing/2014/main" id="{8BBA5911-9291-4B3E-B229-AC8CD3EBFC58}"/>
               </a:ext>
             </a:extLst>
           </p:cNvPr>
@@ -6359,7 +6359,7 @@
           <p:cNvPr id="11" name="">
             <a:extLst xmlns:a="http://schemas.openxmlformats.org/drawingml/2006/main">
               <a:ext uri="{FF2B5EF4-FFF2-40B4-BE49-F238E27FC236}">
-                <a16:creationId xmlns:a16="http://schemas.microsoft.com/office/drawing/2014/main" id="{902EF850-E0E8-4E30-B08F-DD675B9D8C4B}"/>
+                <a16:creationId xmlns:a16="http://schemas.microsoft.com/office/drawing/2014/main" id="{5E0C3863-F5C5-4692-8D34-A10EDF017AD8}"/>
               </a:ext>
             </a:extLst>
           </p:cNvPr>
@@ -6417,7 +6417,7 @@
           <p:cNvPr id="12" name="">
             <a:extLst xmlns:a="http://schemas.openxmlformats.org/drawingml/2006/main">
               <a:ext uri="{FF2B5EF4-FFF2-40B4-BE49-F238E27FC236}">
-                <a16:creationId xmlns:a16="http://schemas.microsoft.com/office/drawing/2014/main" id="{D1B5069B-4CB8-4DA4-B18B-26556C5923EA}"/>
+                <a16:creationId xmlns:a16="http://schemas.microsoft.com/office/drawing/2014/main" id="{D06D4711-84A2-40F8-9F18-5D0AB9638578}"/>
               </a:ext>
             </a:extLst>
           </p:cNvPr>
@@ -6452,7 +6452,7 @@
           <p:cNvPr id="13" name="">
             <a:extLst xmlns:a="http://schemas.openxmlformats.org/drawingml/2006/main">
               <a:ext uri="{FF2B5EF4-FFF2-40B4-BE49-F238E27FC236}">
-                <a16:creationId xmlns:a16="http://schemas.microsoft.com/office/drawing/2014/main" id="{3F11C108-CC97-46D8-9811-C2ED8ED3CCE6}"/>
+                <a16:creationId xmlns:a16="http://schemas.microsoft.com/office/drawing/2014/main" id="{C5FC94C4-C4A5-48EB-879E-BCED866099BF}"/>
               </a:ext>
             </a:extLst>
           </p:cNvPr>
@@ -6510,7 +6510,7 @@
           <p:cNvPr id="14" name="">
             <a:extLst xmlns:a="http://schemas.openxmlformats.org/drawingml/2006/main">
               <a:ext uri="{FF2B5EF4-FFF2-40B4-BE49-F238E27FC236}">
-                <a16:creationId xmlns:a16="http://schemas.microsoft.com/office/drawing/2014/main" id="{38AE27CE-408F-44B3-824B-71D45E4D1FF9}"/>
+                <a16:creationId xmlns:a16="http://schemas.microsoft.com/office/drawing/2014/main" id="{38641DDC-F4E2-4E7A-843D-6C75992582C5}"/>
               </a:ext>
             </a:extLst>
           </p:cNvPr>
@@ -6541,7 +6541,7 @@
           <p:cNvPr id="15" name="">
             <a:extLst xmlns:a="http://schemas.openxmlformats.org/drawingml/2006/main">
               <a:ext uri="{FF2B5EF4-FFF2-40B4-BE49-F238E27FC236}">
-                <a16:creationId xmlns:a16="http://schemas.microsoft.com/office/drawing/2014/main" id="{6C40B7C8-5FE4-4D6C-A657-FA6402DA17D9}"/>
+                <a16:creationId xmlns:a16="http://schemas.microsoft.com/office/drawing/2014/main" id="{886FB000-BE6C-408A-8C8E-382C6CC4ED00}"/>
               </a:ext>
             </a:extLst>
           </p:cNvPr>
@@ -6599,7 +6599,7 @@
           <p:cNvPr id="16" name="">
             <a:extLst xmlns:a="http://schemas.openxmlformats.org/drawingml/2006/main">
               <a:ext uri="{FF2B5EF4-FFF2-40B4-BE49-F238E27FC236}">
-                <a16:creationId xmlns:a16="http://schemas.microsoft.com/office/drawing/2014/main" id="{6BBD1E16-528A-455E-89C2-14AB7E8FCCBB}"/>
+                <a16:creationId xmlns:a16="http://schemas.microsoft.com/office/drawing/2014/main" id="{AA16620B-1256-4E6B-8159-835E86F32B14}"/>
               </a:ext>
             </a:extLst>
           </p:cNvPr>
@@ -6657,7 +6657,7 @@
           <p:cNvPr id="17" name="">
             <a:extLst xmlns:a="http://schemas.openxmlformats.org/drawingml/2006/main">
               <a:ext uri="{FF2B5EF4-FFF2-40B4-BE49-F238E27FC236}">
-                <a16:creationId xmlns:a16="http://schemas.microsoft.com/office/drawing/2014/main" id="{F2A57E5E-3E70-4543-A320-D973693BE131}"/>
+                <a16:creationId xmlns:a16="http://schemas.microsoft.com/office/drawing/2014/main" id="{569205B7-7100-4500-AC3F-9A224BAB37DF}"/>
               </a:ext>
             </a:extLst>
           </p:cNvPr>
@@ -6715,7 +6715,7 @@
           <p:cNvPr id="18" name="">
             <a:extLst xmlns:a="http://schemas.openxmlformats.org/drawingml/2006/main">
               <a:ext uri="{FF2B5EF4-FFF2-40B4-BE49-F238E27FC236}">
-                <a16:creationId xmlns:a16="http://schemas.microsoft.com/office/drawing/2014/main" id="{6F95463D-F0F4-4B49-A967-D6665C0D7DF1}"/>
+                <a16:creationId xmlns:a16="http://schemas.microsoft.com/office/drawing/2014/main" id="{7541A163-B8B6-4747-9572-541244705B5F}"/>
               </a:ext>
             </a:extLst>
           </p:cNvPr>
@@ -6750,7 +6750,7 @@
           <p:cNvPr id="19" name="">
             <a:extLst xmlns:a="http://schemas.openxmlformats.org/drawingml/2006/main">
               <a:ext uri="{FF2B5EF4-FFF2-40B4-BE49-F238E27FC236}">
-                <a16:creationId xmlns:a16="http://schemas.microsoft.com/office/drawing/2014/main" id="{4D79FADA-5CC5-476F-8945-6BE5186634A0}"/>
+                <a16:creationId xmlns:a16="http://schemas.microsoft.com/office/drawing/2014/main" id="{DC073F47-8866-40A5-89B8-BDDFC281F2D4}"/>
               </a:ext>
             </a:extLst>
           </p:cNvPr>
@@ -6808,7 +6808,7 @@
           <p:cNvPr id="20" name="">
             <a:extLst xmlns:a="http://schemas.openxmlformats.org/drawingml/2006/main">
               <a:ext uri="{FF2B5EF4-FFF2-40B4-BE49-F238E27FC236}">
-                <a16:creationId xmlns:a16="http://schemas.microsoft.com/office/drawing/2014/main" id="{42C8C122-1160-44F7-9CB1-731814A02178}"/>
+                <a16:creationId xmlns:a16="http://schemas.microsoft.com/office/drawing/2014/main" id="{148824CB-8F8B-488F-812D-D33D16EDB076}"/>
               </a:ext>
             </a:extLst>
           </p:cNvPr>
@@ -6839,7 +6839,7 @@
           <p:cNvPr id="21" name="">
             <a:extLst xmlns:a="http://schemas.openxmlformats.org/drawingml/2006/main">
               <a:ext uri="{FF2B5EF4-FFF2-40B4-BE49-F238E27FC236}">
-                <a16:creationId xmlns:a16="http://schemas.microsoft.com/office/drawing/2014/main" id="{96FF646E-CAEF-43B3-AD54-1D52E33E5672}"/>
+                <a16:creationId xmlns:a16="http://schemas.microsoft.com/office/drawing/2014/main" id="{56AA46B1-E3EE-4395-8BA5-31B92E337A86}"/>
               </a:ext>
             </a:extLst>
           </p:cNvPr>
@@ -6897,7 +6897,7 @@
           <p:cNvPr id="22" name="">
             <a:extLst xmlns:a="http://schemas.openxmlformats.org/drawingml/2006/main">
               <a:ext uri="{FF2B5EF4-FFF2-40B4-BE49-F238E27FC236}">
-                <a16:creationId xmlns:a16="http://schemas.microsoft.com/office/drawing/2014/main" id="{D98AA185-0972-4871-8402-0353C66A7965}"/>
+                <a16:creationId xmlns:a16="http://schemas.microsoft.com/office/drawing/2014/main" id="{7ADF6E47-E16F-4B73-A801-71986E473376}"/>
               </a:ext>
             </a:extLst>
           </p:cNvPr>
@@ -6955,7 +6955,7 @@
           <p:cNvPr id="23" name="">
             <a:extLst xmlns:a="http://schemas.openxmlformats.org/drawingml/2006/main">
               <a:ext uri="{FF2B5EF4-FFF2-40B4-BE49-F238E27FC236}">
-                <a16:creationId xmlns:a16="http://schemas.microsoft.com/office/drawing/2014/main" id="{CD6EE76D-DA3F-42AA-BC6B-C5234580C4B7}"/>
+                <a16:creationId xmlns:a16="http://schemas.microsoft.com/office/drawing/2014/main" id="{24EBE7F2-102B-4591-AE40-A144E5FC5777}"/>
               </a:ext>
             </a:extLst>
           </p:cNvPr>
@@ -7013,7 +7013,7 @@
           <p:cNvPr id="24" name="">
             <a:extLst xmlns:a="http://schemas.openxmlformats.org/drawingml/2006/main">
               <a:ext uri="{FF2B5EF4-FFF2-40B4-BE49-F238E27FC236}">
-                <a16:creationId xmlns:a16="http://schemas.microsoft.com/office/drawing/2014/main" id="{FA63AC2B-3586-41E7-AF88-AFD7860AEA57}"/>
+                <a16:creationId xmlns:a16="http://schemas.microsoft.com/office/drawing/2014/main" id="{A617B562-73EF-4CF5-901B-B6E892C7FC9B}"/>
               </a:ext>
             </a:extLst>
           </p:cNvPr>
@@ -7048,7 +7048,7 @@
           <p:cNvPr id="25" name="">
             <a:extLst xmlns:a="http://schemas.openxmlformats.org/drawingml/2006/main">
               <a:ext uri="{FF2B5EF4-FFF2-40B4-BE49-F238E27FC236}">
-                <a16:creationId xmlns:a16="http://schemas.microsoft.com/office/drawing/2014/main" id="{8D8CED88-A1F5-4F71-AD95-54A0FBDB4718}"/>
+                <a16:creationId xmlns:a16="http://schemas.microsoft.com/office/drawing/2014/main" id="{8BA2CBB5-9AEE-412B-AD68-E82496D8FF86}"/>
               </a:ext>
             </a:extLst>
           </p:cNvPr>
@@ -7106,7 +7106,7 @@
           <p:cNvPr id="26" name="">
             <a:extLst xmlns:a="http://schemas.openxmlformats.org/drawingml/2006/main">
               <a:ext uri="{FF2B5EF4-FFF2-40B4-BE49-F238E27FC236}">
-                <a16:creationId xmlns:a16="http://schemas.microsoft.com/office/drawing/2014/main" id="{D2D9A347-E616-4471-B496-28E4944BC527}"/>
+                <a16:creationId xmlns:a16="http://schemas.microsoft.com/office/drawing/2014/main" id="{D7960C11-5B00-4865-A580-B71D0496395B}"/>
               </a:ext>
             </a:extLst>
           </p:cNvPr>
@@ -7137,7 +7137,7 @@
           <p:cNvPr id="27" name="">
             <a:extLst xmlns:a="http://schemas.openxmlformats.org/drawingml/2006/main">
               <a:ext uri="{FF2B5EF4-FFF2-40B4-BE49-F238E27FC236}">
-                <a16:creationId xmlns:a16="http://schemas.microsoft.com/office/drawing/2014/main" id="{2FB48DB6-9CEB-4A4A-80E2-AF3951D6A69C}"/>
+                <a16:creationId xmlns:a16="http://schemas.microsoft.com/office/drawing/2014/main" id="{EB92FD8D-0820-4EC7-849A-85EFA231EFF2}"/>
               </a:ext>
             </a:extLst>
           </p:cNvPr>
@@ -7195,7 +7195,7 @@
           <p:cNvPr id="28" name="">
             <a:extLst xmlns:a="http://schemas.openxmlformats.org/drawingml/2006/main">
               <a:ext uri="{FF2B5EF4-FFF2-40B4-BE49-F238E27FC236}">
-                <a16:creationId xmlns:a16="http://schemas.microsoft.com/office/drawing/2014/main" id="{D3AA5976-2F0C-4F6C-BCEA-B96CBDE03472}"/>
+                <a16:creationId xmlns:a16="http://schemas.microsoft.com/office/drawing/2014/main" id="{C41ED7AD-267E-46C9-A934-40765134508C}"/>
               </a:ext>
             </a:extLst>
           </p:cNvPr>
@@ -7253,7 +7253,7 @@
           <p:cNvPr id="29" name="">
             <a:extLst xmlns:a="http://schemas.openxmlformats.org/drawingml/2006/main">
               <a:ext uri="{FF2B5EF4-FFF2-40B4-BE49-F238E27FC236}">
-                <a16:creationId xmlns:a16="http://schemas.microsoft.com/office/drawing/2014/main" id="{B2195EA8-D3D1-45CF-8B7B-94E75A526A21}"/>
+                <a16:creationId xmlns:a16="http://schemas.microsoft.com/office/drawing/2014/main" id="{C6EE10F3-574B-4769-A9DD-4B67C6D39D90}"/>
               </a:ext>
             </a:extLst>
           </p:cNvPr>
@@ -7311,7 +7311,7 @@
           <p:cNvPr id="30" name="">
             <a:extLst xmlns:a="http://schemas.openxmlformats.org/drawingml/2006/main">
               <a:ext uri="{FF2B5EF4-FFF2-40B4-BE49-F238E27FC236}">
-                <a16:creationId xmlns:a16="http://schemas.microsoft.com/office/drawing/2014/main" id="{61098FC5-10B0-47EF-8FD7-B1EE1DB74015}"/>
+                <a16:creationId xmlns:a16="http://schemas.microsoft.com/office/drawing/2014/main" id="{34BBB6C9-A547-43F3-B892-106B66B62B5E}"/>
               </a:ext>
             </a:extLst>
           </p:cNvPr>
@@ -7346,7 +7346,7 @@
           <p:cNvPr id="31" name="">
             <a:extLst xmlns:a="http://schemas.openxmlformats.org/drawingml/2006/main">
               <a:ext uri="{FF2B5EF4-FFF2-40B4-BE49-F238E27FC236}">
-                <a16:creationId xmlns:a16="http://schemas.microsoft.com/office/drawing/2014/main" id="{5E5E1BF6-7CED-4BBC-9C6F-94B92EC5DBCC}"/>
+                <a16:creationId xmlns:a16="http://schemas.microsoft.com/office/drawing/2014/main" id="{DE8036F2-ED54-4805-AFB9-DE1D9444F65B}"/>
               </a:ext>
             </a:extLst>
           </p:cNvPr>
@@ -7404,7 +7404,7 @@
           <p:cNvPr id="32" name="">
             <a:extLst xmlns:a="http://schemas.openxmlformats.org/drawingml/2006/main">
               <a:ext uri="{FF2B5EF4-FFF2-40B4-BE49-F238E27FC236}">
-                <a16:creationId xmlns:a16="http://schemas.microsoft.com/office/drawing/2014/main" id="{B498171D-B871-4D94-82D5-9A9D6A72ABD2}"/>
+                <a16:creationId xmlns:a16="http://schemas.microsoft.com/office/drawing/2014/main" id="{2A2497B6-560C-4E4F-ADC6-58B4AF53BDC2}"/>
               </a:ext>
             </a:extLst>
           </p:cNvPr>
@@ -7435,7 +7435,7 @@
           <p:cNvPr id="33" name="">
             <a:extLst xmlns:a="http://schemas.openxmlformats.org/drawingml/2006/main">
               <a:ext uri="{FF2B5EF4-FFF2-40B4-BE49-F238E27FC236}">
-                <a16:creationId xmlns:a16="http://schemas.microsoft.com/office/drawing/2014/main" id="{88C7C19C-F1BA-4D8B-81C9-AB672466593B}"/>
+                <a16:creationId xmlns:a16="http://schemas.microsoft.com/office/drawing/2014/main" id="{9FC58583-28FD-47FC-864E-E005CEB8F1D5}"/>
               </a:ext>
             </a:extLst>
           </p:cNvPr>
@@ -7493,7 +7493,7 @@
           <p:cNvPr id="34" name="">
             <a:extLst xmlns:a="http://schemas.openxmlformats.org/drawingml/2006/main">
               <a:ext uri="{FF2B5EF4-FFF2-40B4-BE49-F238E27FC236}">
-                <a16:creationId xmlns:a16="http://schemas.microsoft.com/office/drawing/2014/main" id="{99F1186E-AA62-477D-B555-98F69E060AE7}"/>
+                <a16:creationId xmlns:a16="http://schemas.microsoft.com/office/drawing/2014/main" id="{7F29E454-DA74-4F48-B628-51F02E5117CA}"/>
               </a:ext>
             </a:extLst>
           </p:cNvPr>
@@ -7551,7 +7551,7 @@
           <p:cNvPr id="35" name="">
             <a:extLst xmlns:a="http://schemas.openxmlformats.org/drawingml/2006/main">
               <a:ext uri="{FF2B5EF4-FFF2-40B4-BE49-F238E27FC236}">
-                <a16:creationId xmlns:a16="http://schemas.microsoft.com/office/drawing/2014/main" id="{2A0A8EC1-7F16-4D9C-AE41-85DD486AC6E3}"/>
+                <a16:creationId xmlns:a16="http://schemas.microsoft.com/office/drawing/2014/main" id="{2476DC1C-CD9A-4EE1-91DE-5892E02F107E}"/>
               </a:ext>
             </a:extLst>
           </p:cNvPr>
@@ -7607,7 +7607,7 @@
     </p:spTree>
     <p:extLst>
       <p:ext uri="{BB962C8B-B14F-4D97-AF65-F5344CB8AC3E}">
-        <p14:creationId xmlns:p14="http://schemas.microsoft.com/office/powerpoint/2010/main" val="791511663"/>
+        <p14:creationId xmlns:p14="http://schemas.microsoft.com/office/powerpoint/2010/main" val="197884021"/>
       </p:ext>
     </p:extLst>
   </p:cSld>
@@ -7638,7 +7638,7 @@
           <p:cNvPr id="38" name="">
             <a:extLst xmlns:a="http://schemas.openxmlformats.org/drawingml/2006/main">
               <a:ext uri="{FF2B5EF4-FFF2-40B4-BE49-F238E27FC236}">
-                <a16:creationId xmlns:a16="http://schemas.microsoft.com/office/drawing/2014/main" id="{F194442B-FF42-465C-B0C5-C73A6F0645CB}"/>
+                <a16:creationId xmlns:a16="http://schemas.microsoft.com/office/drawing/2014/main" id="{5C7966BE-F6E7-4275-9F29-0D657EFDF681}"/>
               </a:ext>
             </a:extLst>
           </p:cNvPr>
@@ -7696,7 +7696,7 @@
           <p:cNvPr id="2" name="">
             <a:extLst xmlns:a="http://schemas.openxmlformats.org/drawingml/2006/main">
               <a:ext uri="{FF2B5EF4-FFF2-40B4-BE49-F238E27FC236}">
-                <a16:creationId xmlns:a16="http://schemas.microsoft.com/office/drawing/2014/main" id="{65B22BF4-E78C-4736-8B5E-4A4795FD75FE}"/>
+                <a16:creationId xmlns:a16="http://schemas.microsoft.com/office/drawing/2014/main" id="{C4FB1E23-50DD-4A7D-9FEF-522B2C17A457}"/>
               </a:ext>
             </a:extLst>
           </p:cNvPr>
@@ -7754,7 +7754,7 @@
           <p:cNvPr id="3" name="">
             <a:extLst xmlns:a="http://schemas.openxmlformats.org/drawingml/2006/main">
               <a:ext uri="{FF2B5EF4-FFF2-40B4-BE49-F238E27FC236}">
-                <a16:creationId xmlns:a16="http://schemas.microsoft.com/office/drawing/2014/main" id="{712070CD-3689-4F48-914E-5F615FF6D6BB}"/>
+                <a16:creationId xmlns:a16="http://schemas.microsoft.com/office/drawing/2014/main" id="{0127C285-556E-4584-9900-737C0E64FBAF}"/>
               </a:ext>
             </a:extLst>
           </p:cNvPr>
@@ -7787,7 +7787,7 @@
           <p:cNvPr id="4" name="">
             <a:extLst xmlns:a="http://schemas.openxmlformats.org/drawingml/2006/main">
               <a:ext uri="{FF2B5EF4-FFF2-40B4-BE49-F238E27FC236}">
-                <a16:creationId xmlns:a16="http://schemas.microsoft.com/office/drawing/2014/main" id="{13C3F611-CB4A-4EB4-BF45-B1AEAD8F688F}"/>
+                <a16:creationId xmlns:a16="http://schemas.microsoft.com/office/drawing/2014/main" id="{052FEFA4-82AE-4A56-A8AF-5C2433FB4A8A}"/>
               </a:ext>
             </a:extLst>
           </p:cNvPr>
@@ -7845,7 +7845,7 @@
           <p:cNvPr id="5" name="">
             <a:extLst xmlns:a="http://schemas.openxmlformats.org/drawingml/2006/main">
               <a:ext uri="{FF2B5EF4-FFF2-40B4-BE49-F238E27FC236}">
-                <a16:creationId xmlns:a16="http://schemas.microsoft.com/office/drawing/2014/main" id="{3AB9431E-0AD1-4382-8AEE-E61D44E46569}"/>
+                <a16:creationId xmlns:a16="http://schemas.microsoft.com/office/drawing/2014/main" id="{ED78E81D-EE1A-4A20-AA0E-EBBD488EF270}"/>
               </a:ext>
             </a:extLst>
           </p:cNvPr>
@@ -7903,7 +7903,7 @@
           <p:cNvPr id="6" name="">
             <a:extLst xmlns:a="http://schemas.openxmlformats.org/drawingml/2006/main">
               <a:ext uri="{FF2B5EF4-FFF2-40B4-BE49-F238E27FC236}">
-                <a16:creationId xmlns:a16="http://schemas.microsoft.com/office/drawing/2014/main" id="{5B12D7A5-0F64-4372-8BDF-A277164B2072}"/>
+                <a16:creationId xmlns:a16="http://schemas.microsoft.com/office/drawing/2014/main" id="{3FDB71A4-6E2E-4019-9D18-D71B7AE8539B}"/>
               </a:ext>
             </a:extLst>
           </p:cNvPr>
@@ -7938,7 +7938,7 @@
           <p:cNvPr id="7" name="">
             <a:extLst xmlns:a="http://schemas.openxmlformats.org/drawingml/2006/main">
               <a:ext uri="{FF2B5EF4-FFF2-40B4-BE49-F238E27FC236}">
-                <a16:creationId xmlns:a16="http://schemas.microsoft.com/office/drawing/2014/main" id="{A0051F7B-A89B-4922-8D74-5C9A3E2EE486}"/>
+                <a16:creationId xmlns:a16="http://schemas.microsoft.com/office/drawing/2014/main" id="{F5AEDBFE-3EE6-458F-B62F-F3C2FAE408C5}"/>
               </a:ext>
             </a:extLst>
           </p:cNvPr>
@@ -7996,7 +7996,7 @@
           <p:cNvPr id="8" name="">
             <a:extLst xmlns:a="http://schemas.openxmlformats.org/drawingml/2006/main">
               <a:ext uri="{FF2B5EF4-FFF2-40B4-BE49-F238E27FC236}">
-                <a16:creationId xmlns:a16="http://schemas.microsoft.com/office/drawing/2014/main" id="{8CA6D3EB-D3F5-4EE1-9D93-C36E69C57D86}"/>
+                <a16:creationId xmlns:a16="http://schemas.microsoft.com/office/drawing/2014/main" id="{E46F4804-81BD-4291-9CC4-0CB86EAAC9AF}"/>
               </a:ext>
             </a:extLst>
           </p:cNvPr>
@@ -8054,7 +8054,7 @@
           <p:cNvPr id="9" name="">
             <a:extLst xmlns:a="http://schemas.openxmlformats.org/drawingml/2006/main">
               <a:ext uri="{FF2B5EF4-FFF2-40B4-BE49-F238E27FC236}">
-                <a16:creationId xmlns:a16="http://schemas.microsoft.com/office/drawing/2014/main" id="{68C0E1F2-1DDE-4B08-AAA4-0912521EE3A3}"/>
+                <a16:creationId xmlns:a16="http://schemas.microsoft.com/office/drawing/2014/main" id="{05C2BB1D-7F87-45DC-B23D-9F77B266DE73}"/>
               </a:ext>
             </a:extLst>
           </p:cNvPr>
@@ -8112,7 +8112,7 @@
           <p:cNvPr id="10" name="">
             <a:extLst xmlns:a="http://schemas.openxmlformats.org/drawingml/2006/main">
               <a:ext uri="{FF2B5EF4-FFF2-40B4-BE49-F238E27FC236}">
-                <a16:creationId xmlns:a16="http://schemas.microsoft.com/office/drawing/2014/main" id="{D7AF4605-1E89-471C-936C-E45092309A9B}"/>
+                <a16:creationId xmlns:a16="http://schemas.microsoft.com/office/drawing/2014/main" id="{068EA105-2A6A-492F-A1F1-4A26259851F4}"/>
               </a:ext>
             </a:extLst>
           </p:cNvPr>
@@ -8147,7 +8147,7 @@
           <p:cNvPr id="11" name="">
             <a:extLst xmlns:a="http://schemas.openxmlformats.org/drawingml/2006/main">
               <a:ext uri="{FF2B5EF4-FFF2-40B4-BE49-F238E27FC236}">
-                <a16:creationId xmlns:a16="http://schemas.microsoft.com/office/drawing/2014/main" id="{5BBEB97B-4DC5-47AC-9564-3EBA9275E27D}"/>
+                <a16:creationId xmlns:a16="http://schemas.microsoft.com/office/drawing/2014/main" id="{337B57D8-0EE4-4A99-9874-ABABA42E940A}"/>
               </a:ext>
             </a:extLst>
           </p:cNvPr>
@@ -8205,7 +8205,7 @@
           <p:cNvPr id="12" name="">
             <a:extLst xmlns:a="http://schemas.openxmlformats.org/drawingml/2006/main">
               <a:ext uri="{FF2B5EF4-FFF2-40B4-BE49-F238E27FC236}">
-                <a16:creationId xmlns:a16="http://schemas.microsoft.com/office/drawing/2014/main" id="{580750B0-E32D-4320-BF7D-B545B65926AD}"/>
+                <a16:creationId xmlns:a16="http://schemas.microsoft.com/office/drawing/2014/main" id="{28E26364-2D6B-4C6A-87C2-681CF630D979}"/>
               </a:ext>
             </a:extLst>
           </p:cNvPr>
@@ -8263,7 +8263,7 @@
           <p:cNvPr id="13" name="">
             <a:extLst xmlns:a="http://schemas.openxmlformats.org/drawingml/2006/main">
               <a:ext uri="{FF2B5EF4-FFF2-40B4-BE49-F238E27FC236}">
-                <a16:creationId xmlns:a16="http://schemas.microsoft.com/office/drawing/2014/main" id="{05FA55BD-67DA-4E0F-8DAC-1DBF23EFFF7F}"/>
+                <a16:creationId xmlns:a16="http://schemas.microsoft.com/office/drawing/2014/main" id="{C56382CB-BF84-4A1E-885E-D348C249EC25}"/>
               </a:ext>
             </a:extLst>
           </p:cNvPr>
@@ -8321,7 +8321,7 @@
           <p:cNvPr id="14" name="">
             <a:extLst xmlns:a="http://schemas.openxmlformats.org/drawingml/2006/main">
               <a:ext uri="{FF2B5EF4-FFF2-40B4-BE49-F238E27FC236}">
-                <a16:creationId xmlns:a16="http://schemas.microsoft.com/office/drawing/2014/main" id="{DBE85D3A-F024-4178-A55E-9B9301C432D2}"/>
+                <a16:creationId xmlns:a16="http://schemas.microsoft.com/office/drawing/2014/main" id="{EF6DB17E-42F5-4C87-A7F6-2EF69AD065EA}"/>
               </a:ext>
             </a:extLst>
           </p:cNvPr>
@@ -8356,7 +8356,7 @@
           <p:cNvPr id="15" name="">
             <a:extLst xmlns:a="http://schemas.openxmlformats.org/drawingml/2006/main">
               <a:ext uri="{FF2B5EF4-FFF2-40B4-BE49-F238E27FC236}">
-                <a16:creationId xmlns:a16="http://schemas.microsoft.com/office/drawing/2014/main" id="{24694AD7-24D8-4D53-B1A5-434452AAC09E}"/>
+                <a16:creationId xmlns:a16="http://schemas.microsoft.com/office/drawing/2014/main" id="{5A3F3552-0036-4B62-8296-78A6D200E98C}"/>
               </a:ext>
             </a:extLst>
           </p:cNvPr>
@@ -8414,7 +8414,7 @@
           <p:cNvPr id="16" name="">
             <a:extLst xmlns:a="http://schemas.openxmlformats.org/drawingml/2006/main">
               <a:ext uri="{FF2B5EF4-FFF2-40B4-BE49-F238E27FC236}">
-                <a16:creationId xmlns:a16="http://schemas.microsoft.com/office/drawing/2014/main" id="{21F10727-ED98-4965-A7E5-133BBE577F92}"/>
+                <a16:creationId xmlns:a16="http://schemas.microsoft.com/office/drawing/2014/main" id="{4F306799-F3C0-42AF-9F97-39066BACA698}"/>
               </a:ext>
             </a:extLst>
           </p:cNvPr>
@@ -8472,7 +8472,7 @@
           <p:cNvPr id="17" name="">
             <a:extLst xmlns:a="http://schemas.openxmlformats.org/drawingml/2006/main">
               <a:ext uri="{FF2B5EF4-FFF2-40B4-BE49-F238E27FC236}">
-                <a16:creationId xmlns:a16="http://schemas.microsoft.com/office/drawing/2014/main" id="{84EFA18A-F8DF-4126-84C3-BA11B7950895}"/>
+                <a16:creationId xmlns:a16="http://schemas.microsoft.com/office/drawing/2014/main" id="{F8032C06-B080-4C76-A1C7-10EE16EEE21E}"/>
               </a:ext>
             </a:extLst>
           </p:cNvPr>
@@ -8530,7 +8530,7 @@
           <p:cNvPr id="18" name="">
             <a:extLst xmlns:a="http://schemas.openxmlformats.org/drawingml/2006/main">
               <a:ext uri="{FF2B5EF4-FFF2-40B4-BE49-F238E27FC236}">
-                <a16:creationId xmlns:a16="http://schemas.microsoft.com/office/drawing/2014/main" id="{13400944-4946-40CE-B2E6-C0F2AA111DF4}"/>
+                <a16:creationId xmlns:a16="http://schemas.microsoft.com/office/drawing/2014/main" id="{F427C986-193D-44CE-978C-39E77C4D9261}"/>
               </a:ext>
             </a:extLst>
           </p:cNvPr>
@@ -8565,7 +8565,7 @@
           <p:cNvPr id="19" name="">
             <a:extLst xmlns:a="http://schemas.openxmlformats.org/drawingml/2006/main">
               <a:ext uri="{FF2B5EF4-FFF2-40B4-BE49-F238E27FC236}">
-                <a16:creationId xmlns:a16="http://schemas.microsoft.com/office/drawing/2014/main" id="{45183E8F-0D11-4CB4-9FDE-BE02BF59CAEF}"/>
+                <a16:creationId xmlns:a16="http://schemas.microsoft.com/office/drawing/2014/main" id="{9DE61E86-E1D5-4344-8AE7-329AE3F4A0FC}"/>
               </a:ext>
             </a:extLst>
           </p:cNvPr>
@@ -8623,7 +8623,7 @@
           <p:cNvPr id="20" name="">
             <a:extLst xmlns:a="http://schemas.openxmlformats.org/drawingml/2006/main">
               <a:ext uri="{FF2B5EF4-FFF2-40B4-BE49-F238E27FC236}">
-                <a16:creationId xmlns:a16="http://schemas.microsoft.com/office/drawing/2014/main" id="{81963739-0422-4B66-B247-BA8DBD846202}"/>
+                <a16:creationId xmlns:a16="http://schemas.microsoft.com/office/drawing/2014/main" id="{7C2F9C5D-DC48-438C-9034-8BF1A889154C}"/>
               </a:ext>
             </a:extLst>
           </p:cNvPr>
@@ -8681,7 +8681,7 @@
           <p:cNvPr id="21" name="">
             <a:extLst xmlns:a="http://schemas.openxmlformats.org/drawingml/2006/main">
               <a:ext uri="{FF2B5EF4-FFF2-40B4-BE49-F238E27FC236}">
-                <a16:creationId xmlns:a16="http://schemas.microsoft.com/office/drawing/2014/main" id="{1CE88807-6852-410F-8274-D9049B1B6A15}"/>
+                <a16:creationId xmlns:a16="http://schemas.microsoft.com/office/drawing/2014/main" id="{4F9F1C82-E386-43FD-BB1F-ECD6E32C8466}"/>
               </a:ext>
             </a:extLst>
           </p:cNvPr>
@@ -8739,7 +8739,7 @@
           <p:cNvPr id="22" name="">
             <a:extLst xmlns:a="http://schemas.openxmlformats.org/drawingml/2006/main">
               <a:ext uri="{FF2B5EF4-FFF2-40B4-BE49-F238E27FC236}">
-                <a16:creationId xmlns:a16="http://schemas.microsoft.com/office/drawing/2014/main" id="{3BDF37A0-E997-47BD-AF5B-D8C3973BE2DB}"/>
+                <a16:creationId xmlns:a16="http://schemas.microsoft.com/office/drawing/2014/main" id="{D163CF40-3825-4DD3-BE35-B80E53971108}"/>
               </a:ext>
             </a:extLst>
           </p:cNvPr>
@@ -8774,7 +8774,7 @@
           <p:cNvPr id="23" name="">
             <a:extLst xmlns:a="http://schemas.openxmlformats.org/drawingml/2006/main">
               <a:ext uri="{FF2B5EF4-FFF2-40B4-BE49-F238E27FC236}">
-                <a16:creationId xmlns:a16="http://schemas.microsoft.com/office/drawing/2014/main" id="{7B3CDECD-DFEA-4F66-9399-CF9507985907}"/>
+                <a16:creationId xmlns:a16="http://schemas.microsoft.com/office/drawing/2014/main" id="{336B93FD-0BE2-4943-B4DB-7E88AA581D24}"/>
               </a:ext>
             </a:extLst>
           </p:cNvPr>
@@ -8832,7 +8832,7 @@
           <p:cNvPr id="24" name="">
             <a:extLst xmlns:a="http://schemas.openxmlformats.org/drawingml/2006/main">
               <a:ext uri="{FF2B5EF4-FFF2-40B4-BE49-F238E27FC236}">
-                <a16:creationId xmlns:a16="http://schemas.microsoft.com/office/drawing/2014/main" id="{BD12EC40-EABD-42A8-99BB-8B497F400BE9}"/>
+                <a16:creationId xmlns:a16="http://schemas.microsoft.com/office/drawing/2014/main" id="{8BC542D6-022C-4369-B101-639D4F30CB7C}"/>
               </a:ext>
             </a:extLst>
           </p:cNvPr>
@@ -8890,7 +8890,7 @@
           <p:cNvPr id="25" name="">
             <a:extLst xmlns:a="http://schemas.openxmlformats.org/drawingml/2006/main">
               <a:ext uri="{FF2B5EF4-FFF2-40B4-BE49-F238E27FC236}">
-                <a16:creationId xmlns:a16="http://schemas.microsoft.com/office/drawing/2014/main" id="{2C27D37D-4173-442C-AFE4-7DB5AB5E5699}"/>
+                <a16:creationId xmlns:a16="http://schemas.microsoft.com/office/drawing/2014/main" id="{42D586BC-4DD2-4F26-8730-BB6FB59E0F88}"/>
               </a:ext>
             </a:extLst>
           </p:cNvPr>
@@ -8948,7 +8948,7 @@
           <p:cNvPr id="26" name="">
             <a:extLst xmlns:a="http://schemas.openxmlformats.org/drawingml/2006/main">
               <a:ext uri="{FF2B5EF4-FFF2-40B4-BE49-F238E27FC236}">
-                <a16:creationId xmlns:a16="http://schemas.microsoft.com/office/drawing/2014/main" id="{E1E61EE3-FBDA-48D0-AEC4-ED57F088FD14}"/>
+                <a16:creationId xmlns:a16="http://schemas.microsoft.com/office/drawing/2014/main" id="{C573DFC1-3758-4A8A-AB53-B9E3F977DBCB}"/>
               </a:ext>
             </a:extLst>
           </p:cNvPr>
@@ -8983,7 +8983,7 @@
           <p:cNvPr id="27" name="">
             <a:extLst xmlns:a="http://schemas.openxmlformats.org/drawingml/2006/main">
               <a:ext uri="{FF2B5EF4-FFF2-40B4-BE49-F238E27FC236}">
-                <a16:creationId xmlns:a16="http://schemas.microsoft.com/office/drawing/2014/main" id="{4409565E-AA43-4172-8E55-EACA02F76ADE}"/>
+                <a16:creationId xmlns:a16="http://schemas.microsoft.com/office/drawing/2014/main" id="{73B4947F-A5C9-4EC9-AEFD-07AAC1506802}"/>
               </a:ext>
             </a:extLst>
           </p:cNvPr>
@@ -9041,7 +9041,7 @@
           <p:cNvPr id="28" name="">
             <a:extLst xmlns:a="http://schemas.openxmlformats.org/drawingml/2006/main">
               <a:ext uri="{FF2B5EF4-FFF2-40B4-BE49-F238E27FC236}">
-                <a16:creationId xmlns:a16="http://schemas.microsoft.com/office/drawing/2014/main" id="{CFE234A7-27A3-44CA-9B26-7047F2EF485E}"/>
+                <a16:creationId xmlns:a16="http://schemas.microsoft.com/office/drawing/2014/main" id="{4E0B8830-0F8E-4394-93B2-A843E4C1361B}"/>
               </a:ext>
             </a:extLst>
           </p:cNvPr>
@@ -9099,7 +9099,7 @@
           <p:cNvPr id="29" name="">
             <a:extLst xmlns:a="http://schemas.openxmlformats.org/drawingml/2006/main">
               <a:ext uri="{FF2B5EF4-FFF2-40B4-BE49-F238E27FC236}">
-                <a16:creationId xmlns:a16="http://schemas.microsoft.com/office/drawing/2014/main" id="{1AA1218F-E5BC-4B55-A0E6-2C119F728F29}"/>
+                <a16:creationId xmlns:a16="http://schemas.microsoft.com/office/drawing/2014/main" id="{BD294660-AB5F-458A-853B-5BC2B20B6BFA}"/>
               </a:ext>
             </a:extLst>
           </p:cNvPr>
@@ -9157,7 +9157,7 @@
           <p:cNvPr id="30" name="">
             <a:extLst xmlns:a="http://schemas.openxmlformats.org/drawingml/2006/main">
               <a:ext uri="{FF2B5EF4-FFF2-40B4-BE49-F238E27FC236}">
-                <a16:creationId xmlns:a16="http://schemas.microsoft.com/office/drawing/2014/main" id="{DC83FE25-8B90-46F7-AE36-A57CB834AA04}"/>
+                <a16:creationId xmlns:a16="http://schemas.microsoft.com/office/drawing/2014/main" id="{4ACC3700-B505-4E96-8435-478664639B3C}"/>
               </a:ext>
             </a:extLst>
           </p:cNvPr>
@@ -9192,7 +9192,7 @@
           <p:cNvPr id="31" name="">
             <a:extLst xmlns:a="http://schemas.openxmlformats.org/drawingml/2006/main">
               <a:ext uri="{FF2B5EF4-FFF2-40B4-BE49-F238E27FC236}">
-                <a16:creationId xmlns:a16="http://schemas.microsoft.com/office/drawing/2014/main" id="{592D2ACF-9E3E-47EC-9FA2-754B4207C42F}"/>
+                <a16:creationId xmlns:a16="http://schemas.microsoft.com/office/drawing/2014/main" id="{12ED500C-6F23-4F19-998A-099C9028C478}"/>
               </a:ext>
             </a:extLst>
           </p:cNvPr>
@@ -9250,7 +9250,7 @@
           <p:cNvPr id="32" name="">
             <a:extLst xmlns:a="http://schemas.openxmlformats.org/drawingml/2006/main">
               <a:ext uri="{FF2B5EF4-FFF2-40B4-BE49-F238E27FC236}">
-                <a16:creationId xmlns:a16="http://schemas.microsoft.com/office/drawing/2014/main" id="{B5D2F292-5604-4676-BD79-7BE1C090854F}"/>
+                <a16:creationId xmlns:a16="http://schemas.microsoft.com/office/drawing/2014/main" id="{44B37609-9F39-435E-BCB6-656C4D3DD4AC}"/>
               </a:ext>
             </a:extLst>
           </p:cNvPr>
@@ -9308,7 +9308,7 @@
           <p:cNvPr id="33" name="">
             <a:extLst xmlns:a="http://schemas.openxmlformats.org/drawingml/2006/main">
               <a:ext uri="{FF2B5EF4-FFF2-40B4-BE49-F238E27FC236}">
-                <a16:creationId xmlns:a16="http://schemas.microsoft.com/office/drawing/2014/main" id="{401DB4E4-A939-46DD-9AE3-CCE5C38B7152}"/>
+                <a16:creationId xmlns:a16="http://schemas.microsoft.com/office/drawing/2014/main" id="{595DC5D8-4D67-4878-9360-AE854745A9C0}"/>
               </a:ext>
             </a:extLst>
           </p:cNvPr>
@@ -9366,7 +9366,7 @@
           <p:cNvPr id="34" name="">
             <a:extLst xmlns:a="http://schemas.openxmlformats.org/drawingml/2006/main">
               <a:ext uri="{FF2B5EF4-FFF2-40B4-BE49-F238E27FC236}">
-                <a16:creationId xmlns:a16="http://schemas.microsoft.com/office/drawing/2014/main" id="{C2AB0412-4EDC-4272-8EAE-745143DB4EC7}"/>
+                <a16:creationId xmlns:a16="http://schemas.microsoft.com/office/drawing/2014/main" id="{455673E3-2CB6-4F4D-A552-E66FDB0DF63E}"/>
               </a:ext>
             </a:extLst>
           </p:cNvPr>
@@ -9401,7 +9401,7 @@
           <p:cNvPr id="35" name="">
             <a:extLst xmlns:a="http://schemas.openxmlformats.org/drawingml/2006/main">
               <a:ext uri="{FF2B5EF4-FFF2-40B4-BE49-F238E27FC236}">
-                <a16:creationId xmlns:a16="http://schemas.microsoft.com/office/drawing/2014/main" id="{F5488B4B-CD56-48C2-9622-31E32CA06D02}"/>
+                <a16:creationId xmlns:a16="http://schemas.microsoft.com/office/drawing/2014/main" id="{8A3B528A-A47F-4E07-A5DC-CD43345BB8ED}"/>
               </a:ext>
             </a:extLst>
           </p:cNvPr>
@@ -9459,7 +9459,7 @@
           <p:cNvPr id="36" name="">
             <a:extLst xmlns:a="http://schemas.openxmlformats.org/drawingml/2006/main">
               <a:ext uri="{FF2B5EF4-FFF2-40B4-BE49-F238E27FC236}">
-                <a16:creationId xmlns:a16="http://schemas.microsoft.com/office/drawing/2014/main" id="{3461AE90-7421-46C5-BE58-5E1E2CE23864}"/>
+                <a16:creationId xmlns:a16="http://schemas.microsoft.com/office/drawing/2014/main" id="{78B6B3C0-530C-457A-9695-16A8A21C4FDF}"/>
               </a:ext>
             </a:extLst>
           </p:cNvPr>
@@ -9517,7 +9517,7 @@
           <p:cNvPr id="37" name="">
             <a:extLst xmlns:a="http://schemas.openxmlformats.org/drawingml/2006/main">
               <a:ext uri="{FF2B5EF4-FFF2-40B4-BE49-F238E27FC236}">
-                <a16:creationId xmlns:a16="http://schemas.microsoft.com/office/drawing/2014/main" id="{9DB2F312-9D15-4ACC-9160-FFE098CCA07B}"/>
+                <a16:creationId xmlns:a16="http://schemas.microsoft.com/office/drawing/2014/main" id="{9EFED0E1-9F5E-4F5D-8040-397C74E45F66}"/>
               </a:ext>
             </a:extLst>
           </p:cNvPr>
@@ -9573,7 +9573,7 @@
     </p:spTree>
     <p:extLst>
       <p:ext uri="{BB962C8B-B14F-4D97-AF65-F5344CB8AC3E}">
-        <p14:creationId xmlns:p14="http://schemas.microsoft.com/office/powerpoint/2010/main" val="2100173088"/>
+        <p14:creationId xmlns:p14="http://schemas.microsoft.com/office/powerpoint/2010/main" val="399548990"/>
       </p:ext>
     </p:extLst>
   </p:cSld>
@@ -9604,7 +9604,7 @@
           <p:cNvPr id="19" name="">
             <a:extLst xmlns:a="http://schemas.openxmlformats.org/drawingml/2006/main">
               <a:ext uri="{FF2B5EF4-FFF2-40B4-BE49-F238E27FC236}">
-                <a16:creationId xmlns:a16="http://schemas.microsoft.com/office/drawing/2014/main" id="{54A30224-62AE-433D-AF16-DAC1E3EF8388}"/>
+                <a16:creationId xmlns:a16="http://schemas.microsoft.com/office/drawing/2014/main" id="{96004C79-1B60-4852-B22D-842F920AC963}"/>
               </a:ext>
             </a:extLst>
           </p:cNvPr>
@@ -9662,7 +9662,7 @@
           <p:cNvPr id="2" name="">
             <a:extLst xmlns:a="http://schemas.openxmlformats.org/drawingml/2006/main">
               <a:ext uri="{FF2B5EF4-FFF2-40B4-BE49-F238E27FC236}">
-                <a16:creationId xmlns:a16="http://schemas.microsoft.com/office/drawing/2014/main" id="{81E11450-AC91-4809-B29F-D82C8C2475A8}"/>
+                <a16:creationId xmlns:a16="http://schemas.microsoft.com/office/drawing/2014/main" id="{D15C5106-4820-4717-828E-70891A3ACEC7}"/>
               </a:ext>
             </a:extLst>
           </p:cNvPr>
@@ -9720,7 +9720,7 @@
           <p:cNvPr id="3" name="">
             <a:extLst xmlns:a="http://schemas.openxmlformats.org/drawingml/2006/main">
               <a:ext uri="{FF2B5EF4-FFF2-40B4-BE49-F238E27FC236}">
-                <a16:creationId xmlns:a16="http://schemas.microsoft.com/office/drawing/2014/main" id="{70E3289D-659B-4139-AB1A-C42D4441C0AE}"/>
+                <a16:creationId xmlns:a16="http://schemas.microsoft.com/office/drawing/2014/main" id="{8C0F153F-5DC9-4F9B-84AE-06EA2B9EA7DF}"/>
               </a:ext>
             </a:extLst>
           </p:cNvPr>
@@ -9753,7 +9753,7 @@
           <p:cNvPr id="4" name="">
             <a:extLst xmlns:a="http://schemas.openxmlformats.org/drawingml/2006/main">
               <a:ext uri="{FF2B5EF4-FFF2-40B4-BE49-F238E27FC236}">
-                <a16:creationId xmlns:a16="http://schemas.microsoft.com/office/drawing/2014/main" id="{3ACBED6E-93FC-43DF-861C-3D97F2E544E1}"/>
+                <a16:creationId xmlns:a16="http://schemas.microsoft.com/office/drawing/2014/main" id="{70C5ED0E-1535-4547-9023-BCB29088FE91}"/>
               </a:ext>
             </a:extLst>
           </p:cNvPr>
@@ -9811,7 +9811,7 @@
           <p:cNvPr id="5" name="">
             <a:extLst xmlns:a="http://schemas.openxmlformats.org/drawingml/2006/main">
               <a:ext uri="{FF2B5EF4-FFF2-40B4-BE49-F238E27FC236}">
-                <a16:creationId xmlns:a16="http://schemas.microsoft.com/office/drawing/2014/main" id="{F90F093A-388B-46E0-AAAB-D8B6B428A093}"/>
+                <a16:creationId xmlns:a16="http://schemas.microsoft.com/office/drawing/2014/main" id="{AF0E66C6-BAF3-4EE2-8577-8B648D8A13E5}"/>
               </a:ext>
             </a:extLst>
           </p:cNvPr>
@@ -9869,7 +9869,7 @@
           <p:cNvPr id="6" name="">
             <a:extLst xmlns:a="http://schemas.openxmlformats.org/drawingml/2006/main">
               <a:ext uri="{FF2B5EF4-FFF2-40B4-BE49-F238E27FC236}">
-                <a16:creationId xmlns:a16="http://schemas.microsoft.com/office/drawing/2014/main" id="{DD307F61-1442-46BF-B3C8-8CEB74630C0C}"/>
+                <a16:creationId xmlns:a16="http://schemas.microsoft.com/office/drawing/2014/main" id="{37E8C6A5-ECEF-47C9-90AF-AEE12A4FA66B}"/>
               </a:ext>
             </a:extLst>
           </p:cNvPr>
@@ -9904,7 +9904,7 @@
           <p:cNvPr id="7" name="">
             <a:extLst xmlns:a="http://schemas.openxmlformats.org/drawingml/2006/main">
               <a:ext uri="{FF2B5EF4-FFF2-40B4-BE49-F238E27FC236}">
-                <a16:creationId xmlns:a16="http://schemas.microsoft.com/office/drawing/2014/main" id="{3C7321B4-0433-4388-BECC-9CE98E1E733F}"/>
+                <a16:creationId xmlns:a16="http://schemas.microsoft.com/office/drawing/2014/main" id="{E011C251-E744-4245-AA29-3DD15A0548AA}"/>
               </a:ext>
             </a:extLst>
           </p:cNvPr>
@@ -9937,7 +9937,7 @@
           <p:cNvPr id="8" name="">
             <a:extLst xmlns:a="http://schemas.openxmlformats.org/drawingml/2006/main">
               <a:ext uri="{FF2B5EF4-FFF2-40B4-BE49-F238E27FC236}">
-                <a16:creationId xmlns:a16="http://schemas.microsoft.com/office/drawing/2014/main" id="{A1338E85-4616-41E8-86E1-F2EC338252D8}"/>
+                <a16:creationId xmlns:a16="http://schemas.microsoft.com/office/drawing/2014/main" id="{41D44825-3AA5-49B5-ABC0-0B016323C32F}"/>
               </a:ext>
             </a:extLst>
           </p:cNvPr>
@@ -9995,7 +9995,7 @@
           <p:cNvPr id="9" name="">
             <a:extLst xmlns:a="http://schemas.openxmlformats.org/drawingml/2006/main">
               <a:ext uri="{FF2B5EF4-FFF2-40B4-BE49-F238E27FC236}">
-                <a16:creationId xmlns:a16="http://schemas.microsoft.com/office/drawing/2014/main" id="{1576859C-4D8A-495C-ACC7-CCE0239C4704}"/>
+                <a16:creationId xmlns:a16="http://schemas.microsoft.com/office/drawing/2014/main" id="{5ED0B832-251F-45A0-988B-3CA3BC598BAF}"/>
               </a:ext>
             </a:extLst>
           </p:cNvPr>
@@ -10070,7 +10070,7 @@
           <p:cNvPr id="10" name="">
             <a:extLst xmlns:a="http://schemas.openxmlformats.org/drawingml/2006/main">
               <a:ext uri="{FF2B5EF4-FFF2-40B4-BE49-F238E27FC236}">
-                <a16:creationId xmlns:a16="http://schemas.microsoft.com/office/drawing/2014/main" id="{62B0CBA4-187C-412B-A3EF-7D7D1BD0E20F}"/>
+                <a16:creationId xmlns:a16="http://schemas.microsoft.com/office/drawing/2014/main" id="{959DBB76-A691-4C95-963A-7B8D20803606}"/>
               </a:ext>
             </a:extLst>
           </p:cNvPr>
@@ -10105,7 +10105,7 @@
           <p:cNvPr id="11" name="">
             <a:extLst xmlns:a="http://schemas.openxmlformats.org/drawingml/2006/main">
               <a:ext uri="{FF2B5EF4-FFF2-40B4-BE49-F238E27FC236}">
-                <a16:creationId xmlns:a16="http://schemas.microsoft.com/office/drawing/2014/main" id="{CC96ADD1-DFD8-4750-BE36-61A9B9EF7031}"/>
+                <a16:creationId xmlns:a16="http://schemas.microsoft.com/office/drawing/2014/main" id="{03B726C1-F651-4EBE-AEC7-29E710761C4A}"/>
               </a:ext>
             </a:extLst>
           </p:cNvPr>
@@ -10138,7 +10138,7 @@
           <p:cNvPr id="12" name="">
             <a:extLst xmlns:a="http://schemas.openxmlformats.org/drawingml/2006/main">
               <a:ext uri="{FF2B5EF4-FFF2-40B4-BE49-F238E27FC236}">
-                <a16:creationId xmlns:a16="http://schemas.microsoft.com/office/drawing/2014/main" id="{785B24DF-A4FC-4D72-91DA-BEA9DA55585F}"/>
+                <a16:creationId xmlns:a16="http://schemas.microsoft.com/office/drawing/2014/main" id="{4637E8F2-7D05-43F0-BEE1-6E117072455D}"/>
               </a:ext>
             </a:extLst>
           </p:cNvPr>
@@ -10196,7 +10196,7 @@
           <p:cNvPr id="13" name="">
             <a:extLst xmlns:a="http://schemas.openxmlformats.org/drawingml/2006/main">
               <a:ext uri="{FF2B5EF4-FFF2-40B4-BE49-F238E27FC236}">
-                <a16:creationId xmlns:a16="http://schemas.microsoft.com/office/drawing/2014/main" id="{D5EEF78F-C5C7-4E61-B442-B230916E71BA}"/>
+                <a16:creationId xmlns:a16="http://schemas.microsoft.com/office/drawing/2014/main" id="{3620DF2C-4568-4465-84DB-DCF6095C2B4D}"/>
               </a:ext>
             </a:extLst>
           </p:cNvPr>
@@ -10254,7 +10254,7 @@
           <p:cNvPr id="14" name="">
             <a:extLst xmlns:a="http://schemas.openxmlformats.org/drawingml/2006/main">
               <a:ext uri="{FF2B5EF4-FFF2-40B4-BE49-F238E27FC236}">
-                <a16:creationId xmlns:a16="http://schemas.microsoft.com/office/drawing/2014/main" id="{2AF381E3-E872-4A7D-80B3-F68B5FD5BED0}"/>
+                <a16:creationId xmlns:a16="http://schemas.microsoft.com/office/drawing/2014/main" id="{E5D939EF-FCFE-4C5F-850D-8AEAF3E156F9}"/>
               </a:ext>
             </a:extLst>
           </p:cNvPr>
@@ -10289,7 +10289,7 @@
           <p:cNvPr id="15" name="">
             <a:extLst xmlns:a="http://schemas.openxmlformats.org/drawingml/2006/main">
               <a:ext uri="{FF2B5EF4-FFF2-40B4-BE49-F238E27FC236}">
-                <a16:creationId xmlns:a16="http://schemas.microsoft.com/office/drawing/2014/main" id="{D33F1179-CDF1-403A-B44F-FC73C0609206}"/>
+                <a16:creationId xmlns:a16="http://schemas.microsoft.com/office/drawing/2014/main" id="{2CEE4498-62FF-47AC-BD01-7B15C569A67F}"/>
               </a:ext>
             </a:extLst>
           </p:cNvPr>
@@ -10322,7 +10322,7 @@
           <p:cNvPr id="16" name="">
             <a:extLst xmlns:a="http://schemas.openxmlformats.org/drawingml/2006/main">
               <a:ext uri="{FF2B5EF4-FFF2-40B4-BE49-F238E27FC236}">
-                <a16:creationId xmlns:a16="http://schemas.microsoft.com/office/drawing/2014/main" id="{020472D1-ED61-4B04-91DC-4EFC6A5D046A}"/>
+                <a16:creationId xmlns:a16="http://schemas.microsoft.com/office/drawing/2014/main" id="{07C3A1E4-952E-4705-82C2-7A6B11C64EC2}"/>
               </a:ext>
             </a:extLst>
           </p:cNvPr>
@@ -10380,7 +10380,7 @@
           <p:cNvPr id="17" name="">
             <a:extLst xmlns:a="http://schemas.openxmlformats.org/drawingml/2006/main">
               <a:ext uri="{FF2B5EF4-FFF2-40B4-BE49-F238E27FC236}">
-                <a16:creationId xmlns:a16="http://schemas.microsoft.com/office/drawing/2014/main" id="{FBFF4803-6411-4F47-A7E8-5A74DDF5DEB0}"/>
+                <a16:creationId xmlns:a16="http://schemas.microsoft.com/office/drawing/2014/main" id="{7ABB6F1D-1450-450F-91EE-8A8FBFEED41E}"/>
               </a:ext>
             </a:extLst>
           </p:cNvPr>
@@ -10438,7 +10438,7 @@
           <p:cNvPr id="18" name="">
             <a:extLst xmlns:a="http://schemas.openxmlformats.org/drawingml/2006/main">
               <a:ext uri="{FF2B5EF4-FFF2-40B4-BE49-F238E27FC236}">
-                <a16:creationId xmlns:a16="http://schemas.microsoft.com/office/drawing/2014/main" id="{533B6DAF-4A61-4C24-873D-A4806EDAFD47}"/>
+                <a16:creationId xmlns:a16="http://schemas.microsoft.com/office/drawing/2014/main" id="{53144603-3AA1-4FBF-9924-0DA317E3C6BE}"/>
               </a:ext>
             </a:extLst>
           </p:cNvPr>
@@ -10494,7 +10494,7 @@
     </p:spTree>
     <p:extLst>
       <p:ext uri="{BB962C8B-B14F-4D97-AF65-F5344CB8AC3E}">
-        <p14:creationId xmlns:p14="http://schemas.microsoft.com/office/powerpoint/2010/main" val="92706990"/>
+        <p14:creationId xmlns:p14="http://schemas.microsoft.com/office/powerpoint/2010/main" val="830735962"/>
       </p:ext>
     </p:extLst>
   </p:cSld>
@@ -10525,7 +10525,7 @@
           <p:cNvPr id="28" name="">
             <a:extLst xmlns:a="http://schemas.openxmlformats.org/drawingml/2006/main">
               <a:ext uri="{FF2B5EF4-FFF2-40B4-BE49-F238E27FC236}">
-                <a16:creationId xmlns:a16="http://schemas.microsoft.com/office/drawing/2014/main" id="{32A5D573-E700-4670-8798-F8FD0DAF6BFB}"/>
+                <a16:creationId xmlns:a16="http://schemas.microsoft.com/office/drawing/2014/main" id="{E206E35B-5503-4849-9F5D-251CFB0B6DE0}"/>
               </a:ext>
             </a:extLst>
           </p:cNvPr>
@@ -10583,7 +10583,7 @@
           <p:cNvPr id="2" name="">
             <a:extLst xmlns:a="http://schemas.openxmlformats.org/drawingml/2006/main">
               <a:ext uri="{FF2B5EF4-FFF2-40B4-BE49-F238E27FC236}">
-                <a16:creationId xmlns:a16="http://schemas.microsoft.com/office/drawing/2014/main" id="{D537E06B-C5FB-44C3-A96F-568AEEBE5BEB}"/>
+                <a16:creationId xmlns:a16="http://schemas.microsoft.com/office/drawing/2014/main" id="{EE04E6E4-07CB-4CCA-A9E2-4C5949F56A81}"/>
               </a:ext>
             </a:extLst>
           </p:cNvPr>
@@ -10641,7 +10641,7 @@
           <p:cNvPr id="3" name="">
             <a:extLst xmlns:a="http://schemas.openxmlformats.org/drawingml/2006/main">
               <a:ext uri="{FF2B5EF4-FFF2-40B4-BE49-F238E27FC236}">
-                <a16:creationId xmlns:a16="http://schemas.microsoft.com/office/drawing/2014/main" id="{69D00ED6-E3E9-4E4D-96AE-2882098E16BA}"/>
+                <a16:creationId xmlns:a16="http://schemas.microsoft.com/office/drawing/2014/main" id="{4E421F20-DD0C-43C2-B87B-A401077C96CA}"/>
               </a:ext>
             </a:extLst>
           </p:cNvPr>
@@ -10674,7 +10674,7 @@
           <p:cNvPr id="4" name="">
             <a:extLst xmlns:a="http://schemas.openxmlformats.org/drawingml/2006/main">
               <a:ext uri="{FF2B5EF4-FFF2-40B4-BE49-F238E27FC236}">
-                <a16:creationId xmlns:a16="http://schemas.microsoft.com/office/drawing/2014/main" id="{65C0A502-2AB9-41D4-8B46-C789A20CA31E}"/>
+                <a16:creationId xmlns:a16="http://schemas.microsoft.com/office/drawing/2014/main" id="{1942C2FF-637F-4D50-A673-DE676F575208}"/>
               </a:ext>
             </a:extLst>
           </p:cNvPr>
@@ -10732,7 +10732,7 @@
           <p:cNvPr id="5" name="">
             <a:extLst xmlns:a="http://schemas.openxmlformats.org/drawingml/2006/main">
               <a:ext uri="{FF2B5EF4-FFF2-40B4-BE49-F238E27FC236}">
-                <a16:creationId xmlns:a16="http://schemas.microsoft.com/office/drawing/2014/main" id="{631A3DB8-0004-43B8-9800-8ECBEAF17E11}"/>
+                <a16:creationId xmlns:a16="http://schemas.microsoft.com/office/drawing/2014/main" id="{B06B0A6F-B88D-49CE-AA23-A7F25EE54451}"/>
               </a:ext>
             </a:extLst>
           </p:cNvPr>
@@ -10790,7 +10790,7 @@
           <p:cNvPr id="6" name="">
             <a:extLst xmlns:a="http://schemas.openxmlformats.org/drawingml/2006/main">
               <a:ext uri="{FF2B5EF4-FFF2-40B4-BE49-F238E27FC236}">
-                <a16:creationId xmlns:a16="http://schemas.microsoft.com/office/drawing/2014/main" id="{84AA39BD-4937-4204-986B-1520A2F46357}"/>
+                <a16:creationId xmlns:a16="http://schemas.microsoft.com/office/drawing/2014/main" id="{C8B9CDA1-F176-4407-B592-8575E8267646}"/>
               </a:ext>
             </a:extLst>
           </p:cNvPr>
@@ -10825,7 +10825,7 @@
           <p:cNvPr id="7" name="">
             <a:extLst xmlns:a="http://schemas.openxmlformats.org/drawingml/2006/main">
               <a:ext uri="{FF2B5EF4-FFF2-40B4-BE49-F238E27FC236}">
-                <a16:creationId xmlns:a16="http://schemas.microsoft.com/office/drawing/2014/main" id="{9368CDA9-5433-4115-A9CA-A0FFC5A1E781}"/>
+                <a16:creationId xmlns:a16="http://schemas.microsoft.com/office/drawing/2014/main" id="{2E74CB28-322D-43E7-985E-A6BA09BC5EED}"/>
               </a:ext>
             </a:extLst>
           </p:cNvPr>
@@ -10883,7 +10883,7 @@
           <p:cNvPr id="8" name="">
             <a:extLst xmlns:a="http://schemas.openxmlformats.org/drawingml/2006/main">
               <a:ext uri="{FF2B5EF4-FFF2-40B4-BE49-F238E27FC236}">
-                <a16:creationId xmlns:a16="http://schemas.microsoft.com/office/drawing/2014/main" id="{195354CD-85FD-42C9-A1FD-3960A4B4A2FE}"/>
+                <a16:creationId xmlns:a16="http://schemas.microsoft.com/office/drawing/2014/main" id="{9C8DD1F2-EAD8-46CD-8DB8-B87691B7B0E7}"/>
               </a:ext>
             </a:extLst>
           </p:cNvPr>
@@ -10918,7 +10918,7 @@
           <p:cNvPr id="9" name="">
             <a:extLst xmlns:a="http://schemas.openxmlformats.org/drawingml/2006/main">
               <a:ext uri="{FF2B5EF4-FFF2-40B4-BE49-F238E27FC236}">
-                <a16:creationId xmlns:a16="http://schemas.microsoft.com/office/drawing/2014/main" id="{3574053D-5533-4991-8656-B937CCDA2A1B}"/>
+                <a16:creationId xmlns:a16="http://schemas.microsoft.com/office/drawing/2014/main" id="{F14ADCEB-5880-46CD-AC67-8B19074B70D3}"/>
               </a:ext>
             </a:extLst>
           </p:cNvPr>
@@ -10976,7 +10976,7 @@
           <p:cNvPr id="10" name="">
             <a:extLst xmlns:a="http://schemas.openxmlformats.org/drawingml/2006/main">
               <a:ext uri="{FF2B5EF4-FFF2-40B4-BE49-F238E27FC236}">
-                <a16:creationId xmlns:a16="http://schemas.microsoft.com/office/drawing/2014/main" id="{698EED8F-329D-4C3D-8607-ED680DB92584}"/>
+                <a16:creationId xmlns:a16="http://schemas.microsoft.com/office/drawing/2014/main" id="{37DB3F72-22BE-4951-8486-C8D486BA4CA0}"/>
               </a:ext>
             </a:extLst>
           </p:cNvPr>
@@ -11011,7 +11011,7 @@
           <p:cNvPr id="11" name="">
             <a:extLst xmlns:a="http://schemas.openxmlformats.org/drawingml/2006/main">
               <a:ext uri="{FF2B5EF4-FFF2-40B4-BE49-F238E27FC236}">
-                <a16:creationId xmlns:a16="http://schemas.microsoft.com/office/drawing/2014/main" id="{6425CFA7-A776-4573-A341-0907FB22F956}"/>
+                <a16:creationId xmlns:a16="http://schemas.microsoft.com/office/drawing/2014/main" id="{3E6B4CF6-09B4-41E2-93D0-0237D2952191}"/>
               </a:ext>
             </a:extLst>
           </p:cNvPr>
@@ -11069,7 +11069,7 @@
           <p:cNvPr id="12" name="">
             <a:extLst xmlns:a="http://schemas.openxmlformats.org/drawingml/2006/main">
               <a:ext uri="{FF2B5EF4-FFF2-40B4-BE49-F238E27FC236}">
-                <a16:creationId xmlns:a16="http://schemas.microsoft.com/office/drawing/2014/main" id="{D9CAFB31-FB47-49AE-B478-CD8CB03CEBE5}"/>
+                <a16:creationId xmlns:a16="http://schemas.microsoft.com/office/drawing/2014/main" id="{5DD936A6-C46A-4345-8915-67A2FCF414D9}"/>
               </a:ext>
             </a:extLst>
           </p:cNvPr>
@@ -11104,7 +11104,7 @@
           <p:cNvPr id="13" name="">
             <a:extLst xmlns:a="http://schemas.openxmlformats.org/drawingml/2006/main">
               <a:ext uri="{FF2B5EF4-FFF2-40B4-BE49-F238E27FC236}">
-                <a16:creationId xmlns:a16="http://schemas.microsoft.com/office/drawing/2014/main" id="{63C3B459-BB59-49F4-9AE7-BF3842485D45}"/>
+                <a16:creationId xmlns:a16="http://schemas.microsoft.com/office/drawing/2014/main" id="{44404125-2E83-485B-905B-937C5CC20D74}"/>
               </a:ext>
             </a:extLst>
           </p:cNvPr>
@@ -11162,7 +11162,7 @@
           <p:cNvPr id="14" name="">
             <a:extLst xmlns:a="http://schemas.openxmlformats.org/drawingml/2006/main">
               <a:ext uri="{FF2B5EF4-FFF2-40B4-BE49-F238E27FC236}">
-                <a16:creationId xmlns:a16="http://schemas.microsoft.com/office/drawing/2014/main" id="{BD84E74E-178E-4C5B-AD7F-C02E9A3A04C1}"/>
+                <a16:creationId xmlns:a16="http://schemas.microsoft.com/office/drawing/2014/main" id="{73083132-BA7C-49A2-9BF6-A637CB3187F9}"/>
               </a:ext>
             </a:extLst>
           </p:cNvPr>
@@ -11197,7 +11197,7 @@
           <p:cNvPr id="15" name="">
             <a:extLst xmlns:a="http://schemas.openxmlformats.org/drawingml/2006/main">
               <a:ext uri="{FF2B5EF4-FFF2-40B4-BE49-F238E27FC236}">
-                <a16:creationId xmlns:a16="http://schemas.microsoft.com/office/drawing/2014/main" id="{0DFD19C2-42F7-472C-893E-7A7B38B8EA05}"/>
+                <a16:creationId xmlns:a16="http://schemas.microsoft.com/office/drawing/2014/main" id="{823E62A1-F451-4B32-B4D3-B5621E26583A}"/>
               </a:ext>
             </a:extLst>
           </p:cNvPr>
@@ -11255,7 +11255,7 @@
           <p:cNvPr id="16" name="">
             <a:extLst xmlns:a="http://schemas.openxmlformats.org/drawingml/2006/main">
               <a:ext uri="{FF2B5EF4-FFF2-40B4-BE49-F238E27FC236}">
-                <a16:creationId xmlns:a16="http://schemas.microsoft.com/office/drawing/2014/main" id="{F927D4B5-B446-49B7-99DE-7F2F56253569}"/>
+                <a16:creationId xmlns:a16="http://schemas.microsoft.com/office/drawing/2014/main" id="{848D576D-E949-4227-9E44-458BA51426E1}"/>
               </a:ext>
             </a:extLst>
           </p:cNvPr>
@@ -11290,7 +11290,7 @@
           <p:cNvPr id="17" name="">
             <a:extLst xmlns:a="http://schemas.openxmlformats.org/drawingml/2006/main">
               <a:ext uri="{FF2B5EF4-FFF2-40B4-BE49-F238E27FC236}">
-                <a16:creationId xmlns:a16="http://schemas.microsoft.com/office/drawing/2014/main" id="{81A8F3C2-D85A-4B34-97E1-00B865F66D03}"/>
+                <a16:creationId xmlns:a16="http://schemas.microsoft.com/office/drawing/2014/main" id="{6F3D3F32-3FA1-4F00-B14C-B830AC28AA78}"/>
               </a:ext>
             </a:extLst>
           </p:cNvPr>
@@ -11348,7 +11348,7 @@
           <p:cNvPr id="18" name="">
             <a:extLst xmlns:a="http://schemas.openxmlformats.org/drawingml/2006/main">
               <a:ext uri="{FF2B5EF4-FFF2-40B4-BE49-F238E27FC236}">
-                <a16:creationId xmlns:a16="http://schemas.microsoft.com/office/drawing/2014/main" id="{9AD8558E-129E-45E1-8814-CF4CC258A9D7}"/>
+                <a16:creationId xmlns:a16="http://schemas.microsoft.com/office/drawing/2014/main" id="{361FE715-1A9E-49DA-B189-65C59B81178C}"/>
               </a:ext>
             </a:extLst>
           </p:cNvPr>
@@ -11383,7 +11383,7 @@
           <p:cNvPr id="19" name="">
             <a:extLst xmlns:a="http://schemas.openxmlformats.org/drawingml/2006/main">
               <a:ext uri="{FF2B5EF4-FFF2-40B4-BE49-F238E27FC236}">
-                <a16:creationId xmlns:a16="http://schemas.microsoft.com/office/drawing/2014/main" id="{39DDFA05-DEB2-4F70-908A-6B8ED7FB6F05}"/>
+                <a16:creationId xmlns:a16="http://schemas.microsoft.com/office/drawing/2014/main" id="{5BE20373-737E-4103-8185-BC71C159B29F}"/>
               </a:ext>
             </a:extLst>
           </p:cNvPr>
@@ -11441,7 +11441,7 @@
           <p:cNvPr id="20" name="">
             <a:extLst xmlns:a="http://schemas.openxmlformats.org/drawingml/2006/main">
               <a:ext uri="{FF2B5EF4-FFF2-40B4-BE49-F238E27FC236}">
-                <a16:creationId xmlns:a16="http://schemas.microsoft.com/office/drawing/2014/main" id="{E4F1CD7D-6D23-4A95-9660-D9C4091FC522}"/>
+                <a16:creationId xmlns:a16="http://schemas.microsoft.com/office/drawing/2014/main" id="{4A7048F4-EC5D-4DFA-B2DA-DE3F83D5D4D7}"/>
               </a:ext>
             </a:extLst>
           </p:cNvPr>
@@ -11476,7 +11476,7 @@
           <p:cNvPr id="21" name="">
             <a:extLst xmlns:a="http://schemas.openxmlformats.org/drawingml/2006/main">
               <a:ext uri="{FF2B5EF4-FFF2-40B4-BE49-F238E27FC236}">
-                <a16:creationId xmlns:a16="http://schemas.microsoft.com/office/drawing/2014/main" id="{AEB49629-8396-4AB0-B41A-64DE8540BC6E}"/>
+                <a16:creationId xmlns:a16="http://schemas.microsoft.com/office/drawing/2014/main" id="{5F7CB632-60B2-4AC2-A7A0-FB2FF6CE66F9}"/>
               </a:ext>
             </a:extLst>
           </p:cNvPr>
@@ -11534,7 +11534,7 @@
           <p:cNvPr id="22" name="">
             <a:extLst xmlns:a="http://schemas.openxmlformats.org/drawingml/2006/main">
               <a:ext uri="{FF2B5EF4-FFF2-40B4-BE49-F238E27FC236}">
-                <a16:creationId xmlns:a16="http://schemas.microsoft.com/office/drawing/2014/main" id="{0292F852-E855-4DF3-BF65-FB99BA9E34E0}"/>
+                <a16:creationId xmlns:a16="http://schemas.microsoft.com/office/drawing/2014/main" id="{D531F38A-E9D7-4253-A8FF-949B05E12275}"/>
               </a:ext>
             </a:extLst>
           </p:cNvPr>
@@ -11569,7 +11569,7 @@
           <p:cNvPr id="23" name="">
             <a:extLst xmlns:a="http://schemas.openxmlformats.org/drawingml/2006/main">
               <a:ext uri="{FF2B5EF4-FFF2-40B4-BE49-F238E27FC236}">
-                <a16:creationId xmlns:a16="http://schemas.microsoft.com/office/drawing/2014/main" id="{50AD1F34-D6C4-49B2-8589-F0CA3B4A1179}"/>
+                <a16:creationId xmlns:a16="http://schemas.microsoft.com/office/drawing/2014/main" id="{300E9855-0B66-4D8A-B1AC-C78C837F58B6}"/>
               </a:ext>
             </a:extLst>
           </p:cNvPr>
@@ -11627,7 +11627,7 @@
           <p:cNvPr id="24" name="">
             <a:extLst xmlns:a="http://schemas.openxmlformats.org/drawingml/2006/main">
               <a:ext uri="{FF2B5EF4-FFF2-40B4-BE49-F238E27FC236}">
-                <a16:creationId xmlns:a16="http://schemas.microsoft.com/office/drawing/2014/main" id="{2C43181B-6B00-4079-B74D-8D2C0F37EB5E}"/>
+                <a16:creationId xmlns:a16="http://schemas.microsoft.com/office/drawing/2014/main" id="{2C3DBFE7-43F6-4D83-92C8-37AC4A5BDAF3}"/>
               </a:ext>
             </a:extLst>
           </p:cNvPr>
@@ -11685,7 +11685,7 @@
           <p:cNvPr id="25" name="">
             <a:extLst xmlns:a="http://schemas.openxmlformats.org/drawingml/2006/main">
               <a:ext uri="{FF2B5EF4-FFF2-40B4-BE49-F238E27FC236}">
-                <a16:creationId xmlns:a16="http://schemas.microsoft.com/office/drawing/2014/main" id="{963A8B64-FABA-4A25-8ABC-A742F977A9EE}"/>
+                <a16:creationId xmlns:a16="http://schemas.microsoft.com/office/drawing/2014/main" id="{BD34CB3B-66B3-4727-8D38-507D0F08B894}"/>
               </a:ext>
             </a:extLst>
           </p:cNvPr>
@@ -11743,7 +11743,7 @@
           <p:cNvPr id="26" name="">
             <a:extLst xmlns:a="http://schemas.openxmlformats.org/drawingml/2006/main">
               <a:ext uri="{FF2B5EF4-FFF2-40B4-BE49-F238E27FC236}">
-                <a16:creationId xmlns:a16="http://schemas.microsoft.com/office/drawing/2014/main" id="{D78E9755-3E04-4642-BA8A-F33871C13EA0}"/>
+                <a16:creationId xmlns:a16="http://schemas.microsoft.com/office/drawing/2014/main" id="{A65F7E5E-E56D-49A8-97F9-1AF8003BEC94}"/>
               </a:ext>
             </a:extLst>
           </p:cNvPr>
@@ -11801,7 +11801,7 @@
           <p:cNvPr id="27" name="">
             <a:extLst xmlns:a="http://schemas.openxmlformats.org/drawingml/2006/main">
               <a:ext uri="{FF2B5EF4-FFF2-40B4-BE49-F238E27FC236}">
-                <a16:creationId xmlns:a16="http://schemas.microsoft.com/office/drawing/2014/main" id="{6EE43D43-2823-4FF0-A066-C02EE81CC971}"/>
+                <a16:creationId xmlns:a16="http://schemas.microsoft.com/office/drawing/2014/main" id="{8593A14E-2408-42D5-8E13-D6FAC5DA717E}"/>
               </a:ext>
             </a:extLst>
           </p:cNvPr>
@@ -11857,7 +11857,7 @@
     </p:spTree>
     <p:extLst>
       <p:ext uri="{BB962C8B-B14F-4D97-AF65-F5344CB8AC3E}">
-        <p14:creationId xmlns:p14="http://schemas.microsoft.com/office/powerpoint/2010/main" val="821564048"/>
+        <p14:creationId xmlns:p14="http://schemas.microsoft.com/office/powerpoint/2010/main" val="2019014075"/>
       </p:ext>
     </p:extLst>
   </p:cSld>
@@ -11888,7 +11888,7 @@
           <p:cNvPr id="27" name="">
             <a:extLst xmlns:a="http://schemas.openxmlformats.org/drawingml/2006/main">
               <a:ext uri="{FF2B5EF4-FFF2-40B4-BE49-F238E27FC236}">
-                <a16:creationId xmlns:a16="http://schemas.microsoft.com/office/drawing/2014/main" id="{E82DAA6B-5B25-4926-AE02-E4B5CADA74CB}"/>
+                <a16:creationId xmlns:a16="http://schemas.microsoft.com/office/drawing/2014/main" id="{5B114A9B-BE67-4672-8A00-49BC69045DE1}"/>
               </a:ext>
             </a:extLst>
           </p:cNvPr>
@@ -11946,7 +11946,7 @@
           <p:cNvPr id="2" name="">
             <a:extLst xmlns:a="http://schemas.openxmlformats.org/drawingml/2006/main">
               <a:ext uri="{FF2B5EF4-FFF2-40B4-BE49-F238E27FC236}">
-                <a16:creationId xmlns:a16="http://schemas.microsoft.com/office/drawing/2014/main" id="{CA7BEBD5-708B-44C3-879C-22B7E4C44A3C}"/>
+                <a16:creationId xmlns:a16="http://schemas.microsoft.com/office/drawing/2014/main" id="{B875F5F0-EF9D-4920-B78D-CCF04BD00083}"/>
               </a:ext>
             </a:extLst>
           </p:cNvPr>
@@ -12004,7 +12004,7 @@
           <p:cNvPr id="3" name="">
             <a:extLst xmlns:a="http://schemas.openxmlformats.org/drawingml/2006/main">
               <a:ext uri="{FF2B5EF4-FFF2-40B4-BE49-F238E27FC236}">
-                <a16:creationId xmlns:a16="http://schemas.microsoft.com/office/drawing/2014/main" id="{34E947FF-1D2B-4553-A04C-34EC45F073B3}"/>
+                <a16:creationId xmlns:a16="http://schemas.microsoft.com/office/drawing/2014/main" id="{C09E3D1F-7963-4D47-9745-172FD46487DA}"/>
               </a:ext>
             </a:extLst>
           </p:cNvPr>
@@ -12037,7 +12037,7 @@
           <p:cNvPr id="4" name="">
             <a:extLst xmlns:a="http://schemas.openxmlformats.org/drawingml/2006/main">
               <a:ext uri="{FF2B5EF4-FFF2-40B4-BE49-F238E27FC236}">
-                <a16:creationId xmlns:a16="http://schemas.microsoft.com/office/drawing/2014/main" id="{66941578-3722-4E84-A0E7-BE17E45C797C}"/>
+                <a16:creationId xmlns:a16="http://schemas.microsoft.com/office/drawing/2014/main" id="{B8710674-543B-48AB-8D05-52C3961E7659}"/>
               </a:ext>
             </a:extLst>
           </p:cNvPr>
@@ -12095,7 +12095,7 @@
           <p:cNvPr id="5" name="">
             <a:extLst xmlns:a="http://schemas.openxmlformats.org/drawingml/2006/main">
               <a:ext uri="{FF2B5EF4-FFF2-40B4-BE49-F238E27FC236}">
-                <a16:creationId xmlns:a16="http://schemas.microsoft.com/office/drawing/2014/main" id="{ADD224E6-9CAA-46B6-9406-BDAC64C360BC}"/>
+                <a16:creationId xmlns:a16="http://schemas.microsoft.com/office/drawing/2014/main" id="{7A86307F-C337-40D7-B8D4-D905B6F67285}"/>
               </a:ext>
             </a:extLst>
           </p:cNvPr>
@@ -12153,7 +12153,7 @@
           <p:cNvPr id="6" name="">
             <a:extLst xmlns:a="http://schemas.openxmlformats.org/drawingml/2006/main">
               <a:ext uri="{FF2B5EF4-FFF2-40B4-BE49-F238E27FC236}">
-                <a16:creationId xmlns:a16="http://schemas.microsoft.com/office/drawing/2014/main" id="{F6479973-E168-42E4-9B47-9CA7A66A59DF}"/>
+                <a16:creationId xmlns:a16="http://schemas.microsoft.com/office/drawing/2014/main" id="{5A7770F0-3FC0-4A85-8FBB-80036A870959}"/>
               </a:ext>
             </a:extLst>
           </p:cNvPr>
@@ -12188,7 +12188,7 @@
           <p:cNvPr id="7" name="">
             <a:extLst xmlns:a="http://schemas.openxmlformats.org/drawingml/2006/main">
               <a:ext uri="{FF2B5EF4-FFF2-40B4-BE49-F238E27FC236}">
-                <a16:creationId xmlns:a16="http://schemas.microsoft.com/office/drawing/2014/main" id="{A11E6567-EC5E-4F4E-A1FC-FA24065600D1}"/>
+                <a16:creationId xmlns:a16="http://schemas.microsoft.com/office/drawing/2014/main" id="{85DECBC9-6DD2-4D99-A8B3-09129B7F43D5}"/>
               </a:ext>
             </a:extLst>
           </p:cNvPr>
@@ -12246,7 +12246,7 @@
           <p:cNvPr id="8" name="">
             <a:extLst xmlns:a="http://schemas.openxmlformats.org/drawingml/2006/main">
               <a:ext uri="{FF2B5EF4-FFF2-40B4-BE49-F238E27FC236}">
-                <a16:creationId xmlns:a16="http://schemas.microsoft.com/office/drawing/2014/main" id="{B0479564-1C4E-42B7-9BEE-7F9A267069CE}"/>
+                <a16:creationId xmlns:a16="http://schemas.microsoft.com/office/drawing/2014/main" id="{16EACD3D-ED4D-4E7C-9757-48695E5A9EE6}"/>
               </a:ext>
             </a:extLst>
           </p:cNvPr>
@@ -12277,7 +12277,7 @@
           <p:cNvPr id="9" name="">
             <a:extLst xmlns:a="http://schemas.openxmlformats.org/drawingml/2006/main">
               <a:ext uri="{FF2B5EF4-FFF2-40B4-BE49-F238E27FC236}">
-                <a16:creationId xmlns:a16="http://schemas.microsoft.com/office/drawing/2014/main" id="{F9859E06-9F57-4B7A-90AE-D1191E7515D9}"/>
+                <a16:creationId xmlns:a16="http://schemas.microsoft.com/office/drawing/2014/main" id="{09FD354E-D940-4FEC-A30D-4C775EC772CB}"/>
               </a:ext>
             </a:extLst>
           </p:cNvPr>
@@ -12335,7 +12335,7 @@
           <p:cNvPr id="10" name="">
             <a:extLst xmlns:a="http://schemas.openxmlformats.org/drawingml/2006/main">
               <a:ext uri="{FF2B5EF4-FFF2-40B4-BE49-F238E27FC236}">
-                <a16:creationId xmlns:a16="http://schemas.microsoft.com/office/drawing/2014/main" id="{B501CE8A-A1D6-4C3D-A7FD-210EF2AD4CD1}"/>
+                <a16:creationId xmlns:a16="http://schemas.microsoft.com/office/drawing/2014/main" id="{BCEC9431-559B-4C31-BF03-D57ECDE4488C}"/>
               </a:ext>
             </a:extLst>
           </p:cNvPr>
@@ -12393,7 +12393,7 @@
           <p:cNvPr id="11" name="">
             <a:extLst xmlns:a="http://schemas.openxmlformats.org/drawingml/2006/main">
               <a:ext uri="{FF2B5EF4-FFF2-40B4-BE49-F238E27FC236}">
-                <a16:creationId xmlns:a16="http://schemas.microsoft.com/office/drawing/2014/main" id="{ECA32358-59F3-456C-B170-98C7CEB919B0}"/>
+                <a16:creationId xmlns:a16="http://schemas.microsoft.com/office/drawing/2014/main" id="{CEDD9FD3-95E6-494C-AC30-EB264382601F}"/>
               </a:ext>
             </a:extLst>
           </p:cNvPr>
@@ -12428,7 +12428,7 @@
           <p:cNvPr id="12" name="">
             <a:extLst xmlns:a="http://schemas.openxmlformats.org/drawingml/2006/main">
               <a:ext uri="{FF2B5EF4-FFF2-40B4-BE49-F238E27FC236}">
-                <a16:creationId xmlns:a16="http://schemas.microsoft.com/office/drawing/2014/main" id="{85D21143-053E-43FC-B872-A4B930A1D1F4}"/>
+                <a16:creationId xmlns:a16="http://schemas.microsoft.com/office/drawing/2014/main" id="{63DAB177-A56A-49AF-9D59-7C57D959C7C5}"/>
               </a:ext>
             </a:extLst>
           </p:cNvPr>
@@ -12486,7 +12486,7 @@
           <p:cNvPr id="13" name="">
             <a:extLst xmlns:a="http://schemas.openxmlformats.org/drawingml/2006/main">
               <a:ext uri="{FF2B5EF4-FFF2-40B4-BE49-F238E27FC236}">
-                <a16:creationId xmlns:a16="http://schemas.microsoft.com/office/drawing/2014/main" id="{604754E9-824F-442F-A6FE-2DACD568AFBD}"/>
+                <a16:creationId xmlns:a16="http://schemas.microsoft.com/office/drawing/2014/main" id="{23F3355E-2DD3-415A-B9B5-E667855F344F}"/>
               </a:ext>
             </a:extLst>
           </p:cNvPr>
@@ -12517,7 +12517,7 @@
           <p:cNvPr id="14" name="">
             <a:extLst xmlns:a="http://schemas.openxmlformats.org/drawingml/2006/main">
               <a:ext uri="{FF2B5EF4-FFF2-40B4-BE49-F238E27FC236}">
-                <a16:creationId xmlns:a16="http://schemas.microsoft.com/office/drawing/2014/main" id="{6A92B000-4252-4718-9698-CA1881F10745}"/>
+                <a16:creationId xmlns:a16="http://schemas.microsoft.com/office/drawing/2014/main" id="{4FDF60E3-5AD1-40E5-885F-2A9C2FEF1E84}"/>
               </a:ext>
             </a:extLst>
           </p:cNvPr>
@@ -12575,7 +12575,7 @@
           <p:cNvPr id="15" name="">
             <a:extLst xmlns:a="http://schemas.openxmlformats.org/drawingml/2006/main">
               <a:ext uri="{FF2B5EF4-FFF2-40B4-BE49-F238E27FC236}">
-                <a16:creationId xmlns:a16="http://schemas.microsoft.com/office/drawing/2014/main" id="{D764C2A8-EE93-4EC3-9BD5-DAA5AE4A62E7}"/>
+                <a16:creationId xmlns:a16="http://schemas.microsoft.com/office/drawing/2014/main" id="{65EE7850-B024-4B55-9846-0F7E0131B4AF}"/>
               </a:ext>
             </a:extLst>
           </p:cNvPr>
@@ -12633,7 +12633,7 @@
           <p:cNvPr id="16" name="">
             <a:extLst xmlns:a="http://schemas.openxmlformats.org/drawingml/2006/main">
               <a:ext uri="{FF2B5EF4-FFF2-40B4-BE49-F238E27FC236}">
-                <a16:creationId xmlns:a16="http://schemas.microsoft.com/office/drawing/2014/main" id="{990CE891-6035-4A01-A27C-DA75FD559671}"/>
+                <a16:creationId xmlns:a16="http://schemas.microsoft.com/office/drawing/2014/main" id="{0BE59DCA-F838-47D5-86D2-FA5144F0A3DB}"/>
               </a:ext>
             </a:extLst>
           </p:cNvPr>
@@ -12668,7 +12668,7 @@
           <p:cNvPr id="17" name="">
             <a:extLst xmlns:a="http://schemas.openxmlformats.org/drawingml/2006/main">
               <a:ext uri="{FF2B5EF4-FFF2-40B4-BE49-F238E27FC236}">
-                <a16:creationId xmlns:a16="http://schemas.microsoft.com/office/drawing/2014/main" id="{D30CB912-06E2-4E8C-ADB1-1A55E295CE0D}"/>
+                <a16:creationId xmlns:a16="http://schemas.microsoft.com/office/drawing/2014/main" id="{09EA4B01-D6DB-4410-A9CD-792965E9F9A8}"/>
               </a:ext>
             </a:extLst>
           </p:cNvPr>
@@ -12726,7 +12726,7 @@
           <p:cNvPr id="18" name="">
             <a:extLst xmlns:a="http://schemas.openxmlformats.org/drawingml/2006/main">
               <a:ext uri="{FF2B5EF4-FFF2-40B4-BE49-F238E27FC236}">
-                <a16:creationId xmlns:a16="http://schemas.microsoft.com/office/drawing/2014/main" id="{824C8C58-9FAF-4A7B-A0D8-29D40433DB88}"/>
+                <a16:creationId xmlns:a16="http://schemas.microsoft.com/office/drawing/2014/main" id="{F897D453-2D5C-4FF7-9E3D-3263FB15E0D1}"/>
               </a:ext>
             </a:extLst>
           </p:cNvPr>
@@ -12757,7 +12757,7 @@
           <p:cNvPr id="19" name="">
             <a:extLst xmlns:a="http://schemas.openxmlformats.org/drawingml/2006/main">
               <a:ext uri="{FF2B5EF4-FFF2-40B4-BE49-F238E27FC236}">
-                <a16:creationId xmlns:a16="http://schemas.microsoft.com/office/drawing/2014/main" id="{D90202CB-B77E-40EB-AC2F-06128CCFB1B8}"/>
+                <a16:creationId xmlns:a16="http://schemas.microsoft.com/office/drawing/2014/main" id="{C4384D95-2909-44C2-B3DD-667B36C64F10}"/>
               </a:ext>
             </a:extLst>
           </p:cNvPr>
@@ -12815,7 +12815,7 @@
           <p:cNvPr id="20" name="">
             <a:extLst xmlns:a="http://schemas.openxmlformats.org/drawingml/2006/main">
               <a:ext uri="{FF2B5EF4-FFF2-40B4-BE49-F238E27FC236}">
-                <a16:creationId xmlns:a16="http://schemas.microsoft.com/office/drawing/2014/main" id="{D9FDE6FE-A084-4792-8EC0-30BE25CD17A5}"/>
+                <a16:creationId xmlns:a16="http://schemas.microsoft.com/office/drawing/2014/main" id="{9565F79B-D3F3-40E3-A647-5D8AD04AC52A}"/>
               </a:ext>
             </a:extLst>
           </p:cNvPr>
@@ -12873,7 +12873,7 @@
           <p:cNvPr id="21" name="">
             <a:extLst xmlns:a="http://schemas.openxmlformats.org/drawingml/2006/main">
               <a:ext uri="{FF2B5EF4-FFF2-40B4-BE49-F238E27FC236}">
-                <a16:creationId xmlns:a16="http://schemas.microsoft.com/office/drawing/2014/main" id="{FA2A17A2-9BBD-4D7A-8C83-915943096A6C}"/>
+                <a16:creationId xmlns:a16="http://schemas.microsoft.com/office/drawing/2014/main" id="{50B65F26-2556-4C95-911D-9AD7A3EDD43C}"/>
               </a:ext>
             </a:extLst>
           </p:cNvPr>
@@ -12908,7 +12908,7 @@
           <p:cNvPr id="22" name="">
             <a:extLst xmlns:a="http://schemas.openxmlformats.org/drawingml/2006/main">
               <a:ext uri="{FF2B5EF4-FFF2-40B4-BE49-F238E27FC236}">
-                <a16:creationId xmlns:a16="http://schemas.microsoft.com/office/drawing/2014/main" id="{3979852F-73D2-406C-9EB9-5D732D95BDCE}"/>
+                <a16:creationId xmlns:a16="http://schemas.microsoft.com/office/drawing/2014/main" id="{BBAAB437-6D0D-4D7D-94FE-95D272B0E691}"/>
               </a:ext>
             </a:extLst>
           </p:cNvPr>
@@ -12966,7 +12966,7 @@
           <p:cNvPr id="23" name="">
             <a:extLst xmlns:a="http://schemas.openxmlformats.org/drawingml/2006/main">
               <a:ext uri="{FF2B5EF4-FFF2-40B4-BE49-F238E27FC236}">
-                <a16:creationId xmlns:a16="http://schemas.microsoft.com/office/drawing/2014/main" id="{CFB7EE71-7810-482C-8302-E6E40A493D40}"/>
+                <a16:creationId xmlns:a16="http://schemas.microsoft.com/office/drawing/2014/main" id="{29416634-B0E6-4F4C-8587-5440A45510AD}"/>
               </a:ext>
             </a:extLst>
           </p:cNvPr>
@@ -12997,7 +12997,7 @@
           <p:cNvPr id="24" name="">
             <a:extLst xmlns:a="http://schemas.openxmlformats.org/drawingml/2006/main">
               <a:ext uri="{FF2B5EF4-FFF2-40B4-BE49-F238E27FC236}">
-                <a16:creationId xmlns:a16="http://schemas.microsoft.com/office/drawing/2014/main" id="{993DDD04-58F0-4BE4-8465-D4D81016AE7D}"/>
+                <a16:creationId xmlns:a16="http://schemas.microsoft.com/office/drawing/2014/main" id="{3803C189-28A8-4665-826D-4E9610232DE1}"/>
               </a:ext>
             </a:extLst>
           </p:cNvPr>
@@ -13055,7 +13055,7 @@
           <p:cNvPr id="25" name="">
             <a:extLst xmlns:a="http://schemas.openxmlformats.org/drawingml/2006/main">
               <a:ext uri="{FF2B5EF4-FFF2-40B4-BE49-F238E27FC236}">
-                <a16:creationId xmlns:a16="http://schemas.microsoft.com/office/drawing/2014/main" id="{62395A94-21EB-4718-AC93-8F4F9F270299}"/>
+                <a16:creationId xmlns:a16="http://schemas.microsoft.com/office/drawing/2014/main" id="{1CCDFB6B-D704-4EC7-ABBD-44E5688138DE}"/>
               </a:ext>
             </a:extLst>
           </p:cNvPr>
@@ -13113,7 +13113,7 @@
           <p:cNvPr id="26" name="">
             <a:extLst xmlns:a="http://schemas.openxmlformats.org/drawingml/2006/main">
               <a:ext uri="{FF2B5EF4-FFF2-40B4-BE49-F238E27FC236}">
-                <a16:creationId xmlns:a16="http://schemas.microsoft.com/office/drawing/2014/main" id="{14114C34-2504-45C9-AD6A-3C91D8F39496}"/>
+                <a16:creationId xmlns:a16="http://schemas.microsoft.com/office/drawing/2014/main" id="{28146365-DBB2-4020-A4EB-CE0872FC455B}"/>
               </a:ext>
             </a:extLst>
           </p:cNvPr>
@@ -13169,7 +13169,7 @@
     </p:spTree>
     <p:extLst>
       <p:ext uri="{BB962C8B-B14F-4D97-AF65-F5344CB8AC3E}">
-        <p14:creationId xmlns:p14="http://schemas.microsoft.com/office/powerpoint/2010/main" val="462009437"/>
+        <p14:creationId xmlns:p14="http://schemas.microsoft.com/office/powerpoint/2010/main" val="1965684089"/>
       </p:ext>
     </p:extLst>
   </p:cSld>
@@ -13200,7 +13200,7 @@
           <p:cNvPr id="22" name="">
             <a:extLst xmlns:a="http://schemas.openxmlformats.org/drawingml/2006/main">
               <a:ext uri="{FF2B5EF4-FFF2-40B4-BE49-F238E27FC236}">
-                <a16:creationId xmlns:a16="http://schemas.microsoft.com/office/drawing/2014/main" id="{1527A2DF-CEB8-40F8-919C-B0A19726E7DB}"/>
+                <a16:creationId xmlns:a16="http://schemas.microsoft.com/office/drawing/2014/main" id="{E73516A8-5003-450E-847A-AFBA726C0E26}"/>
               </a:ext>
             </a:extLst>
           </p:cNvPr>
@@ -13258,7 +13258,7 @@
           <p:cNvPr id="2" name="">
             <a:extLst xmlns:a="http://schemas.openxmlformats.org/drawingml/2006/main">
               <a:ext uri="{FF2B5EF4-FFF2-40B4-BE49-F238E27FC236}">
-                <a16:creationId xmlns:a16="http://schemas.microsoft.com/office/drawing/2014/main" id="{6BD06311-7B87-4667-8F1D-684276048951}"/>
+                <a16:creationId xmlns:a16="http://schemas.microsoft.com/office/drawing/2014/main" id="{B7F184FD-2FF7-4F63-A2D9-7F184C0FF227}"/>
               </a:ext>
             </a:extLst>
           </p:cNvPr>
@@ -13316,7 +13316,7 @@
           <p:cNvPr id="3" name="">
             <a:extLst xmlns:a="http://schemas.openxmlformats.org/drawingml/2006/main">
               <a:ext uri="{FF2B5EF4-FFF2-40B4-BE49-F238E27FC236}">
-                <a16:creationId xmlns:a16="http://schemas.microsoft.com/office/drawing/2014/main" id="{BC4A05F9-CD8F-4657-898B-F29726DB3BF7}"/>
+                <a16:creationId xmlns:a16="http://schemas.microsoft.com/office/drawing/2014/main" id="{F11790B9-2668-4357-AB19-F4C990EF3E32}"/>
               </a:ext>
             </a:extLst>
           </p:cNvPr>
@@ -13349,7 +13349,7 @@
           <p:cNvPr id="4" name="">
             <a:extLst xmlns:a="http://schemas.openxmlformats.org/drawingml/2006/main">
               <a:ext uri="{FF2B5EF4-FFF2-40B4-BE49-F238E27FC236}">
-                <a16:creationId xmlns:a16="http://schemas.microsoft.com/office/drawing/2014/main" id="{60778AF7-7769-4F6A-B035-56F2EDF68764}"/>
+                <a16:creationId xmlns:a16="http://schemas.microsoft.com/office/drawing/2014/main" id="{AE1523A9-188B-4167-BD13-0F886B9C9B52}"/>
               </a:ext>
             </a:extLst>
           </p:cNvPr>
@@ -13407,7 +13407,7 @@
           <p:cNvPr id="5" name="">
             <a:extLst xmlns:a="http://schemas.openxmlformats.org/drawingml/2006/main">
               <a:ext uri="{FF2B5EF4-FFF2-40B4-BE49-F238E27FC236}">
-                <a16:creationId xmlns:a16="http://schemas.microsoft.com/office/drawing/2014/main" id="{E77DAFEC-98E0-40B9-A1AC-23F473727730}"/>
+                <a16:creationId xmlns:a16="http://schemas.microsoft.com/office/drawing/2014/main" id="{20CF3A46-B567-41B2-BDB3-25FC9CC5E44B}"/>
               </a:ext>
             </a:extLst>
           </p:cNvPr>
@@ -13465,7 +13465,7 @@
           <p:cNvPr id="6" name="">
             <a:extLst xmlns:a="http://schemas.openxmlformats.org/drawingml/2006/main">
               <a:ext uri="{FF2B5EF4-FFF2-40B4-BE49-F238E27FC236}">
-                <a16:creationId xmlns:a16="http://schemas.microsoft.com/office/drawing/2014/main" id="{12C029C6-F095-4501-A436-BABA1D360A08}"/>
+                <a16:creationId xmlns:a16="http://schemas.microsoft.com/office/drawing/2014/main" id="{C1378690-1772-47C0-BCD0-B223DC2E99ED}"/>
               </a:ext>
             </a:extLst>
           </p:cNvPr>
@@ -13500,7 +13500,7 @@
           <p:cNvPr id="7" name="">
             <a:extLst xmlns:a="http://schemas.openxmlformats.org/drawingml/2006/main">
               <a:ext uri="{FF2B5EF4-FFF2-40B4-BE49-F238E27FC236}">
-                <a16:creationId xmlns:a16="http://schemas.microsoft.com/office/drawing/2014/main" id="{844CD6E1-DFC8-4991-A2A7-2930B068D6D9}"/>
+                <a16:creationId xmlns:a16="http://schemas.microsoft.com/office/drawing/2014/main" id="{FDE7785F-C8BA-4BDE-B726-042D63AFC98E}"/>
               </a:ext>
             </a:extLst>
           </p:cNvPr>
@@ -13533,7 +13533,7 @@
           <p:cNvPr id="8" name="">
             <a:extLst xmlns:a="http://schemas.openxmlformats.org/drawingml/2006/main">
               <a:ext uri="{FF2B5EF4-FFF2-40B4-BE49-F238E27FC236}">
-                <a16:creationId xmlns:a16="http://schemas.microsoft.com/office/drawing/2014/main" id="{4BB669BB-CFBB-4AD9-9D80-F91C3D192C80}"/>
+                <a16:creationId xmlns:a16="http://schemas.microsoft.com/office/drawing/2014/main" id="{B9D409D9-CEFF-449E-B794-B04653F0D65D}"/>
               </a:ext>
             </a:extLst>
           </p:cNvPr>
@@ -13591,7 +13591,7 @@
           <p:cNvPr id="9" name="">
             <a:extLst xmlns:a="http://schemas.openxmlformats.org/drawingml/2006/main">
               <a:ext uri="{FF2B5EF4-FFF2-40B4-BE49-F238E27FC236}">
-                <a16:creationId xmlns:a16="http://schemas.microsoft.com/office/drawing/2014/main" id="{80D3C77F-B31C-4B2F-8AAF-2299239A58F5}"/>
+                <a16:creationId xmlns:a16="http://schemas.microsoft.com/office/drawing/2014/main" id="{5C39238A-E5FD-4492-843D-CF2E4E28A233}"/>
               </a:ext>
             </a:extLst>
           </p:cNvPr>
@@ -13649,7 +13649,7 @@
           <p:cNvPr id="10" name="">
             <a:extLst xmlns:a="http://schemas.openxmlformats.org/drawingml/2006/main">
               <a:ext uri="{FF2B5EF4-FFF2-40B4-BE49-F238E27FC236}">
-                <a16:creationId xmlns:a16="http://schemas.microsoft.com/office/drawing/2014/main" id="{AF0D1163-6644-4EF5-AFE1-D7854B869A1C}"/>
+                <a16:creationId xmlns:a16="http://schemas.microsoft.com/office/drawing/2014/main" id="{E045DA54-A87A-4D5A-A572-9028B5A166C1}"/>
               </a:ext>
             </a:extLst>
           </p:cNvPr>
@@ -13684,7 +13684,7 @@
           <p:cNvPr id="11" name="">
             <a:extLst xmlns:a="http://schemas.openxmlformats.org/drawingml/2006/main">
               <a:ext uri="{FF2B5EF4-FFF2-40B4-BE49-F238E27FC236}">
-                <a16:creationId xmlns:a16="http://schemas.microsoft.com/office/drawing/2014/main" id="{43A56457-C64E-42D0-BA52-D811A1F88734}"/>
+                <a16:creationId xmlns:a16="http://schemas.microsoft.com/office/drawing/2014/main" id="{1FB99661-140D-4CA2-903B-F0EBEEBEB7F2}"/>
               </a:ext>
             </a:extLst>
           </p:cNvPr>
@@ -13717,7 +13717,7 @@
           <p:cNvPr id="12" name="">
             <a:extLst xmlns:a="http://schemas.openxmlformats.org/drawingml/2006/main">
               <a:ext uri="{FF2B5EF4-FFF2-40B4-BE49-F238E27FC236}">
-                <a16:creationId xmlns:a16="http://schemas.microsoft.com/office/drawing/2014/main" id="{52F68599-12FA-40DF-923A-5570C8D40518}"/>
+                <a16:creationId xmlns:a16="http://schemas.microsoft.com/office/drawing/2014/main" id="{5EE58C9D-9130-4612-8CAE-69272A01FF3A}"/>
               </a:ext>
             </a:extLst>
           </p:cNvPr>
@@ -13775,7 +13775,7 @@
           <p:cNvPr id="13" name="">
             <a:extLst xmlns:a="http://schemas.openxmlformats.org/drawingml/2006/main">
               <a:ext uri="{FF2B5EF4-FFF2-40B4-BE49-F238E27FC236}">
-                <a16:creationId xmlns:a16="http://schemas.microsoft.com/office/drawing/2014/main" id="{CDB603BC-79F0-4803-82C6-7E6D3E49D8F0}"/>
+                <a16:creationId xmlns:a16="http://schemas.microsoft.com/office/drawing/2014/main" id="{B5CE349E-2DAF-433F-B1BB-B65069108056}"/>
               </a:ext>
             </a:extLst>
           </p:cNvPr>
@@ -13833,7 +13833,7 @@
           <p:cNvPr id="14" name="">
             <a:extLst xmlns:a="http://schemas.openxmlformats.org/drawingml/2006/main">
               <a:ext uri="{FF2B5EF4-FFF2-40B4-BE49-F238E27FC236}">
-                <a16:creationId xmlns:a16="http://schemas.microsoft.com/office/drawing/2014/main" id="{EB21E3B7-CA09-4C9C-82FB-FBFA3D18AD66}"/>
+                <a16:creationId xmlns:a16="http://schemas.microsoft.com/office/drawing/2014/main" id="{6AB04ACF-1C11-4BFE-B4EB-C7900B6A639C}"/>
               </a:ext>
             </a:extLst>
           </p:cNvPr>
@@ -13868,7 +13868,7 @@
           <p:cNvPr id="15" name="">
             <a:extLst xmlns:a="http://schemas.openxmlformats.org/drawingml/2006/main">
               <a:ext uri="{FF2B5EF4-FFF2-40B4-BE49-F238E27FC236}">
-                <a16:creationId xmlns:a16="http://schemas.microsoft.com/office/drawing/2014/main" id="{730AE1AA-DF38-4152-9699-ABD25AC7E559}"/>
+                <a16:creationId xmlns:a16="http://schemas.microsoft.com/office/drawing/2014/main" id="{E84E3F74-C518-41B3-8B95-105618B8F0DA}"/>
               </a:ext>
             </a:extLst>
           </p:cNvPr>
@@ -13901,7 +13901,7 @@
           <p:cNvPr id="16" name="">
             <a:extLst xmlns:a="http://schemas.openxmlformats.org/drawingml/2006/main">
               <a:ext uri="{FF2B5EF4-FFF2-40B4-BE49-F238E27FC236}">
-                <a16:creationId xmlns:a16="http://schemas.microsoft.com/office/drawing/2014/main" id="{57710E7D-64AB-41B3-B8D9-6901670833DB}"/>
+                <a16:creationId xmlns:a16="http://schemas.microsoft.com/office/drawing/2014/main" id="{EDDF9684-921E-41A2-BCDD-AE46A55F6D08}"/>
               </a:ext>
             </a:extLst>
           </p:cNvPr>
@@ -13959,7 +13959,7 @@
           <p:cNvPr id="17" name="">
             <a:extLst xmlns:a="http://schemas.openxmlformats.org/drawingml/2006/main">
               <a:ext uri="{FF2B5EF4-FFF2-40B4-BE49-F238E27FC236}">
-                <a16:creationId xmlns:a16="http://schemas.microsoft.com/office/drawing/2014/main" id="{A1C04FFC-C16E-4A6B-9E41-3C424ABD9C40}"/>
+                <a16:creationId xmlns:a16="http://schemas.microsoft.com/office/drawing/2014/main" id="{F7E4BB9D-D8F4-42CC-BB1A-AB0D3262258E}"/>
               </a:ext>
             </a:extLst>
           </p:cNvPr>
@@ -14017,7 +14017,7 @@
           <p:cNvPr id="18" name="">
             <a:extLst xmlns:a="http://schemas.openxmlformats.org/drawingml/2006/main">
               <a:ext uri="{FF2B5EF4-FFF2-40B4-BE49-F238E27FC236}">
-                <a16:creationId xmlns:a16="http://schemas.microsoft.com/office/drawing/2014/main" id="{65A6BCB9-88F4-4BB7-A514-6B85B67C0BBC}"/>
+                <a16:creationId xmlns:a16="http://schemas.microsoft.com/office/drawing/2014/main" id="{58AFE111-5C9C-41CC-B81C-685E45A8AC62}"/>
               </a:ext>
             </a:extLst>
           </p:cNvPr>
@@ -14052,7 +14052,7 @@
           <p:cNvPr id="19" name="">
             <a:extLst xmlns:a="http://schemas.openxmlformats.org/drawingml/2006/main">
               <a:ext uri="{FF2B5EF4-FFF2-40B4-BE49-F238E27FC236}">
-                <a16:creationId xmlns:a16="http://schemas.microsoft.com/office/drawing/2014/main" id="{BE84875D-FE89-4A57-8E2C-FCB9D2C899A3}"/>
+                <a16:creationId xmlns:a16="http://schemas.microsoft.com/office/drawing/2014/main" id="{D478C0C5-6871-4363-B0CF-72360FA6AA7C}"/>
               </a:ext>
             </a:extLst>
           </p:cNvPr>
@@ -14085,7 +14085,7 @@
           <p:cNvPr id="20" name="">
             <a:extLst xmlns:a="http://schemas.openxmlformats.org/drawingml/2006/main">
               <a:ext uri="{FF2B5EF4-FFF2-40B4-BE49-F238E27FC236}">
-                <a16:creationId xmlns:a16="http://schemas.microsoft.com/office/drawing/2014/main" id="{0327FADE-8671-44C0-BF09-B25B11D50A26}"/>
+                <a16:creationId xmlns:a16="http://schemas.microsoft.com/office/drawing/2014/main" id="{0F0C3989-AE56-4764-9A36-43E3EC5BCAFC}"/>
               </a:ext>
             </a:extLst>
           </p:cNvPr>
@@ -14143,7 +14143,7 @@
           <p:cNvPr id="21" name="">
             <a:extLst xmlns:a="http://schemas.openxmlformats.org/drawingml/2006/main">
               <a:ext uri="{FF2B5EF4-FFF2-40B4-BE49-F238E27FC236}">
-                <a16:creationId xmlns:a16="http://schemas.microsoft.com/office/drawing/2014/main" id="{332DDEBC-13B2-4931-A6F7-E511577D288F}"/>
+                <a16:creationId xmlns:a16="http://schemas.microsoft.com/office/drawing/2014/main" id="{EB7791B1-B1A4-4966-93AC-B2DAE34F1021}"/>
               </a:ext>
             </a:extLst>
           </p:cNvPr>
@@ -14216,7 +14216,7 @@
     </p:spTree>
     <p:extLst>
       <p:ext uri="{BB962C8B-B14F-4D97-AF65-F5344CB8AC3E}">
-        <p14:creationId xmlns:p14="http://schemas.microsoft.com/office/powerpoint/2010/main" val="1962554046"/>
+        <p14:creationId xmlns:p14="http://schemas.microsoft.com/office/powerpoint/2010/main" val="1373585848"/>
       </p:ext>
     </p:extLst>
   </p:cSld>
@@ -14247,7 +14247,7 @@
           <p:cNvPr id="19" name="">
             <a:extLst xmlns:a="http://schemas.openxmlformats.org/drawingml/2006/main">
               <a:ext uri="{FF2B5EF4-FFF2-40B4-BE49-F238E27FC236}">
-                <a16:creationId xmlns:a16="http://schemas.microsoft.com/office/drawing/2014/main" id="{858A17BE-56E1-4234-B2FD-60C500EF0810}"/>
+                <a16:creationId xmlns:a16="http://schemas.microsoft.com/office/drawing/2014/main" id="{216C4C34-153B-4F7F-BEA3-6BE6BFC79809}"/>
               </a:ext>
             </a:extLst>
           </p:cNvPr>
@@ -14305,7 +14305,7 @@
           <p:cNvPr id="2" name="">
             <a:extLst xmlns:a="http://schemas.openxmlformats.org/drawingml/2006/main">
               <a:ext uri="{FF2B5EF4-FFF2-40B4-BE49-F238E27FC236}">
-                <a16:creationId xmlns:a16="http://schemas.microsoft.com/office/drawing/2014/main" id="{A8AEC6BA-4166-4B85-8E0B-15A600748427}"/>
+                <a16:creationId xmlns:a16="http://schemas.microsoft.com/office/drawing/2014/main" id="{FD45978E-FF57-4EDD-A7C4-31A6362BE92F}"/>
               </a:ext>
             </a:extLst>
           </p:cNvPr>
@@ -14363,7 +14363,7 @@
           <p:cNvPr id="3" name="">
             <a:extLst xmlns:a="http://schemas.openxmlformats.org/drawingml/2006/main">
               <a:ext uri="{FF2B5EF4-FFF2-40B4-BE49-F238E27FC236}">
-                <a16:creationId xmlns:a16="http://schemas.microsoft.com/office/drawing/2014/main" id="{D347A7A7-79F4-4C43-8583-EE561F412363}"/>
+                <a16:creationId xmlns:a16="http://schemas.microsoft.com/office/drawing/2014/main" id="{686B7622-A15F-4A8B-915A-6196C825C155}"/>
               </a:ext>
             </a:extLst>
           </p:cNvPr>
@@ -14396,7 +14396,7 @@
           <p:cNvPr id="4" name="">
             <a:extLst xmlns:a="http://schemas.openxmlformats.org/drawingml/2006/main">
               <a:ext uri="{FF2B5EF4-FFF2-40B4-BE49-F238E27FC236}">
-                <a16:creationId xmlns:a16="http://schemas.microsoft.com/office/drawing/2014/main" id="{DB7FFF32-A129-4E7C-B554-BFD83D856BAF}"/>
+                <a16:creationId xmlns:a16="http://schemas.microsoft.com/office/drawing/2014/main" id="{19DB055C-A073-4EEE-93D3-9D7C3AC6AA5B}"/>
               </a:ext>
             </a:extLst>
           </p:cNvPr>
@@ -14454,7 +14454,7 @@
           <p:cNvPr id="5" name="">
             <a:extLst xmlns:a="http://schemas.openxmlformats.org/drawingml/2006/main">
               <a:ext uri="{FF2B5EF4-FFF2-40B4-BE49-F238E27FC236}">
-                <a16:creationId xmlns:a16="http://schemas.microsoft.com/office/drawing/2014/main" id="{D9DC5016-2111-45C9-A8DD-9B7BD5E39F84}"/>
+                <a16:creationId xmlns:a16="http://schemas.microsoft.com/office/drawing/2014/main" id="{62406413-657C-41E2-ABE4-C75096AC9093}"/>
               </a:ext>
             </a:extLst>
           </p:cNvPr>
@@ -14512,7 +14512,7 @@
           <p:cNvPr id="6" name="">
             <a:extLst xmlns:a="http://schemas.openxmlformats.org/drawingml/2006/main">
               <a:ext uri="{FF2B5EF4-FFF2-40B4-BE49-F238E27FC236}">
-                <a16:creationId xmlns:a16="http://schemas.microsoft.com/office/drawing/2014/main" id="{1CD26037-43D6-41A7-A43F-90853337AD7B}"/>
+                <a16:creationId xmlns:a16="http://schemas.microsoft.com/office/drawing/2014/main" id="{6AD6DD7B-D284-4D32-A402-97E751448F1A}"/>
               </a:ext>
             </a:extLst>
           </p:cNvPr>
@@ -14547,7 +14547,7 @@
           <p:cNvPr id="7" name="">
             <a:extLst xmlns:a="http://schemas.openxmlformats.org/drawingml/2006/main">
               <a:ext uri="{FF2B5EF4-FFF2-40B4-BE49-F238E27FC236}">
-                <a16:creationId xmlns:a16="http://schemas.microsoft.com/office/drawing/2014/main" id="{F0E774B3-6D6A-41DD-8AB4-253EAA0C5D0B}"/>
+                <a16:creationId xmlns:a16="http://schemas.microsoft.com/office/drawing/2014/main" id="{3E49DDAD-C269-44B1-95BA-D8FC13968DE2}"/>
               </a:ext>
             </a:extLst>
           </p:cNvPr>
@@ -14605,7 +14605,7 @@
           <p:cNvPr id="8" name="">
             <a:extLst xmlns:a="http://schemas.openxmlformats.org/drawingml/2006/main">
               <a:ext uri="{FF2B5EF4-FFF2-40B4-BE49-F238E27FC236}">
-                <a16:creationId xmlns:a16="http://schemas.microsoft.com/office/drawing/2014/main" id="{C61BAA10-43A3-46FA-AA10-94E9D9480589}"/>
+                <a16:creationId xmlns:a16="http://schemas.microsoft.com/office/drawing/2014/main" id="{B7E71FE5-CF7B-459F-8354-18319C7C6D8D}"/>
               </a:ext>
             </a:extLst>
           </p:cNvPr>
@@ -14663,7 +14663,7 @@
           <p:cNvPr id="9" name="">
             <a:extLst xmlns:a="http://schemas.openxmlformats.org/drawingml/2006/main">
               <a:ext uri="{FF2B5EF4-FFF2-40B4-BE49-F238E27FC236}">
-                <a16:creationId xmlns:a16="http://schemas.microsoft.com/office/drawing/2014/main" id="{D43EE301-93B5-43D9-9648-9D44DA770574}"/>
+                <a16:creationId xmlns:a16="http://schemas.microsoft.com/office/drawing/2014/main" id="{472D5A70-31D9-480B-ACE2-B08EFD78CF7F}"/>
               </a:ext>
             </a:extLst>
           </p:cNvPr>
@@ -14698,7 +14698,7 @@
           <p:cNvPr id="10" name="">
             <a:extLst xmlns:a="http://schemas.openxmlformats.org/drawingml/2006/main">
               <a:ext uri="{FF2B5EF4-FFF2-40B4-BE49-F238E27FC236}">
-                <a16:creationId xmlns:a16="http://schemas.microsoft.com/office/drawing/2014/main" id="{FF354491-3FB4-4525-AE87-A22A014F46F3}"/>
+                <a16:creationId xmlns:a16="http://schemas.microsoft.com/office/drawing/2014/main" id="{36E3BE86-8E06-4F19-A410-C9E03EA265B5}"/>
               </a:ext>
             </a:extLst>
           </p:cNvPr>
@@ -14756,7 +14756,7 @@
           <p:cNvPr id="11" name="">
             <a:extLst xmlns:a="http://schemas.openxmlformats.org/drawingml/2006/main">
               <a:ext uri="{FF2B5EF4-FFF2-40B4-BE49-F238E27FC236}">
-                <a16:creationId xmlns:a16="http://schemas.microsoft.com/office/drawing/2014/main" id="{DBE8E13D-8FAD-47FE-9349-AE280F6FF6B1}"/>
+                <a16:creationId xmlns:a16="http://schemas.microsoft.com/office/drawing/2014/main" id="{57C6C232-466C-4936-9872-342BC9103ADC}"/>
               </a:ext>
             </a:extLst>
           </p:cNvPr>
@@ -14814,7 +14814,7 @@
           <p:cNvPr id="12" name="">
             <a:extLst xmlns:a="http://schemas.openxmlformats.org/drawingml/2006/main">
               <a:ext uri="{FF2B5EF4-FFF2-40B4-BE49-F238E27FC236}">
-                <a16:creationId xmlns:a16="http://schemas.microsoft.com/office/drawing/2014/main" id="{89FCC0FC-DF0C-4AD2-970F-9B137346FCA7}"/>
+                <a16:creationId xmlns:a16="http://schemas.microsoft.com/office/drawing/2014/main" id="{7A331D81-0A40-4710-9412-2B0D44554E8F}"/>
               </a:ext>
             </a:extLst>
           </p:cNvPr>
@@ -14849,7 +14849,7 @@
           <p:cNvPr id="13" name="">
             <a:extLst xmlns:a="http://schemas.openxmlformats.org/drawingml/2006/main">
               <a:ext uri="{FF2B5EF4-FFF2-40B4-BE49-F238E27FC236}">
-                <a16:creationId xmlns:a16="http://schemas.microsoft.com/office/drawing/2014/main" id="{2C310574-2AE1-4FB8-9CFD-AB9DD276FF1D}"/>
+                <a16:creationId xmlns:a16="http://schemas.microsoft.com/office/drawing/2014/main" id="{38B2BCBE-2786-4E2A-8628-DF9D0E32ECDF}"/>
               </a:ext>
             </a:extLst>
           </p:cNvPr>
@@ -14907,7 +14907,7 @@
           <p:cNvPr id="14" name="">
             <a:extLst xmlns:a="http://schemas.openxmlformats.org/drawingml/2006/main">
               <a:ext uri="{FF2B5EF4-FFF2-40B4-BE49-F238E27FC236}">
-                <a16:creationId xmlns:a16="http://schemas.microsoft.com/office/drawing/2014/main" id="{D03F8625-B38B-455E-9668-3261277316F6}"/>
+                <a16:creationId xmlns:a16="http://schemas.microsoft.com/office/drawing/2014/main" id="{CF5D2E6A-A85C-4595-9867-D76554062B5C}"/>
               </a:ext>
             </a:extLst>
           </p:cNvPr>
@@ -14965,7 +14965,7 @@
           <p:cNvPr id="15" name="">
             <a:extLst xmlns:a="http://schemas.openxmlformats.org/drawingml/2006/main">
               <a:ext uri="{FF2B5EF4-FFF2-40B4-BE49-F238E27FC236}">
-                <a16:creationId xmlns:a16="http://schemas.microsoft.com/office/drawing/2014/main" id="{8854DAD9-6F45-4647-BA8A-8FD24B9E2EF2}"/>
+                <a16:creationId xmlns:a16="http://schemas.microsoft.com/office/drawing/2014/main" id="{F3820375-664C-4052-AA8E-F8BB010E5C9A}"/>
               </a:ext>
             </a:extLst>
           </p:cNvPr>
@@ -15000,7 +15000,7 @@
           <p:cNvPr id="16" name="">
             <a:extLst xmlns:a="http://schemas.openxmlformats.org/drawingml/2006/main">
               <a:ext uri="{FF2B5EF4-FFF2-40B4-BE49-F238E27FC236}">
-                <a16:creationId xmlns:a16="http://schemas.microsoft.com/office/drawing/2014/main" id="{8171E8D4-00B9-4BC3-BD9D-B9154E5C9BF2}"/>
+                <a16:creationId xmlns:a16="http://schemas.microsoft.com/office/drawing/2014/main" id="{4981EDE5-CBF9-45E0-8893-97C7988FBCD5}"/>
               </a:ext>
             </a:extLst>
           </p:cNvPr>
@@ -15058,7 +15058,7 @@
           <p:cNvPr id="17" name="">
             <a:extLst xmlns:a="http://schemas.openxmlformats.org/drawingml/2006/main">
               <a:ext uri="{FF2B5EF4-FFF2-40B4-BE49-F238E27FC236}">
-                <a16:creationId xmlns:a16="http://schemas.microsoft.com/office/drawing/2014/main" id="{DE8B5C2E-2DBC-4852-8522-02CF699558E2}"/>
+                <a16:creationId xmlns:a16="http://schemas.microsoft.com/office/drawing/2014/main" id="{8DCC213C-B91E-45B1-8502-AA44C7528FCA}"/>
               </a:ext>
             </a:extLst>
           </p:cNvPr>
@@ -15116,7 +15116,7 @@
           <p:cNvPr id="18" name="">
             <a:extLst xmlns:a="http://schemas.openxmlformats.org/drawingml/2006/main">
               <a:ext uri="{FF2B5EF4-FFF2-40B4-BE49-F238E27FC236}">
-                <a16:creationId xmlns:a16="http://schemas.microsoft.com/office/drawing/2014/main" id="{9207329C-E26F-4C72-BEB5-AA2032579549}"/>
+                <a16:creationId xmlns:a16="http://schemas.microsoft.com/office/drawing/2014/main" id="{0A85A778-175A-4DC9-B9D8-92F6E2BC808B}"/>
               </a:ext>
             </a:extLst>
           </p:cNvPr>
@@ -15164,7 +15164,7 @@
                   <a:srgbClr val="17365D"/>
                 </a:solidFill>
               </a:rPr>
-              <a:t>22 pruebas, 10.000.000 de asuntos y 320.000 análisis concurrentes. Sin caídas.</a:t>
+              <a:t>25 pruebas, 10.000.000 de asuntos y 320.000 análisis concurrentes. Sin caídas.</a:t>
             </a:r>
           </a:p>
         </p:txBody>
@@ -15172,7 +15172,7 @@
     </p:spTree>
     <p:extLst>
       <p:ext uri="{BB962C8B-B14F-4D97-AF65-F5344CB8AC3E}">
-        <p14:creationId xmlns:p14="http://schemas.microsoft.com/office/powerpoint/2010/main" val="717857675"/>
+        <p14:creationId xmlns:p14="http://schemas.microsoft.com/office/powerpoint/2010/main" val="1091002571"/>
       </p:ext>
     </p:extLst>
   </p:cSld>

</xml_diff>

<commit_message>
Validate complete use-case flow and align submission artifacts
</commit_message>
<xml_diff>
--- a/entrega/Presentacion_INF513_P1_Grupo09SA.pptx
+++ b/entrega/Presentacion_INF513_P1_Grupo09SA.pptx
@@ -2,22 +2,22 @@
 <file path=ppt/presentation.xml><?xml version="1.0" encoding="utf-8"?>
 <p:presentation xmlns:p="http://schemas.openxmlformats.org/presentationml/2006/main">
   <p:sldMasterIdLst>
-    <p:sldMasterId xmlns:r="http://schemas.openxmlformats.org/officeDocument/2006/relationships" id="2147483648" r:id="R183afeff50024fd0"/>
+    <p:sldMasterId xmlns:r="http://schemas.openxmlformats.org/officeDocument/2006/relationships" id="2147483648" r:id="R7ed961ffbd1b475f"/>
   </p:sldMasterIdLst>
   <p:notesMasterIdLst>
-    <p:notesMasterId xmlns:r="http://schemas.openxmlformats.org/officeDocument/2006/relationships" r:id="Rbd3c606ae14643c7"/>
+    <p:notesMasterId xmlns:r="http://schemas.openxmlformats.org/officeDocument/2006/relationships" r:id="Rd722031819b4451e"/>
   </p:notesMasterIdLst>
   <p:sldIdLst>
-    <p:sldId xmlns:r="http://schemas.openxmlformats.org/officeDocument/2006/relationships" id="256" r:id="R420c54f92e54425a"/>
-    <p:sldId xmlns:r="http://schemas.openxmlformats.org/officeDocument/2006/relationships" id="257" r:id="R9caada273cfc4b9f"/>
-    <p:sldId xmlns:r="http://schemas.openxmlformats.org/officeDocument/2006/relationships" id="258" r:id="R4d01ad2977b74c44"/>
-    <p:sldId xmlns:r="http://schemas.openxmlformats.org/officeDocument/2006/relationships" id="259" r:id="R3ad3a4a63d5047b2"/>
-    <p:sldId xmlns:r="http://schemas.openxmlformats.org/officeDocument/2006/relationships" id="260" r:id="Ra0d68437449b439f"/>
-    <p:sldId xmlns:r="http://schemas.openxmlformats.org/officeDocument/2006/relationships" id="261" r:id="R6b7dc8aae6ce4ba5"/>
-    <p:sldId xmlns:r="http://schemas.openxmlformats.org/officeDocument/2006/relationships" id="262" r:id="R8cb5ae4ec2924e97"/>
-    <p:sldId xmlns:r="http://schemas.openxmlformats.org/officeDocument/2006/relationships" id="263" r:id="Rf514cec670164025"/>
-    <p:sldId xmlns:r="http://schemas.openxmlformats.org/officeDocument/2006/relationships" id="264" r:id="R84a6e119479f42f4"/>
-    <p:sldId xmlns:r="http://schemas.openxmlformats.org/officeDocument/2006/relationships" id="265" r:id="R8fe62bcc405b40ea"/>
+    <p:sldId xmlns:r="http://schemas.openxmlformats.org/officeDocument/2006/relationships" id="256" r:id="R79dc9e09bdb04a9d"/>
+    <p:sldId xmlns:r="http://schemas.openxmlformats.org/officeDocument/2006/relationships" id="257" r:id="Ra071028d44564206"/>
+    <p:sldId xmlns:r="http://schemas.openxmlformats.org/officeDocument/2006/relationships" id="258" r:id="R0ab1252d80be461e"/>
+    <p:sldId xmlns:r="http://schemas.openxmlformats.org/officeDocument/2006/relationships" id="259" r:id="Rdf0edc0b51b84ab3"/>
+    <p:sldId xmlns:r="http://schemas.openxmlformats.org/officeDocument/2006/relationships" id="260" r:id="R5f9b10e15e764cc5"/>
+    <p:sldId xmlns:r="http://schemas.openxmlformats.org/officeDocument/2006/relationships" id="261" r:id="R9f32ea7c85594b5f"/>
+    <p:sldId xmlns:r="http://schemas.openxmlformats.org/officeDocument/2006/relationships" id="262" r:id="R409d652e9b8a442a"/>
+    <p:sldId xmlns:r="http://schemas.openxmlformats.org/officeDocument/2006/relationships" id="263" r:id="R7029ee8fd8cc4abc"/>
+    <p:sldId xmlns:r="http://schemas.openxmlformats.org/officeDocument/2006/relationships" id="264" r:id="Rd6a06fa528cd470d"/>
+    <p:sldId xmlns:r="http://schemas.openxmlformats.org/officeDocument/2006/relationships" id="265" r:id="R68b66eb8910e489b"/>
   </p:sldIdLst>
   <p:sldSz cx="12192000" cy="6858000"/>
   <p:notesSz cx="6858000" cy="9144000"/>
@@ -1139,6 +1139,7 @@
                 <a:spcPts val="0"/>
               </a:spcAft>
               <a:buNone/>
+              <a:defRPr/>
             </a:lvl1pPr>
             <a:lvl2pPr marL="0" indent="0">
               <a:lnSpc>
@@ -1151,6 +1152,7 @@
                 <a:spcPts val="0"/>
               </a:spcAft>
               <a:buNone/>
+              <a:defRPr/>
             </a:lvl2pPr>
             <a:lvl3pPr marL="0" indent="0">
               <a:lnSpc>
@@ -1163,6 +1165,7 @@
                 <a:spcPts val="0"/>
               </a:spcAft>
               <a:buNone/>
+              <a:defRPr/>
             </a:lvl3pPr>
             <a:lvl4pPr marL="0" indent="0">
               <a:lnSpc>
@@ -1175,6 +1178,7 @@
                 <a:spcPts val="0"/>
               </a:spcAft>
               <a:buNone/>
+              <a:defRPr/>
             </a:lvl4pPr>
             <a:lvl5pPr marL="0" indent="0">
               <a:lnSpc>
@@ -1187,6 +1191,7 @@
                 <a:spcPts val="0"/>
               </a:spcAft>
               <a:buNone/>
+              <a:defRPr/>
             </a:lvl5pPr>
             <a:lvl6pPr marL="0" indent="0">
               <a:lnSpc>
@@ -1199,6 +1204,7 @@
                 <a:spcPts val="0"/>
               </a:spcAft>
               <a:buNone/>
+              <a:defRPr/>
             </a:lvl6pPr>
             <a:lvl7pPr marL="0" indent="0">
               <a:lnSpc>
@@ -1211,6 +1217,7 @@
                 <a:spcPts val="0"/>
               </a:spcAft>
               <a:buNone/>
+              <a:defRPr/>
             </a:lvl7pPr>
             <a:lvl8pPr marL="0" indent="0">
               <a:lnSpc>
@@ -1223,6 +1230,7 @@
                 <a:spcPts val="0"/>
               </a:spcAft>
               <a:buNone/>
+              <a:defRPr/>
             </a:lvl8pPr>
             <a:lvl9pPr marL="0" indent="0">
               <a:lnSpc>
@@ -1235,6 +1243,7 @@
                 <a:spcPts val="0"/>
               </a:spcAft>
               <a:buNone/>
+              <a:defRPr/>
             </a:lvl9pPr>
           </a:lstStyle>
           <a:p xmlns:a="http://schemas.openxmlformats.org/drawingml/2006/main"/>
@@ -1296,6 +1305,7 @@
                 <a:spcPts val="0"/>
               </a:spcAft>
               <a:buNone/>
+              <a:defRPr/>
             </a:lvl1pPr>
             <a:lvl2pPr marL="0" indent="0">
               <a:lnSpc>
@@ -1308,6 +1318,7 @@
                 <a:spcPts val="0"/>
               </a:spcAft>
               <a:buNone/>
+              <a:defRPr/>
             </a:lvl2pPr>
             <a:lvl3pPr marL="0" indent="0">
               <a:lnSpc>
@@ -1320,6 +1331,7 @@
                 <a:spcPts val="0"/>
               </a:spcAft>
               <a:buNone/>
+              <a:defRPr/>
             </a:lvl3pPr>
             <a:lvl4pPr marL="0" indent="0">
               <a:lnSpc>
@@ -1332,6 +1344,7 @@
                 <a:spcPts val="0"/>
               </a:spcAft>
               <a:buNone/>
+              <a:defRPr/>
             </a:lvl4pPr>
             <a:lvl5pPr marL="0" indent="0">
               <a:lnSpc>
@@ -1344,6 +1357,7 @@
                 <a:spcPts val="0"/>
               </a:spcAft>
               <a:buNone/>
+              <a:defRPr/>
             </a:lvl5pPr>
             <a:lvl6pPr marL="0" indent="0">
               <a:lnSpc>
@@ -1356,6 +1370,7 @@
                 <a:spcPts val="0"/>
               </a:spcAft>
               <a:buNone/>
+              <a:defRPr/>
             </a:lvl6pPr>
             <a:lvl7pPr marL="0" indent="0">
               <a:lnSpc>
@@ -1368,6 +1383,7 @@
                 <a:spcPts val="0"/>
               </a:spcAft>
               <a:buNone/>
+              <a:defRPr/>
             </a:lvl7pPr>
             <a:lvl8pPr marL="0" indent="0">
               <a:lnSpc>
@@ -1380,6 +1396,7 @@
                 <a:spcPts val="0"/>
               </a:spcAft>
               <a:buNone/>
+              <a:defRPr/>
             </a:lvl8pPr>
             <a:lvl9pPr marL="0" indent="0">
               <a:lnSpc>
@@ -1392,6 +1409,7 @@
                 <a:spcPts val="0"/>
               </a:spcAft>
               <a:buNone/>
+              <a:defRPr/>
             </a:lvl9pPr>
           </a:lstStyle>
           <a:p xmlns:a="http://schemas.openxmlformats.org/drawingml/2006/main"/>
@@ -1470,6 +1488,7 @@
                 <a:spcPts val="0"/>
               </a:spcAft>
               <a:buNone/>
+              <a:defRPr/>
             </a:lvl1pPr>
             <a:lvl2pPr marL="0" indent="0">
               <a:lnSpc>
@@ -1482,6 +1501,7 @@
                 <a:spcPts val="0"/>
               </a:spcAft>
               <a:buNone/>
+              <a:defRPr/>
             </a:lvl2pPr>
             <a:lvl3pPr marL="0" indent="0">
               <a:lnSpc>
@@ -1494,6 +1514,7 @@
                 <a:spcPts val="0"/>
               </a:spcAft>
               <a:buNone/>
+              <a:defRPr/>
             </a:lvl3pPr>
             <a:lvl4pPr marL="0" indent="0">
               <a:lnSpc>
@@ -1506,6 +1527,7 @@
                 <a:spcPts val="0"/>
               </a:spcAft>
               <a:buNone/>
+              <a:defRPr/>
             </a:lvl4pPr>
             <a:lvl5pPr marL="0" indent="0">
               <a:lnSpc>
@@ -1518,6 +1540,7 @@
                 <a:spcPts val="0"/>
               </a:spcAft>
               <a:buNone/>
+              <a:defRPr/>
             </a:lvl5pPr>
             <a:lvl6pPr marL="0" indent="0">
               <a:lnSpc>
@@ -1530,6 +1553,7 @@
                 <a:spcPts val="0"/>
               </a:spcAft>
               <a:buNone/>
+              <a:defRPr/>
             </a:lvl6pPr>
             <a:lvl7pPr marL="0" indent="0">
               <a:lnSpc>
@@ -1542,6 +1566,7 @@
                 <a:spcPts val="0"/>
               </a:spcAft>
               <a:buNone/>
+              <a:defRPr/>
             </a:lvl7pPr>
             <a:lvl8pPr marL="0" indent="0">
               <a:lnSpc>
@@ -1554,6 +1579,7 @@
                 <a:spcPts val="0"/>
               </a:spcAft>
               <a:buNone/>
+              <a:defRPr/>
             </a:lvl8pPr>
             <a:lvl9pPr marL="0" indent="0">
               <a:lnSpc>
@@ -1566,6 +1592,7 @@
                 <a:spcPts val="0"/>
               </a:spcAft>
               <a:buNone/>
+              <a:defRPr/>
             </a:lvl9pPr>
           </a:lstStyle>
           <a:p xmlns:a="http://schemas.openxmlformats.org/drawingml/2006/main"/>
@@ -1644,6 +1671,7 @@
                 <a:spcPts val="0"/>
               </a:spcAft>
               <a:buNone/>
+              <a:defRPr/>
             </a:lvl1pPr>
             <a:lvl2pPr marL="0" indent="0">
               <a:lnSpc>
@@ -1656,6 +1684,7 @@
                 <a:spcPts val="0"/>
               </a:spcAft>
               <a:buNone/>
+              <a:defRPr/>
             </a:lvl2pPr>
             <a:lvl3pPr marL="0" indent="0">
               <a:lnSpc>
@@ -1668,6 +1697,7 @@
                 <a:spcPts val="0"/>
               </a:spcAft>
               <a:buNone/>
+              <a:defRPr/>
             </a:lvl3pPr>
             <a:lvl4pPr marL="0" indent="0">
               <a:lnSpc>
@@ -1680,6 +1710,7 @@
                 <a:spcPts val="0"/>
               </a:spcAft>
               <a:buNone/>
+              <a:defRPr/>
             </a:lvl4pPr>
             <a:lvl5pPr marL="0" indent="0">
               <a:lnSpc>
@@ -1692,6 +1723,7 @@
                 <a:spcPts val="0"/>
               </a:spcAft>
               <a:buNone/>
+              <a:defRPr/>
             </a:lvl5pPr>
             <a:lvl6pPr marL="0" indent="0">
               <a:lnSpc>
@@ -1704,6 +1736,7 @@
                 <a:spcPts val="0"/>
               </a:spcAft>
               <a:buNone/>
+              <a:defRPr/>
             </a:lvl6pPr>
             <a:lvl7pPr marL="0" indent="0">
               <a:lnSpc>
@@ -1716,6 +1749,7 @@
                 <a:spcPts val="0"/>
               </a:spcAft>
               <a:buNone/>
+              <a:defRPr/>
             </a:lvl7pPr>
             <a:lvl8pPr marL="0" indent="0">
               <a:lnSpc>
@@ -1728,6 +1762,7 @@
                 <a:spcPts val="0"/>
               </a:spcAft>
               <a:buNone/>
+              <a:defRPr/>
             </a:lvl8pPr>
             <a:lvl9pPr marL="0" indent="0">
               <a:lnSpc>
@@ -1740,6 +1775,7 @@
                 <a:spcPts val="0"/>
               </a:spcAft>
               <a:buNone/>
+              <a:defRPr/>
             </a:lvl9pPr>
           </a:lstStyle>
           <a:p xmlns:a="http://schemas.openxmlformats.org/drawingml/2006/main"/>
@@ -1801,6 +1837,7 @@
                 <a:spcPts val="1200"/>
               </a:spcAft>
               <a:buChar char="•"/>
+              <a:defRPr/>
             </a:lvl1pPr>
             <a:lvl2pPr marL="533400" indent="-228600">
               <a:lnSpc>
@@ -1813,6 +1850,7 @@
                 <a:spcPts val="1200"/>
               </a:spcAft>
               <a:buChar char="•"/>
+              <a:defRPr/>
             </a:lvl2pPr>
             <a:lvl3pPr marL="838200" indent="-228600">
               <a:lnSpc>
@@ -1825,6 +1863,7 @@
                 <a:spcPts val="1200"/>
               </a:spcAft>
               <a:buChar char="•"/>
+              <a:defRPr/>
             </a:lvl3pPr>
             <a:lvl4pPr marL="1143000" indent="-228600">
               <a:lnSpc>
@@ -1837,6 +1876,7 @@
                 <a:spcPts val="1200"/>
               </a:spcAft>
               <a:buChar char="•"/>
+              <a:defRPr/>
             </a:lvl4pPr>
             <a:lvl5pPr marL="1447800" indent="-228600">
               <a:lnSpc>
@@ -1849,6 +1889,7 @@
                 <a:spcPts val="1200"/>
               </a:spcAft>
               <a:buChar char="•"/>
+              <a:defRPr/>
             </a:lvl5pPr>
             <a:lvl6pPr marL="1752600" indent="-228600">
               <a:lnSpc>
@@ -1861,6 +1902,7 @@
                 <a:spcPts val="1200"/>
               </a:spcAft>
               <a:buChar char="•"/>
+              <a:defRPr/>
             </a:lvl6pPr>
             <a:lvl7pPr marL="2057400" indent="-228600">
               <a:lnSpc>
@@ -1873,6 +1915,7 @@
                 <a:spcPts val="1200"/>
               </a:spcAft>
               <a:buChar char="•"/>
+              <a:defRPr/>
             </a:lvl7pPr>
             <a:lvl8pPr marL="2362200" indent="-228600">
               <a:lnSpc>
@@ -1885,6 +1928,7 @@
                 <a:spcPts val="1200"/>
               </a:spcAft>
               <a:buChar char="•"/>
+              <a:defRPr/>
             </a:lvl8pPr>
             <a:lvl9pPr marL="2667000" indent="-228600">
               <a:lnSpc>
@@ -1897,6 +1941,7 @@
                 <a:spcPts val="1200"/>
               </a:spcAft>
               <a:buChar char="•"/>
+              <a:defRPr/>
             </a:lvl9pPr>
           </a:lstStyle>
           <a:p xmlns:a="http://schemas.openxmlformats.org/drawingml/2006/main"/>
@@ -1975,6 +2020,7 @@
                 <a:spcPts val="0"/>
               </a:spcAft>
               <a:buNone/>
+              <a:defRPr/>
             </a:lvl1pPr>
             <a:lvl2pPr marL="0" indent="0">
               <a:lnSpc>
@@ -1987,6 +2033,7 @@
                 <a:spcPts val="0"/>
               </a:spcAft>
               <a:buNone/>
+              <a:defRPr/>
             </a:lvl2pPr>
             <a:lvl3pPr marL="0" indent="0">
               <a:lnSpc>
@@ -1999,6 +2046,7 @@
                 <a:spcPts val="0"/>
               </a:spcAft>
               <a:buNone/>
+              <a:defRPr/>
             </a:lvl3pPr>
             <a:lvl4pPr marL="0" indent="0">
               <a:lnSpc>
@@ -2011,6 +2059,7 @@
                 <a:spcPts val="0"/>
               </a:spcAft>
               <a:buNone/>
+              <a:defRPr/>
             </a:lvl4pPr>
             <a:lvl5pPr marL="0" indent="0">
               <a:lnSpc>
@@ -2023,6 +2072,7 @@
                 <a:spcPts val="0"/>
               </a:spcAft>
               <a:buNone/>
+              <a:defRPr/>
             </a:lvl5pPr>
             <a:lvl6pPr marL="0" indent="0">
               <a:lnSpc>
@@ -2035,6 +2085,7 @@
                 <a:spcPts val="0"/>
               </a:spcAft>
               <a:buNone/>
+              <a:defRPr/>
             </a:lvl6pPr>
             <a:lvl7pPr marL="0" indent="0">
               <a:lnSpc>
@@ -2047,6 +2098,7 @@
                 <a:spcPts val="0"/>
               </a:spcAft>
               <a:buNone/>
+              <a:defRPr/>
             </a:lvl7pPr>
             <a:lvl8pPr marL="0" indent="0">
               <a:lnSpc>
@@ -2059,6 +2111,7 @@
                 <a:spcPts val="0"/>
               </a:spcAft>
               <a:buNone/>
+              <a:defRPr/>
             </a:lvl8pPr>
             <a:lvl9pPr marL="0" indent="0">
               <a:lnSpc>
@@ -2071,6 +2124,7 @@
                 <a:spcPts val="0"/>
               </a:spcAft>
               <a:buNone/>
+              <a:defRPr/>
             </a:lvl9pPr>
           </a:lstStyle>
           <a:p xmlns:a="http://schemas.openxmlformats.org/drawingml/2006/main"/>
@@ -2132,6 +2186,7 @@
                 <a:spcPts val="1200"/>
               </a:spcAft>
               <a:buChar char="•"/>
+              <a:defRPr/>
             </a:lvl1pPr>
             <a:lvl2pPr marL="533400" indent="-228600">
               <a:lnSpc>
@@ -2144,6 +2199,7 @@
                 <a:spcPts val="1200"/>
               </a:spcAft>
               <a:buChar char="•"/>
+              <a:defRPr/>
             </a:lvl2pPr>
             <a:lvl3pPr marL="838200" indent="-228600">
               <a:lnSpc>
@@ -2156,6 +2212,7 @@
                 <a:spcPts val="1200"/>
               </a:spcAft>
               <a:buChar char="•"/>
+              <a:defRPr/>
             </a:lvl3pPr>
             <a:lvl4pPr marL="1143000" indent="-228600">
               <a:lnSpc>
@@ -2168,6 +2225,7 @@
                 <a:spcPts val="1200"/>
               </a:spcAft>
               <a:buChar char="•"/>
+              <a:defRPr/>
             </a:lvl4pPr>
             <a:lvl5pPr marL="1447800" indent="-228600">
               <a:lnSpc>
@@ -2180,6 +2238,7 @@
                 <a:spcPts val="1200"/>
               </a:spcAft>
               <a:buChar char="•"/>
+              <a:defRPr/>
             </a:lvl5pPr>
             <a:lvl6pPr marL="1752600" indent="-228600">
               <a:lnSpc>
@@ -2192,6 +2251,7 @@
                 <a:spcPts val="1200"/>
               </a:spcAft>
               <a:buChar char="•"/>
+              <a:defRPr/>
             </a:lvl6pPr>
             <a:lvl7pPr marL="2057400" indent="-228600">
               <a:lnSpc>
@@ -2204,6 +2264,7 @@
                 <a:spcPts val="1200"/>
               </a:spcAft>
               <a:buChar char="•"/>
+              <a:defRPr/>
             </a:lvl7pPr>
             <a:lvl8pPr marL="2362200" indent="-228600">
               <a:lnSpc>
@@ -2216,6 +2277,7 @@
                 <a:spcPts val="1200"/>
               </a:spcAft>
               <a:buChar char="•"/>
+              <a:defRPr/>
             </a:lvl8pPr>
             <a:lvl9pPr marL="2667000" indent="-228600">
               <a:lnSpc>
@@ -2228,6 +2290,7 @@
                 <a:spcPts val="1200"/>
               </a:spcAft>
               <a:buChar char="•"/>
+              <a:defRPr/>
             </a:lvl9pPr>
           </a:lstStyle>
           <a:p xmlns:a="http://schemas.openxmlformats.org/drawingml/2006/main"/>
@@ -2289,6 +2352,7 @@
                 <a:spcPts val="1200"/>
               </a:spcAft>
               <a:buChar char="•"/>
+              <a:defRPr/>
             </a:lvl1pPr>
             <a:lvl2pPr marL="533400" indent="-228600">
               <a:lnSpc>
@@ -2301,6 +2365,7 @@
                 <a:spcPts val="1200"/>
               </a:spcAft>
               <a:buChar char="•"/>
+              <a:defRPr/>
             </a:lvl2pPr>
             <a:lvl3pPr marL="838200" indent="-228600">
               <a:lnSpc>
@@ -2313,6 +2378,7 @@
                 <a:spcPts val="1200"/>
               </a:spcAft>
               <a:buChar char="•"/>
+              <a:defRPr/>
             </a:lvl3pPr>
             <a:lvl4pPr marL="1143000" indent="-228600">
               <a:lnSpc>
@@ -2325,6 +2391,7 @@
                 <a:spcPts val="1200"/>
               </a:spcAft>
               <a:buChar char="•"/>
+              <a:defRPr/>
             </a:lvl4pPr>
             <a:lvl5pPr marL="1447800" indent="-228600">
               <a:lnSpc>
@@ -2337,6 +2404,7 @@
                 <a:spcPts val="1200"/>
               </a:spcAft>
               <a:buChar char="•"/>
+              <a:defRPr/>
             </a:lvl5pPr>
             <a:lvl6pPr marL="1752600" indent="-228600">
               <a:lnSpc>
@@ -2349,6 +2417,7 @@
                 <a:spcPts val="1200"/>
               </a:spcAft>
               <a:buChar char="•"/>
+              <a:defRPr/>
             </a:lvl6pPr>
             <a:lvl7pPr marL="2057400" indent="-228600">
               <a:lnSpc>
@@ -2361,6 +2430,7 @@
                 <a:spcPts val="1200"/>
               </a:spcAft>
               <a:buChar char="•"/>
+              <a:defRPr/>
             </a:lvl7pPr>
             <a:lvl8pPr marL="2362200" indent="-228600">
               <a:lnSpc>
@@ -2373,6 +2443,7 @@
                 <a:spcPts val="1200"/>
               </a:spcAft>
               <a:buChar char="•"/>
+              <a:defRPr/>
             </a:lvl8pPr>
             <a:lvl9pPr marL="2667000" indent="-228600">
               <a:lnSpc>
@@ -2385,6 +2456,7 @@
                 <a:spcPts val="1200"/>
               </a:spcAft>
               <a:buChar char="•"/>
+              <a:defRPr/>
             </a:lvl9pPr>
           </a:lstStyle>
           <a:p xmlns:a="http://schemas.openxmlformats.org/drawingml/2006/main"/>
@@ -2463,6 +2535,7 @@
                 <a:spcPts val="0"/>
               </a:spcAft>
               <a:buNone/>
+              <a:defRPr/>
             </a:lvl1pPr>
             <a:lvl2pPr marL="0" indent="0">
               <a:lnSpc>
@@ -2475,6 +2548,7 @@
                 <a:spcPts val="0"/>
               </a:spcAft>
               <a:buNone/>
+              <a:defRPr/>
             </a:lvl2pPr>
             <a:lvl3pPr marL="0" indent="0">
               <a:lnSpc>
@@ -2487,6 +2561,7 @@
                 <a:spcPts val="0"/>
               </a:spcAft>
               <a:buNone/>
+              <a:defRPr/>
             </a:lvl3pPr>
             <a:lvl4pPr marL="0" indent="0">
               <a:lnSpc>
@@ -2499,6 +2574,7 @@
                 <a:spcPts val="0"/>
               </a:spcAft>
               <a:buNone/>
+              <a:defRPr/>
             </a:lvl4pPr>
             <a:lvl5pPr marL="0" indent="0">
               <a:lnSpc>
@@ -2511,6 +2587,7 @@
                 <a:spcPts val="0"/>
               </a:spcAft>
               <a:buNone/>
+              <a:defRPr/>
             </a:lvl5pPr>
             <a:lvl6pPr marL="0" indent="0">
               <a:lnSpc>
@@ -2523,6 +2600,7 @@
                 <a:spcPts val="0"/>
               </a:spcAft>
               <a:buNone/>
+              <a:defRPr/>
             </a:lvl6pPr>
             <a:lvl7pPr marL="0" indent="0">
               <a:lnSpc>
@@ -2535,6 +2613,7 @@
                 <a:spcPts val="0"/>
               </a:spcAft>
               <a:buNone/>
+              <a:defRPr/>
             </a:lvl7pPr>
             <a:lvl8pPr marL="0" indent="0">
               <a:lnSpc>
@@ -2547,6 +2626,7 @@
                 <a:spcPts val="0"/>
               </a:spcAft>
               <a:buNone/>
+              <a:defRPr/>
             </a:lvl8pPr>
             <a:lvl9pPr marL="0" indent="0">
               <a:lnSpc>
@@ -2559,6 +2639,7 @@
                 <a:spcPts val="0"/>
               </a:spcAft>
               <a:buNone/>
+              <a:defRPr/>
             </a:lvl9pPr>
           </a:lstStyle>
           <a:p xmlns:a="http://schemas.openxmlformats.org/drawingml/2006/main"/>
@@ -2620,6 +2701,7 @@
                 <a:spcPts val="1200"/>
               </a:spcAft>
               <a:buChar char="•"/>
+              <a:defRPr/>
             </a:lvl1pPr>
             <a:lvl2pPr marL="533400" indent="-228600">
               <a:lnSpc>
@@ -2632,6 +2714,7 @@
                 <a:spcPts val="1200"/>
               </a:spcAft>
               <a:buChar char="•"/>
+              <a:defRPr/>
             </a:lvl2pPr>
             <a:lvl3pPr marL="838200" indent="-228600">
               <a:lnSpc>
@@ -2644,6 +2727,7 @@
                 <a:spcPts val="1200"/>
               </a:spcAft>
               <a:buChar char="•"/>
+              <a:defRPr/>
             </a:lvl3pPr>
             <a:lvl4pPr marL="1143000" indent="-228600">
               <a:lnSpc>
@@ -2656,6 +2740,7 @@
                 <a:spcPts val="1200"/>
               </a:spcAft>
               <a:buChar char="•"/>
+              <a:defRPr/>
             </a:lvl4pPr>
             <a:lvl5pPr marL="1447800" indent="-228600">
               <a:lnSpc>
@@ -2668,6 +2753,7 @@
                 <a:spcPts val="1200"/>
               </a:spcAft>
               <a:buChar char="•"/>
+              <a:defRPr/>
             </a:lvl5pPr>
             <a:lvl6pPr marL="1752600" indent="-228600">
               <a:lnSpc>
@@ -2680,6 +2766,7 @@
                 <a:spcPts val="1200"/>
               </a:spcAft>
               <a:buChar char="•"/>
+              <a:defRPr/>
             </a:lvl6pPr>
             <a:lvl7pPr marL="2057400" indent="-228600">
               <a:lnSpc>
@@ -2692,6 +2779,7 @@
                 <a:spcPts val="1200"/>
               </a:spcAft>
               <a:buChar char="•"/>
+              <a:defRPr/>
             </a:lvl7pPr>
             <a:lvl8pPr marL="2362200" indent="-228600">
               <a:lnSpc>
@@ -2704,6 +2792,7 @@
                 <a:spcPts val="1200"/>
               </a:spcAft>
               <a:buChar char="•"/>
+              <a:defRPr/>
             </a:lvl8pPr>
             <a:lvl9pPr marL="2667000" indent="-228600">
               <a:lnSpc>
@@ -2716,6 +2805,7 @@
                 <a:spcPts val="1200"/>
               </a:spcAft>
               <a:buChar char="•"/>
+              <a:defRPr/>
             </a:lvl9pPr>
           </a:lstStyle>
           <a:p xmlns:a="http://schemas.openxmlformats.org/drawingml/2006/main"/>
@@ -2764,12 +2854,12 @@
   </p:cSld>
   <p:clrMap bg1="lt1" tx1="dk1" bg2="lt2" tx2="dk2" accent1="accent1" accent2="accent2" accent3="accent3" accent4="accent4" accent5="accent5" accent6="accent6" hlink="hlink" folHlink="folHlink"/>
   <p:sldLayoutIdLst>
-    <p:sldLayoutId xmlns:r="http://schemas.openxmlformats.org/officeDocument/2006/relationships" id="2147483649" r:id="Rc11bb933e4fa4ae3"/>
-    <p:sldLayoutId xmlns:r="http://schemas.openxmlformats.org/officeDocument/2006/relationships" id="2147483650" r:id="Ra4a80b84e41d4ec3"/>
-    <p:sldLayoutId xmlns:r="http://schemas.openxmlformats.org/officeDocument/2006/relationships" id="2147483651" r:id="R7a229c219a1b4386"/>
-    <p:sldLayoutId xmlns:r="http://schemas.openxmlformats.org/officeDocument/2006/relationships" id="2147483652" r:id="Refdd83a9a9634b94"/>
-    <p:sldLayoutId xmlns:r="http://schemas.openxmlformats.org/officeDocument/2006/relationships" id="2147483653" r:id="R3d5496c736474d35"/>
-    <p:sldLayoutId xmlns:r="http://schemas.openxmlformats.org/officeDocument/2006/relationships" id="2147483654" r:id="Re168382099c64249"/>
+    <p:sldLayoutId xmlns:r="http://schemas.openxmlformats.org/officeDocument/2006/relationships" id="2147483649" r:id="R8b357c76e8c7418c"/>
+    <p:sldLayoutId xmlns:r="http://schemas.openxmlformats.org/officeDocument/2006/relationships" id="2147483650" r:id="Rd8e6bd654cb94bd3"/>
+    <p:sldLayoutId xmlns:r="http://schemas.openxmlformats.org/officeDocument/2006/relationships" id="2147483651" r:id="R83504fd505614c91"/>
+    <p:sldLayoutId xmlns:r="http://schemas.openxmlformats.org/officeDocument/2006/relationships" id="2147483652" r:id="R8706b6aba6ce4984"/>
+    <p:sldLayoutId xmlns:r="http://schemas.openxmlformats.org/officeDocument/2006/relationships" id="2147483653" r:id="R3d713d05f62d40cc"/>
+    <p:sldLayoutId xmlns:r="http://schemas.openxmlformats.org/officeDocument/2006/relationships" id="2147483654" r:id="R582940c72a8a445f"/>
   </p:sldLayoutIdLst>
   <p:txStyles>
     <p:titleStyle>
@@ -3356,6 +3446,7 @@
           </a:lstStyle>
           <a:p xmlns:a="http://schemas.openxmlformats.org/drawingml/2006/main">
             <a:pPr>
+              <a:buNone/>
               <a:defRPr sz="1125" b="1">
                 <a:solidFill>
                   <a:srgbClr val="2F75B5"/>
@@ -3414,6 +3505,7 @@
           </a:lstStyle>
           <a:p xmlns:a="http://schemas.openxmlformats.org/drawingml/2006/main">
             <a:pPr>
+              <a:buNone/>
               <a:defRPr sz="3450" b="1">
                 <a:solidFill>
                   <a:srgbClr val="16202A"/>
@@ -3472,6 +3564,7 @@
           </a:lstStyle>
           <a:p xmlns:a="http://schemas.openxmlformats.org/drawingml/2006/main">
             <a:pPr>
+              <a:buNone/>
               <a:defRPr sz="1650" b="1">
                 <a:solidFill>
                   <a:srgbClr val="2F75B5"/>
@@ -3484,7 +3577,7 @@
                   <a:srgbClr val="2F75B5"/>
                 </a:solidFill>
               </a:rPr>
-              <a:t>Proyecto 1  |  Grupo 09 SA</a:t>
+              <a:t>Proyecto 1   Grupo 09 SA</a:t>
             </a:r>
           </a:p>
         </p:txBody>
@@ -3565,6 +3658,7 @@
           </a:lstStyle>
           <a:p xmlns:a="http://schemas.openxmlformats.org/drawingml/2006/main">
             <a:pPr>
+              <a:buNone/>
               <a:defRPr sz="2025" b="1">
                 <a:solidFill>
                   <a:srgbClr val="FFFFFF"/>
@@ -3623,6 +3717,7 @@
           </a:lstStyle>
           <a:p xmlns:a="http://schemas.openxmlformats.org/drawingml/2006/main">
             <a:pPr>
+              <a:buNone/>
               <a:defRPr sz="1275" b="0">
                 <a:solidFill>
                   <a:srgbClr val="FFFFFF"/>
@@ -3640,6 +3735,7 @@
           </a:p>
           <a:p xmlns:a="http://schemas.openxmlformats.org/drawingml/2006/main">
             <a:pPr>
+              <a:buNone/>
               <a:defRPr sz="1275" b="0">
                 <a:solidFill>
                   <a:srgbClr val="FFFFFF"/>
@@ -3662,6 +3758,7 @@
           </a:p>
           <a:p xmlns:a="http://schemas.openxmlformats.org/drawingml/2006/main">
             <a:pPr>
+              <a:buNone/>
               <a:defRPr sz="1275" b="0">
                 <a:solidFill>
                   <a:srgbClr val="FFFFFF"/>
@@ -3679,6 +3776,7 @@
           </a:p>
           <a:p xmlns:a="http://schemas.openxmlformats.org/drawingml/2006/main">
             <a:pPr>
+              <a:buNone/>
               <a:defRPr sz="1275" b="0">
                 <a:solidFill>
                   <a:srgbClr val="FFFFFF"/>
@@ -3701,6 +3799,7 @@
           </a:p>
           <a:p xmlns:a="http://schemas.openxmlformats.org/drawingml/2006/main">
             <a:pPr>
+              <a:buNone/>
               <a:defRPr sz="1275" b="0">
                 <a:solidFill>
                   <a:srgbClr val="FFFFFF"/>
@@ -3718,6 +3817,7 @@
           </a:p>
           <a:p xmlns:a="http://schemas.openxmlformats.org/drawingml/2006/main">
             <a:pPr>
+              <a:buNone/>
               <a:defRPr sz="1275" b="0">
                 <a:solidFill>
                   <a:srgbClr val="FFFFFF"/>
@@ -3776,6 +3876,7 @@
           </a:lstStyle>
           <a:p xmlns:a="http://schemas.openxmlformats.org/drawingml/2006/main">
             <a:pPr>
+              <a:buNone/>
               <a:defRPr sz="1350" b="0">
                 <a:solidFill>
                   <a:srgbClr val="52606D"/>
@@ -3793,6 +3894,7 @@
           </a:p>
           <a:p xmlns:a="http://schemas.openxmlformats.org/drawingml/2006/main">
             <a:pPr>
+              <a:buNone/>
               <a:defRPr sz="1350" b="0">
                 <a:solidFill>
                   <a:srgbClr val="52606D"/>
@@ -3880,6 +3982,7 @@
           </a:lstStyle>
           <a:p xmlns:a="http://schemas.openxmlformats.org/drawingml/2006/main">
             <a:pPr>
+              <a:buNone/>
               <a:defRPr sz="975" b="1">
                 <a:solidFill>
                   <a:srgbClr val="2F75B5"/>
@@ -3892,7 +3995,7 @@
                   <a:srgbClr val="2F75B5"/>
                 </a:solidFill>
               </a:rPr>
-              <a:t>PROYECTO 1  |  INF513</a:t>
+              <a:t>PROYECTO 1   INF513</a:t>
             </a:r>
           </a:p>
         </p:txBody>
@@ -3938,6 +4041,7 @@
           </a:lstStyle>
           <a:p xmlns:a="http://schemas.openxmlformats.org/drawingml/2006/main">
             <a:pPr>
+              <a:buNone/>
               <a:defRPr sz="2550" b="1">
                 <a:solidFill>
                   <a:srgbClr val="16202A"/>
@@ -4029,6 +4133,7 @@
           </a:lstStyle>
           <a:p xmlns:a="http://schemas.openxmlformats.org/drawingml/2006/main">
             <a:pPr>
+              <a:buNone/>
               <a:defRPr sz="900" b="0">
                 <a:solidFill>
                   <a:srgbClr val="52606D"/>
@@ -4087,6 +4192,7 @@
           </a:lstStyle>
           <a:p xmlns:a="http://schemas.openxmlformats.org/drawingml/2006/main">
             <a:pPr>
+              <a:buNone/>
               <a:defRPr sz="900" b="0">
                 <a:solidFill>
                   <a:srgbClr val="52606D"/>
@@ -4145,6 +4251,7 @@
           </a:lstStyle>
           <a:p xmlns:a="http://schemas.openxmlformats.org/drawingml/2006/main">
             <a:pPr>
+              <a:buNone/>
               <a:defRPr sz="2400" b="1">
                 <a:solidFill>
                   <a:srgbClr val="17365D"/>
@@ -4203,6 +4310,7 @@
           </a:lstStyle>
           <a:p xmlns:a="http://schemas.openxmlformats.org/drawingml/2006/main">
             <a:pPr>
+              <a:buNone/>
               <a:defRPr sz="1650" b="1">
                 <a:solidFill>
                   <a:srgbClr val="2F75B5"/>
@@ -4329,6 +4437,7 @@
           </a:lstStyle>
           <a:p xmlns:a="http://schemas.openxmlformats.org/drawingml/2006/main">
             <a:pPr>
+              <a:buNone/>
               <a:defRPr sz="1500" b="1">
                 <a:solidFill>
                   <a:srgbClr val="16202A"/>
@@ -4387,6 +4496,7 @@
           </a:lstStyle>
           <a:p xmlns:a="http://schemas.openxmlformats.org/drawingml/2006/main">
             <a:pPr>
+              <a:buNone/>
               <a:defRPr sz="1200" b="0">
                 <a:solidFill>
                   <a:srgbClr val="52606D"/>
@@ -4399,11 +4509,12 @@
                   <a:srgbClr val="52606D"/>
                 </a:solidFill>
               </a:rPr>
-              <a:t>1. Explicar el formato del asunto</a:t>
-            </a:r>
-          </a:p>
-          <a:p xmlns:a="http://schemas.openxmlformats.org/drawingml/2006/main">
-            <a:pPr>
+              <a:t>1. Explicar el asunto y CONFIRMAR</a:t>
+            </a:r>
+          </a:p>
+          <a:p xmlns:a="http://schemas.openxmlformats.org/drawingml/2006/main">
+            <a:pPr>
+              <a:buNone/>
               <a:defRPr sz="1200" b="0">
                 <a:solidFill>
                   <a:srgbClr val="52606D"/>
@@ -4416,11 +4527,12 @@
                   <a:srgbClr val="52606D"/>
                 </a:solidFill>
               </a:rPr>
-              <a:t>2. Iniciar en Windows o Fedora</a:t>
-            </a:r>
-          </a:p>
-          <a:p xmlns:a="http://schemas.openxmlformats.org/drawingml/2006/main">
-            <a:pPr>
+              <a:t>2. Iniciar el servicio Java</a:t>
+            </a:r>
+          </a:p>
+          <a:p xmlns:a="http://schemas.openxmlformats.org/drawingml/2006/main">
+            <a:pPr>
+              <a:buNone/>
               <a:defRPr sz="1200" b="0">
                 <a:solidFill>
                   <a:srgbClr val="52606D"/>
@@ -4433,11 +4545,12 @@
                   <a:srgbClr val="52606D"/>
                 </a:solidFill>
               </a:rPr>
-              <a:t>3. Enviar AYUDA y una consulta</a:t>
-            </a:r>
-          </a:p>
-          <a:p xmlns:a="http://schemas.openxmlformats.org/drawingml/2006/main">
-            <a:pPr>
+              <a:t>3. Mostrar consultas y cambios</a:t>
+            </a:r>
+          </a:p>
+          <a:p xmlns:a="http://schemas.openxmlformats.org/drawingml/2006/main">
+            <a:pPr>
+              <a:buNone/>
               <a:defRPr sz="1200" b="0">
                 <a:solidFill>
                   <a:srgbClr val="52606D"/>
@@ -4450,7 +4563,7 @@
                   <a:srgbClr val="52606D"/>
                 </a:solidFill>
               </a:rPr>
-              <a:t>4. Mostrar cola, reintentos y auditoría</a:t>
+              <a:t>4. Mostrar cola y auditoría</a:t>
             </a:r>
           </a:p>
         </p:txBody>
@@ -4564,6 +4677,7 @@
           </a:lstStyle>
           <a:p xmlns:a="http://schemas.openxmlformats.org/drawingml/2006/main">
             <a:pPr>
+              <a:buNone/>
               <a:defRPr sz="1500" b="1">
                 <a:solidFill>
                   <a:srgbClr val="16202A"/>
@@ -4622,6 +4736,7 @@
           </a:lstStyle>
           <a:p xmlns:a="http://schemas.openxmlformats.org/drawingml/2006/main">
             <a:pPr>
+              <a:buNone/>
               <a:defRPr sz="1200" b="0">
                 <a:solidFill>
                   <a:srgbClr val="52606D"/>
@@ -4634,11 +4749,12 @@
                   <a:srgbClr val="52606D"/>
                 </a:solidFill>
               </a:rPr>
-              <a:t>Cola durable e idempotencia</a:t>
-            </a:r>
-          </a:p>
-          <a:p xmlns:a="http://schemas.openxmlformats.org/drawingml/2006/main">
-            <a:pPr>
+              <a:t>Confirmación por correo</a:t>
+            </a:r>
+          </a:p>
+          <a:p xmlns:a="http://schemas.openxmlformats.org/drawingml/2006/main">
+            <a:pPr>
+              <a:buNone/>
               <a:defRPr sz="1200" b="0">
                 <a:solidFill>
                   <a:srgbClr val="52606D"/>
@@ -4651,11 +4767,12 @@
                   <a:srgbClr val="52606D"/>
                 </a:solidFill>
               </a:rPr>
-              <a:t>Reintentos con límite</a:t>
-            </a:r>
-          </a:p>
-          <a:p xmlns:a="http://schemas.openxmlformats.org/drawingml/2006/main">
-            <a:pPr>
+              <a:t>Cola durable y reintentos</a:t>
+            </a:r>
+          </a:p>
+          <a:p xmlns:a="http://schemas.openxmlformats.org/drawingml/2006/main">
+            <a:pPr>
+              <a:buNone/>
               <a:defRPr sz="1200" b="0">
                 <a:solidFill>
                   <a:srgbClr val="52606D"/>
@@ -4673,6 +4790,7 @@
           </a:p>
           <a:p xmlns:a="http://schemas.openxmlformats.org/drawingml/2006/main">
             <a:pPr>
+              <a:buNone/>
               <a:defRPr sz="1200" b="0">
                 <a:solidFill>
                   <a:srgbClr val="52606D"/>
@@ -4685,11 +4803,12 @@
                   <a:srgbClr val="52606D"/>
                 </a:solidFill>
               </a:rPr>
-              <a:t>PUDS, presentación y código</a:t>
-            </a:r>
-          </a:p>
-          <a:p xmlns:a="http://schemas.openxmlformats.org/drawingml/2006/main">
-            <a:pPr>
+              <a:t>Informe, presentación y código</a:t>
+            </a:r>
+          </a:p>
+          <a:p xmlns:a="http://schemas.openxmlformats.org/drawingml/2006/main">
+            <a:pPr>
+              <a:buNone/>
               <a:defRPr sz="1200" b="0">
                 <a:solidFill>
                   <a:srgbClr val="52606D"/>
@@ -4748,6 +4867,7 @@
           </a:lstStyle>
           <a:p xmlns:a="http://schemas.openxmlformats.org/drawingml/2006/main">
             <a:pPr>
+              <a:buNone/>
               <a:defRPr sz="1800" b="1">
                 <a:solidFill>
                   <a:srgbClr val="16202A"/>
@@ -4835,6 +4955,7 @@
           </a:lstStyle>
           <a:p xmlns:a="http://schemas.openxmlformats.org/drawingml/2006/main">
             <a:pPr>
+              <a:buNone/>
               <a:defRPr sz="975" b="1">
                 <a:solidFill>
                   <a:srgbClr val="2F75B5"/>
@@ -4847,7 +4968,7 @@
                   <a:srgbClr val="2F75B5"/>
                 </a:solidFill>
               </a:rPr>
-              <a:t>PROYECTO 1  |  INF513</a:t>
+              <a:t>PROYECTO 1   INF513</a:t>
             </a:r>
           </a:p>
         </p:txBody>
@@ -4893,6 +5014,7 @@
           </a:lstStyle>
           <a:p xmlns:a="http://schemas.openxmlformats.org/drawingml/2006/main">
             <a:pPr>
+              <a:buNone/>
               <a:defRPr sz="2550" b="1">
                 <a:solidFill>
                   <a:srgbClr val="16202A"/>
@@ -4984,6 +5106,7 @@
           </a:lstStyle>
           <a:p xmlns:a="http://schemas.openxmlformats.org/drawingml/2006/main">
             <a:pPr>
+              <a:buNone/>
               <a:defRPr sz="900" b="0">
                 <a:solidFill>
                   <a:srgbClr val="52606D"/>
@@ -5042,6 +5165,7 @@
           </a:lstStyle>
           <a:p xmlns:a="http://schemas.openxmlformats.org/drawingml/2006/main">
             <a:pPr>
+              <a:buNone/>
               <a:defRPr sz="900" b="0">
                 <a:solidFill>
                   <a:srgbClr val="52606D"/>
@@ -5168,6 +5292,7 @@
           </a:lstStyle>
           <a:p xmlns:a="http://schemas.openxmlformats.org/drawingml/2006/main">
             <a:pPr>
+              <a:buNone/>
               <a:defRPr sz="1500" b="1">
                 <a:solidFill>
                   <a:srgbClr val="16202A"/>
@@ -5226,6 +5351,7 @@
           </a:lstStyle>
           <a:p xmlns:a="http://schemas.openxmlformats.org/drawingml/2006/main">
             <a:pPr>
+              <a:buNone/>
               <a:defRPr sz="1200" b="0">
                 <a:solidFill>
                   <a:srgbClr val="52606D"/>
@@ -5352,6 +5478,7 @@
           </a:lstStyle>
           <a:p xmlns:a="http://schemas.openxmlformats.org/drawingml/2006/main">
             <a:pPr>
+              <a:buNone/>
               <a:defRPr sz="1500" b="1">
                 <a:solidFill>
                   <a:srgbClr val="16202A"/>
@@ -5410,6 +5537,7 @@
           </a:lstStyle>
           <a:p xmlns:a="http://schemas.openxmlformats.org/drawingml/2006/main">
             <a:pPr>
+              <a:buNone/>
               <a:defRPr sz="1200" b="0">
                 <a:solidFill>
                   <a:srgbClr val="52606D"/>
@@ -5422,7 +5550,7 @@
                   <a:srgbClr val="52606D"/>
                 </a:solidFill>
               </a:rPr>
-              <a:t>Java valida el comando, los parámetros y el rol antes de ejecutar SQL.</a:t>
+              <a:t>Java valida los datos y solicita confirmación para cada operación sensible.</a:t>
             </a:r>
           </a:p>
         </p:txBody>
@@ -5536,6 +5664,7 @@
           </a:lstStyle>
           <a:p xmlns:a="http://schemas.openxmlformats.org/drawingml/2006/main">
             <a:pPr>
+              <a:buNone/>
               <a:defRPr sz="1500" b="1">
                 <a:solidFill>
                   <a:srgbClr val="16202A"/>
@@ -5594,6 +5723,7 @@
           </a:lstStyle>
           <a:p xmlns:a="http://schemas.openxmlformats.org/drawingml/2006/main">
             <a:pPr>
+              <a:buNone/>
               <a:defRPr sz="1200" b="0">
                 <a:solidFill>
                   <a:srgbClr val="52606D"/>
@@ -5652,6 +5782,7 @@
           </a:lstStyle>
           <a:p xmlns:a="http://schemas.openxmlformats.org/drawingml/2006/main">
             <a:pPr>
+              <a:buNone/>
               <a:defRPr sz="1350" b="1">
                 <a:solidFill>
                   <a:srgbClr val="52606D"/>
@@ -5745,6 +5876,7 @@
           </a:lstStyle>
           <a:p xmlns:a="http://schemas.openxmlformats.org/drawingml/2006/main">
             <a:pPr>
+              <a:buNone/>
               <a:defRPr sz="2025" b="1">
                 <a:solidFill>
                   <a:srgbClr val="FFFFFF"/>
@@ -5803,6 +5935,7 @@
           </a:lstStyle>
           <a:p xmlns:a="http://schemas.openxmlformats.org/drawingml/2006/main">
             <a:pPr>
+              <a:buNone/>
               <a:defRPr sz="1725" b="0">
                 <a:solidFill>
                   <a:srgbClr val="FFFFFF"/>
@@ -5890,6 +6023,7 @@
           </a:lstStyle>
           <a:p xmlns:a="http://schemas.openxmlformats.org/drawingml/2006/main">
             <a:pPr>
+              <a:buNone/>
               <a:defRPr sz="975" b="1">
                 <a:solidFill>
                   <a:srgbClr val="2F75B5"/>
@@ -5902,7 +6036,7 @@
                   <a:srgbClr val="2F75B5"/>
                 </a:solidFill>
               </a:rPr>
-              <a:t>PROYECTO 1  |  INF513</a:t>
+              <a:t>PROYECTO 1   INF513</a:t>
             </a:r>
           </a:p>
         </p:txBody>
@@ -5948,6 +6082,7 @@
           </a:lstStyle>
           <a:p xmlns:a="http://schemas.openxmlformats.org/drawingml/2006/main">
             <a:pPr>
+              <a:buNone/>
               <a:defRPr sz="2550" b="1">
                 <a:solidFill>
                   <a:srgbClr val="16202A"/>
@@ -6039,6 +6174,7 @@
           </a:lstStyle>
           <a:p xmlns:a="http://schemas.openxmlformats.org/drawingml/2006/main">
             <a:pPr>
+              <a:buNone/>
               <a:defRPr sz="900" b="0">
                 <a:solidFill>
                   <a:srgbClr val="52606D"/>
@@ -6097,6 +6233,7 @@
           </a:lstStyle>
           <a:p xmlns:a="http://schemas.openxmlformats.org/drawingml/2006/main">
             <a:pPr>
+              <a:buNone/>
               <a:defRPr sz="900" b="0">
                 <a:solidFill>
                   <a:srgbClr val="52606D"/>
@@ -6190,6 +6327,7 @@
           </a:lstStyle>
           <a:p xmlns:a="http://schemas.openxmlformats.org/drawingml/2006/main">
             <a:pPr>
+              <a:buNone/>
               <a:defRPr sz="1725" b="1">
                 <a:solidFill>
                   <a:srgbClr val="FFFFFF"/>
@@ -6279,6 +6417,7 @@
           </a:lstStyle>
           <a:p xmlns:a="http://schemas.openxmlformats.org/drawingml/2006/main">
             <a:pPr>
+              <a:buNone/>
               <a:defRPr sz="1800" b="1">
                 <a:solidFill>
                   <a:srgbClr val="16202A"/>
@@ -6337,6 +6476,7 @@
           </a:lstStyle>
           <a:p xmlns:a="http://schemas.openxmlformats.org/drawingml/2006/main">
             <a:pPr>
+              <a:buNone/>
               <a:defRPr sz="1125" b="0">
                 <a:solidFill>
                   <a:srgbClr val="52606D"/>
@@ -6395,6 +6535,7 @@
           </a:lstStyle>
           <a:p xmlns:a="http://schemas.openxmlformats.org/drawingml/2006/main">
             <a:pPr>
+              <a:buNone/>
               <a:defRPr sz="3150" b="1">
                 <a:solidFill>
                   <a:srgbClr val="2F75B5"/>
@@ -6488,6 +6629,7 @@
           </a:lstStyle>
           <a:p xmlns:a="http://schemas.openxmlformats.org/drawingml/2006/main">
             <a:pPr>
+              <a:buNone/>
               <a:defRPr sz="1725" b="1">
                 <a:solidFill>
                   <a:srgbClr val="FFFFFF"/>
@@ -6577,6 +6719,7 @@
           </a:lstStyle>
           <a:p xmlns:a="http://schemas.openxmlformats.org/drawingml/2006/main">
             <a:pPr>
+              <a:buNone/>
               <a:defRPr sz="1800" b="1">
                 <a:solidFill>
                   <a:srgbClr val="16202A"/>
@@ -6635,6 +6778,7 @@
           </a:lstStyle>
           <a:p xmlns:a="http://schemas.openxmlformats.org/drawingml/2006/main">
             <a:pPr>
+              <a:buNone/>
               <a:defRPr sz="1125" b="0">
                 <a:solidFill>
                   <a:srgbClr val="52606D"/>
@@ -6693,6 +6837,7 @@
           </a:lstStyle>
           <a:p xmlns:a="http://schemas.openxmlformats.org/drawingml/2006/main">
             <a:pPr>
+              <a:buNone/>
               <a:defRPr sz="3150" b="1">
                 <a:solidFill>
                   <a:srgbClr val="2F75B5"/>
@@ -6786,6 +6931,7 @@
           </a:lstStyle>
           <a:p xmlns:a="http://schemas.openxmlformats.org/drawingml/2006/main">
             <a:pPr>
+              <a:buNone/>
               <a:defRPr sz="1725" b="1">
                 <a:solidFill>
                   <a:srgbClr val="FFFFFF"/>
@@ -6875,6 +7021,7 @@
           </a:lstStyle>
           <a:p xmlns:a="http://schemas.openxmlformats.org/drawingml/2006/main">
             <a:pPr>
+              <a:buNone/>
               <a:defRPr sz="1800" b="1">
                 <a:solidFill>
                   <a:srgbClr val="16202A"/>
@@ -6933,6 +7080,7 @@
           </a:lstStyle>
           <a:p xmlns:a="http://schemas.openxmlformats.org/drawingml/2006/main">
             <a:pPr>
+              <a:buNone/>
               <a:defRPr sz="1125" b="0">
                 <a:solidFill>
                   <a:srgbClr val="52606D"/>
@@ -6945,7 +7093,7 @@
                   <a:srgbClr val="52606D"/>
                 </a:solidFill>
               </a:rPr>
-              <a:t>Sintaxis, permisos y reglas</a:t>
+              <a:t>Sintaxis, confirmación y permisos</a:t>
             </a:r>
           </a:p>
         </p:txBody>
@@ -6991,6 +7139,7 @@
           </a:lstStyle>
           <a:p xmlns:a="http://schemas.openxmlformats.org/drawingml/2006/main">
             <a:pPr>
+              <a:buNone/>
               <a:defRPr sz="3150" b="1">
                 <a:solidFill>
                   <a:srgbClr val="2F75B5"/>
@@ -7084,6 +7233,7 @@
           </a:lstStyle>
           <a:p xmlns:a="http://schemas.openxmlformats.org/drawingml/2006/main">
             <a:pPr>
+              <a:buNone/>
               <a:defRPr sz="1725" b="1">
                 <a:solidFill>
                   <a:srgbClr val="FFFFFF"/>
@@ -7173,6 +7323,7 @@
           </a:lstStyle>
           <a:p xmlns:a="http://schemas.openxmlformats.org/drawingml/2006/main">
             <a:pPr>
+              <a:buNone/>
               <a:defRPr sz="1800" b="1">
                 <a:solidFill>
                   <a:srgbClr val="16202A"/>
@@ -7231,6 +7382,7 @@
           </a:lstStyle>
           <a:p xmlns:a="http://schemas.openxmlformats.org/drawingml/2006/main">
             <a:pPr>
+              <a:buNone/>
               <a:defRPr sz="1125" b="0">
                 <a:solidFill>
                   <a:srgbClr val="52606D"/>
@@ -7289,6 +7441,7 @@
           </a:lstStyle>
           <a:p xmlns:a="http://schemas.openxmlformats.org/drawingml/2006/main">
             <a:pPr>
+              <a:buNone/>
               <a:defRPr sz="3150" b="1">
                 <a:solidFill>
                   <a:srgbClr val="2F75B5"/>
@@ -7382,6 +7535,7 @@
           </a:lstStyle>
           <a:p xmlns:a="http://schemas.openxmlformats.org/drawingml/2006/main">
             <a:pPr>
+              <a:buNone/>
               <a:defRPr sz="1725" b="1">
                 <a:solidFill>
                   <a:srgbClr val="FFFFFF"/>
@@ -7471,6 +7625,7 @@
           </a:lstStyle>
           <a:p xmlns:a="http://schemas.openxmlformats.org/drawingml/2006/main">
             <a:pPr>
+              <a:buNone/>
               <a:defRPr sz="1800" b="1">
                 <a:solidFill>
                   <a:srgbClr val="16202A"/>
@@ -7529,6 +7684,7 @@
           </a:lstStyle>
           <a:p xmlns:a="http://schemas.openxmlformats.org/drawingml/2006/main">
             <a:pPr>
+              <a:buNone/>
               <a:defRPr sz="1125" b="0">
                 <a:solidFill>
                   <a:srgbClr val="52606D"/>
@@ -7587,6 +7743,7 @@
           </a:lstStyle>
           <a:p xmlns:a="http://schemas.openxmlformats.org/drawingml/2006/main">
             <a:pPr>
+              <a:buNone/>
               <a:defRPr sz="1500" b="1">
                 <a:solidFill>
                   <a:srgbClr val="1B7F5A"/>
@@ -7599,7 +7756,7 @@
                   <a:srgbClr val="1B7F5A"/>
                 </a:solidFill>
               </a:rPr>
-              <a:t>El UIDL de cada correo queda almacenado para impedir respuestas duplicadas.</a:t>
+              <a:t>El registro persistente evita repetir cambios de negocio.</a:t>
             </a:r>
           </a:p>
         </p:txBody>
@@ -7674,6 +7831,7 @@
           </a:lstStyle>
           <a:p xmlns:a="http://schemas.openxmlformats.org/drawingml/2006/main">
             <a:pPr>
+              <a:buNone/>
               <a:defRPr sz="975" b="1">
                 <a:solidFill>
                   <a:srgbClr val="2F75B5"/>
@@ -7686,7 +7844,7 @@
                   <a:srgbClr val="2F75B5"/>
                 </a:solidFill>
               </a:rPr>
-              <a:t>PROYECTO 1  |  INF513</a:t>
+              <a:t>PROYECTO 1   INF513</a:t>
             </a:r>
           </a:p>
         </p:txBody>
@@ -7732,6 +7890,7 @@
           </a:lstStyle>
           <a:p xmlns:a="http://schemas.openxmlformats.org/drawingml/2006/main">
             <a:pPr>
+              <a:buNone/>
               <a:defRPr sz="2550" b="1">
                 <a:solidFill>
                   <a:srgbClr val="16202A"/>
@@ -7823,6 +7982,7 @@
           </a:lstStyle>
           <a:p xmlns:a="http://schemas.openxmlformats.org/drawingml/2006/main">
             <a:pPr>
+              <a:buNone/>
               <a:defRPr sz="900" b="0">
                 <a:solidFill>
                   <a:srgbClr val="52606D"/>
@@ -7881,6 +8041,7 @@
           </a:lstStyle>
           <a:p xmlns:a="http://schemas.openxmlformats.org/drawingml/2006/main">
             <a:pPr>
+              <a:buNone/>
               <a:defRPr sz="900" b="0">
                 <a:solidFill>
                   <a:srgbClr val="52606D"/>
@@ -7974,6 +8135,7 @@
           </a:lstStyle>
           <a:p xmlns:a="http://schemas.openxmlformats.org/drawingml/2006/main">
             <a:pPr>
+              <a:buNone/>
               <a:defRPr sz="1650" b="1">
                 <a:solidFill>
                   <a:srgbClr val="2F75B5"/>
@@ -8032,6 +8194,7 @@
           </a:lstStyle>
           <a:p xmlns:a="http://schemas.openxmlformats.org/drawingml/2006/main">
             <a:pPr>
+              <a:buNone/>
               <a:defRPr sz="1350" b="1">
                 <a:solidFill>
                   <a:srgbClr val="16202A"/>
@@ -8090,6 +8253,7 @@
           </a:lstStyle>
           <a:p xmlns:a="http://schemas.openxmlformats.org/drawingml/2006/main">
             <a:pPr>
+              <a:buNone/>
               <a:defRPr sz="1050" b="0">
                 <a:solidFill>
                   <a:srgbClr val="52606D"/>
@@ -8183,6 +8347,7 @@
           </a:lstStyle>
           <a:p xmlns:a="http://schemas.openxmlformats.org/drawingml/2006/main">
             <a:pPr>
+              <a:buNone/>
               <a:defRPr sz="1650" b="1">
                 <a:solidFill>
                   <a:srgbClr val="2F75B5"/>
@@ -8241,6 +8406,7 @@
           </a:lstStyle>
           <a:p xmlns:a="http://schemas.openxmlformats.org/drawingml/2006/main">
             <a:pPr>
+              <a:buNone/>
               <a:defRPr sz="1350" b="1">
                 <a:solidFill>
                   <a:srgbClr val="16202A"/>
@@ -8299,6 +8465,7 @@
           </a:lstStyle>
           <a:p xmlns:a="http://schemas.openxmlformats.org/drawingml/2006/main">
             <a:pPr>
+              <a:buNone/>
               <a:defRPr sz="1050" b="0">
                 <a:solidFill>
                   <a:srgbClr val="52606D"/>
@@ -8392,6 +8559,7 @@
           </a:lstStyle>
           <a:p xmlns:a="http://schemas.openxmlformats.org/drawingml/2006/main">
             <a:pPr>
+              <a:buNone/>
               <a:defRPr sz="1650" b="1">
                 <a:solidFill>
                   <a:srgbClr val="2F75B5"/>
@@ -8450,6 +8618,7 @@
           </a:lstStyle>
           <a:p xmlns:a="http://schemas.openxmlformats.org/drawingml/2006/main">
             <a:pPr>
+              <a:buNone/>
               <a:defRPr sz="1350" b="1">
                 <a:solidFill>
                   <a:srgbClr val="16202A"/>
@@ -8508,6 +8677,7 @@
           </a:lstStyle>
           <a:p xmlns:a="http://schemas.openxmlformats.org/drawingml/2006/main">
             <a:pPr>
+              <a:buNone/>
               <a:defRPr sz="1050" b="0">
                 <a:solidFill>
                   <a:srgbClr val="52606D"/>
@@ -8601,6 +8771,7 @@
           </a:lstStyle>
           <a:p xmlns:a="http://schemas.openxmlformats.org/drawingml/2006/main">
             <a:pPr>
+              <a:buNone/>
               <a:defRPr sz="1650" b="1">
                 <a:solidFill>
                   <a:srgbClr val="2F75B5"/>
@@ -8659,6 +8830,7 @@
           </a:lstStyle>
           <a:p xmlns:a="http://schemas.openxmlformats.org/drawingml/2006/main">
             <a:pPr>
+              <a:buNone/>
               <a:defRPr sz="1350" b="1">
                 <a:solidFill>
                   <a:srgbClr val="16202A"/>
@@ -8717,6 +8889,7 @@
           </a:lstStyle>
           <a:p xmlns:a="http://schemas.openxmlformats.org/drawingml/2006/main">
             <a:pPr>
+              <a:buNone/>
               <a:defRPr sz="1050" b="0">
                 <a:solidFill>
                   <a:srgbClr val="52606D"/>
@@ -8810,6 +8983,7 @@
           </a:lstStyle>
           <a:p xmlns:a="http://schemas.openxmlformats.org/drawingml/2006/main">
             <a:pPr>
+              <a:buNone/>
               <a:defRPr sz="1650" b="1">
                 <a:solidFill>
                   <a:srgbClr val="2F75B5"/>
@@ -8868,6 +9042,7 @@
           </a:lstStyle>
           <a:p xmlns:a="http://schemas.openxmlformats.org/drawingml/2006/main">
             <a:pPr>
+              <a:buNone/>
               <a:defRPr sz="1350" b="1">
                 <a:solidFill>
                   <a:srgbClr val="16202A"/>
@@ -8926,6 +9101,7 @@
           </a:lstStyle>
           <a:p xmlns:a="http://schemas.openxmlformats.org/drawingml/2006/main">
             <a:pPr>
+              <a:buNone/>
               <a:defRPr sz="1050" b="0">
                 <a:solidFill>
                   <a:srgbClr val="52606D"/>
@@ -9019,6 +9195,7 @@
           </a:lstStyle>
           <a:p xmlns:a="http://schemas.openxmlformats.org/drawingml/2006/main">
             <a:pPr>
+              <a:buNone/>
               <a:defRPr sz="1650" b="1">
                 <a:solidFill>
                   <a:srgbClr val="2F75B5"/>
@@ -9077,6 +9254,7 @@
           </a:lstStyle>
           <a:p xmlns:a="http://schemas.openxmlformats.org/drawingml/2006/main">
             <a:pPr>
+              <a:buNone/>
               <a:defRPr sz="1350" b="1">
                 <a:solidFill>
                   <a:srgbClr val="16202A"/>
@@ -9135,6 +9313,7 @@
           </a:lstStyle>
           <a:p xmlns:a="http://schemas.openxmlformats.org/drawingml/2006/main">
             <a:pPr>
+              <a:buNone/>
               <a:defRPr sz="1050" b="0">
                 <a:solidFill>
                   <a:srgbClr val="52606D"/>
@@ -9228,6 +9407,7 @@
           </a:lstStyle>
           <a:p xmlns:a="http://schemas.openxmlformats.org/drawingml/2006/main">
             <a:pPr>
+              <a:buNone/>
               <a:defRPr sz="1650" b="1">
                 <a:solidFill>
                   <a:srgbClr val="2F75B5"/>
@@ -9286,6 +9466,7 @@
           </a:lstStyle>
           <a:p xmlns:a="http://schemas.openxmlformats.org/drawingml/2006/main">
             <a:pPr>
+              <a:buNone/>
               <a:defRPr sz="1350" b="1">
                 <a:solidFill>
                   <a:srgbClr val="16202A"/>
@@ -9344,6 +9525,7 @@
           </a:lstStyle>
           <a:p xmlns:a="http://schemas.openxmlformats.org/drawingml/2006/main">
             <a:pPr>
+              <a:buNone/>
               <a:defRPr sz="1050" b="0">
                 <a:solidFill>
                   <a:srgbClr val="52606D"/>
@@ -9437,6 +9619,7 @@
           </a:lstStyle>
           <a:p xmlns:a="http://schemas.openxmlformats.org/drawingml/2006/main">
             <a:pPr>
+              <a:buNone/>
               <a:defRPr sz="1650" b="1">
                 <a:solidFill>
                   <a:srgbClr val="2F75B5"/>
@@ -9495,6 +9678,7 @@
           </a:lstStyle>
           <a:p xmlns:a="http://schemas.openxmlformats.org/drawingml/2006/main">
             <a:pPr>
+              <a:buNone/>
               <a:defRPr sz="1350" b="1">
                 <a:solidFill>
                   <a:srgbClr val="16202A"/>
@@ -9553,6 +9737,7 @@
           </a:lstStyle>
           <a:p xmlns:a="http://schemas.openxmlformats.org/drawingml/2006/main">
             <a:pPr>
+              <a:buNone/>
               <a:defRPr sz="1050" b="0">
                 <a:solidFill>
                   <a:srgbClr val="52606D"/>
@@ -9640,6 +9825,7 @@
           </a:lstStyle>
           <a:p xmlns:a="http://schemas.openxmlformats.org/drawingml/2006/main">
             <a:pPr>
+              <a:buNone/>
               <a:defRPr sz="975" b="1">
                 <a:solidFill>
                   <a:srgbClr val="2F75B5"/>
@@ -9652,7 +9838,7 @@
                   <a:srgbClr val="2F75B5"/>
                 </a:solidFill>
               </a:rPr>
-              <a:t>PROYECTO 1  |  INF513</a:t>
+              <a:t>PROYECTO 1   INF513</a:t>
             </a:r>
           </a:p>
         </p:txBody>
@@ -9698,6 +9884,7 @@
           </a:lstStyle>
           <a:p xmlns:a="http://schemas.openxmlformats.org/drawingml/2006/main">
             <a:pPr>
+              <a:buNone/>
               <a:defRPr sz="2550" b="1">
                 <a:solidFill>
                   <a:srgbClr val="16202A"/>
@@ -9789,6 +9976,7 @@
           </a:lstStyle>
           <a:p xmlns:a="http://schemas.openxmlformats.org/drawingml/2006/main">
             <a:pPr>
+              <a:buNone/>
               <a:defRPr sz="900" b="0">
                 <a:solidFill>
                   <a:srgbClr val="52606D"/>
@@ -9847,6 +10035,7 @@
           </a:lstStyle>
           <a:p xmlns:a="http://schemas.openxmlformats.org/drawingml/2006/main">
             <a:pPr>
+              <a:buNone/>
               <a:defRPr sz="900" b="0">
                 <a:solidFill>
                   <a:srgbClr val="52606D"/>
@@ -9973,6 +10162,7 @@
           </a:lstStyle>
           <a:p xmlns:a="http://schemas.openxmlformats.org/drawingml/2006/main">
             <a:pPr>
+              <a:buNone/>
               <a:defRPr sz="1500" b="1">
                 <a:solidFill>
                   <a:srgbClr val="16202A"/>
@@ -10031,6 +10221,7 @@
           </a:lstStyle>
           <a:p xmlns:a="http://schemas.openxmlformats.org/drawingml/2006/main">
             <a:pPr>
+              <a:buNone/>
               <a:defRPr sz="1200" b="0">
                 <a:solidFill>
                   <a:srgbClr val="52606D"/>
@@ -10048,6 +10239,7 @@
           </a:p>
           <a:p xmlns:a="http://schemas.openxmlformats.org/drawingml/2006/main">
             <a:pPr>
+              <a:buNone/>
               <a:defRPr sz="1200" b="0">
                 <a:solidFill>
                   <a:srgbClr val="52606D"/>
@@ -10174,6 +10366,7 @@
           </a:lstStyle>
           <a:p xmlns:a="http://schemas.openxmlformats.org/drawingml/2006/main">
             <a:pPr>
+              <a:buNone/>
               <a:defRPr sz="1500" b="1">
                 <a:solidFill>
                   <a:srgbClr val="16202A"/>
@@ -10232,6 +10425,7 @@
           </a:lstStyle>
           <a:p xmlns:a="http://schemas.openxmlformats.org/drawingml/2006/main">
             <a:pPr>
+              <a:buNone/>
               <a:defRPr sz="1200" b="0">
                 <a:solidFill>
                   <a:srgbClr val="52606D"/>
@@ -10358,6 +10552,7 @@
           </a:lstStyle>
           <a:p xmlns:a="http://schemas.openxmlformats.org/drawingml/2006/main">
             <a:pPr>
+              <a:buNone/>
               <a:defRPr sz="1500" b="1">
                 <a:solidFill>
                   <a:srgbClr val="16202A"/>
@@ -10416,6 +10611,7 @@
           </a:lstStyle>
           <a:p xmlns:a="http://schemas.openxmlformats.org/drawingml/2006/main">
             <a:pPr>
+              <a:buNone/>
               <a:defRPr sz="1200" b="0">
                 <a:solidFill>
                   <a:srgbClr val="52606D"/>
@@ -10428,7 +10624,7 @@
                   <a:srgbClr val="52606D"/>
                 </a:solidFill>
               </a:rPr>
-              <a:t>DECANO, VICEDECANO, EVALUADOR y POSTULANTE. Las operaciones privadas verifican el correo activo.</a:t>
+              <a:t>Las órdenes privadas requieren CONFIRMAR["codigo"]. Verificamos la cuenta y el rol vigente.</a:t>
             </a:r>
           </a:p>
         </p:txBody>
@@ -10474,6 +10670,7 @@
           </a:lstStyle>
           <a:p xmlns:a="http://schemas.openxmlformats.org/drawingml/2006/main">
             <a:pPr>
+              <a:buNone/>
               <a:defRPr sz="1575" b="1">
                 <a:solidFill>
                   <a:srgbClr val="17365D"/>
@@ -10486,7 +10683,7 @@
                   <a:srgbClr val="17365D"/>
                 </a:solidFill>
               </a:rPr>
-              <a:t>Las credenciales se cargan mediante variables de entorno y no forman parte del código.</a:t>
+              <a:t>El código confirma solo la orden original y se consume con la transacción.</a:t>
             </a:r>
           </a:p>
         </p:txBody>
@@ -10561,6 +10758,7 @@
           </a:lstStyle>
           <a:p xmlns:a="http://schemas.openxmlformats.org/drawingml/2006/main">
             <a:pPr>
+              <a:buNone/>
               <a:defRPr sz="975" b="1">
                 <a:solidFill>
                   <a:srgbClr val="2F75B5"/>
@@ -10573,7 +10771,7 @@
                   <a:srgbClr val="2F75B5"/>
                 </a:solidFill>
               </a:rPr>
-              <a:t>PROYECTO 1  |  INF513</a:t>
+              <a:t>PROYECTO 1   INF513</a:t>
             </a:r>
           </a:p>
         </p:txBody>
@@ -10619,6 +10817,7 @@
           </a:lstStyle>
           <a:p xmlns:a="http://schemas.openxmlformats.org/drawingml/2006/main">
             <a:pPr>
+              <a:buNone/>
               <a:defRPr sz="2550" b="1">
                 <a:solidFill>
                   <a:srgbClr val="16202A"/>
@@ -10710,6 +10909,7 @@
           </a:lstStyle>
           <a:p xmlns:a="http://schemas.openxmlformats.org/drawingml/2006/main">
             <a:pPr>
+              <a:buNone/>
               <a:defRPr sz="900" b="0">
                 <a:solidFill>
                   <a:srgbClr val="52606D"/>
@@ -10768,6 +10968,7 @@
           </a:lstStyle>
           <a:p xmlns:a="http://schemas.openxmlformats.org/drawingml/2006/main">
             <a:pPr>
+              <a:buNone/>
               <a:defRPr sz="900" b="0">
                 <a:solidFill>
                   <a:srgbClr val="52606D"/>
@@ -10861,6 +11062,7 @@
           </a:lstStyle>
           <a:p xmlns:a="http://schemas.openxmlformats.org/drawingml/2006/main">
             <a:pPr>
+              <a:buNone/>
               <a:defRPr sz="1425" b="1">
                 <a:solidFill>
                   <a:srgbClr val="16202A"/>
@@ -10954,6 +11156,7 @@
           </a:lstStyle>
           <a:p xmlns:a="http://schemas.openxmlformats.org/drawingml/2006/main">
             <a:pPr>
+              <a:buNone/>
               <a:defRPr sz="1425" b="1">
                 <a:solidFill>
                   <a:srgbClr val="16202A"/>
@@ -11047,6 +11250,7 @@
           </a:lstStyle>
           <a:p xmlns:a="http://schemas.openxmlformats.org/drawingml/2006/main">
             <a:pPr>
+              <a:buNone/>
               <a:defRPr sz="1425" b="1">
                 <a:solidFill>
                   <a:srgbClr val="16202A"/>
@@ -11140,6 +11344,7 @@
           </a:lstStyle>
           <a:p xmlns:a="http://schemas.openxmlformats.org/drawingml/2006/main">
             <a:pPr>
+              <a:buNone/>
               <a:defRPr sz="1425" b="1">
                 <a:solidFill>
                   <a:srgbClr val="FFFFFF"/>
@@ -11233,6 +11438,7 @@
           </a:lstStyle>
           <a:p xmlns:a="http://schemas.openxmlformats.org/drawingml/2006/main">
             <a:pPr>
+              <a:buNone/>
               <a:defRPr sz="1425" b="1">
                 <a:solidFill>
                   <a:srgbClr val="16202A"/>
@@ -11326,6 +11532,7 @@
           </a:lstStyle>
           <a:p xmlns:a="http://schemas.openxmlformats.org/drawingml/2006/main">
             <a:pPr>
+              <a:buNone/>
               <a:defRPr sz="1425" b="1">
                 <a:solidFill>
                   <a:srgbClr val="16202A"/>
@@ -11338,7 +11545,7 @@
                   <a:srgbClr val="16202A"/>
                 </a:solidFill>
               </a:rPr>
-              <a:t>p1_requisito</a:t>
+              <a:t>p1_evaluacion_requisito</a:t>
             </a:r>
           </a:p>
         </p:txBody>
@@ -11419,6 +11626,7 @@
           </a:lstStyle>
           <a:p xmlns:a="http://schemas.openxmlformats.org/drawingml/2006/main">
             <a:pPr>
+              <a:buNone/>
               <a:defRPr sz="1425" b="1">
                 <a:solidFill>
                   <a:srgbClr val="16202A"/>
@@ -11512,6 +11720,7 @@
           </a:lstStyle>
           <a:p xmlns:a="http://schemas.openxmlformats.org/drawingml/2006/main">
             <a:pPr>
+              <a:buNone/>
               <a:defRPr sz="1425" b="1">
                 <a:solidFill>
                   <a:srgbClr val="16202A"/>
@@ -11605,6 +11814,7 @@
           </a:lstStyle>
           <a:p xmlns:a="http://schemas.openxmlformats.org/drawingml/2006/main">
             <a:pPr>
+              <a:buNone/>
               <a:defRPr sz="1425" b="1">
                 <a:solidFill>
                   <a:srgbClr val="16202A"/>
@@ -11663,6 +11873,7 @@
           </a:lstStyle>
           <a:p xmlns:a="http://schemas.openxmlformats.org/drawingml/2006/main">
             <a:pPr>
+              <a:buNone/>
               <a:defRPr sz="975" b="0">
                 <a:solidFill>
                   <a:srgbClr val="52606D"/>
@@ -11721,6 +11932,7 @@
           </a:lstStyle>
           <a:p xmlns:a="http://schemas.openxmlformats.org/drawingml/2006/main">
             <a:pPr>
+              <a:buNone/>
               <a:defRPr sz="975" b="1">
                 <a:solidFill>
                   <a:srgbClr val="17365D"/>
@@ -11779,6 +11991,7 @@
           </a:lstStyle>
           <a:p xmlns:a="http://schemas.openxmlformats.org/drawingml/2006/main">
             <a:pPr>
+              <a:buNone/>
               <a:defRPr sz="975" b="0">
                 <a:solidFill>
                   <a:srgbClr val="52606D"/>
@@ -11837,6 +12050,7 @@
           </a:lstStyle>
           <a:p xmlns:a="http://schemas.openxmlformats.org/drawingml/2006/main">
             <a:pPr>
+              <a:buNone/>
               <a:defRPr sz="1425" b="1">
                 <a:solidFill>
                   <a:srgbClr val="1B7F5A"/>
@@ -11924,6 +12138,7 @@
           </a:lstStyle>
           <a:p xmlns:a="http://schemas.openxmlformats.org/drawingml/2006/main">
             <a:pPr>
+              <a:buNone/>
               <a:defRPr sz="975" b="1">
                 <a:solidFill>
                   <a:srgbClr val="2F75B5"/>
@@ -11936,7 +12151,7 @@
                   <a:srgbClr val="2F75B5"/>
                 </a:solidFill>
               </a:rPr>
-              <a:t>PROYECTO 1  |  INF513</a:t>
+              <a:t>PROYECTO 1   INF513</a:t>
             </a:r>
           </a:p>
         </p:txBody>
@@ -11982,6 +12197,7 @@
           </a:lstStyle>
           <a:p xmlns:a="http://schemas.openxmlformats.org/drawingml/2006/main">
             <a:pPr>
+              <a:buNone/>
               <a:defRPr sz="2550" b="1">
                 <a:solidFill>
                   <a:srgbClr val="16202A"/>
@@ -11994,7 +12210,7 @@
                   <a:srgbClr val="16202A"/>
                 </a:solidFill>
               </a:rPr>
-              <a:t>Prueba integral realizada</a:t>
+              <a:t>Prueba institucional anterior</a:t>
             </a:r>
           </a:p>
         </p:txBody>
@@ -12073,6 +12289,7 @@
           </a:lstStyle>
           <a:p xmlns:a="http://schemas.openxmlformats.org/drawingml/2006/main">
             <a:pPr>
+              <a:buNone/>
               <a:defRPr sz="900" b="0">
                 <a:solidFill>
                   <a:srgbClr val="52606D"/>
@@ -12131,6 +12348,7 @@
           </a:lstStyle>
           <a:p xmlns:a="http://schemas.openxmlformats.org/drawingml/2006/main">
             <a:pPr>
+              <a:buNone/>
               <a:defRPr sz="900" b="0">
                 <a:solidFill>
                   <a:srgbClr val="52606D"/>
@@ -12224,6 +12442,7 @@
           </a:lstStyle>
           <a:p xmlns:a="http://schemas.openxmlformats.org/drawingml/2006/main">
             <a:pPr>
+              <a:buNone/>
               <a:defRPr sz="1725" b="1">
                 <a:solidFill>
                   <a:srgbClr val="FFFFFF"/>
@@ -12313,6 +12532,7 @@
           </a:lstStyle>
           <a:p xmlns:a="http://schemas.openxmlformats.org/drawingml/2006/main">
             <a:pPr>
+              <a:buNone/>
               <a:defRPr sz="1500" b="1">
                 <a:solidFill>
                   <a:srgbClr val="16202A"/>
@@ -12371,6 +12591,7 @@
           </a:lstStyle>
           <a:p xmlns:a="http://schemas.openxmlformats.org/drawingml/2006/main">
             <a:pPr>
+              <a:buNone/>
               <a:defRPr sz="1275" b="0">
                 <a:solidFill>
                   <a:srgbClr val="52606D"/>
@@ -12464,6 +12685,7 @@
           </a:lstStyle>
           <a:p xmlns:a="http://schemas.openxmlformats.org/drawingml/2006/main">
             <a:pPr>
+              <a:buNone/>
               <a:defRPr sz="1725" b="1">
                 <a:solidFill>
                   <a:srgbClr val="FFFFFF"/>
@@ -12553,6 +12775,7 @@
           </a:lstStyle>
           <a:p xmlns:a="http://schemas.openxmlformats.org/drawingml/2006/main">
             <a:pPr>
+              <a:buNone/>
               <a:defRPr sz="1500" b="1">
                 <a:solidFill>
                   <a:srgbClr val="16202A"/>
@@ -12611,6 +12834,7 @@
           </a:lstStyle>
           <a:p xmlns:a="http://schemas.openxmlformats.org/drawingml/2006/main">
             <a:pPr>
+              <a:buNone/>
               <a:defRPr sz="1275" b="0">
                 <a:solidFill>
                   <a:srgbClr val="52606D"/>
@@ -12704,6 +12928,7 @@
           </a:lstStyle>
           <a:p xmlns:a="http://schemas.openxmlformats.org/drawingml/2006/main">
             <a:pPr>
+              <a:buNone/>
               <a:defRPr sz="1725" b="1">
                 <a:solidFill>
                   <a:srgbClr val="FFFFFF"/>
@@ -12793,6 +13018,7 @@
           </a:lstStyle>
           <a:p xmlns:a="http://schemas.openxmlformats.org/drawingml/2006/main">
             <a:pPr>
+              <a:buNone/>
               <a:defRPr sz="1500" b="1">
                 <a:solidFill>
                   <a:srgbClr val="16202A"/>
@@ -12851,6 +13077,7 @@
           </a:lstStyle>
           <a:p xmlns:a="http://schemas.openxmlformats.org/drawingml/2006/main">
             <a:pPr>
+              <a:buNone/>
               <a:defRPr sz="1275" b="0">
                 <a:solidFill>
                   <a:srgbClr val="52606D"/>
@@ -12944,6 +13171,7 @@
           </a:lstStyle>
           <a:p xmlns:a="http://schemas.openxmlformats.org/drawingml/2006/main">
             <a:pPr>
+              <a:buNone/>
               <a:defRPr sz="1725" b="1">
                 <a:solidFill>
                   <a:srgbClr val="FFFFFF"/>
@@ -13033,6 +13261,7 @@
           </a:lstStyle>
           <a:p xmlns:a="http://schemas.openxmlformats.org/drawingml/2006/main">
             <a:pPr>
+              <a:buNone/>
               <a:defRPr sz="1500" b="1">
                 <a:solidFill>
                   <a:srgbClr val="16202A"/>
@@ -13091,6 +13320,7 @@
           </a:lstStyle>
           <a:p xmlns:a="http://schemas.openxmlformats.org/drawingml/2006/main">
             <a:pPr>
+              <a:buNone/>
               <a:defRPr sz="1275" b="0">
                 <a:solidFill>
                   <a:srgbClr val="52606D"/>
@@ -13149,6 +13379,7 @@
           </a:lstStyle>
           <a:p xmlns:a="http://schemas.openxmlformats.org/drawingml/2006/main">
             <a:pPr>
+              <a:buNone/>
               <a:defRPr sz="1350" b="1">
                 <a:solidFill>
                   <a:srgbClr val="1B7F5A"/>
@@ -13236,6 +13467,7 @@
           </a:lstStyle>
           <a:p xmlns:a="http://schemas.openxmlformats.org/drawingml/2006/main">
             <a:pPr>
+              <a:buNone/>
               <a:defRPr sz="975" b="1">
                 <a:solidFill>
                   <a:srgbClr val="2F75B5"/>
@@ -13248,7 +13480,7 @@
                   <a:srgbClr val="2F75B5"/>
                 </a:solidFill>
               </a:rPr>
-              <a:t>PROYECTO 1  |  INF513</a:t>
+              <a:t>PROYECTO 1   INF513</a:t>
             </a:r>
           </a:p>
         </p:txBody>
@@ -13294,6 +13526,7 @@
           </a:lstStyle>
           <a:p xmlns:a="http://schemas.openxmlformats.org/drawingml/2006/main">
             <a:pPr>
+              <a:buNone/>
               <a:defRPr sz="2550" b="1">
                 <a:solidFill>
                   <a:srgbClr val="16202A"/>
@@ -13306,7 +13539,7 @@
                   <a:srgbClr val="16202A"/>
                 </a:solidFill>
               </a:rPr>
-              <a:t>Resultados y observaciones</a:t>
+              <a:t>Pruebas y actualización</a:t>
             </a:r>
           </a:p>
         </p:txBody>
@@ -13385,6 +13618,7 @@
           </a:lstStyle>
           <a:p xmlns:a="http://schemas.openxmlformats.org/drawingml/2006/main">
             <a:pPr>
+              <a:buNone/>
               <a:defRPr sz="900" b="0">
                 <a:solidFill>
                   <a:srgbClr val="52606D"/>
@@ -13443,6 +13677,7 @@
           </a:lstStyle>
           <a:p xmlns:a="http://schemas.openxmlformats.org/drawingml/2006/main">
             <a:pPr>
+              <a:buNone/>
               <a:defRPr sz="900" b="0">
                 <a:solidFill>
                   <a:srgbClr val="52606D"/>
@@ -13569,6 +13804,7 @@
           </a:lstStyle>
           <a:p xmlns:a="http://schemas.openxmlformats.org/drawingml/2006/main">
             <a:pPr>
+              <a:buNone/>
               <a:defRPr sz="1500" b="1">
                 <a:solidFill>
                   <a:srgbClr val="16202A"/>
@@ -13581,7 +13817,7 @@
                   <a:srgbClr val="16202A"/>
                 </a:solidFill>
               </a:rPr>
-              <a:t>Consulta SQL</a:t>
+              <a:t>Recorrido local</a:t>
             </a:r>
           </a:p>
         </p:txBody>
@@ -13627,6 +13863,7 @@
           </a:lstStyle>
           <a:p xmlns:a="http://schemas.openxmlformats.org/drawingml/2006/main">
             <a:pPr>
+              <a:buNone/>
               <a:defRPr sz="1200" b="0">
                 <a:solidFill>
                   <a:srgbClr val="52606D"/>
@@ -13639,7 +13876,7 @@
                   <a:srgbClr val="52606D"/>
                 </a:solidFill>
               </a:rPr>
-              <a:t>LISCON["*"] ejecutó el SELECT remoto y respondió “Sin resultados”.</a:t>
+              <a:t>Verificamos los ocho casos de uso con PostgreSQL 15 aislado y confirmaciones.</a:t>
             </a:r>
           </a:p>
         </p:txBody>
@@ -13753,6 +13990,7 @@
           </a:lstStyle>
           <a:p xmlns:a="http://schemas.openxmlformats.org/drawingml/2006/main">
             <a:pPr>
+              <a:buNone/>
               <a:defRPr sz="1500" b="1">
                 <a:solidFill>
                   <a:srgbClr val="16202A"/>
@@ -13765,7 +14003,7 @@
                   <a:srgbClr val="16202A"/>
                 </a:solidFill>
               </a:rPr>
-              <a:t>Entrega externa</a:t>
+              <a:t>Actualización institucional</a:t>
             </a:r>
           </a:p>
         </p:txBody>
@@ -13811,6 +14049,7 @@
           </a:lstStyle>
           <a:p xmlns:a="http://schemas.openxmlformats.org/drawingml/2006/main">
             <a:pPr>
+              <a:buNone/>
               <a:defRPr sz="1200" b="0">
                 <a:solidFill>
                   <a:srgbClr val="52606D"/>
@@ -13823,7 +14062,7 @@
                   <a:srgbClr val="52606D"/>
                 </a:solidFill>
               </a:rPr>
-              <a:t>La respuesta llegó al Gmail utilizado para la prueba.</a:t>
+              <a:t>Pendiente aplicar la migración y reiniciar el servicio con las credenciales del grupo.</a:t>
             </a:r>
           </a:p>
         </p:txBody>
@@ -13937,6 +14176,7 @@
           </a:lstStyle>
           <a:p xmlns:a="http://schemas.openxmlformats.org/drawingml/2006/main">
             <a:pPr>
+              <a:buNone/>
               <a:defRPr sz="1500" b="1">
                 <a:solidFill>
                   <a:srgbClr val="16202A"/>
@@ -13995,6 +14235,7 @@
           </a:lstStyle>
           <a:p xmlns:a="http://schemas.openxmlformats.org/drawingml/2006/main">
             <a:pPr>
+              <a:buNone/>
               <a:defRPr sz="1200" b="0">
                 <a:solidFill>
                   <a:srgbClr val="52606D"/>
@@ -14121,6 +14362,7 @@
           </a:lstStyle>
           <a:p xmlns:a="http://schemas.openxmlformats.org/drawingml/2006/main">
             <a:pPr>
+              <a:buNone/>
               <a:defRPr sz="1500" b="1">
                 <a:solidFill>
                   <a:srgbClr val="16202A"/>
@@ -14179,6 +14421,7 @@
           </a:lstStyle>
           <a:p xmlns:a="http://schemas.openxmlformats.org/drawingml/2006/main">
             <a:pPr>
+              <a:buNone/>
               <a:defRPr sz="1200" b="0">
                 <a:solidFill>
                   <a:srgbClr val="52606D"/>
@@ -14196,6 +14439,7 @@
           </a:p>
           <a:p xmlns:a="http://schemas.openxmlformats.org/drawingml/2006/main">
             <a:pPr>
+              <a:buNone/>
               <a:defRPr sz="1200" b="0">
                 <a:solidFill>
                   <a:srgbClr val="52606D"/>
@@ -14283,6 +14527,7 @@
           </a:lstStyle>
           <a:p xmlns:a="http://schemas.openxmlformats.org/drawingml/2006/main">
             <a:pPr>
+              <a:buNone/>
               <a:defRPr sz="975" b="1">
                 <a:solidFill>
                   <a:srgbClr val="2F75B5"/>
@@ -14295,7 +14540,7 @@
                   <a:srgbClr val="2F75B5"/>
                 </a:solidFill>
               </a:rPr>
-              <a:t>PROYECTO 1  |  INF513</a:t>
+              <a:t>PROYECTO 1   INF513</a:t>
             </a:r>
           </a:p>
         </p:txBody>
@@ -14341,6 +14586,7 @@
           </a:lstStyle>
           <a:p xmlns:a="http://schemas.openxmlformats.org/drawingml/2006/main">
             <a:pPr>
+              <a:buNone/>
               <a:defRPr sz="2550" b="1">
                 <a:solidFill>
                   <a:srgbClr val="16202A"/>
@@ -14432,6 +14678,7 @@
           </a:lstStyle>
           <a:p xmlns:a="http://schemas.openxmlformats.org/drawingml/2006/main">
             <a:pPr>
+              <a:buNone/>
               <a:defRPr sz="900" b="0">
                 <a:solidFill>
                   <a:srgbClr val="52606D"/>
@@ -14490,6 +14737,7 @@
           </a:lstStyle>
           <a:p xmlns:a="http://schemas.openxmlformats.org/drawingml/2006/main">
             <a:pPr>
+              <a:buNone/>
               <a:defRPr sz="900" b="0">
                 <a:solidFill>
                   <a:srgbClr val="52606D"/>
@@ -14583,6 +14831,7 @@
           </a:lstStyle>
           <a:p xmlns:a="http://schemas.openxmlformats.org/drawingml/2006/main">
             <a:pPr>
+              <a:buNone/>
               <a:defRPr sz="1425" b="1">
                 <a:solidFill>
                   <a:srgbClr val="B42318"/>
@@ -14641,6 +14890,7 @@
           </a:lstStyle>
           <a:p xmlns:a="http://schemas.openxmlformats.org/drawingml/2006/main">
             <a:pPr>
+              <a:buNone/>
               <a:defRPr sz="1350" b="0">
                 <a:solidFill>
                   <a:srgbClr val="52606D"/>
@@ -14734,6 +14984,7 @@
           </a:lstStyle>
           <a:p xmlns:a="http://schemas.openxmlformats.org/drawingml/2006/main">
             <a:pPr>
+              <a:buNone/>
               <a:defRPr sz="1425" b="1">
                 <a:solidFill>
                   <a:srgbClr val="B42318"/>
@@ -14792,6 +15043,7 @@
           </a:lstStyle>
           <a:p xmlns:a="http://schemas.openxmlformats.org/drawingml/2006/main">
             <a:pPr>
+              <a:buNone/>
               <a:defRPr sz="1350" b="0">
                 <a:solidFill>
                   <a:srgbClr val="52606D"/>
@@ -14885,6 +15137,7 @@
           </a:lstStyle>
           <a:p xmlns:a="http://schemas.openxmlformats.org/drawingml/2006/main">
             <a:pPr>
+              <a:buNone/>
               <a:defRPr sz="1425" b="1">
                 <a:solidFill>
                   <a:srgbClr val="B42318"/>
@@ -14943,6 +15196,7 @@
           </a:lstStyle>
           <a:p xmlns:a="http://schemas.openxmlformats.org/drawingml/2006/main">
             <a:pPr>
+              <a:buNone/>
               <a:defRPr sz="1350" b="0">
                 <a:solidFill>
                   <a:srgbClr val="52606D"/>
@@ -15036,6 +15290,7 @@
           </a:lstStyle>
           <a:p xmlns:a="http://schemas.openxmlformats.org/drawingml/2006/main">
             <a:pPr>
+              <a:buNone/>
               <a:defRPr sz="1425" b="1">
                 <a:solidFill>
                   <a:srgbClr val="B42318"/>
@@ -15094,6 +15349,7 @@
           </a:lstStyle>
           <a:p xmlns:a="http://schemas.openxmlformats.org/drawingml/2006/main">
             <a:pPr>
+              <a:buNone/>
               <a:defRPr sz="1350" b="0">
                 <a:solidFill>
                   <a:srgbClr val="52606D"/>
@@ -15152,6 +15408,7 @@
           </a:lstStyle>
           <a:p xmlns:a="http://schemas.openxmlformats.org/drawingml/2006/main">
             <a:pPr>
+              <a:buNone/>
               <a:defRPr sz="1350" b="1">
                 <a:solidFill>
                   <a:srgbClr val="17365D"/>
@@ -15164,7 +15421,7 @@
                   <a:srgbClr val="17365D"/>
                 </a:solidFill>
               </a:rPr>
-              <a:t>25 pruebas, 10.000.000 de asuntos y 320.000 análisis concurrentes. Sin caídas.</a:t>
+              <a:t>44 pruebas automatizadas aprobadas en Windows con PostgreSQL 15 local.</a:t>
             </a:r>
           </a:p>
         </p:txBody>

</xml_diff>

<commit_message>
Finalize delivery and test mail-cycle recovery and transient database failures
</commit_message>
<xml_diff>
--- a/entrega/Presentacion_INF513_P1_Grupo09SA.pptx
+++ b/entrega/Presentacion_INF513_P1_Grupo09SA.pptx
@@ -2,22 +2,22 @@
 <file path=ppt/presentation.xml><?xml version="1.0" encoding="utf-8"?>
 <p:presentation xmlns:p="http://schemas.openxmlformats.org/presentationml/2006/main">
   <p:sldMasterIdLst>
-    <p:sldMasterId xmlns:r="http://schemas.openxmlformats.org/officeDocument/2006/relationships" id="2147483648" r:id="R7ed961ffbd1b475f"/>
+    <p:sldMasterId xmlns:r="http://schemas.openxmlformats.org/officeDocument/2006/relationships" id="2147483648" r:id="Rb82ee9c9e83846fb"/>
   </p:sldMasterIdLst>
   <p:notesMasterIdLst>
-    <p:notesMasterId xmlns:r="http://schemas.openxmlformats.org/officeDocument/2006/relationships" r:id="Rd722031819b4451e"/>
+    <p:notesMasterId xmlns:r="http://schemas.openxmlformats.org/officeDocument/2006/relationships" r:id="R5503aa57e98f4acb"/>
   </p:notesMasterIdLst>
   <p:sldIdLst>
-    <p:sldId xmlns:r="http://schemas.openxmlformats.org/officeDocument/2006/relationships" id="256" r:id="R79dc9e09bdb04a9d"/>
-    <p:sldId xmlns:r="http://schemas.openxmlformats.org/officeDocument/2006/relationships" id="257" r:id="Ra071028d44564206"/>
-    <p:sldId xmlns:r="http://schemas.openxmlformats.org/officeDocument/2006/relationships" id="258" r:id="R0ab1252d80be461e"/>
-    <p:sldId xmlns:r="http://schemas.openxmlformats.org/officeDocument/2006/relationships" id="259" r:id="Rdf0edc0b51b84ab3"/>
-    <p:sldId xmlns:r="http://schemas.openxmlformats.org/officeDocument/2006/relationships" id="260" r:id="R5f9b10e15e764cc5"/>
-    <p:sldId xmlns:r="http://schemas.openxmlformats.org/officeDocument/2006/relationships" id="261" r:id="R9f32ea7c85594b5f"/>
-    <p:sldId xmlns:r="http://schemas.openxmlformats.org/officeDocument/2006/relationships" id="262" r:id="R409d652e9b8a442a"/>
-    <p:sldId xmlns:r="http://schemas.openxmlformats.org/officeDocument/2006/relationships" id="263" r:id="R7029ee8fd8cc4abc"/>
-    <p:sldId xmlns:r="http://schemas.openxmlformats.org/officeDocument/2006/relationships" id="264" r:id="Rd6a06fa528cd470d"/>
-    <p:sldId xmlns:r="http://schemas.openxmlformats.org/officeDocument/2006/relationships" id="265" r:id="R68b66eb8910e489b"/>
+    <p:sldId xmlns:r="http://schemas.openxmlformats.org/officeDocument/2006/relationships" id="256" r:id="Ref052a3f49d845c9"/>
+    <p:sldId xmlns:r="http://schemas.openxmlformats.org/officeDocument/2006/relationships" id="257" r:id="R7f20f9441e604567"/>
+    <p:sldId xmlns:r="http://schemas.openxmlformats.org/officeDocument/2006/relationships" id="258" r:id="R4776dd40ce23418f"/>
+    <p:sldId xmlns:r="http://schemas.openxmlformats.org/officeDocument/2006/relationships" id="259" r:id="Rac7a3e88ba054ce9"/>
+    <p:sldId xmlns:r="http://schemas.openxmlformats.org/officeDocument/2006/relationships" id="260" r:id="R980b747166254a83"/>
+    <p:sldId xmlns:r="http://schemas.openxmlformats.org/officeDocument/2006/relationships" id="261" r:id="R5ff8f39befdf4402"/>
+    <p:sldId xmlns:r="http://schemas.openxmlformats.org/officeDocument/2006/relationships" id="262" r:id="R93089cc1c1d74399"/>
+    <p:sldId xmlns:r="http://schemas.openxmlformats.org/officeDocument/2006/relationships" id="263" r:id="Rb8b284a1f8e54934"/>
+    <p:sldId xmlns:r="http://schemas.openxmlformats.org/officeDocument/2006/relationships" id="264" r:id="Read1738a81674507"/>
+    <p:sldId xmlns:r="http://schemas.openxmlformats.org/officeDocument/2006/relationships" id="265" r:id="R3f7516db363b4209"/>
   </p:sldIdLst>
   <p:sldSz cx="12192000" cy="6858000"/>
   <p:notesSz cx="6858000" cy="9144000"/>
@@ -2854,12 +2854,12 @@
   </p:cSld>
   <p:clrMap bg1="lt1" tx1="dk1" bg2="lt2" tx2="dk2" accent1="accent1" accent2="accent2" accent3="accent3" accent4="accent4" accent5="accent5" accent6="accent6" hlink="hlink" folHlink="folHlink"/>
   <p:sldLayoutIdLst>
-    <p:sldLayoutId xmlns:r="http://schemas.openxmlformats.org/officeDocument/2006/relationships" id="2147483649" r:id="R8b357c76e8c7418c"/>
-    <p:sldLayoutId xmlns:r="http://schemas.openxmlformats.org/officeDocument/2006/relationships" id="2147483650" r:id="Rd8e6bd654cb94bd3"/>
-    <p:sldLayoutId xmlns:r="http://schemas.openxmlformats.org/officeDocument/2006/relationships" id="2147483651" r:id="R83504fd505614c91"/>
-    <p:sldLayoutId xmlns:r="http://schemas.openxmlformats.org/officeDocument/2006/relationships" id="2147483652" r:id="R8706b6aba6ce4984"/>
-    <p:sldLayoutId xmlns:r="http://schemas.openxmlformats.org/officeDocument/2006/relationships" id="2147483653" r:id="R3d713d05f62d40cc"/>
-    <p:sldLayoutId xmlns:r="http://schemas.openxmlformats.org/officeDocument/2006/relationships" id="2147483654" r:id="R582940c72a8a445f"/>
+    <p:sldLayoutId xmlns:r="http://schemas.openxmlformats.org/officeDocument/2006/relationships" id="2147483649" r:id="R794c56af50a64b9c"/>
+    <p:sldLayoutId xmlns:r="http://schemas.openxmlformats.org/officeDocument/2006/relationships" id="2147483650" r:id="R632382177d024083"/>
+    <p:sldLayoutId xmlns:r="http://schemas.openxmlformats.org/officeDocument/2006/relationships" id="2147483651" r:id="R725da53db0a444e3"/>
+    <p:sldLayoutId xmlns:r="http://schemas.openxmlformats.org/officeDocument/2006/relationships" id="2147483652" r:id="Rf34ae55cbbd04f52"/>
+    <p:sldLayoutId xmlns:r="http://schemas.openxmlformats.org/officeDocument/2006/relationships" id="2147483653" r:id="R8f4147ea95d943e8"/>
+    <p:sldLayoutId xmlns:r="http://schemas.openxmlformats.org/officeDocument/2006/relationships" id="2147483654" r:id="R7cd0a7939b5f44fc"/>
   </p:sldLayoutIdLst>
   <p:txStyles>
     <p:titleStyle>
@@ -6288,65 +6288,6 @@
       </p:sp>
       <p:sp>
         <p:nvSpPr>
-          <p:cNvPr id="7" name="">
-            <a:extLst xmlns:a="http://schemas.openxmlformats.org/drawingml/2006/main">
-              <a:ext uri="{FF2B5EF4-FFF2-40B4-BE49-F238E27FC236}">
-                <a16:creationId xmlns:a16="http://schemas.microsoft.com/office/drawing/2014/main" id="{8E6DCBFF-837B-41BF-9E9C-80A693135E2B}"/>
-              </a:ext>
-            </a:extLst>
-          </p:cNvPr>
-          <p:cNvSpPr>
-            <a:spLocks xmlns:a="http://schemas.openxmlformats.org/drawingml/2006/main" noGrp="1"/>
-          </p:cNvSpPr>
-          <p:nvPr/>
-        </p:nvSpPr>
-        <p:spPr>
-          <a:xfrm xmlns:a="http://schemas.openxmlformats.org/drawingml/2006/main">
-            <a:off x="742950" y="2352675"/>
-            <a:ext cx="400050" cy="400050"/>
-          </a:xfrm>
-          <a:prstGeom xmlns:a="http://schemas.openxmlformats.org/drawingml/2006/main" prst="rect">
-            <a:avLst/>
-          </a:prstGeom>
-          <a:noFill xmlns:a="http://schemas.openxmlformats.org/drawingml/2006/main"/>
-          <a:ln xmlns:a="http://schemas.openxmlformats.org/drawingml/2006/main" w="0">
-            <a:noFill/>
-            <a:prstDash val="solid"/>
-          </a:ln>
-        </p:spPr>
-        <p:txBody>
-          <a:bodyPr xmlns:a="http://schemas.openxmlformats.org/drawingml/2006/main" anchor="ctr"/>
-          <a:lstStyle xmlns:a="http://schemas.openxmlformats.org/drawingml/2006/main">
-            <a:defPPr>
-              <a:defRPr sz="1725" b="1">
-                <a:solidFill>
-                  <a:srgbClr val="FFFFFF"/>
-                </a:solidFill>
-              </a:defRPr>
-            </a:defPPr>
-          </a:lstStyle>
-          <a:p xmlns:a="http://schemas.openxmlformats.org/drawingml/2006/main">
-            <a:pPr>
-              <a:buNone/>
-              <a:defRPr sz="1725" b="1">
-                <a:solidFill>
-                  <a:srgbClr val="FFFFFF"/>
-                </a:solidFill>
-              </a:defRPr>
-            </a:pPr>
-            <a:r>
-              <a:rPr sz="1725" b="1">
-                <a:solidFill>
-                  <a:srgbClr val="FFFFFF"/>
-                </a:solidFill>
-              </a:rPr>
-              <a:t>1</a:t>
-            </a:r>
-          </a:p>
-        </p:txBody>
-      </p:sp>
-      <p:sp>
-        <p:nvSpPr>
           <p:cNvPr id="8" name="">
             <a:extLst xmlns:a="http://schemas.openxmlformats.org/drawingml/2006/main">
               <a:ext uri="{FF2B5EF4-FFF2-40B4-BE49-F238E27FC236}">
@@ -6590,65 +6531,6 @@
       </p:sp>
       <p:sp>
         <p:nvSpPr>
-          <p:cNvPr id="13" name="">
-            <a:extLst xmlns:a="http://schemas.openxmlformats.org/drawingml/2006/main">
-              <a:ext uri="{FF2B5EF4-FFF2-40B4-BE49-F238E27FC236}">
-                <a16:creationId xmlns:a16="http://schemas.microsoft.com/office/drawing/2014/main" id="{C5FC94C4-C4A5-48EB-879E-BCED866099BF}"/>
-              </a:ext>
-            </a:extLst>
-          </p:cNvPr>
-          <p:cNvSpPr>
-            <a:spLocks xmlns:a="http://schemas.openxmlformats.org/drawingml/2006/main" noGrp="1"/>
-          </p:cNvSpPr>
-          <p:nvPr/>
-        </p:nvSpPr>
-        <p:spPr>
-          <a:xfrm xmlns:a="http://schemas.openxmlformats.org/drawingml/2006/main">
-            <a:off x="3067050" y="2352675"/>
-            <a:ext cx="400050" cy="400050"/>
-          </a:xfrm>
-          <a:prstGeom xmlns:a="http://schemas.openxmlformats.org/drawingml/2006/main" prst="rect">
-            <a:avLst/>
-          </a:prstGeom>
-          <a:noFill xmlns:a="http://schemas.openxmlformats.org/drawingml/2006/main"/>
-          <a:ln xmlns:a="http://schemas.openxmlformats.org/drawingml/2006/main" w="0">
-            <a:noFill/>
-            <a:prstDash val="solid"/>
-          </a:ln>
-        </p:spPr>
-        <p:txBody>
-          <a:bodyPr xmlns:a="http://schemas.openxmlformats.org/drawingml/2006/main" anchor="ctr"/>
-          <a:lstStyle xmlns:a="http://schemas.openxmlformats.org/drawingml/2006/main">
-            <a:defPPr>
-              <a:defRPr sz="1725" b="1">
-                <a:solidFill>
-                  <a:srgbClr val="FFFFFF"/>
-                </a:solidFill>
-              </a:defRPr>
-            </a:defPPr>
-          </a:lstStyle>
-          <a:p xmlns:a="http://schemas.openxmlformats.org/drawingml/2006/main">
-            <a:pPr>
-              <a:buNone/>
-              <a:defRPr sz="1725" b="1">
-                <a:solidFill>
-                  <a:srgbClr val="FFFFFF"/>
-                </a:solidFill>
-              </a:defRPr>
-            </a:pPr>
-            <a:r>
-              <a:rPr sz="1725" b="1">
-                <a:solidFill>
-                  <a:srgbClr val="FFFFFF"/>
-                </a:solidFill>
-              </a:rPr>
-              <a:t>2</a:t>
-            </a:r>
-          </a:p>
-        </p:txBody>
-      </p:sp>
-      <p:sp>
-        <p:nvSpPr>
           <p:cNvPr id="14" name="">
             <a:extLst xmlns:a="http://schemas.openxmlformats.org/drawingml/2006/main">
               <a:ext uri="{FF2B5EF4-FFF2-40B4-BE49-F238E27FC236}">
@@ -6892,65 +6774,6 @@
       </p:sp>
       <p:sp>
         <p:nvSpPr>
-          <p:cNvPr id="19" name="">
-            <a:extLst xmlns:a="http://schemas.openxmlformats.org/drawingml/2006/main">
-              <a:ext uri="{FF2B5EF4-FFF2-40B4-BE49-F238E27FC236}">
-                <a16:creationId xmlns:a16="http://schemas.microsoft.com/office/drawing/2014/main" id="{DC073F47-8866-40A5-89B8-BDDFC281F2D4}"/>
-              </a:ext>
-            </a:extLst>
-          </p:cNvPr>
-          <p:cNvSpPr>
-            <a:spLocks xmlns:a="http://schemas.openxmlformats.org/drawingml/2006/main" noGrp="1"/>
-          </p:cNvSpPr>
-          <p:nvPr/>
-        </p:nvSpPr>
-        <p:spPr>
-          <a:xfrm xmlns:a="http://schemas.openxmlformats.org/drawingml/2006/main">
-            <a:off x="5391150" y="2352675"/>
-            <a:ext cx="400050" cy="400050"/>
-          </a:xfrm>
-          <a:prstGeom xmlns:a="http://schemas.openxmlformats.org/drawingml/2006/main" prst="rect">
-            <a:avLst/>
-          </a:prstGeom>
-          <a:noFill xmlns:a="http://schemas.openxmlformats.org/drawingml/2006/main"/>
-          <a:ln xmlns:a="http://schemas.openxmlformats.org/drawingml/2006/main" w="0">
-            <a:noFill/>
-            <a:prstDash val="solid"/>
-          </a:ln>
-        </p:spPr>
-        <p:txBody>
-          <a:bodyPr xmlns:a="http://schemas.openxmlformats.org/drawingml/2006/main" anchor="ctr"/>
-          <a:lstStyle xmlns:a="http://schemas.openxmlformats.org/drawingml/2006/main">
-            <a:defPPr>
-              <a:defRPr sz="1725" b="1">
-                <a:solidFill>
-                  <a:srgbClr val="FFFFFF"/>
-                </a:solidFill>
-              </a:defRPr>
-            </a:defPPr>
-          </a:lstStyle>
-          <a:p xmlns:a="http://schemas.openxmlformats.org/drawingml/2006/main">
-            <a:pPr>
-              <a:buNone/>
-              <a:defRPr sz="1725" b="1">
-                <a:solidFill>
-                  <a:srgbClr val="FFFFFF"/>
-                </a:solidFill>
-              </a:defRPr>
-            </a:pPr>
-            <a:r>
-              <a:rPr sz="1725" b="1">
-                <a:solidFill>
-                  <a:srgbClr val="FFFFFF"/>
-                </a:solidFill>
-              </a:rPr>
-              <a:t>3</a:t>
-            </a:r>
-          </a:p>
-        </p:txBody>
-      </p:sp>
-      <p:sp>
-        <p:nvSpPr>
           <p:cNvPr id="20" name="">
             <a:extLst xmlns:a="http://schemas.openxmlformats.org/drawingml/2006/main">
               <a:ext uri="{FF2B5EF4-FFF2-40B4-BE49-F238E27FC236}">
@@ -7194,65 +7017,6 @@
       </p:sp>
       <p:sp>
         <p:nvSpPr>
-          <p:cNvPr id="25" name="">
-            <a:extLst xmlns:a="http://schemas.openxmlformats.org/drawingml/2006/main">
-              <a:ext uri="{FF2B5EF4-FFF2-40B4-BE49-F238E27FC236}">
-                <a16:creationId xmlns:a16="http://schemas.microsoft.com/office/drawing/2014/main" id="{8BA2CBB5-9AEE-412B-AD68-E82496D8FF86}"/>
-              </a:ext>
-            </a:extLst>
-          </p:cNvPr>
-          <p:cNvSpPr>
-            <a:spLocks xmlns:a="http://schemas.openxmlformats.org/drawingml/2006/main" noGrp="1"/>
-          </p:cNvSpPr>
-          <p:nvPr/>
-        </p:nvSpPr>
-        <p:spPr>
-          <a:xfrm xmlns:a="http://schemas.openxmlformats.org/drawingml/2006/main">
-            <a:off x="7715250" y="2352675"/>
-            <a:ext cx="400050" cy="400050"/>
-          </a:xfrm>
-          <a:prstGeom xmlns:a="http://schemas.openxmlformats.org/drawingml/2006/main" prst="rect">
-            <a:avLst/>
-          </a:prstGeom>
-          <a:noFill xmlns:a="http://schemas.openxmlformats.org/drawingml/2006/main"/>
-          <a:ln xmlns:a="http://schemas.openxmlformats.org/drawingml/2006/main" w="0">
-            <a:noFill/>
-            <a:prstDash val="solid"/>
-          </a:ln>
-        </p:spPr>
-        <p:txBody>
-          <a:bodyPr xmlns:a="http://schemas.openxmlformats.org/drawingml/2006/main" anchor="ctr"/>
-          <a:lstStyle xmlns:a="http://schemas.openxmlformats.org/drawingml/2006/main">
-            <a:defPPr>
-              <a:defRPr sz="1725" b="1">
-                <a:solidFill>
-                  <a:srgbClr val="FFFFFF"/>
-                </a:solidFill>
-              </a:defRPr>
-            </a:defPPr>
-          </a:lstStyle>
-          <a:p xmlns:a="http://schemas.openxmlformats.org/drawingml/2006/main">
-            <a:pPr>
-              <a:buNone/>
-              <a:defRPr sz="1725" b="1">
-                <a:solidFill>
-                  <a:srgbClr val="FFFFFF"/>
-                </a:solidFill>
-              </a:defRPr>
-            </a:pPr>
-            <a:r>
-              <a:rPr sz="1725" b="1">
-                <a:solidFill>
-                  <a:srgbClr val="FFFFFF"/>
-                </a:solidFill>
-              </a:rPr>
-              <a:t>4</a:t>
-            </a:r>
-          </a:p>
-        </p:txBody>
-      </p:sp>
-      <p:sp>
-        <p:nvSpPr>
           <p:cNvPr id="26" name="">
             <a:extLst xmlns:a="http://schemas.openxmlformats.org/drawingml/2006/main">
               <a:ext uri="{FF2B5EF4-FFF2-40B4-BE49-F238E27FC236}">
@@ -7496,65 +7260,6 @@
       </p:sp>
       <p:sp>
         <p:nvSpPr>
-          <p:cNvPr id="31" name="">
-            <a:extLst xmlns:a="http://schemas.openxmlformats.org/drawingml/2006/main">
-              <a:ext uri="{FF2B5EF4-FFF2-40B4-BE49-F238E27FC236}">
-                <a16:creationId xmlns:a16="http://schemas.microsoft.com/office/drawing/2014/main" id="{DE8036F2-ED54-4805-AFB9-DE1D9444F65B}"/>
-              </a:ext>
-            </a:extLst>
-          </p:cNvPr>
-          <p:cNvSpPr>
-            <a:spLocks xmlns:a="http://schemas.openxmlformats.org/drawingml/2006/main" noGrp="1"/>
-          </p:cNvSpPr>
-          <p:nvPr/>
-        </p:nvSpPr>
-        <p:spPr>
-          <a:xfrm xmlns:a="http://schemas.openxmlformats.org/drawingml/2006/main">
-            <a:off x="10039350" y="2352675"/>
-            <a:ext cx="400050" cy="400050"/>
-          </a:xfrm>
-          <a:prstGeom xmlns:a="http://schemas.openxmlformats.org/drawingml/2006/main" prst="rect">
-            <a:avLst/>
-          </a:prstGeom>
-          <a:noFill xmlns:a="http://schemas.openxmlformats.org/drawingml/2006/main"/>
-          <a:ln xmlns:a="http://schemas.openxmlformats.org/drawingml/2006/main" w="0">
-            <a:noFill/>
-            <a:prstDash val="solid"/>
-          </a:ln>
-        </p:spPr>
-        <p:txBody>
-          <a:bodyPr xmlns:a="http://schemas.openxmlformats.org/drawingml/2006/main" anchor="ctr"/>
-          <a:lstStyle xmlns:a="http://schemas.openxmlformats.org/drawingml/2006/main">
-            <a:defPPr>
-              <a:defRPr sz="1725" b="1">
-                <a:solidFill>
-                  <a:srgbClr val="FFFFFF"/>
-                </a:solidFill>
-              </a:defRPr>
-            </a:defPPr>
-          </a:lstStyle>
-          <a:p xmlns:a="http://schemas.openxmlformats.org/drawingml/2006/main">
-            <a:pPr>
-              <a:buNone/>
-              <a:defRPr sz="1725" b="1">
-                <a:solidFill>
-                  <a:srgbClr val="FFFFFF"/>
-                </a:solidFill>
-              </a:defRPr>
-            </a:pPr>
-            <a:r>
-              <a:rPr sz="1725" b="1">
-                <a:solidFill>
-                  <a:srgbClr val="FFFFFF"/>
-                </a:solidFill>
-              </a:rPr>
-              <a:t>5</a:t>
-            </a:r>
-          </a:p>
-        </p:txBody>
-      </p:sp>
-      <p:sp>
-        <p:nvSpPr>
           <p:cNvPr id="32" name="">
             <a:extLst xmlns:a="http://schemas.openxmlformats.org/drawingml/2006/main">
               <a:ext uri="{FF2B5EF4-FFF2-40B4-BE49-F238E27FC236}">
@@ -7757,6 +7462,301 @@
                 </a:solidFill>
               </a:rPr>
               <a:t>El registro persistente evita repetir cambios de negocio.</a:t>
+            </a:r>
+          </a:p>
+        </p:txBody>
+      </p:sp>
+      <p:sp>
+        <p:nvSpPr>
+          <p:cNvPr id="7" name="">
+            <a:extLst xmlns:a="http://schemas.openxmlformats.org/drawingml/2006/main">
+              <a:ext uri="{FF2B5EF4-FFF2-40B4-BE49-F238E27FC236}">
+                <a16:creationId xmlns:a16="http://schemas.microsoft.com/office/drawing/2014/main" id="{8E6DCBFF-837B-41BF-9E9C-80A693135E2B}"/>
+              </a:ext>
+            </a:extLst>
+          </p:cNvPr>
+          <p:cNvSpPr>
+            <a:spLocks xmlns:a="http://schemas.openxmlformats.org/drawingml/2006/main" noGrp="1"/>
+          </p:cNvSpPr>
+          <p:nvPr/>
+        </p:nvSpPr>
+        <p:spPr>
+          <a:xfrm xmlns:a="http://schemas.openxmlformats.org/drawingml/2006/main">
+            <a:off x="742950" y="2352675"/>
+            <a:ext cx="400050" cy="400050"/>
+          </a:xfrm>
+          <a:prstGeom xmlns:a="http://schemas.openxmlformats.org/drawingml/2006/main" prst="rect">
+            <a:avLst/>
+          </a:prstGeom>
+          <a:noFill xmlns:a="http://schemas.openxmlformats.org/drawingml/2006/main"/>
+          <a:ln xmlns:a="http://schemas.openxmlformats.org/drawingml/2006/main" w="0">
+            <a:noFill/>
+            <a:prstDash val="solid"/>
+          </a:ln>
+        </p:spPr>
+        <p:txBody>
+          <a:bodyPr xmlns:a="http://schemas.openxmlformats.org/drawingml/2006/main" anchor="ctr"/>
+          <a:lstStyle xmlns:a="http://schemas.openxmlformats.org/drawingml/2006/main">
+            <a:defPPr>
+              <a:defRPr sz="1725" b="1">
+                <a:solidFill>
+                  <a:srgbClr val="FFFFFF"/>
+                </a:solidFill>
+              </a:defRPr>
+            </a:defPPr>
+          </a:lstStyle>
+          <a:p xmlns:a="http://schemas.openxmlformats.org/drawingml/2006/main">
+            <a:pPr>
+              <a:buNone/>
+              <a:defRPr sz="1725" b="1">
+                <a:solidFill>
+                  <a:srgbClr val="FFFFFF"/>
+                </a:solidFill>
+              </a:defRPr>
+            </a:pPr>
+            <a:r>
+              <a:rPr sz="1725" b="1">
+                <a:solidFill>
+                  <a:srgbClr val="FFFFFF"/>
+                </a:solidFill>
+              </a:rPr>
+              <a:t>1</a:t>
+            </a:r>
+          </a:p>
+        </p:txBody>
+      </p:sp>
+      <p:sp>
+        <p:nvSpPr>
+          <p:cNvPr id="13" name="">
+            <a:extLst xmlns:a="http://schemas.openxmlformats.org/drawingml/2006/main">
+              <a:ext uri="{FF2B5EF4-FFF2-40B4-BE49-F238E27FC236}">
+                <a16:creationId xmlns:a16="http://schemas.microsoft.com/office/drawing/2014/main" id="{C5FC94C4-C4A5-48EB-879E-BCED866099BF}"/>
+              </a:ext>
+            </a:extLst>
+          </p:cNvPr>
+          <p:cNvSpPr>
+            <a:spLocks xmlns:a="http://schemas.openxmlformats.org/drawingml/2006/main" noGrp="1"/>
+          </p:cNvSpPr>
+          <p:nvPr/>
+        </p:nvSpPr>
+        <p:spPr>
+          <a:xfrm xmlns:a="http://schemas.openxmlformats.org/drawingml/2006/main">
+            <a:off x="3067050" y="2352675"/>
+            <a:ext cx="400050" cy="400050"/>
+          </a:xfrm>
+          <a:prstGeom xmlns:a="http://schemas.openxmlformats.org/drawingml/2006/main" prst="rect">
+            <a:avLst/>
+          </a:prstGeom>
+          <a:noFill xmlns:a="http://schemas.openxmlformats.org/drawingml/2006/main"/>
+          <a:ln xmlns:a="http://schemas.openxmlformats.org/drawingml/2006/main" w="0">
+            <a:noFill/>
+            <a:prstDash val="solid"/>
+          </a:ln>
+        </p:spPr>
+        <p:txBody>
+          <a:bodyPr xmlns:a="http://schemas.openxmlformats.org/drawingml/2006/main" anchor="ctr"/>
+          <a:lstStyle xmlns:a="http://schemas.openxmlformats.org/drawingml/2006/main">
+            <a:defPPr>
+              <a:defRPr sz="1725" b="1">
+                <a:solidFill>
+                  <a:srgbClr val="FFFFFF"/>
+                </a:solidFill>
+              </a:defRPr>
+            </a:defPPr>
+          </a:lstStyle>
+          <a:p xmlns:a="http://schemas.openxmlformats.org/drawingml/2006/main">
+            <a:pPr>
+              <a:buNone/>
+              <a:defRPr sz="1725" b="1">
+                <a:solidFill>
+                  <a:srgbClr val="FFFFFF"/>
+                </a:solidFill>
+              </a:defRPr>
+            </a:pPr>
+            <a:r>
+              <a:rPr sz="1725" b="1">
+                <a:solidFill>
+                  <a:srgbClr val="FFFFFF"/>
+                </a:solidFill>
+              </a:rPr>
+              <a:t>2</a:t>
+            </a:r>
+          </a:p>
+        </p:txBody>
+      </p:sp>
+      <p:sp>
+        <p:nvSpPr>
+          <p:cNvPr id="19" name="">
+            <a:extLst xmlns:a="http://schemas.openxmlformats.org/drawingml/2006/main">
+              <a:ext uri="{FF2B5EF4-FFF2-40B4-BE49-F238E27FC236}">
+                <a16:creationId xmlns:a16="http://schemas.microsoft.com/office/drawing/2014/main" id="{DC073F47-8866-40A5-89B8-BDDFC281F2D4}"/>
+              </a:ext>
+            </a:extLst>
+          </p:cNvPr>
+          <p:cNvSpPr>
+            <a:spLocks xmlns:a="http://schemas.openxmlformats.org/drawingml/2006/main" noGrp="1"/>
+          </p:cNvSpPr>
+          <p:nvPr/>
+        </p:nvSpPr>
+        <p:spPr>
+          <a:xfrm xmlns:a="http://schemas.openxmlformats.org/drawingml/2006/main">
+            <a:off x="5391150" y="2352675"/>
+            <a:ext cx="400050" cy="400050"/>
+          </a:xfrm>
+          <a:prstGeom xmlns:a="http://schemas.openxmlformats.org/drawingml/2006/main" prst="rect">
+            <a:avLst/>
+          </a:prstGeom>
+          <a:noFill xmlns:a="http://schemas.openxmlformats.org/drawingml/2006/main"/>
+          <a:ln xmlns:a="http://schemas.openxmlformats.org/drawingml/2006/main" w="0">
+            <a:noFill/>
+            <a:prstDash val="solid"/>
+          </a:ln>
+        </p:spPr>
+        <p:txBody>
+          <a:bodyPr xmlns:a="http://schemas.openxmlformats.org/drawingml/2006/main" anchor="ctr"/>
+          <a:lstStyle xmlns:a="http://schemas.openxmlformats.org/drawingml/2006/main">
+            <a:defPPr>
+              <a:defRPr sz="1725" b="1">
+                <a:solidFill>
+                  <a:srgbClr val="FFFFFF"/>
+                </a:solidFill>
+              </a:defRPr>
+            </a:defPPr>
+          </a:lstStyle>
+          <a:p xmlns:a="http://schemas.openxmlformats.org/drawingml/2006/main">
+            <a:pPr>
+              <a:buNone/>
+              <a:defRPr sz="1725" b="1">
+                <a:solidFill>
+                  <a:srgbClr val="FFFFFF"/>
+                </a:solidFill>
+              </a:defRPr>
+            </a:pPr>
+            <a:r>
+              <a:rPr sz="1725" b="1">
+                <a:solidFill>
+                  <a:srgbClr val="FFFFFF"/>
+                </a:solidFill>
+              </a:rPr>
+              <a:t>3</a:t>
+            </a:r>
+          </a:p>
+        </p:txBody>
+      </p:sp>
+      <p:sp>
+        <p:nvSpPr>
+          <p:cNvPr id="25" name="">
+            <a:extLst xmlns:a="http://schemas.openxmlformats.org/drawingml/2006/main">
+              <a:ext uri="{FF2B5EF4-FFF2-40B4-BE49-F238E27FC236}">
+                <a16:creationId xmlns:a16="http://schemas.microsoft.com/office/drawing/2014/main" id="{8BA2CBB5-9AEE-412B-AD68-E82496D8FF86}"/>
+              </a:ext>
+            </a:extLst>
+          </p:cNvPr>
+          <p:cNvSpPr>
+            <a:spLocks xmlns:a="http://schemas.openxmlformats.org/drawingml/2006/main" noGrp="1"/>
+          </p:cNvSpPr>
+          <p:nvPr/>
+        </p:nvSpPr>
+        <p:spPr>
+          <a:xfrm xmlns:a="http://schemas.openxmlformats.org/drawingml/2006/main">
+            <a:off x="7715250" y="2352675"/>
+            <a:ext cx="400050" cy="400050"/>
+          </a:xfrm>
+          <a:prstGeom xmlns:a="http://schemas.openxmlformats.org/drawingml/2006/main" prst="rect">
+            <a:avLst/>
+          </a:prstGeom>
+          <a:noFill xmlns:a="http://schemas.openxmlformats.org/drawingml/2006/main"/>
+          <a:ln xmlns:a="http://schemas.openxmlformats.org/drawingml/2006/main" w="0">
+            <a:noFill/>
+            <a:prstDash val="solid"/>
+          </a:ln>
+        </p:spPr>
+        <p:txBody>
+          <a:bodyPr xmlns:a="http://schemas.openxmlformats.org/drawingml/2006/main" anchor="ctr"/>
+          <a:lstStyle xmlns:a="http://schemas.openxmlformats.org/drawingml/2006/main">
+            <a:defPPr>
+              <a:defRPr sz="1725" b="1">
+                <a:solidFill>
+                  <a:srgbClr val="FFFFFF"/>
+                </a:solidFill>
+              </a:defRPr>
+            </a:defPPr>
+          </a:lstStyle>
+          <a:p xmlns:a="http://schemas.openxmlformats.org/drawingml/2006/main">
+            <a:pPr>
+              <a:buNone/>
+              <a:defRPr sz="1725" b="1">
+                <a:solidFill>
+                  <a:srgbClr val="FFFFFF"/>
+                </a:solidFill>
+              </a:defRPr>
+            </a:pPr>
+            <a:r>
+              <a:rPr sz="1725" b="1">
+                <a:solidFill>
+                  <a:srgbClr val="FFFFFF"/>
+                </a:solidFill>
+              </a:rPr>
+              <a:t>4</a:t>
+            </a:r>
+          </a:p>
+        </p:txBody>
+      </p:sp>
+      <p:sp>
+        <p:nvSpPr>
+          <p:cNvPr id="31" name="">
+            <a:extLst xmlns:a="http://schemas.openxmlformats.org/drawingml/2006/main">
+              <a:ext uri="{FF2B5EF4-FFF2-40B4-BE49-F238E27FC236}">
+                <a16:creationId xmlns:a16="http://schemas.microsoft.com/office/drawing/2014/main" id="{DE8036F2-ED54-4805-AFB9-DE1D9444F65B}"/>
+              </a:ext>
+            </a:extLst>
+          </p:cNvPr>
+          <p:cNvSpPr>
+            <a:spLocks xmlns:a="http://schemas.openxmlformats.org/drawingml/2006/main" noGrp="1"/>
+          </p:cNvSpPr>
+          <p:nvPr/>
+        </p:nvSpPr>
+        <p:spPr>
+          <a:xfrm xmlns:a="http://schemas.openxmlformats.org/drawingml/2006/main">
+            <a:off x="10039350" y="2352675"/>
+            <a:ext cx="400050" cy="400050"/>
+          </a:xfrm>
+          <a:prstGeom xmlns:a="http://schemas.openxmlformats.org/drawingml/2006/main" prst="rect">
+            <a:avLst/>
+          </a:prstGeom>
+          <a:noFill xmlns:a="http://schemas.openxmlformats.org/drawingml/2006/main"/>
+          <a:ln xmlns:a="http://schemas.openxmlformats.org/drawingml/2006/main" w="0">
+            <a:noFill/>
+            <a:prstDash val="solid"/>
+          </a:ln>
+        </p:spPr>
+        <p:txBody>
+          <a:bodyPr xmlns:a="http://schemas.openxmlformats.org/drawingml/2006/main" anchor="ctr"/>
+          <a:lstStyle xmlns:a="http://schemas.openxmlformats.org/drawingml/2006/main">
+            <a:defPPr>
+              <a:defRPr sz="1725" b="1">
+                <a:solidFill>
+                  <a:srgbClr val="FFFFFF"/>
+                </a:solidFill>
+              </a:defRPr>
+            </a:defPPr>
+          </a:lstStyle>
+          <a:p xmlns:a="http://schemas.openxmlformats.org/drawingml/2006/main">
+            <a:pPr>
+              <a:buNone/>
+              <a:defRPr sz="1725" b="1">
+                <a:solidFill>
+                  <a:srgbClr val="FFFFFF"/>
+                </a:solidFill>
+              </a:defRPr>
+            </a:pPr>
+            <a:r>
+              <a:rPr sz="1725" b="1">
+                <a:solidFill>
+                  <a:srgbClr val="FFFFFF"/>
+                </a:solidFill>
+              </a:rPr>
+              <a:t>5</a:t>
             </a:r>
           </a:p>
         </p:txBody>
@@ -11848,8 +11848,8 @@
         </p:nvSpPr>
         <p:spPr>
           <a:xfrm xmlns:a="http://schemas.openxmlformats.org/drawingml/2006/main">
-            <a:off x="3048000" y="1857375"/>
-            <a:ext cx="1619250" cy="285750"/>
+            <a:off x="714375" y="1524000"/>
+            <a:ext cx="2857500" cy="228600"/>
           </a:xfrm>
           <a:prstGeom xmlns:a="http://schemas.openxmlformats.org/drawingml/2006/main" prst="rect">
             <a:avLst/>
@@ -12403,65 +12403,6 @@
       </p:sp>
       <p:sp>
         <p:nvSpPr>
-          <p:cNvPr id="7" name="">
-            <a:extLst xmlns:a="http://schemas.openxmlformats.org/drawingml/2006/main">
-              <a:ext uri="{FF2B5EF4-FFF2-40B4-BE49-F238E27FC236}">
-                <a16:creationId xmlns:a16="http://schemas.microsoft.com/office/drawing/2014/main" id="{85DECBC9-6DD2-4D99-A8B3-09129B7F43D5}"/>
-              </a:ext>
-            </a:extLst>
-          </p:cNvPr>
-          <p:cNvSpPr>
-            <a:spLocks xmlns:a="http://schemas.openxmlformats.org/drawingml/2006/main" noGrp="1"/>
-          </p:cNvSpPr>
-          <p:nvPr/>
-        </p:nvSpPr>
-        <p:spPr>
-          <a:xfrm xmlns:a="http://schemas.openxmlformats.org/drawingml/2006/main">
-            <a:off x="1190625" y="1809750"/>
-            <a:ext cx="457200" cy="457200"/>
-          </a:xfrm>
-          <a:prstGeom xmlns:a="http://schemas.openxmlformats.org/drawingml/2006/main" prst="rect">
-            <a:avLst/>
-          </a:prstGeom>
-          <a:noFill xmlns:a="http://schemas.openxmlformats.org/drawingml/2006/main"/>
-          <a:ln xmlns:a="http://schemas.openxmlformats.org/drawingml/2006/main" w="0">
-            <a:noFill/>
-            <a:prstDash val="solid"/>
-          </a:ln>
-        </p:spPr>
-        <p:txBody>
-          <a:bodyPr xmlns:a="http://schemas.openxmlformats.org/drawingml/2006/main" anchor="ctr"/>
-          <a:lstStyle xmlns:a="http://schemas.openxmlformats.org/drawingml/2006/main">
-            <a:defPPr>
-              <a:defRPr sz="1725" b="1">
-                <a:solidFill>
-                  <a:srgbClr val="FFFFFF"/>
-                </a:solidFill>
-              </a:defRPr>
-            </a:defPPr>
-          </a:lstStyle>
-          <a:p xmlns:a="http://schemas.openxmlformats.org/drawingml/2006/main">
-            <a:pPr>
-              <a:buNone/>
-              <a:defRPr sz="1725" b="1">
-                <a:solidFill>
-                  <a:srgbClr val="FFFFFF"/>
-                </a:solidFill>
-              </a:defRPr>
-            </a:pPr>
-            <a:r>
-              <a:rPr sz="1725" b="1">
-                <a:solidFill>
-                  <a:srgbClr val="FFFFFF"/>
-                </a:solidFill>
-              </a:rPr>
-              <a:t>1</a:t>
-            </a:r>
-          </a:p>
-        </p:txBody>
-      </p:sp>
-      <p:sp>
-        <p:nvSpPr>
           <p:cNvPr id="8" name="">
             <a:extLst xmlns:a="http://schemas.openxmlformats.org/drawingml/2006/main">
               <a:ext uri="{FF2B5EF4-FFF2-40B4-BE49-F238E27FC236}">
@@ -12646,65 +12587,6 @@
       </p:sp>
       <p:sp>
         <p:nvSpPr>
-          <p:cNvPr id="12" name="">
-            <a:extLst xmlns:a="http://schemas.openxmlformats.org/drawingml/2006/main">
-              <a:ext uri="{FF2B5EF4-FFF2-40B4-BE49-F238E27FC236}">
-                <a16:creationId xmlns:a16="http://schemas.microsoft.com/office/drawing/2014/main" id="{63DAB177-A56A-49AF-9D59-7C57D959C7C5}"/>
-              </a:ext>
-            </a:extLst>
-          </p:cNvPr>
-          <p:cNvSpPr>
-            <a:spLocks xmlns:a="http://schemas.openxmlformats.org/drawingml/2006/main" noGrp="1"/>
-          </p:cNvSpPr>
-          <p:nvPr/>
-        </p:nvSpPr>
-        <p:spPr>
-          <a:xfrm xmlns:a="http://schemas.openxmlformats.org/drawingml/2006/main">
-            <a:off x="1190625" y="2809875"/>
-            <a:ext cx="457200" cy="457200"/>
-          </a:xfrm>
-          <a:prstGeom xmlns:a="http://schemas.openxmlformats.org/drawingml/2006/main" prst="rect">
-            <a:avLst/>
-          </a:prstGeom>
-          <a:noFill xmlns:a="http://schemas.openxmlformats.org/drawingml/2006/main"/>
-          <a:ln xmlns:a="http://schemas.openxmlformats.org/drawingml/2006/main" w="0">
-            <a:noFill/>
-            <a:prstDash val="solid"/>
-          </a:ln>
-        </p:spPr>
-        <p:txBody>
-          <a:bodyPr xmlns:a="http://schemas.openxmlformats.org/drawingml/2006/main" anchor="ctr"/>
-          <a:lstStyle xmlns:a="http://schemas.openxmlformats.org/drawingml/2006/main">
-            <a:defPPr>
-              <a:defRPr sz="1725" b="1">
-                <a:solidFill>
-                  <a:srgbClr val="FFFFFF"/>
-                </a:solidFill>
-              </a:defRPr>
-            </a:defPPr>
-          </a:lstStyle>
-          <a:p xmlns:a="http://schemas.openxmlformats.org/drawingml/2006/main">
-            <a:pPr>
-              <a:buNone/>
-              <a:defRPr sz="1725" b="1">
-                <a:solidFill>
-                  <a:srgbClr val="FFFFFF"/>
-                </a:solidFill>
-              </a:defRPr>
-            </a:pPr>
-            <a:r>
-              <a:rPr sz="1725" b="1">
-                <a:solidFill>
-                  <a:srgbClr val="FFFFFF"/>
-                </a:solidFill>
-              </a:rPr>
-              <a:t>2</a:t>
-            </a:r>
-          </a:p>
-        </p:txBody>
-      </p:sp>
-      <p:sp>
-        <p:nvSpPr>
           <p:cNvPr id="13" name="">
             <a:extLst xmlns:a="http://schemas.openxmlformats.org/drawingml/2006/main">
               <a:ext uri="{FF2B5EF4-FFF2-40B4-BE49-F238E27FC236}">
@@ -12889,65 +12771,6 @@
       </p:sp>
       <p:sp>
         <p:nvSpPr>
-          <p:cNvPr id="17" name="">
-            <a:extLst xmlns:a="http://schemas.openxmlformats.org/drawingml/2006/main">
-              <a:ext uri="{FF2B5EF4-FFF2-40B4-BE49-F238E27FC236}">
-                <a16:creationId xmlns:a16="http://schemas.microsoft.com/office/drawing/2014/main" id="{09EA4B01-D6DB-4410-A9CD-792965E9F9A8}"/>
-              </a:ext>
-            </a:extLst>
-          </p:cNvPr>
-          <p:cNvSpPr>
-            <a:spLocks xmlns:a="http://schemas.openxmlformats.org/drawingml/2006/main" noGrp="1"/>
-          </p:cNvSpPr>
-          <p:nvPr/>
-        </p:nvSpPr>
-        <p:spPr>
-          <a:xfrm xmlns:a="http://schemas.openxmlformats.org/drawingml/2006/main">
-            <a:off x="1190625" y="3810000"/>
-            <a:ext cx="457200" cy="457200"/>
-          </a:xfrm>
-          <a:prstGeom xmlns:a="http://schemas.openxmlformats.org/drawingml/2006/main" prst="rect">
-            <a:avLst/>
-          </a:prstGeom>
-          <a:noFill xmlns:a="http://schemas.openxmlformats.org/drawingml/2006/main"/>
-          <a:ln xmlns:a="http://schemas.openxmlformats.org/drawingml/2006/main" w="0">
-            <a:noFill/>
-            <a:prstDash val="solid"/>
-          </a:ln>
-        </p:spPr>
-        <p:txBody>
-          <a:bodyPr xmlns:a="http://schemas.openxmlformats.org/drawingml/2006/main" anchor="ctr"/>
-          <a:lstStyle xmlns:a="http://schemas.openxmlformats.org/drawingml/2006/main">
-            <a:defPPr>
-              <a:defRPr sz="1725" b="1">
-                <a:solidFill>
-                  <a:srgbClr val="FFFFFF"/>
-                </a:solidFill>
-              </a:defRPr>
-            </a:defPPr>
-          </a:lstStyle>
-          <a:p xmlns:a="http://schemas.openxmlformats.org/drawingml/2006/main">
-            <a:pPr>
-              <a:buNone/>
-              <a:defRPr sz="1725" b="1">
-                <a:solidFill>
-                  <a:srgbClr val="FFFFFF"/>
-                </a:solidFill>
-              </a:defRPr>
-            </a:pPr>
-            <a:r>
-              <a:rPr sz="1725" b="1">
-                <a:solidFill>
-                  <a:srgbClr val="FFFFFF"/>
-                </a:solidFill>
-              </a:rPr>
-              <a:t>3</a:t>
-            </a:r>
-          </a:p>
-        </p:txBody>
-      </p:sp>
-      <p:sp>
-        <p:nvSpPr>
           <p:cNvPr id="18" name="">
             <a:extLst xmlns:a="http://schemas.openxmlformats.org/drawingml/2006/main">
               <a:ext uri="{FF2B5EF4-FFF2-40B4-BE49-F238E27FC236}">
@@ -13132,65 +12955,6 @@
       </p:sp>
       <p:sp>
         <p:nvSpPr>
-          <p:cNvPr id="22" name="">
-            <a:extLst xmlns:a="http://schemas.openxmlformats.org/drawingml/2006/main">
-              <a:ext uri="{FF2B5EF4-FFF2-40B4-BE49-F238E27FC236}">
-                <a16:creationId xmlns:a16="http://schemas.microsoft.com/office/drawing/2014/main" id="{BBAAB437-6D0D-4D7D-94FE-95D272B0E691}"/>
-              </a:ext>
-            </a:extLst>
-          </p:cNvPr>
-          <p:cNvSpPr>
-            <a:spLocks xmlns:a="http://schemas.openxmlformats.org/drawingml/2006/main" noGrp="1"/>
-          </p:cNvSpPr>
-          <p:nvPr/>
-        </p:nvSpPr>
-        <p:spPr>
-          <a:xfrm xmlns:a="http://schemas.openxmlformats.org/drawingml/2006/main">
-            <a:off x="1190625" y="4810125"/>
-            <a:ext cx="457200" cy="457200"/>
-          </a:xfrm>
-          <a:prstGeom xmlns:a="http://schemas.openxmlformats.org/drawingml/2006/main" prst="rect">
-            <a:avLst/>
-          </a:prstGeom>
-          <a:noFill xmlns:a="http://schemas.openxmlformats.org/drawingml/2006/main"/>
-          <a:ln xmlns:a="http://schemas.openxmlformats.org/drawingml/2006/main" w="0">
-            <a:noFill/>
-            <a:prstDash val="solid"/>
-          </a:ln>
-        </p:spPr>
-        <p:txBody>
-          <a:bodyPr xmlns:a="http://schemas.openxmlformats.org/drawingml/2006/main" anchor="ctr"/>
-          <a:lstStyle xmlns:a="http://schemas.openxmlformats.org/drawingml/2006/main">
-            <a:defPPr>
-              <a:defRPr sz="1725" b="1">
-                <a:solidFill>
-                  <a:srgbClr val="FFFFFF"/>
-                </a:solidFill>
-              </a:defRPr>
-            </a:defPPr>
-          </a:lstStyle>
-          <a:p xmlns:a="http://schemas.openxmlformats.org/drawingml/2006/main">
-            <a:pPr>
-              <a:buNone/>
-              <a:defRPr sz="1725" b="1">
-                <a:solidFill>
-                  <a:srgbClr val="FFFFFF"/>
-                </a:solidFill>
-              </a:defRPr>
-            </a:pPr>
-            <a:r>
-              <a:rPr sz="1725" b="1">
-                <a:solidFill>
-                  <a:srgbClr val="FFFFFF"/>
-                </a:solidFill>
-              </a:rPr>
-              <a:t>4</a:t>
-            </a:r>
-          </a:p>
-        </p:txBody>
-      </p:sp>
-      <p:sp>
-        <p:nvSpPr>
           <p:cNvPr id="23" name="">
             <a:extLst xmlns:a="http://schemas.openxmlformats.org/drawingml/2006/main">
               <a:ext uri="{FF2B5EF4-FFF2-40B4-BE49-F238E27FC236}">
@@ -13393,6 +13157,242 @@
                 </a:solidFill>
               </a:rPr>
               <a:t>Resultado comprobado el 12 de octubre de 2026</a:t>
+            </a:r>
+          </a:p>
+        </p:txBody>
+      </p:sp>
+      <p:sp>
+        <p:nvSpPr>
+          <p:cNvPr id="7" name="">
+            <a:extLst xmlns:a="http://schemas.openxmlformats.org/drawingml/2006/main">
+              <a:ext uri="{FF2B5EF4-FFF2-40B4-BE49-F238E27FC236}">
+                <a16:creationId xmlns:a16="http://schemas.microsoft.com/office/drawing/2014/main" id="{85DECBC9-6DD2-4D99-A8B3-09129B7F43D5}"/>
+              </a:ext>
+            </a:extLst>
+          </p:cNvPr>
+          <p:cNvSpPr>
+            <a:spLocks xmlns:a="http://schemas.openxmlformats.org/drawingml/2006/main" noGrp="1"/>
+          </p:cNvSpPr>
+          <p:nvPr/>
+        </p:nvSpPr>
+        <p:spPr>
+          <a:xfrm xmlns:a="http://schemas.openxmlformats.org/drawingml/2006/main">
+            <a:off x="1190625" y="1809750"/>
+            <a:ext cx="457200" cy="457200"/>
+          </a:xfrm>
+          <a:prstGeom xmlns:a="http://schemas.openxmlformats.org/drawingml/2006/main" prst="rect">
+            <a:avLst/>
+          </a:prstGeom>
+          <a:noFill xmlns:a="http://schemas.openxmlformats.org/drawingml/2006/main"/>
+          <a:ln xmlns:a="http://schemas.openxmlformats.org/drawingml/2006/main" w="0">
+            <a:noFill/>
+            <a:prstDash val="solid"/>
+          </a:ln>
+        </p:spPr>
+        <p:txBody>
+          <a:bodyPr xmlns:a="http://schemas.openxmlformats.org/drawingml/2006/main" anchor="ctr"/>
+          <a:lstStyle xmlns:a="http://schemas.openxmlformats.org/drawingml/2006/main">
+            <a:defPPr>
+              <a:defRPr sz="1725" b="1">
+                <a:solidFill>
+                  <a:srgbClr val="FFFFFF"/>
+                </a:solidFill>
+              </a:defRPr>
+            </a:defPPr>
+          </a:lstStyle>
+          <a:p xmlns:a="http://schemas.openxmlformats.org/drawingml/2006/main">
+            <a:pPr>
+              <a:buNone/>
+              <a:defRPr sz="1725" b="1">
+                <a:solidFill>
+                  <a:srgbClr val="FFFFFF"/>
+                </a:solidFill>
+              </a:defRPr>
+            </a:pPr>
+            <a:r>
+              <a:rPr sz="1725" b="1">
+                <a:solidFill>
+                  <a:srgbClr val="FFFFFF"/>
+                </a:solidFill>
+              </a:rPr>
+              <a:t>1</a:t>
+            </a:r>
+          </a:p>
+        </p:txBody>
+      </p:sp>
+      <p:sp>
+        <p:nvSpPr>
+          <p:cNvPr id="12" name="">
+            <a:extLst xmlns:a="http://schemas.openxmlformats.org/drawingml/2006/main">
+              <a:ext uri="{FF2B5EF4-FFF2-40B4-BE49-F238E27FC236}">
+                <a16:creationId xmlns:a16="http://schemas.microsoft.com/office/drawing/2014/main" id="{63DAB177-A56A-49AF-9D59-7C57D959C7C5}"/>
+              </a:ext>
+            </a:extLst>
+          </p:cNvPr>
+          <p:cNvSpPr>
+            <a:spLocks xmlns:a="http://schemas.openxmlformats.org/drawingml/2006/main" noGrp="1"/>
+          </p:cNvSpPr>
+          <p:nvPr/>
+        </p:nvSpPr>
+        <p:spPr>
+          <a:xfrm xmlns:a="http://schemas.openxmlformats.org/drawingml/2006/main">
+            <a:off x="1190625" y="2809875"/>
+            <a:ext cx="457200" cy="457200"/>
+          </a:xfrm>
+          <a:prstGeom xmlns:a="http://schemas.openxmlformats.org/drawingml/2006/main" prst="rect">
+            <a:avLst/>
+          </a:prstGeom>
+          <a:noFill xmlns:a="http://schemas.openxmlformats.org/drawingml/2006/main"/>
+          <a:ln xmlns:a="http://schemas.openxmlformats.org/drawingml/2006/main" w="0">
+            <a:noFill/>
+            <a:prstDash val="solid"/>
+          </a:ln>
+        </p:spPr>
+        <p:txBody>
+          <a:bodyPr xmlns:a="http://schemas.openxmlformats.org/drawingml/2006/main" anchor="ctr"/>
+          <a:lstStyle xmlns:a="http://schemas.openxmlformats.org/drawingml/2006/main">
+            <a:defPPr>
+              <a:defRPr sz="1725" b="1">
+                <a:solidFill>
+                  <a:srgbClr val="FFFFFF"/>
+                </a:solidFill>
+              </a:defRPr>
+            </a:defPPr>
+          </a:lstStyle>
+          <a:p xmlns:a="http://schemas.openxmlformats.org/drawingml/2006/main">
+            <a:pPr>
+              <a:buNone/>
+              <a:defRPr sz="1725" b="1">
+                <a:solidFill>
+                  <a:srgbClr val="FFFFFF"/>
+                </a:solidFill>
+              </a:defRPr>
+            </a:pPr>
+            <a:r>
+              <a:rPr sz="1725" b="1">
+                <a:solidFill>
+                  <a:srgbClr val="FFFFFF"/>
+                </a:solidFill>
+              </a:rPr>
+              <a:t>2</a:t>
+            </a:r>
+          </a:p>
+        </p:txBody>
+      </p:sp>
+      <p:sp>
+        <p:nvSpPr>
+          <p:cNvPr id="17" name="">
+            <a:extLst xmlns:a="http://schemas.openxmlformats.org/drawingml/2006/main">
+              <a:ext uri="{FF2B5EF4-FFF2-40B4-BE49-F238E27FC236}">
+                <a16:creationId xmlns:a16="http://schemas.microsoft.com/office/drawing/2014/main" id="{09EA4B01-D6DB-4410-A9CD-792965E9F9A8}"/>
+              </a:ext>
+            </a:extLst>
+          </p:cNvPr>
+          <p:cNvSpPr>
+            <a:spLocks xmlns:a="http://schemas.openxmlformats.org/drawingml/2006/main" noGrp="1"/>
+          </p:cNvSpPr>
+          <p:nvPr/>
+        </p:nvSpPr>
+        <p:spPr>
+          <a:xfrm xmlns:a="http://schemas.openxmlformats.org/drawingml/2006/main">
+            <a:off x="1190625" y="3810000"/>
+            <a:ext cx="457200" cy="457200"/>
+          </a:xfrm>
+          <a:prstGeom xmlns:a="http://schemas.openxmlformats.org/drawingml/2006/main" prst="rect">
+            <a:avLst/>
+          </a:prstGeom>
+          <a:noFill xmlns:a="http://schemas.openxmlformats.org/drawingml/2006/main"/>
+          <a:ln xmlns:a="http://schemas.openxmlformats.org/drawingml/2006/main" w="0">
+            <a:noFill/>
+            <a:prstDash val="solid"/>
+          </a:ln>
+        </p:spPr>
+        <p:txBody>
+          <a:bodyPr xmlns:a="http://schemas.openxmlformats.org/drawingml/2006/main" anchor="ctr"/>
+          <a:lstStyle xmlns:a="http://schemas.openxmlformats.org/drawingml/2006/main">
+            <a:defPPr>
+              <a:defRPr sz="1725" b="1">
+                <a:solidFill>
+                  <a:srgbClr val="FFFFFF"/>
+                </a:solidFill>
+              </a:defRPr>
+            </a:defPPr>
+          </a:lstStyle>
+          <a:p xmlns:a="http://schemas.openxmlformats.org/drawingml/2006/main">
+            <a:pPr>
+              <a:buNone/>
+              <a:defRPr sz="1725" b="1">
+                <a:solidFill>
+                  <a:srgbClr val="FFFFFF"/>
+                </a:solidFill>
+              </a:defRPr>
+            </a:pPr>
+            <a:r>
+              <a:rPr sz="1725" b="1">
+                <a:solidFill>
+                  <a:srgbClr val="FFFFFF"/>
+                </a:solidFill>
+              </a:rPr>
+              <a:t>3</a:t>
+            </a:r>
+          </a:p>
+        </p:txBody>
+      </p:sp>
+      <p:sp>
+        <p:nvSpPr>
+          <p:cNvPr id="22" name="">
+            <a:extLst xmlns:a="http://schemas.openxmlformats.org/drawingml/2006/main">
+              <a:ext uri="{FF2B5EF4-FFF2-40B4-BE49-F238E27FC236}">
+                <a16:creationId xmlns:a16="http://schemas.microsoft.com/office/drawing/2014/main" id="{BBAAB437-6D0D-4D7D-94FE-95D272B0E691}"/>
+              </a:ext>
+            </a:extLst>
+          </p:cNvPr>
+          <p:cNvSpPr>
+            <a:spLocks xmlns:a="http://schemas.openxmlformats.org/drawingml/2006/main" noGrp="1"/>
+          </p:cNvSpPr>
+          <p:nvPr/>
+        </p:nvSpPr>
+        <p:spPr>
+          <a:xfrm xmlns:a="http://schemas.openxmlformats.org/drawingml/2006/main">
+            <a:off x="1190625" y="4810125"/>
+            <a:ext cx="457200" cy="457200"/>
+          </a:xfrm>
+          <a:prstGeom xmlns:a="http://schemas.openxmlformats.org/drawingml/2006/main" prst="rect">
+            <a:avLst/>
+          </a:prstGeom>
+          <a:noFill xmlns:a="http://schemas.openxmlformats.org/drawingml/2006/main"/>
+          <a:ln xmlns:a="http://schemas.openxmlformats.org/drawingml/2006/main" w="0">
+            <a:noFill/>
+            <a:prstDash val="solid"/>
+          </a:ln>
+        </p:spPr>
+        <p:txBody>
+          <a:bodyPr xmlns:a="http://schemas.openxmlformats.org/drawingml/2006/main" anchor="ctr"/>
+          <a:lstStyle xmlns:a="http://schemas.openxmlformats.org/drawingml/2006/main">
+            <a:defPPr>
+              <a:defRPr sz="1725" b="1">
+                <a:solidFill>
+                  <a:srgbClr val="FFFFFF"/>
+                </a:solidFill>
+              </a:defRPr>
+            </a:defPPr>
+          </a:lstStyle>
+          <a:p xmlns:a="http://schemas.openxmlformats.org/drawingml/2006/main">
+            <a:pPr>
+              <a:buNone/>
+              <a:defRPr sz="1725" b="1">
+                <a:solidFill>
+                  <a:srgbClr val="FFFFFF"/>
+                </a:solidFill>
+              </a:defRPr>
+            </a:pPr>
+            <a:r>
+              <a:rPr sz="1725" b="1">
+                <a:solidFill>
+                  <a:srgbClr val="FFFFFF"/>
+                </a:solidFill>
+              </a:rPr>
+              <a:t>4</a:t>
             </a:r>
           </a:p>
         </p:txBody>
@@ -15421,7 +15421,7 @@
                   <a:srgbClr val="17365D"/>
                 </a:solidFill>
               </a:rPr>
-              <a:t>44 pruebas automatizadas aprobadas en Windows con PostgreSQL 15 local.</a:t>
+              <a:t>50 pruebas automatizadas aprobadas en Windows con PostgreSQL 15 local.</a:t>
             </a:r>
           </a:p>
         </p:txBody>

</xml_diff>